<commit_message>
Normalize TecnoCampus logo size in manual defense deck
</commit_message>
<xml_diff>
--- a/doc/presentations/defensa-placa-permanent-dsi-ports-sortida-hexagonal/output/IMPORTANTE_MANUAL_defensa-dsi-ports-sortida-hexagonal.pptx
+++ b/doc/presentations/defensa-placa-permanent-dsi-ports-sortida-hexagonal/output/IMPORTANTE_MANUAL_defensa-dsi-ports-sortida-hexagonal.pptx
@@ -3087,7 +3087,7 @@
 </file>
 
 <file path=ppt/slides/slide1.xml><?xml version="1.0" encoding="utf-8"?>
-<p:sld xmlns:a="http://schemas.openxmlformats.org/drawingml/2006/main" xmlns:r="http://schemas.openxmlformats.org/officeDocument/2006/relationships" xmlns:p="http://schemas.openxmlformats.org/presentationml/2006/main">
+<p:sld xmlns:a="http://schemas.openxmlformats.org/drawingml/2006/main" xmlns:p="http://schemas.openxmlformats.org/presentationml/2006/main" xmlns:r="http://schemas.openxmlformats.org/officeDocument/2006/relationships">
   <p:cSld>
     <p:spTree>
       <p:nvGrpSpPr>
@@ -3119,8 +3119,8 @@
         </p:blipFill>
         <p:spPr>
           <a:xfrm>
-            <a:off x="8412480" y="495996"/>
-            <a:ext cx="2971800" cy="562488"/>
+            <a:off x="8480078" y="293025"/>
+            <a:ext cx="3041362" cy="575655"/>
           </a:xfrm>
           <a:prstGeom prst="rect">
             <a:avLst/>
@@ -3170,7 +3170,7 @@
         </p:nvSpPr>
         <p:spPr>
           <a:xfrm>
-            <a:off x="685800" y="1993392"/>
+            <a:off x="685800" y="2041517"/>
             <a:ext cx="9326880" cy="411480"/>
           </a:xfrm>
           <a:prstGeom prst="rect">
@@ -3186,13 +3186,85 @@
           <a:p>
             <a:pPr algn="l"/>
             <a:r>
-              <a:rPr sz="2100" b="0">
+              <a:rPr lang="es-ES" sz="2100" dirty="0">
                 <a:solidFill>
                   <a:srgbClr val="236092"/>
                 </a:solidFill>
                 <a:latin typeface="Arial"/>
               </a:rPr>
-              <a:t>desacoblament entre casos d'ús, domini i APIs externes</a:t>
+              <a:t>D</a:t>
+            </a:r>
+            <a:r>
+              <a:rPr sz="2100" b="0" dirty="0" err="1">
+                <a:solidFill>
+                  <a:srgbClr val="236092"/>
+                </a:solidFill>
+                <a:latin typeface="Arial"/>
+              </a:rPr>
+              <a:t>esacoblament</a:t>
+            </a:r>
+            <a:r>
+              <a:rPr sz="2100" b="0" dirty="0">
+                <a:solidFill>
+                  <a:srgbClr val="236092"/>
+                </a:solidFill>
+                <a:latin typeface="Arial"/>
+              </a:rPr>
+              <a:t> entre </a:t>
+            </a:r>
+            <a:r>
+              <a:rPr sz="2100" b="0" dirty="0" err="1">
+                <a:solidFill>
+                  <a:srgbClr val="236092"/>
+                </a:solidFill>
+                <a:latin typeface="Arial"/>
+              </a:rPr>
+              <a:t>casos</a:t>
+            </a:r>
+            <a:r>
+              <a:rPr sz="2100" b="0" dirty="0">
+                <a:solidFill>
+                  <a:srgbClr val="236092"/>
+                </a:solidFill>
+                <a:latin typeface="Arial"/>
+              </a:rPr>
+              <a:t> </a:t>
+            </a:r>
+            <a:r>
+              <a:rPr sz="2100" b="0" dirty="0" err="1">
+                <a:solidFill>
+                  <a:srgbClr val="236092"/>
+                </a:solidFill>
+                <a:latin typeface="Arial"/>
+              </a:rPr>
+              <a:t>d'ús</a:t>
+            </a:r>
+            <a:r>
+              <a:rPr sz="2100" b="0" dirty="0">
+                <a:solidFill>
+                  <a:srgbClr val="236092"/>
+                </a:solidFill>
+                <a:latin typeface="Arial"/>
+              </a:rPr>
+              <a:t>, domini </a:t>
+            </a:r>
+            <a:r>
+              <a:rPr sz="2100" b="0" dirty="0" err="1">
+                <a:solidFill>
+                  <a:srgbClr val="236092"/>
+                </a:solidFill>
+                <a:latin typeface="Arial"/>
+              </a:rPr>
+              <a:t>i</a:t>
+            </a:r>
+            <a:r>
+              <a:rPr sz="2100" b="0" dirty="0">
+                <a:solidFill>
+                  <a:srgbClr val="236092"/>
+                </a:solidFill>
+                <a:latin typeface="Arial"/>
+              </a:rPr>
+              <a:t> APIs externes</a:t>
             </a:r>
           </a:p>
         </p:txBody>
@@ -3221,14 +3293,140 @@
           <a:p>
             <a:pPr algn="l"/>
             <a:r>
-              <a:rPr sz="1800" b="0">
+              <a:rPr sz="1800" b="0" dirty="0">
                 <a:solidFill>
                   <a:srgbClr val="262626"/>
                 </a:solidFill>
                 <a:latin typeface="Arial"/>
               </a:rPr>
-              <a:t>Una microlliçó de Disseny de Sistemes d'Informació a partir d'un cas real de consultoria i del projecte HexaStock</a:t>
-            </a:r>
+              <a:t>Una </a:t>
+            </a:r>
+            <a:r>
+              <a:rPr sz="1800" b="0" dirty="0" err="1">
+                <a:solidFill>
+                  <a:srgbClr val="262626"/>
+                </a:solidFill>
+                <a:latin typeface="Arial"/>
+              </a:rPr>
+              <a:t>microlliçó</a:t>
+            </a:r>
+            <a:r>
+              <a:rPr sz="1800" b="0" dirty="0">
+                <a:solidFill>
+                  <a:srgbClr val="262626"/>
+                </a:solidFill>
+                <a:latin typeface="Arial"/>
+              </a:rPr>
+              <a:t> de </a:t>
+            </a:r>
+            <a:r>
+              <a:rPr sz="1800" b="0" dirty="0" err="1">
+                <a:solidFill>
+                  <a:srgbClr val="262626"/>
+                </a:solidFill>
+                <a:latin typeface="Arial"/>
+              </a:rPr>
+              <a:t>Disseny</a:t>
+            </a:r>
+            <a:r>
+              <a:rPr sz="1800" b="0" dirty="0">
+                <a:solidFill>
+                  <a:srgbClr val="262626"/>
+                </a:solidFill>
+                <a:latin typeface="Arial"/>
+              </a:rPr>
+              <a:t> de </a:t>
+            </a:r>
+            <a:r>
+              <a:rPr sz="1800" b="0" dirty="0" err="1">
+                <a:solidFill>
+                  <a:srgbClr val="262626"/>
+                </a:solidFill>
+                <a:latin typeface="Arial"/>
+              </a:rPr>
+              <a:t>Sistemes</a:t>
+            </a:r>
+            <a:r>
+              <a:rPr sz="1800" b="0" dirty="0">
+                <a:solidFill>
+                  <a:srgbClr val="262626"/>
+                </a:solidFill>
+                <a:latin typeface="Arial"/>
+              </a:rPr>
+              <a:t> </a:t>
+            </a:r>
+            <a:r>
+              <a:rPr sz="1800" b="0" dirty="0" err="1">
+                <a:solidFill>
+                  <a:srgbClr val="262626"/>
+                </a:solidFill>
+                <a:latin typeface="Arial"/>
+              </a:rPr>
+              <a:t>d'Informació</a:t>
+            </a:r>
+            <a:r>
+              <a:rPr sz="1800" b="0" dirty="0">
+                <a:solidFill>
+                  <a:srgbClr val="262626"/>
+                </a:solidFill>
+                <a:latin typeface="Arial"/>
+              </a:rPr>
+              <a:t> a </a:t>
+            </a:r>
+            <a:r>
+              <a:rPr sz="1800" b="0" dirty="0" err="1">
+                <a:solidFill>
+                  <a:srgbClr val="262626"/>
+                </a:solidFill>
+                <a:latin typeface="Arial"/>
+              </a:rPr>
+              <a:t>partir</a:t>
+            </a:r>
+            <a:r>
+              <a:rPr sz="1800" b="0" dirty="0">
+                <a:solidFill>
+                  <a:srgbClr val="262626"/>
+                </a:solidFill>
+                <a:latin typeface="Arial"/>
+              </a:rPr>
+              <a:t> d'un </a:t>
+            </a:r>
+            <a:r>
+              <a:rPr sz="1800" b="0" dirty="0" err="1">
+                <a:solidFill>
+                  <a:srgbClr val="262626"/>
+                </a:solidFill>
+                <a:latin typeface="Arial"/>
+              </a:rPr>
+              <a:t>cas</a:t>
+            </a:r>
+            <a:r>
+              <a:rPr sz="1800" b="0" dirty="0">
+                <a:solidFill>
+                  <a:srgbClr val="262626"/>
+                </a:solidFill>
+                <a:latin typeface="Arial"/>
+              </a:rPr>
+              <a:t> real de </a:t>
+            </a:r>
+            <a:r>
+              <a:rPr lang="es-ES" dirty="0">
+                <a:solidFill>
+                  <a:srgbClr val="262626"/>
+                </a:solidFill>
+                <a:latin typeface="Arial"/>
+              </a:rPr>
+              <a:t>la Generalitat de Catalunya</a:t>
+            </a:r>
+          </a:p>
+          <a:p>
+            <a:pPr algn="l"/>
+            <a:endParaRPr sz="1800" b="0" dirty="0">
+              <a:solidFill>
+                <a:srgbClr val="262626"/>
+              </a:solidFill>
+              <a:latin typeface="Arial"/>
+            </a:endParaRPr>
           </a:p>
         </p:txBody>
       </p:sp>
@@ -3348,7 +3546,7 @@
 </file>
 
 <file path=ppt/slides/slide10.xml><?xml version="1.0" encoding="utf-8"?>
-<p:sld xmlns:a="http://schemas.openxmlformats.org/drawingml/2006/main" xmlns:r="http://schemas.openxmlformats.org/officeDocument/2006/relationships" xmlns:p="http://schemas.openxmlformats.org/presentationml/2006/main">
+<p:sld xmlns:a="http://schemas.openxmlformats.org/drawingml/2006/main" xmlns:p="http://schemas.openxmlformats.org/presentationml/2006/main" xmlns:r="http://schemas.openxmlformats.org/officeDocument/2006/relationships">
   <p:cSld>
     <p:spTree>
       <p:nvGrpSpPr>
@@ -3501,8 +3699,8 @@
         </p:blipFill>
         <p:spPr>
           <a:xfrm>
-            <a:off x="9738360" y="293025"/>
-            <a:ext cx="1783079" cy="337493"/>
+            <a:off x="8480078" y="293025"/>
+            <a:ext cx="3041362" cy="575655"/>
           </a:xfrm>
           <a:prstGeom prst="rect">
             <a:avLst/>
@@ -3901,7 +4099,7 @@
 </file>
 
 <file path=ppt/slides/slide11.xml><?xml version="1.0" encoding="utf-8"?>
-<p:sld xmlns:a="http://schemas.openxmlformats.org/drawingml/2006/main" xmlns:r="http://schemas.openxmlformats.org/officeDocument/2006/relationships" xmlns:p="http://schemas.openxmlformats.org/presentationml/2006/main">
+<p:sld xmlns:a="http://schemas.openxmlformats.org/drawingml/2006/main" xmlns:p="http://schemas.openxmlformats.org/presentationml/2006/main" xmlns:r="http://schemas.openxmlformats.org/officeDocument/2006/relationships">
   <p:cSld>
     <p:spTree>
       <p:nvGrpSpPr>
@@ -4003,8 +4201,8 @@
         </p:blipFill>
         <p:spPr>
           <a:xfrm>
-            <a:off x="9738360" y="293025"/>
-            <a:ext cx="1783079" cy="337493"/>
+            <a:off x="8480078" y="293025"/>
+            <a:ext cx="3041362" cy="575655"/>
           </a:xfrm>
           <a:prstGeom prst="rect">
             <a:avLst/>
@@ -4310,7 +4508,7 @@
 </file>
 
 <file path=ppt/slides/slide12.xml><?xml version="1.0" encoding="utf-8"?>
-<p:sld xmlns:a="http://schemas.openxmlformats.org/drawingml/2006/main" xmlns:r="http://schemas.openxmlformats.org/officeDocument/2006/relationships" xmlns:p="http://schemas.openxmlformats.org/presentationml/2006/main">
+<p:sld xmlns:a="http://schemas.openxmlformats.org/drawingml/2006/main" xmlns:p="http://schemas.openxmlformats.org/presentationml/2006/main" xmlns:r="http://schemas.openxmlformats.org/officeDocument/2006/relationships">
   <p:cSld>
     <p:spTree>
       <p:nvGrpSpPr>
@@ -4412,8 +4610,8 @@
         </p:blipFill>
         <p:spPr>
           <a:xfrm>
-            <a:off x="9738360" y="293025"/>
-            <a:ext cx="1783079" cy="337493"/>
+            <a:off x="8480078" y="293025"/>
+            <a:ext cx="3041362" cy="575655"/>
           </a:xfrm>
           <a:prstGeom prst="rect">
             <a:avLst/>
@@ -4891,7 +5089,7 @@
 </file>
 
 <file path=ppt/slides/slide13.xml><?xml version="1.0" encoding="utf-8"?>
-<p:sld xmlns:a="http://schemas.openxmlformats.org/drawingml/2006/main" xmlns:r="http://schemas.openxmlformats.org/officeDocument/2006/relationships" xmlns:p="http://schemas.openxmlformats.org/presentationml/2006/main">
+<p:sld xmlns:a="http://schemas.openxmlformats.org/drawingml/2006/main" xmlns:p="http://schemas.openxmlformats.org/presentationml/2006/main" xmlns:r="http://schemas.openxmlformats.org/officeDocument/2006/relationships">
   <p:cSld>
     <p:spTree>
       <p:nvGrpSpPr>
@@ -4993,8 +5191,8 @@
         </p:blipFill>
         <p:spPr>
           <a:xfrm>
-            <a:off x="9738360" y="293025"/>
-            <a:ext cx="1783079" cy="337493"/>
+            <a:off x="8480078" y="293025"/>
+            <a:ext cx="3041362" cy="575655"/>
           </a:xfrm>
           <a:prstGeom prst="rect">
             <a:avLst/>
@@ -5183,7 +5381,7 @@
 </file>
 
 <file path=ppt/slides/slide14.xml><?xml version="1.0" encoding="utf-8"?>
-<p:sld xmlns:a="http://schemas.openxmlformats.org/drawingml/2006/main" xmlns:r="http://schemas.openxmlformats.org/officeDocument/2006/relationships" xmlns:p="http://schemas.openxmlformats.org/presentationml/2006/main">
+<p:sld xmlns:a="http://schemas.openxmlformats.org/drawingml/2006/main" xmlns:p="http://schemas.openxmlformats.org/presentationml/2006/main" xmlns:r="http://schemas.openxmlformats.org/officeDocument/2006/relationships">
   <p:cSld>
     <p:spTree>
       <p:nvGrpSpPr>
@@ -5250,8 +5448,8 @@
         </p:blipFill>
         <p:spPr>
           <a:xfrm>
-            <a:off x="9738360" y="293025"/>
-            <a:ext cx="1783079" cy="337493"/>
+            <a:off x="8480078" y="293025"/>
+            <a:ext cx="3041362" cy="575655"/>
           </a:xfrm>
           <a:prstGeom prst="rect">
             <a:avLst/>
@@ -5532,7 +5730,7 @@
 </file>
 
 <file path=ppt/slides/slide2.xml><?xml version="1.0" encoding="utf-8"?>
-<p:sld xmlns:a="http://schemas.openxmlformats.org/drawingml/2006/main" xmlns:r="http://schemas.openxmlformats.org/officeDocument/2006/relationships" xmlns:p="http://schemas.openxmlformats.org/presentationml/2006/main">
+<p:sld xmlns:a="http://schemas.openxmlformats.org/drawingml/2006/main" xmlns:p="http://schemas.openxmlformats.org/presentationml/2006/main" xmlns:r="http://schemas.openxmlformats.org/officeDocument/2006/relationships">
   <p:cSld>
     <p:spTree>
       <p:nvGrpSpPr>
@@ -6158,7 +6356,7 @@
 </file>
 
 <file path=ppt/slides/slide3.xml><?xml version="1.0" encoding="utf-8"?>
-<p:sld xmlns:a="http://schemas.openxmlformats.org/drawingml/2006/main" xmlns:r="http://schemas.openxmlformats.org/officeDocument/2006/relationships" xmlns:p="http://schemas.openxmlformats.org/presentationml/2006/main">
+<p:sld xmlns:a="http://schemas.openxmlformats.org/drawingml/2006/main" xmlns:ns3="http://schemas.microsoft.com/office/drawing/2014/main" xmlns:ns4="http://schemas.microsoft.com/office/drawing/2010/main" xmlns:p="http://schemas.openxmlformats.org/presentationml/2006/main" xmlns:r="http://schemas.openxmlformats.org/officeDocument/2006/relationships">
   <p:cSld>
     <p:spTree>
       <p:nvGrpSpPr>
@@ -6225,8 +6423,8 @@
         </p:blipFill>
         <p:spPr>
           <a:xfrm>
-            <a:off x="9738360" y="293025"/>
-            <a:ext cx="1783079" cy="337493"/>
+            <a:off x="8480078" y="293025"/>
+            <a:ext cx="3041362" cy="575655"/>
           </a:xfrm>
           <a:prstGeom prst="rect">
             <a:avLst/>
@@ -6513,7 +6711,7 @@
           <p:cNvPr id="1026" name="Picture 2">
             <a:extLst>
               <a:ext uri="{FF2B5EF4-FFF2-40B4-BE49-F238E27FC236}">
-                <a16:creationId xmlns:a16="http://schemas.microsoft.com/office/drawing/2014/main" id="{24324096-D33B-3CBF-C022-BFBBD6A631DD}"/>
+                <ns3:creationId id="{24324096-D33B-3CBF-C022-BFBBD6A631DD}"/>
               </a:ext>
             </a:extLst>
           </p:cNvPr>
@@ -6526,7 +6724,7 @@
           <a:blip r:embed="rId3">
             <a:extLst>
               <a:ext uri="{28A0092B-C50C-407E-A947-70E740481C1C}">
-                <a14:useLocalDpi xmlns:a14="http://schemas.microsoft.com/office/drawing/2010/main" val="0"/>
+                <ns4:useLocalDpi val="0"/>
               </a:ext>
             </a:extLst>
           </a:blip>
@@ -6546,11 +6744,11 @@
           <a:noFill/>
           <a:extLst>
             <a:ext uri="{909E8E84-426E-40DD-AFC4-6F175D3DCCD1}">
-              <a14:hiddenFill xmlns:a14="http://schemas.microsoft.com/office/drawing/2010/main">
+              <ns4:hiddenFill>
                 <a:solidFill>
                   <a:srgbClr val="FFFFFF"/>
                 </a:solidFill>
-              </a14:hiddenFill>
+              </ns4:hiddenFill>
             </a:ext>
           </a:extLst>
         </p:spPr>
@@ -6564,14 +6762,14 @@
 </file>
 
 <file path=ppt/slides/slide4.xml><?xml version="1.0" encoding="utf-8"?>
-<p:sld xmlns:a="http://schemas.openxmlformats.org/drawingml/2006/main" xmlns:r="http://schemas.openxmlformats.org/officeDocument/2006/relationships" xmlns:p="http://schemas.openxmlformats.org/presentationml/2006/main">
+<p:sld xmlns:a="http://schemas.openxmlformats.org/drawingml/2006/main" xmlns:ns2="http://schemas.microsoft.com/office/drawing/2014/main" xmlns:ns4="http://schemas.microsoft.com/office/powerpoint/2010/main" xmlns:p="http://schemas.openxmlformats.org/presentationml/2006/main" xmlns:r="http://schemas.openxmlformats.org/officeDocument/2006/relationships">
   <p:cSld>
     <p:spTree>
       <p:nvGrpSpPr>
         <p:cNvPr id="1" name="">
           <a:extLst>
             <a:ext uri="{FF2B5EF4-FFF2-40B4-BE49-F238E27FC236}">
-              <a16:creationId xmlns:a16="http://schemas.microsoft.com/office/drawing/2014/main" id="{91787A17-E989-2125-8BF4-9FD64C66B0F7}"/>
+              <ns2:creationId id="{91787A17-E989-2125-8BF4-9FD64C66B0F7}"/>
             </a:ext>
           </a:extLst>
         </p:cNvPr>
@@ -6591,7 +6789,7 @@
           <p:cNvPr id="2" name="TextBox 1">
             <a:extLst>
               <a:ext uri="{FF2B5EF4-FFF2-40B4-BE49-F238E27FC236}">
-                <a16:creationId xmlns:a16="http://schemas.microsoft.com/office/drawing/2014/main" id="{6113BE6D-4BF0-DC81-2CE8-23039C4C9D58}"/>
+                <ns2:creationId id="{6113BE6D-4BF0-DC81-2CE8-23039C4C9D58}"/>
               </a:ext>
             </a:extLst>
           </p:cNvPr>
@@ -6665,7 +6863,7 @@
           <p:cNvPr id="3" name="Picture 2" descr="logotip-oficial-tecnocampus-upf-horitzontal-color.png">
             <a:extLst>
               <a:ext uri="{FF2B5EF4-FFF2-40B4-BE49-F238E27FC236}">
-                <a16:creationId xmlns:a16="http://schemas.microsoft.com/office/drawing/2014/main" id="{6E5AEF9E-E38C-2981-74C2-DA381C85519D}"/>
+                <ns2:creationId id="{6E5AEF9E-E38C-2981-74C2-DA381C85519D}"/>
               </a:ext>
             </a:extLst>
           </p:cNvPr>
@@ -6682,8 +6880,8 @@
         </p:blipFill>
         <p:spPr>
           <a:xfrm>
-            <a:off x="9738360" y="293025"/>
-            <a:ext cx="1783079" cy="337493"/>
+            <a:off x="8480078" y="293025"/>
+            <a:ext cx="3041362" cy="575655"/>
           </a:xfrm>
           <a:prstGeom prst="rect">
             <a:avLst/>
@@ -6695,7 +6893,7 @@
           <p:cNvPr id="4" name="Rectangle 3">
             <a:extLst>
               <a:ext uri="{FF2B5EF4-FFF2-40B4-BE49-F238E27FC236}">
-                <a16:creationId xmlns:a16="http://schemas.microsoft.com/office/drawing/2014/main" id="{565CC16B-626E-E880-45E7-0DBECBCD6306}"/>
+                <ns2:creationId id="{565CC16B-626E-E880-45E7-0DBECBCD6306}"/>
               </a:ext>
             </a:extLst>
           </p:cNvPr>
@@ -6745,7 +6943,7 @@
           <p:cNvPr id="5" name="TextBox 4">
             <a:extLst>
               <a:ext uri="{FF2B5EF4-FFF2-40B4-BE49-F238E27FC236}">
-                <a16:creationId xmlns:a16="http://schemas.microsoft.com/office/drawing/2014/main" id="{E5442AE4-020C-7BAB-E612-2262DEB4097A}"/>
+                <ns2:creationId id="{E5442AE4-020C-7BAB-E612-2262DEB4097A}"/>
               </a:ext>
             </a:extLst>
           </p:cNvPr>
@@ -6786,7 +6984,7 @@
           <p:cNvPr id="6" name="Rounded Rectangle 5">
             <a:extLst>
               <a:ext uri="{FF2B5EF4-FFF2-40B4-BE49-F238E27FC236}">
-                <a16:creationId xmlns:a16="http://schemas.microsoft.com/office/drawing/2014/main" id="{064EE3A6-5D0D-EFE6-3907-91BB6540F213}"/>
+                <ns2:creationId id="{064EE3A6-5D0D-EFE6-3907-91BB6540F213}"/>
               </a:ext>
             </a:extLst>
           </p:cNvPr>
@@ -6838,7 +7036,7 @@
           <p:cNvPr id="7" name="TextBox 6">
             <a:extLst>
               <a:ext uri="{FF2B5EF4-FFF2-40B4-BE49-F238E27FC236}">
-                <a16:creationId xmlns:a16="http://schemas.microsoft.com/office/drawing/2014/main" id="{C0F1223D-ADAB-E817-C2A8-78FB596BC6F8}"/>
+                <ns2:creationId id="{C0F1223D-ADAB-E817-C2A8-78FB596BC6F8}"/>
               </a:ext>
             </a:extLst>
           </p:cNvPr>
@@ -6880,7 +7078,7 @@
           <p:cNvPr id="8" name="Rounded Rectangle 7">
             <a:extLst>
               <a:ext uri="{FF2B5EF4-FFF2-40B4-BE49-F238E27FC236}">
-                <a16:creationId xmlns:a16="http://schemas.microsoft.com/office/drawing/2014/main" id="{460CDC97-EADA-2158-DAC3-FD27FD257839}"/>
+                <ns2:creationId id="{460CDC97-EADA-2158-DAC3-FD27FD257839}"/>
               </a:ext>
             </a:extLst>
           </p:cNvPr>
@@ -6932,7 +7130,7 @@
           <p:cNvPr id="9" name="TextBox 8">
             <a:extLst>
               <a:ext uri="{FF2B5EF4-FFF2-40B4-BE49-F238E27FC236}">
-                <a16:creationId xmlns:a16="http://schemas.microsoft.com/office/drawing/2014/main" id="{57DA438C-C49C-5E46-6F61-14F3896E8657}"/>
+                <ns2:creationId id="{57DA438C-C49C-5E46-6F61-14F3896E8657}"/>
               </a:ext>
             </a:extLst>
           </p:cNvPr>
@@ -6974,7 +7172,7 @@
           <p:cNvPr id="10" name="Rounded Rectangle 9">
             <a:extLst>
               <a:ext uri="{FF2B5EF4-FFF2-40B4-BE49-F238E27FC236}">
-                <a16:creationId xmlns:a16="http://schemas.microsoft.com/office/drawing/2014/main" id="{54F82A2A-9916-E9F8-2F4C-A47E7CF470BE}"/>
+                <ns2:creationId id="{54F82A2A-9916-E9F8-2F4C-A47E7CF470BE}"/>
               </a:ext>
             </a:extLst>
           </p:cNvPr>
@@ -7026,7 +7224,7 @@
           <p:cNvPr id="11" name="TextBox 10">
             <a:extLst>
               <a:ext uri="{FF2B5EF4-FFF2-40B4-BE49-F238E27FC236}">
-                <a16:creationId xmlns:a16="http://schemas.microsoft.com/office/drawing/2014/main" id="{C6C32489-28BB-E0B4-6D88-054802179775}"/>
+                <ns2:creationId id="{C6C32489-28BB-E0B4-6D88-054802179775}"/>
               </a:ext>
             </a:extLst>
           </p:cNvPr>
@@ -7068,7 +7266,7 @@
           <p:cNvPr id="12" name="TextBox 11">
             <a:extLst>
               <a:ext uri="{FF2B5EF4-FFF2-40B4-BE49-F238E27FC236}">
-                <a16:creationId xmlns:a16="http://schemas.microsoft.com/office/drawing/2014/main" id="{5298AC41-2EA2-3BF1-14F5-5DF9647D4D84}"/>
+                <ns2:creationId id="{5298AC41-2EA2-3BF1-14F5-5DF9647D4D84}"/>
               </a:ext>
             </a:extLst>
           </p:cNvPr>
@@ -7109,7 +7307,7 @@
           <p:cNvPr id="13" name="TextBox 12">
             <a:extLst>
               <a:ext uri="{FF2B5EF4-FFF2-40B4-BE49-F238E27FC236}">
-                <a16:creationId xmlns:a16="http://schemas.microsoft.com/office/drawing/2014/main" id="{88D08D29-A0AD-1C10-91EF-4939D83B6478}"/>
+                <ns2:creationId id="{88D08D29-A0AD-1C10-91EF-4939D83B6478}"/>
               </a:ext>
             </a:extLst>
           </p:cNvPr>
@@ -7148,7 +7346,7 @@
     </p:spTree>
     <p:extLst>
       <p:ext uri="{BB962C8B-B14F-4D97-AF65-F5344CB8AC3E}">
-        <p14:creationId xmlns:p14="http://schemas.microsoft.com/office/powerpoint/2010/main" val="1026507124"/>
+        <ns4:creationId val="1026507124"/>
       </p:ext>
     </p:extLst>
   </p:cSld>
@@ -7159,7 +7357,7 @@
 </file>
 
 <file path=ppt/slides/slide5.xml><?xml version="1.0" encoding="utf-8"?>
-<p:sld xmlns:a="http://schemas.openxmlformats.org/drawingml/2006/main" xmlns:r="http://schemas.openxmlformats.org/officeDocument/2006/relationships" xmlns:p="http://schemas.openxmlformats.org/presentationml/2006/main">
+<p:sld xmlns:a="http://schemas.openxmlformats.org/drawingml/2006/main" xmlns:p="http://schemas.openxmlformats.org/presentationml/2006/main" xmlns:r="http://schemas.openxmlformats.org/officeDocument/2006/relationships">
   <p:cSld>
     <p:spTree>
       <p:nvGrpSpPr>
@@ -7261,8 +7459,8 @@
         </p:blipFill>
         <p:spPr>
           <a:xfrm>
-            <a:off x="9738360" y="293025"/>
-            <a:ext cx="1783079" cy="337493"/>
+            <a:off x="8480078" y="293025"/>
+            <a:ext cx="3041362" cy="575655"/>
           </a:xfrm>
           <a:prstGeom prst="rect">
             <a:avLst/>
@@ -7571,7 +7769,7 @@
 </file>
 
 <file path=ppt/slides/slide6.xml><?xml version="1.0" encoding="utf-8"?>
-<p:sld xmlns:a="http://schemas.openxmlformats.org/drawingml/2006/main" xmlns:r="http://schemas.openxmlformats.org/officeDocument/2006/relationships" xmlns:p="http://schemas.openxmlformats.org/presentationml/2006/main">
+<p:sld xmlns:a="http://schemas.openxmlformats.org/drawingml/2006/main" xmlns:p="http://schemas.openxmlformats.org/presentationml/2006/main" xmlns:r="http://schemas.openxmlformats.org/officeDocument/2006/relationships">
   <p:cSld>
     <p:spTree>
       <p:nvGrpSpPr>
@@ -7673,8 +7871,8 @@
         </p:blipFill>
         <p:spPr>
           <a:xfrm>
-            <a:off x="9738360" y="293025"/>
-            <a:ext cx="1783079" cy="337493"/>
+            <a:off x="8480078" y="293025"/>
+            <a:ext cx="3041362" cy="575655"/>
           </a:xfrm>
           <a:prstGeom prst="rect">
             <a:avLst/>
@@ -8111,7 +8309,7 @@
 </file>
 
 <file path=ppt/slides/slide7.xml><?xml version="1.0" encoding="utf-8"?>
-<p:sld xmlns:a="http://schemas.openxmlformats.org/drawingml/2006/main" xmlns:r="http://schemas.openxmlformats.org/officeDocument/2006/relationships" xmlns:p="http://schemas.openxmlformats.org/presentationml/2006/main">
+<p:sld xmlns:a="http://schemas.openxmlformats.org/drawingml/2006/main" xmlns:p="http://schemas.openxmlformats.org/presentationml/2006/main" xmlns:r="http://schemas.openxmlformats.org/officeDocument/2006/relationships">
   <p:cSld>
     <p:spTree>
       <p:nvGrpSpPr>
@@ -8178,8 +8376,8 @@
         </p:blipFill>
         <p:spPr>
           <a:xfrm>
-            <a:off x="9738360" y="293025"/>
-            <a:ext cx="1783079" cy="337493"/>
+            <a:off x="8480078" y="293025"/>
+            <a:ext cx="3041362" cy="575655"/>
           </a:xfrm>
           <a:prstGeom prst="rect">
             <a:avLst/>
@@ -8888,7 +9086,7 @@
 </file>
 
 <file path=ppt/slides/slide8.xml><?xml version="1.0" encoding="utf-8"?>
-<p:sld xmlns:a="http://schemas.openxmlformats.org/drawingml/2006/main" xmlns:r="http://schemas.openxmlformats.org/officeDocument/2006/relationships" xmlns:p="http://schemas.openxmlformats.org/presentationml/2006/main">
+<p:sld xmlns:a="http://schemas.openxmlformats.org/drawingml/2006/main" xmlns:p="http://schemas.openxmlformats.org/presentationml/2006/main" xmlns:r="http://schemas.openxmlformats.org/officeDocument/2006/relationships">
   <p:cSld>
     <p:spTree>
       <p:nvGrpSpPr>
@@ -8955,8 +9153,8 @@
         </p:blipFill>
         <p:spPr>
           <a:xfrm>
-            <a:off x="9738360" y="293025"/>
-            <a:ext cx="1783079" cy="337493"/>
+            <a:off x="8480078" y="293025"/>
+            <a:ext cx="3041362" cy="575655"/>
           </a:xfrm>
           <a:prstGeom prst="rect">
             <a:avLst/>
@@ -9585,7 +9783,7 @@
 </file>
 
 <file path=ppt/slides/slide9.xml><?xml version="1.0" encoding="utf-8"?>
-<p:sld xmlns:a="http://schemas.openxmlformats.org/drawingml/2006/main" xmlns:r="http://schemas.openxmlformats.org/officeDocument/2006/relationships" xmlns:p="http://schemas.openxmlformats.org/presentationml/2006/main">
+<p:sld xmlns:a="http://schemas.openxmlformats.org/drawingml/2006/main" xmlns:ns3="http://schemas.microsoft.com/office/drawing/2014/main" xmlns:p="http://schemas.openxmlformats.org/presentationml/2006/main" xmlns:r="http://schemas.openxmlformats.org/officeDocument/2006/relationships">
   <p:cSld>
     <p:spTree>
       <p:nvGrpSpPr>
@@ -9861,8 +10059,8 @@
         </p:blipFill>
         <p:spPr>
           <a:xfrm>
-            <a:off x="9738360" y="293025"/>
-            <a:ext cx="1783079" cy="337493"/>
+            <a:off x="8480078" y="293025"/>
+            <a:ext cx="3041362" cy="575655"/>
           </a:xfrm>
           <a:prstGeom prst="rect">
             <a:avLst/>
@@ -9988,7 +10186,7 @@
           <p:cNvPr id="11" name="Imagen 10">
             <a:extLst>
               <a:ext uri="{FF2B5EF4-FFF2-40B4-BE49-F238E27FC236}">
-                <a16:creationId xmlns:a16="http://schemas.microsoft.com/office/drawing/2014/main" id="{B6A73A3E-C968-EC80-D679-F89DCA1ECD1A}"/>
+                <ns3:creationId id="{B6A73A3E-C968-EC80-D679-F89DCA1ECD1A}"/>
               </a:ext>
             </a:extLst>
           </p:cNvPr>

</xml_diff>

<commit_message>
docs: keep only canonical defense presentation
</commit_message>
<xml_diff>
--- a/doc/presentations/defensa-placa-permanent-dsi-ports-sortida-hexagonal/output/IMPORTANTE_MANUAL_defensa-dsi-ports-sortida-hexagonal.pptx
+++ b/doc/presentations/defensa-placa-permanent-dsi-ports-sortida-hexagonal/output/IMPORTANTE_MANUAL_defensa-dsi-ports-sortida-hexagonal.pptx
@@ -6875,7 +6875,7 @@
 </file>
 
 <file path=ppt/slides/slide2.xml><?xml version="1.0" encoding="utf-8"?>
-<p:sld xmlns:a="http://schemas.openxmlformats.org/drawingml/2006/main" xmlns:r="http://schemas.openxmlformats.org/officeDocument/2006/relationships" xmlns:p="http://schemas.openxmlformats.org/presentationml/2006/main">
+<p:sld xmlns:a="http://schemas.openxmlformats.org/drawingml/2006/main" xmlns:p="http://schemas.openxmlformats.org/presentationml/2006/main" xmlns:r="http://schemas.openxmlformats.org/officeDocument/2006/relationships">
   <p:cSld>
     <p:spTree>
       <p:nvGrpSpPr>
@@ -7409,7 +7409,7 @@
                 </a:solidFill>
                 <a:latin typeface="Arial"/>
               </a:rPr>
-              <a:t> externes de manera desacoplada. </a:t>
+              <a:t> externes de manera desacoblada. </a:t>
             </a:r>
             <a:endParaRPr sz="2200" b="0" dirty="0">
               <a:solidFill>
@@ -7450,7 +7450,7 @@
                 </a:solidFill>
                 <a:latin typeface="Arial"/>
               </a:rPr>
-              <a:t>Microlliçó dins el bloc de clean / hexagonal architecture, ports, adaptadors i DDD.</a:t>
+              <a:t>Pla docent 103322: clean/hexagonal architecture, ports i adaptadors, mapping, mòduls i DDD.</a:t>
             </a:r>
           </a:p>
         </p:txBody>

</xml_diff>

<commit_message>
docs: clarify learning objective slides
</commit_message>
<xml_diff>
--- a/doc/presentations/defensa-placa-permanent-dsi-ports-sortida-hexagonal/output/IMPORTANTE_MANUAL_defensa-dsi-ports-sortida-hexagonal.pptx
+++ b/doc/presentations/defensa-placa-permanent-dsi-ports-sortida-hexagonal/output/IMPORTANTE_MANUAL_defensa-dsi-ports-sortida-hexagonal.pptx
@@ -220,7 +220,7 @@
           <a:p>
             <a:fld id="{0ABAC575-8351-9441-AF95-237B22BB45B7}" type="datetimeFigureOut">
               <a:rPr lang="es-ES" smtClean="0"/>
-              <a:t>29/6/26</a:t>
+              <a:t>30/6/26</a:t>
             </a:fld>
             <a:endParaRPr lang="es-ES"/>
           </a:p>
@@ -830,7 +830,7 @@
           <a:p>
             <a:fld id="{5BCAD085-E8A6-8845-BD4E-CB4CCA059FC4}" type="datetimeFigureOut">
               <a:rPr lang="en-US" smtClean="0"/>
-              <a:t>6/29/26</a:t>
+              <a:t>6/30/26</a:t>
             </a:fld>
             <a:endParaRPr lang="en-US"/>
           </a:p>
@@ -998,7 +998,7 @@
           <a:p>
             <a:fld id="{5BCAD085-E8A6-8845-BD4E-CB4CCA059FC4}" type="datetimeFigureOut">
               <a:rPr lang="en-US" smtClean="0"/>
-              <a:t>6/29/26</a:t>
+              <a:t>6/30/26</a:t>
             </a:fld>
             <a:endParaRPr lang="en-US"/>
           </a:p>
@@ -1176,7 +1176,7 @@
           <a:p>
             <a:fld id="{5BCAD085-E8A6-8845-BD4E-CB4CCA059FC4}" type="datetimeFigureOut">
               <a:rPr lang="en-US" smtClean="0"/>
-              <a:t>6/29/26</a:t>
+              <a:t>6/30/26</a:t>
             </a:fld>
             <a:endParaRPr lang="en-US"/>
           </a:p>
@@ -1344,7 +1344,7 @@
           <a:p>
             <a:fld id="{5BCAD085-E8A6-8845-BD4E-CB4CCA059FC4}" type="datetimeFigureOut">
               <a:rPr lang="en-US" smtClean="0"/>
-              <a:t>6/29/26</a:t>
+              <a:t>6/30/26</a:t>
             </a:fld>
             <a:endParaRPr lang="en-US"/>
           </a:p>
@@ -1589,7 +1589,7 @@
           <a:p>
             <a:fld id="{5BCAD085-E8A6-8845-BD4E-CB4CCA059FC4}" type="datetimeFigureOut">
               <a:rPr lang="en-US" smtClean="0"/>
-              <a:t>6/29/26</a:t>
+              <a:t>6/30/26</a:t>
             </a:fld>
             <a:endParaRPr lang="en-US"/>
           </a:p>
@@ -1874,7 +1874,7 @@
           <a:p>
             <a:fld id="{5BCAD085-E8A6-8845-BD4E-CB4CCA059FC4}" type="datetimeFigureOut">
               <a:rPr lang="en-US" smtClean="0"/>
-              <a:t>6/29/26</a:t>
+              <a:t>6/30/26</a:t>
             </a:fld>
             <a:endParaRPr lang="en-US"/>
           </a:p>
@@ -2293,7 +2293,7 @@
           <a:p>
             <a:fld id="{5BCAD085-E8A6-8845-BD4E-CB4CCA059FC4}" type="datetimeFigureOut">
               <a:rPr lang="en-US" smtClean="0"/>
-              <a:t>6/29/26</a:t>
+              <a:t>6/30/26</a:t>
             </a:fld>
             <a:endParaRPr lang="en-US"/>
           </a:p>
@@ -2410,7 +2410,7 @@
           <a:p>
             <a:fld id="{5BCAD085-E8A6-8845-BD4E-CB4CCA059FC4}" type="datetimeFigureOut">
               <a:rPr lang="en-US" smtClean="0"/>
-              <a:t>6/29/26</a:t>
+              <a:t>6/30/26</a:t>
             </a:fld>
             <a:endParaRPr lang="en-US"/>
           </a:p>
@@ -2505,7 +2505,7 @@
           <a:p>
             <a:fld id="{5BCAD085-E8A6-8845-BD4E-CB4CCA059FC4}" type="datetimeFigureOut">
               <a:rPr lang="en-US" smtClean="0"/>
-              <a:t>6/29/26</a:t>
+              <a:t>6/30/26</a:t>
             </a:fld>
             <a:endParaRPr lang="en-US"/>
           </a:p>
@@ -2780,7 +2780,7 @@
           <a:p>
             <a:fld id="{5BCAD085-E8A6-8845-BD4E-CB4CCA059FC4}" type="datetimeFigureOut">
               <a:rPr lang="en-US" smtClean="0"/>
-              <a:t>6/29/26</a:t>
+              <a:t>6/30/26</a:t>
             </a:fld>
             <a:endParaRPr lang="en-US"/>
           </a:p>
@@ -3032,7 +3032,7 @@
           <a:p>
             <a:fld id="{5BCAD085-E8A6-8845-BD4E-CB4CCA059FC4}" type="datetimeFigureOut">
               <a:rPr lang="en-US" smtClean="0"/>
-              <a:t>6/29/26</a:t>
+              <a:t>6/30/26</a:t>
             </a:fld>
             <a:endParaRPr lang="en-US"/>
           </a:p>
@@ -3243,7 +3243,7 @@
           <a:p>
             <a:fld id="{5BCAD085-E8A6-8845-BD4E-CB4CCA059FC4}" type="datetimeFigureOut">
               <a:rPr lang="en-US" smtClean="0"/>
-              <a:t>6/29/26</a:t>
+              <a:t>6/30/26</a:t>
             </a:fld>
             <a:endParaRPr lang="en-US"/>
           </a:p>
@@ -6875,665 +6875,6 @@
 </file>
 
 <file path=ppt/slides/slide2.xml><?xml version="1.0" encoding="utf-8"?>
-<p:sld xmlns:a="http://schemas.openxmlformats.org/drawingml/2006/main" xmlns:p="http://schemas.openxmlformats.org/presentationml/2006/main" xmlns:r="http://schemas.openxmlformats.org/officeDocument/2006/relationships">
-  <p:cSld>
-    <p:spTree>
-      <p:nvGrpSpPr>
-        <p:cNvPr id="1" name=""/>
-        <p:cNvGrpSpPr/>
-        <p:nvPr/>
-      </p:nvGrpSpPr>
-      <p:grpSpPr>
-        <a:xfrm>
-          <a:off x="0" y="0"/>
-          <a:ext cx="0" cy="0"/>
-          <a:chOff x="0" y="0"/>
-          <a:chExt cx="0" cy="0"/>
-        </a:xfrm>
-      </p:grpSpPr>
-      <p:sp>
-        <p:nvSpPr>
-          <p:cNvPr id="2" name="TextBox 1"/>
-          <p:cNvSpPr txBox="1"/>
-          <p:nvPr/>
-        </p:nvSpPr>
-        <p:spPr>
-          <a:xfrm>
-            <a:off x="594360" y="320040"/>
-            <a:ext cx="8961120" cy="502920"/>
-          </a:xfrm>
-          <a:prstGeom prst="rect">
-            <a:avLst/>
-          </a:prstGeom>
-          <a:noFill/>
-        </p:spPr>
-        <p:txBody>
-          <a:bodyPr wrap="square">
-            <a:normAutofit lnSpcReduction="10000"/>
-          </a:bodyPr>
-          <a:lstStyle/>
-          <a:p>
-            <a:pPr algn="l"/>
-            <a:r>
-              <a:rPr sz="2800" b="1">
-                <a:solidFill>
-                  <a:srgbClr val="192D3E"/>
-                </a:solidFill>
-                <a:latin typeface="Arial"/>
-              </a:rPr>
-              <a:t>On som dins l'assignatura</a:t>
-            </a:r>
-          </a:p>
-        </p:txBody>
-      </p:sp>
-      <p:sp>
-        <p:nvSpPr>
-          <p:cNvPr id="3" name="TextBox 2"/>
-          <p:cNvSpPr txBox="1"/>
-          <p:nvPr/>
-        </p:nvSpPr>
-        <p:spPr>
-          <a:xfrm>
-            <a:off x="612648" y="822960"/>
-            <a:ext cx="8869680" cy="320040"/>
-          </a:xfrm>
-          <a:prstGeom prst="rect">
-            <a:avLst/>
-          </a:prstGeom>
-          <a:noFill/>
-        </p:spPr>
-        <p:txBody>
-          <a:bodyPr wrap="square">
-            <a:normAutofit/>
-          </a:bodyPr>
-          <a:lstStyle/>
-          <a:p>
-            <a:pPr algn="l"/>
-            <a:r>
-              <a:rPr sz="1300" b="0">
-                <a:solidFill>
-                  <a:srgbClr val="66707A"/>
-                </a:solidFill>
-                <a:latin typeface="Arial"/>
-              </a:rPr>
-              <a:t>Disseny de Sistemes d'Informació</a:t>
-            </a:r>
-          </a:p>
-        </p:txBody>
-      </p:sp>
-      <p:pic>
-        <p:nvPicPr>
-          <p:cNvPr id="4" name="Picture 3" descr="logotip-oficial-tecnocampus-upf-horitzontal-color.png"/>
-          <p:cNvPicPr>
-            <a:picLocks noChangeAspect="1"/>
-          </p:cNvPicPr>
-          <p:nvPr/>
-        </p:nvPicPr>
-        <p:blipFill>
-          <a:blip r:embed="rId2"/>
-          <a:stretch>
-            <a:fillRect/>
-          </a:stretch>
-        </p:blipFill>
-        <p:spPr>
-          <a:xfrm>
-            <a:off x="8480078" y="293025"/>
-            <a:ext cx="3041362" cy="575655"/>
-          </a:xfrm>
-          <a:prstGeom prst="rect">
-            <a:avLst/>
-          </a:prstGeom>
-        </p:spPr>
-      </p:pic>
-      <p:sp>
-        <p:nvSpPr>
-          <p:cNvPr id="5" name="Rectangle 4"/>
-          <p:cNvSpPr/>
-          <p:nvPr/>
-        </p:nvSpPr>
-        <p:spPr>
-          <a:xfrm>
-            <a:off x="594360" y="1115568"/>
-            <a:ext cx="10972800" cy="13716"/>
-          </a:xfrm>
-          <a:prstGeom prst="rect">
-            <a:avLst/>
-          </a:prstGeom>
-          <a:solidFill>
-            <a:srgbClr val="D6DBE0"/>
-          </a:solidFill>
-          <a:ln>
-            <a:noFill/>
-          </a:ln>
-        </p:spPr>
-        <p:style>
-          <a:lnRef idx="1">
-            <a:schemeClr val="accent1"/>
-          </a:lnRef>
-          <a:fillRef idx="3">
-            <a:schemeClr val="accent1"/>
-          </a:fillRef>
-          <a:effectRef idx="2">
-            <a:schemeClr val="accent1"/>
-          </a:effectRef>
-          <a:fontRef idx="minor">
-            <a:schemeClr val="lt1"/>
-          </a:fontRef>
-        </p:style>
-        <p:txBody>
-          <a:bodyPr rtlCol="0" anchor="ctr"/>
-          <a:lstStyle/>
-          <a:p>
-            <a:pPr algn="ctr"/>
-            <a:endParaRPr/>
-          </a:p>
-        </p:txBody>
-      </p:sp>
-      <p:sp>
-        <p:nvSpPr>
-          <p:cNvPr id="6" name="TextBox 5"/>
-          <p:cNvSpPr txBox="1"/>
-          <p:nvPr/>
-        </p:nvSpPr>
-        <p:spPr>
-          <a:xfrm>
-            <a:off x="822960" y="1508760"/>
-            <a:ext cx="3749039" cy="914400"/>
-          </a:xfrm>
-          <a:prstGeom prst="rect">
-            <a:avLst/>
-          </a:prstGeom>
-          <a:noFill/>
-        </p:spPr>
-        <p:txBody>
-          <a:bodyPr wrap="square">
-            <a:normAutofit fontScale="77500" lnSpcReduction="20000"/>
-          </a:bodyPr>
-          <a:lstStyle/>
-          <a:p>
-            <a:pPr algn="ctr"/>
-            <a:r>
-              <a:rPr sz="2800" b="1">
-                <a:solidFill>
-                  <a:srgbClr val="192D3E"/>
-                </a:solidFill>
-                <a:latin typeface="Arial"/>
-              </a:rPr>
-              <a:t>Disseny de Sistemes d'Informació
-3r curs · 6 ECTS</a:t>
-            </a:r>
-          </a:p>
-        </p:txBody>
-      </p:sp>
-      <p:sp>
-        <p:nvSpPr>
-          <p:cNvPr id="7" name="Rounded Rectangle 6"/>
-          <p:cNvSpPr/>
-          <p:nvPr/>
-        </p:nvSpPr>
-        <p:spPr>
-          <a:xfrm>
-            <a:off x="4800600" y="1508760"/>
-            <a:ext cx="45720" cy="3200400"/>
-          </a:xfrm>
-          <a:prstGeom prst="roundRect">
-            <a:avLst/>
-          </a:prstGeom>
-          <a:solidFill>
-            <a:srgbClr val="236092"/>
-          </a:solidFill>
-          <a:ln w="9525">
-            <a:solidFill>
-              <a:srgbClr val="236092"/>
-            </a:solidFill>
-          </a:ln>
-        </p:spPr>
-        <p:style>
-          <a:lnRef idx="1">
-            <a:schemeClr val="accent1"/>
-          </a:lnRef>
-          <a:fillRef idx="3">
-            <a:schemeClr val="accent1"/>
-          </a:fillRef>
-          <a:effectRef idx="2">
-            <a:schemeClr val="accent1"/>
-          </a:effectRef>
-          <a:fontRef idx="minor">
-            <a:schemeClr val="lt1"/>
-          </a:fontRef>
-        </p:style>
-        <p:txBody>
-          <a:bodyPr rtlCol="0" anchor="ctr"/>
-          <a:lstStyle/>
-          <a:p>
-            <a:pPr algn="ctr"/>
-            <a:endParaRPr/>
-          </a:p>
-        </p:txBody>
-      </p:sp>
-      <p:sp>
-        <p:nvSpPr>
-          <p:cNvPr id="8" name="TextBox 7"/>
-          <p:cNvSpPr txBox="1"/>
-          <p:nvPr/>
-        </p:nvSpPr>
-        <p:spPr>
-          <a:xfrm>
-            <a:off x="5166360" y="1508760"/>
-            <a:ext cx="5394960" cy="1051560"/>
-          </a:xfrm>
-          <a:prstGeom prst="rect">
-            <a:avLst/>
-          </a:prstGeom>
-          <a:noFill/>
-        </p:spPr>
-        <p:txBody>
-          <a:bodyPr wrap="square">
-            <a:normAutofit/>
-          </a:bodyPr>
-          <a:lstStyle/>
-          <a:p>
-            <a:pPr algn="ctr"/>
-            <a:r>
-              <a:rPr sz="3000" b="1" dirty="0">
-                <a:solidFill>
-                  <a:srgbClr val="192D3E"/>
-                </a:solidFill>
-                <a:latin typeface="Arial"/>
-              </a:rPr>
-              <a:t>Ports de </a:t>
-            </a:r>
-            <a:r>
-              <a:rPr sz="3000" b="1" dirty="0" err="1">
-                <a:solidFill>
-                  <a:srgbClr val="192D3E"/>
-                </a:solidFill>
-                <a:latin typeface="Arial"/>
-              </a:rPr>
-              <a:t>sortida</a:t>
-            </a:r>
-            <a:r>
-              <a:rPr sz="3000" b="1" dirty="0">
-                <a:solidFill>
-                  <a:srgbClr val="192D3E"/>
-                </a:solidFill>
-                <a:latin typeface="Arial"/>
-              </a:rPr>
-              <a:t>
-</a:t>
-            </a:r>
-            <a:r>
-              <a:rPr sz="3000" b="1" dirty="0" err="1">
-                <a:solidFill>
-                  <a:srgbClr val="192D3E"/>
-                </a:solidFill>
-                <a:latin typeface="Arial"/>
-              </a:rPr>
-              <a:t>en</a:t>
-            </a:r>
-            <a:r>
-              <a:rPr sz="3000" b="1" dirty="0">
-                <a:solidFill>
-                  <a:srgbClr val="192D3E"/>
-                </a:solidFill>
-                <a:latin typeface="Arial"/>
-              </a:rPr>
-              <a:t> </a:t>
-            </a:r>
-            <a:r>
-              <a:rPr lang="es-ES" sz="3000" b="1" dirty="0">
-                <a:solidFill>
-                  <a:srgbClr val="192D3E"/>
-                </a:solidFill>
-                <a:latin typeface="Arial"/>
-              </a:rPr>
-              <a:t>A</a:t>
-            </a:r>
-            <a:r>
-              <a:rPr sz="3000" b="1" dirty="0" err="1">
-                <a:solidFill>
-                  <a:srgbClr val="192D3E"/>
-                </a:solidFill>
-                <a:latin typeface="Arial"/>
-              </a:rPr>
-              <a:t>rquitectura</a:t>
-            </a:r>
-            <a:r>
-              <a:rPr sz="3000" b="1" dirty="0">
-                <a:solidFill>
-                  <a:srgbClr val="192D3E"/>
-                </a:solidFill>
-                <a:latin typeface="Arial"/>
-              </a:rPr>
-              <a:t> </a:t>
-            </a:r>
-            <a:r>
-              <a:rPr lang="es-ES" sz="3000" b="1" dirty="0">
-                <a:solidFill>
-                  <a:srgbClr val="192D3E"/>
-                </a:solidFill>
-                <a:latin typeface="Arial"/>
-              </a:rPr>
-              <a:t>H</a:t>
-            </a:r>
-            <a:r>
-              <a:rPr sz="3000" b="1" dirty="0" err="1">
-                <a:solidFill>
-                  <a:srgbClr val="192D3E"/>
-                </a:solidFill>
-                <a:latin typeface="Arial"/>
-              </a:rPr>
-              <a:t>exagonal</a:t>
-            </a:r>
-            <a:endParaRPr sz="3000" b="1" dirty="0">
-              <a:solidFill>
-                <a:srgbClr val="192D3E"/>
-              </a:solidFill>
-              <a:latin typeface="Arial"/>
-            </a:endParaRPr>
-          </a:p>
-        </p:txBody>
-      </p:sp>
-      <p:sp>
-        <p:nvSpPr>
-          <p:cNvPr id="9" name="TextBox 8"/>
-          <p:cNvSpPr txBox="1"/>
-          <p:nvPr/>
-        </p:nvSpPr>
-        <p:spPr>
-          <a:xfrm>
-            <a:off x="5394960" y="2971800"/>
-            <a:ext cx="4983480" cy="1143000"/>
-          </a:xfrm>
-          <a:prstGeom prst="rect">
-            <a:avLst/>
-          </a:prstGeom>
-          <a:noFill/>
-        </p:spPr>
-        <p:txBody>
-          <a:bodyPr wrap="square">
-            <a:normAutofit fontScale="77500" lnSpcReduction="20000"/>
-          </a:bodyPr>
-          <a:lstStyle/>
-          <a:p>
-            <a:pPr algn="ctr"/>
-            <a:r>
-              <a:rPr sz="2200" b="0" dirty="0">
-                <a:solidFill>
-                  <a:srgbClr val="262626"/>
-                </a:solidFill>
-                <a:latin typeface="Arial"/>
-              </a:rPr>
-              <a:t>
-Ens </a:t>
-            </a:r>
-            <a:r>
-              <a:rPr sz="2200" b="0" dirty="0" err="1">
-                <a:solidFill>
-                  <a:srgbClr val="262626"/>
-                </a:solidFill>
-                <a:latin typeface="Arial"/>
-              </a:rPr>
-              <a:t>centr</a:t>
-            </a:r>
-            <a:r>
-              <a:rPr lang="es-ES" sz="2200" b="0" dirty="0">
-                <a:solidFill>
-                  <a:srgbClr val="262626"/>
-                </a:solidFill>
-                <a:latin typeface="Arial"/>
-              </a:rPr>
-              <a:t>are</a:t>
-            </a:r>
-            <a:r>
-              <a:rPr sz="2200" b="0" dirty="0">
-                <a:solidFill>
-                  <a:srgbClr val="262626"/>
-                </a:solidFill>
-                <a:latin typeface="Arial"/>
-              </a:rPr>
-              <a:t>m </a:t>
-            </a:r>
-            <a:r>
-              <a:rPr sz="2200" b="0" dirty="0" err="1">
-                <a:solidFill>
-                  <a:srgbClr val="262626"/>
-                </a:solidFill>
-                <a:latin typeface="Arial"/>
-              </a:rPr>
-              <a:t>en</a:t>
-            </a:r>
-            <a:r>
-              <a:rPr sz="2200" b="0" dirty="0">
-                <a:solidFill>
-                  <a:srgbClr val="262626"/>
-                </a:solidFill>
-                <a:latin typeface="Arial"/>
-              </a:rPr>
-              <a:t> </a:t>
-            </a:r>
-            <a:r>
-              <a:rPr lang="es-ES" sz="2200" b="0" dirty="0">
-                <a:solidFill>
-                  <a:srgbClr val="262626"/>
-                </a:solidFill>
-                <a:latin typeface="Arial"/>
-              </a:rPr>
-              <a:t>el </a:t>
-            </a:r>
-            <a:r>
-              <a:rPr lang="es-ES" sz="2200" b="0" dirty="0" err="1">
-                <a:solidFill>
-                  <a:srgbClr val="262626"/>
-                </a:solidFill>
-                <a:latin typeface="Arial"/>
-              </a:rPr>
-              <a:t>disseny</a:t>
-            </a:r>
-            <a:r>
-              <a:rPr lang="es-ES" sz="2200" b="0" dirty="0">
-                <a:solidFill>
-                  <a:srgbClr val="262626"/>
-                </a:solidFill>
-                <a:latin typeface="Arial"/>
-              </a:rPr>
-              <a:t> de </a:t>
-            </a:r>
-            <a:r>
-              <a:rPr lang="es-ES" sz="2200" b="0" dirty="0" err="1">
-                <a:solidFill>
-                  <a:srgbClr val="262626"/>
-                </a:solidFill>
-                <a:latin typeface="Arial"/>
-              </a:rPr>
-              <a:t>ports</a:t>
-            </a:r>
-            <a:r>
-              <a:rPr lang="es-ES" sz="2200" b="0" dirty="0">
-                <a:solidFill>
-                  <a:srgbClr val="262626"/>
-                </a:solidFill>
-                <a:latin typeface="Arial"/>
-              </a:rPr>
-              <a:t> de </a:t>
-            </a:r>
-            <a:r>
-              <a:rPr lang="es-ES" sz="2200" b="0" dirty="0" err="1">
-                <a:solidFill>
-                  <a:srgbClr val="262626"/>
-                </a:solidFill>
-                <a:latin typeface="Arial"/>
-              </a:rPr>
-              <a:t>sortida</a:t>
-            </a:r>
-            <a:r>
-              <a:rPr lang="es-ES" sz="2200" b="0" dirty="0">
-                <a:solidFill>
-                  <a:srgbClr val="262626"/>
-                </a:solidFill>
-                <a:latin typeface="Arial"/>
-              </a:rPr>
-              <a:t> per interactuar </a:t>
-            </a:r>
-            <a:r>
-              <a:rPr lang="es-ES" sz="2200" b="0" dirty="0" err="1">
-                <a:solidFill>
-                  <a:srgbClr val="262626"/>
-                </a:solidFill>
-                <a:latin typeface="Arial"/>
-              </a:rPr>
-              <a:t>amb</a:t>
-            </a:r>
-            <a:r>
-              <a:rPr lang="es-ES" sz="2200" b="0" dirty="0">
-                <a:solidFill>
-                  <a:srgbClr val="262626"/>
-                </a:solidFill>
-                <a:latin typeface="Arial"/>
-              </a:rPr>
-              <a:t> </a:t>
-            </a:r>
-            <a:r>
-              <a:rPr lang="es-ES" sz="2200" b="0" dirty="0" err="1">
-                <a:solidFill>
-                  <a:srgbClr val="262626"/>
-                </a:solidFill>
-                <a:latin typeface="Arial"/>
-              </a:rPr>
-              <a:t>APIs</a:t>
-            </a:r>
-            <a:r>
-              <a:rPr lang="es-ES" sz="2200" b="0" dirty="0">
-                <a:solidFill>
-                  <a:srgbClr val="262626"/>
-                </a:solidFill>
-                <a:latin typeface="Arial"/>
-              </a:rPr>
-              <a:t> externes de manera desacoblada. </a:t>
-            </a:r>
-            <a:endParaRPr sz="2200" b="0" dirty="0">
-              <a:solidFill>
-                <a:srgbClr val="262626"/>
-              </a:solidFill>
-              <a:latin typeface="Arial"/>
-            </a:endParaRPr>
-          </a:p>
-        </p:txBody>
-      </p:sp>
-      <p:sp>
-        <p:nvSpPr>
-          <p:cNvPr id="10" name="TextBox 9"/>
-          <p:cNvSpPr txBox="1"/>
-          <p:nvPr/>
-        </p:nvSpPr>
-        <p:spPr>
-          <a:xfrm>
-            <a:off x="960120" y="5669280"/>
-            <a:ext cx="9875520" cy="320040"/>
-          </a:xfrm>
-          <a:prstGeom prst="rect">
-            <a:avLst/>
-          </a:prstGeom>
-          <a:noFill/>
-        </p:spPr>
-        <p:txBody>
-          <a:bodyPr wrap="square">
-            <a:normAutofit/>
-          </a:bodyPr>
-          <a:lstStyle/>
-          <a:p>
-            <a:pPr algn="ctr"/>
-            <a:r>
-              <a:rPr sz="1300" b="0">
-                <a:solidFill>
-                  <a:srgbClr val="66707A"/>
-                </a:solidFill>
-                <a:latin typeface="Arial"/>
-              </a:rPr>
-              <a:t>Pla docent 103322: clean/hexagonal architecture, ports i adaptadors, mapping, mòduls i DDD.</a:t>
-            </a:r>
-          </a:p>
-        </p:txBody>
-      </p:sp>
-      <p:sp>
-        <p:nvSpPr>
-          <p:cNvPr id="11" name="TextBox 10"/>
-          <p:cNvSpPr txBox="1"/>
-          <p:nvPr/>
-        </p:nvSpPr>
-        <p:spPr>
-          <a:xfrm>
-            <a:off x="594360" y="6473952"/>
-            <a:ext cx="8595360" cy="201168"/>
-          </a:xfrm>
-          <a:prstGeom prst="rect">
-            <a:avLst/>
-          </a:prstGeom>
-          <a:noFill/>
-        </p:spPr>
-        <p:txBody>
-          <a:bodyPr wrap="square">
-            <a:normAutofit lnSpcReduction="10000"/>
-          </a:bodyPr>
-          <a:lstStyle/>
-          <a:p>
-            <a:pPr algn="l"/>
-            <a:r>
-              <a:rPr sz="800" b="0">
-                <a:solidFill>
-                  <a:srgbClr val="66707A"/>
-                </a:solidFill>
-                <a:latin typeface="Arial"/>
-              </a:rPr>
-              <a:t>Disseny de Sistemes d'Informació · Ports de sortida en arquitectura hexagonal</a:t>
-            </a:r>
-          </a:p>
-        </p:txBody>
-      </p:sp>
-      <p:sp>
-        <p:nvSpPr>
-          <p:cNvPr id="12" name="TextBox 11"/>
-          <p:cNvSpPr txBox="1"/>
-          <p:nvPr/>
-        </p:nvSpPr>
-        <p:spPr>
-          <a:xfrm>
-            <a:off x="11155680" y="6473952"/>
-            <a:ext cx="411480" cy="201168"/>
-          </a:xfrm>
-          <a:prstGeom prst="rect">
-            <a:avLst/>
-          </a:prstGeom>
-          <a:noFill/>
-        </p:spPr>
-        <p:txBody>
-          <a:bodyPr wrap="square">
-            <a:normAutofit lnSpcReduction="10000"/>
-          </a:bodyPr>
-          <a:lstStyle/>
-          <a:p>
-            <a:pPr algn="r"/>
-            <a:r>
-              <a:rPr sz="800" b="0">
-                <a:solidFill>
-                  <a:srgbClr val="66707A"/>
-                </a:solidFill>
-                <a:latin typeface="Arial"/>
-              </a:rPr>
-              <a:t>2</a:t>
-            </a:r>
-          </a:p>
-        </p:txBody>
-      </p:sp>
-    </p:spTree>
-  </p:cSld>
-  <p:clrMapOvr>
-    <a:masterClrMapping/>
-  </p:clrMapOvr>
-</p:sld>
-</file>
-
-<file path=ppt/slides/slide3.xml><?xml version="1.0" encoding="utf-8"?>
 <p:sld xmlns:a="http://schemas.openxmlformats.org/drawingml/2006/main" xmlns:r="http://schemas.openxmlformats.org/officeDocument/2006/relationships" xmlns:p="http://schemas.openxmlformats.org/presentationml/2006/main">
   <p:cSld>
     <p:spTree>
@@ -7580,14 +6921,49 @@
                 </a:solidFill>
                 <a:latin typeface="Arial"/>
               </a:rPr>
-              <a:t>Objectiu d'aprenentatge</a:t>
+              <a:t>On som dins l'assignatura</a:t>
+            </a:r>
+          </a:p>
+        </p:txBody>
+      </p:sp>
+      <p:sp>
+        <p:nvSpPr>
+          <p:cNvPr id="3" name="TextBox 2"/>
+          <p:cNvSpPr txBox="1"/>
+          <p:nvPr/>
+        </p:nvSpPr>
+        <p:spPr>
+          <a:xfrm>
+            <a:off x="612648" y="822960"/>
+            <a:ext cx="8869680" cy="320040"/>
+          </a:xfrm>
+          <a:prstGeom prst="rect">
+            <a:avLst/>
+          </a:prstGeom>
+          <a:noFill/>
+        </p:spPr>
+        <p:txBody>
+          <a:bodyPr wrap="square">
+            <a:normAutofit/>
+          </a:bodyPr>
+          <a:lstStyle/>
+          <a:p>
+            <a:pPr algn="l"/>
+            <a:r>
+              <a:rPr sz="1300" b="0">
+                <a:solidFill>
+                  <a:srgbClr val="66707A"/>
+                </a:solidFill>
+                <a:latin typeface="Arial"/>
+              </a:rPr>
+              <a:t>Disseny de Sistemes d'Informació</a:t>
             </a:r>
           </a:p>
         </p:txBody>
       </p:sp>
       <p:pic>
         <p:nvPicPr>
-          <p:cNvPr id="3" name="Picture 2" descr="logotip-oficial-tecnocampus-upf-horitzontal-color.png"/>
+          <p:cNvPr id="4" name="Picture 3" descr="logotip-oficial-tecnocampus-upf-horitzontal-color.png"/>
           <p:cNvPicPr>
             <a:picLocks noChangeAspect="1"/>
           </p:cNvPicPr>
@@ -7611,7 +6987,7 @@
       </p:pic>
       <p:sp>
         <p:nvSpPr>
-          <p:cNvPr id="4" name="Rectangle 3"/>
+          <p:cNvPr id="5" name="Rectangle 4"/>
           <p:cNvSpPr/>
           <p:nvPr/>
         </p:nvSpPr>
@@ -7655,6 +7031,711 @@
       </p:sp>
       <p:sp>
         <p:nvSpPr>
+          <p:cNvPr id="6" name="TextBox 5"/>
+          <p:cNvSpPr txBox="1"/>
+          <p:nvPr/>
+        </p:nvSpPr>
+        <p:spPr>
+          <a:xfrm>
+            <a:off x="822960" y="1508760"/>
+            <a:ext cx="3749039" cy="914400"/>
+          </a:xfrm>
+          <a:prstGeom prst="rect">
+            <a:avLst/>
+          </a:prstGeom>
+          <a:noFill/>
+        </p:spPr>
+        <p:txBody>
+          <a:bodyPr wrap="square">
+            <a:normAutofit fontScale="77500" lnSpcReduction="20000"/>
+          </a:bodyPr>
+          <a:lstStyle/>
+          <a:p>
+            <a:pPr algn="ctr"/>
+            <a:r>
+              <a:rPr sz="2800" b="1">
+                <a:solidFill>
+                  <a:srgbClr val="192D3E"/>
+                </a:solidFill>
+                <a:latin typeface="Arial"/>
+              </a:rPr>
+              <a:t>Disseny de Sistemes d'Informació
+3r curs · 6 ECTS</a:t>
+            </a:r>
+          </a:p>
+        </p:txBody>
+      </p:sp>
+      <p:sp>
+        <p:nvSpPr>
+          <p:cNvPr id="7" name="Rounded Rectangle 6"/>
+          <p:cNvSpPr/>
+          <p:nvPr/>
+        </p:nvSpPr>
+        <p:spPr>
+          <a:xfrm>
+            <a:off x="4800600" y="1508760"/>
+            <a:ext cx="45720" cy="3200400"/>
+          </a:xfrm>
+          <a:prstGeom prst="roundRect">
+            <a:avLst/>
+          </a:prstGeom>
+          <a:solidFill>
+            <a:srgbClr val="236092"/>
+          </a:solidFill>
+          <a:ln w="9525">
+            <a:solidFill>
+              <a:srgbClr val="236092"/>
+            </a:solidFill>
+          </a:ln>
+        </p:spPr>
+        <p:style>
+          <a:lnRef idx="1">
+            <a:schemeClr val="accent1"/>
+          </a:lnRef>
+          <a:fillRef idx="3">
+            <a:schemeClr val="accent1"/>
+          </a:fillRef>
+          <a:effectRef idx="2">
+            <a:schemeClr val="accent1"/>
+          </a:effectRef>
+          <a:fontRef idx="minor">
+            <a:schemeClr val="lt1"/>
+          </a:fontRef>
+        </p:style>
+        <p:txBody>
+          <a:bodyPr rtlCol="0" anchor="ctr"/>
+          <a:lstStyle/>
+          <a:p>
+            <a:pPr algn="ctr"/>
+            <a:endParaRPr/>
+          </a:p>
+        </p:txBody>
+      </p:sp>
+      <p:sp>
+        <p:nvSpPr>
+          <p:cNvPr id="8" name="TextBox 7"/>
+          <p:cNvSpPr txBox="1"/>
+          <p:nvPr/>
+        </p:nvSpPr>
+        <p:spPr>
+          <a:xfrm>
+            <a:off x="5166360" y="1508760"/>
+            <a:ext cx="5394960" cy="1051560"/>
+          </a:xfrm>
+          <a:prstGeom prst="rect">
+            <a:avLst/>
+          </a:prstGeom>
+          <a:noFill/>
+        </p:spPr>
+        <p:txBody>
+          <a:bodyPr wrap="square">
+            <a:normAutofit/>
+          </a:bodyPr>
+          <a:lstStyle/>
+          <a:p>
+            <a:pPr algn="ctr"/>
+            <a:r>
+              <a:rPr sz="3000" b="1" dirty="0">
+                <a:solidFill>
+                  <a:srgbClr val="192D3E"/>
+                </a:solidFill>
+                <a:latin typeface="Arial"/>
+              </a:rPr>
+              <a:t>Ports de </a:t>
+            </a:r>
+            <a:r>
+              <a:rPr sz="3000" b="1" dirty="0" err="1">
+                <a:solidFill>
+                  <a:srgbClr val="192D3E"/>
+                </a:solidFill>
+                <a:latin typeface="Arial"/>
+              </a:rPr>
+              <a:t>sortida</a:t>
+            </a:r>
+            <a:r>
+              <a:rPr sz="3000" b="1" dirty="0">
+                <a:solidFill>
+                  <a:srgbClr val="192D3E"/>
+                </a:solidFill>
+                <a:latin typeface="Arial"/>
+              </a:rPr>
+              <a:t>
+</a:t>
+            </a:r>
+            <a:r>
+              <a:rPr sz="3000" b="1" dirty="0" err="1">
+                <a:solidFill>
+                  <a:srgbClr val="192D3E"/>
+                </a:solidFill>
+                <a:latin typeface="Arial"/>
+              </a:rPr>
+              <a:t>en</a:t>
+            </a:r>
+            <a:r>
+              <a:rPr sz="3000" b="1" dirty="0">
+                <a:solidFill>
+                  <a:srgbClr val="192D3E"/>
+                </a:solidFill>
+                <a:latin typeface="Arial"/>
+              </a:rPr>
+              <a:t> </a:t>
+            </a:r>
+            <a:r>
+              <a:rPr lang="es-ES" sz="3000" b="1" dirty="0">
+                <a:solidFill>
+                  <a:srgbClr val="192D3E"/>
+                </a:solidFill>
+                <a:latin typeface="Arial"/>
+              </a:rPr>
+              <a:t>A</a:t>
+            </a:r>
+            <a:r>
+              <a:rPr sz="3000" b="1" dirty="0" err="1">
+                <a:solidFill>
+                  <a:srgbClr val="192D3E"/>
+                </a:solidFill>
+                <a:latin typeface="Arial"/>
+              </a:rPr>
+              <a:t>rquitectura</a:t>
+            </a:r>
+            <a:r>
+              <a:rPr sz="3000" b="1" dirty="0">
+                <a:solidFill>
+                  <a:srgbClr val="192D3E"/>
+                </a:solidFill>
+                <a:latin typeface="Arial"/>
+              </a:rPr>
+              <a:t> </a:t>
+            </a:r>
+            <a:r>
+              <a:rPr lang="es-ES" sz="3000" b="1" dirty="0">
+                <a:solidFill>
+                  <a:srgbClr val="192D3E"/>
+                </a:solidFill>
+                <a:latin typeface="Arial"/>
+              </a:rPr>
+              <a:t>H</a:t>
+            </a:r>
+            <a:r>
+              <a:rPr sz="3000" b="1" dirty="0" err="1">
+                <a:solidFill>
+                  <a:srgbClr val="192D3E"/>
+                </a:solidFill>
+                <a:latin typeface="Arial"/>
+              </a:rPr>
+              <a:t>exagonal</a:t>
+            </a:r>
+            <a:endParaRPr sz="3000" b="1" dirty="0">
+              <a:solidFill>
+                <a:srgbClr val="192D3E"/>
+              </a:solidFill>
+              <a:latin typeface="Arial"/>
+            </a:endParaRPr>
+          </a:p>
+        </p:txBody>
+      </p:sp>
+      <p:sp>
+        <p:nvSpPr>
+          <p:cNvPr id="9" name="TextBox 8"/>
+          <p:cNvSpPr txBox="1"/>
+          <p:nvPr/>
+        </p:nvSpPr>
+        <p:spPr>
+          <a:xfrm>
+            <a:off x="5394960" y="2971800"/>
+            <a:ext cx="4983480" cy="1143000"/>
+          </a:xfrm>
+          <a:prstGeom prst="rect">
+            <a:avLst/>
+          </a:prstGeom>
+          <a:noFill/>
+        </p:spPr>
+        <p:txBody>
+          <a:bodyPr wrap="square">
+            <a:normAutofit fontScale="70000" lnSpcReduction="20000"/>
+          </a:bodyPr>
+          <a:lstStyle/>
+          <a:p>
+            <a:pPr algn="ctr"/>
+            <a:r>
+              <a:rPr sz="2200" b="0" dirty="0">
+                <a:solidFill>
+                  <a:srgbClr val="262626"/>
+                </a:solidFill>
+                <a:latin typeface="Arial"/>
+              </a:rPr>
+              <a:t>
+</a:t>
+            </a:r>
+            <a:r>
+              <a:rPr lang="es-ES" sz="2200" b="0" dirty="0">
+                <a:solidFill>
+                  <a:srgbClr val="262626"/>
+                </a:solidFill>
+                <a:latin typeface="Arial"/>
+              </a:rPr>
+              <a:t> La </a:t>
+            </a:r>
+            <a:r>
+              <a:rPr lang="es-ES" sz="2200" b="0" dirty="0" err="1">
+                <a:solidFill>
+                  <a:srgbClr val="262626"/>
+                </a:solidFill>
+                <a:latin typeface="Arial"/>
+              </a:rPr>
+              <a:t>sessió</a:t>
+            </a:r>
+            <a:r>
+              <a:rPr lang="es-ES" sz="2200" b="0" dirty="0">
+                <a:solidFill>
+                  <a:srgbClr val="262626"/>
+                </a:solidFill>
+                <a:latin typeface="Arial"/>
+              </a:rPr>
+              <a:t> se centra en el </a:t>
+            </a:r>
+            <a:r>
+              <a:rPr lang="es-ES" sz="2200" b="0" dirty="0" err="1">
+                <a:solidFill>
+                  <a:srgbClr val="262626"/>
+                </a:solidFill>
+                <a:latin typeface="Arial"/>
+              </a:rPr>
+              <a:t>disseny</a:t>
+            </a:r>
+            <a:r>
+              <a:rPr lang="es-ES" sz="2200" b="0" dirty="0">
+                <a:solidFill>
+                  <a:srgbClr val="262626"/>
+                </a:solidFill>
+                <a:latin typeface="Arial"/>
+              </a:rPr>
+              <a:t> de </a:t>
+            </a:r>
+            <a:r>
+              <a:rPr lang="es-ES" sz="2200" b="0" dirty="0" err="1">
+                <a:solidFill>
+                  <a:srgbClr val="262626"/>
+                </a:solidFill>
+                <a:latin typeface="Arial"/>
+              </a:rPr>
+              <a:t>ports</a:t>
+            </a:r>
+            <a:r>
+              <a:rPr lang="es-ES" sz="2200" b="0" dirty="0">
+                <a:solidFill>
+                  <a:srgbClr val="262626"/>
+                </a:solidFill>
+                <a:latin typeface="Arial"/>
+              </a:rPr>
+              <a:t> de </a:t>
+            </a:r>
+            <a:r>
+              <a:rPr lang="es-ES" sz="2200" b="0" dirty="0" err="1">
+                <a:solidFill>
+                  <a:srgbClr val="262626"/>
+                </a:solidFill>
+                <a:latin typeface="Arial"/>
+              </a:rPr>
+              <a:t>sortida</a:t>
+            </a:r>
+            <a:r>
+              <a:rPr lang="es-ES" sz="2200" b="0" dirty="0">
+                <a:solidFill>
+                  <a:srgbClr val="262626"/>
+                </a:solidFill>
+                <a:latin typeface="Arial"/>
+              </a:rPr>
+              <a:t> </a:t>
+            </a:r>
+            <a:r>
+              <a:rPr lang="es-ES" sz="2200" b="0" dirty="0" err="1">
+                <a:solidFill>
+                  <a:srgbClr val="262626"/>
+                </a:solidFill>
+                <a:latin typeface="Arial"/>
+              </a:rPr>
+              <a:t>com</a:t>
+            </a:r>
+            <a:r>
+              <a:rPr lang="es-ES" sz="2200" b="0" dirty="0">
+                <a:solidFill>
+                  <a:srgbClr val="262626"/>
+                </a:solidFill>
+                <a:latin typeface="Arial"/>
+              </a:rPr>
+              <a:t> a </a:t>
+            </a:r>
+            <a:r>
+              <a:rPr lang="es-ES" sz="2200" b="0" dirty="0" err="1">
+                <a:solidFill>
+                  <a:srgbClr val="262626"/>
+                </a:solidFill>
+                <a:latin typeface="Arial"/>
+              </a:rPr>
+              <a:t>mecanisme</a:t>
+            </a:r>
+            <a:r>
+              <a:rPr lang="es-ES" sz="2200" b="0" dirty="0">
+                <a:solidFill>
+                  <a:srgbClr val="262626"/>
+                </a:solidFill>
+                <a:latin typeface="Arial"/>
+              </a:rPr>
+              <a:t> per separar les </a:t>
+            </a:r>
+            <a:r>
+              <a:rPr lang="es-ES" sz="2200" b="0" dirty="0" err="1">
+                <a:solidFill>
+                  <a:srgbClr val="262626"/>
+                </a:solidFill>
+                <a:latin typeface="Arial"/>
+              </a:rPr>
+              <a:t>necessitats</a:t>
+            </a:r>
+            <a:r>
+              <a:rPr lang="es-ES" sz="2200" b="0" dirty="0">
+                <a:solidFill>
+                  <a:srgbClr val="262626"/>
+                </a:solidFill>
+                <a:latin typeface="Arial"/>
+              </a:rPr>
+              <a:t> del cas </a:t>
+            </a:r>
+            <a:r>
+              <a:rPr lang="es-ES" sz="2200" b="0" dirty="0" err="1">
+                <a:solidFill>
+                  <a:srgbClr val="262626"/>
+                </a:solidFill>
+                <a:latin typeface="Arial"/>
+              </a:rPr>
+              <a:t>d’ús</a:t>
+            </a:r>
+            <a:r>
+              <a:rPr lang="es-ES" sz="2200" b="0" dirty="0">
+                <a:solidFill>
+                  <a:srgbClr val="262626"/>
+                </a:solidFill>
+                <a:latin typeface="Arial"/>
+              </a:rPr>
+              <a:t> </a:t>
+            </a:r>
+            <a:r>
+              <a:rPr lang="es-ES" sz="2200" b="0" dirty="0" err="1">
+                <a:solidFill>
+                  <a:srgbClr val="262626"/>
+                </a:solidFill>
+                <a:latin typeface="Arial"/>
+              </a:rPr>
+              <a:t>dels</a:t>
+            </a:r>
+            <a:r>
+              <a:rPr lang="es-ES" sz="2200" b="0" dirty="0">
+                <a:solidFill>
+                  <a:srgbClr val="262626"/>
+                </a:solidFill>
+                <a:latin typeface="Arial"/>
+              </a:rPr>
+              <a:t> </a:t>
+            </a:r>
+            <a:r>
+              <a:rPr lang="es-ES" sz="2200" b="0" dirty="0" err="1">
+                <a:solidFill>
+                  <a:srgbClr val="262626"/>
+                </a:solidFill>
+                <a:latin typeface="Arial"/>
+              </a:rPr>
+              <a:t>detalls</a:t>
+            </a:r>
+            <a:r>
+              <a:rPr lang="es-ES" sz="2200" b="0" dirty="0">
+                <a:solidFill>
+                  <a:srgbClr val="262626"/>
+                </a:solidFill>
+                <a:latin typeface="Arial"/>
+              </a:rPr>
+              <a:t> </a:t>
+            </a:r>
+            <a:r>
+              <a:rPr lang="es-ES" sz="2200" b="0" dirty="0" err="1">
+                <a:solidFill>
+                  <a:srgbClr val="262626"/>
+                </a:solidFill>
+                <a:latin typeface="Arial"/>
+              </a:rPr>
+              <a:t>tècnics</a:t>
+            </a:r>
+            <a:r>
+              <a:rPr lang="es-ES" sz="2200" b="0" dirty="0">
+                <a:solidFill>
+                  <a:srgbClr val="262626"/>
+                </a:solidFill>
+                <a:latin typeface="Arial"/>
+              </a:rPr>
+              <a:t> de les </a:t>
+            </a:r>
+            <a:r>
+              <a:rPr lang="es-ES" sz="2200" b="0" dirty="0" err="1">
+                <a:solidFill>
+                  <a:srgbClr val="262626"/>
+                </a:solidFill>
+                <a:latin typeface="Arial"/>
+              </a:rPr>
+              <a:t>integracions</a:t>
+            </a:r>
+            <a:r>
+              <a:rPr lang="es-ES" sz="2200" b="0" dirty="0">
+                <a:solidFill>
+                  <a:srgbClr val="262626"/>
+                </a:solidFill>
+                <a:latin typeface="Arial"/>
+              </a:rPr>
+              <a:t> externes.</a:t>
+            </a:r>
+            <a:endParaRPr sz="2200" b="0" dirty="0">
+              <a:solidFill>
+                <a:srgbClr val="262626"/>
+              </a:solidFill>
+              <a:latin typeface="Arial"/>
+            </a:endParaRPr>
+          </a:p>
+        </p:txBody>
+      </p:sp>
+      <p:sp>
+        <p:nvSpPr>
+          <p:cNvPr id="10" name="TextBox 9"/>
+          <p:cNvSpPr txBox="1"/>
+          <p:nvPr/>
+        </p:nvSpPr>
+        <p:spPr>
+          <a:xfrm>
+            <a:off x="960120" y="5669280"/>
+            <a:ext cx="9875520" cy="320040"/>
+          </a:xfrm>
+          <a:prstGeom prst="rect">
+            <a:avLst/>
+          </a:prstGeom>
+          <a:noFill/>
+        </p:spPr>
+        <p:txBody>
+          <a:bodyPr wrap="square">
+            <a:normAutofit/>
+          </a:bodyPr>
+          <a:lstStyle/>
+          <a:p>
+            <a:pPr algn="ctr"/>
+            <a:r>
+              <a:rPr sz="1300" b="0">
+                <a:solidFill>
+                  <a:srgbClr val="66707A"/>
+                </a:solidFill>
+                <a:latin typeface="Arial"/>
+              </a:rPr>
+              <a:t>Pla docent 103322: clean/hexagonal architecture, ports i adaptadors, mapping, mòduls i DDD.</a:t>
+            </a:r>
+          </a:p>
+        </p:txBody>
+      </p:sp>
+      <p:sp>
+        <p:nvSpPr>
+          <p:cNvPr id="11" name="TextBox 10"/>
+          <p:cNvSpPr txBox="1"/>
+          <p:nvPr/>
+        </p:nvSpPr>
+        <p:spPr>
+          <a:xfrm>
+            <a:off x="594360" y="6473952"/>
+            <a:ext cx="8595360" cy="201168"/>
+          </a:xfrm>
+          <a:prstGeom prst="rect">
+            <a:avLst/>
+          </a:prstGeom>
+          <a:noFill/>
+        </p:spPr>
+        <p:txBody>
+          <a:bodyPr wrap="square">
+            <a:normAutofit lnSpcReduction="10000"/>
+          </a:bodyPr>
+          <a:lstStyle/>
+          <a:p>
+            <a:pPr algn="l"/>
+            <a:r>
+              <a:rPr sz="800" b="0">
+                <a:solidFill>
+                  <a:srgbClr val="66707A"/>
+                </a:solidFill>
+                <a:latin typeface="Arial"/>
+              </a:rPr>
+              <a:t>Disseny de Sistemes d'Informació · Ports de sortida en arquitectura hexagonal</a:t>
+            </a:r>
+          </a:p>
+        </p:txBody>
+      </p:sp>
+      <p:sp>
+        <p:nvSpPr>
+          <p:cNvPr id="12" name="TextBox 11"/>
+          <p:cNvSpPr txBox="1"/>
+          <p:nvPr/>
+        </p:nvSpPr>
+        <p:spPr>
+          <a:xfrm>
+            <a:off x="11155680" y="6473952"/>
+            <a:ext cx="411480" cy="201168"/>
+          </a:xfrm>
+          <a:prstGeom prst="rect">
+            <a:avLst/>
+          </a:prstGeom>
+          <a:noFill/>
+        </p:spPr>
+        <p:txBody>
+          <a:bodyPr wrap="square">
+            <a:normAutofit lnSpcReduction="10000"/>
+          </a:bodyPr>
+          <a:lstStyle/>
+          <a:p>
+            <a:pPr algn="r"/>
+            <a:r>
+              <a:rPr sz="800" b="0">
+                <a:solidFill>
+                  <a:srgbClr val="66707A"/>
+                </a:solidFill>
+                <a:latin typeface="Arial"/>
+              </a:rPr>
+              <a:t>2</a:t>
+            </a:r>
+          </a:p>
+        </p:txBody>
+      </p:sp>
+    </p:spTree>
+  </p:cSld>
+  <p:clrMapOvr>
+    <a:masterClrMapping/>
+  </p:clrMapOvr>
+</p:sld>
+</file>
+
+<file path=ppt/slides/slide3.xml><?xml version="1.0" encoding="utf-8"?>
+<p:sld xmlns:a="http://schemas.openxmlformats.org/drawingml/2006/main" xmlns:ns3="http://schemas.microsoft.com/office/drawing/2014/main" xmlns:ns4="http://schemas.microsoft.com/office/drawing/2010/main" xmlns:p="http://schemas.openxmlformats.org/presentationml/2006/main" xmlns:r="http://schemas.openxmlformats.org/officeDocument/2006/relationships">
+  <p:cSld>
+    <p:spTree>
+      <p:nvGrpSpPr>
+        <p:cNvPr id="1" name=""/>
+        <p:cNvGrpSpPr/>
+        <p:nvPr/>
+      </p:nvGrpSpPr>
+      <p:grpSpPr>
+        <a:xfrm>
+          <a:off x="0" y="0"/>
+          <a:ext cx="0" cy="0"/>
+          <a:chOff x="0" y="0"/>
+          <a:chExt cx="0" cy="0"/>
+        </a:xfrm>
+      </p:grpSpPr>
+      <p:sp>
+        <p:nvSpPr>
+          <p:cNvPr id="2" name="TextBox 1"/>
+          <p:cNvSpPr txBox="1"/>
+          <p:nvPr/>
+        </p:nvSpPr>
+        <p:spPr>
+          <a:xfrm>
+            <a:off x="594360" y="320040"/>
+            <a:ext cx="8961120" cy="502920"/>
+          </a:xfrm>
+          <a:prstGeom prst="rect">
+            <a:avLst/>
+          </a:prstGeom>
+          <a:noFill/>
+        </p:spPr>
+        <p:txBody>
+          <a:bodyPr wrap="square">
+            <a:normAutofit lnSpcReduction="10000"/>
+          </a:bodyPr>
+          <a:lstStyle/>
+          <a:p>
+            <a:pPr algn="l"/>
+            <a:r>
+              <a:rPr sz="2800" b="1">
+                <a:solidFill>
+                  <a:srgbClr val="192D3E"/>
+                </a:solidFill>
+                <a:latin typeface="Arial"/>
+              </a:rPr>
+              <a:t>Principi de disseny</a:t>
+            </a:r>
+          </a:p>
+        </p:txBody>
+      </p:sp>
+      <p:pic>
+        <p:nvPicPr>
+          <p:cNvPr id="3" name="Picture 2" descr="logotip-oficial-tecnocampus-upf-horitzontal-color.png"/>
+          <p:cNvPicPr>
+            <a:picLocks noChangeAspect="1"/>
+          </p:cNvPicPr>
+          <p:nvPr/>
+        </p:nvPicPr>
+        <p:blipFill>
+          <a:blip r:embed="rId2"/>
+          <a:stretch>
+            <a:fillRect/>
+          </a:stretch>
+        </p:blipFill>
+        <p:spPr>
+          <a:xfrm>
+            <a:off x="8480078" y="293025"/>
+            <a:ext cx="3041362" cy="575655"/>
+          </a:xfrm>
+          <a:prstGeom prst="rect">
+            <a:avLst/>
+          </a:prstGeom>
+        </p:spPr>
+      </p:pic>
+      <p:sp>
+        <p:nvSpPr>
+          <p:cNvPr id="4" name="Rectangle 3"/>
+          <p:cNvSpPr/>
+          <p:nvPr/>
+        </p:nvSpPr>
+        <p:spPr>
+          <a:xfrm>
+            <a:off x="594360" y="1115568"/>
+            <a:ext cx="10972800" cy="13716"/>
+          </a:xfrm>
+          <a:prstGeom prst="rect">
+            <a:avLst/>
+          </a:prstGeom>
+          <a:solidFill>
+            <a:srgbClr val="D6DBE0"/>
+          </a:solidFill>
+          <a:ln>
+            <a:noFill/>
+          </a:ln>
+        </p:spPr>
+        <p:style>
+          <a:lnRef idx="1">
+            <a:schemeClr val="accent1"/>
+          </a:lnRef>
+          <a:fillRef idx="3">
+            <a:schemeClr val="accent1"/>
+          </a:fillRef>
+          <a:effectRef idx="2">
+            <a:schemeClr val="accent1"/>
+          </a:effectRef>
+          <a:fontRef idx="minor">
+            <a:schemeClr val="lt1"/>
+          </a:fontRef>
+        </p:style>
+        <p:txBody>
+          <a:bodyPr rtlCol="0" anchor="ctr"/>
+          <a:lstStyle/>
+          <a:p>
+            <a:pPr algn="ctr"/>
+            <a:endParaRPr/>
+          </a:p>
+        </p:txBody>
+      </p:sp>
+      <p:sp>
+        <p:nvSpPr>
           <p:cNvPr id="5" name="TextBox 4"/>
           <p:cNvSpPr txBox="1"/>
           <p:nvPr/>
@@ -7889,7 +7970,7 @@
           <p:cNvPr id="1026" name="Picture 2">
             <a:extLst>
               <a:ext uri="{FF2B5EF4-FFF2-40B4-BE49-F238E27FC236}">
-                <a16:creationId xmlns:a16="http://schemas.microsoft.com/office/drawing/2014/main" id="{24324096-D33B-3CBF-C022-BFBBD6A631DD}"/>
+                <ns3:creationId id="{24324096-D33B-3CBF-C022-BFBBD6A631DD}"/>
               </a:ext>
             </a:extLst>
           </p:cNvPr>
@@ -7902,7 +7983,7 @@
           <a:blip r:embed="rId3">
             <a:extLst>
               <a:ext uri="{28A0092B-C50C-407E-A947-70E740481C1C}">
-                <a14:useLocalDpi xmlns:a14="http://schemas.microsoft.com/office/drawing/2010/main" val="0"/>
+                <ns4:useLocalDpi val="0"/>
               </a:ext>
             </a:extLst>
           </a:blip>
@@ -7922,11 +8003,11 @@
           <a:noFill/>
           <a:extLst>
             <a:ext uri="{909E8E84-426E-40DD-AFC4-6F175D3DCCD1}">
-              <a14:hiddenFill xmlns:a14="http://schemas.microsoft.com/office/drawing/2010/main">
+              <ns4:hiddenFill>
                 <a:solidFill>
                   <a:srgbClr val="FFFFFF"/>
                 </a:solidFill>
-              </a14:hiddenFill>
+              </ns4:hiddenFill>
             </a:ext>
           </a:extLst>
         </p:spPr>
@@ -7940,14 +8021,14 @@
 </file>
 
 <file path=ppt/slides/slide4.xml><?xml version="1.0" encoding="utf-8"?>
-<p:sld xmlns:a="http://schemas.openxmlformats.org/drawingml/2006/main" xmlns:r="http://schemas.openxmlformats.org/officeDocument/2006/relationships" xmlns:p="http://schemas.openxmlformats.org/presentationml/2006/main">
+<p:sld xmlns:a="http://schemas.openxmlformats.org/drawingml/2006/main" xmlns:ns2="http://schemas.microsoft.com/office/drawing/2014/main" xmlns:ns4="http://schemas.microsoft.com/office/powerpoint/2010/main" xmlns:p="http://schemas.openxmlformats.org/presentationml/2006/main" xmlns:r="http://schemas.openxmlformats.org/officeDocument/2006/relationships">
   <p:cSld>
     <p:spTree>
       <p:nvGrpSpPr>
         <p:cNvPr id="1" name="">
           <a:extLst>
             <a:ext uri="{FF2B5EF4-FFF2-40B4-BE49-F238E27FC236}">
-              <a16:creationId xmlns:a16="http://schemas.microsoft.com/office/drawing/2014/main" id="{91787A17-E989-2125-8BF4-9FD64C66B0F7}"/>
+              <ns2:creationId id="{91787A17-E989-2125-8BF4-9FD64C66B0F7}"/>
             </a:ext>
           </a:extLst>
         </p:cNvPr>
@@ -7967,7 +8048,7 @@
           <p:cNvPr id="2" name="TextBox 1">
             <a:extLst>
               <a:ext uri="{FF2B5EF4-FFF2-40B4-BE49-F238E27FC236}">
-                <a16:creationId xmlns:a16="http://schemas.microsoft.com/office/drawing/2014/main" id="{6113BE6D-4BF0-DC81-2CE8-23039C4C9D58}"/>
+                <ns2:creationId id="{6113BE6D-4BF0-DC81-2CE8-23039C4C9D58}"/>
               </a:ext>
             </a:extLst>
           </p:cNvPr>
@@ -7998,7 +8079,7 @@
                 </a:solidFill>
                 <a:latin typeface="Arial"/>
               </a:rPr>
-              <a:t>Objectiu</a:t>
+              <a:t>Objectiu d'aprenentatge</a:t>
             </a:r>
             <a:r>
               <a:rPr sz="2800" b="1" dirty="0">
@@ -8007,7 +8088,7 @@
                 </a:solidFill>
                 <a:latin typeface="Arial"/>
               </a:rPr>
-              <a:t> </a:t>
+              <a:t/>
             </a:r>
             <a:r>
               <a:rPr sz="2800" b="1" dirty="0" err="1">
@@ -8016,7 +8097,7 @@
                 </a:solidFill>
                 <a:latin typeface="Arial"/>
               </a:rPr>
-              <a:t>d'aprenentatge</a:t>
+              <a:t/>
             </a:r>
             <a:r>
               <a:rPr lang="es-ES" sz="2800" b="1" dirty="0">
@@ -8025,7 +8106,7 @@
                 </a:solidFill>
                 <a:latin typeface="Arial"/>
               </a:rPr>
-              <a:t> II</a:t>
+              <a:t/>
             </a:r>
             <a:endParaRPr sz="2800" b="1" dirty="0">
               <a:solidFill>
@@ -8041,7 +8122,7 @@
           <p:cNvPr id="3" name="Picture 2" descr="logotip-oficial-tecnocampus-upf-horitzontal-color.png">
             <a:extLst>
               <a:ext uri="{FF2B5EF4-FFF2-40B4-BE49-F238E27FC236}">
-                <a16:creationId xmlns:a16="http://schemas.microsoft.com/office/drawing/2014/main" id="{6E5AEF9E-E38C-2981-74C2-DA381C85519D}"/>
+                <ns2:creationId id="{6E5AEF9E-E38C-2981-74C2-DA381C85519D}"/>
               </a:ext>
             </a:extLst>
           </p:cNvPr>
@@ -8071,7 +8152,7 @@
           <p:cNvPr id="4" name="Rectangle 3">
             <a:extLst>
               <a:ext uri="{FF2B5EF4-FFF2-40B4-BE49-F238E27FC236}">
-                <a16:creationId xmlns:a16="http://schemas.microsoft.com/office/drawing/2014/main" id="{565CC16B-626E-E880-45E7-0DBECBCD6306}"/>
+                <ns2:creationId id="{565CC16B-626E-E880-45E7-0DBECBCD6306}"/>
               </a:ext>
             </a:extLst>
           </p:cNvPr>
@@ -8121,7 +8202,7 @@
           <p:cNvPr id="5" name="TextBox 4">
             <a:extLst>
               <a:ext uri="{FF2B5EF4-FFF2-40B4-BE49-F238E27FC236}">
-                <a16:creationId xmlns:a16="http://schemas.microsoft.com/office/drawing/2014/main" id="{E5442AE4-020C-7BAB-E612-2262DEB4097A}"/>
+                <ns2:creationId id="{E5442AE4-020C-7BAB-E612-2262DEB4097A}"/>
               </a:ext>
             </a:extLst>
           </p:cNvPr>
@@ -8152,7 +8233,7 @@
                 </a:solidFill>
                 <a:latin typeface="Arial"/>
               </a:rPr>
-              <a:t>El </a:t>
+              <a:t>Aplicar el principi en tres operacions observables.</a:t>
             </a:r>
             <a:r>
               <a:rPr sz="2700" b="1" dirty="0" err="1">
@@ -8161,7 +8242,7 @@
                 </a:solidFill>
                 <a:latin typeface="Arial"/>
               </a:rPr>
-              <a:t>servei</a:t>
+              <a:t/>
             </a:r>
             <a:r>
               <a:rPr sz="2700" b="1" dirty="0">
@@ -8170,7 +8251,7 @@
                 </a:solidFill>
                 <a:latin typeface="Arial"/>
               </a:rPr>
-              <a:t> </a:t>
+              <a:t/>
             </a:r>
             <a:r>
               <a:rPr sz="2700" b="1" dirty="0" err="1">
@@ -8179,7 +8260,7 @@
                 </a:solidFill>
                 <a:latin typeface="Arial"/>
               </a:rPr>
-              <a:t>d'aplicació</a:t>
+              <a:t/>
             </a:r>
             <a:r>
               <a:rPr sz="2700" b="1" dirty="0">
@@ -8188,7 +8269,7 @@
                 </a:solidFill>
                 <a:latin typeface="Arial"/>
               </a:rPr>
-              <a:t> </a:t>
+              <a:t/>
             </a:r>
             <a:r>
               <a:rPr sz="2700" b="1" dirty="0" err="1">
@@ -8197,7 +8278,7 @@
                 </a:solidFill>
                 <a:latin typeface="Arial"/>
               </a:rPr>
-              <a:t>necessita</a:t>
+              <a:t/>
             </a:r>
             <a:r>
               <a:rPr sz="2700" b="1" dirty="0">
@@ -8206,7 +8287,7 @@
                 </a:solidFill>
                 <a:latin typeface="Arial"/>
               </a:rPr>
-              <a:t> </a:t>
+              <a:t/>
             </a:r>
             <a:r>
               <a:rPr sz="2700" b="1" dirty="0" err="1">
@@ -8215,7 +8296,7 @@
                 </a:solidFill>
                 <a:latin typeface="Arial"/>
               </a:rPr>
-              <a:t>una</a:t>
+              <a:t/>
             </a:r>
             <a:r>
               <a:rPr sz="2700" b="1" dirty="0">
@@ -8224,7 +8305,7 @@
                 </a:solidFill>
                 <a:latin typeface="Arial"/>
               </a:rPr>
-              <a:t> </a:t>
+              <a:t/>
             </a:r>
             <a:r>
               <a:rPr sz="2700" b="1" dirty="0" err="1">
@@ -8233,7 +8314,7 @@
                 </a:solidFill>
                 <a:latin typeface="Arial"/>
               </a:rPr>
-              <a:t>capacitat</a:t>
+              <a:t/>
             </a:r>
             <a:r>
               <a:rPr sz="2700" b="1" dirty="0">
@@ -8242,7 +8323,7 @@
                 </a:solidFill>
                 <a:latin typeface="Arial"/>
               </a:rPr>
-              <a:t>, no </a:t>
+              <a:t/>
             </a:r>
             <a:r>
               <a:rPr sz="2700" b="1" dirty="0" err="1">
@@ -8251,7 +8332,7 @@
                 </a:solidFill>
                 <a:latin typeface="Arial"/>
               </a:rPr>
-              <a:t>una</a:t>
+              <a:t/>
             </a:r>
             <a:r>
               <a:rPr sz="2700" b="1" dirty="0">
@@ -8260,7 +8341,7 @@
                 </a:solidFill>
                 <a:latin typeface="Arial"/>
               </a:rPr>
-              <a:t> </a:t>
+              <a:t/>
             </a:r>
             <a:r>
               <a:rPr sz="2700" b="1" dirty="0" err="1">
@@ -8269,7 +8350,7 @@
                 </a:solidFill>
                 <a:latin typeface="Arial"/>
               </a:rPr>
-              <a:t>tecnolog</a:t>
+              <a:t/>
             </a:r>
             <a:r>
               <a:rPr lang="es-ES" sz="2700" b="1" dirty="0">
@@ -8278,7 +8359,7 @@
                 </a:solidFill>
                 <a:latin typeface="Arial"/>
               </a:rPr>
-              <a:t>í</a:t>
+              <a:t/>
             </a:r>
             <a:r>
               <a:rPr sz="2700" b="1" dirty="0">
@@ -8287,7 +8368,7 @@
                 </a:solidFill>
                 <a:latin typeface="Arial"/>
               </a:rPr>
-              <a:t>a</a:t>
+              <a:t/>
             </a:r>
             <a:r>
               <a:rPr lang="es-ES" sz="2700" b="1" dirty="0">
@@ -8296,7 +8377,7 @@
                 </a:solidFill>
                 <a:latin typeface="Arial"/>
               </a:rPr>
-              <a:t> específica</a:t>
+              <a:t/>
             </a:r>
             <a:r>
               <a:rPr sz="2700" b="1" dirty="0">
@@ -8305,7 +8386,7 @@
                 </a:solidFill>
                 <a:latin typeface="Arial"/>
               </a:rPr>
-              <a:t>.</a:t>
+              <a:t/>
             </a:r>
           </a:p>
         </p:txBody>
@@ -8315,7 +8396,7 @@
           <p:cNvPr id="6" name="Rounded Rectangle 5">
             <a:extLst>
               <a:ext uri="{FF2B5EF4-FFF2-40B4-BE49-F238E27FC236}">
-                <a16:creationId xmlns:a16="http://schemas.microsoft.com/office/drawing/2014/main" id="{064EE3A6-5D0D-EFE6-3907-91BB6540F213}"/>
+                <ns2:creationId id="{064EE3A6-5D0D-EFE6-3907-91BB6540F213}"/>
               </a:ext>
             </a:extLst>
           </p:cNvPr>
@@ -8367,7 +8448,7 @@
           <p:cNvPr id="7" name="TextBox 6">
             <a:extLst>
               <a:ext uri="{FF2B5EF4-FFF2-40B4-BE49-F238E27FC236}">
-                <a16:creationId xmlns:a16="http://schemas.microsoft.com/office/drawing/2014/main" id="{C0F1223D-ADAB-E817-C2A8-78FB596BC6F8}"/>
+                <ns2:creationId id="{C0F1223D-ADAB-E817-C2A8-78FB596BC6F8}"/>
               </a:ext>
             </a:extLst>
           </p:cNvPr>
@@ -8398,7 +8479,8 @@
                 </a:solidFill>
                 <a:latin typeface="Arial"/>
               </a:rPr>
-              <a:t>Identificar</a:t>
+              <a:t>Identificar
+una necessitat</a:t>
             </a:r>
             <a:r>
               <a:rPr sz="2400" b="1" dirty="0">
@@ -8407,8 +8489,7 @@
                 </a:solidFill>
                 <a:latin typeface="Arial"/>
               </a:rPr>
-              <a:t>
-</a:t>
+              <a:t/>
             </a:r>
             <a:r>
               <a:rPr lang="es-ES" sz="2400" b="1" dirty="0" err="1">
@@ -8417,7 +8498,7 @@
                 </a:solidFill>
                 <a:latin typeface="Arial"/>
               </a:rPr>
-              <a:t>necessitat</a:t>
+              <a:t/>
             </a:r>
             <a:r>
               <a:rPr lang="es-ES" sz="2400" b="1" dirty="0">
@@ -8426,7 +8507,7 @@
                 </a:solidFill>
                 <a:latin typeface="Arial"/>
               </a:rPr>
-              <a:t> o </a:t>
+              <a:t/>
             </a:r>
             <a:r>
               <a:rPr lang="es-ES" sz="2400" b="1" dirty="0" err="1">
@@ -8435,7 +8516,7 @@
                 </a:solidFill>
                 <a:latin typeface="Arial"/>
               </a:rPr>
-              <a:t>capacitat</a:t>
+              <a:t/>
             </a:r>
             <a:endParaRPr lang="es-ES" sz="2400" b="1" dirty="0">
               <a:solidFill>
@@ -8460,7 +8541,7 @@
           <p:cNvPr id="8" name="Rounded Rectangle 7">
             <a:extLst>
               <a:ext uri="{FF2B5EF4-FFF2-40B4-BE49-F238E27FC236}">
-                <a16:creationId xmlns:a16="http://schemas.microsoft.com/office/drawing/2014/main" id="{460CDC97-EADA-2158-DAC3-FD27FD257839}"/>
+                <ns2:creationId id="{460CDC97-EADA-2158-DAC3-FD27FD257839}"/>
               </a:ext>
             </a:extLst>
           </p:cNvPr>
@@ -8512,7 +8593,7 @@
           <p:cNvPr id="9" name="TextBox 8">
             <a:extLst>
               <a:ext uri="{FF2B5EF4-FFF2-40B4-BE49-F238E27FC236}">
-                <a16:creationId xmlns:a16="http://schemas.microsoft.com/office/drawing/2014/main" id="{57DA438C-C49C-5E46-6F61-14F3896E8657}"/>
+                <ns2:creationId id="{57DA438C-C49C-5E46-6F61-14F3896E8657}"/>
               </a:ext>
             </a:extLst>
           </p:cNvPr>
@@ -8543,7 +8624,8 @@
                 </a:solidFill>
                 <a:latin typeface="Arial"/>
               </a:rPr>
-              <a:t>Definir</a:t>
+              <a:t>Definir
+un port</a:t>
             </a:r>
             <a:r>
               <a:rPr sz="2400" b="1" dirty="0">
@@ -8552,8 +8634,7 @@
                 </a:solidFill>
                 <a:latin typeface="Arial"/>
               </a:rPr>
-              <a:t>
-un port</a:t>
+              <a:t/>
             </a:r>
           </a:p>
         </p:txBody>
@@ -8563,7 +8644,7 @@
           <p:cNvPr id="10" name="Rounded Rectangle 9">
             <a:extLst>
               <a:ext uri="{FF2B5EF4-FFF2-40B4-BE49-F238E27FC236}">
-                <a16:creationId xmlns:a16="http://schemas.microsoft.com/office/drawing/2014/main" id="{54F82A2A-9916-E9F8-2F4C-A47E7CF470BE}"/>
+                <ns2:creationId id="{54F82A2A-9916-E9F8-2F4C-A47E7CF470BE}"/>
               </a:ext>
             </a:extLst>
           </p:cNvPr>
@@ -8615,7 +8696,7 @@
           <p:cNvPr id="11" name="TextBox 10">
             <a:extLst>
               <a:ext uri="{FF2B5EF4-FFF2-40B4-BE49-F238E27FC236}">
-                <a16:creationId xmlns:a16="http://schemas.microsoft.com/office/drawing/2014/main" id="{C6C32489-28BB-E0B4-6D88-054802179775}"/>
+                <ns2:creationId id="{C6C32489-28BB-E0B4-6D88-054802179775}"/>
               </a:ext>
             </a:extLst>
           </p:cNvPr>
@@ -8646,7 +8727,8 @@
                 </a:solidFill>
                 <a:latin typeface="Arial"/>
               </a:rPr>
-              <a:t>Implementar</a:t>
+              <a:t>Implementar
+adaptadors</a:t>
             </a:r>
             <a:r>
               <a:rPr sz="2400" b="1" dirty="0">
@@ -8655,8 +8737,16 @@
                 </a:solidFill>
                 <a:latin typeface="Arial"/>
               </a:rPr>
-              <a:t>
-</a:t>
+              <a:t/>
+            </a:r>
+            <a:r>
+              <a:rPr lang="es-ES" sz="2400" b="1" dirty="0">
+                <a:solidFill>
+                  <a:srgbClr val="192D3E"/>
+                </a:solidFill>
+                <a:latin typeface="Arial"/>
+              </a:rPr>
+              <a:t/>
             </a:r>
             <a:r>
               <a:rPr sz="2400" b="1" dirty="0" err="1">
@@ -8665,7 +8755,7 @@
                 </a:solidFill>
                 <a:latin typeface="Arial"/>
               </a:rPr>
-              <a:t>adaptadors</a:t>
+              <a:t/>
             </a:r>
             <a:endParaRPr sz="2400" b="1" dirty="0">
               <a:solidFill>
@@ -8681,7 +8771,7 @@
           <p:cNvPr id="12" name="TextBox 11">
             <a:extLst>
               <a:ext uri="{FF2B5EF4-FFF2-40B4-BE49-F238E27FC236}">
-                <a16:creationId xmlns:a16="http://schemas.microsoft.com/office/drawing/2014/main" id="{5298AC41-2EA2-3BF1-14F5-5DF9647D4D84}"/>
+                <ns2:creationId id="{5298AC41-2EA2-3BF1-14F5-5DF9647D4D84}"/>
               </a:ext>
             </a:extLst>
           </p:cNvPr>
@@ -8722,7 +8812,7 @@
           <p:cNvPr id="13" name="TextBox 12">
             <a:extLst>
               <a:ext uri="{FF2B5EF4-FFF2-40B4-BE49-F238E27FC236}">
-                <a16:creationId xmlns:a16="http://schemas.microsoft.com/office/drawing/2014/main" id="{88D08D29-A0AD-1C10-91EF-4939D83B6478}"/>
+                <ns2:creationId id="{88D08D29-A0AD-1C10-91EF-4939D83B6478}"/>
               </a:ext>
             </a:extLst>
           </p:cNvPr>
@@ -8753,7 +8843,7 @@
                 </a:solidFill>
                 <a:latin typeface="Arial"/>
               </a:rPr>
-              <a:t>3</a:t>
+              <a:t>4</a:t>
             </a:r>
           </a:p>
         </p:txBody>
@@ -8761,7 +8851,7 @@
     </p:spTree>
     <p:extLst>
       <p:ext uri="{BB962C8B-B14F-4D97-AF65-F5344CB8AC3E}">
-        <p14:creationId xmlns:p14="http://schemas.microsoft.com/office/powerpoint/2010/main" val="1026507124"/>
+        <ns4:creationId val="1026507124"/>
       </p:ext>
     </p:extLst>
   </p:cSld>

</xml_diff>

<commit_message>
docs: refine scholarship wording
</commit_message>
<xml_diff>
--- a/doc/presentations/defensa-placa-permanent-dsi-ports-sortida-hexagonal/output/IMPORTANTE_MANUAL_defensa-dsi-ports-sortida-hexagonal.pptx
+++ b/doc/presentations/defensa-placa-permanent-dsi-ports-sortida-hexagonal/output/IMPORTANTE_MANUAL_defensa-dsi-ports-sortida-hexagonal.pptx
@@ -7615,7 +7615,7 @@
 </file>
 
 <file path=ppt/slides/slide3.xml><?xml version="1.0" encoding="utf-8"?>
-<p:sld xmlns:a="http://schemas.openxmlformats.org/drawingml/2006/main" xmlns:ns3="http://schemas.microsoft.com/office/drawing/2014/main" xmlns:ns4="http://schemas.microsoft.com/office/drawing/2010/main" xmlns:p="http://schemas.openxmlformats.org/presentationml/2006/main" xmlns:r="http://schemas.openxmlformats.org/officeDocument/2006/relationships">
+<p:sld xmlns:a="http://schemas.openxmlformats.org/drawingml/2006/main" xmlns:r="http://schemas.openxmlformats.org/officeDocument/2006/relationships" xmlns:p="http://schemas.openxmlformats.org/presentationml/2006/main">
   <p:cSld>
     <p:spTree>
       <p:nvGrpSpPr>
@@ -7970,7 +7970,7 @@
           <p:cNvPr id="1026" name="Picture 2">
             <a:extLst>
               <a:ext uri="{FF2B5EF4-FFF2-40B4-BE49-F238E27FC236}">
-                <ns3:creationId id="{24324096-D33B-3CBF-C022-BFBBD6A631DD}"/>
+                <a16:creationId xmlns:a16="http://schemas.microsoft.com/office/drawing/2014/main" id="{24324096-D33B-3CBF-C022-BFBBD6A631DD}"/>
               </a:ext>
             </a:extLst>
           </p:cNvPr>
@@ -7983,7 +7983,7 @@
           <a:blip r:embed="rId3">
             <a:extLst>
               <a:ext uri="{28A0092B-C50C-407E-A947-70E740481C1C}">
-                <ns4:useLocalDpi val="0"/>
+                <a14:useLocalDpi xmlns:a14="http://schemas.microsoft.com/office/drawing/2010/main" val="0"/>
               </a:ext>
             </a:extLst>
           </a:blip>
@@ -8003,11 +8003,11 @@
           <a:noFill/>
           <a:extLst>
             <a:ext uri="{909E8E84-426E-40DD-AFC4-6F175D3DCCD1}">
-              <ns4:hiddenFill>
+              <a14:hiddenFill xmlns:a14="http://schemas.microsoft.com/office/drawing/2010/main">
                 <a:solidFill>
                   <a:srgbClr val="FFFFFF"/>
                 </a:solidFill>
-              </ns4:hiddenFill>
+              </a14:hiddenFill>
             </a:ext>
           </a:extLst>
         </p:spPr>
@@ -8021,14 +8021,14 @@
 </file>
 
 <file path=ppt/slides/slide4.xml><?xml version="1.0" encoding="utf-8"?>
-<p:sld xmlns:a="http://schemas.openxmlformats.org/drawingml/2006/main" xmlns:ns2="http://schemas.microsoft.com/office/drawing/2014/main" xmlns:ns4="http://schemas.microsoft.com/office/powerpoint/2010/main" xmlns:p="http://schemas.openxmlformats.org/presentationml/2006/main" xmlns:r="http://schemas.openxmlformats.org/officeDocument/2006/relationships">
+<p:sld xmlns:a="http://schemas.openxmlformats.org/drawingml/2006/main" xmlns:r="http://schemas.openxmlformats.org/officeDocument/2006/relationships" xmlns:p="http://schemas.openxmlformats.org/presentationml/2006/main">
   <p:cSld>
     <p:spTree>
       <p:nvGrpSpPr>
         <p:cNvPr id="1" name="">
           <a:extLst>
             <a:ext uri="{FF2B5EF4-FFF2-40B4-BE49-F238E27FC236}">
-              <ns2:creationId id="{91787A17-E989-2125-8BF4-9FD64C66B0F7}"/>
+              <a16:creationId xmlns:a16="http://schemas.microsoft.com/office/drawing/2014/main" id="{91787A17-E989-2125-8BF4-9FD64C66B0F7}"/>
             </a:ext>
           </a:extLst>
         </p:cNvPr>
@@ -8048,7 +8048,7 @@
           <p:cNvPr id="2" name="TextBox 1">
             <a:extLst>
               <a:ext uri="{FF2B5EF4-FFF2-40B4-BE49-F238E27FC236}">
-                <ns2:creationId id="{6113BE6D-4BF0-DC81-2CE8-23039C4C9D58}"/>
+                <a16:creationId xmlns:a16="http://schemas.microsoft.com/office/drawing/2014/main" id="{6113BE6D-4BF0-DC81-2CE8-23039C4C9D58}"/>
               </a:ext>
             </a:extLst>
           </p:cNvPr>
@@ -8080,33 +8080,6 @@
                 <a:latin typeface="Arial"/>
               </a:rPr>
               <a:t>Objectiu d'aprenentatge</a:t>
-            </a:r>
-            <a:r>
-              <a:rPr sz="2800" b="1" dirty="0">
-                <a:solidFill>
-                  <a:srgbClr val="192D3E"/>
-                </a:solidFill>
-                <a:latin typeface="Arial"/>
-              </a:rPr>
-              <a:t/>
-            </a:r>
-            <a:r>
-              <a:rPr sz="2800" b="1" dirty="0" err="1">
-                <a:solidFill>
-                  <a:srgbClr val="192D3E"/>
-                </a:solidFill>
-                <a:latin typeface="Arial"/>
-              </a:rPr>
-              <a:t/>
-            </a:r>
-            <a:r>
-              <a:rPr lang="es-ES" sz="2800" b="1" dirty="0">
-                <a:solidFill>
-                  <a:srgbClr val="192D3E"/>
-                </a:solidFill>
-                <a:latin typeface="Arial"/>
-              </a:rPr>
-              <a:t/>
             </a:r>
             <a:endParaRPr sz="2800" b="1" dirty="0">
               <a:solidFill>
@@ -8122,7 +8095,7 @@
           <p:cNvPr id="3" name="Picture 2" descr="logotip-oficial-tecnocampus-upf-horitzontal-color.png">
             <a:extLst>
               <a:ext uri="{FF2B5EF4-FFF2-40B4-BE49-F238E27FC236}">
-                <ns2:creationId id="{6E5AEF9E-E38C-2981-74C2-DA381C85519D}"/>
+                <a16:creationId xmlns:a16="http://schemas.microsoft.com/office/drawing/2014/main" id="{6E5AEF9E-E38C-2981-74C2-DA381C85519D}"/>
               </a:ext>
             </a:extLst>
           </p:cNvPr>
@@ -8152,7 +8125,7 @@
           <p:cNvPr id="4" name="Rectangle 3">
             <a:extLst>
               <a:ext uri="{FF2B5EF4-FFF2-40B4-BE49-F238E27FC236}">
-                <ns2:creationId id="{565CC16B-626E-E880-45E7-0DBECBCD6306}"/>
+                <a16:creationId xmlns:a16="http://schemas.microsoft.com/office/drawing/2014/main" id="{565CC16B-626E-E880-45E7-0DBECBCD6306}"/>
               </a:ext>
             </a:extLst>
           </p:cNvPr>
@@ -8202,7 +8175,7 @@
           <p:cNvPr id="5" name="TextBox 4">
             <a:extLst>
               <a:ext uri="{FF2B5EF4-FFF2-40B4-BE49-F238E27FC236}">
-                <ns2:creationId id="{E5442AE4-020C-7BAB-E612-2262DEB4097A}"/>
+                <a16:creationId xmlns:a16="http://schemas.microsoft.com/office/drawing/2014/main" id="{E5442AE4-020C-7BAB-E612-2262DEB4097A}"/>
               </a:ext>
             </a:extLst>
           </p:cNvPr>
@@ -8235,159 +8208,6 @@
               </a:rPr>
               <a:t>Aplicar el principi en tres operacions observables.</a:t>
             </a:r>
-            <a:r>
-              <a:rPr sz="2700" b="1" dirty="0" err="1">
-                <a:solidFill>
-                  <a:srgbClr val="192D3E"/>
-                </a:solidFill>
-                <a:latin typeface="Arial"/>
-              </a:rPr>
-              <a:t/>
-            </a:r>
-            <a:r>
-              <a:rPr sz="2700" b="1" dirty="0">
-                <a:solidFill>
-                  <a:srgbClr val="192D3E"/>
-                </a:solidFill>
-                <a:latin typeface="Arial"/>
-              </a:rPr>
-              <a:t/>
-            </a:r>
-            <a:r>
-              <a:rPr sz="2700" b="1" dirty="0" err="1">
-                <a:solidFill>
-                  <a:srgbClr val="192D3E"/>
-                </a:solidFill>
-                <a:latin typeface="Arial"/>
-              </a:rPr>
-              <a:t/>
-            </a:r>
-            <a:r>
-              <a:rPr sz="2700" b="1" dirty="0">
-                <a:solidFill>
-                  <a:srgbClr val="192D3E"/>
-                </a:solidFill>
-                <a:latin typeface="Arial"/>
-              </a:rPr>
-              <a:t/>
-            </a:r>
-            <a:r>
-              <a:rPr sz="2700" b="1" dirty="0" err="1">
-                <a:solidFill>
-                  <a:srgbClr val="192D3E"/>
-                </a:solidFill>
-                <a:latin typeface="Arial"/>
-              </a:rPr>
-              <a:t/>
-            </a:r>
-            <a:r>
-              <a:rPr sz="2700" b="1" dirty="0">
-                <a:solidFill>
-                  <a:srgbClr val="192D3E"/>
-                </a:solidFill>
-                <a:latin typeface="Arial"/>
-              </a:rPr>
-              <a:t/>
-            </a:r>
-            <a:r>
-              <a:rPr sz="2700" b="1" dirty="0" err="1">
-                <a:solidFill>
-                  <a:srgbClr val="192D3E"/>
-                </a:solidFill>
-                <a:latin typeface="Arial"/>
-              </a:rPr>
-              <a:t/>
-            </a:r>
-            <a:r>
-              <a:rPr sz="2700" b="1" dirty="0">
-                <a:solidFill>
-                  <a:srgbClr val="192D3E"/>
-                </a:solidFill>
-                <a:latin typeface="Arial"/>
-              </a:rPr>
-              <a:t/>
-            </a:r>
-            <a:r>
-              <a:rPr sz="2700" b="1" dirty="0" err="1">
-                <a:solidFill>
-                  <a:srgbClr val="192D3E"/>
-                </a:solidFill>
-                <a:latin typeface="Arial"/>
-              </a:rPr>
-              <a:t/>
-            </a:r>
-            <a:r>
-              <a:rPr sz="2700" b="1" dirty="0">
-                <a:solidFill>
-                  <a:srgbClr val="192D3E"/>
-                </a:solidFill>
-                <a:latin typeface="Arial"/>
-              </a:rPr>
-              <a:t/>
-            </a:r>
-            <a:r>
-              <a:rPr sz="2700" b="1" dirty="0" err="1">
-                <a:solidFill>
-                  <a:srgbClr val="192D3E"/>
-                </a:solidFill>
-                <a:latin typeface="Arial"/>
-              </a:rPr>
-              <a:t/>
-            </a:r>
-            <a:r>
-              <a:rPr sz="2700" b="1" dirty="0">
-                <a:solidFill>
-                  <a:srgbClr val="192D3E"/>
-                </a:solidFill>
-                <a:latin typeface="Arial"/>
-              </a:rPr>
-              <a:t/>
-            </a:r>
-            <a:r>
-              <a:rPr sz="2700" b="1" dirty="0" err="1">
-                <a:solidFill>
-                  <a:srgbClr val="192D3E"/>
-                </a:solidFill>
-                <a:latin typeface="Arial"/>
-              </a:rPr>
-              <a:t/>
-            </a:r>
-            <a:r>
-              <a:rPr lang="es-ES" sz="2700" b="1" dirty="0">
-                <a:solidFill>
-                  <a:srgbClr val="192D3E"/>
-                </a:solidFill>
-                <a:latin typeface="Arial"/>
-              </a:rPr>
-              <a:t/>
-            </a:r>
-            <a:r>
-              <a:rPr sz="2700" b="1" dirty="0">
-                <a:solidFill>
-                  <a:srgbClr val="192D3E"/>
-                </a:solidFill>
-                <a:latin typeface="Arial"/>
-              </a:rPr>
-              <a:t/>
-            </a:r>
-            <a:r>
-              <a:rPr lang="es-ES" sz="2700" b="1" dirty="0">
-                <a:solidFill>
-                  <a:srgbClr val="192D3E"/>
-                </a:solidFill>
-                <a:latin typeface="Arial"/>
-              </a:rPr>
-              <a:t/>
-            </a:r>
-            <a:r>
-              <a:rPr sz="2700" b="1" dirty="0">
-                <a:solidFill>
-                  <a:srgbClr val="192D3E"/>
-                </a:solidFill>
-                <a:latin typeface="Arial"/>
-              </a:rPr>
-              <a:t/>
-            </a:r>
           </a:p>
         </p:txBody>
       </p:sp>
@@ -8396,7 +8216,7 @@
           <p:cNvPr id="6" name="Rounded Rectangle 5">
             <a:extLst>
               <a:ext uri="{FF2B5EF4-FFF2-40B4-BE49-F238E27FC236}">
-                <ns2:creationId id="{064EE3A6-5D0D-EFE6-3907-91BB6540F213}"/>
+                <a16:creationId xmlns:a16="http://schemas.microsoft.com/office/drawing/2014/main" id="{064EE3A6-5D0D-EFE6-3907-91BB6540F213}"/>
               </a:ext>
             </a:extLst>
           </p:cNvPr>
@@ -8448,7 +8268,7 @@
           <p:cNvPr id="7" name="TextBox 6">
             <a:extLst>
               <a:ext uri="{FF2B5EF4-FFF2-40B4-BE49-F238E27FC236}">
-                <ns2:creationId id="{C0F1223D-ADAB-E817-C2A8-78FB596BC6F8}"/>
+                <a16:creationId xmlns:a16="http://schemas.microsoft.com/office/drawing/2014/main" id="{C0F1223D-ADAB-E817-C2A8-78FB596BC6F8}"/>
               </a:ext>
             </a:extLst>
           </p:cNvPr>
@@ -8481,42 +8301,6 @@
               </a:rPr>
               <a:t>Identificar
 una necessitat</a:t>
-            </a:r>
-            <a:r>
-              <a:rPr sz="2400" b="1" dirty="0">
-                <a:solidFill>
-                  <a:srgbClr val="192D3E"/>
-                </a:solidFill>
-                <a:latin typeface="Arial"/>
-              </a:rPr>
-              <a:t/>
-            </a:r>
-            <a:r>
-              <a:rPr lang="es-ES" sz="2400" b="1" dirty="0" err="1">
-                <a:solidFill>
-                  <a:srgbClr val="192D3E"/>
-                </a:solidFill>
-                <a:latin typeface="Arial"/>
-              </a:rPr>
-              <a:t/>
-            </a:r>
-            <a:r>
-              <a:rPr lang="es-ES" sz="2400" b="1" dirty="0">
-                <a:solidFill>
-                  <a:srgbClr val="192D3E"/>
-                </a:solidFill>
-                <a:latin typeface="Arial"/>
-              </a:rPr>
-              <a:t/>
-            </a:r>
-            <a:r>
-              <a:rPr lang="es-ES" sz="2400" b="1" dirty="0" err="1">
-                <a:solidFill>
-                  <a:srgbClr val="192D3E"/>
-                </a:solidFill>
-                <a:latin typeface="Arial"/>
-              </a:rPr>
-              <a:t/>
             </a:r>
             <a:endParaRPr lang="es-ES" sz="2400" b="1" dirty="0">
               <a:solidFill>
@@ -8541,7 +8325,7 @@
           <p:cNvPr id="8" name="Rounded Rectangle 7">
             <a:extLst>
               <a:ext uri="{FF2B5EF4-FFF2-40B4-BE49-F238E27FC236}">
-                <ns2:creationId id="{460CDC97-EADA-2158-DAC3-FD27FD257839}"/>
+                <a16:creationId xmlns:a16="http://schemas.microsoft.com/office/drawing/2014/main" id="{460CDC97-EADA-2158-DAC3-FD27FD257839}"/>
               </a:ext>
             </a:extLst>
           </p:cNvPr>
@@ -8593,7 +8377,7 @@
           <p:cNvPr id="9" name="TextBox 8">
             <a:extLst>
               <a:ext uri="{FF2B5EF4-FFF2-40B4-BE49-F238E27FC236}">
-                <ns2:creationId id="{57DA438C-C49C-5E46-6F61-14F3896E8657}"/>
+                <a16:creationId xmlns:a16="http://schemas.microsoft.com/office/drawing/2014/main" id="{57DA438C-C49C-5E46-6F61-14F3896E8657}"/>
               </a:ext>
             </a:extLst>
           </p:cNvPr>
@@ -8627,15 +8411,6 @@
               <a:t>Definir
 un port</a:t>
             </a:r>
-            <a:r>
-              <a:rPr sz="2400" b="1" dirty="0">
-                <a:solidFill>
-                  <a:srgbClr val="192D3E"/>
-                </a:solidFill>
-                <a:latin typeface="Arial"/>
-              </a:rPr>
-              <a:t/>
-            </a:r>
           </a:p>
         </p:txBody>
       </p:sp>
@@ -8644,7 +8419,7 @@
           <p:cNvPr id="10" name="Rounded Rectangle 9">
             <a:extLst>
               <a:ext uri="{FF2B5EF4-FFF2-40B4-BE49-F238E27FC236}">
-                <ns2:creationId id="{54F82A2A-9916-E9F8-2F4C-A47E7CF470BE}"/>
+                <a16:creationId xmlns:a16="http://schemas.microsoft.com/office/drawing/2014/main" id="{54F82A2A-9916-E9F8-2F4C-A47E7CF470BE}"/>
               </a:ext>
             </a:extLst>
           </p:cNvPr>
@@ -8696,7 +8471,7 @@
           <p:cNvPr id="11" name="TextBox 10">
             <a:extLst>
               <a:ext uri="{FF2B5EF4-FFF2-40B4-BE49-F238E27FC236}">
-                <ns2:creationId id="{C6C32489-28BB-E0B4-6D88-054802179775}"/>
+                <a16:creationId xmlns:a16="http://schemas.microsoft.com/office/drawing/2014/main" id="{C6C32489-28BB-E0B4-6D88-054802179775}"/>
               </a:ext>
             </a:extLst>
           </p:cNvPr>
@@ -8729,33 +8504,6 @@
               </a:rPr>
               <a:t>Implementar
 adaptadors</a:t>
-            </a:r>
-            <a:r>
-              <a:rPr sz="2400" b="1" dirty="0">
-                <a:solidFill>
-                  <a:srgbClr val="192D3E"/>
-                </a:solidFill>
-                <a:latin typeface="Arial"/>
-              </a:rPr>
-              <a:t/>
-            </a:r>
-            <a:r>
-              <a:rPr lang="es-ES" sz="2400" b="1" dirty="0">
-                <a:solidFill>
-                  <a:srgbClr val="192D3E"/>
-                </a:solidFill>
-                <a:latin typeface="Arial"/>
-              </a:rPr>
-              <a:t/>
-            </a:r>
-            <a:r>
-              <a:rPr sz="2400" b="1" dirty="0" err="1">
-                <a:solidFill>
-                  <a:srgbClr val="192D3E"/>
-                </a:solidFill>
-                <a:latin typeface="Arial"/>
-              </a:rPr>
-              <a:t/>
             </a:r>
             <a:endParaRPr sz="2400" b="1" dirty="0">
               <a:solidFill>
@@ -8771,7 +8519,7 @@
           <p:cNvPr id="12" name="TextBox 11">
             <a:extLst>
               <a:ext uri="{FF2B5EF4-FFF2-40B4-BE49-F238E27FC236}">
-                <ns2:creationId id="{5298AC41-2EA2-3BF1-14F5-5DF9647D4D84}"/>
+                <a16:creationId xmlns:a16="http://schemas.microsoft.com/office/drawing/2014/main" id="{5298AC41-2EA2-3BF1-14F5-5DF9647D4D84}"/>
               </a:ext>
             </a:extLst>
           </p:cNvPr>
@@ -8812,7 +8560,7 @@
           <p:cNvPr id="13" name="TextBox 12">
             <a:extLst>
               <a:ext uri="{FF2B5EF4-FFF2-40B4-BE49-F238E27FC236}">
-                <ns2:creationId id="{88D08D29-A0AD-1C10-91EF-4939D83B6478}"/>
+                <a16:creationId xmlns:a16="http://schemas.microsoft.com/office/drawing/2014/main" id="{88D08D29-A0AD-1C10-91EF-4939D83B6478}"/>
               </a:ext>
             </a:extLst>
           </p:cNvPr>
@@ -8851,7 +8599,7 @@
     </p:spTree>
     <p:extLst>
       <p:ext uri="{BB962C8B-B14F-4D97-AF65-F5344CB8AC3E}">
-        <ns4:creationId val="1026507124"/>
+        <p14:creationId xmlns:p14="http://schemas.microsoft.com/office/powerpoint/2010/main" val="1026507124"/>
       </p:ext>
     </p:extLst>
   </p:cSld>
@@ -9196,16 +8944,130 @@
           <a:p>
             <a:pPr algn="ctr"/>
             <a:r>
+              <a:rPr sz="1800" b="1" dirty="0" err="1">
+                <a:solidFill>
+                  <a:srgbClr val="192D3E"/>
+                </a:solidFill>
+                <a:latin typeface="Arial"/>
+              </a:rPr>
+              <a:t>Sol·licitud</a:t>
+            </a:r>
+            <a:r>
+              <a:rPr sz="1800" b="1" dirty="0">
+                <a:solidFill>
+                  <a:srgbClr val="192D3E"/>
+                </a:solidFill>
+                <a:latin typeface="Arial"/>
+              </a:rPr>
+              <a:t> → Expedient → </a:t>
+            </a:r>
+            <a:r>
+              <a:rPr sz="1800" b="1" dirty="0" err="1">
+                <a:solidFill>
+                  <a:srgbClr val="192D3E"/>
+                </a:solidFill>
+                <a:latin typeface="Arial"/>
+              </a:rPr>
+              <a:t>Requisits</a:t>
+            </a:r>
+            <a:r>
+              <a:rPr sz="1800" b="1" dirty="0">
+                <a:solidFill>
+                  <a:srgbClr val="192D3E"/>
+                </a:solidFill>
+                <a:latin typeface="Arial"/>
+              </a:rPr>
+              <a:t> generals
+→ </a:t>
+            </a:r>
+            <a:r>
+              <a:rPr sz="1800" b="1" dirty="0" err="1">
+                <a:solidFill>
+                  <a:srgbClr val="192D3E"/>
+                </a:solidFill>
+                <a:latin typeface="Arial"/>
+              </a:rPr>
+              <a:t>Requisits</a:t>
+            </a:r>
+            <a:r>
+              <a:rPr sz="1800" b="1" dirty="0">
+                <a:solidFill>
+                  <a:srgbClr val="192D3E"/>
+                </a:solidFill>
+                <a:latin typeface="Arial"/>
+              </a:rPr>
+              <a:t> </a:t>
+            </a:r>
+            <a:r>
+              <a:rPr sz="1800" b="1" dirty="0" err="1">
+                <a:solidFill>
+                  <a:srgbClr val="192D3E"/>
+                </a:solidFill>
+                <a:latin typeface="Arial"/>
+              </a:rPr>
+              <a:t>econòmics</a:t>
+            </a:r>
+            <a:r>
+              <a:rPr sz="1800" b="1" dirty="0">
+                <a:solidFill>
+                  <a:srgbClr val="192D3E"/>
+                </a:solidFill>
+                <a:latin typeface="Arial"/>
+              </a:rPr>
+              <a:t> → </a:t>
+            </a:r>
+            <a:r>
+              <a:rPr sz="1800" b="1" dirty="0" err="1">
+                <a:solidFill>
+                  <a:srgbClr val="192D3E"/>
+                </a:solidFill>
+                <a:latin typeface="Arial"/>
+              </a:rPr>
+              <a:t>Revisió</a:t>
+            </a:r>
+            <a:r>
+              <a:rPr sz="1800" b="1" dirty="0">
+                <a:solidFill>
+                  <a:srgbClr val="192D3E"/>
+                </a:solidFill>
+                <a:latin typeface="Arial"/>
+              </a:rPr>
+              <a:t> </a:t>
+            </a:r>
+            <a:r>
+              <a:rPr sz="1800" b="1" dirty="0" err="1">
+                <a:solidFill>
+                  <a:srgbClr val="192D3E"/>
+                </a:solidFill>
+                <a:latin typeface="Arial"/>
+              </a:rPr>
+              <a:t>acadèmica</a:t>
+            </a:r>
+            <a:r>
               <a:rPr sz="1800" b="1">
                 <a:solidFill>
                   <a:srgbClr val="192D3E"/>
                 </a:solidFill>
                 <a:latin typeface="Arial"/>
               </a:rPr>
-              <a:t>Sol·licitud → Expedient → Requisits generals
-→ Requisits econòmics → Revisió acadèmica
-→ Resolució</a:t>
-            </a:r>
+              <a:t>
+→ </a:t>
+            </a:r>
+            <a:r>
+              <a:rPr sz="1800" b="1" dirty="0" err="1">
+                <a:solidFill>
+                  <a:srgbClr val="192D3E"/>
+                </a:solidFill>
+                <a:latin typeface="Arial"/>
+              </a:rPr>
+              <a:t>Resolució</a:t>
+            </a:r>
+            <a:endParaRPr sz="1800" b="1" dirty="0">
+              <a:solidFill>
+                <a:srgbClr val="192D3E"/>
+              </a:solidFill>
+              <a:latin typeface="Arial"/>
+            </a:endParaRPr>
           </a:p>
         </p:txBody>
       </p:sp>
@@ -9217,8 +9079,8 @@
         </p:nvSpPr>
         <p:spPr>
           <a:xfrm>
-            <a:off x="8001000" y="3337560"/>
-            <a:ext cx="3063240" cy="1234440"/>
+            <a:off x="7867561" y="3304599"/>
+            <a:ext cx="3375837" cy="1579148"/>
           </a:xfrm>
           <a:prstGeom prst="roundRect">
             <a:avLst/>
@@ -9263,8 +9125,8 @@
         </p:nvSpPr>
         <p:spPr>
           <a:xfrm>
-            <a:off x="8229600" y="3566160"/>
-            <a:ext cx="2606040" cy="749808"/>
+            <a:off x="8229599" y="3566160"/>
+            <a:ext cx="2871981" cy="959186"/>
           </a:xfrm>
           <a:prstGeom prst="rect">
             <a:avLst/>
@@ -9279,35 +9141,79 @@
           <a:p>
             <a:pPr algn="ctr"/>
             <a:r>
-              <a:rPr sz="2000" b="1" dirty="0">
-                <a:solidFill>
-                  <a:srgbClr val="192D3E"/>
-                </a:solidFill>
-                <a:latin typeface="Arial"/>
-              </a:rPr>
-              <a:t>Si no es </a:t>
-            </a:r>
-            <a:r>
-              <a:rPr sz="2000" b="1" dirty="0" err="1">
-                <a:solidFill>
-                  <a:srgbClr val="192D3E"/>
-                </a:solidFill>
-                <a:latin typeface="Arial"/>
-              </a:rPr>
-              <a:t>compleixen</a:t>
-            </a:r>
-            <a:r>
-              <a:rPr sz="2000" b="1" dirty="0">
-                <a:solidFill>
-                  <a:srgbClr val="192D3E"/>
-                </a:solidFill>
-                <a:latin typeface="Arial"/>
-              </a:rPr>
-              <a:t>
-</a:t>
-            </a:r>
-            <a:r>
-              <a:rPr sz="2000" b="1" dirty="0" err="1">
+              <a:rPr lang="es-ES" sz="2000" b="1" dirty="0" err="1">
+                <a:solidFill>
+                  <a:srgbClr val="192D3E"/>
+                </a:solidFill>
+                <a:latin typeface="Arial"/>
+              </a:rPr>
+              <a:t>Quan</a:t>
+            </a:r>
+            <a:r>
+              <a:rPr lang="es-ES" sz="2000" b="1" dirty="0">
+                <a:solidFill>
+                  <a:srgbClr val="192D3E"/>
+                </a:solidFill>
+                <a:latin typeface="Arial"/>
+              </a:rPr>
+              <a:t> no </a:t>
+            </a:r>
+            <a:r>
+              <a:rPr lang="es-ES" sz="2000" b="1" dirty="0" err="1">
+                <a:solidFill>
+                  <a:srgbClr val="192D3E"/>
+                </a:solidFill>
+                <a:latin typeface="Arial"/>
+              </a:rPr>
+              <a:t>s’acredita</a:t>
+            </a:r>
+            <a:r>
+              <a:rPr lang="es-ES" sz="2000" b="1" dirty="0">
+                <a:solidFill>
+                  <a:srgbClr val="192D3E"/>
+                </a:solidFill>
+                <a:latin typeface="Arial"/>
+              </a:rPr>
+              <a:t> el </a:t>
+            </a:r>
+            <a:r>
+              <a:rPr lang="es-ES" sz="2000" b="1" dirty="0" err="1">
+                <a:solidFill>
+                  <a:srgbClr val="192D3E"/>
+                </a:solidFill>
+                <a:latin typeface="Arial"/>
+              </a:rPr>
+              <a:t>compliment</a:t>
+            </a:r>
+            <a:r>
+              <a:rPr lang="es-ES" sz="2000" b="1" dirty="0">
+                <a:solidFill>
+                  <a:srgbClr val="192D3E"/>
+                </a:solidFill>
+                <a:latin typeface="Arial"/>
+              </a:rPr>
+              <a:t> </a:t>
+            </a:r>
+            <a:r>
+              <a:rPr lang="es-ES" sz="2000" b="1" dirty="0" err="1">
+                <a:solidFill>
+                  <a:srgbClr val="192D3E"/>
+                </a:solidFill>
+                <a:latin typeface="Arial"/>
+              </a:rPr>
+              <a:t>dels</a:t>
+            </a:r>
+            <a:r>
+              <a:rPr lang="es-ES" sz="2000" b="1" dirty="0">
+                <a:solidFill>
+                  <a:srgbClr val="192D3E"/>
+                </a:solidFill>
+                <a:latin typeface="Arial"/>
+              </a:rPr>
+              <a:t> </a:t>
+            </a:r>
+            <a:r>
+              <a:rPr lang="es-ES" sz="2000" b="1" dirty="0" err="1">
                 <a:solidFill>
                   <a:srgbClr val="192D3E"/>
                 </a:solidFill>
@@ -9316,7 +9222,7 @@
               <a:t>requisits</a:t>
             </a:r>
             <a:r>
-              <a:rPr sz="2000" b="1" dirty="0">
+              <a:rPr lang="es-ES" sz="2000" b="1" dirty="0">
                 <a:solidFill>
                   <a:srgbClr val="192D3E"/>
                 </a:solidFill>
@@ -9325,7 +9231,7 @@
               <a:t> </a:t>
             </a:r>
             <a:r>
-              <a:rPr sz="2000" b="1" dirty="0" err="1">
+              <a:rPr lang="es-ES" sz="2000" b="1" dirty="0" err="1">
                 <a:solidFill>
                   <a:srgbClr val="192D3E"/>
                 </a:solidFill>
@@ -9334,23 +9240,13 @@
               <a:t>econòmics</a:t>
             </a:r>
             <a:r>
-              <a:rPr sz="2000" b="1" dirty="0">
-                <a:solidFill>
-                  <a:srgbClr val="192D3E"/>
-                </a:solidFill>
-                <a:latin typeface="Arial"/>
-              </a:rPr>
-              <a:t>,
-</a:t>
-            </a:r>
-            <a:r>
               <a:rPr lang="es-ES" sz="2000" b="1" dirty="0">
                 <a:solidFill>
                   <a:srgbClr val="192D3E"/>
                 </a:solidFill>
                 <a:latin typeface="Arial"/>
               </a:rPr>
-              <a:t>no es </a:t>
+              <a:t>, </a:t>
             </a:r>
             <a:r>
               <a:rPr lang="es-ES" sz="2000" b="1" dirty="0" err="1">
@@ -9359,7 +9255,7 @@
                 </a:solidFill>
                 <a:latin typeface="Arial"/>
               </a:rPr>
-              <a:t>pot</a:t>
+              <a:t>l’expedient</a:t>
             </a:r>
             <a:r>
               <a:rPr lang="es-ES" sz="2000" b="1" dirty="0">
@@ -9368,7 +9264,7 @@
                 </a:solidFill>
                 <a:latin typeface="Arial"/>
               </a:rPr>
-              <a:t> </a:t>
+              <a:t> no </a:t>
             </a:r>
             <a:r>
               <a:rPr lang="es-ES" sz="2000" b="1" dirty="0" err="1">
@@ -9377,7 +9273,7 @@
                 </a:solidFill>
                 <a:latin typeface="Arial"/>
               </a:rPr>
-              <a:t>concedir</a:t>
+              <a:t>obté</a:t>
             </a:r>
             <a:r>
               <a:rPr lang="es-ES" sz="2000" b="1" dirty="0">
@@ -9386,17 +9282,50 @@
                 </a:solidFill>
                 <a:latin typeface="Arial"/>
               </a:rPr>
-              <a:t> la beca</a:t>
-            </a:r>
-            <a:r>
-              <a:rPr sz="2000" b="1" dirty="0">
-                <a:solidFill>
-                  <a:srgbClr val="192D3E"/>
-                </a:solidFill>
-                <a:latin typeface="Arial"/>
-              </a:rPr>
-              <a:t>.</a:t>
-            </a:r>
+              <a:t> una </a:t>
+            </a:r>
+            <a:r>
+              <a:rPr lang="es-ES" sz="2000" b="1" dirty="0" err="1">
+                <a:solidFill>
+                  <a:srgbClr val="192D3E"/>
+                </a:solidFill>
+                <a:latin typeface="Arial"/>
+              </a:rPr>
+              <a:t>valoració</a:t>
+            </a:r>
+            <a:r>
+              <a:rPr lang="es-ES" sz="2000" b="1" dirty="0">
+                <a:solidFill>
+                  <a:srgbClr val="192D3E"/>
+                </a:solidFill>
+                <a:latin typeface="Arial"/>
+              </a:rPr>
+              <a:t> favorable en </a:t>
+            </a:r>
+            <a:r>
+              <a:rPr lang="es-ES" sz="2000" b="1" dirty="0" err="1">
+                <a:solidFill>
+                  <a:srgbClr val="192D3E"/>
+                </a:solidFill>
+                <a:latin typeface="Arial"/>
+              </a:rPr>
+              <a:t>aquesta</a:t>
+            </a:r>
+            <a:r>
+              <a:rPr lang="es-ES" sz="2000" b="1" dirty="0">
+                <a:solidFill>
+                  <a:srgbClr val="192D3E"/>
+                </a:solidFill>
+                <a:latin typeface="Arial"/>
+              </a:rPr>
+              <a:t> fase.</a:t>
+            </a:r>
+            <a:endParaRPr sz="2000" b="1" dirty="0">
+              <a:solidFill>
+                <a:srgbClr val="192D3E"/>
+              </a:solidFill>
+              <a:latin typeface="Arial"/>
+            </a:endParaRPr>
           </a:p>
         </p:txBody>
       </p:sp>

</xml_diff>

<commit_message>
docs: update presentation closing wording
</commit_message>
<xml_diff>
--- a/doc/presentations/defensa-placa-permanent-dsi-ports-sortida-hexagonal/output/IMPORTANTE_MANUAL_defensa-dsi-ports-sortida-hexagonal.pptx
+++ b/doc/presentations/defensa-placa-permanent-dsi-ports-sortida-hexagonal/output/IMPORTANTE_MANUAL_defensa-dsi-ports-sortida-hexagonal.pptx
@@ -4187,94 +4187,85 @@
           <a:p>
             <a:pPr algn="l"/>
             <a:r>
-              <a:rPr sz="1300" b="0" dirty="0">
-                <a:solidFill>
-                  <a:srgbClr val="66707A"/>
-                </a:solidFill>
-                <a:latin typeface="Arial"/>
-              </a:rPr>
-              <a:t>Venda </a:t>
-            </a:r>
-            <a:r>
-              <a:rPr sz="1300" b="0" dirty="0" err="1">
-                <a:solidFill>
-                  <a:srgbClr val="66707A"/>
-                </a:solidFill>
-                <a:latin typeface="Arial"/>
-              </a:rPr>
-              <a:t>d'accions</a:t>
-            </a:r>
-            <a:r>
-              <a:rPr sz="1300" b="0" dirty="0">
-                <a:solidFill>
-                  <a:srgbClr val="66707A"/>
+              <a:rPr lang="es-ES" sz="1400" b="1" dirty="0">
+                <a:solidFill>
+                  <a:srgbClr val="192D3E"/>
+                </a:solidFill>
+                <a:latin typeface="Arial"/>
+              </a:rPr>
+              <a:t>   El cas </a:t>
+            </a:r>
+            <a:r>
+              <a:rPr lang="es-ES" sz="1400" b="1" dirty="0" err="1">
+                <a:solidFill>
+                  <a:srgbClr val="192D3E"/>
+                </a:solidFill>
+                <a:latin typeface="Arial"/>
+              </a:rPr>
+              <a:t>d’ús</a:t>
+            </a:r>
+            <a:r>
+              <a:rPr lang="es-ES" sz="1400" b="1" dirty="0">
+                <a:solidFill>
+                  <a:srgbClr val="192D3E"/>
                 </a:solidFill>
                 <a:latin typeface="Arial"/>
               </a:rPr>
               <a:t> </a:t>
             </a:r>
             <a:r>
-              <a:rPr sz="1300" b="0" dirty="0" err="1">
-                <a:solidFill>
-                  <a:srgbClr val="66707A"/>
-                </a:solidFill>
-                <a:latin typeface="Arial"/>
-              </a:rPr>
-              <a:t>amb</a:t>
-            </a:r>
-            <a:r>
-              <a:rPr sz="1300" b="0" dirty="0">
-                <a:solidFill>
-                  <a:srgbClr val="66707A"/>
+              <a:rPr lang="es-ES" sz="1400" b="1" dirty="0" err="1">
+                <a:solidFill>
+                  <a:srgbClr val="192D3E"/>
+                </a:solidFill>
+                <a:latin typeface="Arial"/>
+              </a:rPr>
+              <a:t>necessita</a:t>
+            </a:r>
+            <a:r>
+              <a:rPr lang="es-ES" sz="1400" b="1" dirty="0">
+                <a:solidFill>
+                  <a:srgbClr val="192D3E"/>
+                </a:solidFill>
+                <a:latin typeface="Arial"/>
+              </a:rPr>
+              <a:t> el preu actual, no un </a:t>
+            </a:r>
+            <a:r>
+              <a:rPr lang="es-ES" sz="1400" b="1" dirty="0" err="1">
+                <a:solidFill>
+                  <a:srgbClr val="192D3E"/>
+                </a:solidFill>
+                <a:latin typeface="Arial"/>
+              </a:rPr>
+              <a:t>proveïdor</a:t>
+            </a:r>
+            <a:r>
+              <a:rPr lang="es-ES" sz="1400" b="1" dirty="0">
+                <a:solidFill>
+                  <a:srgbClr val="192D3E"/>
                 </a:solidFill>
                 <a:latin typeface="Arial"/>
               </a:rPr>
               <a:t> </a:t>
             </a:r>
             <a:r>
-              <a:rPr sz="1300" b="0" dirty="0" err="1">
-                <a:solidFill>
-                  <a:srgbClr val="66707A"/>
-                </a:solidFill>
-                <a:latin typeface="Arial"/>
-              </a:rPr>
-              <a:t>proveïdor</a:t>
-            </a:r>
-            <a:r>
-              <a:rPr sz="1300" b="0" dirty="0">
-                <a:solidFill>
-                  <a:srgbClr val="66707A"/>
-                </a:solidFill>
-                <a:latin typeface="Arial"/>
-              </a:rPr>
-              <a:t> de </a:t>
-            </a:r>
-            <a:r>
-              <a:rPr sz="1300" b="0" dirty="0" err="1">
-                <a:solidFill>
-                  <a:srgbClr val="66707A"/>
-                </a:solidFill>
-                <a:latin typeface="Arial"/>
-              </a:rPr>
-              <a:t>preus</a:t>
-            </a:r>
-            <a:r>
-              <a:rPr sz="1300" b="0" dirty="0">
-                <a:solidFill>
-                  <a:srgbClr val="66707A"/>
-                </a:solidFill>
-                <a:latin typeface="Arial"/>
-              </a:rPr>
-              <a:t> </a:t>
-            </a:r>
-            <a:r>
-              <a:rPr sz="1300" b="0" dirty="0" err="1">
-                <a:solidFill>
-                  <a:srgbClr val="66707A"/>
-                </a:solidFill>
-                <a:latin typeface="Arial"/>
-              </a:rPr>
-              <a:t>substituïble</a:t>
+              <a:rPr lang="es-ES" sz="1400" b="1" dirty="0" err="1">
+                <a:solidFill>
+                  <a:srgbClr val="192D3E"/>
+                </a:solidFill>
+                <a:latin typeface="Arial"/>
+              </a:rPr>
+              <a:t>concret</a:t>
+            </a:r>
+            <a:r>
+              <a:rPr lang="es-ES" sz="1400" b="1" dirty="0">
+                <a:solidFill>
+                  <a:srgbClr val="192D3E"/>
+                </a:solidFill>
+                <a:latin typeface="Arial"/>
+              </a:rPr>
+              <a:t>.</a:t>
             </a:r>
             <a:endParaRPr sz="1300" b="0" dirty="0">
               <a:solidFill>
@@ -4423,9 +4414,104 @@
           </a:p>
         </p:txBody>
       </p:sp>
+      <p:sp>
+        <p:nvSpPr>
+          <p:cNvPr id="14" name="Slide 10 port note"/>
+          <p:cNvSpPr txBox="1"/>
+          <p:nvPr/>
+        </p:nvSpPr>
+        <p:spPr>
+          <a:xfrm>
+            <a:off x="4274820" y="6523074"/>
+            <a:ext cx="10561320" cy="201168"/>
+          </a:xfrm>
+          <a:prstGeom prst="rect">
+            <a:avLst/>
+          </a:prstGeom>
+          <a:noFill/>
+        </p:spPr>
+        <p:txBody>
+          <a:bodyPr wrap="square">
+            <a:normAutofit fontScale="92500" lnSpcReduction="10000"/>
+          </a:bodyPr>
+          <a:lstStyle/>
+          <a:p>
+            <a:pPr algn="ctr"/>
+            <a:r>
+              <a:rPr sz="900" b="0" dirty="0">
+                <a:solidFill>
+                  <a:srgbClr val="66707A"/>
+                </a:solidFill>
+                <a:latin typeface="Arial"/>
+              </a:rPr>
+              <a:t>Port: </a:t>
+            </a:r>
+            <a:r>
+              <a:rPr sz="900" b="0" dirty="0" err="1">
+                <a:solidFill>
+                  <a:srgbClr val="66707A"/>
+                </a:solidFill>
+                <a:latin typeface="Arial"/>
+              </a:rPr>
+              <a:t>StockPriceProviderPort</a:t>
+            </a:r>
+            <a:r>
+              <a:rPr sz="900" b="0" dirty="0">
+                <a:solidFill>
+                  <a:srgbClr val="66707A"/>
+                </a:solidFill>
+                <a:latin typeface="Arial"/>
+              </a:rPr>
+              <a:t> · </a:t>
+            </a:r>
+            <a:r>
+              <a:rPr sz="900" b="0" dirty="0" err="1">
+                <a:solidFill>
+                  <a:srgbClr val="66707A"/>
+                </a:solidFill>
+                <a:latin typeface="Arial"/>
+              </a:rPr>
+              <a:t>Adaptadors</a:t>
+            </a:r>
+            <a:r>
+              <a:rPr sz="900" b="0" dirty="0">
+                <a:solidFill>
+                  <a:srgbClr val="66707A"/>
+                </a:solidFill>
+                <a:latin typeface="Arial"/>
+              </a:rPr>
+              <a:t>: </a:t>
+            </a:r>
+            <a:r>
+              <a:rPr sz="900" b="0" dirty="0" err="1">
+                <a:solidFill>
+                  <a:srgbClr val="66707A"/>
+                </a:solidFill>
+                <a:latin typeface="Arial"/>
+              </a:rPr>
+              <a:t>Finnhub</a:t>
+            </a:r>
+            <a:r>
+              <a:rPr sz="900" b="0" dirty="0">
+                <a:solidFill>
+                  <a:srgbClr val="66707A"/>
+                </a:solidFill>
+                <a:latin typeface="Arial"/>
+              </a:rPr>
+              <a:t>, Alpha Vantage, mock</a:t>
+            </a:r>
+          </a:p>
+        </p:txBody>
+      </p:sp>
       <p:pic>
         <p:nvPicPr>
-          <p:cNvPr id="12" name="HexaStock architecture enlarged" descr="hexastock_architecture_cropped_for_slide10.png"/>
+          <p:cNvPr id="7" name="Imagen 6">
+            <a:extLst>
+              <a:ext uri="{FF2B5EF4-FFF2-40B4-BE49-F238E27FC236}">
+                <a16:creationId xmlns:a16="http://schemas.microsoft.com/office/drawing/2014/main" id="{A6EDC6F8-5757-04F1-70A5-BEE4AFAFA363}"/>
+              </a:ext>
+            </a:extLst>
+          </p:cNvPr>
           <p:cNvPicPr>
             <a:picLocks noChangeAspect="1"/>
           </p:cNvPicPr>
@@ -4439,84 +4525,14 @@
         </p:blipFill>
         <p:spPr>
           <a:xfrm>
-            <a:off x="1154989" y="1225296"/>
-            <a:ext cx="9622941" cy="4315968"/>
+            <a:off x="702128" y="1101320"/>
+            <a:ext cx="10757264" cy="5348071"/>
           </a:xfrm>
           <a:prstGeom prst="rect">
             <a:avLst/>
           </a:prstGeom>
         </p:spPr>
       </p:pic>
-      <p:sp>
-        <p:nvSpPr>
-          <p:cNvPr id="13" name="Slide 10 bottom message"/>
-          <p:cNvSpPr txBox="1"/>
-          <p:nvPr/>
-        </p:nvSpPr>
-        <p:spPr>
-          <a:xfrm>
-            <a:off x="822960" y="5532120"/>
-            <a:ext cx="10561320" cy="310896"/>
-          </a:xfrm>
-          <a:prstGeom prst="rect">
-            <a:avLst/>
-          </a:prstGeom>
-          <a:noFill/>
-        </p:spPr>
-        <p:txBody>
-          <a:bodyPr wrap="square">
-            <a:normAutofit/>
-          </a:bodyPr>
-          <a:lstStyle/>
-          <a:p>
-            <a:pPr algn="ctr"/>
-            <a:r>
-              <a:rPr sz="1700" b="1">
-                <a:solidFill>
-                  <a:srgbClr val="192D3E"/>
-                </a:solidFill>
-                <a:latin typeface="Arial"/>
-              </a:rPr>
-              <a:t>Mateix patró, diferent domini: el cas d’ús necessita el preu actual, no un proveïdor concret.</a:t>
-            </a:r>
-          </a:p>
-        </p:txBody>
-      </p:sp>
-      <p:sp>
-        <p:nvSpPr>
-          <p:cNvPr id="14" name="Slide 10 port note"/>
-          <p:cNvSpPr txBox="1"/>
-          <p:nvPr/>
-        </p:nvSpPr>
-        <p:spPr>
-          <a:xfrm>
-            <a:off x="822960" y="5870448"/>
-            <a:ext cx="10561320" cy="201168"/>
-          </a:xfrm>
-          <a:prstGeom prst="rect">
-            <a:avLst/>
-          </a:prstGeom>
-          <a:noFill/>
-        </p:spPr>
-        <p:txBody>
-          <a:bodyPr wrap="square">
-            <a:normAutofit/>
-          </a:bodyPr>
-          <a:lstStyle/>
-          <a:p>
-            <a:pPr algn="ctr"/>
-            <a:r>
-              <a:rPr sz="900" b="0">
-                <a:solidFill>
-                  <a:srgbClr val="66707A"/>
-                </a:solidFill>
-                <a:latin typeface="Arial"/>
-              </a:rPr>
-              <a:t>Port: StockPriceProviderPort · Adaptadors: Finnhub, Alpha Vantage, mock</a:t>
-            </a:r>
-          </a:p>
-        </p:txBody>
-      </p:sp>
     </p:spTree>
   </p:cSld>
   <p:clrMapOvr>
@@ -6211,8 +6227,8 @@
         </p:nvSpPr>
         <p:spPr>
           <a:xfrm>
-            <a:off x="1234440" y="1600200"/>
-            <a:ext cx="9601200" cy="1005840"/>
+            <a:off x="1178973" y="1874094"/>
+            <a:ext cx="9834053" cy="1780528"/>
           </a:xfrm>
           <a:prstGeom prst="rect">
             <a:avLst/>
@@ -6221,13 +6237,13 @@
         </p:spPr>
         <p:txBody>
           <a:bodyPr wrap="square">
-            <a:normAutofit fontScale="92500" lnSpcReduction="10000"/>
+            <a:normAutofit/>
           </a:bodyPr>
           <a:lstStyle/>
           <a:p>
             <a:pPr algn="ctr"/>
             <a:r>
-              <a:rPr sz="2400" b="0" dirty="0" err="1">
+              <a:rPr lang="es-ES" sz="2400" b="0" dirty="0" err="1">
                 <a:solidFill>
                   <a:srgbClr val="192D3E"/>
                 </a:solidFill>
@@ -6236,7 +6252,7 @@
               <a:t>Vull</a:t>
             </a:r>
             <a:r>
-              <a:rPr sz="2400" b="0" dirty="0">
+              <a:rPr lang="es-ES" sz="2400" b="0" dirty="0">
                 <a:solidFill>
                   <a:srgbClr val="192D3E"/>
                 </a:solidFill>
@@ -6245,7 +6261,7 @@
               <a:t> </a:t>
             </a:r>
             <a:r>
-              <a:rPr sz="2400" b="0" dirty="0" err="1">
+              <a:rPr lang="es-ES" sz="2400" b="0" dirty="0" err="1">
                 <a:solidFill>
                   <a:srgbClr val="192D3E"/>
                 </a:solidFill>
@@ -6254,7 +6270,25 @@
               <a:t>expressar</a:t>
             </a:r>
             <a:r>
-              <a:rPr sz="2400" b="0" dirty="0">
+              <a:rPr lang="es-ES" sz="2400" b="0" dirty="0">
+                <a:solidFill>
+                  <a:srgbClr val="192D3E"/>
+                </a:solidFill>
+                <a:latin typeface="Arial"/>
+              </a:rPr>
+              <a:t> el </a:t>
+            </a:r>
+            <a:r>
+              <a:rPr lang="es-ES" sz="2400" b="0" dirty="0" err="1">
+                <a:solidFill>
+                  <a:srgbClr val="192D3E"/>
+                </a:solidFill>
+                <a:latin typeface="Arial"/>
+              </a:rPr>
+              <a:t>meu</a:t>
+            </a:r>
+            <a:r>
+              <a:rPr lang="es-ES" sz="2400" b="0" dirty="0">
                 <a:solidFill>
                   <a:srgbClr val="192D3E"/>
                 </a:solidFill>
@@ -6263,25 +6297,7 @@
               <a:t> </a:t>
             </a:r>
             <a:r>
-              <a:rPr sz="2400" b="0" dirty="0" err="1">
-                <a:solidFill>
-                  <a:srgbClr val="192D3E"/>
-                </a:solidFill>
-                <a:latin typeface="Arial"/>
-              </a:rPr>
-              <a:t>el</a:t>
-            </a:r>
-            <a:r>
-              <a:rPr sz="2400" b="0" dirty="0">
-                <a:solidFill>
-                  <a:srgbClr val="192D3E"/>
-                </a:solidFill>
-                <a:latin typeface="Arial"/>
-              </a:rPr>
-              <a:t> meu </a:t>
-            </a:r>
-            <a:r>
-              <a:rPr sz="2400" b="0" dirty="0" err="1">
+              <a:rPr lang="es-ES" sz="2400" b="0" dirty="0" err="1">
                 <a:solidFill>
                   <a:srgbClr val="192D3E"/>
                 </a:solidFill>
@@ -6290,7 +6306,7 @@
               <a:t>agraïment</a:t>
             </a:r>
             <a:r>
-              <a:rPr sz="2400" b="0" dirty="0">
+              <a:rPr lang="es-ES" sz="2400" b="0" dirty="0">
                 <a:solidFill>
                   <a:srgbClr val="192D3E"/>
                 </a:solidFill>
@@ -6299,7 +6315,7 @@
               <a:t> al </a:t>
             </a:r>
             <a:r>
-              <a:rPr sz="2400" b="0" dirty="0" err="1">
+              <a:rPr lang="es-ES" sz="2400" b="0" dirty="0" err="1">
                 <a:solidFill>
                   <a:srgbClr val="192D3E"/>
                 </a:solidFill>
@@ -6308,25 +6324,97 @@
               <a:t>TecnoCampus</a:t>
             </a:r>
             <a:r>
-              <a:rPr sz="2400" b="0" dirty="0">
-                <a:solidFill>
-                  <a:srgbClr val="192D3E"/>
-                </a:solidFill>
-                <a:latin typeface="Arial"/>
-              </a:rPr>
-              <a:t> per </a:t>
-            </a:r>
-            <a:r>
-              <a:rPr sz="2400" b="0" dirty="0" err="1">
-                <a:solidFill>
-                  <a:srgbClr val="192D3E"/>
-                </a:solidFill>
-                <a:latin typeface="Arial"/>
-              </a:rPr>
-              <a:t>l'oportunitat</a:t>
-            </a:r>
-            <a:r>
-              <a:rPr sz="2400" b="0" dirty="0">
+              <a:rPr lang="es-ES" sz="2400" b="0" dirty="0">
+                <a:solidFill>
+                  <a:srgbClr val="192D3E"/>
+                </a:solidFill>
+                <a:latin typeface="Arial"/>
+              </a:rPr>
+              <a:t> per un </a:t>
+            </a:r>
+            <a:r>
+              <a:rPr lang="es-ES" sz="2400" b="0" dirty="0" err="1">
+                <a:solidFill>
+                  <a:srgbClr val="192D3E"/>
+                </a:solidFill>
+                <a:latin typeface="Arial"/>
+              </a:rPr>
+              <a:t>entorn</a:t>
+            </a:r>
+            <a:r>
+              <a:rPr lang="es-ES" sz="2400" b="0" dirty="0">
+                <a:solidFill>
+                  <a:srgbClr val="192D3E"/>
+                </a:solidFill>
+                <a:latin typeface="Arial"/>
+              </a:rPr>
+              <a:t> que </a:t>
+            </a:r>
+            <a:r>
+              <a:rPr lang="es-ES" sz="2400" b="0" dirty="0" err="1">
+                <a:solidFill>
+                  <a:srgbClr val="192D3E"/>
+                </a:solidFill>
+                <a:latin typeface="Arial"/>
+              </a:rPr>
+              <a:t>m’encoratja</a:t>
+            </a:r>
+            <a:r>
+              <a:rPr lang="es-ES" sz="2400" b="0" dirty="0">
+                <a:solidFill>
+                  <a:srgbClr val="192D3E"/>
+                </a:solidFill>
+                <a:latin typeface="Arial"/>
+              </a:rPr>
+              <a:t> a </a:t>
+            </a:r>
+            <a:r>
+              <a:rPr lang="es-ES" sz="2400" b="0" dirty="0" err="1">
+                <a:solidFill>
+                  <a:srgbClr val="192D3E"/>
+                </a:solidFill>
+                <a:latin typeface="Arial"/>
+              </a:rPr>
+              <a:t>créixer</a:t>
+            </a:r>
+            <a:r>
+              <a:rPr lang="es-ES" sz="2400" b="0" dirty="0">
+                <a:solidFill>
+                  <a:srgbClr val="192D3E"/>
+                </a:solidFill>
+                <a:latin typeface="Arial"/>
+              </a:rPr>
+              <a:t>, </a:t>
+            </a:r>
+            <a:r>
+              <a:rPr lang="es-ES" sz="2400" b="0" dirty="0" err="1">
+                <a:solidFill>
+                  <a:srgbClr val="192D3E"/>
+                </a:solidFill>
+                <a:latin typeface="Arial"/>
+              </a:rPr>
+              <a:t>tant</a:t>
+            </a:r>
+            <a:r>
+              <a:rPr lang="es-ES" sz="2400" b="0" dirty="0">
+                <a:solidFill>
+                  <a:srgbClr val="192D3E"/>
+                </a:solidFill>
+                <a:latin typeface="Arial"/>
+              </a:rPr>
+              <a:t> en la </a:t>
+            </a:r>
+            <a:r>
+              <a:rPr lang="es-ES" sz="2400" b="0" dirty="0" err="1">
+                <a:solidFill>
+                  <a:srgbClr val="192D3E"/>
+                </a:solidFill>
+                <a:latin typeface="Arial"/>
+              </a:rPr>
+              <a:t>docència</a:t>
+            </a:r>
+            <a:r>
+              <a:rPr lang="es-ES" sz="2400" b="0" dirty="0">
                 <a:solidFill>
                   <a:srgbClr val="192D3E"/>
                 </a:solidFill>
@@ -6335,16 +6423,196 @@
               <a:t> </a:t>
             </a:r>
             <a:r>
-              <a:rPr sz="2400" b="0" dirty="0" err="1">
-                <a:solidFill>
-                  <a:srgbClr val="192D3E"/>
-                </a:solidFill>
-                <a:latin typeface="Arial"/>
-              </a:rPr>
-              <a:t>d'aprendre</a:t>
-            </a:r>
-            <a:r>
-              <a:rPr sz="2400" b="0" dirty="0">
+              <a:rPr lang="es-ES" sz="2400" b="0" dirty="0" err="1">
+                <a:solidFill>
+                  <a:srgbClr val="192D3E"/>
+                </a:solidFill>
+                <a:latin typeface="Arial"/>
+              </a:rPr>
+              <a:t>com</a:t>
+            </a:r>
+            <a:r>
+              <a:rPr lang="es-ES" sz="2400" b="0" dirty="0">
+                <a:solidFill>
+                  <a:srgbClr val="192D3E"/>
+                </a:solidFill>
+                <a:latin typeface="Arial"/>
+              </a:rPr>
+              <a:t> en </a:t>
+            </a:r>
+            <a:r>
+              <a:rPr lang="es-ES" sz="2400" b="0" dirty="0" err="1">
+                <a:solidFill>
+                  <a:srgbClr val="192D3E"/>
+                </a:solidFill>
+                <a:latin typeface="Arial"/>
+              </a:rPr>
+              <a:t>l’àmbit</a:t>
+            </a:r>
+            <a:r>
+              <a:rPr lang="es-ES" sz="2400" b="0" dirty="0">
+                <a:solidFill>
+                  <a:srgbClr val="192D3E"/>
+                </a:solidFill>
+                <a:latin typeface="Arial"/>
+              </a:rPr>
+              <a:t> </a:t>
+            </a:r>
+            <a:r>
+              <a:rPr lang="es-ES" sz="2400" b="0" dirty="0" err="1">
+                <a:solidFill>
+                  <a:srgbClr val="192D3E"/>
+                </a:solidFill>
+                <a:latin typeface="Arial"/>
+              </a:rPr>
+              <a:t>acadèmic</a:t>
+            </a:r>
+            <a:r>
+              <a:rPr lang="es-ES" sz="2400" b="0" dirty="0">
+                <a:solidFill>
+                  <a:srgbClr val="192D3E"/>
+                </a:solidFill>
+                <a:latin typeface="Arial"/>
+              </a:rPr>
+              <a:t>, al </a:t>
+            </a:r>
+            <a:r>
+              <a:rPr lang="es-ES" sz="2400" b="0" dirty="0" err="1">
+                <a:solidFill>
+                  <a:srgbClr val="192D3E"/>
+                </a:solidFill>
+                <a:latin typeface="Arial"/>
+              </a:rPr>
+              <a:t>costat</a:t>
+            </a:r>
+            <a:r>
+              <a:rPr lang="es-ES" sz="2400" b="0" dirty="0">
+                <a:solidFill>
+                  <a:srgbClr val="192D3E"/>
+                </a:solidFill>
+                <a:latin typeface="Arial"/>
+              </a:rPr>
+              <a:t> </a:t>
+            </a:r>
+            <a:r>
+              <a:rPr lang="es-ES" sz="2400" b="0" dirty="0" err="1">
+                <a:solidFill>
+                  <a:srgbClr val="192D3E"/>
+                </a:solidFill>
+                <a:latin typeface="Arial"/>
+              </a:rPr>
+              <a:t>d’un</a:t>
+            </a:r>
+            <a:r>
+              <a:rPr lang="es-ES" sz="2400" b="0" dirty="0">
+                <a:solidFill>
+                  <a:srgbClr val="192D3E"/>
+                </a:solidFill>
+                <a:latin typeface="Arial"/>
+              </a:rPr>
+              <a:t> </a:t>
+            </a:r>
+            <a:r>
+              <a:rPr lang="es-ES" sz="2400" b="0" dirty="0" err="1">
+                <a:solidFill>
+                  <a:srgbClr val="192D3E"/>
+                </a:solidFill>
+                <a:latin typeface="Arial"/>
+              </a:rPr>
+              <a:t>equip</a:t>
+            </a:r>
+            <a:r>
+              <a:rPr lang="es-ES" sz="2400" b="0" dirty="0">
+                <a:solidFill>
+                  <a:srgbClr val="192D3E"/>
+                </a:solidFill>
+                <a:latin typeface="Arial"/>
+              </a:rPr>
+              <a:t> del </a:t>
+            </a:r>
+            <a:r>
+              <a:rPr lang="es-ES" sz="2400" b="0" dirty="0" err="1">
+                <a:solidFill>
+                  <a:srgbClr val="192D3E"/>
+                </a:solidFill>
+                <a:latin typeface="Arial"/>
+              </a:rPr>
+              <a:t>qual</a:t>
+            </a:r>
+            <a:r>
+              <a:rPr lang="es-ES" sz="2400" b="0" dirty="0">
+                <a:solidFill>
+                  <a:srgbClr val="192D3E"/>
+                </a:solidFill>
+                <a:latin typeface="Arial"/>
+              </a:rPr>
+              <a:t> </a:t>
+            </a:r>
+            <a:r>
+              <a:rPr lang="es-ES" sz="2400" b="0" dirty="0" err="1">
+                <a:solidFill>
+                  <a:srgbClr val="192D3E"/>
+                </a:solidFill>
+                <a:latin typeface="Arial"/>
+              </a:rPr>
+              <a:t>aprenc</a:t>
+            </a:r>
+            <a:r>
+              <a:rPr lang="es-ES" sz="2400" b="0" dirty="0">
+                <a:solidFill>
+                  <a:srgbClr val="192D3E"/>
+                </a:solidFill>
+                <a:latin typeface="Arial"/>
+              </a:rPr>
+              <a:t> i </a:t>
+            </a:r>
+            <a:r>
+              <a:rPr lang="es-ES" sz="2400" b="0" dirty="0" err="1">
+                <a:solidFill>
+                  <a:srgbClr val="192D3E"/>
+                </a:solidFill>
+                <a:latin typeface="Arial"/>
+              </a:rPr>
+              <a:t>amb</a:t>
+            </a:r>
+            <a:r>
+              <a:rPr lang="es-ES" sz="2400" b="0" dirty="0">
+                <a:solidFill>
+                  <a:srgbClr val="192D3E"/>
+                </a:solidFill>
+                <a:latin typeface="Arial"/>
+              </a:rPr>
+              <a:t> qui </a:t>
+            </a:r>
+            <a:r>
+              <a:rPr lang="es-ES" sz="2400" b="0" dirty="0" err="1">
+                <a:solidFill>
+                  <a:srgbClr val="192D3E"/>
+                </a:solidFill>
+                <a:latin typeface="Arial"/>
+              </a:rPr>
+              <a:t>comparteixo</a:t>
+            </a:r>
+            <a:r>
+              <a:rPr lang="es-ES" sz="2400" b="0" dirty="0">
+                <a:solidFill>
+                  <a:srgbClr val="192D3E"/>
+                </a:solidFill>
+                <a:latin typeface="Arial"/>
+              </a:rPr>
+              <a:t> </a:t>
+            </a:r>
+            <a:r>
+              <a:rPr lang="es-ES" sz="2400" b="0" dirty="0" err="1">
+                <a:solidFill>
+                  <a:srgbClr val="192D3E"/>
+                </a:solidFill>
+                <a:latin typeface="Arial"/>
+              </a:rPr>
+              <a:t>coneixement</a:t>
+            </a:r>
+            <a:r>
+              <a:rPr lang="es-ES" sz="2400" b="0" dirty="0">
                 <a:solidFill>
                   <a:srgbClr val="192D3E"/>
                 </a:solidFill>
@@ -6353,34 +6621,34 @@
               <a:t>, </a:t>
             </a:r>
             <a:r>
-              <a:rPr sz="2400" b="0" dirty="0" err="1">
-                <a:solidFill>
-                  <a:srgbClr val="192D3E"/>
-                </a:solidFill>
-                <a:latin typeface="Arial"/>
-              </a:rPr>
-              <a:t>créixer</a:t>
-            </a:r>
-            <a:r>
-              <a:rPr sz="2400" b="0" dirty="0">
-                <a:solidFill>
-                  <a:srgbClr val="192D3E"/>
-                </a:solidFill>
-                <a:latin typeface="Arial"/>
-              </a:rPr>
-              <a:t> com a docent </a:t>
-            </a:r>
-            <a:r>
-              <a:rPr sz="2400" b="0" dirty="0" err="1">
-                <a:solidFill>
-                  <a:srgbClr val="192D3E"/>
-                </a:solidFill>
-                <a:latin typeface="Arial"/>
-              </a:rPr>
-              <a:t>i</a:t>
-            </a:r>
-            <a:r>
-              <a:rPr sz="2400" b="0" dirty="0">
+              <a:rPr lang="es-ES" sz="2400" b="0" dirty="0" err="1">
+                <a:solidFill>
+                  <a:srgbClr val="192D3E"/>
+                </a:solidFill>
+                <a:latin typeface="Arial"/>
+              </a:rPr>
+              <a:t>responsabilitat</a:t>
+            </a:r>
+            <a:r>
+              <a:rPr lang="es-ES" sz="2400" b="0" dirty="0">
+                <a:solidFill>
+                  <a:srgbClr val="192D3E"/>
+                </a:solidFill>
+                <a:latin typeface="Arial"/>
+              </a:rPr>
+              <a:t> i </a:t>
+            </a:r>
+            <a:r>
+              <a:rPr lang="es-ES" sz="2400" b="0" dirty="0" err="1">
+                <a:solidFill>
+                  <a:srgbClr val="192D3E"/>
+                </a:solidFill>
+                <a:latin typeface="Arial"/>
+              </a:rPr>
+              <a:t>compromís</a:t>
+            </a:r>
+            <a:r>
+              <a:rPr lang="es-ES" sz="2400" b="0" dirty="0">
                 <a:solidFill>
                   <a:srgbClr val="192D3E"/>
                 </a:solidFill>
@@ -6389,16 +6657,34 @@
               <a:t> </a:t>
             </a:r>
             <a:r>
-              <a:rPr sz="2400" b="0" dirty="0" err="1">
-                <a:solidFill>
-                  <a:srgbClr val="192D3E"/>
-                </a:solidFill>
-                <a:latin typeface="Arial"/>
-              </a:rPr>
-              <a:t>transferir</a:t>
-            </a:r>
-            <a:r>
-              <a:rPr sz="2400" b="0" dirty="0">
+              <a:rPr lang="es-ES" sz="2400" b="0" dirty="0" err="1">
+                <a:solidFill>
+                  <a:srgbClr val="192D3E"/>
+                </a:solidFill>
+                <a:latin typeface="Arial"/>
+              </a:rPr>
+              <a:t>amb</a:t>
+            </a:r>
+            <a:r>
+              <a:rPr lang="es-ES" sz="2400" b="0" dirty="0">
+                <a:solidFill>
+                  <a:srgbClr val="192D3E"/>
+                </a:solidFill>
+                <a:latin typeface="Arial"/>
+              </a:rPr>
+              <a:t> la </a:t>
+            </a:r>
+            <a:r>
+              <a:rPr lang="es-ES" sz="2400" b="0" dirty="0" err="1">
+                <a:solidFill>
+                  <a:srgbClr val="192D3E"/>
+                </a:solidFill>
+                <a:latin typeface="Arial"/>
+              </a:rPr>
+              <a:t>formació</a:t>
+            </a:r>
+            <a:r>
+              <a:rPr lang="es-ES" sz="2400" b="0" dirty="0">
                 <a:solidFill>
                   <a:srgbClr val="192D3E"/>
                 </a:solidFill>
@@ -6407,22 +6693,13 @@
               <a:t> </a:t>
             </a:r>
             <a:r>
-              <a:rPr sz="2400" b="0" dirty="0" err="1">
-                <a:solidFill>
-                  <a:srgbClr val="192D3E"/>
-                </a:solidFill>
-                <a:latin typeface="Arial"/>
-              </a:rPr>
-              <a:t>coneixement</a:t>
-            </a:r>
-            <a:r>
-              <a:rPr sz="2400" b="0" dirty="0">
-                <a:solidFill>
-                  <a:srgbClr val="192D3E"/>
-                </a:solidFill>
-                <a:latin typeface="Arial"/>
-              </a:rPr>
-              <a:t> entre </a:t>
+              <a:rPr lang="es-ES" sz="2400" b="0" dirty="0" err="1">
+                <a:solidFill>
+                  <a:srgbClr val="192D3E"/>
+                </a:solidFill>
+                <a:latin typeface="Arial"/>
+              </a:rPr>
+              <a:t>universitària</a:t>
             </a:r>
             <a:r>
               <a:rPr lang="es-ES" sz="2400" b="0" dirty="0">
@@ -6431,71 +6708,14 @@
                 </a:solidFill>
                 <a:latin typeface="Arial"/>
               </a:rPr>
-              <a:t>la </a:t>
-            </a:r>
-            <a:r>
-              <a:rPr lang="es-ES" sz="2400" dirty="0" err="1">
-                <a:solidFill>
-                  <a:srgbClr val="192D3E"/>
-                </a:solidFill>
-                <a:latin typeface="Arial"/>
-              </a:rPr>
-              <a:t>U</a:t>
-            </a:r>
-            <a:r>
-              <a:rPr lang="es-ES" sz="2400" b="0" dirty="0" err="1">
-                <a:solidFill>
-                  <a:srgbClr val="192D3E"/>
-                </a:solidFill>
-                <a:latin typeface="Arial"/>
-              </a:rPr>
-              <a:t>niversitat</a:t>
-            </a:r>
-            <a:r>
-              <a:rPr lang="es-ES" sz="2400" b="0" dirty="0">
-                <a:solidFill>
-                  <a:srgbClr val="192D3E"/>
-                </a:solidFill>
-                <a:latin typeface="Arial"/>
-              </a:rPr>
-              <a:t> </a:t>
-            </a:r>
-            <a:r>
-              <a:rPr sz="2400" b="0" dirty="0" err="1">
-                <a:solidFill>
-                  <a:srgbClr val="192D3E"/>
-                </a:solidFill>
-                <a:latin typeface="Arial"/>
-              </a:rPr>
-              <a:t>i</a:t>
-            </a:r>
-            <a:r>
-              <a:rPr sz="2400" b="0" dirty="0">
-                <a:solidFill>
-                  <a:srgbClr val="192D3E"/>
-                </a:solidFill>
-                <a:latin typeface="Arial"/>
-              </a:rPr>
-              <a:t> l</a:t>
-            </a:r>
-            <a:r>
-              <a:rPr lang="es-ES" sz="2400" b="0" dirty="0">
-                <a:solidFill>
-                  <a:srgbClr val="192D3E"/>
-                </a:solidFill>
-                <a:latin typeface="Arial"/>
-              </a:rPr>
-              <a:t>’empresa</a:t>
-            </a:r>
-            <a:r>
-              <a:rPr sz="2400" b="0" dirty="0">
-                <a:solidFill>
-                  <a:srgbClr val="192D3E"/>
-                </a:solidFill>
-                <a:latin typeface="Arial"/>
-              </a:rPr>
               <a:t>.</a:t>
             </a:r>
+            <a:endParaRPr sz="2400" b="0" dirty="0">
+              <a:solidFill>
+                <a:srgbClr val="192D3E"/>
+              </a:solidFill>
+              <a:latin typeface="Arial"/>
+            </a:endParaRPr>
           </a:p>
         </p:txBody>
       </p:sp>
@@ -6507,7 +6727,7 @@
         </p:nvSpPr>
         <p:spPr>
           <a:xfrm>
-            <a:off x="1737360" y="3519164"/>
+            <a:off x="1885683" y="4295446"/>
             <a:ext cx="8595360" cy="1217428"/>
           </a:xfrm>
           <a:prstGeom prst="roundRect">
@@ -6553,7 +6773,7 @@
         </p:nvSpPr>
         <p:spPr>
           <a:xfrm>
-            <a:off x="1897912" y="3729475"/>
+            <a:off x="2046235" y="4399432"/>
             <a:ext cx="8099528" cy="868681"/>
           </a:xfrm>
           <a:prstGeom prst="rect">
@@ -6692,7 +6912,7 @@
                 </a:solidFill>
                 <a:latin typeface="Arial"/>
               </a:rPr>
-              <a:t> molt </a:t>
+              <a:t> </a:t>
             </a:r>
             <a:r>
               <a:rPr sz="1600" b="0" dirty="0" err="1">
@@ -6749,43 +6969,79 @@
               <a:t>software</a:t>
             </a:r>
             <a:r>
+              <a:rPr lang="es-ES" sz="1600" dirty="0">
+                <a:solidFill>
+                  <a:srgbClr val="192D3E"/>
+                </a:solidFill>
+                <a:latin typeface="Arial"/>
+              </a:rPr>
+              <a:t>, </a:t>
+            </a:r>
+            <a:r>
+              <a:rPr lang="es-ES" sz="1600" b="0" dirty="0" err="1">
+                <a:solidFill>
+                  <a:srgbClr val="192D3E"/>
+                </a:solidFill>
+                <a:latin typeface="Arial"/>
+              </a:rPr>
+              <a:t>metodologies</a:t>
+            </a:r>
+            <a:r>
               <a:rPr lang="es-ES" sz="1600" b="0" dirty="0">
                 <a:solidFill>
                   <a:srgbClr val="192D3E"/>
                 </a:solidFill>
                 <a:latin typeface="Arial"/>
               </a:rPr>
+              <a:t> actives </a:t>
+            </a:r>
+            <a:r>
+              <a:rPr lang="es-ES" sz="1600" b="0" dirty="0" err="1">
+                <a:solidFill>
+                  <a:srgbClr val="192D3E"/>
+                </a:solidFill>
+                <a:latin typeface="Arial"/>
+              </a:rPr>
+              <a:t>d'aprenentatge</a:t>
+            </a:r>
+            <a:r>
+              <a:rPr lang="es-ES" sz="1600" dirty="0">
+                <a:solidFill>
+                  <a:srgbClr val="192D3E"/>
+                </a:solidFill>
+                <a:latin typeface="Arial"/>
+              </a:rPr>
               <a:t> i </a:t>
             </a:r>
             <a:r>
-              <a:rPr lang="es-ES" sz="1600" b="0" dirty="0" err="1">
-                <a:solidFill>
-                  <a:srgbClr val="192D3E"/>
-                </a:solidFill>
-                <a:latin typeface="Arial"/>
-              </a:rPr>
-              <a:t>metodologies</a:t>
-            </a:r>
-            <a:r>
-              <a:rPr lang="es-ES" sz="1600" b="0" dirty="0">
-                <a:solidFill>
-                  <a:srgbClr val="192D3E"/>
-                </a:solidFill>
-                <a:latin typeface="Arial"/>
-              </a:rPr>
-              <a:t> actives </a:t>
-            </a:r>
-            <a:r>
-              <a:rPr lang="es-ES" sz="1600" b="0" dirty="0" err="1">
-                <a:solidFill>
-                  <a:srgbClr val="192D3E"/>
-                </a:solidFill>
-                <a:latin typeface="Arial"/>
-              </a:rPr>
-              <a:t>d'aprenentatge</a:t>
-            </a:r>
-            <a:r>
-              <a:rPr sz="1600" b="0" dirty="0">
+              <a:rPr lang="es-ES" sz="1600" dirty="0" err="1">
+                <a:solidFill>
+                  <a:srgbClr val="192D3E"/>
+                </a:solidFill>
+                <a:latin typeface="Arial"/>
+              </a:rPr>
+              <a:t>treball</a:t>
+            </a:r>
+            <a:r>
+              <a:rPr lang="es-ES" sz="1600" dirty="0">
+                <a:solidFill>
+                  <a:srgbClr val="192D3E"/>
+                </a:solidFill>
+                <a:latin typeface="Arial"/>
+              </a:rPr>
+              <a:t> en </a:t>
+            </a:r>
+            <a:r>
+              <a:rPr lang="es-ES" sz="1600" dirty="0" err="1">
+                <a:solidFill>
+                  <a:srgbClr val="192D3E"/>
+                </a:solidFill>
+                <a:latin typeface="Arial"/>
+              </a:rPr>
+              <a:t>equip</a:t>
+            </a:r>
+            <a:r>
+              <a:rPr lang="es-ES" sz="1600" dirty="0">
                 <a:solidFill>
                   <a:srgbClr val="192D3E"/>
                 </a:solidFill>
@@ -6793,6 +7049,12 @@
               </a:rPr>
               <a:t>.</a:t>
             </a:r>
+            <a:endParaRPr sz="1600" b="0" dirty="0">
+              <a:solidFill>
+                <a:srgbClr val="192D3E"/>
+              </a:solidFill>
+              <a:latin typeface="Arial"/>
+            </a:endParaRPr>
           </a:p>
         </p:txBody>
       </p:sp>
@@ -8194,7 +8456,7 @@
         </p:spPr>
         <p:txBody>
           <a:bodyPr wrap="square">
-            <a:normAutofit lnSpcReduction="10000"/>
+            <a:normAutofit/>
           </a:bodyPr>
           <a:lstStyle/>
           <a:p>
@@ -8287,7 +8549,7 @@
         </p:spPr>
         <p:txBody>
           <a:bodyPr wrap="square">
-            <a:normAutofit fontScale="92500" lnSpcReduction="20000"/>
+            <a:normAutofit/>
           </a:bodyPr>
           <a:lstStyle/>
           <a:p>
@@ -10187,7 +10449,7 @@
         </p:spPr>
         <p:txBody>
           <a:bodyPr wrap="square">
-            <a:normAutofit/>
+            <a:normAutofit fontScale="85000" lnSpcReduction="10000"/>
           </a:bodyPr>
           <a:lstStyle/>
           <a:p>
@@ -12894,7 +13156,7 @@
         </p:nvSpPr>
         <p:spPr>
           <a:xfrm>
-            <a:off x="594360" y="6473952"/>
+            <a:off x="604993" y="6473952"/>
             <a:ext cx="8595360" cy="201168"/>
           </a:xfrm>
           <a:prstGeom prst="rect">
@@ -12958,10 +13220,10 @@
       </p:sp>
       <p:pic>
         <p:nvPicPr>
-          <p:cNvPr id="11" name="Imagen 10">
+          <p:cNvPr id="7" name="Imagen 6">
             <a:extLst>
               <a:ext uri="{FF2B5EF4-FFF2-40B4-BE49-F238E27FC236}">
-                <a16:creationId xmlns:a16="http://schemas.microsoft.com/office/drawing/2014/main" id="{B6A73A3E-C968-EC80-D679-F89DCA1ECD1A}"/>
+                <a16:creationId xmlns:a16="http://schemas.microsoft.com/office/drawing/2014/main" id="{74450190-3EBE-2ED3-C573-816824D86797}"/>
               </a:ext>
             </a:extLst>
           </p:cNvPr>
@@ -12978,8 +13240,8 @@
         </p:blipFill>
         <p:spPr>
           <a:xfrm>
-            <a:off x="178054" y="1129284"/>
-            <a:ext cx="11486875" cy="5344668"/>
+            <a:off x="594360" y="1197888"/>
+            <a:ext cx="11229045" cy="5234892"/>
           </a:xfrm>
           <a:prstGeom prst="rect">
             <a:avLst/>

</xml_diff>

<commit_message>
docs: fix presentation spelling
</commit_message>
<xml_diff>
--- a/doc/presentations/defensa-placa-permanent-dsi-ports-sortida-hexagonal/output/IMPORTANTE_MANUAL_defensa-dsi-ports-sortida-hexagonal.pptx
+++ b/doc/presentations/defensa-placa-permanent-dsi-ports-sortida-hexagonal/output/IMPORTANTE_MANUAL_defensa-dsi-ports-sortida-hexagonal.pptx
@@ -4061,7 +4061,7 @@
 </file>
 
 <file path=ppt/slides/slide10.xml><?xml version="1.0" encoding="utf-8"?>
-<p:sld xmlns:a="http://schemas.openxmlformats.org/drawingml/2006/main" xmlns:r="http://schemas.openxmlformats.org/officeDocument/2006/relationships" xmlns:p="http://schemas.openxmlformats.org/presentationml/2006/main">
+<p:sld xmlns:a="http://schemas.openxmlformats.org/drawingml/2006/main" xmlns:ns3="http://schemas.microsoft.com/office/drawing/2014/main" xmlns:p="http://schemas.openxmlformats.org/presentationml/2006/main" xmlns:r="http://schemas.openxmlformats.org/officeDocument/2006/relationships">
   <p:cSld>
     <p:spTree>
       <p:nvGrpSpPr>
@@ -4193,7 +4193,7 @@
                 </a:solidFill>
                 <a:latin typeface="Arial"/>
               </a:rPr>
-              <a:t>   El cas </a:t>
+              <a:t>El cas d’ús necessita el preu actual, no un proveïdor concret.</a:t>
             </a:r>
             <a:r>
               <a:rPr lang="es-ES" sz="1400" b="1" dirty="0" err="1">
@@ -4202,7 +4202,7 @@
                 </a:solidFill>
                 <a:latin typeface="Arial"/>
               </a:rPr>
-              <a:t>d’ús</a:t>
+              <a:t/>
             </a:r>
             <a:r>
               <a:rPr lang="es-ES" sz="1400" b="1" dirty="0">
@@ -4211,7 +4211,7 @@
                 </a:solidFill>
                 <a:latin typeface="Arial"/>
               </a:rPr>
-              <a:t> </a:t>
+              <a:t/>
             </a:r>
             <a:r>
               <a:rPr lang="es-ES" sz="1400" b="1" dirty="0" err="1">
@@ -4220,7 +4220,7 @@
                 </a:solidFill>
                 <a:latin typeface="Arial"/>
               </a:rPr>
-              <a:t>necessita</a:t>
+              <a:t/>
             </a:r>
             <a:r>
               <a:rPr lang="es-ES" sz="1400" b="1" dirty="0">
@@ -4229,7 +4229,7 @@
                 </a:solidFill>
                 <a:latin typeface="Arial"/>
               </a:rPr>
-              <a:t> el preu actual, no un </a:t>
+              <a:t/>
             </a:r>
             <a:r>
               <a:rPr lang="es-ES" sz="1400" b="1" dirty="0" err="1">
@@ -4238,7 +4238,7 @@
                 </a:solidFill>
                 <a:latin typeface="Arial"/>
               </a:rPr>
-              <a:t>proveïdor</a:t>
+              <a:t/>
             </a:r>
             <a:r>
               <a:rPr lang="es-ES" sz="1400" b="1" dirty="0">
@@ -4247,7 +4247,7 @@
                 </a:solidFill>
                 <a:latin typeface="Arial"/>
               </a:rPr>
-              <a:t> </a:t>
+              <a:t/>
             </a:r>
             <a:r>
               <a:rPr lang="es-ES" sz="1400" b="1" dirty="0" err="1">
@@ -4256,7 +4256,7 @@
                 </a:solidFill>
                 <a:latin typeface="Arial"/>
               </a:rPr>
-              <a:t>concret</a:t>
+              <a:t/>
             </a:r>
             <a:r>
               <a:rPr lang="es-ES" sz="1400" b="1" dirty="0">
@@ -4265,7 +4265,7 @@
                 </a:solidFill>
                 <a:latin typeface="Arial"/>
               </a:rPr>
-              <a:t>.</a:t>
+              <a:t/>
             </a:r>
             <a:endParaRPr sz="1300" b="0" dirty="0">
               <a:solidFill>
@@ -4409,7 +4409,7 @@
                 </a:solidFill>
                 <a:latin typeface="Arial"/>
               </a:rPr>
-              <a:t>9</a:t>
+              <a:t>10</a:t>
             </a:r>
           </a:p>
         </p:txBody>
@@ -4508,7 +4508,7 @@
           <p:cNvPr id="7" name="Imagen 6">
             <a:extLst>
               <a:ext uri="{FF2B5EF4-FFF2-40B4-BE49-F238E27FC236}">
-                <a16:creationId xmlns:a16="http://schemas.microsoft.com/office/drawing/2014/main" id="{A6EDC6F8-5757-04F1-70A5-BEE4AFAFA363}"/>
+                <ns3:creationId id="{A6EDC6F8-5757-04F1-70A5-BEE4AFAFA363}"/>
               </a:ext>
             </a:extLst>
           </p:cNvPr>
@@ -4542,7 +4542,7 @@
 </file>
 
 <file path=ppt/slides/slide11.xml><?xml version="1.0" encoding="utf-8"?>
-<p:sld xmlns:a="http://schemas.openxmlformats.org/drawingml/2006/main" xmlns:r="http://schemas.openxmlformats.org/officeDocument/2006/relationships" xmlns:p="http://schemas.openxmlformats.org/presentationml/2006/main">
+<p:sld xmlns:a="http://schemas.openxmlformats.org/drawingml/2006/main" xmlns:p="http://schemas.openxmlformats.org/presentationml/2006/main" xmlns:r="http://schemas.openxmlformats.org/officeDocument/2006/relationships">
   <p:cSld>
     <p:spTree>
       <p:nvGrpSpPr>
@@ -4926,7 +4926,7 @@
                 </a:solidFill>
                 <a:latin typeface="Arial"/>
               </a:rPr>
-              <a:t>10</a:t>
+              <a:t>11</a:t>
             </a:r>
           </a:p>
         </p:txBody>
@@ -4964,7 +4964,7 @@
 </file>
 
 <file path=ppt/slides/slide12.xml><?xml version="1.0" encoding="utf-8"?>
-<p:sld xmlns:a="http://schemas.openxmlformats.org/drawingml/2006/main" xmlns:r="http://schemas.openxmlformats.org/officeDocument/2006/relationships" xmlns:p="http://schemas.openxmlformats.org/presentationml/2006/main">
+<p:sld xmlns:a="http://schemas.openxmlformats.org/drawingml/2006/main" xmlns:p="http://schemas.openxmlformats.org/presentationml/2006/main" xmlns:r="http://schemas.openxmlformats.org/officeDocument/2006/relationships">
   <p:cSld>
     <p:spTree>
       <p:nvGrpSpPr>
@@ -5723,7 +5723,7 @@
                 </a:solidFill>
                 <a:latin typeface="Arial"/>
               </a:rPr>
-              <a:t>Canvi</a:t>
+              <a:t>Canvi tecnològic: adaptador Finnhub ↔ adaptador Alpha Vantage</a:t>
             </a:r>
             <a:r>
               <a:rPr lang="es-ES" sz="2600" b="1" dirty="0">
@@ -5732,7 +5732,7 @@
                 </a:solidFill>
                 <a:latin typeface="Arial"/>
               </a:rPr>
-              <a:t> </a:t>
+              <a:t/>
             </a:r>
             <a:r>
               <a:rPr lang="es-ES" sz="2600" b="1" dirty="0" err="1">
@@ -5741,7 +5741,7 @@
                 </a:solidFill>
                 <a:latin typeface="Arial"/>
               </a:rPr>
-              <a:t>tecnològic</a:t>
+              <a:t/>
             </a:r>
             <a:r>
               <a:rPr sz="2600" b="1" dirty="0">
@@ -5750,7 +5750,7 @@
                 </a:solidFill>
                 <a:latin typeface="Arial"/>
               </a:rPr>
-              <a:t>: </a:t>
+              <a:t/>
             </a:r>
             <a:r>
               <a:rPr sz="2600" b="1" dirty="0" err="1">
@@ -5759,7 +5759,7 @@
                 </a:solidFill>
                 <a:latin typeface="Arial"/>
               </a:rPr>
-              <a:t>adaptador</a:t>
+              <a:t/>
             </a:r>
             <a:r>
               <a:rPr sz="2600" b="1" dirty="0">
@@ -5768,7 +5768,7 @@
                 </a:solidFill>
                 <a:latin typeface="Arial"/>
               </a:rPr>
-              <a:t> </a:t>
+              <a:t/>
             </a:r>
             <a:r>
               <a:rPr lang="es-ES" sz="2600" b="1" dirty="0" err="1">
@@ -5777,7 +5777,7 @@
                 </a:solidFill>
                 <a:latin typeface="Arial"/>
               </a:rPr>
-              <a:t>FinHub</a:t>
+              <a:t/>
             </a:r>
             <a:r>
               <a:rPr sz="2600" b="1" dirty="0">
@@ -5786,7 +5786,7 @@
                 </a:solidFill>
                 <a:latin typeface="Arial"/>
               </a:rPr>
-              <a:t>  ↔  </a:t>
+              <a:t/>
             </a:r>
             <a:r>
               <a:rPr sz="2600" b="1" dirty="0" err="1">
@@ -5795,7 +5795,7 @@
                 </a:solidFill>
                 <a:latin typeface="Arial"/>
               </a:rPr>
-              <a:t>adaptador</a:t>
+              <a:t/>
             </a:r>
             <a:r>
               <a:rPr lang="es-ES" sz="2600" b="1" dirty="0">
@@ -5804,7 +5804,7 @@
                 </a:solidFill>
                 <a:latin typeface="Arial"/>
               </a:rPr>
-              <a:t> </a:t>
+              <a:t/>
             </a:r>
             <a:r>
               <a:rPr lang="es-ES" sz="2600" b="1" dirty="0" err="1">
@@ -5813,7 +5813,7 @@
                 </a:solidFill>
                 <a:latin typeface="Arial"/>
               </a:rPr>
-              <a:t>AlphaVantage</a:t>
+              <a:t/>
             </a:r>
             <a:endParaRPr sz="2600" b="1" dirty="0">
               <a:solidFill>
@@ -6086,7 +6086,7 @@
                 </a:solidFill>
                 <a:latin typeface="Arial"/>
               </a:rPr>
-              <a:t>11</a:t>
+              <a:t>12</a:t>
             </a:r>
           </a:p>
         </p:txBody>
@@ -8872,7 +8872,7 @@
 </file>
 
 <file path=ppt/slides/slide5.xml><?xml version="1.0" encoding="utf-8"?>
-<p:sld xmlns:a="http://schemas.openxmlformats.org/drawingml/2006/main" xmlns:r="http://schemas.openxmlformats.org/officeDocument/2006/relationships" xmlns:p="http://schemas.openxmlformats.org/presentationml/2006/main">
+<p:sld xmlns:a="http://schemas.openxmlformats.org/drawingml/2006/main" xmlns:p="http://schemas.openxmlformats.org/presentationml/2006/main" xmlns:r="http://schemas.openxmlformats.org/officeDocument/2006/relationships">
   <p:cSld>
     <p:spTree>
       <p:nvGrpSpPr>
@@ -9691,7 +9691,7 @@
                 </a:solidFill>
                 <a:latin typeface="Arial"/>
               </a:rPr>
-              <a:t>4</a:t>
+              <a:t>5</a:t>
             </a:r>
           </a:p>
         </p:txBody>
@@ -9705,7 +9705,7 @@
 </file>
 
 <file path=ppt/slides/slide6.xml><?xml version="1.0" encoding="utf-8"?>
-<p:sld xmlns:a="http://schemas.openxmlformats.org/drawingml/2006/main" xmlns:r="http://schemas.openxmlformats.org/officeDocument/2006/relationships" xmlns:p="http://schemas.openxmlformats.org/presentationml/2006/main">
+<p:sld xmlns:a="http://schemas.openxmlformats.org/drawingml/2006/main" xmlns:p="http://schemas.openxmlformats.org/presentationml/2006/main" xmlns:r="http://schemas.openxmlformats.org/officeDocument/2006/relationships">
   <p:cSld>
     <p:spTree>
       <p:nvGrpSpPr>
@@ -10161,7 +10161,7 @@
                 </a:solidFill>
                 <a:latin typeface="Arial"/>
               </a:rPr>
-              <a:t>PICA = Plataforma </a:t>
+              <a:t>PICA = Plataforma d’Integració i Col·laboració Administrativa de la Generalitat de Catalunya. És una plataforma corporativa de la Generalitat per facilitar la interoperabilitat entre sistemes de la Generalitat, altres administracions públiques i institucions.</a:t>
             </a:r>
             <a:r>
               <a:rPr lang="es-ES" sz="1000" b="0" dirty="0" err="1">
@@ -10170,7 +10170,7 @@
                 </a:solidFill>
                 <a:latin typeface="Arial"/>
               </a:rPr>
-              <a:t>d’Integració</a:t>
+              <a:t/>
             </a:r>
             <a:r>
               <a:rPr lang="es-ES" sz="1000" b="0" dirty="0">
@@ -10179,7 +10179,7 @@
                 </a:solidFill>
                 <a:latin typeface="Arial"/>
               </a:rPr>
-              <a:t> i </a:t>
+              <a:t/>
             </a:r>
             <a:r>
               <a:rPr lang="es-ES" sz="1000" b="0" dirty="0" err="1">
@@ -10188,7 +10188,7 @@
                 </a:solidFill>
                 <a:latin typeface="Arial"/>
               </a:rPr>
-              <a:t>Col·laboració</a:t>
+              <a:t/>
             </a:r>
             <a:r>
               <a:rPr lang="es-ES" sz="1000" b="0" dirty="0">
@@ -10197,7 +10197,7 @@
                 </a:solidFill>
                 <a:latin typeface="Arial"/>
               </a:rPr>
-              <a:t> Administrativa de la </a:t>
+              <a:t/>
             </a:r>
             <a:r>
               <a:rPr lang="es-ES" sz="1000" b="0" dirty="0" err="1">
@@ -10206,7 +10206,7 @@
                 </a:solidFill>
                 <a:latin typeface="Arial"/>
               </a:rPr>
-              <a:t>Generarlitat</a:t>
+              <a:t/>
             </a:r>
             <a:r>
               <a:rPr lang="es-ES" sz="1000" b="0" dirty="0">
@@ -10215,7 +10215,7 @@
                 </a:solidFill>
                 <a:latin typeface="Arial"/>
               </a:rPr>
-              <a:t> de Catalunya</a:t>
+              <a:t/>
             </a:r>
             <a:br>
               <a:rPr lang="es-ES" sz="1000" b="0" dirty="0">
@@ -10232,7 +10232,7 @@
                 </a:solidFill>
                 <a:latin typeface="Arial"/>
               </a:rPr>
-              <a:t>És</a:t>
+              <a:t/>
             </a:r>
             <a:r>
               <a:rPr lang="es-ES" sz="1000" b="0" dirty="0">
@@ -10241,7 +10241,7 @@
                 </a:solidFill>
                 <a:latin typeface="Arial"/>
               </a:rPr>
-              <a:t> una plataforma corporativa de la Generalitat per a facilitar la </a:t>
+              <a:t/>
             </a:r>
             <a:r>
               <a:rPr lang="es-ES" sz="1000" b="0" dirty="0" err="1">
@@ -10250,7 +10250,7 @@
                 </a:solidFill>
                 <a:latin typeface="Arial"/>
               </a:rPr>
-              <a:t>interoperabilitat</a:t>
+              <a:t/>
             </a:r>
             <a:r>
               <a:rPr lang="es-ES" sz="1000" b="0" dirty="0">
@@ -10259,7 +10259,7 @@
                 </a:solidFill>
                 <a:latin typeface="Arial"/>
               </a:rPr>
-              <a:t> entre </a:t>
+              <a:t/>
             </a:r>
             <a:r>
               <a:rPr lang="es-ES" sz="1000" b="0" dirty="0" err="1">
@@ -10268,7 +10268,7 @@
                 </a:solidFill>
                 <a:latin typeface="Arial"/>
               </a:rPr>
-              <a:t>sistemes</a:t>
+              <a:t/>
             </a:r>
             <a:r>
               <a:rPr lang="es-ES" sz="1000" b="0" dirty="0">
@@ -10277,7 +10277,7 @@
                 </a:solidFill>
                 <a:latin typeface="Arial"/>
               </a:rPr>
-              <a:t> de la Generalitat, </a:t>
+              <a:t/>
             </a:r>
             <a:r>
               <a:rPr lang="es-ES" sz="1000" b="0" dirty="0" err="1">
@@ -10286,7 +10286,7 @@
                 </a:solidFill>
                 <a:latin typeface="Arial"/>
               </a:rPr>
-              <a:t>altres</a:t>
+              <a:t/>
             </a:r>
             <a:r>
               <a:rPr lang="es-ES" sz="1000" b="0" dirty="0">
@@ -10295,7 +10295,7 @@
                 </a:solidFill>
                 <a:latin typeface="Arial"/>
               </a:rPr>
-              <a:t> </a:t>
+              <a:t/>
             </a:r>
             <a:r>
               <a:rPr lang="es-ES" sz="1000" b="0" dirty="0" err="1">
@@ -10304,7 +10304,7 @@
                 </a:solidFill>
                 <a:latin typeface="Arial"/>
               </a:rPr>
-              <a:t>administracions</a:t>
+              <a:t/>
             </a:r>
             <a:r>
               <a:rPr lang="es-ES" sz="1000" b="0" dirty="0">
@@ -10313,7 +10313,7 @@
                 </a:solidFill>
                 <a:latin typeface="Arial"/>
               </a:rPr>
-              <a:t> públiques i </a:t>
+              <a:t/>
             </a:r>
             <a:r>
               <a:rPr lang="es-ES" sz="1000" b="0" dirty="0" err="1">
@@ -10322,7 +10322,7 @@
                 </a:solidFill>
                 <a:latin typeface="Arial"/>
               </a:rPr>
-              <a:t>institucions</a:t>
+              <a:t/>
             </a:r>
             <a:r>
               <a:rPr lang="es-ES" sz="1000" b="0" dirty="0">
@@ -10331,7 +10331,7 @@
                 </a:solidFill>
                 <a:latin typeface="Arial"/>
               </a:rPr>
-              <a:t>.</a:t>
+              <a:t/>
             </a:r>
           </a:p>
         </p:txBody>
@@ -10401,7 +10401,7 @@
                 </a:solidFill>
                 <a:latin typeface="Arial"/>
               </a:rPr>
-              <a:t>5</a:t>
+              <a:t>6</a:t>
             </a:r>
           </a:p>
         </p:txBody>
@@ -10415,7 +10415,7 @@
 </file>
 
 <file path=ppt/slides/slide7.xml><?xml version="1.0" encoding="utf-8"?>
-<p:sld xmlns:a="http://schemas.openxmlformats.org/drawingml/2006/main" xmlns:r="http://schemas.openxmlformats.org/officeDocument/2006/relationships" xmlns:p="http://schemas.openxmlformats.org/presentationml/2006/main">
+<p:sld xmlns:a="http://schemas.openxmlformats.org/drawingml/2006/main" xmlns:p="http://schemas.openxmlformats.org/presentationml/2006/main" xmlns:r="http://schemas.openxmlformats.org/officeDocument/2006/relationships">
   <p:cSld>
     <p:spTree>
       <p:nvGrpSpPr>
@@ -11332,7 +11332,7 @@
                 </a:solidFill>
                 <a:latin typeface="Arial"/>
               </a:rPr>
-              <a:t>6</a:t>
+              <a:t>7</a:t>
             </a:r>
           </a:p>
         </p:txBody>
@@ -11741,7 +11741,7 @@
                 </a:solidFill>
                 <a:latin typeface="Arial"/>
               </a:rPr>
-              <a:t>CTTI: Centre de </a:t>
+              <a:t>CTTI: Centre de Telecomunicacions i Tecnologies de la Informació de la Generalitat de Catalunya. És l’organisme de la Generalitat de Catalunya que presta serveis TIC corporatius i impulsa l’arquitectura i les solucions tecnològiques transversals de la Generalitat.</a:t>
             </a:r>
             <a:r>
               <a:rPr lang="es-ES" sz="1000" b="0" dirty="0" err="1">
@@ -11750,7 +11750,7 @@
                 </a:solidFill>
                 <a:latin typeface="Arial"/>
               </a:rPr>
-              <a:t>Telecomunicacions</a:t>
+              <a:t/>
             </a:r>
             <a:r>
               <a:rPr lang="es-ES" sz="1000" b="0" dirty="0">
@@ -11759,7 +11759,7 @@
                 </a:solidFill>
                 <a:latin typeface="Arial"/>
               </a:rPr>
-              <a:t> i </a:t>
+              <a:t/>
             </a:r>
             <a:r>
               <a:rPr lang="es-ES" sz="1000" b="0" dirty="0" err="1">
@@ -11768,7 +11768,7 @@
                 </a:solidFill>
                 <a:latin typeface="Arial"/>
               </a:rPr>
-              <a:t>Tecnologies</a:t>
+              <a:t/>
             </a:r>
             <a:r>
               <a:rPr lang="es-ES" sz="1000" b="0" dirty="0">
@@ -11777,7 +11777,7 @@
                 </a:solidFill>
                 <a:latin typeface="Arial"/>
               </a:rPr>
-              <a:t> de la </a:t>
+              <a:t/>
             </a:r>
             <a:r>
               <a:rPr lang="es-ES" sz="1000" b="0" dirty="0" err="1">
@@ -11786,7 +11786,7 @@
                 </a:solidFill>
                 <a:latin typeface="Arial"/>
               </a:rPr>
-              <a:t>Informació</a:t>
+              <a:t/>
             </a:r>
             <a:r>
               <a:rPr lang="es-ES" sz="1000" b="0" dirty="0">
@@ -11795,7 +11795,7 @@
                 </a:solidFill>
                 <a:latin typeface="Arial"/>
               </a:rPr>
-              <a:t> de la Generalitat de Catalunya.</a:t>
+              <a:t/>
             </a:r>
             <a:br>
               <a:rPr lang="es-ES" sz="1000" b="0" dirty="0">
@@ -11812,7 +11812,7 @@
                 </a:solidFill>
                 <a:latin typeface="Arial"/>
               </a:rPr>
-              <a:t>És</a:t>
+              <a:t/>
             </a:r>
             <a:r>
               <a:rPr lang="es-ES" sz="1000" b="0" dirty="0">
@@ -11821,7 +11821,7 @@
                 </a:solidFill>
                 <a:latin typeface="Arial"/>
               </a:rPr>
-              <a:t> </a:t>
+              <a:t/>
             </a:r>
             <a:r>
               <a:rPr lang="es-ES" sz="1000" b="0" dirty="0" err="1">
@@ -11830,7 +11830,7 @@
                 </a:solidFill>
                 <a:latin typeface="Arial"/>
               </a:rPr>
-              <a:t>l’organisme</a:t>
+              <a:t/>
             </a:r>
             <a:r>
               <a:rPr lang="es-ES" sz="1000" b="0" dirty="0">
@@ -11839,7 +11839,7 @@
                 </a:solidFill>
                 <a:latin typeface="Arial"/>
               </a:rPr>
-              <a:t> de la Generalitat de Catalunya que presta </a:t>
+              <a:t/>
             </a:r>
             <a:r>
               <a:rPr lang="es-ES" sz="1000" b="0" dirty="0" err="1">
@@ -11848,7 +11848,7 @@
                 </a:solidFill>
                 <a:latin typeface="Arial"/>
               </a:rPr>
-              <a:t>serveis</a:t>
+              <a:t/>
             </a:r>
             <a:r>
               <a:rPr lang="es-ES" sz="1000" b="0" dirty="0">
@@ -11857,7 +11857,7 @@
                 </a:solidFill>
                 <a:latin typeface="Arial"/>
               </a:rPr>
-              <a:t> TIC </a:t>
+              <a:t/>
             </a:r>
             <a:r>
               <a:rPr lang="es-ES" sz="1000" b="0" dirty="0" err="1">
@@ -11866,7 +11866,7 @@
                 </a:solidFill>
                 <a:latin typeface="Arial"/>
               </a:rPr>
-              <a:t>corporatius</a:t>
+              <a:t/>
             </a:r>
             <a:r>
               <a:rPr lang="es-ES" sz="1000" b="0" dirty="0">
@@ -11875,7 +11875,7 @@
                 </a:solidFill>
                 <a:latin typeface="Arial"/>
               </a:rPr>
-              <a:t> i impulsa </a:t>
+              <a:t/>
             </a:r>
             <a:r>
               <a:rPr lang="es-ES" sz="1000" b="0" dirty="0" err="1">
@@ -11884,7 +11884,7 @@
                 </a:solidFill>
                 <a:latin typeface="Arial"/>
               </a:rPr>
-              <a:t>l’arquitectura</a:t>
+              <a:t/>
             </a:r>
             <a:r>
               <a:rPr lang="es-ES" sz="1000" b="0" dirty="0">
@@ -11893,7 +11893,7 @@
                 </a:solidFill>
                 <a:latin typeface="Arial"/>
               </a:rPr>
-              <a:t> i les </a:t>
+              <a:t/>
             </a:r>
             <a:r>
               <a:rPr lang="es-ES" sz="1000" b="0" dirty="0" err="1">
@@ -11902,7 +11902,7 @@
                 </a:solidFill>
                 <a:latin typeface="Arial"/>
               </a:rPr>
-              <a:t>solucions</a:t>
+              <a:t/>
             </a:r>
             <a:r>
               <a:rPr lang="es-ES" sz="1000" b="0" dirty="0">
@@ -11911,7 +11911,7 @@
                 </a:solidFill>
                 <a:latin typeface="Arial"/>
               </a:rPr>
-              <a:t> </a:t>
+              <a:t/>
             </a:r>
             <a:r>
               <a:rPr lang="es-ES" sz="1000" b="0" dirty="0" err="1">
@@ -11920,7 +11920,7 @@
                 </a:solidFill>
                 <a:latin typeface="Arial"/>
               </a:rPr>
-              <a:t>tecnològiques</a:t>
+              <a:t/>
             </a:r>
             <a:r>
               <a:rPr lang="es-ES" sz="1000" b="0" dirty="0">
@@ -11929,7 +11929,7 @@
                 </a:solidFill>
                 <a:latin typeface="Arial"/>
               </a:rPr>
-              <a:t> </a:t>
+              <a:t/>
             </a:r>
             <a:r>
               <a:rPr lang="es-ES" sz="1000" b="0" dirty="0" err="1">
@@ -11938,7 +11938,7 @@
                 </a:solidFill>
                 <a:latin typeface="Arial"/>
               </a:rPr>
-              <a:t>transversals</a:t>
+              <a:t/>
             </a:r>
             <a:r>
               <a:rPr lang="es-ES" sz="1000" b="0" dirty="0">
@@ -11947,7 +11947,7 @@
                 </a:solidFill>
                 <a:latin typeface="Arial"/>
               </a:rPr>
-              <a:t> de la Generalitat.</a:t>
+              <a:t/>
             </a:r>
             <a:endParaRPr sz="1000" b="0" dirty="0">
               <a:solidFill>
@@ -11967,7 +11967,7 @@
 </file>
 
 <file path=ppt/slides/slide8.xml><?xml version="1.0" encoding="utf-8"?>
-<p:sld xmlns:a="http://schemas.openxmlformats.org/drawingml/2006/main" xmlns:r="http://schemas.openxmlformats.org/officeDocument/2006/relationships" xmlns:p="http://schemas.openxmlformats.org/presentationml/2006/main">
+<p:sld xmlns:a="http://schemas.openxmlformats.org/drawingml/2006/main" xmlns:p="http://schemas.openxmlformats.org/presentationml/2006/main" xmlns:r="http://schemas.openxmlformats.org/officeDocument/2006/relationships">
   <p:cSld>
     <p:spTree>
       <p:nvGrpSpPr>
@@ -12545,7 +12545,7 @@
                 </a:solidFill>
                 <a:latin typeface="Arial"/>
               </a:rPr>
-              <a:t>El port </a:t>
+              <a:t>El port defineix “què” necessita el cas d’ús</a:t>
             </a:r>
             <a:r>
               <a:rPr sz="2300" b="1" dirty="0" err="1">
@@ -12554,7 +12554,7 @@
                 </a:solidFill>
                 <a:latin typeface="Arial"/>
               </a:rPr>
-              <a:t>defineix</a:t>
+              <a:t/>
             </a:r>
             <a:r>
               <a:rPr sz="2300" b="1" dirty="0">
@@ -12563,7 +12563,7 @@
                 </a:solidFill>
                 <a:latin typeface="Arial"/>
               </a:rPr>
-              <a:t> </a:t>
+              <a:t/>
             </a:r>
             <a:r>
               <a:rPr lang="es-ES" sz="2300" b="1" dirty="0">
@@ -12572,7 +12572,7 @@
                 </a:solidFill>
                 <a:latin typeface="Arial"/>
               </a:rPr>
-              <a:t>"</a:t>
+              <a:t/>
             </a:r>
             <a:r>
               <a:rPr sz="2300" b="1" dirty="0" err="1">
@@ -12581,7 +12581,7 @@
                 </a:solidFill>
                 <a:latin typeface="Arial"/>
               </a:rPr>
-              <a:t>què</a:t>
+              <a:t/>
             </a:r>
             <a:r>
               <a:rPr lang="es-ES" sz="2300" b="1" dirty="0">
@@ -12590,7 +12590,7 @@
                 </a:solidFill>
                 <a:latin typeface="Arial"/>
               </a:rPr>
-              <a:t>" necesita el cas </a:t>
+              <a:t/>
             </a:r>
             <a:r>
               <a:rPr lang="es-ES" sz="2300" b="1" dirty="0" err="1">
@@ -12599,7 +12599,7 @@
                 </a:solidFill>
                 <a:latin typeface="Arial"/>
               </a:rPr>
-              <a:t>d´ús</a:t>
+              <a:t/>
             </a:r>
             <a:endParaRPr sz="2300" b="1" dirty="0">
               <a:solidFill>
@@ -12640,7 +12640,7 @@
                 </a:solidFill>
                 <a:latin typeface="Arial"/>
               </a:rPr>
-              <a:t>L'adaptador</a:t>
+              <a:t>L’adaptador resol “com”, integrant amb tecnologia específica</a:t>
             </a:r>
             <a:r>
               <a:rPr sz="2300" b="1" dirty="0">
@@ -12649,7 +12649,7 @@
                 </a:solidFill>
                 <a:latin typeface="Arial"/>
               </a:rPr>
-              <a:t> </a:t>
+              <a:t/>
             </a:r>
             <a:r>
               <a:rPr sz="2300" b="1" dirty="0" err="1">
@@ -12658,7 +12658,7 @@
                 </a:solidFill>
                 <a:latin typeface="Arial"/>
               </a:rPr>
-              <a:t>resol</a:t>
+              <a:t/>
             </a:r>
             <a:r>
               <a:rPr sz="2300" b="1" dirty="0">
@@ -12667,7 +12667,7 @@
                 </a:solidFill>
                 <a:latin typeface="Arial"/>
               </a:rPr>
-              <a:t> </a:t>
+              <a:t/>
             </a:r>
             <a:r>
               <a:rPr lang="es-ES" sz="2300" b="1" dirty="0">
@@ -12676,7 +12676,7 @@
                 </a:solidFill>
                 <a:latin typeface="Arial"/>
               </a:rPr>
-              <a:t>"</a:t>
+              <a:t/>
             </a:r>
             <a:r>
               <a:rPr sz="2300" b="1" dirty="0">
@@ -12685,7 +12685,7 @@
                 </a:solidFill>
                 <a:latin typeface="Arial"/>
               </a:rPr>
-              <a:t>com</a:t>
+              <a:t/>
             </a:r>
             <a:r>
               <a:rPr lang="es-ES" sz="2300" b="1" dirty="0">
@@ -12694,7 +12694,7 @@
                 </a:solidFill>
                 <a:latin typeface="Arial"/>
               </a:rPr>
-              <a:t>”, </a:t>
+              <a:t/>
             </a:r>
             <a:r>
               <a:rPr lang="es-ES" sz="2300" b="1" dirty="0" err="1">
@@ -12703,7 +12703,7 @@
                 </a:solidFill>
                 <a:latin typeface="Arial"/>
               </a:rPr>
-              <a:t>integrant</a:t>
+              <a:t/>
             </a:r>
             <a:r>
               <a:rPr lang="es-ES" sz="2300" b="1" dirty="0">
@@ -12712,7 +12712,7 @@
                 </a:solidFill>
                 <a:latin typeface="Arial"/>
               </a:rPr>
-              <a:t> </a:t>
+              <a:t/>
             </a:r>
             <a:r>
               <a:rPr lang="es-ES" sz="2300" b="1" dirty="0" err="1">
@@ -12721,7 +12721,7 @@
                 </a:solidFill>
                 <a:latin typeface="Arial"/>
               </a:rPr>
-              <a:t>amb</a:t>
+              <a:t/>
             </a:r>
             <a:r>
               <a:rPr lang="es-ES" sz="2300" b="1" dirty="0">
@@ -12730,7 +12730,7 @@
                 </a:solidFill>
                 <a:latin typeface="Arial"/>
               </a:rPr>
-              <a:t> tecnología específica</a:t>
+              <a:t/>
             </a:r>
             <a:endParaRPr sz="2300" b="1" dirty="0">
               <a:solidFill>
@@ -12806,7 +12806,7 @@
                 </a:solidFill>
                 <a:latin typeface="Arial"/>
               </a:rPr>
-              <a:t>7</a:t>
+              <a:t>8</a:t>
             </a:r>
           </a:p>
         </p:txBody>
@@ -12820,7 +12820,7 @@
 </file>
 
 <file path=ppt/slides/slide9.xml><?xml version="1.0" encoding="utf-8"?>
-<p:sld xmlns:a="http://schemas.openxmlformats.org/drawingml/2006/main" xmlns:r="http://schemas.openxmlformats.org/officeDocument/2006/relationships" xmlns:p="http://schemas.openxmlformats.org/presentationml/2006/main">
+<p:sld xmlns:a="http://schemas.openxmlformats.org/drawingml/2006/main" xmlns:ns3="http://schemas.microsoft.com/office/drawing/2014/main" xmlns:p="http://schemas.openxmlformats.org/presentationml/2006/main" xmlns:r="http://schemas.openxmlformats.org/officeDocument/2006/relationships">
   <p:cSld>
     <p:spTree>
       <p:nvGrpSpPr>
@@ -13213,7 +13213,7 @@
                 </a:solidFill>
                 <a:latin typeface="Arial"/>
               </a:rPr>
-              <a:t>8</a:t>
+              <a:t>9</a:t>
             </a:r>
           </a:p>
         </p:txBody>
@@ -13223,7 +13223,7 @@
           <p:cNvPr id="7" name="Imagen 6">
             <a:extLst>
               <a:ext uri="{FF2B5EF4-FFF2-40B4-BE49-F238E27FC236}">
-                <a16:creationId xmlns:a16="http://schemas.microsoft.com/office/drawing/2014/main" id="{74450190-3EBE-2ED3-C573-816824D86797}"/>
+                <ns3:creationId id="{74450190-3EBE-2ED3-C573-816824D86797}"/>
               </a:ext>
             </a:extLst>
           </p:cNvPr>

</xml_diff>

<commit_message>
docs: merge learning objective slides
</commit_message>
<xml_diff>
--- a/doc/presentations/defensa-placa-permanent-dsi-ports-sortida-hexagonal/output/IMPORTANTE_MANUAL_defensa-dsi-ports-sortida-hexagonal.pptx
+++ b/doc/presentations/defensa-placa-permanent-dsi-ports-sortida-hexagonal/output/IMPORTANTE_MANUAL_defensa-dsi-ports-sortida-hexagonal.pptx
@@ -1,6 +1,6 @@
 
 <file path=ppt/presentation.xml><?xml version="1.0" encoding="utf-8"?>
-<p:presentation xmlns:a="http://schemas.openxmlformats.org/drawingml/2006/main" xmlns:r="http://schemas.openxmlformats.org/officeDocument/2006/relationships" xmlns:p="http://schemas.openxmlformats.org/presentationml/2006/main" saveSubsetFonts="1" autoCompressPictures="0">
+<p:presentation xmlns:a="http://schemas.openxmlformats.org/drawingml/2006/main" xmlns:ns3="http://schemas.microsoft.com/office/powerpoint/2012/main" xmlns:p="http://schemas.openxmlformats.org/presentationml/2006/main" xmlns:r="http://schemas.openxmlformats.org/officeDocument/2006/relationships" saveSubsetFonts="1" autoCompressPictures="0">
   <p:sldMasterIdLst>
     <p:sldMasterId id="2147483648" r:id="rId1"/>
   </p:sldMasterIdLst>
@@ -11,7 +11,6 @@
     <p:sldId id="256" r:id="rId2"/>
     <p:sldId id="257" r:id="rId3"/>
     <p:sldId id="258" r:id="rId4"/>
-    <p:sldId id="269" r:id="rId5"/>
     <p:sldId id="259" r:id="rId6"/>
     <p:sldId id="260" r:id="rId7"/>
     <p:sldId id="261" r:id="rId8"/>
@@ -121,18 +120,18 @@
   </p:defaultTextStyle>
   <p:extLst>
     <p:ext uri="{EFAFB233-063F-42B5-8137-9DF3F51BA10A}">
-      <p15:sldGuideLst xmlns:p15="http://schemas.microsoft.com/office/powerpoint/2012/main">
-        <p15:guide id="1" orient="horz" pos="2160">
-          <p15:clr>
+      <ns3:sldGuideLst>
+        <ns3:guide id="1" orient="horz" pos="2160">
+          <ns3:clr>
             <a:srgbClr val="A4A3A4"/>
-          </p15:clr>
-        </p15:guide>
-        <p15:guide id="2" pos="2880">
-          <p15:clr>
+          </ns3:clr>
+        </ns3:guide>
+        <ns3:guide id="2" pos="2880">
+          <ns3:clr>
             <a:srgbClr val="A4A3A4"/>
-          </p15:clr>
-        </p15:guide>
-      </p15:sldGuideLst>
+          </ns3:clr>
+        </ns3:guide>
+      </ns3:sldGuideLst>
     </p:ext>
   </p:extLst>
 </p:presentation>
@@ -3602,7 +3601,7 @@
 </file>
 
 <file path=ppt/slides/slide1.xml><?xml version="1.0" encoding="utf-8"?>
-<p:sld xmlns:a="http://schemas.openxmlformats.org/drawingml/2006/main" xmlns:r="http://schemas.openxmlformats.org/officeDocument/2006/relationships" xmlns:p="http://schemas.openxmlformats.org/presentationml/2006/main">
+<p:sld xmlns:a="http://schemas.openxmlformats.org/drawingml/2006/main" xmlns:p="http://schemas.openxmlformats.org/presentationml/2006/main" xmlns:r="http://schemas.openxmlformats.org/officeDocument/2006/relationships">
   <p:cSld>
     <p:spTree>
       <p:nvGrpSpPr>
@@ -4409,7 +4408,7 @@
                 </a:solidFill>
                 <a:latin typeface="Arial"/>
               </a:rPr>
-              <a:t>10</a:t>
+              <a:t>9</a:t>
             </a:r>
           </a:p>
         </p:txBody>
@@ -4926,7 +4925,7 @@
                 </a:solidFill>
                 <a:latin typeface="Arial"/>
               </a:rPr>
-              <a:t>11</a:t>
+              <a:t>10</a:t>
             </a:r>
           </a:p>
         </p:txBody>
@@ -6086,7 +6085,7 @@
                 </a:solidFill>
                 <a:latin typeface="Arial"/>
               </a:rPr>
-              <a:t>12</a:t>
+              <a:t>11</a:t>
             </a:r>
           </a:p>
         </p:txBody>
@@ -6100,7 +6099,7 @@
 </file>
 
 <file path=ppt/slides/slide13.xml><?xml version="1.0" encoding="utf-8"?>
-<p:sld xmlns:a="http://schemas.openxmlformats.org/drawingml/2006/main" xmlns:r="http://schemas.openxmlformats.org/officeDocument/2006/relationships" xmlns:p="http://schemas.openxmlformats.org/presentationml/2006/main">
+<p:sld xmlns:a="http://schemas.openxmlformats.org/drawingml/2006/main" xmlns:p="http://schemas.openxmlformats.org/presentationml/2006/main" xmlns:r="http://schemas.openxmlformats.org/officeDocument/2006/relationships">
   <p:cSld>
     <p:spTree>
       <p:nvGrpSpPr>
@@ -7123,7 +7122,7 @@
                 </a:solidFill>
                 <a:latin typeface="Arial"/>
               </a:rPr>
-              <a:t>13</a:t>
+              <a:t>12</a:t>
             </a:r>
           </a:p>
         </p:txBody>
@@ -7137,7 +7136,7 @@
 </file>
 
 <file path=ppt/slides/slide2.xml><?xml version="1.0" encoding="utf-8"?>
-<p:sld xmlns:a="http://schemas.openxmlformats.org/drawingml/2006/main" xmlns:r="http://schemas.openxmlformats.org/officeDocument/2006/relationships" xmlns:p="http://schemas.openxmlformats.org/presentationml/2006/main">
+<p:sld xmlns:a="http://schemas.openxmlformats.org/drawingml/2006/main" xmlns:p="http://schemas.openxmlformats.org/presentationml/2006/main" xmlns:r="http://schemas.openxmlformats.org/officeDocument/2006/relationships">
   <p:cSld>
     <p:spTree>
       <p:nvGrpSpPr>
@@ -7877,11 +7876,17 @@
 </file>
 
 <file path=ppt/slides/slide3.xml><?xml version="1.0" encoding="utf-8"?>
-<p:sld xmlns:a="http://schemas.openxmlformats.org/drawingml/2006/main" xmlns:r="http://schemas.openxmlformats.org/officeDocument/2006/relationships" xmlns:p="http://schemas.openxmlformats.org/presentationml/2006/main">
+<p:sld xmlns:a="http://schemas.openxmlformats.org/drawingml/2006/main" xmlns:ns2="http://schemas.microsoft.com/office/drawing/2014/main" xmlns:ns4="http://schemas.microsoft.com/office/powerpoint/2010/main" xmlns:p="http://schemas.openxmlformats.org/presentationml/2006/main" xmlns:r="http://schemas.openxmlformats.org/officeDocument/2006/relationships">
   <p:cSld>
     <p:spTree>
       <p:nvGrpSpPr>
-        <p:cNvPr id="1" name=""/>
+        <p:cNvPr id="1" name="">
+          <a:extLst>
+            <a:ext uri="{FF2B5EF4-FFF2-40B4-BE49-F238E27FC236}">
+              <ns2:creationId id="{91787A17-E989-2125-8BF4-9FD64C66B0F7}"/>
+            </a:ext>
+          </a:extLst>
+        </p:cNvPr>
         <p:cNvGrpSpPr/>
         <p:nvPr/>
       </p:nvGrpSpPr>
@@ -7895,7 +7900,13 @@
       </p:grpSpPr>
       <p:sp>
         <p:nvSpPr>
-          <p:cNvPr id="2" name="TextBox 1"/>
+          <p:cNvPr id="2" name="TextBox 1">
+            <a:extLst>
+              <a:ext uri="{FF2B5EF4-FFF2-40B4-BE49-F238E27FC236}">
+                <ns2:creationId id="{6113BE6D-4BF0-DC81-2CE8-23039C4C9D58}"/>
+              </a:ext>
+            </a:extLst>
+          </p:cNvPr>
           <p:cNvSpPr txBox="1"/>
           <p:nvPr/>
         </p:nvSpPr>
@@ -7917,20 +7928,32 @@
           <a:p>
             <a:pPr algn="l"/>
             <a:r>
-              <a:rPr sz="2800" b="1">
-                <a:solidFill>
-                  <a:srgbClr val="192D3E"/>
-                </a:solidFill>
-                <a:latin typeface="Arial"/>
-              </a:rPr>
-              <a:t>Principi de disseny</a:t>
-            </a:r>
+              <a:rPr sz="2800" b="1" dirty="0" err="1">
+                <a:solidFill>
+                  <a:srgbClr val="192D3E"/>
+                </a:solidFill>
+                <a:latin typeface="Arial"/>
+              </a:rPr>
+              <a:t>Objectiu de la sessió</a:t>
+            </a:r>
+            <a:endParaRPr sz="2800" b="1" dirty="0">
+              <a:solidFill>
+                <a:srgbClr val="192D3E"/>
+              </a:solidFill>
+              <a:latin typeface="Arial"/>
+            </a:endParaRPr>
           </a:p>
         </p:txBody>
       </p:sp>
       <p:pic>
         <p:nvPicPr>
-          <p:cNvPr id="3" name="Picture 2" descr="logotip-oficial-tecnocampus-upf-horitzontal-color.png"/>
+          <p:cNvPr id="3" name="Picture 2" descr="logotip-oficial-tecnocampus-upf-horitzontal-color.png">
+            <a:extLst>
+              <a:ext uri="{FF2B5EF4-FFF2-40B4-BE49-F238E27FC236}">
+                <ns2:creationId id="{6E5AEF9E-E38C-2981-74C2-DA381C85519D}"/>
+              </a:ext>
+            </a:extLst>
+          </p:cNvPr>
           <p:cNvPicPr>
             <a:picLocks noChangeAspect="1"/>
           </p:cNvPicPr>
@@ -7954,7 +7977,13 @@
       </p:pic>
       <p:sp>
         <p:nvSpPr>
-          <p:cNvPr id="4" name="Rectangle 3"/>
+          <p:cNvPr id="4" name="Rectangle 3">
+            <a:extLst>
+              <a:ext uri="{FF2B5EF4-FFF2-40B4-BE49-F238E27FC236}">
+                <ns2:creationId id="{565CC16B-626E-E880-45E7-0DBECBCD6306}"/>
+              </a:ext>
+            </a:extLst>
+          </p:cNvPr>
           <p:cNvSpPr/>
           <p:nvPr/>
         </p:nvSpPr>
@@ -7998,14 +8027,20 @@
       </p:sp>
       <p:sp>
         <p:nvSpPr>
-          <p:cNvPr id="5" name="TextBox 4"/>
+          <p:cNvPr id="5" name="TextBox 4">
+            <a:extLst>
+              <a:ext uri="{FF2B5EF4-FFF2-40B4-BE49-F238E27FC236}">
+                <ns2:creationId id="{E5442AE4-020C-7BAB-E612-2262DEB4097A}"/>
+              </a:ext>
+            </a:extLst>
+          </p:cNvPr>
           <p:cNvSpPr txBox="1"/>
           <p:nvPr/>
         </p:nvSpPr>
         <p:spPr>
           <a:xfrm>
             <a:off x="960120" y="1417320"/>
-            <a:ext cx="10241280" cy="640080"/>
+            <a:ext cx="10195560" cy="886862"/>
           </a:xfrm>
           <a:prstGeom prst="rect">
             <a:avLst/>
@@ -8014,7 +8049,7 @@
         </p:spPr>
         <p:txBody>
           <a:bodyPr wrap="square">
-            <a:normAutofit fontScale="92500"/>
+            <a:normAutofit/>
           </a:bodyPr>
           <a:lstStyle/>
           <a:p>
@@ -8026,147 +8061,189 @@
                 </a:solidFill>
                 <a:latin typeface="Arial"/>
               </a:rPr>
-              <a:t>El </a:t>
-            </a:r>
-            <a:r>
-              <a:rPr sz="2700" b="1" dirty="0" err="1">
-                <a:solidFill>
-                  <a:srgbClr val="192D3E"/>
-                </a:solidFill>
-                <a:latin typeface="Arial"/>
-              </a:rPr>
-              <a:t>servei</a:t>
-            </a:r>
-            <a:r>
-              <a:rPr sz="2700" b="1" dirty="0">
-                <a:solidFill>
-                  <a:srgbClr val="192D3E"/>
-                </a:solidFill>
-                <a:latin typeface="Arial"/>
-              </a:rPr>
-              <a:t> </a:t>
-            </a:r>
-            <a:r>
-              <a:rPr sz="2700" b="1" dirty="0" err="1">
-                <a:solidFill>
-                  <a:srgbClr val="192D3E"/>
-                </a:solidFill>
-                <a:latin typeface="Arial"/>
-              </a:rPr>
-              <a:t>d'aplicació</a:t>
-            </a:r>
-            <a:r>
-              <a:rPr sz="2700" b="1" dirty="0">
-                <a:solidFill>
-                  <a:srgbClr val="192D3E"/>
-                </a:solidFill>
-                <a:latin typeface="Arial"/>
-              </a:rPr>
-              <a:t> </a:t>
-            </a:r>
-            <a:r>
-              <a:rPr sz="2700" b="1" dirty="0" err="1">
-                <a:solidFill>
-                  <a:srgbClr val="192D3E"/>
-                </a:solidFill>
-                <a:latin typeface="Arial"/>
-              </a:rPr>
-              <a:t>necessita</a:t>
-            </a:r>
-            <a:r>
-              <a:rPr sz="2700" b="1" dirty="0">
-                <a:solidFill>
-                  <a:srgbClr val="192D3E"/>
-                </a:solidFill>
-                <a:latin typeface="Arial"/>
-              </a:rPr>
-              <a:t> </a:t>
-            </a:r>
-            <a:r>
-              <a:rPr sz="2700" b="1" dirty="0" err="1">
-                <a:solidFill>
-                  <a:srgbClr val="192D3E"/>
-                </a:solidFill>
-                <a:latin typeface="Arial"/>
-              </a:rPr>
-              <a:t>una</a:t>
-            </a:r>
-            <a:r>
-              <a:rPr sz="2700" b="1" dirty="0">
-                <a:solidFill>
-                  <a:srgbClr val="192D3E"/>
-                </a:solidFill>
-                <a:latin typeface="Arial"/>
-              </a:rPr>
-              <a:t> </a:t>
-            </a:r>
-            <a:r>
-              <a:rPr sz="2700" b="1" dirty="0" err="1">
-                <a:solidFill>
-                  <a:srgbClr val="192D3E"/>
-                </a:solidFill>
-                <a:latin typeface="Arial"/>
-              </a:rPr>
-              <a:t>capacitat</a:t>
-            </a:r>
-            <a:r>
-              <a:rPr sz="2700" b="1" dirty="0">
-                <a:solidFill>
-                  <a:srgbClr val="192D3E"/>
-                </a:solidFill>
-                <a:latin typeface="Arial"/>
-              </a:rPr>
-              <a:t>, no </a:t>
-            </a:r>
-            <a:r>
-              <a:rPr sz="2700" b="1" dirty="0" err="1">
-                <a:solidFill>
-                  <a:srgbClr val="192D3E"/>
-                </a:solidFill>
-                <a:latin typeface="Arial"/>
-              </a:rPr>
-              <a:t>una</a:t>
-            </a:r>
-            <a:r>
-              <a:rPr sz="2700" b="1" dirty="0">
-                <a:solidFill>
-                  <a:srgbClr val="192D3E"/>
-                </a:solidFill>
-                <a:latin typeface="Arial"/>
-              </a:rPr>
-              <a:t> </a:t>
-            </a:r>
-            <a:r>
-              <a:rPr sz="2700" b="1" dirty="0" err="1">
-                <a:solidFill>
-                  <a:srgbClr val="192D3E"/>
-                </a:solidFill>
-                <a:latin typeface="Arial"/>
-              </a:rPr>
-              <a:t>tecnologia</a:t>
-            </a:r>
-            <a:r>
-              <a:rPr sz="2700" b="1" dirty="0">
-                <a:solidFill>
-                  <a:srgbClr val="192D3E"/>
-                </a:solidFill>
-                <a:latin typeface="Arial"/>
-              </a:rPr>
-              <a:t>.</a:t>
-            </a:r>
-          </a:p>
-        </p:txBody>
-      </p:sp>
-      <p:sp>
-        <p:nvSpPr>
-          <p:cNvPr id="12" name="TextBox 11"/>
+              <a:t>Principi de treball: el cas d’ús necessita una capacitat, no una tecnologia.
+Ho explorarem a partir d’un cas real d’administració pública.</a:t>
+            </a:r>
+          </a:p>
+        </p:txBody>
+      </p:sp>
+      <p:sp>
+        <p:nvSpPr>
+          <p:cNvPr id="6" name="Rounded Rectangle 5">
+            <a:extLst>
+              <a:ext uri="{FF2B5EF4-FFF2-40B4-BE49-F238E27FC236}">
+                <ns2:creationId id="{064EE3A6-5D0D-EFE6-3907-91BB6540F213}"/>
+              </a:ext>
+            </a:extLst>
+          </p:cNvPr>
+          <p:cNvSpPr/>
+          <p:nvPr/>
+        </p:nvSpPr>
+        <p:spPr>
+          <a:xfrm>
+            <a:off x="822960" y="2987751"/>
+            <a:ext cx="3246120" cy="1600200"/>
+          </a:xfrm>
+          <a:prstGeom prst="roundRect">
+            <a:avLst/>
+          </a:prstGeom>
+          <a:solidFill>
+            <a:srgbClr val="F8EAEA"/>
+          </a:solidFill>
+          <a:ln w="9525">
+            <a:solidFill>
+              <a:srgbClr val="DCE0E4"/>
+            </a:solidFill>
+          </a:ln>
+        </p:spPr>
+        <p:style>
+          <a:lnRef idx="1">
+            <a:schemeClr val="accent1"/>
+          </a:lnRef>
+          <a:fillRef idx="3">
+            <a:schemeClr val="accent1"/>
+          </a:fillRef>
+          <a:effectRef idx="2">
+            <a:schemeClr val="accent1"/>
+          </a:effectRef>
+          <a:fontRef idx="minor">
+            <a:schemeClr val="lt1"/>
+          </a:fontRef>
+        </p:style>
+        <p:txBody>
+          <a:bodyPr rtlCol="0" anchor="ctr"/>
+          <a:lstStyle/>
+          <a:p>
+            <a:pPr algn="ctr"/>
+            <a:endParaRPr/>
+          </a:p>
+        </p:txBody>
+      </p:sp>
+      <p:sp>
+        <p:nvSpPr>
+          <p:cNvPr id="7" name="TextBox 6">
+            <a:extLst>
+              <a:ext uri="{FF2B5EF4-FFF2-40B4-BE49-F238E27FC236}">
+                <ns2:creationId id="{C0F1223D-ADAB-E817-C2A8-78FB596BC6F8}"/>
+              </a:ext>
+            </a:extLst>
+          </p:cNvPr>
           <p:cNvSpPr txBox="1"/>
           <p:nvPr/>
         </p:nvSpPr>
         <p:spPr>
           <a:xfrm>
-            <a:off x="594360" y="6473952"/>
-            <a:ext cx="8595360" cy="201168"/>
+            <a:off x="1024127" y="3307791"/>
+            <a:ext cx="2846123" cy="977132"/>
+          </a:xfrm>
+          <a:prstGeom prst="rect">
+            <a:avLst/>
+          </a:prstGeom>
+          <a:noFill/>
+        </p:spPr>
+        <p:txBody>
+          <a:bodyPr wrap="square">
+            <a:normAutofit/>
+          </a:bodyPr>
+          <a:lstStyle/>
+          <a:p>
+            <a:pPr algn="ctr"/>
+            <a:r>
+              <a:rPr sz="2400" b="1" dirty="0" err="1">
+                <a:solidFill>
+                  <a:srgbClr val="192D3E"/>
+                </a:solidFill>
+                <a:latin typeface="Arial"/>
+              </a:rPr>
+              <a:t>Identificar
+necessitat</a:t>
+            </a:r>
+            <a:endParaRPr lang="es-ES" sz="2400" b="1" dirty="0">
+              <a:solidFill>
+                <a:srgbClr val="192D3E"/>
+              </a:solidFill>
+              <a:latin typeface="Arial"/>
+            </a:endParaRPr>
+          </a:p>
+          <a:p>
+            <a:pPr algn="ctr"/>
+            <a:endParaRPr sz="2400" b="1" dirty="0">
+              <a:solidFill>
+                <a:srgbClr val="192D3E"/>
+              </a:solidFill>
+              <a:latin typeface="Arial"/>
+            </a:endParaRPr>
+          </a:p>
+        </p:txBody>
+      </p:sp>
+      <p:sp>
+        <p:nvSpPr>
+          <p:cNvPr id="8" name="Rounded Rectangle 7">
+            <a:extLst>
+              <a:ext uri="{FF2B5EF4-FFF2-40B4-BE49-F238E27FC236}">
+                <ns2:creationId id="{460CDC97-EADA-2158-DAC3-FD27FD257839}"/>
+              </a:ext>
+            </a:extLst>
+          </p:cNvPr>
+          <p:cNvSpPr/>
+          <p:nvPr/>
+        </p:nvSpPr>
+        <p:spPr>
+          <a:xfrm>
+            <a:off x="4553712" y="2987751"/>
+            <a:ext cx="3246120" cy="1600200"/>
+          </a:xfrm>
+          <a:prstGeom prst="roundRect">
+            <a:avLst/>
+          </a:prstGeom>
+          <a:solidFill>
+            <a:srgbClr val="FFF3D6"/>
+          </a:solidFill>
+          <a:ln w="9525">
+            <a:solidFill>
+              <a:srgbClr val="DCE0E4"/>
+            </a:solidFill>
+          </a:ln>
+        </p:spPr>
+        <p:style>
+          <a:lnRef idx="1">
+            <a:schemeClr val="accent1"/>
+          </a:lnRef>
+          <a:fillRef idx="3">
+            <a:schemeClr val="accent1"/>
+          </a:fillRef>
+          <a:effectRef idx="2">
+            <a:schemeClr val="accent1"/>
+          </a:effectRef>
+          <a:fontRef idx="minor">
+            <a:schemeClr val="lt1"/>
+          </a:fontRef>
+        </p:style>
+        <p:txBody>
+          <a:bodyPr rtlCol="0" anchor="ctr"/>
+          <a:lstStyle/>
+          <a:p>
+            <a:pPr algn="ctr"/>
+            <a:endParaRPr/>
+          </a:p>
+        </p:txBody>
+      </p:sp>
+      <p:sp>
+        <p:nvSpPr>
+          <p:cNvPr id="9" name="TextBox 8">
+            <a:extLst>
+              <a:ext uri="{FF2B5EF4-FFF2-40B4-BE49-F238E27FC236}">
+                <ns2:creationId id="{57DA438C-C49C-5E46-6F61-14F3896E8657}"/>
+              </a:ext>
+            </a:extLst>
+          </p:cNvPr>
+          <p:cNvSpPr txBox="1"/>
+          <p:nvPr/>
+        </p:nvSpPr>
+        <p:spPr>
+          <a:xfrm>
+            <a:off x="4754880" y="3307791"/>
+            <a:ext cx="2834640" cy="777240"/>
           </a:xfrm>
           <a:prstGeom prst="rect">
             <a:avLst/>
@@ -8179,29 +8256,88 @@
           </a:bodyPr>
           <a:lstStyle/>
           <a:p>
-            <a:pPr algn="l"/>
-            <a:r>
-              <a:rPr sz="800" b="0">
-                <a:solidFill>
-                  <a:srgbClr val="66707A"/>
-                </a:solidFill>
-                <a:latin typeface="Arial"/>
-              </a:rPr>
-              <a:t>Disseny de Sistemes d'Informació · Ports de sortida en arquitectura hexagonal</a:t>
-            </a:r>
-          </a:p>
-        </p:txBody>
-      </p:sp>
-      <p:sp>
-        <p:nvSpPr>
-          <p:cNvPr id="13" name="TextBox 12"/>
+            <a:pPr algn="ctr"/>
+            <a:r>
+              <a:rPr sz="2400" b="1" dirty="0" err="1">
+                <a:solidFill>
+                  <a:srgbClr val="192D3E"/>
+                </a:solidFill>
+                <a:latin typeface="Arial"/>
+              </a:rPr>
+              <a:t>Definir
+port de sortida</a:t>
+            </a:r>
+          </a:p>
+        </p:txBody>
+      </p:sp>
+      <p:sp>
+        <p:nvSpPr>
+          <p:cNvPr id="10" name="Rounded Rectangle 9">
+            <a:extLst>
+              <a:ext uri="{FF2B5EF4-FFF2-40B4-BE49-F238E27FC236}">
+                <ns2:creationId id="{54F82A2A-9916-E9F8-2F4C-A47E7CF470BE}"/>
+              </a:ext>
+            </a:extLst>
+          </p:cNvPr>
+          <p:cNvSpPr/>
+          <p:nvPr/>
+        </p:nvSpPr>
+        <p:spPr>
+          <a:xfrm>
+            <a:off x="8284464" y="2987751"/>
+            <a:ext cx="3246120" cy="1600200"/>
+          </a:xfrm>
+          <a:prstGeom prst="roundRect">
+            <a:avLst/>
+          </a:prstGeom>
+          <a:solidFill>
+            <a:srgbClr val="EBF6F0"/>
+          </a:solidFill>
+          <a:ln w="9525">
+            <a:solidFill>
+              <a:srgbClr val="DCE0E4"/>
+            </a:solidFill>
+          </a:ln>
+        </p:spPr>
+        <p:style>
+          <a:lnRef idx="1">
+            <a:schemeClr val="accent1"/>
+          </a:lnRef>
+          <a:fillRef idx="3">
+            <a:schemeClr val="accent1"/>
+          </a:fillRef>
+          <a:effectRef idx="2">
+            <a:schemeClr val="accent1"/>
+          </a:effectRef>
+          <a:fontRef idx="minor">
+            <a:schemeClr val="lt1"/>
+          </a:fontRef>
+        </p:style>
+        <p:txBody>
+          <a:bodyPr rtlCol="0" anchor="ctr"/>
+          <a:lstStyle/>
+          <a:p>
+            <a:pPr algn="ctr"/>
+            <a:endParaRPr/>
+          </a:p>
+        </p:txBody>
+      </p:sp>
+      <p:sp>
+        <p:nvSpPr>
+          <p:cNvPr id="11" name="TextBox 10">
+            <a:extLst>
+              <a:ext uri="{FF2B5EF4-FFF2-40B4-BE49-F238E27FC236}">
+                <ns2:creationId id="{C6C32489-28BB-E0B4-6D88-054802179775}"/>
+              </a:ext>
+            </a:extLst>
+          </p:cNvPr>
           <p:cNvSpPr txBox="1"/>
           <p:nvPr/>
         </p:nvSpPr>
         <p:spPr>
           <a:xfrm>
-            <a:off x="11155680" y="6473952"/>
-            <a:ext cx="411480" cy="201168"/>
+            <a:off x="8485632" y="3307791"/>
+            <a:ext cx="2834640" cy="777240"/>
           </a:xfrm>
           <a:prstGeom prst="rect">
             <a:avLst/>
@@ -8214,67 +8350,114 @@
           </a:bodyPr>
           <a:lstStyle/>
           <a:p>
-            <a:pPr algn="r"/>
-            <a:r>
-              <a:rPr sz="800" b="0">
-                <a:solidFill>
-                  <a:srgbClr val="66707A"/>
-                </a:solidFill>
-                <a:latin typeface="Arial"/>
-              </a:rPr>
-              <a:t>3</a:t>
-            </a:r>
-          </a:p>
-        </p:txBody>
-      </p:sp>
-      <p:pic>
-        <p:nvPicPr>
-          <p:cNvPr id="1026" name="Picture 2">
+            <a:pPr algn="ctr"/>
+            <a:r>
+              <a:rPr lang="es-ES" sz="2400" b="1" dirty="0">
+                <a:solidFill>
+                  <a:srgbClr val="192D3E"/>
+                </a:solidFill>
+                <a:latin typeface="Arial"/>
+              </a:rPr>
+              <a:t>Implementar
+adaptadors</a:t>
+            </a:r>
+            <a:endParaRPr sz="2400" b="1" dirty="0">
+              <a:solidFill>
+                <a:srgbClr val="192D3E"/>
+              </a:solidFill>
+              <a:latin typeface="Arial"/>
+            </a:endParaRPr>
+          </a:p>
+        </p:txBody>
+      </p:sp>
+      <p:sp>
+        <p:nvSpPr>
+          <p:cNvPr id="12" name="TextBox 11">
             <a:extLst>
               <a:ext uri="{FF2B5EF4-FFF2-40B4-BE49-F238E27FC236}">
-                <a16:creationId xmlns:a16="http://schemas.microsoft.com/office/drawing/2014/main" id="{24324096-D33B-3CBF-C022-BFBBD6A631DD}"/>
+                <ns2:creationId id="{5298AC41-2EA2-3BF1-14F5-5DF9647D4D84}"/>
               </a:ext>
             </a:extLst>
           </p:cNvPr>
-          <p:cNvPicPr>
-            <a:picLocks noChangeAspect="1" noChangeArrowheads="1"/>
-          </p:cNvPicPr>
-          <p:nvPr/>
-        </p:nvPicPr>
-        <p:blipFill>
-          <a:blip r:embed="rId3">
+          <p:cNvSpPr txBox="1"/>
+          <p:nvPr/>
+        </p:nvSpPr>
+        <p:spPr>
+          <a:xfrm>
+            <a:off x="594360" y="6473952"/>
+            <a:ext cx="8595360" cy="201168"/>
+          </a:xfrm>
+          <a:prstGeom prst="rect">
+            <a:avLst/>
+          </a:prstGeom>
+          <a:noFill/>
+        </p:spPr>
+        <p:txBody>
+          <a:bodyPr wrap="square">
+            <a:normAutofit lnSpcReduction="10000"/>
+          </a:bodyPr>
+          <a:lstStyle/>
+          <a:p>
+            <a:pPr algn="l"/>
+            <a:r>
+              <a:rPr sz="800" b="0">
+                <a:solidFill>
+                  <a:srgbClr val="66707A"/>
+                </a:solidFill>
+                <a:latin typeface="Arial"/>
+              </a:rPr>
+              <a:t>Disseny de Sistemes d'Informació · Ports de sortida en arquitectura hexagonal</a:t>
+            </a:r>
+          </a:p>
+        </p:txBody>
+      </p:sp>
+      <p:sp>
+        <p:nvSpPr>
+          <p:cNvPr id="13" name="TextBox 12">
             <a:extLst>
-              <a:ext uri="{28A0092B-C50C-407E-A947-70E740481C1C}">
-                <a14:useLocalDpi xmlns:a14="http://schemas.microsoft.com/office/drawing/2010/main" val="0"/>
+              <a:ext uri="{FF2B5EF4-FFF2-40B4-BE49-F238E27FC236}">
+                <ns2:creationId id="{88D08D29-A0AD-1C10-91EF-4939D83B6478}"/>
               </a:ext>
             </a:extLst>
-          </a:blip>
-          <a:srcRect/>
-          <a:stretch>
-            <a:fillRect/>
-          </a:stretch>
-        </p:blipFill>
-        <p:spPr bwMode="auto">
-          <a:xfrm>
-            <a:off x="1759017" y="2139756"/>
-            <a:ext cx="8085221" cy="4027872"/>
+          </p:cNvPr>
+          <p:cNvSpPr txBox="1"/>
+          <p:nvPr/>
+        </p:nvSpPr>
+        <p:spPr>
+          <a:xfrm>
+            <a:off x="11155680" y="6473952"/>
+            <a:ext cx="411480" cy="201168"/>
           </a:xfrm>
           <a:prstGeom prst="rect">
             <a:avLst/>
           </a:prstGeom>
           <a:noFill/>
-          <a:extLst>
-            <a:ext uri="{909E8E84-426E-40DD-AFC4-6F175D3DCCD1}">
-              <a14:hiddenFill xmlns:a14="http://schemas.microsoft.com/office/drawing/2010/main">
-                <a:solidFill>
-                  <a:srgbClr val="FFFFFF"/>
-                </a:solidFill>
-              </a14:hiddenFill>
-            </a:ext>
-          </a:extLst>
-        </p:spPr>
-      </p:pic>
+        </p:spPr>
+        <p:txBody>
+          <a:bodyPr wrap="square">
+            <a:normAutofit lnSpcReduction="10000"/>
+          </a:bodyPr>
+          <a:lstStyle/>
+          <a:p>
+            <a:pPr algn="r"/>
+            <a:r>
+              <a:rPr sz="800" b="0">
+                <a:solidFill>
+                  <a:srgbClr val="66707A"/>
+                </a:solidFill>
+                <a:latin typeface="Arial"/>
+              </a:rPr>
+              <a:t>3</a:t>
+            </a:r>
+          </a:p>
+        </p:txBody>
+      </p:sp>
     </p:spTree>
+    <p:extLst>
+      <p:ext uri="{BB962C8B-B14F-4D97-AF65-F5344CB8AC3E}">
+        <ns4:creationId val="1026507124"/>
+      </p:ext>
+    </p:extLst>
   </p:cSld>
   <p:clrMapOvr>
     <a:masterClrMapping/>
@@ -9691,7 +9874,7 @@
                 </a:solidFill>
                 <a:latin typeface="Arial"/>
               </a:rPr>
-              <a:t>5</a:t>
+              <a:t>4</a:t>
             </a:r>
           </a:p>
         </p:txBody>
@@ -10401,7 +10584,7 @@
                 </a:solidFill>
                 <a:latin typeface="Arial"/>
               </a:rPr>
-              <a:t>6</a:t>
+              <a:t>5</a:t>
             </a:r>
           </a:p>
         </p:txBody>
@@ -11332,7 +11515,7 @@
                 </a:solidFill>
                 <a:latin typeface="Arial"/>
               </a:rPr>
-              <a:t>7</a:t>
+              <a:t>6</a:t>
             </a:r>
           </a:p>
         </p:txBody>
@@ -12806,7 +12989,7 @@
                 </a:solidFill>
                 <a:latin typeface="Arial"/>
               </a:rPr>
-              <a:t>8</a:t>
+              <a:t>7</a:t>
             </a:r>
           </a:p>
         </p:txBody>
@@ -13213,7 +13396,7 @@
                 </a:solidFill>
                 <a:latin typeface="Arial"/>
               </a:rPr>
-              <a:t>9</a:t>
+              <a:t>8</a:t>
             </a:r>
           </a:p>
         </p:txBody>

</xml_diff>

<commit_message>
docs: polish oral defense wording
</commit_message>
<xml_diff>
--- a/doc/presentations/defensa-placa-permanent-dsi-ports-sortida-hexagonal/output/IMPORTANTE_MANUAL_defensa-dsi-ports-sortida-hexagonal.pptx
+++ b/doc/presentations/defensa-placa-permanent-dsi-ports-sortida-hexagonal/output/IMPORTANTE_MANUAL_defensa-dsi-ports-sortida-hexagonal.pptx
@@ -539,7 +539,7 @@
           </a:p>
           <a:p>
             <a:r>
-              <a:t>Per a aquesta microlliçó, la idea important és funcional: el procediment necessita informació administrativa fiable; no necessita dependre d’una API concreta en el llenguatge del cas d’ús.</a:t>
+              <a:t>Per a aquesta classe, la idea important és funcional: el procediment necessita informació administrativa fiable; no necessita dependre d’una API concreta en el llenguatge del cas d’ús.</a:t>
             </a:r>
           </a:p>
         </p:txBody>
@@ -3822,7 +3822,7 @@
                 </a:solidFill>
                 <a:latin typeface="Arial"/>
               </a:rPr>
-              <a:t>microlliçó</a:t>
+              <a:t>classe</a:t>
             </a:r>
             <a:r>
               <a:rPr sz="1800" b="0" dirty="0">
@@ -7468,8 +7468,8 @@
         </p:nvSpPr>
         <p:spPr>
           <a:xfrm>
-            <a:off x="960120" y="1417320"/>
-            <a:ext cx="10195560" cy="886862"/>
+            <a:off x="960121" y="1417318"/>
+            <a:ext cx="10062106" cy="2011681"/>
           </a:xfrm>
           <a:prstGeom prst="rect">
             <a:avLst/>
@@ -7484,13 +7484,75 @@
           <a:p>
             <a:pPr algn="ctr"/>
             <a:r>
-              <a:rPr sz="2700" b="1" dirty="0">
-                <a:solidFill>
-                  <a:srgbClr val="192D3E"/>
-                </a:solidFill>
-                <a:latin typeface="Arial"/>
-              </a:rPr>
-              <a:t>Principi de treball: el cas d’ús necessita una capacitat, no una tecnologia.
+              <a:rPr sz="2400" b="1" dirty="0">
+                <a:solidFill>
+                  <a:srgbClr val="192D3E"/>
+                </a:solidFill>
+                <a:latin typeface="Arial"/>
+              </a:rPr>
+              <a:t>Principi de treball: el cas d’ús necessita una capacitat, no </a:t>
+            </a:r>
+            <a:r>
+              <a:rPr sz="2400" b="1" dirty="0" err="1">
+                <a:solidFill>
+                  <a:srgbClr val="192D3E"/>
+                </a:solidFill>
+                <a:latin typeface="Arial"/>
+              </a:rPr>
+              <a:t>una</a:t>
+            </a:r>
+            <a:r>
+              <a:rPr sz="2400" b="1" dirty="0">
+                <a:solidFill>
+                  <a:srgbClr val="192D3E"/>
+                </a:solidFill>
+                <a:latin typeface="Arial"/>
+              </a:rPr>
+              <a:t> </a:t>
+            </a:r>
+            <a:r>
+              <a:rPr sz="2400" b="1" dirty="0" err="1">
+                <a:solidFill>
+                  <a:srgbClr val="192D3E"/>
+                </a:solidFill>
+                <a:latin typeface="Arial"/>
+              </a:rPr>
+              <a:t>tecnologia</a:t>
+            </a:r>
+            <a:r>
+              <a:rPr lang="es-ES" sz="2400" b="1" dirty="0">
+                <a:solidFill>
+                  <a:srgbClr val="192D3E"/>
+                </a:solidFill>
+                <a:latin typeface="Arial"/>
+              </a:rPr>
+              <a:t> específica</a:t>
+            </a:r>
+            <a:r>
+              <a:rPr sz="2400" b="1" dirty="0">
+                <a:solidFill>
+                  <a:srgbClr val="192D3E"/>
+                </a:solidFill>
+                <a:latin typeface="Arial"/>
+              </a:rPr>
+              <a:t>.</a:t>
+            </a:r>
+            <a:br>
+              <a:rPr lang="es-ES" sz="2400" b="1" dirty="0">
+                <a:solidFill>
+                  <a:srgbClr val="192D3E"/>
+                </a:solidFill>
+                <a:latin typeface="Arial"/>
+              </a:rPr>
+            </a:br>
+            <a:r>
+              <a:rPr sz="2400" b="1" dirty="0">
+                <a:solidFill>
+                  <a:srgbClr val="192D3E"/>
+                </a:solidFill>
+                <a:latin typeface="Arial"/>
+              </a:rPr>
+              <a:t>
 Ho explorarem a partir d’un cas real d’administració pública.</a:t>
             </a:r>
           </a:p>
@@ -7510,7 +7572,7 @@
         </p:nvSpPr>
         <p:spPr>
           <a:xfrm>
-            <a:off x="822960" y="2987751"/>
+            <a:off x="813816" y="3786975"/>
             <a:ext cx="3246120" cy="1600200"/>
           </a:xfrm>
           <a:prstGeom prst="roundRect">
@@ -7562,7 +7624,7 @@
         </p:nvSpPr>
         <p:spPr>
           <a:xfrm>
-            <a:off x="1024127" y="3307791"/>
+            <a:off x="1014983" y="4107015"/>
             <a:ext cx="2846123" cy="977132"/>
           </a:xfrm>
           <a:prstGeom prst="rect">
@@ -7619,7 +7681,7 @@
         </p:nvSpPr>
         <p:spPr>
           <a:xfrm>
-            <a:off x="4553712" y="2987751"/>
+            <a:off x="4544568" y="3786975"/>
             <a:ext cx="3246120" cy="1600200"/>
           </a:xfrm>
           <a:prstGeom prst="roundRect">
@@ -7671,7 +7733,7 @@
         </p:nvSpPr>
         <p:spPr>
           <a:xfrm>
-            <a:off x="4754880" y="3307791"/>
+            <a:off x="4745736" y="4107015"/>
             <a:ext cx="2834640" cy="777240"/>
           </a:xfrm>
           <a:prstGeom prst="rect">
@@ -7713,7 +7775,7 @@
         </p:nvSpPr>
         <p:spPr>
           <a:xfrm>
-            <a:off x="8284464" y="2987751"/>
+            <a:off x="8275320" y="3786975"/>
             <a:ext cx="3246120" cy="1600200"/>
           </a:xfrm>
           <a:prstGeom prst="roundRect">
@@ -7765,7 +7827,7 @@
         </p:nvSpPr>
         <p:spPr>
           <a:xfrm>
-            <a:off x="8485632" y="3307791"/>
+            <a:off x="8476488" y="4107015"/>
             <a:ext cx="2834640" cy="777240"/>
           </a:xfrm>
           <a:prstGeom prst="rect">

</xml_diff>

<commit_message>
docs: clarify output port dependency inversion
</commit_message>
<xml_diff>
--- a/doc/presentations/defensa-placa-permanent-dsi-ports-sortida-hexagonal/output/IMPORTANTE_MANUAL_defensa-dsi-ports-sortida-hexagonal.pptx
+++ b/doc/presentations/defensa-placa-permanent-dsi-ports-sortida-hexagonal/output/IMPORTANTE_MANUAL_defensa-dsi-ports-sortida-hexagonal.pptx
@@ -10792,7 +10792,7 @@
 </file>
 
 <file path=ppt/slides/slide7.xml><?xml version="1.0" encoding="utf-8"?>
-<p:sld xmlns:a="http://schemas.openxmlformats.org/drawingml/2006/main" xmlns:r="http://schemas.openxmlformats.org/officeDocument/2006/relationships" xmlns:p="http://schemas.openxmlformats.org/presentationml/2006/main">
+<p:sld xmlns:a="http://schemas.openxmlformats.org/drawingml/2006/main" xmlns:p="http://schemas.openxmlformats.org/presentationml/2006/main" xmlns:r="http://schemas.openxmlformats.org/officeDocument/2006/relationships">
   <p:cSld>
     <p:spTree>
       <p:nvGrpSpPr>
@@ -10987,7 +10987,7 @@
                 </a:solidFill>
                 <a:latin typeface="Arial"/>
               </a:rPr>
-              <a:t>Cas d'ús</a:t>
+              <a:t>Flux d'execució</a:t>
             </a:r>
           </a:p>
         </p:txBody>
@@ -11022,7 +11022,7 @@
                 </a:solidFill>
                 <a:latin typeface="Arial"/>
               </a:rPr>
-              <a:t>↓</a:t>
+              <a:t>Cas d'ús → Port → Adaptador → Sistema extern</a:t>
             </a:r>
           </a:p>
         </p:txBody>
@@ -11103,7 +11103,7 @@
                 </a:solidFill>
                 <a:latin typeface="Arial"/>
               </a:rPr>
-              <a:t>Port de sortida</a:t>
+              <a:t/>
             </a:r>
           </a:p>
         </p:txBody>
@@ -11138,7 +11138,7 @@
                 </a:solidFill>
                 <a:latin typeface="Arial"/>
               </a:rPr>
-              <a:t>↓</a:t>
+              <a:t/>
             </a:r>
           </a:p>
         </p:txBody>
@@ -11219,7 +11219,7 @@
                 </a:solidFill>
                 <a:latin typeface="Arial"/>
               </a:rPr>
-              <a:t>Adaptador</a:t>
+              <a:t>Dependència de codi</a:t>
             </a:r>
           </a:p>
         </p:txBody>
@@ -11254,7 +11254,7 @@
                 </a:solidFill>
                 <a:latin typeface="Arial"/>
               </a:rPr>
-              <a:t>↓</a:t>
+              <a:t/>
             </a:r>
           </a:p>
         </p:txBody>
@@ -11335,7 +11335,7 @@
                 </a:solidFill>
                 <a:latin typeface="Arial"/>
               </a:rPr>
-              <a:t>Sistema extern</a:t>
+              <a:t>Cas d'ús → Port de sortida ← Adaptador</a:t>
             </a:r>
           </a:p>
         </p:txBody>
@@ -11370,7 +11370,7 @@
                 </a:solidFill>
                 <a:latin typeface="Arial"/>
               </a:rPr>
-              <a:t>El port defineix “què” necessita el cas d’ús</a:t>
+              <a:t>El port defineix què necessita el cas d’ús</a:t>
             </a:r>
           </a:p>
         </p:txBody>
@@ -11405,7 +11405,7 @@
                 </a:solidFill>
                 <a:latin typeface="Arial"/>
               </a:rPr>
-              <a:t>L’adaptador resol “com”, integrant amb tecnologia específica</a:t>
+              <a:t>La infraestructura depèn del port definit per l’aplicació</a:t>
             </a:r>
             <a:endParaRPr sz="2300" b="1" dirty="0">
               <a:solidFill>

</xml_diff>

<commit_message>
docs: separate financial transfer from HexaStock demo
</commit_message>
<xml_diff>
--- a/doc/presentations/defensa-placa-permanent-dsi-ports-sortida-hexagonal/output/IMPORTANTE_MANUAL_defensa-dsi-ports-sortida-hexagonal.pptx
+++ b/doc/presentations/defensa-placa-permanent-dsi-ports-sortida-hexagonal/output/IMPORTANTE_MANUAL_defensa-dsi-ports-sortida-hexagonal.pptx
@@ -4482,7 +4482,7 @@
 </file>
 
 <file path=ppt/slides/slide11.xml><?xml version="1.0" encoding="utf-8"?>
-<p:sld xmlns:a="http://schemas.openxmlformats.org/drawingml/2006/main" xmlns:r="http://schemas.openxmlformats.org/officeDocument/2006/relationships" xmlns:p="http://schemas.openxmlformats.org/presentationml/2006/main">
+<p:sld xmlns:a="http://schemas.openxmlformats.org/drawingml/2006/main" xmlns:p="http://schemas.openxmlformats.org/presentationml/2006/main" xmlns:r="http://schemas.openxmlformats.org/officeDocument/2006/relationships">
   <p:cSld>
     <p:spTree>
       <p:nvGrpSpPr>
@@ -4681,7 +4681,7 @@
                 </a:solidFill>
                 <a:latin typeface="Arial"/>
               </a:rPr>
-              <a:t>HexaStock</a:t>
+              <a:t>HexaStock és un projecte open source propi utilitzat en docència universitària i formació o consultoria professional.</a:t>
             </a:r>
             <a:r>
               <a:rPr sz="1800" b="0" dirty="0">
@@ -4690,7 +4690,7 @@
                 </a:solidFill>
                 <a:latin typeface="Arial"/>
               </a:rPr>
-              <a:t> </a:t>
+              <a:t/>
             </a:r>
             <a:r>
               <a:rPr sz="1800" b="0" dirty="0" err="1">
@@ -4699,7 +4699,7 @@
                 </a:solidFill>
                 <a:latin typeface="Arial"/>
               </a:rPr>
-              <a:t>és</a:t>
+              <a:t/>
             </a:r>
             <a:r>
               <a:rPr sz="1800" b="0" dirty="0">
@@ -4708,7 +4708,7 @@
                 </a:solidFill>
                 <a:latin typeface="Arial"/>
               </a:rPr>
-              <a:t> un </a:t>
+              <a:t/>
             </a:r>
             <a:r>
               <a:rPr sz="1800" b="0" dirty="0" err="1">
@@ -4717,7 +4717,7 @@
                 </a:solidFill>
                 <a:latin typeface="Arial"/>
               </a:rPr>
-              <a:t>projecte</a:t>
+              <a:t/>
             </a:r>
             <a:r>
               <a:rPr sz="1800" b="0" dirty="0">
@@ -4726,7 +4726,7 @@
                 </a:solidFill>
                 <a:latin typeface="Arial"/>
               </a:rPr>
-              <a:t> open source </a:t>
+              <a:t/>
             </a:r>
             <a:r>
               <a:rPr sz="1800" b="0" dirty="0" err="1">
@@ -4735,7 +4735,7 @@
                 </a:solidFill>
                 <a:latin typeface="Arial"/>
               </a:rPr>
-              <a:t>propi</a:t>
+              <a:t/>
             </a:r>
             <a:r>
               <a:rPr sz="1800" b="0" dirty="0">
@@ -4744,7 +4744,7 @@
                 </a:solidFill>
                 <a:latin typeface="Arial"/>
               </a:rPr>
-              <a:t> </a:t>
+              <a:t/>
             </a:r>
             <a:r>
               <a:rPr sz="1800" b="0" dirty="0" err="1">
@@ -4753,7 +4753,7 @@
                 </a:solidFill>
                 <a:latin typeface="Arial"/>
               </a:rPr>
-              <a:t>utilitzat</a:t>
+              <a:t/>
             </a:r>
             <a:r>
               <a:rPr sz="1800" b="0" dirty="0">
@@ -4762,7 +4762,7 @@
                 </a:solidFill>
                 <a:latin typeface="Arial"/>
               </a:rPr>
-              <a:t> </a:t>
+              <a:t/>
             </a:r>
             <a:r>
               <a:rPr sz="1800" b="0" dirty="0" err="1">
@@ -4771,7 +4771,7 @@
                 </a:solidFill>
                 <a:latin typeface="Arial"/>
               </a:rPr>
-              <a:t>en</a:t>
+              <a:t/>
             </a:r>
             <a:r>
               <a:rPr sz="1800" b="0" dirty="0">
@@ -4780,7 +4780,7 @@
                 </a:solidFill>
                 <a:latin typeface="Arial"/>
               </a:rPr>
-              <a:t> </a:t>
+              <a:t/>
             </a:r>
             <a:r>
               <a:rPr sz="1800" b="0" dirty="0" err="1">
@@ -4789,7 +4789,7 @@
                 </a:solidFill>
                 <a:latin typeface="Arial"/>
               </a:rPr>
-              <a:t>docència</a:t>
+              <a:t/>
             </a:r>
             <a:r>
               <a:rPr sz="1800" b="0" dirty="0">
@@ -4798,7 +4798,7 @@
                 </a:solidFill>
                 <a:latin typeface="Arial"/>
               </a:rPr>
-              <a:t> </a:t>
+              <a:t/>
             </a:r>
             <a:r>
               <a:rPr sz="1800" b="0" dirty="0" err="1">
@@ -4807,7 +4807,7 @@
                 </a:solidFill>
                 <a:latin typeface="Arial"/>
               </a:rPr>
-              <a:t>universitària</a:t>
+              <a:t/>
             </a:r>
             <a:r>
               <a:rPr sz="1800" b="0" dirty="0">
@@ -4816,7 +4816,7 @@
                 </a:solidFill>
                 <a:latin typeface="Arial"/>
               </a:rPr>
-              <a:t> </a:t>
+              <a:t/>
             </a:r>
             <a:r>
               <a:rPr sz="1800" b="0" dirty="0" err="1">
@@ -4825,7 +4825,7 @@
                 </a:solidFill>
                 <a:latin typeface="Arial"/>
               </a:rPr>
-              <a:t>i</a:t>
+              <a:t/>
             </a:r>
             <a:r>
               <a:rPr sz="1800" b="0" dirty="0">
@@ -4834,7 +4834,7 @@
                 </a:solidFill>
                 <a:latin typeface="Arial"/>
               </a:rPr>
-              <a:t> </a:t>
+              <a:t/>
             </a:r>
             <a:r>
               <a:rPr sz="1800" b="0" dirty="0" err="1">
@@ -4843,7 +4843,7 @@
                 </a:solidFill>
                 <a:latin typeface="Arial"/>
               </a:rPr>
-              <a:t>formació</a:t>
+              <a:t/>
             </a:r>
             <a:r>
               <a:rPr sz="1800" b="0" dirty="0">
@@ -4852,7 +4852,7 @@
                 </a:solidFill>
                 <a:latin typeface="Arial"/>
               </a:rPr>
-              <a:t> o </a:t>
+              <a:t/>
             </a:r>
             <a:r>
               <a:rPr sz="1800" b="0" dirty="0" err="1">
@@ -4861,7 +4861,7 @@
                 </a:solidFill>
                 <a:latin typeface="Arial"/>
               </a:rPr>
-              <a:t>consultoria</a:t>
+              <a:t/>
             </a:r>
             <a:r>
               <a:rPr sz="1800" b="0" dirty="0">
@@ -4870,7 +4870,7 @@
                 </a:solidFill>
                 <a:latin typeface="Arial"/>
               </a:rPr>
-              <a:t> </a:t>
+              <a:t/>
             </a:r>
             <a:r>
               <a:rPr lang="es-ES" dirty="0">
@@ -4879,7 +4879,7 @@
                 </a:solidFill>
                 <a:latin typeface="Arial"/>
               </a:rPr>
-              <a:t>empresarial</a:t>
+              <a:t/>
             </a:r>
             <a:r>
               <a:rPr sz="1800" b="0" dirty="0">
@@ -4888,7 +4888,7 @@
                 </a:solidFill>
                 <a:latin typeface="Arial"/>
               </a:rPr>
-              <a:t>.</a:t>
+              <a:t/>
             </a:r>
           </a:p>
         </p:txBody>
@@ -5241,7 +5241,7 @@
                 </a:solidFill>
                 <a:latin typeface="Arial"/>
               </a:rPr>
-              <a:t>Canvi tecnològic: adaptador Finnhub ↔ adaptador Alpha Vantage</a:t>
+              <a:t>Canvi: adaptador real ↔ adaptador mock</a:t>
             </a:r>
             <a:endParaRPr sz="2600" b="1" dirty="0">
               <a:solidFill>
@@ -10965,8 +10965,8 @@
         </p:nvSpPr>
         <p:spPr>
           <a:xfrm>
-            <a:off x="3977639" y="1517904"/>
-            <a:ext cx="4114800" cy="256032"/>
+            <a:off x="2743200" y="1517904"/>
+            <a:ext cx="6858000" cy="256032"/>
           </a:xfrm>
           <a:prstGeom prst="rect">
             <a:avLst/>
@@ -11022,7 +11022,7 @@
                 </a:solidFill>
                 <a:latin typeface="Arial"/>
               </a:rPr>
-              <a:t>Cas d'ús → Port → Adaptador → Sistema extern</a:t>
+              <a:t/>
             </a:r>
           </a:p>
         </p:txBody>
@@ -11081,8 +11081,8 @@
         </p:nvSpPr>
         <p:spPr>
           <a:xfrm>
-            <a:off x="3977639" y="2478024"/>
-            <a:ext cx="4114800" cy="256032"/>
+            <a:off x="2743200" y="2478024"/>
+            <a:ext cx="6858000" cy="256032"/>
           </a:xfrm>
           <a:prstGeom prst="rect">
             <a:avLst/>
@@ -11103,7 +11103,7 @@
                 </a:solidFill>
                 <a:latin typeface="Arial"/>
               </a:rPr>
-              <a:t/>
+              <a:t>Cas d'ús → Port → Adaptador → Sistema extern</a:t>
             </a:r>
           </a:p>
         </p:txBody>
@@ -11197,8 +11197,8 @@
         </p:nvSpPr>
         <p:spPr>
           <a:xfrm>
-            <a:off x="3977639" y="3438144"/>
-            <a:ext cx="4114800" cy="256032"/>
+            <a:off x="2743200" y="3438144"/>
+            <a:ext cx="6858000" cy="256032"/>
           </a:xfrm>
           <a:prstGeom prst="rect">
             <a:avLst/>
@@ -11313,8 +11313,8 @@
         </p:nvSpPr>
         <p:spPr>
           <a:xfrm>
-            <a:off x="3977639" y="4398264"/>
-            <a:ext cx="4114800" cy="256032"/>
+            <a:off x="2743200" y="4398264"/>
+            <a:ext cx="6858000" cy="256032"/>
           </a:xfrm>
           <a:prstGeom prst="rect">
             <a:avLst/>
@@ -11932,7 +11932,7 @@
 </file>
 
 <file path=ppt/slides/slide9.xml><?xml version="1.0" encoding="utf-8"?>
-<p:sld xmlns:a="http://schemas.openxmlformats.org/drawingml/2006/main" xmlns:r="http://schemas.openxmlformats.org/officeDocument/2006/relationships" xmlns:p="http://schemas.openxmlformats.org/presentationml/2006/main">
+<p:sld xmlns:a="http://schemas.openxmlformats.org/drawingml/2006/main" xmlns:p="http://schemas.openxmlformats.org/presentationml/2006/main" xmlns:r="http://schemas.openxmlformats.org/officeDocument/2006/relationships">
   <p:cSld>
     <p:spTree>
       <p:nvGrpSpPr>
@@ -12042,8 +12042,8 @@
         </p:nvSpPr>
         <p:spPr>
           <a:xfrm>
-            <a:off x="612648" y="822960"/>
-            <a:ext cx="8869680" cy="320040"/>
+            <a:off x="914400" y="1280160"/>
+            <a:ext cx="10058400" cy="3108960"/>
           </a:xfrm>
           <a:prstGeom prst="rect">
             <a:avLst/>
@@ -12064,7 +12064,10 @@
                 </a:solidFill>
                 <a:latin typeface="Arial"/>
               </a:rPr>
-              <a:t>El cas </a:t>
+              <a:t>Cas d'ús: vendre accions d'una cartera personal
+Necessitat: obtenir el preu actual de l'acció que l'usuari vol vendre
+Port de sortida: defineix aquesta capacitat
+Adaptador: resol la connexió amb el proveïdor concret</a:t>
             </a:r>
             <a:r>
               <a:rPr lang="es-ES" sz="1400" dirty="0" err="1">
@@ -12073,7 +12076,7 @@
                 </a:solidFill>
                 <a:latin typeface="Arial"/>
               </a:rPr>
-              <a:t>d'ús</a:t>
+              <a:t/>
             </a:r>
             <a:r>
               <a:rPr lang="es-ES" sz="1400" dirty="0">
@@ -12082,7 +12085,7 @@
                 </a:solidFill>
                 <a:latin typeface="Arial"/>
               </a:rPr>
-              <a:t> 'Venda </a:t>
+              <a:t/>
             </a:r>
             <a:r>
               <a:rPr lang="es-ES" sz="1400" dirty="0" err="1">
@@ -12091,7 +12094,7 @@
                 </a:solidFill>
                 <a:latin typeface="Arial"/>
               </a:rPr>
-              <a:t>d'accions</a:t>
+              <a:t/>
             </a:r>
             <a:r>
               <a:rPr lang="es-ES" sz="1400" dirty="0">
@@ -12100,7 +12103,7 @@
                 </a:solidFill>
                 <a:latin typeface="Arial"/>
               </a:rPr>
-              <a:t> </a:t>
+              <a:t/>
             </a:r>
             <a:r>
               <a:rPr lang="es-ES" sz="1400" dirty="0" err="1">
@@ -12109,7 +12112,7 @@
                 </a:solidFill>
                 <a:latin typeface="Arial"/>
               </a:rPr>
-              <a:t>borsàries</a:t>
+              <a:t/>
             </a:r>
             <a:r>
               <a:rPr lang="es-ES" sz="1400" dirty="0">
@@ -12118,7 +12121,7 @@
                 </a:solidFill>
                 <a:latin typeface="Arial"/>
               </a:rPr>
-              <a:t>' </a:t>
+              <a:t/>
             </a:r>
             <a:r>
               <a:rPr lang="es-ES" sz="1400" dirty="0" err="1">
@@ -12127,7 +12130,7 @@
                 </a:solidFill>
                 <a:latin typeface="Arial"/>
               </a:rPr>
-              <a:t>necessita</a:t>
+              <a:t/>
             </a:r>
             <a:r>
               <a:rPr lang="es-ES" sz="1400" dirty="0">
@@ -12136,7 +12139,7 @@
                 </a:solidFill>
                 <a:latin typeface="Arial"/>
               </a:rPr>
-              <a:t> el preu actual, </a:t>
+              <a:t/>
             </a:r>
             <a:r>
               <a:rPr lang="es-ES" sz="1400" dirty="0" err="1">
@@ -12145,7 +12148,7 @@
                 </a:solidFill>
                 <a:latin typeface="Arial"/>
               </a:rPr>
-              <a:t>independentment</a:t>
+              <a:t/>
             </a:r>
             <a:r>
               <a:rPr lang="es-ES" sz="1400" dirty="0">
@@ -12154,7 +12157,7 @@
                 </a:solidFill>
                 <a:latin typeface="Arial"/>
               </a:rPr>
-              <a:t> del </a:t>
+              <a:t/>
             </a:r>
             <a:r>
               <a:rPr lang="es-ES" sz="1400" dirty="0" err="1">
@@ -12163,7 +12166,7 @@
                 </a:solidFill>
                 <a:latin typeface="Arial"/>
               </a:rPr>
-              <a:t>proveïdor</a:t>
+              <a:t/>
             </a:r>
             <a:r>
               <a:rPr lang="es-ES" sz="1400" dirty="0">
@@ -12172,7 +12175,7 @@
                 </a:solidFill>
                 <a:latin typeface="Arial"/>
               </a:rPr>
-              <a:t> (API).</a:t>
+              <a:t/>
             </a:r>
             <a:endParaRPr sz="1300" dirty="0">
               <a:solidFill>
@@ -12329,8 +12332,8 @@
         </p:nvSpPr>
         <p:spPr>
           <a:xfrm>
-            <a:off x="4274820" y="6523074"/>
-            <a:ext cx="10561320" cy="201168"/>
+            <a:off x="914400" y="5349240"/>
+            <a:ext cx="10058400" cy="457200"/>
           </a:xfrm>
           <a:prstGeom prst="rect">
             <a:avLst/>
@@ -12351,7 +12354,7 @@
                 </a:solidFill>
                 <a:latin typeface="Arial"/>
               </a:rPr>
-              <a:t>Port: </a:t>
+              <a:t>El cas d'ús expressa una necessitat; no tria proveïdor, endpoint, token ni format tècnic.</a:t>
             </a:r>
             <a:r>
               <a:rPr sz="900" b="0" dirty="0" err="1">
@@ -12360,7 +12363,7 @@
                 </a:solidFill>
                 <a:latin typeface="Arial"/>
               </a:rPr>
-              <a:t>StockPriceProviderPort</a:t>
+              <a:t/>
             </a:r>
             <a:r>
               <a:rPr sz="900" b="0" dirty="0">
@@ -12369,7 +12372,7 @@
                 </a:solidFill>
                 <a:latin typeface="Arial"/>
               </a:rPr>
-              <a:t> · </a:t>
+              <a:t/>
             </a:r>
             <a:r>
               <a:rPr sz="900" b="0" dirty="0" err="1">
@@ -12378,7 +12381,7 @@
                 </a:solidFill>
                 <a:latin typeface="Arial"/>
               </a:rPr>
-              <a:t>Adaptadors</a:t>
+              <a:t/>
             </a:r>
             <a:r>
               <a:rPr sz="900" b="0" dirty="0">
@@ -12387,7 +12390,7 @@
                 </a:solidFill>
                 <a:latin typeface="Arial"/>
               </a:rPr>
-              <a:t>: </a:t>
+              <a:t/>
             </a:r>
             <a:r>
               <a:rPr sz="900" b="0" dirty="0" err="1">
@@ -12396,7 +12399,7 @@
                 </a:solidFill>
                 <a:latin typeface="Arial"/>
               </a:rPr>
-              <a:t>Finnhub</a:t>
+              <a:t/>
             </a:r>
             <a:r>
               <a:rPr sz="900" b="0" dirty="0">
@@ -12405,41 +12408,11 @@
                 </a:solidFill>
                 <a:latin typeface="Arial"/>
               </a:rPr>
-              <a:t>, Alpha Vantage, mock</a:t>
-            </a:r>
-          </a:p>
-        </p:txBody>
-      </p:sp>
-      <p:pic>
-        <p:nvPicPr>
-          <p:cNvPr id="7" name="Imagen 6">
-            <a:extLst>
-              <a:ext uri="{FF2B5EF4-FFF2-40B4-BE49-F238E27FC236}">
-                <a16:creationId xmlns:a16="http://schemas.microsoft.com/office/drawing/2014/main" id="{A6EDC6F8-5757-04F1-70A5-BEE4AFAFA363}"/>
-              </a:ext>
-            </a:extLst>
-          </p:cNvPr>
-          <p:cNvPicPr>
-            <a:picLocks noChangeAspect="1"/>
-          </p:cNvPicPr>
-          <p:nvPr/>
-        </p:nvPicPr>
-        <p:blipFill>
-          <a:blip r:embed="rId3"/>
-          <a:stretch>
-            <a:fillRect/>
-          </a:stretch>
-        </p:blipFill>
-        <p:spPr>
-          <a:xfrm>
-            <a:off x="702128" y="1101320"/>
-            <a:ext cx="10757264" cy="5348071"/>
-          </a:xfrm>
-          <a:prstGeom prst="rect">
-            <a:avLst/>
-          </a:prstGeom>
-        </p:spPr>
-      </p:pic>
+              <a:t/>
+            </a:r>
+          </a:p>
+        </p:txBody>
+      </p:sp>
     </p:spTree>
   </p:cSld>
   <p:clrMapOvr>

</xml_diff>

<commit_message>
docs: restore financial transfer diagram
</commit_message>
<xml_diff>
--- a/doc/presentations/defensa-placa-permanent-dsi-ports-sortida-hexagonal/output/IMPORTANTE_MANUAL_defensa-dsi-ports-sortida-hexagonal.pptx
+++ b/doc/presentations/defensa-placa-permanent-dsi-ports-sortida-hexagonal/output/IMPORTANTE_MANUAL_defensa-dsi-ports-sortida-hexagonal.pptx
@@ -11932,7 +11932,7 @@
 </file>
 
 <file path=ppt/slides/slide9.xml><?xml version="1.0" encoding="utf-8"?>
-<p:sld xmlns:a="http://schemas.openxmlformats.org/drawingml/2006/main" xmlns:p="http://schemas.openxmlformats.org/presentationml/2006/main" xmlns:r="http://schemas.openxmlformats.org/officeDocument/2006/relationships">
+<p:sld xmlns:a="http://schemas.openxmlformats.org/drawingml/2006/main" xmlns:r="http://schemas.openxmlformats.org/officeDocument/2006/relationships" xmlns:p="http://schemas.openxmlformats.org/presentationml/2006/main">
   <p:cSld>
     <p:spTree>
       <p:nvGrpSpPr>
@@ -12042,8 +12042,8 @@
         </p:nvSpPr>
         <p:spPr>
           <a:xfrm>
-            <a:off x="914400" y="1280160"/>
-            <a:ext cx="10058400" cy="3108960"/>
+            <a:off x="612648" y="822960"/>
+            <a:ext cx="8869680" cy="320040"/>
           </a:xfrm>
           <a:prstGeom prst="rect">
             <a:avLst/>
@@ -12064,10 +12064,7 @@
                 </a:solidFill>
                 <a:latin typeface="Arial"/>
               </a:rPr>
-              <a:t>Cas d'ús: vendre accions d'una cartera personal
-Necessitat: obtenir el preu actual de l'acció que l'usuari vol vendre
-Port de sortida: defineix aquesta capacitat
-Adaptador: resol la connexió amb el proveïdor concret</a:t>
+              <a:t>El cas </a:t>
             </a:r>
             <a:r>
               <a:rPr lang="es-ES" sz="1400" dirty="0" err="1">
@@ -12076,7 +12073,7 @@
                 </a:solidFill>
                 <a:latin typeface="Arial"/>
               </a:rPr>
-              <a:t/>
+              <a:t>d'ús</a:t>
             </a:r>
             <a:r>
               <a:rPr lang="es-ES" sz="1400" dirty="0">
@@ -12085,7 +12082,7 @@
                 </a:solidFill>
                 <a:latin typeface="Arial"/>
               </a:rPr>
-              <a:t/>
+              <a:t> 'Venda </a:t>
             </a:r>
             <a:r>
               <a:rPr lang="es-ES" sz="1400" dirty="0" err="1">
@@ -12094,7 +12091,7 @@
                 </a:solidFill>
                 <a:latin typeface="Arial"/>
               </a:rPr>
-              <a:t/>
+              <a:t>d'accions</a:t>
             </a:r>
             <a:r>
               <a:rPr lang="es-ES" sz="1400" dirty="0">
@@ -12103,7 +12100,7 @@
                 </a:solidFill>
                 <a:latin typeface="Arial"/>
               </a:rPr>
-              <a:t/>
+              <a:t> </a:t>
             </a:r>
             <a:r>
               <a:rPr lang="es-ES" sz="1400" dirty="0" err="1">
@@ -12112,7 +12109,7 @@
                 </a:solidFill>
                 <a:latin typeface="Arial"/>
               </a:rPr>
-              <a:t/>
+              <a:t>borsàries</a:t>
             </a:r>
             <a:r>
               <a:rPr lang="es-ES" sz="1400" dirty="0">
@@ -12121,7 +12118,7 @@
                 </a:solidFill>
                 <a:latin typeface="Arial"/>
               </a:rPr>
-              <a:t/>
+              <a:t>' </a:t>
             </a:r>
             <a:r>
               <a:rPr lang="es-ES" sz="1400" dirty="0" err="1">
@@ -12130,7 +12127,7 @@
                 </a:solidFill>
                 <a:latin typeface="Arial"/>
               </a:rPr>
-              <a:t/>
+              <a:t>necessita</a:t>
             </a:r>
             <a:r>
               <a:rPr lang="es-ES" sz="1400" dirty="0">
@@ -12139,7 +12136,7 @@
                 </a:solidFill>
                 <a:latin typeface="Arial"/>
               </a:rPr>
-              <a:t/>
+              <a:t> el preu actual, </a:t>
             </a:r>
             <a:r>
               <a:rPr lang="es-ES" sz="1400" dirty="0" err="1">
@@ -12148,7 +12145,7 @@
                 </a:solidFill>
                 <a:latin typeface="Arial"/>
               </a:rPr>
-              <a:t/>
+              <a:t>independentment</a:t>
             </a:r>
             <a:r>
               <a:rPr lang="es-ES" sz="1400" dirty="0">
@@ -12157,7 +12154,7 @@
                 </a:solidFill>
                 <a:latin typeface="Arial"/>
               </a:rPr>
-              <a:t/>
+              <a:t> del </a:t>
             </a:r>
             <a:r>
               <a:rPr lang="es-ES" sz="1400" dirty="0" err="1">
@@ -12166,7 +12163,7 @@
                 </a:solidFill>
                 <a:latin typeface="Arial"/>
               </a:rPr>
-              <a:t/>
+              <a:t>proveïdor</a:t>
             </a:r>
             <a:r>
               <a:rPr lang="es-ES" sz="1400" dirty="0">
@@ -12175,7 +12172,7 @@
                 </a:solidFill>
                 <a:latin typeface="Arial"/>
               </a:rPr>
-              <a:t/>
+              <a:t> (API).</a:t>
             </a:r>
             <a:endParaRPr sz="1300" dirty="0">
               <a:solidFill>
@@ -12332,8 +12329,8 @@
         </p:nvSpPr>
         <p:spPr>
           <a:xfrm>
-            <a:off x="914400" y="5349240"/>
-            <a:ext cx="10058400" cy="457200"/>
+            <a:off x="4274820" y="6523074"/>
+            <a:ext cx="10561320" cy="201168"/>
           </a:xfrm>
           <a:prstGeom prst="rect">
             <a:avLst/>
@@ -12354,7 +12351,7 @@
                 </a:solidFill>
                 <a:latin typeface="Arial"/>
               </a:rPr>
-              <a:t>El cas d'ús expressa una necessitat; no tria proveïdor, endpoint, token ni format tècnic.</a:t>
+              <a:t>Port: </a:t>
             </a:r>
             <a:r>
               <a:rPr sz="900" b="0" dirty="0" err="1">
@@ -12363,7 +12360,7 @@
                 </a:solidFill>
                 <a:latin typeface="Arial"/>
               </a:rPr>
-              <a:t/>
+              <a:t>StockPriceProviderPort</a:t>
             </a:r>
             <a:r>
               <a:rPr sz="900" b="0" dirty="0">
@@ -12372,7 +12369,7 @@
                 </a:solidFill>
                 <a:latin typeface="Arial"/>
               </a:rPr>
-              <a:t/>
+              <a:t> · </a:t>
             </a:r>
             <a:r>
               <a:rPr sz="900" b="0" dirty="0" err="1">
@@ -12381,7 +12378,7 @@
                 </a:solidFill>
                 <a:latin typeface="Arial"/>
               </a:rPr>
-              <a:t/>
+              <a:t>Adaptadors</a:t>
             </a:r>
             <a:r>
               <a:rPr sz="900" b="0" dirty="0">
@@ -12390,7 +12387,7 @@
                 </a:solidFill>
                 <a:latin typeface="Arial"/>
               </a:rPr>
-              <a:t/>
+              <a:t>: </a:t>
             </a:r>
             <a:r>
               <a:rPr sz="900" b="0" dirty="0" err="1">
@@ -12399,7 +12396,7 @@
                 </a:solidFill>
                 <a:latin typeface="Arial"/>
               </a:rPr>
-              <a:t/>
+              <a:t>Finnhub</a:t>
             </a:r>
             <a:r>
               <a:rPr sz="900" b="0" dirty="0">
@@ -12408,11 +12405,41 @@
                 </a:solidFill>
                 <a:latin typeface="Arial"/>
               </a:rPr>
-              <a:t/>
-            </a:r>
-          </a:p>
-        </p:txBody>
-      </p:sp>
+              <a:t>, Alpha Vantage, mock</a:t>
+            </a:r>
+          </a:p>
+        </p:txBody>
+      </p:sp>
+      <p:pic>
+        <p:nvPicPr>
+          <p:cNvPr id="7" name="Imagen 6">
+            <a:extLst>
+              <a:ext uri="{FF2B5EF4-FFF2-40B4-BE49-F238E27FC236}">
+                <a16:creationId xmlns:a16="http://schemas.microsoft.com/office/drawing/2014/main" id="{A6EDC6F8-5757-04F1-70A5-BEE4AFAFA363}"/>
+              </a:ext>
+            </a:extLst>
+          </p:cNvPr>
+          <p:cNvPicPr>
+            <a:picLocks noChangeAspect="1"/>
+          </p:cNvPicPr>
+          <p:nvPr/>
+        </p:nvPicPr>
+        <p:blipFill>
+          <a:blip r:embed="rId3"/>
+          <a:stretch>
+            <a:fillRect/>
+          </a:stretch>
+        </p:blipFill>
+        <p:spPr>
+          <a:xfrm>
+            <a:off x="702128" y="1101320"/>
+            <a:ext cx="10757264" cy="5348071"/>
+          </a:xfrm>
+          <a:prstGeom prst="rect">
+            <a:avLst/>
+          </a:prstGeom>
+        </p:spPr>
+      </p:pic>
     </p:spTree>
   </p:cSld>
   <p:clrMapOvr>

</xml_diff>

<commit_message>
docs: restore concrete demo adapter wording
</commit_message>
<xml_diff>
--- a/doc/presentations/defensa-placa-permanent-dsi-ports-sortida-hexagonal/output/IMPORTANTE_MANUAL_defensa-dsi-ports-sortida-hexagonal.pptx
+++ b/doc/presentations/defensa-placa-permanent-dsi-ports-sortida-hexagonal/output/IMPORTANTE_MANUAL_defensa-dsi-ports-sortida-hexagonal.pptx
@@ -219,7 +219,7 @@
           <a:p>
             <a:fld id="{0ABAC575-8351-9441-AF95-237B22BB45B7}" type="datetimeFigureOut">
               <a:rPr lang="es-ES" smtClean="0"/>
-              <a:t>1/7/26</a:t>
+              <a:t>3/7/26</a:t>
             </a:fld>
             <a:endParaRPr lang="es-ES"/>
           </a:p>
@@ -829,7 +829,7 @@
           <a:p>
             <a:fld id="{5BCAD085-E8A6-8845-BD4E-CB4CCA059FC4}" type="datetimeFigureOut">
               <a:rPr lang="en-US" smtClean="0"/>
-              <a:t>7/1/26</a:t>
+              <a:t>7/3/26</a:t>
             </a:fld>
             <a:endParaRPr lang="en-US"/>
           </a:p>
@@ -997,7 +997,7 @@
           <a:p>
             <a:fld id="{5BCAD085-E8A6-8845-BD4E-CB4CCA059FC4}" type="datetimeFigureOut">
               <a:rPr lang="en-US" smtClean="0"/>
-              <a:t>7/1/26</a:t>
+              <a:t>7/3/26</a:t>
             </a:fld>
             <a:endParaRPr lang="en-US"/>
           </a:p>
@@ -1175,7 +1175,7 @@
           <a:p>
             <a:fld id="{5BCAD085-E8A6-8845-BD4E-CB4CCA059FC4}" type="datetimeFigureOut">
               <a:rPr lang="en-US" smtClean="0"/>
-              <a:t>7/1/26</a:t>
+              <a:t>7/3/26</a:t>
             </a:fld>
             <a:endParaRPr lang="en-US"/>
           </a:p>
@@ -1343,7 +1343,7 @@
           <a:p>
             <a:fld id="{5BCAD085-E8A6-8845-BD4E-CB4CCA059FC4}" type="datetimeFigureOut">
               <a:rPr lang="en-US" smtClean="0"/>
-              <a:t>7/1/26</a:t>
+              <a:t>7/3/26</a:t>
             </a:fld>
             <a:endParaRPr lang="en-US"/>
           </a:p>
@@ -1588,7 +1588,7 @@
           <a:p>
             <a:fld id="{5BCAD085-E8A6-8845-BD4E-CB4CCA059FC4}" type="datetimeFigureOut">
               <a:rPr lang="en-US" smtClean="0"/>
-              <a:t>7/1/26</a:t>
+              <a:t>7/3/26</a:t>
             </a:fld>
             <a:endParaRPr lang="en-US"/>
           </a:p>
@@ -1873,7 +1873,7 @@
           <a:p>
             <a:fld id="{5BCAD085-E8A6-8845-BD4E-CB4CCA059FC4}" type="datetimeFigureOut">
               <a:rPr lang="en-US" smtClean="0"/>
-              <a:t>7/1/26</a:t>
+              <a:t>7/3/26</a:t>
             </a:fld>
             <a:endParaRPr lang="en-US"/>
           </a:p>
@@ -2292,7 +2292,7 @@
           <a:p>
             <a:fld id="{5BCAD085-E8A6-8845-BD4E-CB4CCA059FC4}" type="datetimeFigureOut">
               <a:rPr lang="en-US" smtClean="0"/>
-              <a:t>7/1/26</a:t>
+              <a:t>7/3/26</a:t>
             </a:fld>
             <a:endParaRPr lang="en-US"/>
           </a:p>
@@ -2409,7 +2409,7 @@
           <a:p>
             <a:fld id="{5BCAD085-E8A6-8845-BD4E-CB4CCA059FC4}" type="datetimeFigureOut">
               <a:rPr lang="en-US" smtClean="0"/>
-              <a:t>7/1/26</a:t>
+              <a:t>7/3/26</a:t>
             </a:fld>
             <a:endParaRPr lang="en-US"/>
           </a:p>
@@ -2504,7 +2504,7 @@
           <a:p>
             <a:fld id="{5BCAD085-E8A6-8845-BD4E-CB4CCA059FC4}" type="datetimeFigureOut">
               <a:rPr lang="en-US" smtClean="0"/>
-              <a:t>7/1/26</a:t>
+              <a:t>7/3/26</a:t>
             </a:fld>
             <a:endParaRPr lang="en-US"/>
           </a:p>
@@ -2779,7 +2779,7 @@
           <a:p>
             <a:fld id="{5BCAD085-E8A6-8845-BD4E-CB4CCA059FC4}" type="datetimeFigureOut">
               <a:rPr lang="en-US" smtClean="0"/>
-              <a:t>7/1/26</a:t>
+              <a:t>7/3/26</a:t>
             </a:fld>
             <a:endParaRPr lang="en-US"/>
           </a:p>
@@ -3031,7 +3031,7 @@
           <a:p>
             <a:fld id="{5BCAD085-E8A6-8845-BD4E-CB4CCA059FC4}" type="datetimeFigureOut">
               <a:rPr lang="en-US" smtClean="0"/>
-              <a:t>7/1/26</a:t>
+              <a:t>7/3/26</a:t>
             </a:fld>
             <a:endParaRPr lang="en-US"/>
           </a:p>
@@ -3242,7 +3242,7 @@
           <a:p>
             <a:fld id="{5BCAD085-E8A6-8845-BD4E-CB4CCA059FC4}" type="datetimeFigureOut">
               <a:rPr lang="en-US" smtClean="0"/>
-              <a:t>7/1/26</a:t>
+              <a:t>7/3/26</a:t>
             </a:fld>
             <a:endParaRPr lang="en-US"/>
           </a:p>
@@ -4482,7 +4482,7 @@
 </file>
 
 <file path=ppt/slides/slide11.xml><?xml version="1.0" encoding="utf-8"?>
-<p:sld xmlns:a="http://schemas.openxmlformats.org/drawingml/2006/main" xmlns:p="http://schemas.openxmlformats.org/presentationml/2006/main" xmlns:r="http://schemas.openxmlformats.org/officeDocument/2006/relationships">
+<p:sld xmlns:a="http://schemas.openxmlformats.org/drawingml/2006/main" xmlns:r="http://schemas.openxmlformats.org/officeDocument/2006/relationships" xmlns:p="http://schemas.openxmlformats.org/presentationml/2006/main">
   <p:cSld>
     <p:spTree>
       <p:nvGrpSpPr>
@@ -4683,213 +4683,6 @@
               </a:rPr>
               <a:t>HexaStock és un projecte open source propi utilitzat en docència universitària i formació o consultoria professional.</a:t>
             </a:r>
-            <a:r>
-              <a:rPr sz="1800" b="0" dirty="0">
-                <a:solidFill>
-                  <a:srgbClr val="192D3E"/>
-                </a:solidFill>
-                <a:latin typeface="Arial"/>
-              </a:rPr>
-              <a:t/>
-            </a:r>
-            <a:r>
-              <a:rPr sz="1800" b="0" dirty="0" err="1">
-                <a:solidFill>
-                  <a:srgbClr val="192D3E"/>
-                </a:solidFill>
-                <a:latin typeface="Arial"/>
-              </a:rPr>
-              <a:t/>
-            </a:r>
-            <a:r>
-              <a:rPr sz="1800" b="0" dirty="0">
-                <a:solidFill>
-                  <a:srgbClr val="192D3E"/>
-                </a:solidFill>
-                <a:latin typeface="Arial"/>
-              </a:rPr>
-              <a:t/>
-            </a:r>
-            <a:r>
-              <a:rPr sz="1800" b="0" dirty="0" err="1">
-                <a:solidFill>
-                  <a:srgbClr val="192D3E"/>
-                </a:solidFill>
-                <a:latin typeface="Arial"/>
-              </a:rPr>
-              <a:t/>
-            </a:r>
-            <a:r>
-              <a:rPr sz="1800" b="0" dirty="0">
-                <a:solidFill>
-                  <a:srgbClr val="192D3E"/>
-                </a:solidFill>
-                <a:latin typeface="Arial"/>
-              </a:rPr>
-              <a:t/>
-            </a:r>
-            <a:r>
-              <a:rPr sz="1800" b="0" dirty="0" err="1">
-                <a:solidFill>
-                  <a:srgbClr val="192D3E"/>
-                </a:solidFill>
-                <a:latin typeface="Arial"/>
-              </a:rPr>
-              <a:t/>
-            </a:r>
-            <a:r>
-              <a:rPr sz="1800" b="0" dirty="0">
-                <a:solidFill>
-                  <a:srgbClr val="192D3E"/>
-                </a:solidFill>
-                <a:latin typeface="Arial"/>
-              </a:rPr>
-              <a:t/>
-            </a:r>
-            <a:r>
-              <a:rPr sz="1800" b="0" dirty="0" err="1">
-                <a:solidFill>
-                  <a:srgbClr val="192D3E"/>
-                </a:solidFill>
-                <a:latin typeface="Arial"/>
-              </a:rPr>
-              <a:t/>
-            </a:r>
-            <a:r>
-              <a:rPr sz="1800" b="0" dirty="0">
-                <a:solidFill>
-                  <a:srgbClr val="192D3E"/>
-                </a:solidFill>
-                <a:latin typeface="Arial"/>
-              </a:rPr>
-              <a:t/>
-            </a:r>
-            <a:r>
-              <a:rPr sz="1800" b="0" dirty="0" err="1">
-                <a:solidFill>
-                  <a:srgbClr val="192D3E"/>
-                </a:solidFill>
-                <a:latin typeface="Arial"/>
-              </a:rPr>
-              <a:t/>
-            </a:r>
-            <a:r>
-              <a:rPr sz="1800" b="0" dirty="0">
-                <a:solidFill>
-                  <a:srgbClr val="192D3E"/>
-                </a:solidFill>
-                <a:latin typeface="Arial"/>
-              </a:rPr>
-              <a:t/>
-            </a:r>
-            <a:r>
-              <a:rPr sz="1800" b="0" dirty="0" err="1">
-                <a:solidFill>
-                  <a:srgbClr val="192D3E"/>
-                </a:solidFill>
-                <a:latin typeface="Arial"/>
-              </a:rPr>
-              <a:t/>
-            </a:r>
-            <a:r>
-              <a:rPr sz="1800" b="0" dirty="0">
-                <a:solidFill>
-                  <a:srgbClr val="192D3E"/>
-                </a:solidFill>
-                <a:latin typeface="Arial"/>
-              </a:rPr>
-              <a:t/>
-            </a:r>
-            <a:r>
-              <a:rPr sz="1800" b="0" dirty="0" err="1">
-                <a:solidFill>
-                  <a:srgbClr val="192D3E"/>
-                </a:solidFill>
-                <a:latin typeface="Arial"/>
-              </a:rPr>
-              <a:t/>
-            </a:r>
-            <a:r>
-              <a:rPr sz="1800" b="0" dirty="0">
-                <a:solidFill>
-                  <a:srgbClr val="192D3E"/>
-                </a:solidFill>
-                <a:latin typeface="Arial"/>
-              </a:rPr>
-              <a:t/>
-            </a:r>
-            <a:r>
-              <a:rPr sz="1800" b="0" dirty="0" err="1">
-                <a:solidFill>
-                  <a:srgbClr val="192D3E"/>
-                </a:solidFill>
-                <a:latin typeface="Arial"/>
-              </a:rPr>
-              <a:t/>
-            </a:r>
-            <a:r>
-              <a:rPr sz="1800" b="0" dirty="0">
-                <a:solidFill>
-                  <a:srgbClr val="192D3E"/>
-                </a:solidFill>
-                <a:latin typeface="Arial"/>
-              </a:rPr>
-              <a:t/>
-            </a:r>
-            <a:r>
-              <a:rPr sz="1800" b="0" dirty="0" err="1">
-                <a:solidFill>
-                  <a:srgbClr val="192D3E"/>
-                </a:solidFill>
-                <a:latin typeface="Arial"/>
-              </a:rPr>
-              <a:t/>
-            </a:r>
-            <a:r>
-              <a:rPr sz="1800" b="0" dirty="0">
-                <a:solidFill>
-                  <a:srgbClr val="192D3E"/>
-                </a:solidFill>
-                <a:latin typeface="Arial"/>
-              </a:rPr>
-              <a:t/>
-            </a:r>
-            <a:r>
-              <a:rPr sz="1800" b="0" dirty="0" err="1">
-                <a:solidFill>
-                  <a:srgbClr val="192D3E"/>
-                </a:solidFill>
-                <a:latin typeface="Arial"/>
-              </a:rPr>
-              <a:t/>
-            </a:r>
-            <a:r>
-              <a:rPr sz="1800" b="0" dirty="0">
-                <a:solidFill>
-                  <a:srgbClr val="192D3E"/>
-                </a:solidFill>
-                <a:latin typeface="Arial"/>
-              </a:rPr>
-              <a:t/>
-            </a:r>
-            <a:r>
-              <a:rPr lang="es-ES" dirty="0">
-                <a:solidFill>
-                  <a:srgbClr val="192D3E"/>
-                </a:solidFill>
-                <a:latin typeface="Arial"/>
-              </a:rPr>
-              <a:t/>
-            </a:r>
-            <a:r>
-              <a:rPr sz="1800" b="0" dirty="0">
-                <a:solidFill>
-                  <a:srgbClr val="192D3E"/>
-                </a:solidFill>
-                <a:latin typeface="Arial"/>
-              </a:rPr>
-              <a:t/>
-            </a:r>
           </a:p>
         </p:txBody>
       </p:sp>
@@ -5104,14 +4897,50 @@
               <a:t> </a:t>
             </a:r>
             <a:r>
+              <a:rPr lang="es-ES" sz="1900" b="1" dirty="0">
+                <a:solidFill>
+                  <a:srgbClr val="192D3E"/>
+                </a:solidFill>
+                <a:latin typeface="Arial"/>
+              </a:rPr>
+              <a:t>S</a:t>
+            </a:r>
+            <a:r>
               <a:rPr sz="1900" b="1" dirty="0" err="1">
                 <a:solidFill>
                   <a:srgbClr val="192D3E"/>
                 </a:solidFill>
                 <a:latin typeface="Arial"/>
               </a:rPr>
-              <a:t>servei</a:t>
-            </a:r>
+              <a:t>ervei</a:t>
+            </a:r>
+            <a:r>
+              <a:rPr lang="es-ES" sz="1900" b="1" dirty="0">
+                <a:solidFill>
+                  <a:srgbClr val="192D3E"/>
+                </a:solidFill>
+                <a:latin typeface="Arial"/>
+              </a:rPr>
+              <a:t> </a:t>
+            </a:r>
+            <a:r>
+              <a:rPr lang="es-ES" sz="1900" b="1" dirty="0" err="1">
+                <a:solidFill>
+                  <a:srgbClr val="192D3E"/>
+                </a:solidFill>
+                <a:latin typeface="Arial"/>
+              </a:rPr>
+              <a:t>d’Aplicació</a:t>
+            </a:r>
+            <a:endParaRPr lang="es-ES" sz="1900" b="1" dirty="0">
+              <a:solidFill>
+                <a:srgbClr val="192D3E"/>
+              </a:solidFill>
+              <a:latin typeface="Arial"/>
+            </a:endParaRPr>
+          </a:p>
+          <a:p>
+            <a:pPr algn="ctr"/>
             <a:endParaRPr sz="1900" b="1" dirty="0">
               <a:solidFill>
                 <a:srgbClr val="192D3E"/>
@@ -5235,13 +5064,67 @@
           <a:p>
             <a:pPr algn="ctr"/>
             <a:r>
-              <a:rPr sz="2600" b="1" dirty="0" err="1">
+              <a:rPr lang="es-ES" sz="2600" b="1" dirty="0" err="1">
                 <a:solidFill>
                   <a:srgbClr val="236092"/>
                 </a:solidFill>
                 <a:latin typeface="Arial"/>
               </a:rPr>
-              <a:t>Canvi: adaptador real ↔ adaptador mock</a:t>
+              <a:t>Canvi</a:t>
+            </a:r>
+            <a:r>
+              <a:rPr lang="es-ES" sz="2600" b="1" dirty="0">
+                <a:solidFill>
+                  <a:srgbClr val="236092"/>
+                </a:solidFill>
+                <a:latin typeface="Arial"/>
+              </a:rPr>
+              <a:t> </a:t>
+            </a:r>
+            <a:r>
+              <a:rPr lang="es-ES" sz="2600" b="1" dirty="0" err="1">
+                <a:solidFill>
+                  <a:srgbClr val="236092"/>
+                </a:solidFill>
+                <a:latin typeface="Arial"/>
+              </a:rPr>
+              <a:t>tecnològic</a:t>
+            </a:r>
+            <a:r>
+              <a:rPr lang="es-ES" sz="2600" b="1" dirty="0">
+                <a:solidFill>
+                  <a:srgbClr val="236092"/>
+                </a:solidFill>
+                <a:latin typeface="Arial"/>
+              </a:rPr>
+              <a:t>: adaptador </a:t>
+            </a:r>
+            <a:r>
+              <a:rPr lang="es-ES" sz="2600" b="1" dirty="0" err="1">
+                <a:solidFill>
+                  <a:srgbClr val="236092"/>
+                </a:solidFill>
+                <a:latin typeface="Arial"/>
+              </a:rPr>
+              <a:t>Finnhub</a:t>
+            </a:r>
+            <a:r>
+              <a:rPr lang="es-ES" sz="2600" b="1" dirty="0">
+                <a:solidFill>
+                  <a:srgbClr val="236092"/>
+                </a:solidFill>
+                <a:latin typeface="Arial"/>
+              </a:rPr>
+              <a:t> ↔ adaptador Alpha </a:t>
+            </a:r>
+            <a:r>
+              <a:rPr lang="es-ES" sz="2600" b="1" dirty="0" err="1">
+                <a:solidFill>
+                  <a:srgbClr val="236092"/>
+                </a:solidFill>
+                <a:latin typeface="Arial"/>
+              </a:rPr>
+              <a:t>Vantage</a:t>
             </a:r>
             <a:endParaRPr sz="2600" b="1" dirty="0">
               <a:solidFill>
@@ -10792,7 +10675,7 @@
 </file>
 
 <file path=ppt/slides/slide7.xml><?xml version="1.0" encoding="utf-8"?>
-<p:sld xmlns:a="http://schemas.openxmlformats.org/drawingml/2006/main" xmlns:p="http://schemas.openxmlformats.org/presentationml/2006/main" xmlns:r="http://schemas.openxmlformats.org/officeDocument/2006/relationships">
+<p:sld xmlns:a="http://schemas.openxmlformats.org/drawingml/2006/main" xmlns:r="http://schemas.openxmlformats.org/officeDocument/2006/relationships" xmlns:p="http://schemas.openxmlformats.org/presentationml/2006/main">
   <p:cSld>
     <p:spTree>
       <p:nvGrpSpPr>
@@ -11015,15 +10898,7 @@
           <a:lstStyle/>
           <a:p>
             <a:pPr algn="ctr"/>
-            <a:r>
-              <a:rPr sz="2200" b="1">
-                <a:solidFill>
-                  <a:srgbClr val="236092"/>
-                </a:solidFill>
-                <a:latin typeface="Arial"/>
-              </a:rPr>
-              <a:t/>
-            </a:r>
+            <a:endParaRPr/>
           </a:p>
         </p:txBody>
       </p:sp>
@@ -11131,15 +11006,7 @@
           <a:lstStyle/>
           <a:p>
             <a:pPr algn="ctr"/>
-            <a:r>
-              <a:rPr sz="2200" b="1">
-                <a:solidFill>
-                  <a:srgbClr val="236092"/>
-                </a:solidFill>
-                <a:latin typeface="Arial"/>
-              </a:rPr>
-              <a:t/>
-            </a:r>
+            <a:endParaRPr/>
           </a:p>
         </p:txBody>
       </p:sp>
@@ -11247,15 +11114,7 @@
           <a:lstStyle/>
           <a:p>
             <a:pPr algn="ctr"/>
-            <a:r>
-              <a:rPr sz="2200" b="1">
-                <a:solidFill>
-                  <a:srgbClr val="236092"/>
-                </a:solidFill>
-                <a:latin typeface="Arial"/>
-              </a:rPr>
-              <a:t/>
-            </a:r>
+            <a:endParaRPr/>
           </a:p>
         </p:txBody>
       </p:sp>

</xml_diff>

<commit_message>
docs: update oral presentation materials to clarify demo as optional
</commit_message>
<xml_diff>
--- a/doc/presentations/defensa-placa-permanent-dsi-ports-sortida-hexagonal/output/IMPORTANTE_MANUAL_defensa-dsi-ports-sortida-hexagonal.pptx
+++ b/doc/presentations/defensa-placa-permanent-dsi-ports-sortida-hexagonal/output/IMPORTANTE_MANUAL_defensa-dsi-ports-sortida-hexagonal.pptx
@@ -18,8 +18,8 @@
     <p:sldId id="263" r:id="rId9"/>
     <p:sldId id="264" r:id="rId10"/>
     <p:sldId id="265" r:id="rId11"/>
-    <p:sldId id="266" r:id="rId12"/>
-    <p:sldId id="268" r:id="rId13"/>
+    <p:sldId id="268" r:id="rId12"/>
+    <p:sldId id="266" r:id="rId13"/>
   </p:sldIdLst>
   <p:sldSz cx="12192000" cy="6858000"/>
   <p:notesSz cx="6858000" cy="9144000"/>
@@ -4522,70 +4522,20 @@
           <a:p>
             <a:pPr algn="l"/>
             <a:r>
-              <a:rPr sz="2800" b="1" dirty="0">
-                <a:solidFill>
-                  <a:srgbClr val="192D3E"/>
-                </a:solidFill>
-                <a:latin typeface="Arial"/>
-              </a:rPr>
-              <a:t>Dem</a:t>
-            </a:r>
-            <a:r>
-              <a:rPr lang="es-ES" sz="2800" b="1" dirty="0">
-                <a:solidFill>
-                  <a:srgbClr val="192D3E"/>
-                </a:solidFill>
-                <a:latin typeface="Arial"/>
-              </a:rPr>
-              <a:t>o (Opcional)</a:t>
-            </a:r>
-            <a:endParaRPr sz="2800" b="1" dirty="0">
-              <a:solidFill>
-                <a:srgbClr val="192D3E"/>
-              </a:solidFill>
-              <a:latin typeface="Arial"/>
-            </a:endParaRPr>
-          </a:p>
-        </p:txBody>
-      </p:sp>
-      <p:sp>
-        <p:nvSpPr>
-          <p:cNvPr id="3" name="TextBox 2"/>
-          <p:cNvSpPr txBox="1"/>
-          <p:nvPr/>
-        </p:nvSpPr>
-        <p:spPr>
-          <a:xfrm>
-            <a:off x="612648" y="822960"/>
-            <a:ext cx="8869680" cy="320040"/>
-          </a:xfrm>
-          <a:prstGeom prst="rect">
-            <a:avLst/>
-          </a:prstGeom>
-          <a:noFill/>
-        </p:spPr>
-        <p:txBody>
-          <a:bodyPr wrap="square">
-            <a:normAutofit/>
-          </a:bodyPr>
-          <a:lstStyle/>
-          <a:p>
-            <a:pPr algn="l"/>
-            <a:r>
-              <a:rPr sz="1300" b="0">
-                <a:solidFill>
-                  <a:srgbClr val="66707A"/>
-                </a:solidFill>
-                <a:latin typeface="Arial"/>
-              </a:rPr>
-              <a:t>Mateix cas d'ús, adaptador substituïble</a:t>
+              <a:rPr sz="2800" b="1">
+                <a:solidFill>
+                  <a:srgbClr val="192D3E"/>
+                </a:solidFill>
+                <a:latin typeface="Arial"/>
+              </a:rPr>
+              <a:t>Agraïment</a:t>
             </a:r>
           </a:p>
         </p:txBody>
       </p:sp>
       <p:pic>
         <p:nvPicPr>
-          <p:cNvPr id="4" name="Picture 3" descr="logotip-oficial-tecnocampus-upf-horitzontal-color.png"/>
+          <p:cNvPr id="3" name="Picture 2" descr="logotip-oficial-tecnocampus-upf-horitzontal-color.png"/>
           <p:cNvPicPr>
             <a:picLocks noChangeAspect="1"/>
           </p:cNvPicPr>
@@ -4609,7 +4559,7 @@
       </p:pic>
       <p:sp>
         <p:nvSpPr>
-          <p:cNvPr id="5" name="Rectangle 4"/>
+          <p:cNvPr id="4" name="Rectangle 3"/>
           <p:cNvSpPr/>
           <p:nvPr/>
         </p:nvSpPr>
@@ -4653,14 +4603,14 @@
       </p:sp>
       <p:sp>
         <p:nvSpPr>
-          <p:cNvPr id="6" name="TextBox 5"/>
+          <p:cNvPr id="5" name="TextBox 4"/>
           <p:cNvSpPr txBox="1"/>
           <p:nvPr/>
         </p:nvSpPr>
         <p:spPr>
           <a:xfrm>
-            <a:off x="914400" y="1325880"/>
-            <a:ext cx="10287000" cy="502920"/>
+            <a:off x="1178973" y="1874094"/>
+            <a:ext cx="9834053" cy="1780528"/>
           </a:xfrm>
           <a:prstGeom prst="rect">
             <a:avLst/>
@@ -4669,20 +4619,485 @@
         </p:spPr>
         <p:txBody>
           <a:bodyPr wrap="square">
-            <a:normAutofit fontScale="85000" lnSpcReduction="10000"/>
+            <a:normAutofit/>
           </a:bodyPr>
           <a:lstStyle/>
           <a:p>
             <a:pPr algn="ctr"/>
             <a:r>
-              <a:rPr sz="1800" b="0" dirty="0" err="1">
-                <a:solidFill>
-                  <a:srgbClr val="192D3E"/>
-                </a:solidFill>
-                <a:latin typeface="Arial"/>
-              </a:rPr>
-              <a:t>HexaStock és un projecte open source propi utilitzat en docència universitària i formació o consultoria professional.</a:t>
-            </a:r>
+              <a:rPr lang="es-ES" sz="2400" b="0" dirty="0" err="1">
+                <a:solidFill>
+                  <a:srgbClr val="192D3E"/>
+                </a:solidFill>
+                <a:latin typeface="Arial"/>
+              </a:rPr>
+              <a:t>Vull</a:t>
+            </a:r>
+            <a:r>
+              <a:rPr lang="es-ES" sz="2400" b="0" dirty="0">
+                <a:solidFill>
+                  <a:srgbClr val="192D3E"/>
+                </a:solidFill>
+                <a:latin typeface="Arial"/>
+              </a:rPr>
+              <a:t> </a:t>
+            </a:r>
+            <a:r>
+              <a:rPr lang="es-ES" sz="2400" b="0" dirty="0" err="1">
+                <a:solidFill>
+                  <a:srgbClr val="192D3E"/>
+                </a:solidFill>
+                <a:latin typeface="Arial"/>
+              </a:rPr>
+              <a:t>expressar</a:t>
+            </a:r>
+            <a:r>
+              <a:rPr lang="es-ES" sz="2400" b="0" dirty="0">
+                <a:solidFill>
+                  <a:srgbClr val="192D3E"/>
+                </a:solidFill>
+                <a:latin typeface="Arial"/>
+              </a:rPr>
+              <a:t> el </a:t>
+            </a:r>
+            <a:r>
+              <a:rPr lang="es-ES" sz="2400" b="0" dirty="0" err="1">
+                <a:solidFill>
+                  <a:srgbClr val="192D3E"/>
+                </a:solidFill>
+                <a:latin typeface="Arial"/>
+              </a:rPr>
+              <a:t>meu</a:t>
+            </a:r>
+            <a:r>
+              <a:rPr lang="es-ES" sz="2400" b="0" dirty="0">
+                <a:solidFill>
+                  <a:srgbClr val="192D3E"/>
+                </a:solidFill>
+                <a:latin typeface="Arial"/>
+              </a:rPr>
+              <a:t> </a:t>
+            </a:r>
+            <a:r>
+              <a:rPr lang="es-ES" sz="2400" b="0" dirty="0" err="1">
+                <a:solidFill>
+                  <a:srgbClr val="192D3E"/>
+                </a:solidFill>
+                <a:latin typeface="Arial"/>
+              </a:rPr>
+              <a:t>agraïment</a:t>
+            </a:r>
+            <a:r>
+              <a:rPr lang="es-ES" sz="2400" b="0" dirty="0">
+                <a:solidFill>
+                  <a:srgbClr val="192D3E"/>
+                </a:solidFill>
+                <a:latin typeface="Arial"/>
+              </a:rPr>
+              <a:t> al </a:t>
+            </a:r>
+            <a:r>
+              <a:rPr lang="es-ES" sz="2400" b="0" dirty="0" err="1">
+                <a:solidFill>
+                  <a:srgbClr val="192D3E"/>
+                </a:solidFill>
+                <a:latin typeface="Arial"/>
+              </a:rPr>
+              <a:t>TecnoCampus</a:t>
+            </a:r>
+            <a:r>
+              <a:rPr lang="es-ES" sz="2400" b="0" dirty="0">
+                <a:solidFill>
+                  <a:srgbClr val="192D3E"/>
+                </a:solidFill>
+                <a:latin typeface="Arial"/>
+              </a:rPr>
+              <a:t> per un </a:t>
+            </a:r>
+            <a:r>
+              <a:rPr lang="es-ES" sz="2400" b="0" dirty="0" err="1">
+                <a:solidFill>
+                  <a:srgbClr val="192D3E"/>
+                </a:solidFill>
+                <a:latin typeface="Arial"/>
+              </a:rPr>
+              <a:t>entorn</a:t>
+            </a:r>
+            <a:r>
+              <a:rPr lang="es-ES" sz="2400" b="0" dirty="0">
+                <a:solidFill>
+                  <a:srgbClr val="192D3E"/>
+                </a:solidFill>
+                <a:latin typeface="Arial"/>
+              </a:rPr>
+              <a:t> que </a:t>
+            </a:r>
+            <a:r>
+              <a:rPr lang="es-ES" sz="2400" b="0" dirty="0" err="1">
+                <a:solidFill>
+                  <a:srgbClr val="192D3E"/>
+                </a:solidFill>
+                <a:latin typeface="Arial"/>
+              </a:rPr>
+              <a:t>m’encoratja</a:t>
+            </a:r>
+            <a:r>
+              <a:rPr lang="es-ES" sz="2400" b="0" dirty="0">
+                <a:solidFill>
+                  <a:srgbClr val="192D3E"/>
+                </a:solidFill>
+                <a:latin typeface="Arial"/>
+              </a:rPr>
+              <a:t> a </a:t>
+            </a:r>
+            <a:r>
+              <a:rPr lang="es-ES" sz="2400" b="0" dirty="0" err="1">
+                <a:solidFill>
+                  <a:srgbClr val="192D3E"/>
+                </a:solidFill>
+                <a:latin typeface="Arial"/>
+              </a:rPr>
+              <a:t>créixer</a:t>
+            </a:r>
+            <a:r>
+              <a:rPr lang="es-ES" sz="2400" b="0" dirty="0">
+                <a:solidFill>
+                  <a:srgbClr val="192D3E"/>
+                </a:solidFill>
+                <a:latin typeface="Arial"/>
+              </a:rPr>
+              <a:t>, </a:t>
+            </a:r>
+            <a:r>
+              <a:rPr lang="es-ES" sz="2400" b="0" dirty="0" err="1">
+                <a:solidFill>
+                  <a:srgbClr val="192D3E"/>
+                </a:solidFill>
+                <a:latin typeface="Arial"/>
+              </a:rPr>
+              <a:t>tant</a:t>
+            </a:r>
+            <a:r>
+              <a:rPr lang="es-ES" sz="2400" b="0" dirty="0">
+                <a:solidFill>
+                  <a:srgbClr val="192D3E"/>
+                </a:solidFill>
+                <a:latin typeface="Arial"/>
+              </a:rPr>
+              <a:t> en la </a:t>
+            </a:r>
+            <a:r>
+              <a:rPr lang="es-ES" sz="2400" b="0" dirty="0" err="1">
+                <a:solidFill>
+                  <a:srgbClr val="192D3E"/>
+                </a:solidFill>
+                <a:latin typeface="Arial"/>
+              </a:rPr>
+              <a:t>docència</a:t>
+            </a:r>
+            <a:r>
+              <a:rPr lang="es-ES" sz="2400" b="0" dirty="0">
+                <a:solidFill>
+                  <a:srgbClr val="192D3E"/>
+                </a:solidFill>
+                <a:latin typeface="Arial"/>
+              </a:rPr>
+              <a:t> </a:t>
+            </a:r>
+            <a:r>
+              <a:rPr lang="es-ES" sz="2400" b="0" dirty="0" err="1">
+                <a:solidFill>
+                  <a:srgbClr val="192D3E"/>
+                </a:solidFill>
+                <a:latin typeface="Arial"/>
+              </a:rPr>
+              <a:t>com</a:t>
+            </a:r>
+            <a:r>
+              <a:rPr lang="es-ES" sz="2400" b="0" dirty="0">
+                <a:solidFill>
+                  <a:srgbClr val="192D3E"/>
+                </a:solidFill>
+                <a:latin typeface="Arial"/>
+              </a:rPr>
+              <a:t> en </a:t>
+            </a:r>
+            <a:r>
+              <a:rPr lang="es-ES" sz="2400" b="0" dirty="0" err="1">
+                <a:solidFill>
+                  <a:srgbClr val="192D3E"/>
+                </a:solidFill>
+                <a:latin typeface="Arial"/>
+              </a:rPr>
+              <a:t>l’àmbit</a:t>
+            </a:r>
+            <a:r>
+              <a:rPr lang="es-ES" sz="2400" b="0" dirty="0">
+                <a:solidFill>
+                  <a:srgbClr val="192D3E"/>
+                </a:solidFill>
+                <a:latin typeface="Arial"/>
+              </a:rPr>
+              <a:t> </a:t>
+            </a:r>
+            <a:r>
+              <a:rPr lang="es-ES" sz="2400" b="0" dirty="0" err="1">
+                <a:solidFill>
+                  <a:srgbClr val="192D3E"/>
+                </a:solidFill>
+                <a:latin typeface="Arial"/>
+              </a:rPr>
+              <a:t>acadèmic</a:t>
+            </a:r>
+            <a:r>
+              <a:rPr lang="es-ES" sz="2400" b="0" dirty="0">
+                <a:solidFill>
+                  <a:srgbClr val="192D3E"/>
+                </a:solidFill>
+                <a:latin typeface="Arial"/>
+              </a:rPr>
+              <a:t>, al </a:t>
+            </a:r>
+            <a:r>
+              <a:rPr lang="es-ES" sz="2400" b="0" dirty="0" err="1">
+                <a:solidFill>
+                  <a:srgbClr val="192D3E"/>
+                </a:solidFill>
+                <a:latin typeface="Arial"/>
+              </a:rPr>
+              <a:t>costat</a:t>
+            </a:r>
+            <a:r>
+              <a:rPr lang="es-ES" sz="2400" b="0" dirty="0">
+                <a:solidFill>
+                  <a:srgbClr val="192D3E"/>
+                </a:solidFill>
+                <a:latin typeface="Arial"/>
+              </a:rPr>
+              <a:t> </a:t>
+            </a:r>
+            <a:r>
+              <a:rPr lang="es-ES" sz="2400" b="0" dirty="0" err="1">
+                <a:solidFill>
+                  <a:srgbClr val="192D3E"/>
+                </a:solidFill>
+                <a:latin typeface="Arial"/>
+              </a:rPr>
+              <a:t>d’un</a:t>
+            </a:r>
+            <a:r>
+              <a:rPr lang="es-ES" sz="2400" b="0" dirty="0">
+                <a:solidFill>
+                  <a:srgbClr val="192D3E"/>
+                </a:solidFill>
+                <a:latin typeface="Arial"/>
+              </a:rPr>
+              <a:t> </a:t>
+            </a:r>
+            <a:r>
+              <a:rPr lang="es-ES" sz="2400" b="0" dirty="0" err="1">
+                <a:solidFill>
+                  <a:srgbClr val="192D3E"/>
+                </a:solidFill>
+                <a:latin typeface="Arial"/>
+              </a:rPr>
+              <a:t>equip</a:t>
+            </a:r>
+            <a:r>
+              <a:rPr lang="es-ES" sz="2400" b="0" dirty="0">
+                <a:solidFill>
+                  <a:srgbClr val="192D3E"/>
+                </a:solidFill>
+                <a:latin typeface="Arial"/>
+              </a:rPr>
+              <a:t> del </a:t>
+            </a:r>
+            <a:r>
+              <a:rPr lang="es-ES" sz="2400" b="0" dirty="0" err="1">
+                <a:solidFill>
+                  <a:srgbClr val="192D3E"/>
+                </a:solidFill>
+                <a:latin typeface="Arial"/>
+              </a:rPr>
+              <a:t>qual</a:t>
+            </a:r>
+            <a:r>
+              <a:rPr lang="es-ES" sz="2400" b="0" dirty="0">
+                <a:solidFill>
+                  <a:srgbClr val="192D3E"/>
+                </a:solidFill>
+                <a:latin typeface="Arial"/>
+              </a:rPr>
+              <a:t> </a:t>
+            </a:r>
+            <a:r>
+              <a:rPr lang="es-ES" sz="2400" b="0" dirty="0" err="1">
+                <a:solidFill>
+                  <a:srgbClr val="192D3E"/>
+                </a:solidFill>
+                <a:latin typeface="Arial"/>
+              </a:rPr>
+              <a:t>aprenc</a:t>
+            </a:r>
+            <a:r>
+              <a:rPr lang="es-ES" sz="2400" b="0" dirty="0">
+                <a:solidFill>
+                  <a:srgbClr val="192D3E"/>
+                </a:solidFill>
+                <a:latin typeface="Arial"/>
+              </a:rPr>
+              <a:t> i </a:t>
+            </a:r>
+            <a:r>
+              <a:rPr lang="es-ES" sz="2400" b="0" dirty="0" err="1">
+                <a:solidFill>
+                  <a:srgbClr val="192D3E"/>
+                </a:solidFill>
+                <a:latin typeface="Arial"/>
+              </a:rPr>
+              <a:t>amb</a:t>
+            </a:r>
+            <a:r>
+              <a:rPr lang="es-ES" sz="2400" b="0" dirty="0">
+                <a:solidFill>
+                  <a:srgbClr val="192D3E"/>
+                </a:solidFill>
+                <a:latin typeface="Arial"/>
+              </a:rPr>
+              <a:t> qui </a:t>
+            </a:r>
+            <a:r>
+              <a:rPr lang="es-ES" sz="2400" b="0" dirty="0" err="1">
+                <a:solidFill>
+                  <a:srgbClr val="192D3E"/>
+                </a:solidFill>
+                <a:latin typeface="Arial"/>
+              </a:rPr>
+              <a:t>comparteixo</a:t>
+            </a:r>
+            <a:r>
+              <a:rPr lang="es-ES" sz="2400" b="0" dirty="0">
+                <a:solidFill>
+                  <a:srgbClr val="192D3E"/>
+                </a:solidFill>
+                <a:latin typeface="Arial"/>
+              </a:rPr>
+              <a:t> </a:t>
+            </a:r>
+            <a:r>
+              <a:rPr lang="es-ES" sz="2400" b="0" dirty="0" err="1">
+                <a:solidFill>
+                  <a:srgbClr val="192D3E"/>
+                </a:solidFill>
+                <a:latin typeface="Arial"/>
+              </a:rPr>
+              <a:t>coneixement</a:t>
+            </a:r>
+            <a:r>
+              <a:rPr lang="es-ES" sz="2400" b="0" dirty="0">
+                <a:solidFill>
+                  <a:srgbClr val="192D3E"/>
+                </a:solidFill>
+                <a:latin typeface="Arial"/>
+              </a:rPr>
+              <a:t>, </a:t>
+            </a:r>
+            <a:r>
+              <a:rPr lang="es-ES" sz="2400" b="0" dirty="0" err="1">
+                <a:solidFill>
+                  <a:srgbClr val="192D3E"/>
+                </a:solidFill>
+                <a:latin typeface="Arial"/>
+              </a:rPr>
+              <a:t>responsabilitat</a:t>
+            </a:r>
+            <a:r>
+              <a:rPr lang="es-ES" sz="2400" b="0" dirty="0">
+                <a:solidFill>
+                  <a:srgbClr val="192D3E"/>
+                </a:solidFill>
+                <a:latin typeface="Arial"/>
+              </a:rPr>
+              <a:t> i </a:t>
+            </a:r>
+            <a:r>
+              <a:rPr lang="es-ES" sz="2400" b="0" dirty="0" err="1">
+                <a:solidFill>
+                  <a:srgbClr val="192D3E"/>
+                </a:solidFill>
+                <a:latin typeface="Arial"/>
+              </a:rPr>
+              <a:t>compromís</a:t>
+            </a:r>
+            <a:r>
+              <a:rPr lang="es-ES" sz="2400" b="0" dirty="0">
+                <a:solidFill>
+                  <a:srgbClr val="192D3E"/>
+                </a:solidFill>
+                <a:latin typeface="Arial"/>
+              </a:rPr>
+              <a:t> </a:t>
+            </a:r>
+            <a:r>
+              <a:rPr lang="es-ES" sz="2400" b="0" dirty="0" err="1">
+                <a:solidFill>
+                  <a:srgbClr val="192D3E"/>
+                </a:solidFill>
+                <a:latin typeface="Arial"/>
+              </a:rPr>
+              <a:t>amb</a:t>
+            </a:r>
+            <a:r>
+              <a:rPr lang="es-ES" sz="2400" b="0" dirty="0">
+                <a:solidFill>
+                  <a:srgbClr val="192D3E"/>
+                </a:solidFill>
+                <a:latin typeface="Arial"/>
+              </a:rPr>
+              <a:t> la </a:t>
+            </a:r>
+            <a:r>
+              <a:rPr lang="es-ES" sz="2400" b="0" dirty="0" err="1">
+                <a:solidFill>
+                  <a:srgbClr val="192D3E"/>
+                </a:solidFill>
+                <a:latin typeface="Arial"/>
+              </a:rPr>
+              <a:t>formació</a:t>
+            </a:r>
+            <a:r>
+              <a:rPr lang="es-ES" sz="2400" b="0" dirty="0">
+                <a:solidFill>
+                  <a:srgbClr val="192D3E"/>
+                </a:solidFill>
+                <a:latin typeface="Arial"/>
+              </a:rPr>
+              <a:t> </a:t>
+            </a:r>
+            <a:r>
+              <a:rPr lang="es-ES" sz="2400" b="0" dirty="0" err="1">
+                <a:solidFill>
+                  <a:srgbClr val="192D3E"/>
+                </a:solidFill>
+                <a:latin typeface="Arial"/>
+              </a:rPr>
+              <a:t>universitària</a:t>
+            </a:r>
+            <a:r>
+              <a:rPr lang="es-ES" sz="2400" b="0" dirty="0">
+                <a:solidFill>
+                  <a:srgbClr val="192D3E"/>
+                </a:solidFill>
+                <a:latin typeface="Arial"/>
+              </a:rPr>
+              <a:t>.</a:t>
+            </a:r>
+            <a:endParaRPr sz="2400" b="0" dirty="0">
+              <a:solidFill>
+                <a:srgbClr val="192D3E"/>
+              </a:solidFill>
+              <a:latin typeface="Arial"/>
+            </a:endParaRPr>
           </a:p>
         </p:txBody>
       </p:sp>
@@ -4694,14 +5109,14 @@
         </p:nvSpPr>
         <p:spPr>
           <a:xfrm>
-            <a:off x="868680" y="2240280"/>
-            <a:ext cx="3246120" cy="960120"/>
+            <a:off x="1885683" y="4295446"/>
+            <a:ext cx="8595360" cy="1217428"/>
           </a:xfrm>
           <a:prstGeom prst="roundRect">
             <a:avLst/>
           </a:prstGeom>
           <a:solidFill>
-            <a:srgbClr val="E8F1F8"/>
+            <a:srgbClr val="F7F8FA"/>
           </a:solidFill>
           <a:ln w="9525">
             <a:solidFill>
@@ -4740,8 +5155,8 @@
         </p:nvSpPr>
         <p:spPr>
           <a:xfrm>
-            <a:off x="1051560" y="2542032"/>
-            <a:ext cx="2880360" cy="256032"/>
+            <a:off x="2046235" y="4399432"/>
+            <a:ext cx="8099528" cy="868681"/>
           </a:xfrm>
           <a:prstGeom prst="rect">
             <a:avLst/>
@@ -4750,22 +5165,94 @@
         </p:spPr>
         <p:txBody>
           <a:bodyPr wrap="square">
-            <a:normAutofit fontScale="70000" lnSpcReduction="20000"/>
+            <a:normAutofit/>
           </a:bodyPr>
           <a:lstStyle/>
           <a:p>
             <a:pPr algn="ctr"/>
             <a:r>
-              <a:rPr sz="1900" b="1" dirty="0" err="1">
-                <a:solidFill>
-                  <a:srgbClr val="192D3E"/>
-                </a:solidFill>
-                <a:latin typeface="Arial"/>
-              </a:rPr>
-              <a:t>Mateix</a:t>
-            </a:r>
-            <a:r>
-              <a:rPr sz="1900" b="1" dirty="0">
+              <a:rPr sz="1600" b="0" dirty="0" err="1">
+                <a:solidFill>
+                  <a:srgbClr val="192D3E"/>
+                </a:solidFill>
+                <a:latin typeface="Arial"/>
+              </a:rPr>
+              <a:t>Agraïment</a:t>
+            </a:r>
+            <a:r>
+              <a:rPr sz="1600" b="0" dirty="0">
+                <a:solidFill>
+                  <a:srgbClr val="192D3E"/>
+                </a:solidFill>
+                <a:latin typeface="Arial"/>
+              </a:rPr>
+              <a:t> especial al Dr. Josep </a:t>
+            </a:r>
+            <a:r>
+              <a:rPr sz="1600" b="0" dirty="0" err="1">
+                <a:solidFill>
+                  <a:srgbClr val="192D3E"/>
+                </a:solidFill>
+                <a:latin typeface="Arial"/>
+              </a:rPr>
+              <a:t>Roure</a:t>
+            </a:r>
+            <a:r>
+              <a:rPr sz="1600" b="0" dirty="0">
+                <a:solidFill>
+                  <a:srgbClr val="192D3E"/>
+                </a:solidFill>
+                <a:latin typeface="Arial"/>
+              </a:rPr>
+              <a:t>, company professor del </a:t>
+            </a:r>
+            <a:r>
+              <a:rPr sz="1600" b="0" dirty="0" err="1">
+                <a:solidFill>
+                  <a:srgbClr val="192D3E"/>
+                </a:solidFill>
+                <a:latin typeface="Arial"/>
+              </a:rPr>
+              <a:t>TecnoCampus</a:t>
+            </a:r>
+            <a:r>
+              <a:rPr sz="1600" b="0" dirty="0">
+                <a:solidFill>
+                  <a:srgbClr val="192D3E"/>
+                </a:solidFill>
+                <a:latin typeface="Arial"/>
+              </a:rPr>
+              <a:t>, </a:t>
+            </a:r>
+            <a:r>
+              <a:rPr sz="1600" b="0" dirty="0" err="1">
+                <a:solidFill>
+                  <a:srgbClr val="192D3E"/>
+                </a:solidFill>
+                <a:latin typeface="Arial"/>
+              </a:rPr>
+              <a:t>amb</a:t>
+            </a:r>
+            <a:r>
+              <a:rPr sz="1600" b="0" dirty="0">
+                <a:solidFill>
+                  <a:srgbClr val="192D3E"/>
+                </a:solidFill>
+                <a:latin typeface="Arial"/>
+              </a:rPr>
+              <a:t> qui he </a:t>
+            </a:r>
+            <a:r>
+              <a:rPr sz="1600" b="0" dirty="0" err="1">
+                <a:solidFill>
+                  <a:srgbClr val="192D3E"/>
+                </a:solidFill>
+                <a:latin typeface="Arial"/>
+              </a:rPr>
+              <a:t>tingut</a:t>
+            </a:r>
+            <a:r>
+              <a:rPr sz="1600" b="0" dirty="0">
                 <a:solidFill>
                   <a:srgbClr val="192D3E"/>
                 </a:solidFill>
@@ -4774,16 +5261,16 @@
               <a:t> </a:t>
             </a:r>
             <a:r>
-              <a:rPr sz="1900" b="1" dirty="0" err="1">
-                <a:solidFill>
-                  <a:srgbClr val="192D3E"/>
-                </a:solidFill>
-                <a:latin typeface="Arial"/>
-              </a:rPr>
-              <a:t>cas</a:t>
-            </a:r>
-            <a:r>
-              <a:rPr sz="1900" b="1" dirty="0">
+              <a:rPr sz="1600" b="0" dirty="0" err="1">
+                <a:solidFill>
+                  <a:srgbClr val="192D3E"/>
+                </a:solidFill>
+                <a:latin typeface="Arial"/>
+              </a:rPr>
+              <a:t>l'oportunitat</a:t>
+            </a:r>
+            <a:r>
+              <a:rPr sz="1600" b="0" dirty="0">
                 <a:solidFill>
                   <a:srgbClr val="192D3E"/>
                 </a:solidFill>
@@ -4792,15 +5279,159 @@
               <a:t> </a:t>
             </a:r>
             <a:r>
-              <a:rPr sz="1900" b="1" dirty="0" err="1">
-                <a:solidFill>
-                  <a:srgbClr val="192D3E"/>
-                </a:solidFill>
-                <a:latin typeface="Arial"/>
-              </a:rPr>
-              <a:t>d'ús</a:t>
-            </a:r>
-            <a:endParaRPr sz="1900" b="1" dirty="0">
+              <a:rPr sz="1600" b="0" dirty="0" err="1">
+                <a:solidFill>
+                  <a:srgbClr val="192D3E"/>
+                </a:solidFill>
+                <a:latin typeface="Arial"/>
+              </a:rPr>
+              <a:t>d'aprendre</a:t>
+            </a:r>
+            <a:r>
+              <a:rPr sz="1600" b="0" dirty="0">
+                <a:solidFill>
+                  <a:srgbClr val="192D3E"/>
+                </a:solidFill>
+                <a:latin typeface="Arial"/>
+              </a:rPr>
+              <a:t> </a:t>
+            </a:r>
+            <a:r>
+              <a:rPr sz="1600" b="0" dirty="0" err="1">
+                <a:solidFill>
+                  <a:srgbClr val="192D3E"/>
+                </a:solidFill>
+                <a:latin typeface="Arial"/>
+              </a:rPr>
+              <a:t>sobre</a:t>
+            </a:r>
+            <a:r>
+              <a:rPr sz="1600" b="0" dirty="0">
+                <a:solidFill>
+                  <a:srgbClr val="192D3E"/>
+                </a:solidFill>
+                <a:latin typeface="Arial"/>
+              </a:rPr>
+              <a:t> </a:t>
+            </a:r>
+            <a:r>
+              <a:rPr sz="1600" b="0" dirty="0" err="1">
+                <a:solidFill>
+                  <a:srgbClr val="192D3E"/>
+                </a:solidFill>
+                <a:latin typeface="Arial"/>
+              </a:rPr>
+              <a:t>arquitectura</a:t>
+            </a:r>
+            <a:r>
+              <a:rPr sz="1600" b="0" dirty="0">
+                <a:solidFill>
+                  <a:srgbClr val="192D3E"/>
+                </a:solidFill>
+                <a:latin typeface="Arial"/>
+              </a:rPr>
+              <a:t> </a:t>
+            </a:r>
+            <a:r>
+              <a:rPr lang="es-ES" sz="1600" dirty="0">
+                <a:solidFill>
+                  <a:srgbClr val="192D3E"/>
+                </a:solidFill>
+                <a:latin typeface="Arial"/>
+              </a:rPr>
+              <a:t>de </a:t>
+            </a:r>
+            <a:r>
+              <a:rPr sz="1600" b="0" dirty="0">
+                <a:solidFill>
+                  <a:srgbClr val="192D3E"/>
+                </a:solidFill>
+                <a:latin typeface="Arial"/>
+              </a:rPr>
+              <a:t>software</a:t>
+            </a:r>
+            <a:r>
+              <a:rPr lang="es-ES" sz="1600" dirty="0">
+                <a:solidFill>
+                  <a:srgbClr val="192D3E"/>
+                </a:solidFill>
+                <a:latin typeface="Arial"/>
+              </a:rPr>
+              <a:t>, </a:t>
+            </a:r>
+            <a:r>
+              <a:rPr lang="es-ES" sz="1600" b="0" dirty="0" err="1">
+                <a:solidFill>
+                  <a:srgbClr val="192D3E"/>
+                </a:solidFill>
+                <a:latin typeface="Arial"/>
+              </a:rPr>
+              <a:t>metodologies</a:t>
+            </a:r>
+            <a:r>
+              <a:rPr lang="es-ES" sz="1600" b="0" dirty="0">
+                <a:solidFill>
+                  <a:srgbClr val="192D3E"/>
+                </a:solidFill>
+                <a:latin typeface="Arial"/>
+              </a:rPr>
+              <a:t> actives </a:t>
+            </a:r>
+            <a:r>
+              <a:rPr lang="es-ES" sz="1600" b="0" dirty="0" err="1">
+                <a:solidFill>
+                  <a:srgbClr val="192D3E"/>
+                </a:solidFill>
+                <a:latin typeface="Arial"/>
+              </a:rPr>
+              <a:t>d'aprenentatge</a:t>
+            </a:r>
+            <a:r>
+              <a:rPr lang="es-ES" sz="1600" dirty="0">
+                <a:solidFill>
+                  <a:srgbClr val="192D3E"/>
+                </a:solidFill>
+                <a:latin typeface="Arial"/>
+              </a:rPr>
+              <a:t> i </a:t>
+            </a:r>
+            <a:r>
+              <a:rPr lang="es-ES" sz="1600" dirty="0" err="1">
+                <a:solidFill>
+                  <a:srgbClr val="192D3E"/>
+                </a:solidFill>
+                <a:latin typeface="Arial"/>
+              </a:rPr>
+              <a:t>treball</a:t>
+            </a:r>
+            <a:r>
+              <a:rPr lang="es-ES" sz="1600" dirty="0">
+                <a:solidFill>
+                  <a:srgbClr val="192D3E"/>
+                </a:solidFill>
+                <a:latin typeface="Arial"/>
+              </a:rPr>
+              <a:t> en </a:t>
+            </a:r>
+            <a:r>
+              <a:rPr lang="es-ES" sz="1600" dirty="0" err="1">
+                <a:solidFill>
+                  <a:srgbClr val="192D3E"/>
+                </a:solidFill>
+                <a:latin typeface="Arial"/>
+              </a:rPr>
+              <a:t>equip</a:t>
+            </a:r>
+            <a:r>
+              <a:rPr lang="es-ES" sz="1600" dirty="0">
+                <a:solidFill>
+                  <a:srgbClr val="192D3E"/>
+                </a:solidFill>
+                <a:latin typeface="Arial"/>
+              </a:rPr>
+              <a:t>.</a:t>
+            </a:r>
+            <a:endParaRPr sz="1600" b="0" dirty="0">
               <a:solidFill>
                 <a:srgbClr val="192D3E"/>
               </a:solidFill>
@@ -4811,47 +5442,36 @@
       </p:sp>
       <p:sp>
         <p:nvSpPr>
-          <p:cNvPr id="9" name="Rounded Rectangle 8"/>
-          <p:cNvSpPr/>
-          <p:nvPr/>
-        </p:nvSpPr>
-        <p:spPr>
-          <a:xfrm>
-            <a:off x="4572000" y="2240280"/>
-            <a:ext cx="3246120" cy="960120"/>
-          </a:xfrm>
-          <a:prstGeom prst="roundRect">
-            <a:avLst/>
-          </a:prstGeom>
-          <a:solidFill>
-            <a:srgbClr val="FFF3D6"/>
-          </a:solidFill>
-          <a:ln w="9525">
-            <a:solidFill>
-              <a:srgbClr val="DCE0E4"/>
-            </a:solidFill>
-          </a:ln>
-        </p:spPr>
-        <p:style>
-          <a:lnRef idx="1">
-            <a:schemeClr val="accent1"/>
-          </a:lnRef>
-          <a:fillRef idx="3">
-            <a:schemeClr val="accent1"/>
-          </a:fillRef>
-          <a:effectRef idx="2">
-            <a:schemeClr val="accent1"/>
-          </a:effectRef>
-          <a:fontRef idx="minor">
-            <a:schemeClr val="lt1"/>
-          </a:fontRef>
-        </p:style>
-        <p:txBody>
-          <a:bodyPr rtlCol="0" anchor="ctr"/>
-          <a:lstStyle/>
-          <a:p>
-            <a:pPr algn="ctr"/>
-            <a:endParaRPr/>
+          <p:cNvPr id="9" name="TextBox 8"/>
+          <p:cNvSpPr txBox="1"/>
+          <p:nvPr/>
+        </p:nvSpPr>
+        <p:spPr>
+          <a:xfrm>
+            <a:off x="594360" y="6473952"/>
+            <a:ext cx="8595360" cy="201168"/>
+          </a:xfrm>
+          <a:prstGeom prst="rect">
+            <a:avLst/>
+          </a:prstGeom>
+          <a:noFill/>
+        </p:spPr>
+        <p:txBody>
+          <a:bodyPr wrap="square">
+            <a:normAutofit lnSpcReduction="10000"/>
+          </a:bodyPr>
+          <a:lstStyle/>
+          <a:p>
+            <a:pPr algn="l"/>
+            <a:r>
+              <a:rPr sz="800" b="0">
+                <a:solidFill>
+                  <a:srgbClr val="66707A"/>
+                </a:solidFill>
+                <a:latin typeface="Arial"/>
+              </a:rPr>
+              <a:t>Disseny de Sistemes d'Informació · Ports de sortida en arquitectura hexagonal</a:t>
+            </a:r>
           </a:p>
         </p:txBody>
       </p:sp>
@@ -4863,8 +5483,8 @@
         </p:nvSpPr>
         <p:spPr>
           <a:xfrm>
-            <a:off x="4754880" y="2542032"/>
-            <a:ext cx="2880360" cy="256032"/>
+            <a:off x="11155680" y="6473952"/>
+            <a:ext cx="411480" cy="201168"/>
           </a:xfrm>
           <a:prstGeom prst="rect">
             <a:avLst/>
@@ -4873,532 +5493,29 @@
         </p:spPr>
         <p:txBody>
           <a:bodyPr wrap="square">
-            <a:normAutofit fontScale="70000" lnSpcReduction="20000"/>
+            <a:normAutofit lnSpcReduction="10000"/>
           </a:bodyPr>
           <a:lstStyle/>
           <a:p>
-            <a:pPr algn="ctr"/>
-            <a:r>
-              <a:rPr sz="1900" b="1" dirty="0" err="1">
-                <a:solidFill>
-                  <a:srgbClr val="192D3E"/>
-                </a:solidFill>
-                <a:latin typeface="Arial"/>
-              </a:rPr>
-              <a:t>Mateix</a:t>
-            </a:r>
-            <a:r>
-              <a:rPr sz="1900" b="1" dirty="0">
-                <a:solidFill>
-                  <a:srgbClr val="192D3E"/>
-                </a:solidFill>
-                <a:latin typeface="Arial"/>
-              </a:rPr>
-              <a:t> </a:t>
-            </a:r>
-            <a:r>
-              <a:rPr lang="es-ES" sz="1900" b="1" dirty="0">
-                <a:solidFill>
-                  <a:srgbClr val="192D3E"/>
-                </a:solidFill>
-                <a:latin typeface="Arial"/>
-              </a:rPr>
-              <a:t>S</a:t>
-            </a:r>
-            <a:r>
-              <a:rPr sz="1900" b="1" dirty="0" err="1">
-                <a:solidFill>
-                  <a:srgbClr val="192D3E"/>
-                </a:solidFill>
-                <a:latin typeface="Arial"/>
-              </a:rPr>
-              <a:t>ervei</a:t>
-            </a:r>
-            <a:r>
-              <a:rPr lang="es-ES" sz="1900" b="1" dirty="0">
-                <a:solidFill>
-                  <a:srgbClr val="192D3E"/>
-                </a:solidFill>
-                <a:latin typeface="Arial"/>
-              </a:rPr>
-              <a:t> </a:t>
-            </a:r>
-            <a:r>
-              <a:rPr lang="es-ES" sz="1900" b="1" dirty="0" err="1">
-                <a:solidFill>
-                  <a:srgbClr val="192D3E"/>
-                </a:solidFill>
-                <a:latin typeface="Arial"/>
-              </a:rPr>
-              <a:t>d’Aplicació</a:t>
-            </a:r>
-            <a:endParaRPr lang="es-ES" sz="1900" b="1" dirty="0">
+            <a:pPr algn="r"/>
+            <a:r>
+              <a:rPr lang="es-ES" sz="800" b="0" dirty="0">
+                <a:solidFill>
+                  <a:srgbClr val="66707A"/>
+                </a:solidFill>
+                <a:latin typeface="Arial"/>
+              </a:rPr>
+              <a:t>11</a:t>
+            </a:r>
+          </a:p>
+          <a:p>
+            <a:pPr algn="r"/>
+            <a:endParaRPr sz="800" b="0" dirty="0">
               <a:solidFill>
-                <a:srgbClr val="192D3E"/>
+                <a:srgbClr val="66707A"/>
               </a:solidFill>
               <a:latin typeface="Arial"/>
             </a:endParaRPr>
-          </a:p>
-          <a:p>
-            <a:pPr algn="ctr"/>
-            <a:endParaRPr sz="1900" b="1" dirty="0">
-              <a:solidFill>
-                <a:srgbClr val="192D3E"/>
-              </a:solidFill>
-              <a:latin typeface="Arial"/>
-            </a:endParaRPr>
-          </a:p>
-        </p:txBody>
-      </p:sp>
-      <p:sp>
-        <p:nvSpPr>
-          <p:cNvPr id="11" name="Rounded Rectangle 10"/>
-          <p:cNvSpPr/>
-          <p:nvPr/>
-        </p:nvSpPr>
-        <p:spPr>
-          <a:xfrm>
-            <a:off x="8275319" y="2240280"/>
-            <a:ext cx="3246120" cy="960120"/>
-          </a:xfrm>
-          <a:prstGeom prst="roundRect">
-            <a:avLst/>
-          </a:prstGeom>
-          <a:solidFill>
-            <a:srgbClr val="EBF6F0"/>
-          </a:solidFill>
-          <a:ln w="9525">
-            <a:solidFill>
-              <a:srgbClr val="DCE0E4"/>
-            </a:solidFill>
-          </a:ln>
-        </p:spPr>
-        <p:style>
-          <a:lnRef idx="1">
-            <a:schemeClr val="accent1"/>
-          </a:lnRef>
-          <a:fillRef idx="3">
-            <a:schemeClr val="accent1"/>
-          </a:fillRef>
-          <a:effectRef idx="2">
-            <a:schemeClr val="accent1"/>
-          </a:effectRef>
-          <a:fontRef idx="minor">
-            <a:schemeClr val="lt1"/>
-          </a:fontRef>
-        </p:style>
-        <p:txBody>
-          <a:bodyPr rtlCol="0" anchor="ctr"/>
-          <a:lstStyle/>
-          <a:p>
-            <a:pPr algn="ctr"/>
-            <a:endParaRPr/>
-          </a:p>
-        </p:txBody>
-      </p:sp>
-      <p:sp>
-        <p:nvSpPr>
-          <p:cNvPr id="12" name="TextBox 11"/>
-          <p:cNvSpPr txBox="1"/>
-          <p:nvPr/>
-        </p:nvSpPr>
-        <p:spPr>
-          <a:xfrm>
-            <a:off x="8458199" y="2542032"/>
-            <a:ext cx="2880360" cy="256032"/>
-          </a:xfrm>
-          <a:prstGeom prst="rect">
-            <a:avLst/>
-          </a:prstGeom>
-          <a:noFill/>
-        </p:spPr>
-        <p:txBody>
-          <a:bodyPr wrap="square">
-            <a:normAutofit fontScale="70000" lnSpcReduction="20000"/>
-          </a:bodyPr>
-          <a:lstStyle/>
-          <a:p>
-            <a:pPr algn="ctr"/>
-            <a:r>
-              <a:rPr sz="1900" b="1" dirty="0" err="1">
-                <a:solidFill>
-                  <a:srgbClr val="192D3E"/>
-                </a:solidFill>
-                <a:latin typeface="Arial"/>
-              </a:rPr>
-              <a:t>Mateix</a:t>
-            </a:r>
-            <a:r>
-              <a:rPr sz="1900" b="1" dirty="0">
-                <a:solidFill>
-                  <a:srgbClr val="192D3E"/>
-                </a:solidFill>
-                <a:latin typeface="Arial"/>
-              </a:rPr>
-              <a:t> domini</a:t>
-            </a:r>
-          </a:p>
-        </p:txBody>
-      </p:sp>
-      <p:sp>
-        <p:nvSpPr>
-          <p:cNvPr id="13" name="TextBox 12"/>
-          <p:cNvSpPr txBox="1"/>
-          <p:nvPr/>
-        </p:nvSpPr>
-        <p:spPr>
-          <a:xfrm>
-            <a:off x="1051560" y="3886200"/>
-            <a:ext cx="10058400" cy="502920"/>
-          </a:xfrm>
-          <a:prstGeom prst="rect">
-            <a:avLst/>
-          </a:prstGeom>
-          <a:noFill/>
-        </p:spPr>
-        <p:txBody>
-          <a:bodyPr wrap="square">
-            <a:normAutofit fontScale="92500"/>
-          </a:bodyPr>
-          <a:lstStyle/>
-          <a:p>
-            <a:pPr algn="ctr"/>
-            <a:r>
-              <a:rPr lang="es-ES" sz="2600" b="1" dirty="0" err="1">
-                <a:solidFill>
-                  <a:srgbClr val="236092"/>
-                </a:solidFill>
-                <a:latin typeface="Arial"/>
-              </a:rPr>
-              <a:t>Canvi</a:t>
-            </a:r>
-            <a:r>
-              <a:rPr lang="es-ES" sz="2600" b="1" dirty="0">
-                <a:solidFill>
-                  <a:srgbClr val="236092"/>
-                </a:solidFill>
-                <a:latin typeface="Arial"/>
-              </a:rPr>
-              <a:t> </a:t>
-            </a:r>
-            <a:r>
-              <a:rPr lang="es-ES" sz="2600" b="1" dirty="0" err="1">
-                <a:solidFill>
-                  <a:srgbClr val="236092"/>
-                </a:solidFill>
-                <a:latin typeface="Arial"/>
-              </a:rPr>
-              <a:t>tecnològic</a:t>
-            </a:r>
-            <a:r>
-              <a:rPr lang="es-ES" sz="2600" b="1" dirty="0">
-                <a:solidFill>
-                  <a:srgbClr val="236092"/>
-                </a:solidFill>
-                <a:latin typeface="Arial"/>
-              </a:rPr>
-              <a:t>: adaptador </a:t>
-            </a:r>
-            <a:r>
-              <a:rPr lang="es-ES" sz="2600" b="1" dirty="0" err="1">
-                <a:solidFill>
-                  <a:srgbClr val="236092"/>
-                </a:solidFill>
-                <a:latin typeface="Arial"/>
-              </a:rPr>
-              <a:t>Finnhub</a:t>
-            </a:r>
-            <a:r>
-              <a:rPr lang="es-ES" sz="2600" b="1" dirty="0">
-                <a:solidFill>
-                  <a:srgbClr val="236092"/>
-                </a:solidFill>
-                <a:latin typeface="Arial"/>
-              </a:rPr>
-              <a:t> ↔ adaptador Alpha </a:t>
-            </a:r>
-            <a:r>
-              <a:rPr lang="es-ES" sz="2600" b="1" dirty="0" err="1">
-                <a:solidFill>
-                  <a:srgbClr val="236092"/>
-                </a:solidFill>
-                <a:latin typeface="Arial"/>
-              </a:rPr>
-              <a:t>Vantage</a:t>
-            </a:r>
-            <a:endParaRPr sz="2600" b="1" dirty="0">
-              <a:solidFill>
-                <a:srgbClr val="236092"/>
-              </a:solidFill>
-              <a:latin typeface="Arial"/>
-            </a:endParaRPr>
-          </a:p>
-        </p:txBody>
-      </p:sp>
-      <p:sp>
-        <p:nvSpPr>
-          <p:cNvPr id="14" name="TextBox 13"/>
-          <p:cNvSpPr txBox="1"/>
-          <p:nvPr/>
-        </p:nvSpPr>
-        <p:spPr>
-          <a:xfrm>
-            <a:off x="1051560" y="5074920"/>
-            <a:ext cx="10058400" cy="457200"/>
-          </a:xfrm>
-          <a:prstGeom prst="rect">
-            <a:avLst/>
-          </a:prstGeom>
-          <a:noFill/>
-        </p:spPr>
-        <p:txBody>
-          <a:bodyPr wrap="square">
-            <a:normAutofit/>
-          </a:bodyPr>
-          <a:lstStyle/>
-          <a:p>
-            <a:pPr algn="ctr"/>
-            <a:r>
-              <a:rPr sz="2400" b="1" dirty="0" err="1">
-                <a:solidFill>
-                  <a:srgbClr val="192D3E"/>
-                </a:solidFill>
-                <a:latin typeface="Arial"/>
-              </a:rPr>
-              <a:t>Canvia</a:t>
-            </a:r>
-            <a:r>
-              <a:rPr sz="2400" b="1" dirty="0">
-                <a:solidFill>
-                  <a:srgbClr val="192D3E"/>
-                </a:solidFill>
-                <a:latin typeface="Arial"/>
-              </a:rPr>
-              <a:t> la </a:t>
-            </a:r>
-            <a:r>
-              <a:rPr sz="2400" b="1" dirty="0" err="1">
-                <a:solidFill>
-                  <a:srgbClr val="192D3E"/>
-                </a:solidFill>
-                <a:latin typeface="Arial"/>
-              </a:rPr>
-              <a:t>infraestructura</a:t>
-            </a:r>
-            <a:r>
-              <a:rPr sz="2400" b="1" dirty="0">
-                <a:solidFill>
-                  <a:srgbClr val="192D3E"/>
-                </a:solidFill>
-                <a:latin typeface="Arial"/>
-              </a:rPr>
-              <a:t>; </a:t>
-            </a:r>
-            <a:r>
-              <a:rPr sz="2400" b="1" dirty="0" err="1">
-                <a:solidFill>
-                  <a:srgbClr val="192D3E"/>
-                </a:solidFill>
-                <a:latin typeface="Arial"/>
-              </a:rPr>
-              <a:t>el</a:t>
-            </a:r>
-            <a:r>
-              <a:rPr sz="2400" b="1" dirty="0">
-                <a:solidFill>
-                  <a:srgbClr val="192D3E"/>
-                </a:solidFill>
-                <a:latin typeface="Arial"/>
-              </a:rPr>
-              <a:t> </a:t>
-            </a:r>
-            <a:r>
-              <a:rPr sz="2400" b="1" dirty="0" err="1">
-                <a:solidFill>
-                  <a:srgbClr val="192D3E"/>
-                </a:solidFill>
-                <a:latin typeface="Arial"/>
-              </a:rPr>
-              <a:t>cas</a:t>
-            </a:r>
-            <a:r>
-              <a:rPr sz="2400" b="1" dirty="0">
-                <a:solidFill>
-                  <a:srgbClr val="192D3E"/>
-                </a:solidFill>
-                <a:latin typeface="Arial"/>
-              </a:rPr>
-              <a:t> </a:t>
-            </a:r>
-            <a:r>
-              <a:rPr sz="2400" b="1" dirty="0" err="1">
-                <a:solidFill>
-                  <a:srgbClr val="192D3E"/>
-                </a:solidFill>
-                <a:latin typeface="Arial"/>
-              </a:rPr>
-              <a:t>d'ús</a:t>
-            </a:r>
-            <a:r>
-              <a:rPr sz="2400" b="1" dirty="0">
-                <a:solidFill>
-                  <a:srgbClr val="192D3E"/>
-                </a:solidFill>
-                <a:latin typeface="Arial"/>
-              </a:rPr>
-              <a:t> </a:t>
-            </a:r>
-            <a:r>
-              <a:rPr lang="es-ES" sz="2400" b="1" dirty="0">
-                <a:solidFill>
-                  <a:srgbClr val="192D3E"/>
-                </a:solidFill>
-                <a:latin typeface="Arial"/>
-              </a:rPr>
-              <a:t>i el </a:t>
-            </a:r>
-            <a:r>
-              <a:rPr lang="es-ES" sz="2400" b="1" dirty="0" err="1">
-                <a:solidFill>
-                  <a:srgbClr val="192D3E"/>
-                </a:solidFill>
-                <a:latin typeface="Arial"/>
-              </a:rPr>
-              <a:t>domini</a:t>
-            </a:r>
-            <a:r>
-              <a:rPr lang="es-ES" sz="2400" b="1" dirty="0">
-                <a:solidFill>
-                  <a:srgbClr val="192D3E"/>
-                </a:solidFill>
-                <a:latin typeface="Arial"/>
-              </a:rPr>
-              <a:t> </a:t>
-            </a:r>
-            <a:r>
-              <a:rPr sz="2400" b="1" dirty="0">
-                <a:solidFill>
-                  <a:srgbClr val="192D3E"/>
-                </a:solidFill>
-                <a:latin typeface="Arial"/>
-              </a:rPr>
-              <a:t>roman</a:t>
-            </a:r>
-            <a:r>
-              <a:rPr lang="es-ES" sz="2400" b="1" dirty="0">
-                <a:solidFill>
-                  <a:srgbClr val="192D3E"/>
-                </a:solidFill>
-                <a:latin typeface="Arial"/>
-              </a:rPr>
-              <a:t>en</a:t>
-            </a:r>
-            <a:r>
-              <a:rPr sz="2400" b="1" dirty="0">
-                <a:solidFill>
-                  <a:srgbClr val="192D3E"/>
-                </a:solidFill>
-                <a:latin typeface="Arial"/>
-              </a:rPr>
-              <a:t> </a:t>
-            </a:r>
-            <a:r>
-              <a:rPr sz="2400" b="1" dirty="0" err="1">
-                <a:solidFill>
-                  <a:srgbClr val="192D3E"/>
-                </a:solidFill>
-                <a:latin typeface="Arial"/>
-              </a:rPr>
-              <a:t>estable</a:t>
-            </a:r>
-            <a:r>
-              <a:rPr lang="es-ES" sz="2400" b="1" dirty="0">
-                <a:solidFill>
-                  <a:srgbClr val="192D3E"/>
-                </a:solidFill>
-                <a:latin typeface="Arial"/>
-              </a:rPr>
-              <a:t>s</a:t>
-            </a:r>
-            <a:r>
-              <a:rPr sz="2400" b="1" dirty="0">
-                <a:solidFill>
-                  <a:srgbClr val="192D3E"/>
-                </a:solidFill>
-                <a:latin typeface="Arial"/>
-              </a:rPr>
-              <a:t>.</a:t>
-            </a:r>
-          </a:p>
-        </p:txBody>
-      </p:sp>
-      <p:sp>
-        <p:nvSpPr>
-          <p:cNvPr id="15" name="TextBox 14"/>
-          <p:cNvSpPr txBox="1"/>
-          <p:nvPr/>
-        </p:nvSpPr>
-        <p:spPr>
-          <a:xfrm>
-            <a:off x="594360" y="6473952"/>
-            <a:ext cx="8595360" cy="201168"/>
-          </a:xfrm>
-          <a:prstGeom prst="rect">
-            <a:avLst/>
-          </a:prstGeom>
-          <a:noFill/>
-        </p:spPr>
-        <p:txBody>
-          <a:bodyPr wrap="square">
-            <a:normAutofit lnSpcReduction="10000"/>
-          </a:bodyPr>
-          <a:lstStyle/>
-          <a:p>
-            <a:pPr algn="l"/>
-            <a:r>
-              <a:rPr sz="800" b="0">
-                <a:solidFill>
-                  <a:srgbClr val="66707A"/>
-                </a:solidFill>
-                <a:latin typeface="Arial"/>
-              </a:rPr>
-              <a:t>Disseny de Sistemes d'Informació · Ports de sortida en arquitectura hexagonal</a:t>
-            </a:r>
-          </a:p>
-        </p:txBody>
-      </p:sp>
-      <p:sp>
-        <p:nvSpPr>
-          <p:cNvPr id="16" name="TextBox 15"/>
-          <p:cNvSpPr txBox="1"/>
-          <p:nvPr/>
-        </p:nvSpPr>
-        <p:spPr>
-          <a:xfrm>
-            <a:off x="11155680" y="6473952"/>
-            <a:ext cx="411480" cy="201168"/>
-          </a:xfrm>
-          <a:prstGeom prst="rect">
-            <a:avLst/>
-          </a:prstGeom>
-          <a:noFill/>
-        </p:spPr>
-        <p:txBody>
-          <a:bodyPr wrap="square">
-            <a:normAutofit lnSpcReduction="10000"/>
-          </a:bodyPr>
-          <a:lstStyle/>
-          <a:p>
-            <a:pPr algn="r"/>
-            <a:r>
-              <a:rPr sz="800" b="0">
-                <a:solidFill>
-                  <a:srgbClr val="66707A"/>
-                </a:solidFill>
-                <a:latin typeface="Arial"/>
-              </a:rPr>
-              <a:t>11</a:t>
-            </a:r>
           </a:p>
         </p:txBody>
       </p:sp>
@@ -5451,20 +5568,70 @@
           <a:p>
             <a:pPr algn="l"/>
             <a:r>
-              <a:rPr sz="2800" b="1">
-                <a:solidFill>
-                  <a:srgbClr val="192D3E"/>
-                </a:solidFill>
-                <a:latin typeface="Arial"/>
-              </a:rPr>
-              <a:t>Agraïment</a:t>
+              <a:rPr lang="es-ES" sz="2800" b="1" dirty="0" err="1">
+                <a:solidFill>
+                  <a:srgbClr val="192D3E"/>
+                </a:solidFill>
+                <a:latin typeface="Arial"/>
+              </a:rPr>
+              <a:t>Annex</a:t>
+            </a:r>
+            <a:r>
+              <a:rPr lang="es-ES" sz="2800" b="1" dirty="0">
+                <a:solidFill>
+                  <a:srgbClr val="192D3E"/>
+                </a:solidFill>
+                <a:latin typeface="Arial"/>
+              </a:rPr>
+              <a:t>. Demo opcional</a:t>
+            </a:r>
+            <a:endParaRPr sz="2800" b="1" dirty="0">
+              <a:solidFill>
+                <a:srgbClr val="192D3E"/>
+              </a:solidFill>
+              <a:latin typeface="Arial"/>
+            </a:endParaRPr>
+          </a:p>
+        </p:txBody>
+      </p:sp>
+      <p:sp>
+        <p:nvSpPr>
+          <p:cNvPr id="3" name="TextBox 2"/>
+          <p:cNvSpPr txBox="1"/>
+          <p:nvPr/>
+        </p:nvSpPr>
+        <p:spPr>
+          <a:xfrm>
+            <a:off x="612648" y="822960"/>
+            <a:ext cx="8869680" cy="320040"/>
+          </a:xfrm>
+          <a:prstGeom prst="rect">
+            <a:avLst/>
+          </a:prstGeom>
+          <a:noFill/>
+        </p:spPr>
+        <p:txBody>
+          <a:bodyPr wrap="square">
+            <a:normAutofit/>
+          </a:bodyPr>
+          <a:lstStyle/>
+          <a:p>
+            <a:pPr algn="l"/>
+            <a:r>
+              <a:rPr sz="1300" b="0">
+                <a:solidFill>
+                  <a:srgbClr val="66707A"/>
+                </a:solidFill>
+                <a:latin typeface="Arial"/>
+              </a:rPr>
+              <a:t>Mateix cas d'ús, adaptador substituïble</a:t>
             </a:r>
           </a:p>
         </p:txBody>
       </p:sp>
       <p:pic>
         <p:nvPicPr>
-          <p:cNvPr id="3" name="Picture 2" descr="logotip-oficial-tecnocampus-upf-horitzontal-color.png"/>
+          <p:cNvPr id="4" name="Picture 3" descr="logotip-oficial-tecnocampus-upf-horitzontal-color.png"/>
           <p:cNvPicPr>
             <a:picLocks noChangeAspect="1"/>
           </p:cNvPicPr>
@@ -5488,7 +5655,7 @@
       </p:pic>
       <p:sp>
         <p:nvSpPr>
-          <p:cNvPr id="4" name="Rectangle 3"/>
+          <p:cNvPr id="5" name="Rectangle 4"/>
           <p:cNvSpPr/>
           <p:nvPr/>
         </p:nvSpPr>
@@ -5532,14 +5699,14 @@
       </p:sp>
       <p:sp>
         <p:nvSpPr>
-          <p:cNvPr id="5" name="TextBox 4"/>
+          <p:cNvPr id="6" name="TextBox 5"/>
           <p:cNvSpPr txBox="1"/>
           <p:nvPr/>
         </p:nvSpPr>
         <p:spPr>
           <a:xfrm>
-            <a:off x="1178973" y="1874094"/>
-            <a:ext cx="9834053" cy="1780528"/>
+            <a:off x="914400" y="1325880"/>
+            <a:ext cx="10287000" cy="502920"/>
           </a:xfrm>
           <a:prstGeom prst="rect">
             <a:avLst/>
@@ -5548,485 +5715,20 @@
         </p:spPr>
         <p:txBody>
           <a:bodyPr wrap="square">
-            <a:normAutofit/>
+            <a:normAutofit fontScale="85000" lnSpcReduction="10000"/>
           </a:bodyPr>
           <a:lstStyle/>
           <a:p>
             <a:pPr algn="ctr"/>
             <a:r>
-              <a:rPr lang="es-ES" sz="2400" b="0" dirty="0" err="1">
-                <a:solidFill>
-                  <a:srgbClr val="192D3E"/>
-                </a:solidFill>
-                <a:latin typeface="Arial"/>
-              </a:rPr>
-              <a:t>Vull</a:t>
-            </a:r>
-            <a:r>
-              <a:rPr lang="es-ES" sz="2400" b="0" dirty="0">
-                <a:solidFill>
-                  <a:srgbClr val="192D3E"/>
-                </a:solidFill>
-                <a:latin typeface="Arial"/>
-              </a:rPr>
-              <a:t> </a:t>
-            </a:r>
-            <a:r>
-              <a:rPr lang="es-ES" sz="2400" b="0" dirty="0" err="1">
-                <a:solidFill>
-                  <a:srgbClr val="192D3E"/>
-                </a:solidFill>
-                <a:latin typeface="Arial"/>
-              </a:rPr>
-              <a:t>expressar</a:t>
-            </a:r>
-            <a:r>
-              <a:rPr lang="es-ES" sz="2400" b="0" dirty="0">
-                <a:solidFill>
-                  <a:srgbClr val="192D3E"/>
-                </a:solidFill>
-                <a:latin typeface="Arial"/>
-              </a:rPr>
-              <a:t> el </a:t>
-            </a:r>
-            <a:r>
-              <a:rPr lang="es-ES" sz="2400" b="0" dirty="0" err="1">
-                <a:solidFill>
-                  <a:srgbClr val="192D3E"/>
-                </a:solidFill>
-                <a:latin typeface="Arial"/>
-              </a:rPr>
-              <a:t>meu</a:t>
-            </a:r>
-            <a:r>
-              <a:rPr lang="es-ES" sz="2400" b="0" dirty="0">
-                <a:solidFill>
-                  <a:srgbClr val="192D3E"/>
-                </a:solidFill>
-                <a:latin typeface="Arial"/>
-              </a:rPr>
-              <a:t> </a:t>
-            </a:r>
-            <a:r>
-              <a:rPr lang="es-ES" sz="2400" b="0" dirty="0" err="1">
-                <a:solidFill>
-                  <a:srgbClr val="192D3E"/>
-                </a:solidFill>
-                <a:latin typeface="Arial"/>
-              </a:rPr>
-              <a:t>agraïment</a:t>
-            </a:r>
-            <a:r>
-              <a:rPr lang="es-ES" sz="2400" b="0" dirty="0">
-                <a:solidFill>
-                  <a:srgbClr val="192D3E"/>
-                </a:solidFill>
-                <a:latin typeface="Arial"/>
-              </a:rPr>
-              <a:t> al </a:t>
-            </a:r>
-            <a:r>
-              <a:rPr lang="es-ES" sz="2400" b="0" dirty="0" err="1">
-                <a:solidFill>
-                  <a:srgbClr val="192D3E"/>
-                </a:solidFill>
-                <a:latin typeface="Arial"/>
-              </a:rPr>
-              <a:t>TecnoCampus</a:t>
-            </a:r>
-            <a:r>
-              <a:rPr lang="es-ES" sz="2400" b="0" dirty="0">
-                <a:solidFill>
-                  <a:srgbClr val="192D3E"/>
-                </a:solidFill>
-                <a:latin typeface="Arial"/>
-              </a:rPr>
-              <a:t> per un </a:t>
-            </a:r>
-            <a:r>
-              <a:rPr lang="es-ES" sz="2400" b="0" dirty="0" err="1">
-                <a:solidFill>
-                  <a:srgbClr val="192D3E"/>
-                </a:solidFill>
-                <a:latin typeface="Arial"/>
-              </a:rPr>
-              <a:t>entorn</a:t>
-            </a:r>
-            <a:r>
-              <a:rPr lang="es-ES" sz="2400" b="0" dirty="0">
-                <a:solidFill>
-                  <a:srgbClr val="192D3E"/>
-                </a:solidFill>
-                <a:latin typeface="Arial"/>
-              </a:rPr>
-              <a:t> que </a:t>
-            </a:r>
-            <a:r>
-              <a:rPr lang="es-ES" sz="2400" b="0" dirty="0" err="1">
-                <a:solidFill>
-                  <a:srgbClr val="192D3E"/>
-                </a:solidFill>
-                <a:latin typeface="Arial"/>
-              </a:rPr>
-              <a:t>m’encoratja</a:t>
-            </a:r>
-            <a:r>
-              <a:rPr lang="es-ES" sz="2400" b="0" dirty="0">
-                <a:solidFill>
-                  <a:srgbClr val="192D3E"/>
-                </a:solidFill>
-                <a:latin typeface="Arial"/>
-              </a:rPr>
-              <a:t> a </a:t>
-            </a:r>
-            <a:r>
-              <a:rPr lang="es-ES" sz="2400" b="0" dirty="0" err="1">
-                <a:solidFill>
-                  <a:srgbClr val="192D3E"/>
-                </a:solidFill>
-                <a:latin typeface="Arial"/>
-              </a:rPr>
-              <a:t>créixer</a:t>
-            </a:r>
-            <a:r>
-              <a:rPr lang="es-ES" sz="2400" b="0" dirty="0">
-                <a:solidFill>
-                  <a:srgbClr val="192D3E"/>
-                </a:solidFill>
-                <a:latin typeface="Arial"/>
-              </a:rPr>
-              <a:t>, </a:t>
-            </a:r>
-            <a:r>
-              <a:rPr lang="es-ES" sz="2400" b="0" dirty="0" err="1">
-                <a:solidFill>
-                  <a:srgbClr val="192D3E"/>
-                </a:solidFill>
-                <a:latin typeface="Arial"/>
-              </a:rPr>
-              <a:t>tant</a:t>
-            </a:r>
-            <a:r>
-              <a:rPr lang="es-ES" sz="2400" b="0" dirty="0">
-                <a:solidFill>
-                  <a:srgbClr val="192D3E"/>
-                </a:solidFill>
-                <a:latin typeface="Arial"/>
-              </a:rPr>
-              <a:t> en la </a:t>
-            </a:r>
-            <a:r>
-              <a:rPr lang="es-ES" sz="2400" b="0" dirty="0" err="1">
-                <a:solidFill>
-                  <a:srgbClr val="192D3E"/>
-                </a:solidFill>
-                <a:latin typeface="Arial"/>
-              </a:rPr>
-              <a:t>docència</a:t>
-            </a:r>
-            <a:r>
-              <a:rPr lang="es-ES" sz="2400" b="0" dirty="0">
-                <a:solidFill>
-                  <a:srgbClr val="192D3E"/>
-                </a:solidFill>
-                <a:latin typeface="Arial"/>
-              </a:rPr>
-              <a:t> </a:t>
-            </a:r>
-            <a:r>
-              <a:rPr lang="es-ES" sz="2400" b="0" dirty="0" err="1">
-                <a:solidFill>
-                  <a:srgbClr val="192D3E"/>
-                </a:solidFill>
-                <a:latin typeface="Arial"/>
-              </a:rPr>
-              <a:t>com</a:t>
-            </a:r>
-            <a:r>
-              <a:rPr lang="es-ES" sz="2400" b="0" dirty="0">
-                <a:solidFill>
-                  <a:srgbClr val="192D3E"/>
-                </a:solidFill>
-                <a:latin typeface="Arial"/>
-              </a:rPr>
-              <a:t> en </a:t>
-            </a:r>
-            <a:r>
-              <a:rPr lang="es-ES" sz="2400" b="0" dirty="0" err="1">
-                <a:solidFill>
-                  <a:srgbClr val="192D3E"/>
-                </a:solidFill>
-                <a:latin typeface="Arial"/>
-              </a:rPr>
-              <a:t>l’àmbit</a:t>
-            </a:r>
-            <a:r>
-              <a:rPr lang="es-ES" sz="2400" b="0" dirty="0">
-                <a:solidFill>
-                  <a:srgbClr val="192D3E"/>
-                </a:solidFill>
-                <a:latin typeface="Arial"/>
-              </a:rPr>
-              <a:t> </a:t>
-            </a:r>
-            <a:r>
-              <a:rPr lang="es-ES" sz="2400" b="0" dirty="0" err="1">
-                <a:solidFill>
-                  <a:srgbClr val="192D3E"/>
-                </a:solidFill>
-                <a:latin typeface="Arial"/>
-              </a:rPr>
-              <a:t>acadèmic</a:t>
-            </a:r>
-            <a:r>
-              <a:rPr lang="es-ES" sz="2400" b="0" dirty="0">
-                <a:solidFill>
-                  <a:srgbClr val="192D3E"/>
-                </a:solidFill>
-                <a:latin typeface="Arial"/>
-              </a:rPr>
-              <a:t>, al </a:t>
-            </a:r>
-            <a:r>
-              <a:rPr lang="es-ES" sz="2400" b="0" dirty="0" err="1">
-                <a:solidFill>
-                  <a:srgbClr val="192D3E"/>
-                </a:solidFill>
-                <a:latin typeface="Arial"/>
-              </a:rPr>
-              <a:t>costat</a:t>
-            </a:r>
-            <a:r>
-              <a:rPr lang="es-ES" sz="2400" b="0" dirty="0">
-                <a:solidFill>
-                  <a:srgbClr val="192D3E"/>
-                </a:solidFill>
-                <a:latin typeface="Arial"/>
-              </a:rPr>
-              <a:t> </a:t>
-            </a:r>
-            <a:r>
-              <a:rPr lang="es-ES" sz="2400" b="0" dirty="0" err="1">
-                <a:solidFill>
-                  <a:srgbClr val="192D3E"/>
-                </a:solidFill>
-                <a:latin typeface="Arial"/>
-              </a:rPr>
-              <a:t>d’un</a:t>
-            </a:r>
-            <a:r>
-              <a:rPr lang="es-ES" sz="2400" b="0" dirty="0">
-                <a:solidFill>
-                  <a:srgbClr val="192D3E"/>
-                </a:solidFill>
-                <a:latin typeface="Arial"/>
-              </a:rPr>
-              <a:t> </a:t>
-            </a:r>
-            <a:r>
-              <a:rPr lang="es-ES" sz="2400" b="0" dirty="0" err="1">
-                <a:solidFill>
-                  <a:srgbClr val="192D3E"/>
-                </a:solidFill>
-                <a:latin typeface="Arial"/>
-              </a:rPr>
-              <a:t>equip</a:t>
-            </a:r>
-            <a:r>
-              <a:rPr lang="es-ES" sz="2400" b="0" dirty="0">
-                <a:solidFill>
-                  <a:srgbClr val="192D3E"/>
-                </a:solidFill>
-                <a:latin typeface="Arial"/>
-              </a:rPr>
-              <a:t> del </a:t>
-            </a:r>
-            <a:r>
-              <a:rPr lang="es-ES" sz="2400" b="0" dirty="0" err="1">
-                <a:solidFill>
-                  <a:srgbClr val="192D3E"/>
-                </a:solidFill>
-                <a:latin typeface="Arial"/>
-              </a:rPr>
-              <a:t>qual</a:t>
-            </a:r>
-            <a:r>
-              <a:rPr lang="es-ES" sz="2400" b="0" dirty="0">
-                <a:solidFill>
-                  <a:srgbClr val="192D3E"/>
-                </a:solidFill>
-                <a:latin typeface="Arial"/>
-              </a:rPr>
-              <a:t> </a:t>
-            </a:r>
-            <a:r>
-              <a:rPr lang="es-ES" sz="2400" b="0" dirty="0" err="1">
-                <a:solidFill>
-                  <a:srgbClr val="192D3E"/>
-                </a:solidFill>
-                <a:latin typeface="Arial"/>
-              </a:rPr>
-              <a:t>aprenc</a:t>
-            </a:r>
-            <a:r>
-              <a:rPr lang="es-ES" sz="2400" b="0" dirty="0">
-                <a:solidFill>
-                  <a:srgbClr val="192D3E"/>
-                </a:solidFill>
-                <a:latin typeface="Arial"/>
-              </a:rPr>
-              <a:t> i </a:t>
-            </a:r>
-            <a:r>
-              <a:rPr lang="es-ES" sz="2400" b="0" dirty="0" err="1">
-                <a:solidFill>
-                  <a:srgbClr val="192D3E"/>
-                </a:solidFill>
-                <a:latin typeface="Arial"/>
-              </a:rPr>
-              <a:t>amb</a:t>
-            </a:r>
-            <a:r>
-              <a:rPr lang="es-ES" sz="2400" b="0" dirty="0">
-                <a:solidFill>
-                  <a:srgbClr val="192D3E"/>
-                </a:solidFill>
-                <a:latin typeface="Arial"/>
-              </a:rPr>
-              <a:t> qui </a:t>
-            </a:r>
-            <a:r>
-              <a:rPr lang="es-ES" sz="2400" b="0" dirty="0" err="1">
-                <a:solidFill>
-                  <a:srgbClr val="192D3E"/>
-                </a:solidFill>
-                <a:latin typeface="Arial"/>
-              </a:rPr>
-              <a:t>comparteixo</a:t>
-            </a:r>
-            <a:r>
-              <a:rPr lang="es-ES" sz="2400" b="0" dirty="0">
-                <a:solidFill>
-                  <a:srgbClr val="192D3E"/>
-                </a:solidFill>
-                <a:latin typeface="Arial"/>
-              </a:rPr>
-              <a:t> </a:t>
-            </a:r>
-            <a:r>
-              <a:rPr lang="es-ES" sz="2400" b="0" dirty="0" err="1">
-                <a:solidFill>
-                  <a:srgbClr val="192D3E"/>
-                </a:solidFill>
-                <a:latin typeface="Arial"/>
-              </a:rPr>
-              <a:t>coneixement</a:t>
-            </a:r>
-            <a:r>
-              <a:rPr lang="es-ES" sz="2400" b="0" dirty="0">
-                <a:solidFill>
-                  <a:srgbClr val="192D3E"/>
-                </a:solidFill>
-                <a:latin typeface="Arial"/>
-              </a:rPr>
-              <a:t>, </a:t>
-            </a:r>
-            <a:r>
-              <a:rPr lang="es-ES" sz="2400" b="0" dirty="0" err="1">
-                <a:solidFill>
-                  <a:srgbClr val="192D3E"/>
-                </a:solidFill>
-                <a:latin typeface="Arial"/>
-              </a:rPr>
-              <a:t>responsabilitat</a:t>
-            </a:r>
-            <a:r>
-              <a:rPr lang="es-ES" sz="2400" b="0" dirty="0">
-                <a:solidFill>
-                  <a:srgbClr val="192D3E"/>
-                </a:solidFill>
-                <a:latin typeface="Arial"/>
-              </a:rPr>
-              <a:t> i </a:t>
-            </a:r>
-            <a:r>
-              <a:rPr lang="es-ES" sz="2400" b="0" dirty="0" err="1">
-                <a:solidFill>
-                  <a:srgbClr val="192D3E"/>
-                </a:solidFill>
-                <a:latin typeface="Arial"/>
-              </a:rPr>
-              <a:t>compromís</a:t>
-            </a:r>
-            <a:r>
-              <a:rPr lang="es-ES" sz="2400" b="0" dirty="0">
-                <a:solidFill>
-                  <a:srgbClr val="192D3E"/>
-                </a:solidFill>
-                <a:latin typeface="Arial"/>
-              </a:rPr>
-              <a:t> </a:t>
-            </a:r>
-            <a:r>
-              <a:rPr lang="es-ES" sz="2400" b="0" dirty="0" err="1">
-                <a:solidFill>
-                  <a:srgbClr val="192D3E"/>
-                </a:solidFill>
-                <a:latin typeface="Arial"/>
-              </a:rPr>
-              <a:t>amb</a:t>
-            </a:r>
-            <a:r>
-              <a:rPr lang="es-ES" sz="2400" b="0" dirty="0">
-                <a:solidFill>
-                  <a:srgbClr val="192D3E"/>
-                </a:solidFill>
-                <a:latin typeface="Arial"/>
-              </a:rPr>
-              <a:t> la </a:t>
-            </a:r>
-            <a:r>
-              <a:rPr lang="es-ES" sz="2400" b="0" dirty="0" err="1">
-                <a:solidFill>
-                  <a:srgbClr val="192D3E"/>
-                </a:solidFill>
-                <a:latin typeface="Arial"/>
-              </a:rPr>
-              <a:t>formació</a:t>
-            </a:r>
-            <a:r>
-              <a:rPr lang="es-ES" sz="2400" b="0" dirty="0">
-                <a:solidFill>
-                  <a:srgbClr val="192D3E"/>
-                </a:solidFill>
-                <a:latin typeface="Arial"/>
-              </a:rPr>
-              <a:t> </a:t>
-            </a:r>
-            <a:r>
-              <a:rPr lang="es-ES" sz="2400" b="0" dirty="0" err="1">
-                <a:solidFill>
-                  <a:srgbClr val="192D3E"/>
-                </a:solidFill>
-                <a:latin typeface="Arial"/>
-              </a:rPr>
-              <a:t>universitària</a:t>
-            </a:r>
-            <a:r>
-              <a:rPr lang="es-ES" sz="2400" b="0" dirty="0">
-                <a:solidFill>
-                  <a:srgbClr val="192D3E"/>
-                </a:solidFill>
-                <a:latin typeface="Arial"/>
-              </a:rPr>
-              <a:t>.</a:t>
-            </a:r>
-            <a:endParaRPr sz="2400" b="0" dirty="0">
-              <a:solidFill>
-                <a:srgbClr val="192D3E"/>
-              </a:solidFill>
-              <a:latin typeface="Arial"/>
-            </a:endParaRPr>
+              <a:rPr sz="1800" b="0" dirty="0" err="1">
+                <a:solidFill>
+                  <a:srgbClr val="192D3E"/>
+                </a:solidFill>
+                <a:latin typeface="Arial"/>
+              </a:rPr>
+              <a:t>HexaStock és un projecte open source propi utilitzat en docència universitària i formació o consultoria professional.</a:t>
+            </a:r>
           </a:p>
         </p:txBody>
       </p:sp>
@@ -6038,14 +5740,14 @@
         </p:nvSpPr>
         <p:spPr>
           <a:xfrm>
-            <a:off x="1885683" y="4295446"/>
-            <a:ext cx="8595360" cy="1217428"/>
+            <a:off x="868680" y="2240280"/>
+            <a:ext cx="3246120" cy="960120"/>
           </a:xfrm>
           <a:prstGeom prst="roundRect">
             <a:avLst/>
           </a:prstGeom>
           <a:solidFill>
-            <a:srgbClr val="F7F8FA"/>
+            <a:srgbClr val="E8F1F8"/>
           </a:solidFill>
           <a:ln w="9525">
             <a:solidFill>
@@ -6084,8 +5786,8 @@
         </p:nvSpPr>
         <p:spPr>
           <a:xfrm>
-            <a:off x="2046235" y="4399432"/>
-            <a:ext cx="8099528" cy="868681"/>
+            <a:off x="1051560" y="2542032"/>
+            <a:ext cx="2880360" cy="256032"/>
           </a:xfrm>
           <a:prstGeom prst="rect">
             <a:avLst/>
@@ -6094,94 +5796,22 @@
         </p:spPr>
         <p:txBody>
           <a:bodyPr wrap="square">
-            <a:normAutofit/>
+            <a:normAutofit fontScale="70000" lnSpcReduction="20000"/>
           </a:bodyPr>
           <a:lstStyle/>
           <a:p>
             <a:pPr algn="ctr"/>
             <a:r>
-              <a:rPr sz="1600" b="0" dirty="0" err="1">
-                <a:solidFill>
-                  <a:srgbClr val="192D3E"/>
-                </a:solidFill>
-                <a:latin typeface="Arial"/>
-              </a:rPr>
-              <a:t>Agraïment</a:t>
-            </a:r>
-            <a:r>
-              <a:rPr sz="1600" b="0" dirty="0">
-                <a:solidFill>
-                  <a:srgbClr val="192D3E"/>
-                </a:solidFill>
-                <a:latin typeface="Arial"/>
-              </a:rPr>
-              <a:t> especial al Dr. Josep </a:t>
-            </a:r>
-            <a:r>
-              <a:rPr sz="1600" b="0" dirty="0" err="1">
-                <a:solidFill>
-                  <a:srgbClr val="192D3E"/>
-                </a:solidFill>
-                <a:latin typeface="Arial"/>
-              </a:rPr>
-              <a:t>Roure</a:t>
-            </a:r>
-            <a:r>
-              <a:rPr sz="1600" b="0" dirty="0">
-                <a:solidFill>
-                  <a:srgbClr val="192D3E"/>
-                </a:solidFill>
-                <a:latin typeface="Arial"/>
-              </a:rPr>
-              <a:t>, company professor del </a:t>
-            </a:r>
-            <a:r>
-              <a:rPr sz="1600" b="0" dirty="0" err="1">
-                <a:solidFill>
-                  <a:srgbClr val="192D3E"/>
-                </a:solidFill>
-                <a:latin typeface="Arial"/>
-              </a:rPr>
-              <a:t>TecnoCampus</a:t>
-            </a:r>
-            <a:r>
-              <a:rPr sz="1600" b="0" dirty="0">
-                <a:solidFill>
-                  <a:srgbClr val="192D3E"/>
-                </a:solidFill>
-                <a:latin typeface="Arial"/>
-              </a:rPr>
-              <a:t>, </a:t>
-            </a:r>
-            <a:r>
-              <a:rPr sz="1600" b="0" dirty="0" err="1">
-                <a:solidFill>
-                  <a:srgbClr val="192D3E"/>
-                </a:solidFill>
-                <a:latin typeface="Arial"/>
-              </a:rPr>
-              <a:t>amb</a:t>
-            </a:r>
-            <a:r>
-              <a:rPr sz="1600" b="0" dirty="0">
-                <a:solidFill>
-                  <a:srgbClr val="192D3E"/>
-                </a:solidFill>
-                <a:latin typeface="Arial"/>
-              </a:rPr>
-              <a:t> qui he </a:t>
-            </a:r>
-            <a:r>
-              <a:rPr sz="1600" b="0" dirty="0" err="1">
-                <a:solidFill>
-                  <a:srgbClr val="192D3E"/>
-                </a:solidFill>
-                <a:latin typeface="Arial"/>
-              </a:rPr>
-              <a:t>tingut</a:t>
-            </a:r>
-            <a:r>
-              <a:rPr sz="1600" b="0" dirty="0">
+              <a:rPr sz="1900" b="1" dirty="0" err="1">
+                <a:solidFill>
+                  <a:srgbClr val="192D3E"/>
+                </a:solidFill>
+                <a:latin typeface="Arial"/>
+              </a:rPr>
+              <a:t>Mateix</a:t>
+            </a:r>
+            <a:r>
+              <a:rPr sz="1900" b="1" dirty="0">
                 <a:solidFill>
                   <a:srgbClr val="192D3E"/>
                 </a:solidFill>
@@ -6190,16 +5820,16 @@
               <a:t> </a:t>
             </a:r>
             <a:r>
-              <a:rPr sz="1600" b="0" dirty="0" err="1">
-                <a:solidFill>
-                  <a:srgbClr val="192D3E"/>
-                </a:solidFill>
-                <a:latin typeface="Arial"/>
-              </a:rPr>
-              <a:t>l'oportunitat</a:t>
-            </a:r>
-            <a:r>
-              <a:rPr sz="1600" b="0" dirty="0">
+              <a:rPr sz="1900" b="1" dirty="0" err="1">
+                <a:solidFill>
+                  <a:srgbClr val="192D3E"/>
+                </a:solidFill>
+                <a:latin typeface="Arial"/>
+              </a:rPr>
+              <a:t>cas</a:t>
+            </a:r>
+            <a:r>
+              <a:rPr sz="1900" b="1" dirty="0">
                 <a:solidFill>
                   <a:srgbClr val="192D3E"/>
                 </a:solidFill>
@@ -6208,159 +5838,15 @@
               <a:t> </a:t>
             </a:r>
             <a:r>
-              <a:rPr sz="1600" b="0" dirty="0" err="1">
-                <a:solidFill>
-                  <a:srgbClr val="192D3E"/>
-                </a:solidFill>
-                <a:latin typeface="Arial"/>
-              </a:rPr>
-              <a:t>d'aprendre</a:t>
-            </a:r>
-            <a:r>
-              <a:rPr sz="1600" b="0" dirty="0">
-                <a:solidFill>
-                  <a:srgbClr val="192D3E"/>
-                </a:solidFill>
-                <a:latin typeface="Arial"/>
-              </a:rPr>
-              <a:t> </a:t>
-            </a:r>
-            <a:r>
-              <a:rPr sz="1600" b="0" dirty="0" err="1">
-                <a:solidFill>
-                  <a:srgbClr val="192D3E"/>
-                </a:solidFill>
-                <a:latin typeface="Arial"/>
-              </a:rPr>
-              <a:t>sobre</a:t>
-            </a:r>
-            <a:r>
-              <a:rPr sz="1600" b="0" dirty="0">
-                <a:solidFill>
-                  <a:srgbClr val="192D3E"/>
-                </a:solidFill>
-                <a:latin typeface="Arial"/>
-              </a:rPr>
-              <a:t> </a:t>
-            </a:r>
-            <a:r>
-              <a:rPr sz="1600" b="0" dirty="0" err="1">
-                <a:solidFill>
-                  <a:srgbClr val="192D3E"/>
-                </a:solidFill>
-                <a:latin typeface="Arial"/>
-              </a:rPr>
-              <a:t>arquitectura</a:t>
-            </a:r>
-            <a:r>
-              <a:rPr sz="1600" b="0" dirty="0">
-                <a:solidFill>
-                  <a:srgbClr val="192D3E"/>
-                </a:solidFill>
-                <a:latin typeface="Arial"/>
-              </a:rPr>
-              <a:t> </a:t>
-            </a:r>
-            <a:r>
-              <a:rPr lang="es-ES" sz="1600" dirty="0">
-                <a:solidFill>
-                  <a:srgbClr val="192D3E"/>
-                </a:solidFill>
-                <a:latin typeface="Arial"/>
-              </a:rPr>
-              <a:t>de </a:t>
-            </a:r>
-            <a:r>
-              <a:rPr sz="1600" b="0" dirty="0">
-                <a:solidFill>
-                  <a:srgbClr val="192D3E"/>
-                </a:solidFill>
-                <a:latin typeface="Arial"/>
-              </a:rPr>
-              <a:t>software</a:t>
-            </a:r>
-            <a:r>
-              <a:rPr lang="es-ES" sz="1600" dirty="0">
-                <a:solidFill>
-                  <a:srgbClr val="192D3E"/>
-                </a:solidFill>
-                <a:latin typeface="Arial"/>
-              </a:rPr>
-              <a:t>, </a:t>
-            </a:r>
-            <a:r>
-              <a:rPr lang="es-ES" sz="1600" b="0" dirty="0" err="1">
-                <a:solidFill>
-                  <a:srgbClr val="192D3E"/>
-                </a:solidFill>
-                <a:latin typeface="Arial"/>
-              </a:rPr>
-              <a:t>metodologies</a:t>
-            </a:r>
-            <a:r>
-              <a:rPr lang="es-ES" sz="1600" b="0" dirty="0">
-                <a:solidFill>
-                  <a:srgbClr val="192D3E"/>
-                </a:solidFill>
-                <a:latin typeface="Arial"/>
-              </a:rPr>
-              <a:t> actives </a:t>
-            </a:r>
-            <a:r>
-              <a:rPr lang="es-ES" sz="1600" b="0" dirty="0" err="1">
-                <a:solidFill>
-                  <a:srgbClr val="192D3E"/>
-                </a:solidFill>
-                <a:latin typeface="Arial"/>
-              </a:rPr>
-              <a:t>d'aprenentatge</a:t>
-            </a:r>
-            <a:r>
-              <a:rPr lang="es-ES" sz="1600" dirty="0">
-                <a:solidFill>
-                  <a:srgbClr val="192D3E"/>
-                </a:solidFill>
-                <a:latin typeface="Arial"/>
-              </a:rPr>
-              <a:t> i </a:t>
-            </a:r>
-            <a:r>
-              <a:rPr lang="es-ES" sz="1600" dirty="0" err="1">
-                <a:solidFill>
-                  <a:srgbClr val="192D3E"/>
-                </a:solidFill>
-                <a:latin typeface="Arial"/>
-              </a:rPr>
-              <a:t>treball</a:t>
-            </a:r>
-            <a:r>
-              <a:rPr lang="es-ES" sz="1600" dirty="0">
-                <a:solidFill>
-                  <a:srgbClr val="192D3E"/>
-                </a:solidFill>
-                <a:latin typeface="Arial"/>
-              </a:rPr>
-              <a:t> en </a:t>
-            </a:r>
-            <a:r>
-              <a:rPr lang="es-ES" sz="1600" dirty="0" err="1">
-                <a:solidFill>
-                  <a:srgbClr val="192D3E"/>
-                </a:solidFill>
-                <a:latin typeface="Arial"/>
-              </a:rPr>
-              <a:t>equip</a:t>
-            </a:r>
-            <a:r>
-              <a:rPr lang="es-ES" sz="1600" dirty="0">
-                <a:solidFill>
-                  <a:srgbClr val="192D3E"/>
-                </a:solidFill>
-                <a:latin typeface="Arial"/>
-              </a:rPr>
-              <a:t>.</a:t>
-            </a:r>
-            <a:endParaRPr sz="1600" b="0" dirty="0">
+              <a:rPr sz="1900" b="1" dirty="0" err="1">
+                <a:solidFill>
+                  <a:srgbClr val="192D3E"/>
+                </a:solidFill>
+                <a:latin typeface="Arial"/>
+              </a:rPr>
+              <a:t>d'ús</a:t>
+            </a:r>
+            <a:endParaRPr sz="1900" b="1" dirty="0">
               <a:solidFill>
                 <a:srgbClr val="192D3E"/>
               </a:solidFill>
@@ -6371,7 +5857,530 @@
       </p:sp>
       <p:sp>
         <p:nvSpPr>
-          <p:cNvPr id="9" name="TextBox 8"/>
+          <p:cNvPr id="9" name="Rounded Rectangle 8"/>
+          <p:cNvSpPr/>
+          <p:nvPr/>
+        </p:nvSpPr>
+        <p:spPr>
+          <a:xfrm>
+            <a:off x="4572000" y="2240280"/>
+            <a:ext cx="3246120" cy="960120"/>
+          </a:xfrm>
+          <a:prstGeom prst="roundRect">
+            <a:avLst/>
+          </a:prstGeom>
+          <a:solidFill>
+            <a:srgbClr val="FFF3D6"/>
+          </a:solidFill>
+          <a:ln w="9525">
+            <a:solidFill>
+              <a:srgbClr val="DCE0E4"/>
+            </a:solidFill>
+          </a:ln>
+        </p:spPr>
+        <p:style>
+          <a:lnRef idx="1">
+            <a:schemeClr val="accent1"/>
+          </a:lnRef>
+          <a:fillRef idx="3">
+            <a:schemeClr val="accent1"/>
+          </a:fillRef>
+          <a:effectRef idx="2">
+            <a:schemeClr val="accent1"/>
+          </a:effectRef>
+          <a:fontRef idx="minor">
+            <a:schemeClr val="lt1"/>
+          </a:fontRef>
+        </p:style>
+        <p:txBody>
+          <a:bodyPr rtlCol="0" anchor="ctr"/>
+          <a:lstStyle/>
+          <a:p>
+            <a:pPr algn="ctr"/>
+            <a:endParaRPr/>
+          </a:p>
+        </p:txBody>
+      </p:sp>
+      <p:sp>
+        <p:nvSpPr>
+          <p:cNvPr id="10" name="TextBox 9"/>
+          <p:cNvSpPr txBox="1"/>
+          <p:nvPr/>
+        </p:nvSpPr>
+        <p:spPr>
+          <a:xfrm>
+            <a:off x="4754880" y="2542032"/>
+            <a:ext cx="2880360" cy="256032"/>
+          </a:xfrm>
+          <a:prstGeom prst="rect">
+            <a:avLst/>
+          </a:prstGeom>
+          <a:noFill/>
+        </p:spPr>
+        <p:txBody>
+          <a:bodyPr wrap="square">
+            <a:normAutofit fontScale="70000" lnSpcReduction="20000"/>
+          </a:bodyPr>
+          <a:lstStyle/>
+          <a:p>
+            <a:pPr algn="ctr"/>
+            <a:r>
+              <a:rPr sz="1900" b="1" dirty="0" err="1">
+                <a:solidFill>
+                  <a:srgbClr val="192D3E"/>
+                </a:solidFill>
+                <a:latin typeface="Arial"/>
+              </a:rPr>
+              <a:t>Mateix</a:t>
+            </a:r>
+            <a:r>
+              <a:rPr sz="1900" b="1" dirty="0">
+                <a:solidFill>
+                  <a:srgbClr val="192D3E"/>
+                </a:solidFill>
+                <a:latin typeface="Arial"/>
+              </a:rPr>
+              <a:t> </a:t>
+            </a:r>
+            <a:r>
+              <a:rPr lang="es-ES" sz="1900" b="1" dirty="0">
+                <a:solidFill>
+                  <a:srgbClr val="192D3E"/>
+                </a:solidFill>
+                <a:latin typeface="Arial"/>
+              </a:rPr>
+              <a:t>S</a:t>
+            </a:r>
+            <a:r>
+              <a:rPr sz="1900" b="1" dirty="0" err="1">
+                <a:solidFill>
+                  <a:srgbClr val="192D3E"/>
+                </a:solidFill>
+                <a:latin typeface="Arial"/>
+              </a:rPr>
+              <a:t>ervei</a:t>
+            </a:r>
+            <a:r>
+              <a:rPr lang="es-ES" sz="1900" b="1" dirty="0">
+                <a:solidFill>
+                  <a:srgbClr val="192D3E"/>
+                </a:solidFill>
+                <a:latin typeface="Arial"/>
+              </a:rPr>
+              <a:t> </a:t>
+            </a:r>
+            <a:r>
+              <a:rPr lang="es-ES" sz="1900" b="1" dirty="0" err="1">
+                <a:solidFill>
+                  <a:srgbClr val="192D3E"/>
+                </a:solidFill>
+                <a:latin typeface="Arial"/>
+              </a:rPr>
+              <a:t>d’Aplicació</a:t>
+            </a:r>
+            <a:endParaRPr lang="es-ES" sz="1900" b="1" dirty="0">
+              <a:solidFill>
+                <a:srgbClr val="192D3E"/>
+              </a:solidFill>
+              <a:latin typeface="Arial"/>
+            </a:endParaRPr>
+          </a:p>
+          <a:p>
+            <a:pPr algn="ctr"/>
+            <a:endParaRPr sz="1900" b="1" dirty="0">
+              <a:solidFill>
+                <a:srgbClr val="192D3E"/>
+              </a:solidFill>
+              <a:latin typeface="Arial"/>
+            </a:endParaRPr>
+          </a:p>
+        </p:txBody>
+      </p:sp>
+      <p:sp>
+        <p:nvSpPr>
+          <p:cNvPr id="11" name="Rounded Rectangle 10"/>
+          <p:cNvSpPr/>
+          <p:nvPr/>
+        </p:nvSpPr>
+        <p:spPr>
+          <a:xfrm>
+            <a:off x="8275319" y="2240280"/>
+            <a:ext cx="3246120" cy="960120"/>
+          </a:xfrm>
+          <a:prstGeom prst="roundRect">
+            <a:avLst/>
+          </a:prstGeom>
+          <a:solidFill>
+            <a:srgbClr val="EBF6F0"/>
+          </a:solidFill>
+          <a:ln w="9525">
+            <a:solidFill>
+              <a:srgbClr val="DCE0E4"/>
+            </a:solidFill>
+          </a:ln>
+        </p:spPr>
+        <p:style>
+          <a:lnRef idx="1">
+            <a:schemeClr val="accent1"/>
+          </a:lnRef>
+          <a:fillRef idx="3">
+            <a:schemeClr val="accent1"/>
+          </a:fillRef>
+          <a:effectRef idx="2">
+            <a:schemeClr val="accent1"/>
+          </a:effectRef>
+          <a:fontRef idx="minor">
+            <a:schemeClr val="lt1"/>
+          </a:fontRef>
+        </p:style>
+        <p:txBody>
+          <a:bodyPr rtlCol="0" anchor="ctr"/>
+          <a:lstStyle/>
+          <a:p>
+            <a:pPr algn="ctr"/>
+            <a:endParaRPr/>
+          </a:p>
+        </p:txBody>
+      </p:sp>
+      <p:sp>
+        <p:nvSpPr>
+          <p:cNvPr id="12" name="TextBox 11"/>
+          <p:cNvSpPr txBox="1"/>
+          <p:nvPr/>
+        </p:nvSpPr>
+        <p:spPr>
+          <a:xfrm>
+            <a:off x="8458199" y="2542032"/>
+            <a:ext cx="2880360" cy="256032"/>
+          </a:xfrm>
+          <a:prstGeom prst="rect">
+            <a:avLst/>
+          </a:prstGeom>
+          <a:noFill/>
+        </p:spPr>
+        <p:txBody>
+          <a:bodyPr wrap="square">
+            <a:normAutofit fontScale="70000" lnSpcReduction="20000"/>
+          </a:bodyPr>
+          <a:lstStyle/>
+          <a:p>
+            <a:pPr algn="ctr"/>
+            <a:r>
+              <a:rPr sz="1900" b="1" dirty="0" err="1">
+                <a:solidFill>
+                  <a:srgbClr val="192D3E"/>
+                </a:solidFill>
+                <a:latin typeface="Arial"/>
+              </a:rPr>
+              <a:t>Mateix</a:t>
+            </a:r>
+            <a:r>
+              <a:rPr sz="1900" b="1" dirty="0">
+                <a:solidFill>
+                  <a:srgbClr val="192D3E"/>
+                </a:solidFill>
+                <a:latin typeface="Arial"/>
+              </a:rPr>
+              <a:t> domini</a:t>
+            </a:r>
+          </a:p>
+        </p:txBody>
+      </p:sp>
+      <p:sp>
+        <p:nvSpPr>
+          <p:cNvPr id="13" name="TextBox 12"/>
+          <p:cNvSpPr txBox="1"/>
+          <p:nvPr/>
+        </p:nvSpPr>
+        <p:spPr>
+          <a:xfrm>
+            <a:off x="1051560" y="3886200"/>
+            <a:ext cx="10058400" cy="502920"/>
+          </a:xfrm>
+          <a:prstGeom prst="rect">
+            <a:avLst/>
+          </a:prstGeom>
+          <a:noFill/>
+        </p:spPr>
+        <p:txBody>
+          <a:bodyPr wrap="square">
+            <a:normAutofit fontScale="92500"/>
+          </a:bodyPr>
+          <a:lstStyle/>
+          <a:p>
+            <a:pPr algn="ctr"/>
+            <a:r>
+              <a:rPr lang="es-ES" sz="2600" b="1" dirty="0" err="1">
+                <a:solidFill>
+                  <a:srgbClr val="236092"/>
+                </a:solidFill>
+                <a:latin typeface="Arial"/>
+              </a:rPr>
+              <a:t>Canvi</a:t>
+            </a:r>
+            <a:r>
+              <a:rPr lang="es-ES" sz="2600" b="1" dirty="0">
+                <a:solidFill>
+                  <a:srgbClr val="236092"/>
+                </a:solidFill>
+                <a:latin typeface="Arial"/>
+              </a:rPr>
+              <a:t> </a:t>
+            </a:r>
+            <a:r>
+              <a:rPr lang="es-ES" sz="2600" b="1" dirty="0" err="1">
+                <a:solidFill>
+                  <a:srgbClr val="236092"/>
+                </a:solidFill>
+                <a:latin typeface="Arial"/>
+              </a:rPr>
+              <a:t>tecnològic</a:t>
+            </a:r>
+            <a:r>
+              <a:rPr lang="es-ES" sz="2600" b="1" dirty="0">
+                <a:solidFill>
+                  <a:srgbClr val="236092"/>
+                </a:solidFill>
+                <a:latin typeface="Arial"/>
+              </a:rPr>
+              <a:t>: adaptador </a:t>
+            </a:r>
+            <a:r>
+              <a:rPr lang="es-ES" sz="2600" b="1" dirty="0" err="1">
+                <a:solidFill>
+                  <a:srgbClr val="236092"/>
+                </a:solidFill>
+                <a:latin typeface="Arial"/>
+              </a:rPr>
+              <a:t>Finnhub</a:t>
+            </a:r>
+            <a:r>
+              <a:rPr lang="es-ES" sz="2600" b="1" dirty="0">
+                <a:solidFill>
+                  <a:srgbClr val="236092"/>
+                </a:solidFill>
+                <a:latin typeface="Arial"/>
+              </a:rPr>
+              <a:t> ↔ adaptador Alpha </a:t>
+            </a:r>
+            <a:r>
+              <a:rPr lang="es-ES" sz="2600" b="1" dirty="0" err="1">
+                <a:solidFill>
+                  <a:srgbClr val="236092"/>
+                </a:solidFill>
+                <a:latin typeface="Arial"/>
+              </a:rPr>
+              <a:t>Vantage</a:t>
+            </a:r>
+            <a:endParaRPr sz="2600" b="1" dirty="0">
+              <a:solidFill>
+                <a:srgbClr val="236092"/>
+              </a:solidFill>
+              <a:latin typeface="Arial"/>
+            </a:endParaRPr>
+          </a:p>
+        </p:txBody>
+      </p:sp>
+      <p:sp>
+        <p:nvSpPr>
+          <p:cNvPr id="14" name="TextBox 13"/>
+          <p:cNvSpPr txBox="1"/>
+          <p:nvPr/>
+        </p:nvSpPr>
+        <p:spPr>
+          <a:xfrm>
+            <a:off x="1051560" y="5074920"/>
+            <a:ext cx="10058400" cy="457200"/>
+          </a:xfrm>
+          <a:prstGeom prst="rect">
+            <a:avLst/>
+          </a:prstGeom>
+          <a:noFill/>
+        </p:spPr>
+        <p:txBody>
+          <a:bodyPr wrap="square">
+            <a:normAutofit/>
+          </a:bodyPr>
+          <a:lstStyle/>
+          <a:p>
+            <a:pPr algn="ctr"/>
+            <a:r>
+              <a:rPr sz="2400" b="1" dirty="0" err="1">
+                <a:solidFill>
+                  <a:srgbClr val="192D3E"/>
+                </a:solidFill>
+                <a:latin typeface="Arial"/>
+              </a:rPr>
+              <a:t>Canvia</a:t>
+            </a:r>
+            <a:r>
+              <a:rPr sz="2400" b="1" dirty="0">
+                <a:solidFill>
+                  <a:srgbClr val="192D3E"/>
+                </a:solidFill>
+                <a:latin typeface="Arial"/>
+              </a:rPr>
+              <a:t> la </a:t>
+            </a:r>
+            <a:r>
+              <a:rPr sz="2400" b="1" dirty="0" err="1">
+                <a:solidFill>
+                  <a:srgbClr val="192D3E"/>
+                </a:solidFill>
+                <a:latin typeface="Arial"/>
+              </a:rPr>
+              <a:t>infraestructura</a:t>
+            </a:r>
+            <a:r>
+              <a:rPr sz="2400" b="1" dirty="0">
+                <a:solidFill>
+                  <a:srgbClr val="192D3E"/>
+                </a:solidFill>
+                <a:latin typeface="Arial"/>
+              </a:rPr>
+              <a:t>; </a:t>
+            </a:r>
+            <a:r>
+              <a:rPr sz="2400" b="1" dirty="0" err="1">
+                <a:solidFill>
+                  <a:srgbClr val="192D3E"/>
+                </a:solidFill>
+                <a:latin typeface="Arial"/>
+              </a:rPr>
+              <a:t>el</a:t>
+            </a:r>
+            <a:r>
+              <a:rPr sz="2400" b="1" dirty="0">
+                <a:solidFill>
+                  <a:srgbClr val="192D3E"/>
+                </a:solidFill>
+                <a:latin typeface="Arial"/>
+              </a:rPr>
+              <a:t> </a:t>
+            </a:r>
+            <a:r>
+              <a:rPr sz="2400" b="1" dirty="0" err="1">
+                <a:solidFill>
+                  <a:srgbClr val="192D3E"/>
+                </a:solidFill>
+                <a:latin typeface="Arial"/>
+              </a:rPr>
+              <a:t>cas</a:t>
+            </a:r>
+            <a:r>
+              <a:rPr sz="2400" b="1" dirty="0">
+                <a:solidFill>
+                  <a:srgbClr val="192D3E"/>
+                </a:solidFill>
+                <a:latin typeface="Arial"/>
+              </a:rPr>
+              <a:t> </a:t>
+            </a:r>
+            <a:r>
+              <a:rPr sz="2400" b="1" dirty="0" err="1">
+                <a:solidFill>
+                  <a:srgbClr val="192D3E"/>
+                </a:solidFill>
+                <a:latin typeface="Arial"/>
+              </a:rPr>
+              <a:t>d'ús</a:t>
+            </a:r>
+            <a:r>
+              <a:rPr sz="2400" b="1" dirty="0">
+                <a:solidFill>
+                  <a:srgbClr val="192D3E"/>
+                </a:solidFill>
+                <a:latin typeface="Arial"/>
+              </a:rPr>
+              <a:t> </a:t>
+            </a:r>
+            <a:r>
+              <a:rPr lang="es-ES" sz="2400" b="1" dirty="0">
+                <a:solidFill>
+                  <a:srgbClr val="192D3E"/>
+                </a:solidFill>
+                <a:latin typeface="Arial"/>
+              </a:rPr>
+              <a:t>i el </a:t>
+            </a:r>
+            <a:r>
+              <a:rPr lang="es-ES" sz="2400" b="1" dirty="0" err="1">
+                <a:solidFill>
+                  <a:srgbClr val="192D3E"/>
+                </a:solidFill>
+                <a:latin typeface="Arial"/>
+              </a:rPr>
+              <a:t>domini</a:t>
+            </a:r>
+            <a:r>
+              <a:rPr lang="es-ES" sz="2400" b="1" dirty="0">
+                <a:solidFill>
+                  <a:srgbClr val="192D3E"/>
+                </a:solidFill>
+                <a:latin typeface="Arial"/>
+              </a:rPr>
+              <a:t> </a:t>
+            </a:r>
+            <a:r>
+              <a:rPr sz="2400" b="1" dirty="0">
+                <a:solidFill>
+                  <a:srgbClr val="192D3E"/>
+                </a:solidFill>
+                <a:latin typeface="Arial"/>
+              </a:rPr>
+              <a:t>roman</a:t>
+            </a:r>
+            <a:r>
+              <a:rPr lang="es-ES" sz="2400" b="1" dirty="0">
+                <a:solidFill>
+                  <a:srgbClr val="192D3E"/>
+                </a:solidFill>
+                <a:latin typeface="Arial"/>
+              </a:rPr>
+              <a:t>en</a:t>
+            </a:r>
+            <a:r>
+              <a:rPr sz="2400" b="1" dirty="0">
+                <a:solidFill>
+                  <a:srgbClr val="192D3E"/>
+                </a:solidFill>
+                <a:latin typeface="Arial"/>
+              </a:rPr>
+              <a:t> </a:t>
+            </a:r>
+            <a:r>
+              <a:rPr sz="2400" b="1" dirty="0" err="1">
+                <a:solidFill>
+                  <a:srgbClr val="192D3E"/>
+                </a:solidFill>
+                <a:latin typeface="Arial"/>
+              </a:rPr>
+              <a:t>estable</a:t>
+            </a:r>
+            <a:r>
+              <a:rPr lang="es-ES" sz="2400" b="1" dirty="0">
+                <a:solidFill>
+                  <a:srgbClr val="192D3E"/>
+                </a:solidFill>
+                <a:latin typeface="Arial"/>
+              </a:rPr>
+              <a:t>s</a:t>
+            </a:r>
+            <a:r>
+              <a:rPr sz="2400" b="1" dirty="0">
+                <a:solidFill>
+                  <a:srgbClr val="192D3E"/>
+                </a:solidFill>
+                <a:latin typeface="Arial"/>
+              </a:rPr>
+              <a:t>.</a:t>
+            </a:r>
+          </a:p>
+        </p:txBody>
+      </p:sp>
+      <p:sp>
+        <p:nvSpPr>
+          <p:cNvPr id="15" name="TextBox 14"/>
           <p:cNvSpPr txBox="1"/>
           <p:nvPr/>
         </p:nvSpPr>
@@ -6406,7 +6415,7 @@
       </p:sp>
       <p:sp>
         <p:nvSpPr>
-          <p:cNvPr id="10" name="TextBox 9"/>
+          <p:cNvPr id="16" name="TextBox 15"/>
           <p:cNvSpPr txBox="1"/>
           <p:nvPr/>
         </p:nvSpPr>
@@ -6428,7 +6437,7 @@
           <a:p>
             <a:pPr algn="r"/>
             <a:r>
-              <a:rPr sz="800" b="0">
+              <a:rPr lang="es-ES" sz="800" b="0" dirty="0">
                 <a:solidFill>
                   <a:srgbClr val="66707A"/>
                 </a:solidFill>
@@ -6436,6 +6445,15 @@
               </a:rPr>
               <a:t>12</a:t>
             </a:r>
+          </a:p>
+          <a:p>
+            <a:pPr algn="r"/>
+            <a:endParaRPr sz="800" b="0" dirty="0">
+              <a:solidFill>
+                <a:srgbClr val="66707A"/>
+              </a:solidFill>
+              <a:latin typeface="Arial"/>
+            </a:endParaRPr>
           </a:p>
         </p:txBody>
       </p:sp>

</xml_diff>

<commit_message>
docs: clarify output port explanation
</commit_message>
<xml_diff>
--- a/doc/presentations/defensa-placa-permanent-dsi-ports-sortida-hexagonal/output/IMPORTANTE_MANUAL_defensa-dsi-ports-sortida-hexagonal.pptx
+++ b/doc/presentations/defensa-placa-permanent-dsi-ports-sortida-hexagonal/output/IMPORTANTE_MANUAL_defensa-dsi-ports-sortida-hexagonal.pptx
@@ -10693,7 +10693,7 @@
 </file>
 
 <file path=ppt/slides/slide7.xml><?xml version="1.0" encoding="utf-8"?>
-<p:sld xmlns:a="http://schemas.openxmlformats.org/drawingml/2006/main" xmlns:r="http://schemas.openxmlformats.org/officeDocument/2006/relationships" xmlns:p="http://schemas.openxmlformats.org/presentationml/2006/main">
+<p:sld xmlns:a="http://schemas.openxmlformats.org/drawingml/2006/main" xmlns:p="http://schemas.openxmlformats.org/presentationml/2006/main" xmlns:r="http://schemas.openxmlformats.org/officeDocument/2006/relationships">
   <p:cSld>
     <p:spTree>
       <p:nvGrpSpPr>
@@ -10820,7 +10820,7 @@
         </p:nvSpPr>
         <p:spPr>
           <a:xfrm>
-            <a:off x="3794760" y="1417320"/>
+            <a:off x="2514600" y="1417320"/>
             <a:ext cx="4480560" cy="566928"/>
           </a:xfrm>
           <a:prstGeom prst="roundRect">
@@ -10866,8 +10866,8 @@
         </p:nvSpPr>
         <p:spPr>
           <a:xfrm>
-            <a:off x="2743200" y="1517904"/>
-            <a:ext cx="6858000" cy="256032"/>
+            <a:off x="2514600" y="1517904"/>
+            <a:ext cx="4480560" cy="256032"/>
           </a:xfrm>
           <a:prstGeom prst="rect">
             <a:avLst/>
@@ -10928,7 +10928,7 @@
         </p:nvSpPr>
         <p:spPr>
           <a:xfrm>
-            <a:off x="3794760" y="2377440"/>
+            <a:off x="2514600" y="2377440"/>
             <a:ext cx="4480560" cy="566928"/>
           </a:xfrm>
           <a:prstGeom prst="roundRect">
@@ -10974,8 +10974,8 @@
         </p:nvSpPr>
         <p:spPr>
           <a:xfrm>
-            <a:off x="2743200" y="2478024"/>
-            <a:ext cx="6858000" cy="256032"/>
+            <a:off x="2514600" y="2478024"/>
+            <a:ext cx="4480560" cy="256032"/>
           </a:xfrm>
           <a:prstGeom prst="rect">
             <a:avLst/>
@@ -11036,7 +11036,7 @@
         </p:nvSpPr>
         <p:spPr>
           <a:xfrm>
-            <a:off x="3794760" y="3337560"/>
+            <a:off x="2514600" y="3337560"/>
             <a:ext cx="4480560" cy="566928"/>
           </a:xfrm>
           <a:prstGeom prst="roundRect">
@@ -11082,8 +11082,8 @@
         </p:nvSpPr>
         <p:spPr>
           <a:xfrm>
-            <a:off x="2743200" y="3438144"/>
-            <a:ext cx="6858000" cy="256032"/>
+            <a:off x="2514600" y="3438144"/>
+            <a:ext cx="4480560" cy="256032"/>
           </a:xfrm>
           <a:prstGeom prst="rect">
             <a:avLst/>
@@ -11144,7 +11144,7 @@
         </p:nvSpPr>
         <p:spPr>
           <a:xfrm>
-            <a:off x="3794760" y="4297680"/>
+            <a:off x="2514600" y="4297680"/>
             <a:ext cx="4480560" cy="566928"/>
           </a:xfrm>
           <a:prstGeom prst="roundRect">
@@ -11190,8 +11190,8 @@
         </p:nvSpPr>
         <p:spPr>
           <a:xfrm>
-            <a:off x="2743200" y="4398264"/>
-            <a:ext cx="6858000" cy="256032"/>
+            <a:off x="2514600" y="4398264"/>
+            <a:ext cx="4480560" cy="256032"/>
           </a:xfrm>
           <a:prstGeom prst="rect">
             <a:avLst/>
@@ -11213,6 +11213,116 @@
                 <a:latin typeface="Arial"/>
               </a:rPr>
               <a:t>Cas d'ús → Port de sortida ← Adaptador</a:t>
+            </a:r>
+          </a:p>
+        </p:txBody>
+      </p:sp>
+      <p:sp>
+        <p:nvSpPr>
+          <p:cNvPr id="20" name="Rounded Rectangle 19"/>
+          <p:cNvSpPr/>
+          <p:nvPr/>
+        </p:nvSpPr>
+        <p:spPr>
+          <a:xfrm>
+            <a:off x="7543800" y="1600200"/>
+            <a:ext cx="3200400" cy="3200400"/>
+          </a:xfrm>
+          <a:prstGeom prst="roundRect">
+            <a:avLst>
+              <a:gd name="adj" fmla="val 5000"/>
+            </a:avLst>
+          </a:prstGeom>
+          <a:solidFill>
+            <a:srgbClr val="F4F8FB"/>
+          </a:solidFill>
+          <a:ln w="9525">
+            <a:solidFill>
+              <a:srgbClr val="DCE0E4"/>
+            </a:solidFill>
+          </a:ln>
+        </p:spPr>
+        <p:style>
+          <a:lnRef idx="1">
+            <a:schemeClr val="accent1"/>
+          </a:lnRef>
+          <a:fillRef idx="3">
+            <a:schemeClr val="accent1"/>
+          </a:fillRef>
+          <a:effectRef idx="2">
+            <a:schemeClr val="accent1"/>
+          </a:effectRef>
+          <a:fontRef idx="minor">
+            <a:schemeClr val="lt1"/>
+          </a:fontRef>
+        </p:style>
+        <p:txBody>
+          <a:bodyPr rtlCol="0" anchor="ctr" wrap="square" lIns="182880" rIns="182880" tIns="182880" bIns="182880"/>
+          <a:lstStyle/>
+          <a:p>
+            <a:pPr algn="ctr"/>
+            <a:r>
+              <a:rPr sz="1650" b="1">
+                <a:solidFill>
+                  <a:srgbClr val="192D3E"/>
+                </a:solidFill>
+                <a:latin typeface="Arial"/>
+              </a:rPr>
+              <a:t>Concreció en Java</a:t>
+            </a:r>
+          </a:p>
+          <a:p>
+            <a:endParaRPr sz="500"/>
+          </a:p>
+          <a:p>
+            <a:pPr algn="ctr"/>
+            <a:r>
+              <a:rPr sz="1400" b="1">
+                <a:solidFill>
+                  <a:srgbClr val="192D3E"/>
+                </a:solidFill>
+                <a:latin typeface="Arial"/>
+              </a:rPr>
+              <a:t>Port de sortida</a:t>
+            </a:r>
+          </a:p>
+          <a:p>
+            <a:pPr algn="ctr"/>
+            <a:r>
+              <a:rPr sz="1300">
+                <a:solidFill>
+                  <a:srgbClr val="192D3E"/>
+                </a:solidFill>
+                <a:latin typeface="Arial"/>
+              </a:rPr>
+              <a:t>interfície de l’aplicació</a:t>
+            </a:r>
+          </a:p>
+          <a:p>
+            <a:endParaRPr sz="500"/>
+          </a:p>
+          <a:p>
+            <a:pPr algn="ctr"/>
+            <a:r>
+              <a:rPr sz="1400" b="1">
+                <a:solidFill>
+                  <a:srgbClr val="192D3E"/>
+                </a:solidFill>
+                <a:latin typeface="Arial"/>
+              </a:rPr>
+              <a:t>Adaptador</a:t>
+            </a:r>
+          </a:p>
+          <a:p>
+            <a:pPr algn="ctr"/>
+            <a:r>
+              <a:rPr sz="1300">
+                <a:solidFill>
+                  <a:srgbClr val="192D3E"/>
+                </a:solidFill>
+                <a:latin typeface="Arial"/>
+              </a:rPr>
+              <a:t>classe que implementa aquesta interfície</a:t>
             </a:r>
           </a:p>
         </p:txBody>

</xml_diff>

<commit_message>
docs: shorten speaker notes for defense deck
</commit_message>
<xml_diff>
--- a/doc/presentations/defensa-placa-permanent-dsi-ports-sortida-hexagonal/output/IMPORTANTE_MANUAL_defensa-dsi-ports-sortida-hexagonal.pptx
+++ b/doc/presentations/defensa-placa-permanent-dsi-ports-sortida-hexagonal/output/IMPORTANTE_MANUAL_defensa-dsi-ports-sortida-hexagonal.pptx
@@ -219,7 +219,7 @@
           <a:p>
             <a:fld id="{0ABAC575-8351-9441-AF95-237B22BB45B7}" type="datetimeFigureOut">
               <a:rPr lang="es-ES" smtClean="0"/>
-              <a:t>3/7/26</a:t>
+              <a:t>4/7/26</a:t>
             </a:fld>
             <a:endParaRPr lang="es-ES"/>
           </a:p>
@@ -531,15 +531,323 @@
           <a:lstStyle/>
           <a:p>
             <a:r>
-              <a:t>PICA és la Plataforma d’Integració i Col·laboració Administrativa de la Generalitat. És una plataforma corporativa d’interoperabilitat que permet l’accés a informació d’organismes de la Generalitat, altres administracions públiques i institucions, i també facilita la integració entre sistemes d’informació departamentals i la plataforma de tramitació corporativa.</a:t>
-            </a:r>
-          </a:p>
-          <a:p>
-            <a:endParaRPr/>
-          </a:p>
-          <a:p>
-            <a:r>
-              <a:t>Per a aquesta classe, la idea important és funcional: el procediment necessita informació administrativa fiable; no necessita dependre d’una API concreta en el llenguatge del cas d’ús.</a:t>
+              <a:rPr lang="ca-ES"/>
+              <a:t>Context: classe de DSI, no panoràmica completa.</a:t>
+            </a:r>
+          </a:p>
+          <a:p>
+            <a:r>
+              <a:rPr lang="ca-ES"/>
+              <a:t>Cas real acreditat: consultoria Generalitat / AGAUR.</a:t>
+            </a:r>
+          </a:p>
+          <a:p>
+            <a:r>
+              <a:rPr lang="ca-ES"/>
+              <a:t>Idea: trobada entre dimensió acadèmica i professional.</a:t>
+            </a:r>
+          </a:p>
+          <a:p>
+            <a:r>
+              <a:rPr lang="ca-ES"/>
+              <a:t>Focus: ports de sortida quan cal informació externa.</a:t>
+            </a:r>
+          </a:p>
+          <a:p>
+            <a:r>
+              <a:rPr lang="ca-ES"/>
+              <a:t>Transició: situar la sessió dins l’assignatura.</a:t>
+            </a:r>
+          </a:p>
+        </p:txBody>
+      </p:sp>
+      <p:sp>
+        <p:nvSpPr>
+          <p:cNvPr id="4" name="Slide Number Placeholder 3"/>
+          <p:cNvSpPr>
+            <a:spLocks noGrp="1"/>
+          </p:cNvSpPr>
+          <p:nvPr>
+            <p:ph type="sldNum" sz="quarter" idx="5"/>
+          </p:nvPr>
+        </p:nvSpPr>
+        <p:spPr/>
+      </p:sp>
+    </p:spTree>
+  </p:cSld>
+  <p:clrMapOvr>
+    <a:masterClrMapping/>
+  </p:clrMapOvr>
+</p:notes>
+</file>
+
+<file path=ppt/notesSlides/notesSlide10.xml><?xml version="1.0" encoding="utf-8"?>
+<p:notes xmlns:a="http://schemas.openxmlformats.org/drawingml/2006/main" xmlns:r="http://schemas.openxmlformats.org/officeDocument/2006/relationships" xmlns:p="http://schemas.openxmlformats.org/presentationml/2006/main">
+  <p:cSld>
+    <p:spTree>
+      <p:nvGrpSpPr>
+        <p:cNvPr id="1" name=""/>
+        <p:cNvGrpSpPr/>
+        <p:nvPr/>
+      </p:nvGrpSpPr>
+      <p:grpSpPr>
+        <a:xfrm>
+          <a:off x="0" y="0"/>
+          <a:ext cx="0" cy="0"/>
+          <a:chOff x="0" y="0"/>
+          <a:chExt cx="0" cy="0"/>
+        </a:xfrm>
+      </p:grpSpPr>
+      <p:sp>
+        <p:nvSpPr>
+          <p:cNvPr id="2" name="Slide Image Placeholder 1"/>
+          <p:cNvSpPr>
+            <a:spLocks noGrp="1" noRot="1" noChangeAspect="1"/>
+          </p:cNvSpPr>
+          <p:nvPr>
+            <p:ph type="sldImg" idx="2"/>
+          </p:nvPr>
+        </p:nvSpPr>
+        <p:spPr/>
+      </p:sp>
+      <p:sp>
+        <p:nvSpPr>
+          <p:cNvPr id="3" name="Notes Placeholder 2"/>
+          <p:cNvSpPr>
+            <a:spLocks noGrp="1"/>
+          </p:cNvSpPr>
+          <p:nvPr>
+            <p:ph type="body" sz="quarter" idx="3"/>
+          </p:nvPr>
+        </p:nvSpPr>
+        <p:spPr/>
+        <p:txBody>
+          <a:bodyPr/>
+          <a:lstStyle/>
+          <a:p>
+            <a:r>
+              <a:rPr lang="ca-ES"/>
+              <a:t>Diagrama de seqüència = flux temporal.</a:t>
+            </a:r>
+          </a:p>
+          <a:p>
+            <a:r>
+              <a:rPr lang="ca-ES"/>
+              <a:t>Controller -&gt; port d’entrada -&gt; servei d’aplicació.</a:t>
+            </a:r>
+          </a:p>
+          <a:p>
+            <a:r>
+              <a:rPr lang="ca-ES"/>
+              <a:t>El servei coordina: portfolio, preu, domini.</a:t>
+            </a:r>
+          </a:p>
+          <a:p>
+            <a:r>
+              <a:rPr lang="ca-ES"/>
+              <a:t>El domini decideix la venda; l’adaptador integra.</a:t>
+            </a:r>
+          </a:p>
+          <a:p>
+            <a:r>
+              <a:rPr lang="ca-ES"/>
+              <a:t>Frase clau: servei coordina, domini decideix, adaptador integra.</a:t>
+            </a:r>
+          </a:p>
+          <a:p>
+            <a:r>
+              <a:rPr lang="ca-ES"/>
+              <a:t>Transició: tancament conceptual.</a:t>
+            </a:r>
+          </a:p>
+        </p:txBody>
+      </p:sp>
+      <p:sp>
+        <p:nvSpPr>
+          <p:cNvPr id="4" name="Slide Number Placeholder 3"/>
+          <p:cNvSpPr>
+            <a:spLocks noGrp="1"/>
+          </p:cNvSpPr>
+          <p:nvPr>
+            <p:ph type="sldNum" sz="quarter" idx="5"/>
+          </p:nvPr>
+        </p:nvSpPr>
+        <p:spPr/>
+      </p:sp>
+    </p:spTree>
+  </p:cSld>
+  <p:clrMapOvr>
+    <a:masterClrMapping/>
+  </p:clrMapOvr>
+</p:notes>
+</file>
+
+<file path=ppt/notesSlides/notesSlide11.xml><?xml version="1.0" encoding="utf-8"?>
+<p:notes xmlns:a="http://schemas.openxmlformats.org/drawingml/2006/main" xmlns:r="http://schemas.openxmlformats.org/officeDocument/2006/relationships" xmlns:p="http://schemas.openxmlformats.org/presentationml/2006/main">
+  <p:cSld>
+    <p:spTree>
+      <p:nvGrpSpPr>
+        <p:cNvPr id="1" name=""/>
+        <p:cNvGrpSpPr/>
+        <p:nvPr/>
+      </p:nvGrpSpPr>
+      <p:grpSpPr>
+        <a:xfrm>
+          <a:off x="0" y="0"/>
+          <a:ext cx="0" cy="0"/>
+          <a:chOff x="0" y="0"/>
+          <a:chExt cx="0" cy="0"/>
+        </a:xfrm>
+      </p:grpSpPr>
+      <p:sp>
+        <p:nvSpPr>
+          <p:cNvPr id="2" name="Slide Image Placeholder 1"/>
+          <p:cNvSpPr>
+            <a:spLocks noGrp="1" noRot="1" noChangeAspect="1"/>
+          </p:cNvSpPr>
+          <p:nvPr>
+            <p:ph type="sldImg" idx="2"/>
+          </p:nvPr>
+        </p:nvSpPr>
+        <p:spPr/>
+      </p:sp>
+      <p:sp>
+        <p:nvSpPr>
+          <p:cNvPr id="3" name="Notes Placeholder 2"/>
+          <p:cNvSpPr>
+            <a:spLocks noGrp="1"/>
+          </p:cNvSpPr>
+          <p:nvPr>
+            <p:ph type="body" sz="quarter" idx="3"/>
+          </p:nvPr>
+        </p:nvSpPr>
+        <p:spPr/>
+        <p:txBody>
+          <a:bodyPr/>
+          <a:lstStyle/>
+          <a:p>
+            <a:r>
+              <a:rPr lang="ca-ES"/>
+              <a:t>Tancament: l’arquitectura no elimina el canvi; el localitza.</a:t>
+            </a:r>
+          </a:p>
+          <a:p>
+            <a:r>
+              <a:rPr lang="ca-ES"/>
+              <a:t>Quan canvia proveïdor o API, volem canviar l’adaptador.</a:t>
+            </a:r>
+          </a:p>
+          <a:p>
+            <a:r>
+              <a:rPr lang="ca-ES"/>
+              <a:t>No reescriure cas d’ús ni deformar domini.</a:t>
+            </a:r>
+          </a:p>
+          <a:p>
+            <a:r>
+              <a:rPr lang="ca-ES"/>
+              <a:t>Agrair TecnoCampus i Dr. Josep Roure.</a:t>
+            </a:r>
+          </a:p>
+          <a:p>
+            <a:r>
+              <a:rPr lang="ca-ES"/>
+              <a:t>Tancar mirant el tribunal: Moltes gràcies.</a:t>
+            </a:r>
+          </a:p>
+        </p:txBody>
+      </p:sp>
+      <p:sp>
+        <p:nvSpPr>
+          <p:cNvPr id="4" name="Slide Number Placeholder 3"/>
+          <p:cNvSpPr>
+            <a:spLocks noGrp="1"/>
+          </p:cNvSpPr>
+          <p:nvPr>
+            <p:ph type="sldNum" sz="quarter" idx="5"/>
+          </p:nvPr>
+        </p:nvSpPr>
+        <p:spPr/>
+      </p:sp>
+    </p:spTree>
+  </p:cSld>
+  <p:clrMapOvr>
+    <a:masterClrMapping/>
+  </p:clrMapOvr>
+</p:notes>
+</file>
+
+<file path=ppt/notesSlides/notesSlide12.xml><?xml version="1.0" encoding="utf-8"?>
+<p:notes xmlns:a="http://schemas.openxmlformats.org/drawingml/2006/main" xmlns:r="http://schemas.openxmlformats.org/officeDocument/2006/relationships" xmlns:p="http://schemas.openxmlformats.org/presentationml/2006/main">
+  <p:cSld>
+    <p:spTree>
+      <p:nvGrpSpPr>
+        <p:cNvPr id="1" name=""/>
+        <p:cNvGrpSpPr/>
+        <p:nvPr/>
+      </p:nvGrpSpPr>
+      <p:grpSpPr>
+        <a:xfrm>
+          <a:off x="0" y="0"/>
+          <a:ext cx="0" cy="0"/>
+          <a:chOff x="0" y="0"/>
+          <a:chExt cx="0" cy="0"/>
+        </a:xfrm>
+      </p:grpSpPr>
+      <p:sp>
+        <p:nvSpPr>
+          <p:cNvPr id="2" name="Slide Image Placeholder 1"/>
+          <p:cNvSpPr>
+            <a:spLocks noGrp="1" noRot="1" noChangeAspect="1"/>
+          </p:cNvSpPr>
+          <p:nvPr>
+            <p:ph type="sldImg" idx="2"/>
+          </p:nvPr>
+        </p:nvSpPr>
+        <p:spPr/>
+      </p:sp>
+      <p:sp>
+        <p:nvSpPr>
+          <p:cNvPr id="3" name="Notes Placeholder 2"/>
+          <p:cNvSpPr>
+            <a:spLocks noGrp="1"/>
+          </p:cNvSpPr>
+          <p:nvPr>
+            <p:ph type="body" sz="quarter" idx="3"/>
+          </p:nvPr>
+        </p:nvSpPr>
+        <p:spPr/>
+        <p:txBody>
+          <a:bodyPr/>
+          <a:lstStyle/>
+          <a:p>
+            <a:r>
+              <a:rPr lang="ca-ES"/>
+              <a:t>Annex opcional: només si el tribunal ho demana o queda temps clar.</a:t>
+            </a:r>
+          </a:p>
+          <a:p>
+            <a:r>
+              <a:rPr lang="ca-ES"/>
+              <a:t>No forma part del cos principal de 20 minuts.</a:t>
+            </a:r>
+          </a:p>
+          <a:p>
+            <a:r>
+              <a:rPr lang="ca-ES"/>
+              <a:t>Missatge demo: mateix cas d’ús, servei i domini.</a:t>
+            </a:r>
+          </a:p>
+          <a:p>
+            <a:r>
+              <a:rPr lang="ca-ES"/>
+              <a:t>Canvia l’adaptador: Finnhub, Alpha Vantage o mock.</a:t>
+            </a:r>
+          </a:p>
+          <a:p>
+            <a:r>
+              <a:rPr lang="ca-ES"/>
+              <a:t>Objectiu docent: contracte estable, infraestructura substituïble.</a:t>
             </a:r>
           </a:p>
         </p:txBody>
@@ -609,23 +917,709 @@
           <a:lstStyle/>
           <a:p>
             <a:r>
-              <a:t>PICA és la Plataforma d’Integració i Col·laboració Administrativa de la Generalitat. És una plataforma corporativa d’interoperabilitat que permet accedir a informació d’altres administracions i integrar sistemes departamentals amb la tramitació corporativa.</a:t>
-            </a:r>
-          </a:p>
-          <a:p>
-            <a:endParaRPr/>
-          </a:p>
-          <a:p>
-            <a:r>
-              <a:t>Aquí és important no presentar PICA com el problema. PICA és una plataforma corporativa d’interoperabilitat. El problema arquitectònic és que el cas d’ús o la lògica del procediment administratiu depenguin directament dels detalls tècnics de la integració, com SOAP/XML, DTOs o clients específics.</a:t>
-            </a:r>
-          </a:p>
-          <a:p>
-            <a:endParaRPr/>
-          </a:p>
-          <a:p>
-            <a:r>
-              <a:t>En el context de la consultoria a AGAUR, el problema no era consumir PICA. El problema era que part de la lògica del procediment administratiu quedava massa vinculada a crides SOAP/XML i a detalls tècnics d’integració. Si en el futur el mecanisme corporatiu d’interoperabilitat evoluciona cap a REST, API Manager o altres models, aquest acoblament genera un risc molt alt de manteniment i continuïtat operativa.</a:t>
+              <a:rPr lang="ca-ES" dirty="0"/>
+              <a:t>Situar: DSI, tercer curs, 6 ECTS.</a:t>
+            </a:r>
+          </a:p>
+          <a:p>
+            <a:r>
+              <a:rPr lang="ca-ES" dirty="0"/>
+              <a:t>El temari inclou arquitectura hexagonal, ports i adaptadors.</a:t>
+            </a:r>
+          </a:p>
+          <a:p>
+            <a:r>
+              <a:rPr lang="ca-ES" dirty="0"/>
+              <a:t>Encaixa en el pla docent.</a:t>
+            </a:r>
+          </a:p>
+          <a:p>
+            <a:r>
+              <a:rPr lang="ca-ES" dirty="0"/>
+              <a:t>Focus limitat: port de sortida.</a:t>
+            </a:r>
+          </a:p>
+          <a:p>
+            <a:r>
+              <a:rPr lang="ca-ES" dirty="0"/>
+              <a:t>Transició: formular l’objectiu de treball.</a:t>
+            </a:r>
+          </a:p>
+        </p:txBody>
+      </p:sp>
+      <p:sp>
+        <p:nvSpPr>
+          <p:cNvPr id="4" name="Slide Number Placeholder 3"/>
+          <p:cNvSpPr>
+            <a:spLocks noGrp="1"/>
+          </p:cNvSpPr>
+          <p:nvPr>
+            <p:ph type="sldNum" sz="quarter" idx="5"/>
+          </p:nvPr>
+        </p:nvSpPr>
+        <p:spPr/>
+      </p:sp>
+    </p:spTree>
+  </p:cSld>
+  <p:clrMapOvr>
+    <a:masterClrMapping/>
+  </p:clrMapOvr>
+</p:notes>
+</file>
+
+<file path=ppt/notesSlides/notesSlide3.xml><?xml version="1.0" encoding="utf-8"?>
+<p:notes xmlns:a="http://schemas.openxmlformats.org/drawingml/2006/main" xmlns:r="http://schemas.openxmlformats.org/officeDocument/2006/relationships" xmlns:p="http://schemas.openxmlformats.org/presentationml/2006/main">
+  <p:cSld>
+    <p:spTree>
+      <p:nvGrpSpPr>
+        <p:cNvPr id="1" name=""/>
+        <p:cNvGrpSpPr/>
+        <p:nvPr/>
+      </p:nvGrpSpPr>
+      <p:grpSpPr>
+        <a:xfrm>
+          <a:off x="0" y="0"/>
+          <a:ext cx="0" cy="0"/>
+          <a:chOff x="0" y="0"/>
+          <a:chExt cx="0" cy="0"/>
+        </a:xfrm>
+      </p:grpSpPr>
+      <p:sp>
+        <p:nvSpPr>
+          <p:cNvPr id="2" name="Slide Image Placeholder 1"/>
+          <p:cNvSpPr>
+            <a:spLocks noGrp="1" noRot="1" noChangeAspect="1"/>
+          </p:cNvSpPr>
+          <p:nvPr>
+            <p:ph type="sldImg" idx="2"/>
+          </p:nvPr>
+        </p:nvSpPr>
+        <p:spPr/>
+      </p:sp>
+      <p:sp>
+        <p:nvSpPr>
+          <p:cNvPr id="3" name="Notes Placeholder 2"/>
+          <p:cNvSpPr>
+            <a:spLocks noGrp="1"/>
+          </p:cNvSpPr>
+          <p:nvPr>
+            <p:ph type="body" sz="quarter" idx="3"/>
+          </p:nvPr>
+        </p:nvSpPr>
+        <p:spPr/>
+        <p:txBody>
+          <a:bodyPr/>
+          <a:lstStyle/>
+          <a:p>
+            <a:r>
+              <a:rPr lang="ca-ES"/>
+              <a:t>Frase clau: capacitat, no tecnologia específica.</a:t>
+            </a:r>
+          </a:p>
+          <a:p>
+            <a:r>
+              <a:rPr lang="ca-ES"/>
+              <a:t>Tres decisions: identificar necessitat, definir port, implementar adaptador.</a:t>
+            </a:r>
+          </a:p>
+          <a:p>
+            <a:r>
+              <a:rPr lang="ca-ES"/>
+              <a:t>No explicar encara tota l’abstracció.</a:t>
+            </a:r>
+          </a:p>
+          <a:p>
+            <a:r>
+              <a:rPr lang="ca-ES"/>
+              <a:t>Primer cas real, després decisió arquitectònica.</a:t>
+            </a:r>
+          </a:p>
+          <a:p>
+            <a:r>
+              <a:rPr lang="ca-ES"/>
+              <a:t>Transició: procediment administratiu de beca.</a:t>
+            </a:r>
+          </a:p>
+        </p:txBody>
+      </p:sp>
+      <p:sp>
+        <p:nvSpPr>
+          <p:cNvPr id="4" name="Slide Number Placeholder 3"/>
+          <p:cNvSpPr>
+            <a:spLocks noGrp="1"/>
+          </p:cNvSpPr>
+          <p:nvPr>
+            <p:ph type="sldNum" sz="quarter" idx="5"/>
+          </p:nvPr>
+        </p:nvSpPr>
+        <p:spPr/>
+      </p:sp>
+    </p:spTree>
+  </p:cSld>
+  <p:clrMapOvr>
+    <a:masterClrMapping/>
+  </p:clrMapOvr>
+</p:notes>
+</file>
+
+<file path=ppt/notesSlides/notesSlide4.xml><?xml version="1.0" encoding="utf-8"?>
+<p:notes xmlns:a="http://schemas.openxmlformats.org/drawingml/2006/main" xmlns:r="http://schemas.openxmlformats.org/officeDocument/2006/relationships" xmlns:p="http://schemas.openxmlformats.org/presentationml/2006/main">
+  <p:cSld>
+    <p:spTree>
+      <p:nvGrpSpPr>
+        <p:cNvPr id="1" name=""/>
+        <p:cNvGrpSpPr/>
+        <p:nvPr/>
+      </p:nvGrpSpPr>
+      <p:grpSpPr>
+        <a:xfrm>
+          <a:off x="0" y="0"/>
+          <a:ext cx="0" cy="0"/>
+          <a:chOff x="0" y="0"/>
+          <a:chExt cx="0" cy="0"/>
+        </a:xfrm>
+      </p:grpSpPr>
+      <p:sp>
+        <p:nvSpPr>
+          <p:cNvPr id="2" name="Slide Image Placeholder 1"/>
+          <p:cNvSpPr>
+            <a:spLocks noGrp="1" noRot="1" noChangeAspect="1"/>
+          </p:cNvSpPr>
+          <p:nvPr>
+            <p:ph type="sldImg" idx="2"/>
+          </p:nvPr>
+        </p:nvSpPr>
+        <p:spPr/>
+      </p:sp>
+      <p:sp>
+        <p:nvSpPr>
+          <p:cNvPr id="3" name="Notes Placeholder 2"/>
+          <p:cNvSpPr>
+            <a:spLocks noGrp="1"/>
+          </p:cNvSpPr>
+          <p:nvPr>
+            <p:ph type="body" sz="quarter" idx="3"/>
+          </p:nvPr>
+        </p:nvSpPr>
+        <p:spPr/>
+        <p:txBody>
+          <a:bodyPr/>
+          <a:lstStyle/>
+          <a:p>
+            <a:r>
+              <a:rPr lang="ca-ES" dirty="0"/>
+              <a:t>Primer entendre el procediment; després la tecnologia.</a:t>
+            </a:r>
+          </a:p>
+          <a:p>
+            <a:r>
+              <a:rPr lang="ca-ES" dirty="0"/>
+              <a:t>Sol·licitud -&gt; expedient -&gt; requisits -&gt; resolució.</a:t>
+            </a:r>
+          </a:p>
+          <a:p>
+            <a:r>
+              <a:rPr lang="ca-ES" dirty="0"/>
+              <a:t>Avaluació econòmica: renda i patrimoni.</a:t>
+            </a:r>
+          </a:p>
+          <a:p>
+            <a:r>
+              <a:rPr lang="ca-ES" dirty="0"/>
+              <a:t>Encara no parlar de SOAP, REST o BD.</a:t>
+            </a:r>
+          </a:p>
+          <a:p>
+            <a:r>
+              <a:rPr lang="ca-ES" dirty="0"/>
+              <a:t>Transició: quina informació externa cal?</a:t>
+            </a:r>
+          </a:p>
+        </p:txBody>
+      </p:sp>
+      <p:sp>
+        <p:nvSpPr>
+          <p:cNvPr id="4" name="Slide Number Placeholder 3"/>
+          <p:cNvSpPr>
+            <a:spLocks noGrp="1"/>
+          </p:cNvSpPr>
+          <p:nvPr>
+            <p:ph type="sldNum" sz="quarter" idx="5"/>
+          </p:nvPr>
+        </p:nvSpPr>
+        <p:spPr/>
+      </p:sp>
+    </p:spTree>
+  </p:cSld>
+  <p:clrMapOvr>
+    <a:masterClrMapping/>
+  </p:clrMapOvr>
+</p:notes>
+</file>
+
+<file path=ppt/notesSlides/notesSlide5.xml><?xml version="1.0" encoding="utf-8"?>
+<p:notes xmlns:a="http://schemas.openxmlformats.org/drawingml/2006/main" xmlns:r="http://schemas.openxmlformats.org/officeDocument/2006/relationships" xmlns:p="http://schemas.openxmlformats.org/presentationml/2006/main">
+  <p:cSld>
+    <p:spTree>
+      <p:nvGrpSpPr>
+        <p:cNvPr id="1" name=""/>
+        <p:cNvGrpSpPr/>
+        <p:nvPr/>
+      </p:nvGrpSpPr>
+      <p:grpSpPr>
+        <a:xfrm>
+          <a:off x="0" y="0"/>
+          <a:ext cx="0" cy="0"/>
+          <a:chOff x="0" y="0"/>
+          <a:chExt cx="0" cy="0"/>
+        </a:xfrm>
+      </p:grpSpPr>
+      <p:sp>
+        <p:nvSpPr>
+          <p:cNvPr id="2" name="Slide Image Placeholder 1"/>
+          <p:cNvSpPr>
+            <a:spLocks noGrp="1" noRot="1" noChangeAspect="1"/>
+          </p:cNvSpPr>
+          <p:nvPr>
+            <p:ph type="sldImg" idx="2"/>
+          </p:nvPr>
+        </p:nvSpPr>
+        <p:spPr/>
+      </p:sp>
+      <p:sp>
+        <p:nvSpPr>
+          <p:cNvPr id="3" name="Notes Placeholder 2"/>
+          <p:cNvSpPr>
+            <a:spLocks noGrp="1"/>
+          </p:cNvSpPr>
+          <p:nvPr>
+            <p:ph type="body" sz="quarter" idx="3"/>
+          </p:nvPr>
+        </p:nvSpPr>
+        <p:spPr/>
+        <p:txBody>
+          <a:bodyPr/>
+          <a:lstStyle/>
+          <a:p>
+            <a:r>
+              <a:rPr lang="ca-ES"/>
+              <a:t>Necessitat funcional: informació fiable de renda i patrimoni.</a:t>
+            </a:r>
+          </a:p>
+          <a:p>
+            <a:r>
+              <a:rPr lang="ca-ES"/>
+              <a:t>Fonts possibles: AEAT, Cadastre, PICA.</a:t>
+            </a:r>
+          </a:p>
+          <a:p>
+            <a:r>
+              <a:rPr lang="ca-ES"/>
+              <a:t>PICA = interoperabilitat administrativa, no “el problema”.</a:t>
+            </a:r>
+          </a:p>
+          <a:p>
+            <a:r>
+              <a:rPr lang="ca-ES"/>
+              <a:t>Frase clau: informació administrativa, no API concreta.</a:t>
+            </a:r>
+          </a:p>
+          <a:p>
+            <a:r>
+              <a:rPr lang="ca-ES"/>
+              <a:t>Transició: què passa si el cas d’ús coneix la integració?</a:t>
+            </a:r>
+          </a:p>
+        </p:txBody>
+      </p:sp>
+      <p:sp>
+        <p:nvSpPr>
+          <p:cNvPr id="4" name="Slide Number Placeholder 3"/>
+          <p:cNvSpPr>
+            <a:spLocks noGrp="1"/>
+          </p:cNvSpPr>
+          <p:nvPr>
+            <p:ph type="sldNum" sz="quarter" idx="5"/>
+          </p:nvPr>
+        </p:nvSpPr>
+        <p:spPr/>
+      </p:sp>
+    </p:spTree>
+  </p:cSld>
+  <p:clrMapOvr>
+    <a:masterClrMapping/>
+  </p:clrMapOvr>
+</p:notes>
+</file>
+
+<file path=ppt/notesSlides/notesSlide6.xml><?xml version="1.0" encoding="utf-8"?>
+<p:notes xmlns:a="http://schemas.openxmlformats.org/drawingml/2006/main" xmlns:r="http://schemas.openxmlformats.org/officeDocument/2006/relationships" xmlns:p="http://schemas.openxmlformats.org/presentationml/2006/main">
+  <p:cSld>
+    <p:spTree>
+      <p:nvGrpSpPr>
+        <p:cNvPr id="1" name=""/>
+        <p:cNvGrpSpPr/>
+        <p:nvPr/>
+      </p:nvGrpSpPr>
+      <p:grpSpPr>
+        <a:xfrm>
+          <a:off x="0" y="0"/>
+          <a:ext cx="0" cy="0"/>
+          <a:chOff x="0" y="0"/>
+          <a:chExt cx="0" cy="0"/>
+        </a:xfrm>
+      </p:grpSpPr>
+      <p:sp>
+        <p:nvSpPr>
+          <p:cNvPr id="2" name="Slide Image Placeholder 1"/>
+          <p:cNvSpPr>
+            <a:spLocks noGrp="1" noRot="1" noChangeAspect="1"/>
+          </p:cNvSpPr>
+          <p:nvPr>
+            <p:ph type="sldImg" idx="2"/>
+          </p:nvPr>
+        </p:nvSpPr>
+        <p:spPr/>
+      </p:sp>
+      <p:sp>
+        <p:nvSpPr>
+          <p:cNvPr id="3" name="Notes Placeholder 2"/>
+          <p:cNvSpPr>
+            <a:spLocks noGrp="1"/>
+          </p:cNvSpPr>
+          <p:nvPr>
+            <p:ph type="body" sz="quarter" idx="3"/>
+          </p:nvPr>
+        </p:nvSpPr>
+        <p:spPr/>
+        <p:txBody>
+          <a:bodyPr/>
+          <a:lstStyle/>
+          <a:p>
+            <a:r>
+              <a:rPr lang="ca-ES"/>
+              <a:t>Problema: acoblament directe amb detalls tècnics.</a:t>
+            </a:r>
+          </a:p>
+          <a:p>
+            <a:r>
+              <a:rPr lang="ca-ES"/>
+              <a:t>El cas d’ús acaba coneixent SOAP/XML, DTOs, clients i errors.</a:t>
+            </a:r>
+          </a:p>
+          <a:p>
+            <a:r>
+              <a:rPr lang="ca-ES"/>
+              <a:t>Si canvia la integració, el canvi travessa el cas d’ús.</a:t>
+            </a:r>
+          </a:p>
+          <a:p>
+            <a:r>
+              <a:rPr lang="ca-ES"/>
+              <a:t>Riscos: manteniment fràgil i continuïtat operativa.</a:t>
+            </a:r>
+          </a:p>
+          <a:p>
+            <a:r>
+              <a:rPr lang="ca-ES"/>
+              <a:t>Transició: resposta arquitectònica, port de sortida.</a:t>
+            </a:r>
+          </a:p>
+        </p:txBody>
+      </p:sp>
+      <p:sp>
+        <p:nvSpPr>
+          <p:cNvPr id="4" name="Slide Number Placeholder 3"/>
+          <p:cNvSpPr>
+            <a:spLocks noGrp="1"/>
+          </p:cNvSpPr>
+          <p:nvPr>
+            <p:ph type="sldNum" sz="quarter" idx="5"/>
+          </p:nvPr>
+        </p:nvSpPr>
+        <p:spPr/>
+      </p:sp>
+    </p:spTree>
+  </p:cSld>
+  <p:clrMapOvr>
+    <a:masterClrMapping/>
+  </p:clrMapOvr>
+</p:notes>
+</file>
+
+<file path=ppt/notesSlides/notesSlide7.xml><?xml version="1.0" encoding="utf-8"?>
+<p:notes xmlns:a="http://schemas.openxmlformats.org/drawingml/2006/main" xmlns:r="http://schemas.openxmlformats.org/officeDocument/2006/relationships" xmlns:p="http://schemas.openxmlformats.org/presentationml/2006/main">
+  <p:cSld>
+    <p:spTree>
+      <p:nvGrpSpPr>
+        <p:cNvPr id="1" name=""/>
+        <p:cNvGrpSpPr/>
+        <p:nvPr/>
+      </p:nvGrpSpPr>
+      <p:grpSpPr>
+        <a:xfrm>
+          <a:off x="0" y="0"/>
+          <a:ext cx="0" cy="0"/>
+          <a:chOff x="0" y="0"/>
+          <a:chExt cx="0" cy="0"/>
+        </a:xfrm>
+      </p:grpSpPr>
+      <p:sp>
+        <p:nvSpPr>
+          <p:cNvPr id="2" name="Slide Image Placeholder 1"/>
+          <p:cNvSpPr>
+            <a:spLocks noGrp="1" noRot="1" noChangeAspect="1"/>
+          </p:cNvSpPr>
+          <p:nvPr>
+            <p:ph type="sldImg" idx="2"/>
+          </p:nvPr>
+        </p:nvSpPr>
+        <p:spPr/>
+      </p:sp>
+      <p:sp>
+        <p:nvSpPr>
+          <p:cNvPr id="3" name="Notes Placeholder 2"/>
+          <p:cNvSpPr>
+            <a:spLocks noGrp="1"/>
+          </p:cNvSpPr>
+          <p:nvPr>
+            <p:ph type="body" sz="quarter" idx="3"/>
+          </p:nvPr>
+        </p:nvSpPr>
+        <p:spPr/>
+        <p:txBody>
+          <a:bodyPr/>
+          <a:lstStyle/>
+          <a:p>
+            <a:r>
+              <a:rPr lang="ca-ES"/>
+              <a:t>Distingir dues fletxes: flux i dependència de codi.</a:t>
+            </a:r>
+          </a:p>
+          <a:p>
+            <a:r>
+              <a:rPr lang="ca-ES"/>
+              <a:t>Flux: el cas d’ús demana informació cap enfora.</a:t>
+            </a:r>
+          </a:p>
+          <a:p>
+            <a:r>
+              <a:rPr lang="ca-ES"/>
+              <a:t>Dependència: cas d’ús -&gt; port; adaptador -&gt; port.</a:t>
+            </a:r>
+          </a:p>
+          <a:p>
+            <a:r>
+              <a:rPr lang="ca-ES"/>
+              <a:t>Java: port = interfície; adaptador = classe que la implementa.</a:t>
+            </a:r>
+          </a:p>
+          <a:p>
+            <a:r>
+              <a:rPr lang="ca-ES"/>
+              <a:t>Frase clau: la infraestructura depèn del port de l’aplicació.</a:t>
+            </a:r>
+          </a:p>
+          <a:p>
+            <a:r>
+              <a:rPr lang="ca-ES"/>
+              <a:t>Transició: aplicar-ho al cas patrimonial.</a:t>
+            </a:r>
+          </a:p>
+        </p:txBody>
+      </p:sp>
+      <p:sp>
+        <p:nvSpPr>
+          <p:cNvPr id="4" name="Slide Number Placeholder 3"/>
+          <p:cNvSpPr>
+            <a:spLocks noGrp="1"/>
+          </p:cNvSpPr>
+          <p:nvPr>
+            <p:ph type="sldNum" sz="quarter" idx="5"/>
+          </p:nvPr>
+        </p:nvSpPr>
+        <p:spPr/>
+      </p:sp>
+    </p:spTree>
+  </p:cSld>
+  <p:clrMapOvr>
+    <a:masterClrMapping/>
+  </p:clrMapOvr>
+</p:notes>
+</file>
+
+<file path=ppt/notesSlides/notesSlide8.xml><?xml version="1.0" encoding="utf-8"?>
+<p:notes xmlns:a="http://schemas.openxmlformats.org/drawingml/2006/main" xmlns:r="http://schemas.openxmlformats.org/officeDocument/2006/relationships" xmlns:p="http://schemas.openxmlformats.org/presentationml/2006/main">
+  <p:cSld>
+    <p:spTree>
+      <p:nvGrpSpPr>
+        <p:cNvPr id="1" name=""/>
+        <p:cNvGrpSpPr/>
+        <p:nvPr/>
+      </p:nvGrpSpPr>
+      <p:grpSpPr>
+        <a:xfrm>
+          <a:off x="0" y="0"/>
+          <a:ext cx="0" cy="0"/>
+          <a:chOff x="0" y="0"/>
+          <a:chExt cx="0" cy="0"/>
+        </a:xfrm>
+      </p:grpSpPr>
+      <p:sp>
+        <p:nvSpPr>
+          <p:cNvPr id="2" name="Slide Image Placeholder 1"/>
+          <p:cNvSpPr>
+            <a:spLocks noGrp="1" noRot="1" noChangeAspect="1"/>
+          </p:cNvSpPr>
+          <p:nvPr>
+            <p:ph type="sldImg" idx="2"/>
+          </p:nvPr>
+        </p:nvSpPr>
+        <p:spPr/>
+      </p:sp>
+      <p:sp>
+        <p:nvSpPr>
+          <p:cNvPr id="3" name="Notes Placeholder 2"/>
+          <p:cNvSpPr>
+            <a:spLocks noGrp="1"/>
+          </p:cNvSpPr>
+          <p:nvPr>
+            <p:ph type="body" sz="quarter" idx="3"/>
+          </p:nvPr>
+        </p:nvSpPr>
+        <p:spPr/>
+        <p:txBody>
+          <a:bodyPr/>
+          <a:lstStyle/>
+          <a:p>
+            <a:r>
+              <a:rPr lang="ca-ES"/>
+              <a:t>Servei d’aplicació depèn de contractes propis.</a:t>
+            </a:r>
+          </a:p>
+          <a:p>
+            <a:r>
+              <a:rPr lang="ca-ES"/>
+              <a:t>Ports dins del llenguatge de l’aplicació.</a:t>
+            </a:r>
+          </a:p>
+          <a:p>
+            <a:r>
+              <a:rPr lang="ca-ES"/>
+              <a:t>Adaptadors fora del nucli: PICA, JDBC, REST, SOAP/XML.</a:t>
+            </a:r>
+          </a:p>
+          <a:p>
+            <a:r>
+              <a:rPr lang="ca-ES"/>
+              <a:t>Fletxa important: l’adaptador implementa el port.</a:t>
+            </a:r>
+          </a:p>
+          <a:p>
+            <a:r>
+              <a:rPr lang="ca-ES"/>
+              <a:t>Transició: mateix patró, canvi de domini.</a:t>
+            </a:r>
+          </a:p>
+        </p:txBody>
+      </p:sp>
+      <p:sp>
+        <p:nvSpPr>
+          <p:cNvPr id="4" name="Slide Number Placeholder 3"/>
+          <p:cNvSpPr>
+            <a:spLocks noGrp="1"/>
+          </p:cNvSpPr>
+          <p:nvPr>
+            <p:ph type="sldNum" sz="quarter" idx="5"/>
+          </p:nvPr>
+        </p:nvSpPr>
+        <p:spPr/>
+      </p:sp>
+    </p:spTree>
+  </p:cSld>
+  <p:clrMapOvr>
+    <a:masterClrMapping/>
+  </p:clrMapOvr>
+</p:notes>
+</file>
+
+<file path=ppt/notesSlides/notesSlide9.xml><?xml version="1.0" encoding="utf-8"?>
+<p:notes xmlns:a="http://schemas.openxmlformats.org/drawingml/2006/main" xmlns:r="http://schemas.openxmlformats.org/officeDocument/2006/relationships" xmlns:p="http://schemas.openxmlformats.org/presentationml/2006/main">
+  <p:cSld>
+    <p:spTree>
+      <p:nvGrpSpPr>
+        <p:cNvPr id="1" name=""/>
+        <p:cNvGrpSpPr/>
+        <p:nvPr/>
+      </p:nvGrpSpPr>
+      <p:grpSpPr>
+        <a:xfrm>
+          <a:off x="0" y="0"/>
+          <a:ext cx="0" cy="0"/>
+          <a:chOff x="0" y="0"/>
+          <a:chExt cx="0" cy="0"/>
+        </a:xfrm>
+      </p:grpSpPr>
+      <p:sp>
+        <p:nvSpPr>
+          <p:cNvPr id="2" name="Slide Image Placeholder 1"/>
+          <p:cNvSpPr>
+            <a:spLocks noGrp="1" noRot="1" noChangeAspect="1"/>
+          </p:cNvSpPr>
+          <p:nvPr>
+            <p:ph type="sldImg" idx="2"/>
+          </p:nvPr>
+        </p:nvSpPr>
+        <p:spPr/>
+      </p:sp>
+      <p:sp>
+        <p:nvSpPr>
+          <p:cNvPr id="3" name="Notes Placeholder 2"/>
+          <p:cNvSpPr>
+            <a:spLocks noGrp="1"/>
+          </p:cNvSpPr>
+          <p:nvPr>
+            <p:ph type="body" sz="quarter" idx="3"/>
+          </p:nvPr>
+        </p:nvSpPr>
+        <p:spPr/>
+        <p:txBody>
+          <a:bodyPr/>
+          <a:lstStyle/>
+          <a:p>
+            <a:r>
+              <a:rPr lang="ca-ES"/>
+              <a:t>Canvi explícit: beca -&gt; cartera d’inversió personal.</a:t>
+            </a:r>
+          </a:p>
+          <a:p>
+            <a:r>
+              <a:rPr lang="ca-ES"/>
+              <a:t>Cas d’ús: vendre accions.</a:t>
+            </a:r>
+          </a:p>
+          <a:p>
+            <a:r>
+              <a:rPr lang="ca-ES"/>
+              <a:t>Necessitat: preu actual de l’acció.</a:t>
+            </a:r>
+          </a:p>
+          <a:p>
+            <a:r>
+              <a:rPr lang="ca-ES"/>
+              <a:t>No dependre de proveïdor, API, endpoint o format.</a:t>
+            </a:r>
+          </a:p>
+          <a:p>
+            <a:r>
+              <a:rPr lang="ca-ES"/>
+              <a:t>Patró: necessitat -&gt; port -&gt; adaptador.</a:t>
+            </a:r>
+          </a:p>
+          <a:p>
+            <a:r>
+              <a:rPr lang="ca-ES"/>
+              <a:t>Transició: projecte concret HexaStock.</a:t>
             </a:r>
           </a:p>
         </p:txBody>
@@ -829,7 +1823,7 @@
           <a:p>
             <a:fld id="{5BCAD085-E8A6-8845-BD4E-CB4CCA059FC4}" type="datetimeFigureOut">
               <a:rPr lang="en-US" smtClean="0"/>
-              <a:t>7/3/26</a:t>
+              <a:t>7/4/26</a:t>
             </a:fld>
             <a:endParaRPr lang="en-US"/>
           </a:p>
@@ -997,7 +1991,7 @@
           <a:p>
             <a:fld id="{5BCAD085-E8A6-8845-BD4E-CB4CCA059FC4}" type="datetimeFigureOut">
               <a:rPr lang="en-US" smtClean="0"/>
-              <a:t>7/3/26</a:t>
+              <a:t>7/4/26</a:t>
             </a:fld>
             <a:endParaRPr lang="en-US"/>
           </a:p>
@@ -1175,7 +2169,7 @@
           <a:p>
             <a:fld id="{5BCAD085-E8A6-8845-BD4E-CB4CCA059FC4}" type="datetimeFigureOut">
               <a:rPr lang="en-US" smtClean="0"/>
-              <a:t>7/3/26</a:t>
+              <a:t>7/4/26</a:t>
             </a:fld>
             <a:endParaRPr lang="en-US"/>
           </a:p>
@@ -1343,7 +2337,7 @@
           <a:p>
             <a:fld id="{5BCAD085-E8A6-8845-BD4E-CB4CCA059FC4}" type="datetimeFigureOut">
               <a:rPr lang="en-US" smtClean="0"/>
-              <a:t>7/3/26</a:t>
+              <a:t>7/4/26</a:t>
             </a:fld>
             <a:endParaRPr lang="en-US"/>
           </a:p>
@@ -1588,7 +2582,7 @@
           <a:p>
             <a:fld id="{5BCAD085-E8A6-8845-BD4E-CB4CCA059FC4}" type="datetimeFigureOut">
               <a:rPr lang="en-US" smtClean="0"/>
-              <a:t>7/3/26</a:t>
+              <a:t>7/4/26</a:t>
             </a:fld>
             <a:endParaRPr lang="en-US"/>
           </a:p>
@@ -1873,7 +2867,7 @@
           <a:p>
             <a:fld id="{5BCAD085-E8A6-8845-BD4E-CB4CCA059FC4}" type="datetimeFigureOut">
               <a:rPr lang="en-US" smtClean="0"/>
-              <a:t>7/3/26</a:t>
+              <a:t>7/4/26</a:t>
             </a:fld>
             <a:endParaRPr lang="en-US"/>
           </a:p>
@@ -2292,7 +3286,7 @@
           <a:p>
             <a:fld id="{5BCAD085-E8A6-8845-BD4E-CB4CCA059FC4}" type="datetimeFigureOut">
               <a:rPr lang="en-US" smtClean="0"/>
-              <a:t>7/3/26</a:t>
+              <a:t>7/4/26</a:t>
             </a:fld>
             <a:endParaRPr lang="en-US"/>
           </a:p>
@@ -2409,7 +3403,7 @@
           <a:p>
             <a:fld id="{5BCAD085-E8A6-8845-BD4E-CB4CCA059FC4}" type="datetimeFigureOut">
               <a:rPr lang="en-US" smtClean="0"/>
-              <a:t>7/3/26</a:t>
+              <a:t>7/4/26</a:t>
             </a:fld>
             <a:endParaRPr lang="en-US"/>
           </a:p>
@@ -2504,7 +3498,7 @@
           <a:p>
             <a:fld id="{5BCAD085-E8A6-8845-BD4E-CB4CCA059FC4}" type="datetimeFigureOut">
               <a:rPr lang="en-US" smtClean="0"/>
-              <a:t>7/3/26</a:t>
+              <a:t>7/4/26</a:t>
             </a:fld>
             <a:endParaRPr lang="en-US"/>
           </a:p>
@@ -2779,7 +3773,7 @@
           <a:p>
             <a:fld id="{5BCAD085-E8A6-8845-BD4E-CB4CCA059FC4}" type="datetimeFigureOut">
               <a:rPr lang="en-US" smtClean="0"/>
-              <a:t>7/3/26</a:t>
+              <a:t>7/4/26</a:t>
             </a:fld>
             <a:endParaRPr lang="en-US"/>
           </a:p>
@@ -3031,7 +4025,7 @@
           <a:p>
             <a:fld id="{5BCAD085-E8A6-8845-BD4E-CB4CCA059FC4}" type="datetimeFigureOut">
               <a:rPr lang="en-US" smtClean="0"/>
-              <a:t>7/3/26</a:t>
+              <a:t>7/4/26</a:t>
             </a:fld>
             <a:endParaRPr lang="en-US"/>
           </a:p>
@@ -3242,7 +4236,7 @@
           <a:p>
             <a:fld id="{5BCAD085-E8A6-8845-BD4E-CB4CCA059FC4}" type="datetimeFigureOut">
               <a:rPr lang="en-US" smtClean="0"/>
-              <a:t>7/3/26</a:t>
+              <a:t>7/4/26</a:t>
             </a:fld>
             <a:endParaRPr lang="en-US"/>
           </a:p>
@@ -3626,7 +4620,7 @@
           <p:nvPr/>
         </p:nvPicPr>
         <p:blipFill>
-          <a:blip r:embed="rId2"/>
+          <a:blip r:embed="rId3"/>
           <a:stretch>
             <a:fillRect/>
           </a:stretch>
@@ -4320,7 +5314,7 @@
           <p:nvPr/>
         </p:nvPicPr>
         <p:blipFill>
-          <a:blip r:embed="rId2"/>
+          <a:blip r:embed="rId3"/>
           <a:stretch>
             <a:fillRect/>
           </a:stretch>
@@ -4458,7 +5452,7 @@
           <p:nvPr/>
         </p:nvPicPr>
         <p:blipFill>
-          <a:blip r:embed="rId3"/>
+          <a:blip r:embed="rId4"/>
           <a:stretch>
             <a:fillRect/>
           </a:stretch>
@@ -4542,7 +5536,7 @@
           <p:nvPr/>
         </p:nvPicPr>
         <p:blipFill>
-          <a:blip r:embed="rId2"/>
+          <a:blip r:embed="rId3"/>
           <a:stretch>
             <a:fillRect/>
           </a:stretch>
@@ -5638,7 +6632,7 @@
           <p:nvPr/>
         </p:nvPicPr>
         <p:blipFill>
-          <a:blip r:embed="rId2"/>
+          <a:blip r:embed="rId3"/>
           <a:stretch>
             <a:fillRect/>
           </a:stretch>
@@ -6561,7 +7555,7 @@
           <p:nvPr/>
         </p:nvPicPr>
         <p:blipFill>
-          <a:blip r:embed="rId2"/>
+          <a:blip r:embed="rId3"/>
           <a:stretch>
             <a:fillRect/>
           </a:stretch>
@@ -7290,7 +8284,7 @@
           <p:nvPr/>
         </p:nvPicPr>
         <p:blipFill>
-          <a:blip r:embed="rId2"/>
+          <a:blip r:embed="rId3"/>
           <a:stretch>
             <a:fillRect/>
           </a:stretch>
@@ -8085,7 +9079,7 @@
           <p:nvPr/>
         </p:nvPicPr>
         <p:blipFill>
-          <a:blip r:embed="rId2"/>
+          <a:blip r:embed="rId3"/>
           <a:stretch>
             <a:fillRect/>
           </a:stretch>
@@ -8153,7 +9147,7 @@
           <p:nvPr/>
         </p:nvPicPr>
         <p:blipFill>
-          <a:blip r:embed="rId3"/>
+          <a:blip r:embed="rId4"/>
           <a:stretch>
             <a:fillRect/>
           </a:stretch>
@@ -10693,7 +11687,7 @@
 </file>
 
 <file path=ppt/slides/slide7.xml><?xml version="1.0" encoding="utf-8"?>
-<p:sld xmlns:a="http://schemas.openxmlformats.org/drawingml/2006/main" xmlns:p="http://schemas.openxmlformats.org/presentationml/2006/main" xmlns:r="http://schemas.openxmlformats.org/officeDocument/2006/relationships">
+<p:sld xmlns:a="http://schemas.openxmlformats.org/drawingml/2006/main" xmlns:r="http://schemas.openxmlformats.org/officeDocument/2006/relationships" xmlns:p="http://schemas.openxmlformats.org/presentationml/2006/main">
   <p:cSld>
     <p:spTree>
       <p:nvGrpSpPr>
@@ -10753,7 +11747,7 @@
           <p:nvPr/>
         </p:nvPicPr>
         <p:blipFill>
-          <a:blip r:embed="rId2"/>
+          <a:blip r:embed="rId3"/>
           <a:stretch>
             <a:fillRect/>
           </a:stretch>
@@ -11257,7 +12251,7 @@
           </a:fontRef>
         </p:style>
         <p:txBody>
-          <a:bodyPr rtlCol="0" anchor="ctr" wrap="square" lIns="182880" rIns="182880" tIns="182880" bIns="182880"/>
+          <a:bodyPr wrap="square" lIns="182880" tIns="182880" rIns="182880" bIns="182880" rtlCol="0" anchor="ctr"/>
           <a:lstStyle/>
           <a:p>
             <a:pPr algn="ctr"/>
@@ -11751,7 +12745,7 @@
           <p:nvPr/>
         </p:nvPicPr>
         <p:blipFill>
-          <a:blip r:embed="rId2"/>
+          <a:blip r:embed="rId3"/>
           <a:stretch>
             <a:fillRect/>
           </a:stretch>
@@ -11895,7 +12889,7 @@
           <p:nvPr/>
         </p:nvPicPr>
         <p:blipFill>
-          <a:blip r:embed="rId3"/>
+          <a:blip r:embed="rId4"/>
           <a:stretch>
             <a:fillRect/>
           </a:stretch>
@@ -12179,7 +13173,7 @@
           <p:nvPr/>
         </p:nvPicPr>
         <p:blipFill>
-          <a:blip r:embed="rId2"/>
+          <a:blip r:embed="rId3"/>
           <a:stretch>
             <a:fillRect/>
           </a:stretch>
@@ -12412,7 +13406,7 @@
           <p:nvPr/>
         </p:nvPicPr>
         <p:blipFill>
-          <a:blip r:embed="rId3"/>
+          <a:blip r:embed="rId4"/>
           <a:stretch>
             <a:fillRect/>
           </a:stretch>

</xml_diff>

<commit_message>
docs: update presentation notes
</commit_message>
<xml_diff>
--- a/doc/presentations/defensa-placa-permanent-dsi-ports-sortida-hexagonal/output/IMPORTANTE_MANUAL_defensa-dsi-ports-sortida-hexagonal.pptx
+++ b/doc/presentations/defensa-placa-permanent-dsi-ports-sortida-hexagonal/output/IMPORTANTE_MANUAL_defensa-dsi-ports-sortida-hexagonal.pptx
@@ -219,7 +219,7 @@
           <a:p>
             <a:fld id="{0ABAC575-8351-9441-AF95-237B22BB45B7}" type="datetimeFigureOut">
               <a:rPr lang="es-ES" smtClean="0"/>
-              <a:t>4/7/26</a:t>
+              <a:t>5/7/26</a:t>
             </a:fld>
             <a:endParaRPr lang="es-ES"/>
           </a:p>
@@ -531,31 +531,31 @@
           <a:lstStyle/>
           <a:p>
             <a:r>
-              <a:rPr lang="ca-ES"/>
-              <a:t>Context: classe de DSI, no panoràmica completa.</a:t>
-            </a:r>
-          </a:p>
-          <a:p>
-            <a:r>
-              <a:rPr lang="ca-ES"/>
+              <a:rPr lang="ca-ES" dirty="0"/>
+              <a:t>Context: classe de DSI.</a:t>
+            </a:r>
+          </a:p>
+          <a:p>
+            <a:r>
+              <a:rPr lang="ca-ES" dirty="0"/>
               <a:t>Cas real acreditat: consultoria Generalitat / AGAUR.</a:t>
             </a:r>
           </a:p>
           <a:p>
             <a:r>
-              <a:rPr lang="ca-ES"/>
+              <a:rPr lang="ca-ES" dirty="0"/>
               <a:t>Idea: trobada entre dimensió acadèmica i professional.</a:t>
             </a:r>
           </a:p>
           <a:p>
             <a:r>
-              <a:rPr lang="ca-ES"/>
-              <a:t>Focus: ports de sortida quan cal informació externa.</a:t>
-            </a:r>
-          </a:p>
-          <a:p>
-            <a:r>
-              <a:rPr lang="ca-ES"/>
+              <a:rPr lang="ca-ES" dirty="0"/>
+              <a:t>Focus: ports de sortida quan cal informació externa. No panoràmica completa de Arquitectura Hexagonal.</a:t>
+            </a:r>
+          </a:p>
+          <a:p>
+            <a:r>
+              <a:rPr lang="ca-ES" dirty="0"/>
               <a:t>Transició: situar la sessió dins l’assignatura.</a:t>
             </a:r>
           </a:p>
@@ -924,13 +924,15 @@
           <a:p>
             <a:r>
               <a:rPr lang="ca-ES" dirty="0"/>
-              <a:t>El temari inclou arquitectura hexagonal, ports i adaptadors.</a:t>
-            </a:r>
-          </a:p>
-          <a:p>
+              <a:t>El temari inclou arquitectura capes, hexagonal, </a:t>
+            </a:r>
+            <a:r>
+              <a:rPr lang="ca-ES" dirty="0" err="1"/>
+              <a:t>microserveis</a:t>
+            </a:r>
             <a:r>
               <a:rPr lang="ca-ES" dirty="0"/>
-              <a:t>Encaixa en el pla docent.</a:t>
+              <a:t>, ports i adaptadors.</a:t>
             </a:r>
           </a:p>
           <a:p>
@@ -1012,31 +1014,31 @@
           <a:lstStyle/>
           <a:p>
             <a:r>
-              <a:rPr lang="ca-ES"/>
+              <a:rPr lang="ca-ES" dirty="0"/>
               <a:t>Frase clau: capacitat, no tecnologia específica.</a:t>
             </a:r>
           </a:p>
           <a:p>
             <a:r>
-              <a:rPr lang="ca-ES"/>
+              <a:rPr lang="ca-ES" dirty="0"/>
               <a:t>Tres decisions: identificar necessitat, definir port, implementar adaptador.</a:t>
             </a:r>
           </a:p>
           <a:p>
             <a:r>
-              <a:rPr lang="ca-ES"/>
+              <a:rPr lang="ca-ES" dirty="0"/>
               <a:t>No explicar encara tota l’abstracció.</a:t>
             </a:r>
           </a:p>
           <a:p>
             <a:r>
-              <a:rPr lang="ca-ES"/>
+              <a:rPr lang="ca-ES" dirty="0"/>
               <a:t>Primer cas real, després decisió arquitectònica.</a:t>
             </a:r>
           </a:p>
           <a:p>
             <a:r>
-              <a:rPr lang="ca-ES"/>
+              <a:rPr lang="ca-ES" dirty="0"/>
               <a:t>Transició: procediment administratiu de beca.</a:t>
             </a:r>
           </a:p>
@@ -1126,7 +1128,7 @@
           <a:p>
             <a:r>
               <a:rPr lang="ca-ES" dirty="0"/>
-              <a:t>Encara no parlar de SOAP, REST o BD.</a:t>
+              <a:t>Encara no parlar de SOAP, XML, REST o BD.</a:t>
             </a:r>
           </a:p>
           <a:p>
@@ -1392,38 +1394,38 @@
           <a:lstStyle/>
           <a:p>
             <a:r>
-              <a:rPr lang="ca-ES"/>
+              <a:rPr lang="ca-ES" dirty="0"/>
               <a:t>Distingir dues fletxes: flux i dependència de codi.</a:t>
             </a:r>
           </a:p>
           <a:p>
             <a:r>
-              <a:rPr lang="ca-ES"/>
+              <a:rPr lang="ca-ES" dirty="0"/>
               <a:t>Flux: el cas d’ús demana informació cap enfora.</a:t>
             </a:r>
           </a:p>
           <a:p>
             <a:r>
-              <a:rPr lang="ca-ES"/>
+              <a:rPr lang="ca-ES" dirty="0"/>
               <a:t>Dependència: cas d’ús -&gt; port; adaptador -&gt; port.</a:t>
             </a:r>
           </a:p>
           <a:p>
             <a:r>
-              <a:rPr lang="ca-ES"/>
+              <a:rPr lang="ca-ES" dirty="0"/>
               <a:t>Java: port = interfície; adaptador = classe que la implementa.</a:t>
             </a:r>
           </a:p>
           <a:p>
             <a:r>
-              <a:rPr lang="ca-ES"/>
+              <a:rPr lang="ca-ES" dirty="0"/>
               <a:t>Frase clau: la infraestructura depèn del port de l’aplicació.</a:t>
             </a:r>
           </a:p>
           <a:p>
             <a:r>
-              <a:rPr lang="ca-ES"/>
-              <a:t>Transició: aplicar-ho al cas patrimonial.</a:t>
+              <a:rPr lang="ca-ES" dirty="0"/>
+              <a:t>Transició: aplicar-ho a la necessitat de informació econòmica.</a:t>
             </a:r>
           </a:p>
         </p:txBody>
@@ -1823,7 +1825,7 @@
           <a:p>
             <a:fld id="{5BCAD085-E8A6-8845-BD4E-CB4CCA059FC4}" type="datetimeFigureOut">
               <a:rPr lang="en-US" smtClean="0"/>
-              <a:t>7/4/26</a:t>
+              <a:t>7/5/26</a:t>
             </a:fld>
             <a:endParaRPr lang="en-US"/>
           </a:p>
@@ -1991,7 +1993,7 @@
           <a:p>
             <a:fld id="{5BCAD085-E8A6-8845-BD4E-CB4CCA059FC4}" type="datetimeFigureOut">
               <a:rPr lang="en-US" smtClean="0"/>
-              <a:t>7/4/26</a:t>
+              <a:t>7/5/26</a:t>
             </a:fld>
             <a:endParaRPr lang="en-US"/>
           </a:p>
@@ -2169,7 +2171,7 @@
           <a:p>
             <a:fld id="{5BCAD085-E8A6-8845-BD4E-CB4CCA059FC4}" type="datetimeFigureOut">
               <a:rPr lang="en-US" smtClean="0"/>
-              <a:t>7/4/26</a:t>
+              <a:t>7/5/26</a:t>
             </a:fld>
             <a:endParaRPr lang="en-US"/>
           </a:p>
@@ -2337,7 +2339,7 @@
           <a:p>
             <a:fld id="{5BCAD085-E8A6-8845-BD4E-CB4CCA059FC4}" type="datetimeFigureOut">
               <a:rPr lang="en-US" smtClean="0"/>
-              <a:t>7/4/26</a:t>
+              <a:t>7/5/26</a:t>
             </a:fld>
             <a:endParaRPr lang="en-US"/>
           </a:p>
@@ -2582,7 +2584,7 @@
           <a:p>
             <a:fld id="{5BCAD085-E8A6-8845-BD4E-CB4CCA059FC4}" type="datetimeFigureOut">
               <a:rPr lang="en-US" smtClean="0"/>
-              <a:t>7/4/26</a:t>
+              <a:t>7/5/26</a:t>
             </a:fld>
             <a:endParaRPr lang="en-US"/>
           </a:p>
@@ -2867,7 +2869,7 @@
           <a:p>
             <a:fld id="{5BCAD085-E8A6-8845-BD4E-CB4CCA059FC4}" type="datetimeFigureOut">
               <a:rPr lang="en-US" smtClean="0"/>
-              <a:t>7/4/26</a:t>
+              <a:t>7/5/26</a:t>
             </a:fld>
             <a:endParaRPr lang="en-US"/>
           </a:p>
@@ -3286,7 +3288,7 @@
           <a:p>
             <a:fld id="{5BCAD085-E8A6-8845-BD4E-CB4CCA059FC4}" type="datetimeFigureOut">
               <a:rPr lang="en-US" smtClean="0"/>
-              <a:t>7/4/26</a:t>
+              <a:t>7/5/26</a:t>
             </a:fld>
             <a:endParaRPr lang="en-US"/>
           </a:p>
@@ -3403,7 +3405,7 @@
           <a:p>
             <a:fld id="{5BCAD085-E8A6-8845-BD4E-CB4CCA059FC4}" type="datetimeFigureOut">
               <a:rPr lang="en-US" smtClean="0"/>
-              <a:t>7/4/26</a:t>
+              <a:t>7/5/26</a:t>
             </a:fld>
             <a:endParaRPr lang="en-US"/>
           </a:p>
@@ -3498,7 +3500,7 @@
           <a:p>
             <a:fld id="{5BCAD085-E8A6-8845-BD4E-CB4CCA059FC4}" type="datetimeFigureOut">
               <a:rPr lang="en-US" smtClean="0"/>
-              <a:t>7/4/26</a:t>
+              <a:t>7/5/26</a:t>
             </a:fld>
             <a:endParaRPr lang="en-US"/>
           </a:p>
@@ -3773,7 +3775,7 @@
           <a:p>
             <a:fld id="{5BCAD085-E8A6-8845-BD4E-CB4CCA059FC4}" type="datetimeFigureOut">
               <a:rPr lang="en-US" smtClean="0"/>
-              <a:t>7/4/26</a:t>
+              <a:t>7/5/26</a:t>
             </a:fld>
             <a:endParaRPr lang="en-US"/>
           </a:p>
@@ -4025,7 +4027,7 @@
           <a:p>
             <a:fld id="{5BCAD085-E8A6-8845-BD4E-CB4CCA059FC4}" type="datetimeFigureOut">
               <a:rPr lang="en-US" smtClean="0"/>
-              <a:t>7/4/26</a:t>
+              <a:t>7/5/26</a:t>
             </a:fld>
             <a:endParaRPr lang="en-US"/>
           </a:p>
@@ -4236,7 +4238,7 @@
           <a:p>
             <a:fld id="{5BCAD085-E8A6-8845-BD4E-CB4CCA059FC4}" type="datetimeFigureOut">
               <a:rPr lang="en-US" smtClean="0"/>
-              <a:t>7/4/26</a:t>
+              <a:t>7/5/26</a:t>
             </a:fld>
             <a:endParaRPr lang="en-US"/>
           </a:p>

</xml_diff>

<commit_message>
Update TecnoCampus defense materials
</commit_message>
<xml_diff>
--- a/doc/presentations/defensa-placa-permanent-dsi-ports-sortida-hexagonal/output/IMPORTANTE_MANUAL_defensa-dsi-ports-sortida-hexagonal.pptx
+++ b/doc/presentations/defensa-placa-permanent-dsi-ports-sortida-hexagonal/output/IMPORTANTE_MANUAL_defensa-dsi-ports-sortida-hexagonal.pptx
@@ -219,7 +219,7 @@
           <a:p>
             <a:fld id="{0ABAC575-8351-9441-AF95-237B22BB45B7}" type="datetimeFigureOut">
               <a:rPr lang="es-ES" smtClean="0"/>
-              <a:t>5/7/26</a:t>
+              <a:t>12/7/26</a:t>
             </a:fld>
             <a:endParaRPr lang="es-ES"/>
           </a:p>
@@ -550,7 +550,7 @@
           <a:p>
             <a:r>
               <a:rPr lang="ca-ES" dirty="0"/>
-              <a:t>Focus: ports de sortida quan cal informació externa. No panoràmica completa de Arquitectura Hexagonal.</a:t>
+              <a:t>Focus: ports de sortida quan cal informació externa. No panoràmica completa d'arquitectura hexagonal.</a:t>
             </a:r>
           </a:p>
           <a:p>
@@ -651,7 +651,7 @@
           <a:p>
             <a:r>
               <a:rPr lang="ca-ES"/>
-              <a:t>Frase clau: servei coordina, domini decideix, adaptador integra.</a:t>
+              <a:t>Frase clau: en aquesta implementació, servei coordina, domini decideix i adaptador integra.</a:t>
             </a:r>
           </a:p>
           <a:p>
@@ -728,13 +728,13 @@
           <a:p>
             <a:r>
               <a:rPr lang="ca-ES"/>
-              <a:t>Tancament: l’arquitectura no elimina el canvi; el localitza.</a:t>
+              <a:t>Tancament: l’arquitectura no elimina la dependència externa; la situa en una frontera explícita i controlable.</a:t>
             </a:r>
           </a:p>
           <a:p>
             <a:r>
               <a:rPr lang="ca-ES"/>
-              <a:t>Quan canvia proveïdor o API, volem canviar l’adaptador.</a:t>
+              <a:t>Quan canvia proveïdor o API, volem localitzar l’impacte a l’adaptador.</a:t>
             </a:r>
           </a:p>
           <a:p>
@@ -746,7 +746,7 @@
           <a:p>
             <a:r>
               <a:rPr lang="ca-ES"/>
-              <a:t>Agrair TecnoCampus i Dr. Josep Roure.</a:t>
+              <a:t>Agraïment breu al TecnoCampus i al Dr. Josep Roure.</a:t>
             </a:r>
           </a:p>
           <a:p>
@@ -924,15 +924,7 @@
           <a:p>
             <a:r>
               <a:rPr lang="ca-ES" dirty="0"/>
-              <a:t>El temari inclou arquitectura capes, hexagonal, </a:t>
-            </a:r>
-            <a:r>
-              <a:rPr lang="ca-ES" dirty="0" err="1"/>
-              <a:t>microserveis</a:t>
-            </a:r>
-            <a:r>
-              <a:rPr lang="ca-ES" dirty="0"/>
-              <a:t>, ports i adaptadors.</a:t>
+              <a:t>Bloc: Clean Architecture i arquitectura hexagonal, ports i adaptadors, mapping, modularització i Domain-Driven Design.</a:t>
             </a:r>
           </a:p>
           <a:p>
@@ -1015,7 +1007,7 @@
           <a:p>
             <a:r>
               <a:rPr lang="ca-ES" dirty="0"/>
-              <a:t>Frase clau: capacitat, no tecnologia específica.</a:t>
+              <a:t>Frase clau: capacitat funcional, no tecnologia específica.</a:t>
             </a:r>
           </a:p>
           <a:p>
@@ -1211,13 +1203,19 @@
           <a:p>
             <a:r>
               <a:rPr lang="ca-ES"/>
-              <a:t>Fonts possibles: AEAT, Cadastre, PICA.</a:t>
+              <a:t>Fonts administratives: AEAT i Cadastre.</a:t>
             </a:r>
           </a:p>
           <a:p>
             <a:r>
               <a:rPr lang="ca-ES"/>
-              <a:t>PICA = interoperabilitat administrativa, no “el problema”.</a:t>
+              <a:t>Canal o plataforma d’interoperabilitat: PICA.</a:t>
+            </a:r>
+          </a:p>
+          <a:p>
+            <a:r>
+              <a:rPr lang="ca-ES"/>
+              <a:t>No presentar PICA com a font original del mateix tipus.</a:t>
             </a:r>
           </a:p>
           <a:p>
@@ -1306,6 +1304,12 @@
           <a:p>
             <a:r>
               <a:rPr lang="ca-ES"/>
+              <a:t>La cadena SOAP/XML -&gt; PICA -&gt; AEAT i/o Cadastre és el problema, no la solució.</a:t>
+            </a:r>
+          </a:p>
+          <a:p>
+            <a:r>
+              <a:rPr lang="ca-ES"/>
               <a:t>El cas d’ús acaba coneixent SOAP/XML, DTOs, clients i errors.</a:t>
             </a:r>
           </a:p>
@@ -1318,7 +1322,7 @@
           <a:p>
             <a:r>
               <a:rPr lang="ca-ES"/>
-              <a:t>Riscos: manteniment fràgil i continuïtat operativa.</a:t>
+              <a:t>Riscos: manteniment fràgil i més superfície d’impacte davant canvis externs.</a:t>
             </a:r>
           </a:p>
           <a:p>
@@ -1413,7 +1417,13 @@
           <a:p>
             <a:r>
               <a:rPr lang="ca-ES" dirty="0"/>
-              <a:t>Java: port = interfície; adaptador = classe que la implementa.</a:t>
+              <a:t>Conceptualment, el port és un contracte; en Java, aquí s’expressa com una interfície.</a:t>
+            </a:r>
+          </a:p>
+          <a:p>
+            <a:r>
+              <a:rPr lang="ca-ES" dirty="0"/>
+              <a:t>L’adaptador implementa aquesta interfície.</a:t>
             </a:r>
           </a:p>
           <a:p>
@@ -1425,7 +1435,7 @@
           <a:p>
             <a:r>
               <a:rPr lang="ca-ES" dirty="0"/>
-              <a:t>Transició: aplicar-ho a la necessitat de informació econòmica.</a:t>
+              <a:t>Transició: aplicar-ho a la necessitat d’informació econòmica.</a:t>
             </a:r>
           </a:p>
         </p:txBody>
@@ -1609,7 +1619,7 @@
           <a:p>
             <a:r>
               <a:rPr lang="ca-ES"/>
-              <a:t>No dependre de proveïdor, API, endpoint o format.</a:t>
+              <a:t>Separar proveïdor de dades, API concreta, contracte tècnic i adaptador.</a:t>
             </a:r>
           </a:p>
           <a:p>
@@ -1825,7 +1835,7 @@
           <a:p>
             <a:fld id="{5BCAD085-E8A6-8845-BD4E-CB4CCA059FC4}" type="datetimeFigureOut">
               <a:rPr lang="en-US" smtClean="0"/>
-              <a:t>7/5/26</a:t>
+              <a:t>7/12/26</a:t>
             </a:fld>
             <a:endParaRPr lang="en-US"/>
           </a:p>
@@ -1993,7 +2003,7 @@
           <a:p>
             <a:fld id="{5BCAD085-E8A6-8845-BD4E-CB4CCA059FC4}" type="datetimeFigureOut">
               <a:rPr lang="en-US" smtClean="0"/>
-              <a:t>7/5/26</a:t>
+              <a:t>7/12/26</a:t>
             </a:fld>
             <a:endParaRPr lang="en-US"/>
           </a:p>
@@ -2171,7 +2181,7 @@
           <a:p>
             <a:fld id="{5BCAD085-E8A6-8845-BD4E-CB4CCA059FC4}" type="datetimeFigureOut">
               <a:rPr lang="en-US" smtClean="0"/>
-              <a:t>7/5/26</a:t>
+              <a:t>7/12/26</a:t>
             </a:fld>
             <a:endParaRPr lang="en-US"/>
           </a:p>
@@ -2339,7 +2349,7 @@
           <a:p>
             <a:fld id="{5BCAD085-E8A6-8845-BD4E-CB4CCA059FC4}" type="datetimeFigureOut">
               <a:rPr lang="en-US" smtClean="0"/>
-              <a:t>7/5/26</a:t>
+              <a:t>7/12/26</a:t>
             </a:fld>
             <a:endParaRPr lang="en-US"/>
           </a:p>
@@ -2584,7 +2594,7 @@
           <a:p>
             <a:fld id="{5BCAD085-E8A6-8845-BD4E-CB4CCA059FC4}" type="datetimeFigureOut">
               <a:rPr lang="en-US" smtClean="0"/>
-              <a:t>7/5/26</a:t>
+              <a:t>7/12/26</a:t>
             </a:fld>
             <a:endParaRPr lang="en-US"/>
           </a:p>
@@ -2869,7 +2879,7 @@
           <a:p>
             <a:fld id="{5BCAD085-E8A6-8845-BD4E-CB4CCA059FC4}" type="datetimeFigureOut">
               <a:rPr lang="en-US" smtClean="0"/>
-              <a:t>7/5/26</a:t>
+              <a:t>7/12/26</a:t>
             </a:fld>
             <a:endParaRPr lang="en-US"/>
           </a:p>
@@ -3288,7 +3298,7 @@
           <a:p>
             <a:fld id="{5BCAD085-E8A6-8845-BD4E-CB4CCA059FC4}" type="datetimeFigureOut">
               <a:rPr lang="en-US" smtClean="0"/>
-              <a:t>7/5/26</a:t>
+              <a:t>7/12/26</a:t>
             </a:fld>
             <a:endParaRPr lang="en-US"/>
           </a:p>
@@ -3405,7 +3415,7 @@
           <a:p>
             <a:fld id="{5BCAD085-E8A6-8845-BD4E-CB4CCA059FC4}" type="datetimeFigureOut">
               <a:rPr lang="en-US" smtClean="0"/>
-              <a:t>7/5/26</a:t>
+              <a:t>7/12/26</a:t>
             </a:fld>
             <a:endParaRPr lang="en-US"/>
           </a:p>
@@ -3500,7 +3510,7 @@
           <a:p>
             <a:fld id="{5BCAD085-E8A6-8845-BD4E-CB4CCA059FC4}" type="datetimeFigureOut">
               <a:rPr lang="en-US" smtClean="0"/>
-              <a:t>7/5/26</a:t>
+              <a:t>7/12/26</a:t>
             </a:fld>
             <a:endParaRPr lang="en-US"/>
           </a:p>
@@ -3775,7 +3785,7 @@
           <a:p>
             <a:fld id="{5BCAD085-E8A6-8845-BD4E-CB4CCA059FC4}" type="datetimeFigureOut">
               <a:rPr lang="en-US" smtClean="0"/>
-              <a:t>7/5/26</a:t>
+              <a:t>7/12/26</a:t>
             </a:fld>
             <a:endParaRPr lang="en-US"/>
           </a:p>
@@ -4027,7 +4037,7 @@
           <a:p>
             <a:fld id="{5BCAD085-E8A6-8845-BD4E-CB4CCA059FC4}" type="datetimeFigureOut">
               <a:rPr lang="en-US" smtClean="0"/>
-              <a:t>7/5/26</a:t>
+              <a:t>7/12/26</a:t>
             </a:fld>
             <a:endParaRPr lang="en-US"/>
           </a:p>
@@ -4238,7 +4248,7 @@
           <a:p>
             <a:fld id="{5BCAD085-E8A6-8845-BD4E-CB4CCA059FC4}" type="datetimeFigureOut">
               <a:rPr lang="en-US" smtClean="0"/>
-              <a:t>7/5/26</a:t>
+              <a:t>7/12/26</a:t>
             </a:fld>
             <a:endParaRPr lang="en-US"/>
           </a:p>
@@ -4702,79 +4712,7 @@
                 </a:solidFill>
                 <a:latin typeface="Arial"/>
               </a:rPr>
-              <a:t>D</a:t>
-            </a:r>
-            <a:r>
-              <a:rPr sz="2100" b="0" dirty="0" err="1">
-                <a:solidFill>
-                  <a:srgbClr val="236092"/>
-                </a:solidFill>
-                <a:latin typeface="Arial"/>
-              </a:rPr>
-              <a:t>esacoblament</a:t>
-            </a:r>
-            <a:r>
-              <a:rPr sz="2100" b="0" dirty="0">
-                <a:solidFill>
-                  <a:srgbClr val="236092"/>
-                </a:solidFill>
-                <a:latin typeface="Arial"/>
-              </a:rPr>
-              <a:t> entre </a:t>
-            </a:r>
-            <a:r>
-              <a:rPr sz="2100" b="0" dirty="0" err="1">
-                <a:solidFill>
-                  <a:srgbClr val="236092"/>
-                </a:solidFill>
-                <a:latin typeface="Arial"/>
-              </a:rPr>
-              <a:t>casos</a:t>
-            </a:r>
-            <a:r>
-              <a:rPr sz="2100" b="0" dirty="0">
-                <a:solidFill>
-                  <a:srgbClr val="236092"/>
-                </a:solidFill>
-                <a:latin typeface="Arial"/>
-              </a:rPr>
-              <a:t> </a:t>
-            </a:r>
-            <a:r>
-              <a:rPr sz="2100" b="0" dirty="0" err="1">
-                <a:solidFill>
-                  <a:srgbClr val="236092"/>
-                </a:solidFill>
-                <a:latin typeface="Arial"/>
-              </a:rPr>
-              <a:t>d'ús</a:t>
-            </a:r>
-            <a:r>
-              <a:rPr sz="2100" b="0" dirty="0">
-                <a:solidFill>
-                  <a:srgbClr val="236092"/>
-                </a:solidFill>
-                <a:latin typeface="Arial"/>
-              </a:rPr>
-              <a:t>, domini </a:t>
-            </a:r>
-            <a:r>
-              <a:rPr sz="2100" b="0" dirty="0" err="1">
-                <a:solidFill>
-                  <a:srgbClr val="236092"/>
-                </a:solidFill>
-                <a:latin typeface="Arial"/>
-              </a:rPr>
-              <a:t>i</a:t>
-            </a:r>
-            <a:r>
-              <a:rPr sz="2100" b="0" dirty="0">
-                <a:solidFill>
-                  <a:srgbClr val="236092"/>
-                </a:solidFill>
-                <a:latin typeface="Arial"/>
-              </a:rPr>
-              <a:t> APIs externes</a:t>
+              <a:t>Desacoblament entre casos d'ús, domini i serveis externs</a:t>
             </a:r>
           </a:p>
         </p:txBody>
@@ -5188,122 +5126,8 @@
                 </a:solidFill>
                 <a:latin typeface="Arial"/>
               </a:rPr>
-              <a:t>El </a:t>
-            </a:r>
-            <a:r>
-              <a:rPr sz="1300" b="0" dirty="0" err="1">
-                <a:solidFill>
-                  <a:srgbClr val="66707A"/>
-                </a:solidFill>
-                <a:latin typeface="Arial"/>
-              </a:rPr>
-              <a:t>servei</a:t>
-            </a:r>
-            <a:r>
-              <a:rPr sz="1300" b="0" dirty="0">
-                <a:solidFill>
-                  <a:srgbClr val="66707A"/>
-                </a:solidFill>
-                <a:latin typeface="Arial"/>
-              </a:rPr>
-              <a:t> </a:t>
-            </a:r>
-            <a:r>
-              <a:rPr sz="1300" b="0" dirty="0" err="1">
-                <a:solidFill>
-                  <a:srgbClr val="66707A"/>
-                </a:solidFill>
-                <a:latin typeface="Arial"/>
-              </a:rPr>
-              <a:t>coordina</a:t>
-            </a:r>
-            <a:r>
-              <a:rPr sz="1300" b="0" dirty="0">
-                <a:solidFill>
-                  <a:srgbClr val="66707A"/>
-                </a:solidFill>
-                <a:latin typeface="Arial"/>
-              </a:rPr>
-              <a:t>. El domini </a:t>
-            </a:r>
-            <a:r>
-              <a:rPr sz="1300" b="0" dirty="0" err="1">
-                <a:solidFill>
-                  <a:srgbClr val="66707A"/>
-                </a:solidFill>
-                <a:latin typeface="Arial"/>
-              </a:rPr>
-              <a:t>decideix</a:t>
-            </a:r>
-            <a:r>
-              <a:rPr sz="1300" b="0" dirty="0">
-                <a:solidFill>
-                  <a:srgbClr val="66707A"/>
-                </a:solidFill>
-                <a:latin typeface="Arial"/>
-              </a:rPr>
-              <a:t>. </a:t>
-            </a:r>
-            <a:r>
-              <a:rPr lang="es-ES" sz="1300" b="0" dirty="0" err="1">
-                <a:solidFill>
-                  <a:srgbClr val="66707A"/>
-                </a:solidFill>
-                <a:latin typeface="Arial"/>
-              </a:rPr>
-              <a:t>L'adaptador</a:t>
-            </a:r>
-            <a:r>
-              <a:rPr lang="es-ES" sz="1300" b="0" dirty="0">
-                <a:solidFill>
-                  <a:srgbClr val="66707A"/>
-                </a:solidFill>
-                <a:latin typeface="Arial"/>
-              </a:rPr>
-              <a:t> integra </a:t>
-            </a:r>
-            <a:r>
-              <a:rPr lang="es-ES" sz="1300" b="0" dirty="0" err="1">
-                <a:solidFill>
-                  <a:srgbClr val="66707A"/>
-                </a:solidFill>
-                <a:latin typeface="Arial"/>
-              </a:rPr>
-              <a:t>amb</a:t>
-            </a:r>
-            <a:r>
-              <a:rPr lang="es-ES" sz="1300" b="0" dirty="0">
-                <a:solidFill>
-                  <a:srgbClr val="66707A"/>
-                </a:solidFill>
-                <a:latin typeface="Arial"/>
-              </a:rPr>
-              <a:t> infraestructura </a:t>
-            </a:r>
-            <a:r>
-              <a:rPr lang="es-ES" sz="1300" b="0" dirty="0" err="1">
-                <a:solidFill>
-                  <a:srgbClr val="66707A"/>
-                </a:solidFill>
-                <a:latin typeface="Arial"/>
-              </a:rPr>
-              <a:t>tecnològica</a:t>
-            </a:r>
-            <a:r>
-              <a:rPr lang="es-ES" sz="1300" b="0" dirty="0">
-                <a:solidFill>
-                  <a:srgbClr val="66707A"/>
-                </a:solidFill>
-                <a:latin typeface="Arial"/>
-              </a:rPr>
-              <a:t>. </a:t>
-            </a:r>
-            <a:endParaRPr sz="1300" b="0" dirty="0">
-              <a:solidFill>
-                <a:srgbClr val="66707A"/>
-              </a:solidFill>
-              <a:latin typeface="Arial"/>
-            </a:endParaRPr>
+              <a:t>En aquesta implementació: el servei coordina, el domini decideix i l'adaptador integra amb infraestructura tecnològica.</a:t>
+            </a:r>
           </a:p>
         </p:txBody>
       </p:sp>
@@ -5615,7 +5439,7 @@
         </p:spPr>
         <p:txBody>
           <a:bodyPr wrap="square">
-            <a:normAutofit/>
+            <a:normAutofit lnSpcReduction="10000"/>
           </a:bodyPr>
           <a:lstStyle/>
           <a:p>
@@ -5735,7 +5559,7 @@
                 </a:solidFill>
                 <a:latin typeface="Arial"/>
               </a:rPr>
-              <a:t>m’encoratja</a:t>
+              <a:t>m'encoratja</a:t>
             </a:r>
             <a:r>
               <a:rPr lang="es-ES" sz="2400" b="0" dirty="0">
@@ -5825,7 +5649,7 @@
                 </a:solidFill>
                 <a:latin typeface="Arial"/>
               </a:rPr>
-              <a:t>l’àmbit</a:t>
+              <a:t>l'àmbit</a:t>
             </a:r>
             <a:r>
               <a:rPr lang="es-ES" sz="2400" b="0" dirty="0">
@@ -5879,7 +5703,7 @@
                 </a:solidFill>
                 <a:latin typeface="Arial"/>
               </a:rPr>
-              <a:t>d’un</a:t>
+              <a:t>d'un</a:t>
             </a:r>
             <a:r>
               <a:rPr lang="es-ES" sz="2400" b="0" dirty="0">
@@ -6086,9 +5910,17 @@
                 </a:solidFill>
                 <a:latin typeface="Arial"/>
               </a:rPr>
-              <a:t>.</a:t>
-            </a:r>
-            <a:endParaRPr sz="2400" b="0" dirty="0">
+              <a:t>. </a:t>
+            </a:r>
+            <a:br>
+              <a:rPr lang="es-ES" sz="2400" b="0" dirty="0">
+                <a:solidFill>
+                  <a:srgbClr val="192D3E"/>
+                </a:solidFill>
+                <a:latin typeface="Arial"/>
+              </a:rPr>
+            </a:br>
+            <a:endParaRPr lang="es-ES" sz="2400" b="0" dirty="0">
               <a:solidFill>
                 <a:srgbClr val="192D3E"/>
               </a:solidFill>
@@ -6173,259 +6005,7 @@
                 </a:solidFill>
                 <a:latin typeface="Arial"/>
               </a:rPr>
-              <a:t>Agraïment</a:t>
-            </a:r>
-            <a:r>
-              <a:rPr sz="1600" b="0" dirty="0">
-                <a:solidFill>
-                  <a:srgbClr val="192D3E"/>
-                </a:solidFill>
-                <a:latin typeface="Arial"/>
-              </a:rPr>
-              <a:t> especial al Dr. Josep </a:t>
-            </a:r>
-            <a:r>
-              <a:rPr sz="1600" b="0" dirty="0" err="1">
-                <a:solidFill>
-                  <a:srgbClr val="192D3E"/>
-                </a:solidFill>
-                <a:latin typeface="Arial"/>
-              </a:rPr>
-              <a:t>Roure</a:t>
-            </a:r>
-            <a:r>
-              <a:rPr sz="1600" b="0" dirty="0">
-                <a:solidFill>
-                  <a:srgbClr val="192D3E"/>
-                </a:solidFill>
-                <a:latin typeface="Arial"/>
-              </a:rPr>
-              <a:t>, company professor del </a:t>
-            </a:r>
-            <a:r>
-              <a:rPr sz="1600" b="0" dirty="0" err="1">
-                <a:solidFill>
-                  <a:srgbClr val="192D3E"/>
-                </a:solidFill>
-                <a:latin typeface="Arial"/>
-              </a:rPr>
-              <a:t>TecnoCampus</a:t>
-            </a:r>
-            <a:r>
-              <a:rPr sz="1600" b="0" dirty="0">
-                <a:solidFill>
-                  <a:srgbClr val="192D3E"/>
-                </a:solidFill>
-                <a:latin typeface="Arial"/>
-              </a:rPr>
-              <a:t>, </a:t>
-            </a:r>
-            <a:r>
-              <a:rPr sz="1600" b="0" dirty="0" err="1">
-                <a:solidFill>
-                  <a:srgbClr val="192D3E"/>
-                </a:solidFill>
-                <a:latin typeface="Arial"/>
-              </a:rPr>
-              <a:t>amb</a:t>
-            </a:r>
-            <a:r>
-              <a:rPr sz="1600" b="0" dirty="0">
-                <a:solidFill>
-                  <a:srgbClr val="192D3E"/>
-                </a:solidFill>
-                <a:latin typeface="Arial"/>
-              </a:rPr>
-              <a:t> qui he </a:t>
-            </a:r>
-            <a:r>
-              <a:rPr sz="1600" b="0" dirty="0" err="1">
-                <a:solidFill>
-                  <a:srgbClr val="192D3E"/>
-                </a:solidFill>
-                <a:latin typeface="Arial"/>
-              </a:rPr>
-              <a:t>tingut</a:t>
-            </a:r>
-            <a:r>
-              <a:rPr sz="1600" b="0" dirty="0">
-                <a:solidFill>
-                  <a:srgbClr val="192D3E"/>
-                </a:solidFill>
-                <a:latin typeface="Arial"/>
-              </a:rPr>
-              <a:t> </a:t>
-            </a:r>
-            <a:r>
-              <a:rPr sz="1600" b="0" dirty="0" err="1">
-                <a:solidFill>
-                  <a:srgbClr val="192D3E"/>
-                </a:solidFill>
-                <a:latin typeface="Arial"/>
-              </a:rPr>
-              <a:t>l'oportunitat</a:t>
-            </a:r>
-            <a:r>
-              <a:rPr sz="1600" b="0" dirty="0">
-                <a:solidFill>
-                  <a:srgbClr val="192D3E"/>
-                </a:solidFill>
-                <a:latin typeface="Arial"/>
-              </a:rPr>
-              <a:t> </a:t>
-            </a:r>
-            <a:r>
-              <a:rPr sz="1600" b="0" dirty="0" err="1">
-                <a:solidFill>
-                  <a:srgbClr val="192D3E"/>
-                </a:solidFill>
-                <a:latin typeface="Arial"/>
-              </a:rPr>
-              <a:t>d'aprendre</a:t>
-            </a:r>
-            <a:r>
-              <a:rPr sz="1600" b="0" dirty="0">
-                <a:solidFill>
-                  <a:srgbClr val="192D3E"/>
-                </a:solidFill>
-                <a:latin typeface="Arial"/>
-              </a:rPr>
-              <a:t> </a:t>
-            </a:r>
-            <a:r>
-              <a:rPr sz="1600" b="0" dirty="0" err="1">
-                <a:solidFill>
-                  <a:srgbClr val="192D3E"/>
-                </a:solidFill>
-                <a:latin typeface="Arial"/>
-              </a:rPr>
-              <a:t>sobre</a:t>
-            </a:r>
-            <a:r>
-              <a:rPr sz="1600" b="0" dirty="0">
-                <a:solidFill>
-                  <a:srgbClr val="192D3E"/>
-                </a:solidFill>
-                <a:latin typeface="Arial"/>
-              </a:rPr>
-              <a:t> </a:t>
-            </a:r>
-            <a:r>
-              <a:rPr sz="1600" b="0" dirty="0" err="1">
-                <a:solidFill>
-                  <a:srgbClr val="192D3E"/>
-                </a:solidFill>
-                <a:latin typeface="Arial"/>
-              </a:rPr>
-              <a:t>arquitectura</a:t>
-            </a:r>
-            <a:r>
-              <a:rPr sz="1600" b="0" dirty="0">
-                <a:solidFill>
-                  <a:srgbClr val="192D3E"/>
-                </a:solidFill>
-                <a:latin typeface="Arial"/>
-              </a:rPr>
-              <a:t> </a:t>
-            </a:r>
-            <a:r>
-              <a:rPr lang="es-ES" sz="1600" dirty="0">
-                <a:solidFill>
-                  <a:srgbClr val="192D3E"/>
-                </a:solidFill>
-                <a:latin typeface="Arial"/>
-              </a:rPr>
-              <a:t>de </a:t>
-            </a:r>
-            <a:r>
-              <a:rPr sz="1600" b="0" dirty="0">
-                <a:solidFill>
-                  <a:srgbClr val="192D3E"/>
-                </a:solidFill>
-                <a:latin typeface="Arial"/>
-              </a:rPr>
-              <a:t>software</a:t>
-            </a:r>
-            <a:r>
-              <a:rPr lang="es-ES" sz="1600" dirty="0">
-                <a:solidFill>
-                  <a:srgbClr val="192D3E"/>
-                </a:solidFill>
-                <a:latin typeface="Arial"/>
-              </a:rPr>
-              <a:t>, </a:t>
-            </a:r>
-            <a:r>
-              <a:rPr lang="es-ES" sz="1600" b="0" dirty="0" err="1">
-                <a:solidFill>
-                  <a:srgbClr val="192D3E"/>
-                </a:solidFill>
-                <a:latin typeface="Arial"/>
-              </a:rPr>
-              <a:t>metodologies</a:t>
-            </a:r>
-            <a:r>
-              <a:rPr lang="es-ES" sz="1600" b="0" dirty="0">
-                <a:solidFill>
-                  <a:srgbClr val="192D3E"/>
-                </a:solidFill>
-                <a:latin typeface="Arial"/>
-              </a:rPr>
-              <a:t> actives </a:t>
-            </a:r>
-            <a:r>
-              <a:rPr lang="es-ES" sz="1600" b="0" dirty="0" err="1">
-                <a:solidFill>
-                  <a:srgbClr val="192D3E"/>
-                </a:solidFill>
-                <a:latin typeface="Arial"/>
-              </a:rPr>
-              <a:t>d'aprenentatge</a:t>
-            </a:r>
-            <a:r>
-              <a:rPr lang="es-ES" sz="1600" dirty="0">
-                <a:solidFill>
-                  <a:srgbClr val="192D3E"/>
-                </a:solidFill>
-                <a:latin typeface="Arial"/>
-              </a:rPr>
-              <a:t> i </a:t>
-            </a:r>
-            <a:r>
-              <a:rPr lang="es-ES" sz="1600" dirty="0" err="1">
-                <a:solidFill>
-                  <a:srgbClr val="192D3E"/>
-                </a:solidFill>
-                <a:latin typeface="Arial"/>
-              </a:rPr>
-              <a:t>treball</a:t>
-            </a:r>
-            <a:r>
-              <a:rPr lang="es-ES" sz="1600" dirty="0">
-                <a:solidFill>
-                  <a:srgbClr val="192D3E"/>
-                </a:solidFill>
-                <a:latin typeface="Arial"/>
-              </a:rPr>
-              <a:t> en </a:t>
-            </a:r>
-            <a:r>
-              <a:rPr lang="es-ES" sz="1600" dirty="0" err="1">
-                <a:solidFill>
-                  <a:srgbClr val="192D3E"/>
-                </a:solidFill>
-                <a:latin typeface="Arial"/>
-              </a:rPr>
-              <a:t>equip</a:t>
-            </a:r>
-            <a:r>
-              <a:rPr lang="es-ES" sz="1600" dirty="0">
-                <a:solidFill>
-                  <a:srgbClr val="192D3E"/>
-                </a:solidFill>
-                <a:latin typeface="Arial"/>
-              </a:rPr>
-              <a:t>.</a:t>
+              <a:t>Agraïment al TecnoCampus i al Dr. Josep Roure pel treball compartit en arquitectura de software, docència i metodologies actives.</a:t>
             </a:r>
             <a:endParaRPr sz="1600" b="0" dirty="0">
               <a:solidFill>
@@ -8118,7 +7698,7 @@
                 </a:solidFill>
                 <a:latin typeface="Arial"/>
               </a:rPr>
-              <a:t>Pla docent 103322: clean/hexagonal architecture, ports i adaptadors, mapping, mòduls i DDD.</a:t>
+              <a:t>Pla docent 103322: Clean Architecture i arquitectura hexagonal, ports i adaptadors, mapping, modularització i Domain-Driven Design.</a:t>
             </a:r>
           </a:p>
         </p:txBody>
@@ -8387,7 +7967,52 @@
                 </a:solidFill>
                 <a:latin typeface="Arial"/>
               </a:rPr>
-              <a:t>Principi de treball: el cas d’ús necessita una capacitat, no </a:t>
+              <a:t>Principi de treball: el cas d’ús necessita </a:t>
+            </a:r>
+            <a:r>
+              <a:rPr sz="2400" b="1" dirty="0" err="1">
+                <a:solidFill>
+                  <a:srgbClr val="192D3E"/>
+                </a:solidFill>
+                <a:latin typeface="Arial"/>
+              </a:rPr>
+              <a:t>una</a:t>
+            </a:r>
+            <a:r>
+              <a:rPr sz="2400" b="1" dirty="0">
+                <a:solidFill>
+                  <a:srgbClr val="192D3E"/>
+                </a:solidFill>
+                <a:latin typeface="Arial"/>
+              </a:rPr>
+              <a:t> </a:t>
+            </a:r>
+            <a:r>
+              <a:rPr sz="2400" b="1" dirty="0" err="1">
+                <a:solidFill>
+                  <a:srgbClr val="192D3E"/>
+                </a:solidFill>
+                <a:latin typeface="Arial"/>
+              </a:rPr>
+              <a:t>capacitat</a:t>
+            </a:r>
+            <a:r>
+              <a:rPr lang="es-ES" sz="2400" b="1" dirty="0">
+                <a:solidFill>
+                  <a:srgbClr val="192D3E"/>
+                </a:solidFill>
+                <a:latin typeface="Arial"/>
+              </a:rPr>
+              <a:t> funcional</a:t>
+            </a:r>
+            <a:r>
+              <a:rPr sz="2400" b="1" dirty="0">
+                <a:solidFill>
+                  <a:srgbClr val="192D3E"/>
+                </a:solidFill>
+                <a:latin typeface="Arial"/>
+              </a:rPr>
+              <a:t>, no </a:t>
             </a:r>
             <a:r>
               <a:rPr sz="2400" b="1" dirty="0" err="1">
@@ -9687,7 +9312,7 @@
 </file>
 
 <file path=ppt/slides/slide5.xml><?xml version="1.0" encoding="utf-8"?>
-<p:sld xmlns:a="http://schemas.openxmlformats.org/drawingml/2006/main" xmlns:r="http://schemas.openxmlformats.org/officeDocument/2006/relationships" xmlns:p="http://schemas.openxmlformats.org/presentationml/2006/main">
+<p:sld xmlns:a="http://schemas.openxmlformats.org/drawingml/2006/main" xmlns:p="http://schemas.openxmlformats.org/presentationml/2006/main" xmlns:r="http://schemas.openxmlformats.org/officeDocument/2006/relationships">
   <p:cSld>
     <p:spTree>
       <p:nvGrpSpPr>
@@ -9727,94 +9352,13 @@
           <a:p>
             <a:pPr algn="l"/>
             <a:r>
-              <a:rPr sz="2800" b="1" dirty="0" err="1">
-                <a:solidFill>
-                  <a:srgbClr val="192D3E"/>
-                </a:solidFill>
-                <a:latin typeface="Arial"/>
-              </a:rPr>
-              <a:t>Quina</a:t>
-            </a:r>
-            <a:r>
-              <a:rPr sz="2800" b="1" dirty="0">
-                <a:solidFill>
-                  <a:srgbClr val="192D3E"/>
-                </a:solidFill>
-                <a:latin typeface="Arial"/>
-              </a:rPr>
-              <a:t> </a:t>
-            </a:r>
-            <a:r>
-              <a:rPr sz="2800" b="1" dirty="0" err="1">
-                <a:solidFill>
-                  <a:srgbClr val="192D3E"/>
-                </a:solidFill>
-                <a:latin typeface="Arial"/>
-              </a:rPr>
-              <a:t>informació</a:t>
-            </a:r>
-            <a:r>
-              <a:rPr sz="2800" b="1" dirty="0">
-                <a:solidFill>
-                  <a:srgbClr val="192D3E"/>
-                </a:solidFill>
-                <a:latin typeface="Arial"/>
-              </a:rPr>
-              <a:t> externa </a:t>
-            </a:r>
-            <a:r>
-              <a:rPr sz="2800" b="1" dirty="0" err="1">
-                <a:solidFill>
-                  <a:srgbClr val="192D3E"/>
-                </a:solidFill>
-                <a:latin typeface="Arial"/>
-              </a:rPr>
-              <a:t>necessita</a:t>
-            </a:r>
-            <a:r>
-              <a:rPr sz="2800" b="1" dirty="0">
-                <a:solidFill>
-                  <a:srgbClr val="192D3E"/>
-                </a:solidFill>
-                <a:latin typeface="Arial"/>
-              </a:rPr>
-              <a:t> </a:t>
-            </a:r>
-            <a:r>
-              <a:rPr sz="2800" b="1" dirty="0" err="1">
-                <a:solidFill>
-                  <a:srgbClr val="192D3E"/>
-                </a:solidFill>
-                <a:latin typeface="Arial"/>
-              </a:rPr>
-              <a:t>el</a:t>
-            </a:r>
-            <a:r>
-              <a:rPr sz="2800" b="1" dirty="0">
-                <a:solidFill>
-                  <a:srgbClr val="192D3E"/>
-                </a:solidFill>
-                <a:latin typeface="Arial"/>
-              </a:rPr>
-              <a:t> </a:t>
-            </a:r>
-            <a:r>
-              <a:rPr sz="2800" b="1" dirty="0" err="1">
-                <a:solidFill>
-                  <a:srgbClr val="192D3E"/>
-                </a:solidFill>
-                <a:latin typeface="Arial"/>
-              </a:rPr>
-              <a:t>procediment</a:t>
-            </a:r>
-            <a:r>
-              <a:rPr sz="2800" b="1" dirty="0">
-                <a:solidFill>
-                  <a:srgbClr val="192D3E"/>
-                </a:solidFill>
-                <a:latin typeface="Arial"/>
-              </a:rPr>
-              <a:t>?</a:t>
+              <a:rPr lang="ca-ES" sz="2800" b="1" noProof="1">
+                <a:solidFill>
+                  <a:srgbClr val="192D3E"/>
+                </a:solidFill>
+                <a:latin typeface="Arial"/>
+              </a:rPr>
+              <a:t>Quina informació externa necessita el procediment?</a:t>
             </a:r>
           </a:p>
         </p:txBody>
@@ -9843,7 +9387,7 @@
           <a:p>
             <a:pPr algn="l"/>
             <a:r>
-              <a:rPr sz="1300" b="0">
+              <a:rPr lang="ca-ES" sz="1300" b="0" noProof="1">
                 <a:solidFill>
                   <a:srgbClr val="66707A"/>
                 </a:solidFill>
@@ -9918,7 +9462,7 @@
           <a:lstStyle/>
           <a:p>
             <a:pPr algn="ctr"/>
-            <a:endParaRPr/>
+            <a:endParaRPr lang="ca-ES" noProof="1"/>
           </a:p>
         </p:txBody>
       </p:sp>
@@ -9938,8 +9482,8 @@
         </p:blipFill>
         <p:spPr>
           <a:xfrm>
-            <a:off x="2889754" y="1234440"/>
-            <a:ext cx="2541531" cy="4709160"/>
+            <a:off x="2460482" y="1234440"/>
+            <a:ext cx="3400073" cy="4709160"/>
           </a:xfrm>
           <a:prstGeom prst="rect">
             <a:avLst/>
@@ -9948,14 +9492,85 @@
       </p:pic>
       <p:sp>
         <p:nvSpPr>
-          <p:cNvPr id="7" name="TextBox 6"/>
+          <p:cNvPr id="11" name="TextBox 10"/>
           <p:cNvSpPr txBox="1"/>
           <p:nvPr/>
         </p:nvSpPr>
         <p:spPr>
           <a:xfrm>
-            <a:off x="8183879" y="1417320"/>
-            <a:ext cx="2926080" cy="320040"/>
+            <a:off x="7850000" y="5180000"/>
+            <a:ext cx="3370000" cy="520000"/>
+          </a:xfrm>
+          <a:prstGeom prst="rect">
+            <a:avLst/>
+          </a:prstGeom>
+          <a:noFill/>
+        </p:spPr>
+        <p:txBody>
+          <a:bodyPr wrap="square">
+            <a:normAutofit fontScale="92500" lnSpcReduction="20000"/>
+          </a:bodyPr>
+          <a:lstStyle/>
+          <a:p>
+            <a:pPr algn="ctr"/>
+            <a:r>
+              <a:rPr lang="ca-ES" sz="1370" b="1" noProof="1">
+                <a:solidFill>
+                  <a:srgbClr val="192D3E"/>
+                </a:solidFill>
+                <a:latin typeface="Arial"/>
+              </a:rPr>
+              <a:t>El procediment necessita informació administrativa,
+no una API concreta.</a:t>
+            </a:r>
+          </a:p>
+        </p:txBody>
+      </p:sp>
+      <p:sp>
+        <p:nvSpPr>
+          <p:cNvPr id="12" name="TextBox 11"/>
+          <p:cNvSpPr txBox="1"/>
+          <p:nvPr/>
+        </p:nvSpPr>
+        <p:spPr>
+          <a:xfrm>
+            <a:off x="1028700" y="6020000"/>
+            <a:ext cx="10492740" cy="420000"/>
+          </a:xfrm>
+          <a:prstGeom prst="rect">
+            <a:avLst/>
+          </a:prstGeom>
+          <a:noFill/>
+        </p:spPr>
+        <p:txBody>
+          <a:bodyPr wrap="square">
+            <a:normAutofit/>
+          </a:bodyPr>
+          <a:lstStyle/>
+          <a:p>
+            <a:pPr algn="ctr"/>
+            <a:r>
+              <a:rPr lang="ca-ES" sz="1000" b="0" noProof="1">
+                <a:solidFill>
+                  <a:srgbClr val="66707A"/>
+                </a:solidFill>
+                <a:latin typeface="Arial"/>
+              </a:rPr>
+              <a:t>PICA = Plataforma d’Integració i Col·laboració Administrativa. En aquesta sessió es tracta com a canal corporatiu d’interoperabilitat, no com a font administrativa original del mateix tipus que AEAT o Cadastre.</a:t>
+            </a:r>
+          </a:p>
+        </p:txBody>
+      </p:sp>
+      <p:sp>
+        <p:nvSpPr>
+          <p:cNvPr id="13" name="TextBox 12"/>
+          <p:cNvSpPr txBox="1"/>
+          <p:nvPr/>
+        </p:nvSpPr>
+        <p:spPr>
+          <a:xfrm>
+            <a:off x="594360" y="6473952"/>
+            <a:ext cx="8595360" cy="201168"/>
           </a:xfrm>
           <a:prstGeom prst="rect">
             <a:avLst/>
@@ -9968,113 +9583,29 @@
           </a:bodyPr>
           <a:lstStyle/>
           <a:p>
-            <a:pPr algn="ctr"/>
-            <a:r>
-              <a:rPr sz="1600" b="1">
-                <a:solidFill>
-                  <a:srgbClr val="236092"/>
-                </a:solidFill>
-                <a:latin typeface="Arial"/>
-              </a:rPr>
-              <a:t>NECESSITAT</a:t>
-            </a:r>
-          </a:p>
-        </p:txBody>
-      </p:sp>
-      <p:sp>
-        <p:nvSpPr>
-          <p:cNvPr id="8" name="TextBox 7"/>
+            <a:pPr algn="l"/>
+            <a:r>
+              <a:rPr lang="ca-ES" sz="800" b="0" noProof="1">
+                <a:solidFill>
+                  <a:srgbClr val="66707A"/>
+                </a:solidFill>
+                <a:latin typeface="Arial"/>
+              </a:rPr>
+              <a:t>Disseny de Sistemes d'Informació · Ports de sortida en arquitectura hexagonal</a:t>
+            </a:r>
+          </a:p>
+        </p:txBody>
+      </p:sp>
+      <p:sp>
+        <p:nvSpPr>
+          <p:cNvPr id="14" name="TextBox 13"/>
           <p:cNvSpPr txBox="1"/>
           <p:nvPr/>
         </p:nvSpPr>
         <p:spPr>
           <a:xfrm>
-            <a:off x="8275320" y="1828800"/>
-            <a:ext cx="2743200" cy="960120"/>
-          </a:xfrm>
-          <a:prstGeom prst="rect">
-            <a:avLst/>
-          </a:prstGeom>
-          <a:noFill/>
-        </p:spPr>
-        <p:txBody>
-          <a:bodyPr wrap="square">
-            <a:normAutofit fontScale="92500" lnSpcReduction="10000"/>
-          </a:bodyPr>
-          <a:lstStyle/>
-          <a:p>
-            <a:pPr>
-              <a:spcAft>
-                <a:spcPts val="800"/>
-              </a:spcAft>
-              <a:defRPr sz="1700">
-                <a:solidFill>
-                  <a:srgbClr val="262626"/>
-                </a:solidFill>
-                <a:latin typeface="Arial"/>
-              </a:defRPr>
-            </a:pPr>
-            <a:r>
-              <a:rPr dirty="0"/>
-              <a:t>Renda familiar</a:t>
-            </a:r>
-          </a:p>
-          <a:p>
-            <a:pPr>
-              <a:spcAft>
-                <a:spcPts val="800"/>
-              </a:spcAft>
-              <a:defRPr sz="1700">
-                <a:solidFill>
-                  <a:srgbClr val="262626"/>
-                </a:solidFill>
-                <a:latin typeface="Arial"/>
-              </a:defRPr>
-            </a:pPr>
-            <a:r>
-              <a:rPr dirty="0" err="1"/>
-              <a:t>Patrimoni</a:t>
-            </a:r>
-            <a:endParaRPr dirty="0"/>
-          </a:p>
-          <a:p>
-            <a:pPr>
-              <a:spcAft>
-                <a:spcPts val="800"/>
-              </a:spcAft>
-              <a:defRPr sz="1700">
-                <a:solidFill>
-                  <a:srgbClr val="262626"/>
-                </a:solidFill>
-                <a:latin typeface="Arial"/>
-              </a:defRPr>
-            </a:pPr>
-            <a:r>
-              <a:rPr dirty="0" err="1"/>
-              <a:t>Béns</a:t>
-            </a:r>
-            <a:r>
-              <a:rPr dirty="0"/>
-              <a:t> </a:t>
-            </a:r>
-            <a:r>
-              <a:rPr dirty="0" err="1"/>
-              <a:t>immobles</a:t>
-            </a:r>
-            <a:endParaRPr dirty="0"/>
-          </a:p>
-        </p:txBody>
-      </p:sp>
-      <p:sp>
-        <p:nvSpPr>
-          <p:cNvPr id="9" name="TextBox 8"/>
-          <p:cNvSpPr txBox="1"/>
-          <p:nvPr/>
-        </p:nvSpPr>
-        <p:spPr>
-          <a:xfrm>
-            <a:off x="8183879" y="3063240"/>
-            <a:ext cx="2926080" cy="320040"/>
+            <a:off x="11155680" y="6473952"/>
+            <a:ext cx="411480" cy="201168"/>
           </a:xfrm>
           <a:prstGeom prst="rect">
             <a:avLst/>
@@ -10087,241 +9618,243 @@
           </a:bodyPr>
           <a:lstStyle/>
           <a:p>
-            <a:pPr algn="ctr"/>
-            <a:r>
-              <a:rPr sz="1600" b="1">
+            <a:pPr algn="r"/>
+            <a:r>
+              <a:rPr lang="ca-ES" sz="800" b="0" noProof="1">
+                <a:solidFill>
+                  <a:srgbClr val="66707A"/>
+                </a:solidFill>
+                <a:latin typeface="Arial"/>
+              </a:rPr>
+              <a:t>5</a:t>
+            </a:r>
+          </a:p>
+        </p:txBody>
+      </p:sp>
+      <p:sp>
+        <p:nvSpPr>
+          <p:cNvPr id="15" name="Grup necessitat"/>
+          <p:cNvSpPr/>
+          <p:nvPr/>
+        </p:nvSpPr>
+        <p:spPr>
+          <a:xfrm>
+            <a:off x="7850000" y="1375000"/>
+            <a:ext cx="3370000" cy="1330000"/>
+          </a:xfrm>
+          <a:prstGeom prst="roundRect">
+            <a:avLst/>
+          </a:prstGeom>
+          <a:solidFill>
+            <a:srgbClr val="F4F9FD"/>
+          </a:solidFill>
+          <a:ln w="9525">
+            <a:solidFill>
+              <a:srgbClr val="D6DBE0"/>
+            </a:solidFill>
+          </a:ln>
+        </p:spPr>
+        <p:txBody>
+          <a:bodyPr wrap="square" lIns="190000" tIns="120000" rIns="190000" bIns="100000"/>
+          <a:lstStyle/>
+          <a:p>
+            <a:pPr algn="ctr">
+              <a:spcAft>
+                <a:spcPts val="650"/>
+              </a:spcAft>
+            </a:pPr>
+            <a:r>
+              <a:rPr lang="ca-ES" sz="1250" b="1" noProof="1">
                 <a:solidFill>
                   <a:srgbClr val="236092"/>
                 </a:solidFill>
                 <a:latin typeface="Arial"/>
               </a:rPr>
-              <a:t>FONTS</a:t>
-            </a:r>
-          </a:p>
-        </p:txBody>
-      </p:sp>
-      <p:sp>
-        <p:nvSpPr>
-          <p:cNvPr id="10" name="TextBox 9"/>
-          <p:cNvSpPr txBox="1"/>
-          <p:nvPr/>
-        </p:nvSpPr>
-        <p:spPr>
-          <a:xfrm>
-            <a:off x="8275320" y="3474720"/>
-            <a:ext cx="2743200" cy="914400"/>
-          </a:xfrm>
-          <a:prstGeom prst="rect">
-            <a:avLst/>
-          </a:prstGeom>
-          <a:noFill/>
-        </p:spPr>
-        <p:txBody>
-          <a:bodyPr wrap="square">
-            <a:normAutofit fontScale="92500" lnSpcReduction="20000"/>
-          </a:bodyPr>
-          <a:lstStyle/>
-          <a:p>
-            <a:pPr>
+              <a:t>NECESSITAT</a:t>
+            </a:r>
+          </a:p>
+          <a:p>
+            <a:pPr algn="l">
               <a:spcAft>
-                <a:spcPts val="800"/>
+                <a:spcPts val="220"/>
               </a:spcAft>
-              <a:defRPr sz="1700">
+            </a:pPr>
+            <a:r>
+              <a:rPr lang="ca-ES" sz="1420" noProof="1">
                 <a:solidFill>
                   <a:srgbClr val="262626"/>
                 </a:solidFill>
                 <a:latin typeface="Arial"/>
-              </a:defRPr>
+              </a:rPr>
+              <a:t>Renda familiar</a:t>
+            </a:r>
+          </a:p>
+          <a:p>
+            <a:pPr algn="l">
+              <a:spcAft>
+                <a:spcPts val="220"/>
+              </a:spcAft>
             </a:pPr>
             <a:r>
+              <a:rPr lang="ca-ES" sz="1420" noProof="1">
+                <a:solidFill>
+                  <a:srgbClr val="262626"/>
+                </a:solidFill>
+                <a:latin typeface="Arial"/>
+              </a:rPr>
+              <a:t>Patrimoni</a:t>
+            </a:r>
+          </a:p>
+          <a:p>
+            <a:pPr algn="l">
+              <a:spcAft>
+                <a:spcPts val="220"/>
+              </a:spcAft>
+            </a:pPr>
+            <a:r>
+              <a:rPr lang="ca-ES" sz="1420" noProof="1">
+                <a:solidFill>
+                  <a:srgbClr val="262626"/>
+                </a:solidFill>
+                <a:latin typeface="Arial"/>
+              </a:rPr>
+              <a:t>Béns immobles</a:t>
+            </a:r>
+          </a:p>
+        </p:txBody>
+      </p:sp>
+      <p:sp>
+        <p:nvSpPr>
+          <p:cNvPr id="16" name="Grup fonts administratives"/>
+          <p:cNvSpPr/>
+          <p:nvPr/>
+        </p:nvSpPr>
+        <p:spPr>
+          <a:xfrm>
+            <a:off x="7850000" y="2860000"/>
+            <a:ext cx="3370000" cy="1120000"/>
+          </a:xfrm>
+          <a:prstGeom prst="roundRect">
+            <a:avLst/>
+          </a:prstGeom>
+          <a:solidFill>
+            <a:srgbClr val="F8FBF6"/>
+          </a:solidFill>
+          <a:ln w="9525">
+            <a:solidFill>
+              <a:srgbClr val="D6DBE0"/>
+            </a:solidFill>
+          </a:ln>
+        </p:spPr>
+        <p:txBody>
+          <a:bodyPr wrap="square" lIns="190000" tIns="120000" rIns="190000" bIns="100000"/>
+          <a:lstStyle/>
+          <a:p>
+            <a:pPr algn="ctr">
+              <a:spcAft>
+                <a:spcPts val="650"/>
+              </a:spcAft>
+            </a:pPr>
+            <a:r>
+              <a:rPr lang="ca-ES" sz="1250" b="1" noProof="1">
+                <a:solidFill>
+                  <a:srgbClr val="236092"/>
+                </a:solidFill>
+                <a:latin typeface="Arial"/>
+              </a:rPr>
+              <a:t>FONTS ADMINISTRATIVES</a:t>
+            </a:r>
+          </a:p>
+          <a:p>
+            <a:pPr algn="l">
+              <a:spcAft>
+                <a:spcPts val="220"/>
+              </a:spcAft>
+            </a:pPr>
+            <a:r>
+              <a:rPr lang="ca-ES" sz="1420" noProof="1">
+                <a:solidFill>
+                  <a:srgbClr val="262626"/>
+                </a:solidFill>
+                <a:latin typeface="Arial"/>
+              </a:rPr>
               <a:t>AEAT</a:t>
             </a:r>
           </a:p>
           <a:p>
-            <a:pPr>
+            <a:pPr algn="l">
               <a:spcAft>
-                <a:spcPts val="800"/>
+                <a:spcPts val="220"/>
               </a:spcAft>
-              <a:defRPr sz="1700">
+            </a:pPr>
+            <a:r>
+              <a:rPr lang="ca-ES" sz="1420" noProof="1">
                 <a:solidFill>
                   <a:srgbClr val="262626"/>
                 </a:solidFill>
                 <a:latin typeface="Arial"/>
-              </a:defRPr>
+              </a:rPr>
+              <a:t>Cadastre</a:t>
+            </a:r>
+          </a:p>
+        </p:txBody>
+      </p:sp>
+      <p:sp>
+        <p:nvSpPr>
+          <p:cNvPr id="17" name="Grup canal interoperabilitat"/>
+          <p:cNvSpPr/>
+          <p:nvPr/>
+        </p:nvSpPr>
+        <p:spPr>
+          <a:xfrm>
+            <a:off x="7850000" y="4130000"/>
+            <a:ext cx="3370000" cy="780000"/>
+          </a:xfrm>
+          <a:prstGeom prst="roundRect">
+            <a:avLst/>
+          </a:prstGeom>
+          <a:solidFill>
+            <a:srgbClr val="FFF7E3"/>
+          </a:solidFill>
+          <a:ln w="9525">
+            <a:solidFill>
+              <a:srgbClr val="D6DBE0"/>
+            </a:solidFill>
+          </a:ln>
+        </p:spPr>
+        <p:txBody>
+          <a:bodyPr wrap="square" lIns="190000" tIns="120000" rIns="190000" bIns="100000"/>
+          <a:lstStyle/>
+          <a:p>
+            <a:pPr algn="ctr">
+              <a:spcAft>
+                <a:spcPts val="650"/>
+              </a:spcAft>
             </a:pPr>
             <a:r>
-              <a:t>Cadastre</a:t>
-            </a:r>
-          </a:p>
-          <a:p>
-            <a:pPr>
+              <a:rPr lang="ca-ES" sz="1250" b="1" noProof="1">
+                <a:solidFill>
+                  <a:srgbClr val="236092"/>
+                </a:solidFill>
+                <a:latin typeface="Arial"/>
+              </a:rPr>
+              <a:t>CANAL D’INTEROPERABILITAT</a:t>
+            </a:r>
+          </a:p>
+          <a:p>
+            <a:pPr algn="l">
               <a:spcAft>
-                <a:spcPts val="800"/>
+                <a:spcPts val="220"/>
               </a:spcAft>
-              <a:defRPr sz="1700">
+            </a:pPr>
+            <a:r>
+              <a:rPr lang="ca-ES" sz="1420" noProof="1">
                 <a:solidFill>
                   <a:srgbClr val="262626"/>
                 </a:solidFill>
                 <a:latin typeface="Arial"/>
-              </a:defRPr>
-            </a:pPr>
-            <a:r>
+              </a:rPr>
               <a:t>PICA</a:t>
-            </a:r>
-          </a:p>
-        </p:txBody>
-      </p:sp>
-      <p:sp>
-        <p:nvSpPr>
-          <p:cNvPr id="11" name="TextBox 10"/>
-          <p:cNvSpPr txBox="1"/>
-          <p:nvPr/>
-        </p:nvSpPr>
-        <p:spPr>
-          <a:xfrm>
-            <a:off x="8092440" y="4892040"/>
-            <a:ext cx="3063240" cy="685800"/>
-          </a:xfrm>
-          <a:prstGeom prst="rect">
-            <a:avLst/>
-          </a:prstGeom>
-          <a:noFill/>
-        </p:spPr>
-        <p:txBody>
-          <a:bodyPr wrap="square">
-            <a:normAutofit fontScale="92500" lnSpcReduction="20000"/>
-          </a:bodyPr>
-          <a:lstStyle/>
-          <a:p>
-            <a:pPr algn="ctr"/>
-            <a:r>
-              <a:rPr sz="1600" b="1">
-                <a:solidFill>
-                  <a:srgbClr val="192D3E"/>
-                </a:solidFill>
-                <a:latin typeface="Arial"/>
-              </a:rPr>
-              <a:t>El procediment necessita informació administrativa,
-no una API concreta.</a:t>
-            </a:r>
-          </a:p>
-        </p:txBody>
-      </p:sp>
-      <p:sp>
-        <p:nvSpPr>
-          <p:cNvPr id="12" name="TextBox 11"/>
-          <p:cNvSpPr txBox="1"/>
-          <p:nvPr/>
-        </p:nvSpPr>
-        <p:spPr>
-          <a:xfrm>
-            <a:off x="1028700" y="6003036"/>
-            <a:ext cx="10492740" cy="457200"/>
-          </a:xfrm>
-          <a:prstGeom prst="rect">
-            <a:avLst/>
-          </a:prstGeom>
-          <a:noFill/>
-        </p:spPr>
-        <p:txBody>
-          <a:bodyPr wrap="square">
-            <a:normAutofit/>
-          </a:bodyPr>
-          <a:lstStyle/>
-          <a:p>
-            <a:pPr algn="ctr"/>
-            <a:r>
-              <a:rPr lang="es-ES" sz="1000" b="0" dirty="0">
-                <a:solidFill>
-                  <a:srgbClr val="66707A"/>
-                </a:solidFill>
-                <a:latin typeface="Arial"/>
-              </a:rPr>
-              <a:t>PICA = Plataforma d’Integració i Col·laboració Administrativa de la Generalitat de Catalunya. És una plataforma corporativa de la Generalitat per facilitar la interoperabilitat entre sistemes de la Generalitat, altres administracions públiques i institucions.</a:t>
-            </a:r>
-            <a:br>
-              <a:rPr lang="es-ES" sz="1000" b="0" dirty="0">
-                <a:solidFill>
-                  <a:srgbClr val="66707A"/>
-                </a:solidFill>
-                <a:latin typeface="Arial"/>
-              </a:rPr>
-            </a:br>
-            <a:endParaRPr lang="es-ES" sz="1000" b="0" dirty="0">
-              <a:solidFill>
-                <a:srgbClr val="66707A"/>
-              </a:solidFill>
-              <a:latin typeface="Arial"/>
-            </a:endParaRPr>
-          </a:p>
-        </p:txBody>
-      </p:sp>
-      <p:sp>
-        <p:nvSpPr>
-          <p:cNvPr id="13" name="TextBox 12"/>
-          <p:cNvSpPr txBox="1"/>
-          <p:nvPr/>
-        </p:nvSpPr>
-        <p:spPr>
-          <a:xfrm>
-            <a:off x="594360" y="6473952"/>
-            <a:ext cx="8595360" cy="201168"/>
-          </a:xfrm>
-          <a:prstGeom prst="rect">
-            <a:avLst/>
-          </a:prstGeom>
-          <a:noFill/>
-        </p:spPr>
-        <p:txBody>
-          <a:bodyPr wrap="square">
-            <a:normAutofit lnSpcReduction="10000"/>
-          </a:bodyPr>
-          <a:lstStyle/>
-          <a:p>
-            <a:pPr algn="l"/>
-            <a:r>
-              <a:rPr sz="800" b="0">
-                <a:solidFill>
-                  <a:srgbClr val="66707A"/>
-                </a:solidFill>
-                <a:latin typeface="Arial"/>
-              </a:rPr>
-              <a:t>Disseny de Sistemes d'Informació · Ports de sortida en arquitectura hexagonal</a:t>
-            </a:r>
-          </a:p>
-        </p:txBody>
-      </p:sp>
-      <p:sp>
-        <p:nvSpPr>
-          <p:cNvPr id="14" name="TextBox 13"/>
-          <p:cNvSpPr txBox="1"/>
-          <p:nvPr/>
-        </p:nvSpPr>
-        <p:spPr>
-          <a:xfrm>
-            <a:off x="11155680" y="6473952"/>
-            <a:ext cx="411480" cy="201168"/>
-          </a:xfrm>
-          <a:prstGeom prst="rect">
-            <a:avLst/>
-          </a:prstGeom>
-          <a:noFill/>
-        </p:spPr>
-        <p:txBody>
-          <a:bodyPr wrap="square">
-            <a:normAutofit lnSpcReduction="10000"/>
-          </a:bodyPr>
-          <a:lstStyle/>
-          <a:p>
-            <a:pPr algn="r"/>
-            <a:r>
-              <a:rPr sz="800" b="0">
-                <a:solidFill>
-                  <a:srgbClr val="66707A"/>
-                </a:solidFill>
-                <a:latin typeface="Arial"/>
-              </a:rPr>
-              <a:t>5</a:t>
             </a:r>
           </a:p>
         </p:txBody>
@@ -10490,17 +10023,11 @@
                 </a:solidFill>
                 <a:latin typeface="Arial"/>
               </a:rPr>
-              <a:t>Cas </a:t>
-            </a:r>
-            <a:r>
-              <a:rPr sz="2900" b="1" dirty="0" err="1">
-                <a:solidFill>
-                  <a:srgbClr val="192D3E"/>
-                </a:solidFill>
-                <a:latin typeface="Arial"/>
-              </a:rPr>
-              <a:t>d'ús</a:t>
-            </a:r>
+              <a:t>Escenari d'acoblament indesitjable:</a:t>
+            </a:r>
+          </a:p>
+          <a:p>
+            <a:pPr algn="ctr"/>
             <a:r>
               <a:rPr sz="2900" b="1" dirty="0">
                 <a:solidFill>
@@ -10508,32 +10035,8 @@
                 </a:solidFill>
                 <a:latin typeface="Arial"/>
               </a:rPr>
-              <a:t>  →  SOAP/XML  →  PICA  →  AEAT</a:t>
-            </a:r>
-            <a:r>
-              <a:rPr lang="es-ES" sz="2900" b="1" dirty="0">
-                <a:solidFill>
-                  <a:srgbClr val="192D3E"/>
-                </a:solidFill>
-                <a:latin typeface="Arial"/>
-              </a:rPr>
-              <a:t> / </a:t>
-            </a:r>
-            <a:r>
-              <a:rPr lang="es-ES" sz="2900" b="1" dirty="0" err="1">
-                <a:solidFill>
-                  <a:srgbClr val="192D3E"/>
-                </a:solidFill>
-                <a:latin typeface="Arial"/>
-              </a:rPr>
-              <a:t>Cadastre</a:t>
-            </a:r>
-            <a:endParaRPr sz="2900" b="1" dirty="0">
-              <a:solidFill>
-                <a:srgbClr val="192D3E"/>
-              </a:solidFill>
-              <a:latin typeface="Arial"/>
-            </a:endParaRPr>
+              <a:t>Cas d'ús  →  SOAP/XML  →  PICA  →  AEAT / Cadastre</a:t>
+            </a:r>
           </a:p>
         </p:txBody>
       </p:sp>
@@ -10783,7 +10286,7 @@
                 <a:latin typeface="Arial"/>
               </a:rPr>
               <a:t>Impacte en el cas d’ús
-L’evolució de l’API travessa la frontera</a:t>
+L’evolució de la integració travessa la frontera</a:t>
             </a:r>
             <a:endParaRPr sz="1800" b="1" dirty="0">
               <a:solidFill>
@@ -10870,116 +10373,8 @@
                 </a:solidFill>
                 <a:latin typeface="Arial"/>
               </a:rPr>
-              <a:t>Risc</a:t>
-            </a:r>
-            <a:r>
-              <a:rPr sz="1700" b="1" dirty="0">
-                <a:solidFill>
-                  <a:srgbClr val="192D3E"/>
-                </a:solidFill>
-                <a:latin typeface="Arial"/>
-              </a:rPr>
-              <a:t> de </a:t>
-            </a:r>
-            <a:r>
-              <a:rPr sz="1700" b="1" dirty="0" err="1">
-                <a:solidFill>
-                  <a:srgbClr val="192D3E"/>
-                </a:solidFill>
-                <a:latin typeface="Arial"/>
-              </a:rPr>
-              <a:t>continuïtat</a:t>
-            </a:r>
-            <a:r>
-              <a:rPr sz="1700" b="1" dirty="0">
-                <a:solidFill>
-                  <a:srgbClr val="192D3E"/>
-                </a:solidFill>
-                <a:latin typeface="Arial"/>
-              </a:rPr>
-              <a:t> </a:t>
-            </a:r>
-            <a:r>
-              <a:rPr sz="1700" b="1" dirty="0" err="1">
-                <a:solidFill>
-                  <a:srgbClr val="192D3E"/>
-                </a:solidFill>
-                <a:latin typeface="Arial"/>
-              </a:rPr>
-              <a:t>operativa</a:t>
-            </a:r>
-            <a:r>
-              <a:rPr sz="1700" b="1" dirty="0">
-                <a:solidFill>
-                  <a:srgbClr val="192D3E"/>
-                </a:solidFill>
-                <a:latin typeface="Arial"/>
-              </a:rPr>
-              <a:t>
-</a:t>
-            </a:r>
-            <a:r>
-              <a:rPr sz="1700" b="1" dirty="0" err="1">
-                <a:solidFill>
-                  <a:srgbClr val="192D3E"/>
-                </a:solidFill>
-                <a:latin typeface="Arial"/>
-              </a:rPr>
-              <a:t>Manteniment</a:t>
-            </a:r>
-            <a:r>
-              <a:rPr sz="1700" b="1" dirty="0">
-                <a:solidFill>
-                  <a:srgbClr val="192D3E"/>
-                </a:solidFill>
-                <a:latin typeface="Arial"/>
-              </a:rPr>
-              <a:t> </a:t>
-            </a:r>
-            <a:r>
-              <a:rPr sz="1700" b="1" dirty="0" err="1">
-                <a:solidFill>
-                  <a:srgbClr val="192D3E"/>
-                </a:solidFill>
-                <a:latin typeface="Arial"/>
-              </a:rPr>
-              <a:t>més</a:t>
-            </a:r>
-            <a:r>
-              <a:rPr sz="1700" b="1" dirty="0">
-                <a:solidFill>
-                  <a:srgbClr val="192D3E"/>
-                </a:solidFill>
-                <a:latin typeface="Arial"/>
-              </a:rPr>
-              <a:t> </a:t>
-            </a:r>
-            <a:r>
-              <a:rPr sz="1700" b="1" dirty="0" err="1">
-                <a:solidFill>
-                  <a:srgbClr val="192D3E"/>
-                </a:solidFill>
-                <a:latin typeface="Arial"/>
-              </a:rPr>
-              <a:t>fràgil</a:t>
-            </a:r>
-            <a:r>
-              <a:rPr sz="1700" b="1" dirty="0">
-                <a:solidFill>
-                  <a:srgbClr val="192D3E"/>
-                </a:solidFill>
-                <a:latin typeface="Arial"/>
-              </a:rPr>
-              <a:t> del </a:t>
-            </a:r>
-            <a:r>
-              <a:rPr sz="1700" b="1" dirty="0" err="1">
-                <a:solidFill>
-                  <a:srgbClr val="192D3E"/>
-                </a:solidFill>
-                <a:latin typeface="Arial"/>
-              </a:rPr>
-              <a:t>servei</a:t>
+              <a:t>Més superfície d'impacte
+Manteniment més fràgil del servei</a:t>
             </a:r>
             <a:endParaRPr sz="1800" b="1" dirty="0">
               <a:solidFill>
@@ -11020,169 +10415,7 @@
                 </a:solidFill>
                 <a:latin typeface="Arial"/>
               </a:rPr>
-              <a:t>El </a:t>
-            </a:r>
-            <a:r>
-              <a:rPr sz="2500" b="1" dirty="0" err="1">
-                <a:solidFill>
-                  <a:srgbClr val="236092"/>
-                </a:solidFill>
-                <a:latin typeface="Arial"/>
-              </a:rPr>
-              <a:t>problema</a:t>
-            </a:r>
-            <a:r>
-              <a:rPr sz="2500" b="1" dirty="0">
-                <a:solidFill>
-                  <a:srgbClr val="236092"/>
-                </a:solidFill>
-                <a:latin typeface="Arial"/>
-              </a:rPr>
-              <a:t> no </a:t>
-            </a:r>
-            <a:r>
-              <a:rPr sz="2500" b="1" dirty="0" err="1">
-                <a:solidFill>
-                  <a:srgbClr val="236092"/>
-                </a:solidFill>
-                <a:latin typeface="Arial"/>
-              </a:rPr>
-              <a:t>és</a:t>
-            </a:r>
-            <a:r>
-              <a:rPr sz="2500" b="1" dirty="0">
-                <a:solidFill>
-                  <a:srgbClr val="236092"/>
-                </a:solidFill>
-                <a:latin typeface="Arial"/>
-              </a:rPr>
-              <a:t> </a:t>
-            </a:r>
-            <a:r>
-              <a:rPr sz="2500" b="1" dirty="0" err="1">
-                <a:solidFill>
-                  <a:srgbClr val="236092"/>
-                </a:solidFill>
-                <a:latin typeface="Arial"/>
-              </a:rPr>
-              <a:t>consumir</a:t>
-            </a:r>
-            <a:r>
-              <a:rPr sz="2500" b="1" dirty="0">
-                <a:solidFill>
-                  <a:srgbClr val="236092"/>
-                </a:solidFill>
-                <a:latin typeface="Arial"/>
-              </a:rPr>
-              <a:t> PICA; </a:t>
-            </a:r>
-            <a:r>
-              <a:rPr sz="2500" b="1" dirty="0" err="1">
-                <a:solidFill>
-                  <a:srgbClr val="236092"/>
-                </a:solidFill>
-                <a:latin typeface="Arial"/>
-              </a:rPr>
-              <a:t>és</a:t>
-            </a:r>
-            <a:r>
-              <a:rPr sz="2500" b="1" dirty="0">
-                <a:solidFill>
-                  <a:srgbClr val="236092"/>
-                </a:solidFill>
-                <a:latin typeface="Arial"/>
-              </a:rPr>
-              <a:t> que </a:t>
-            </a:r>
-            <a:r>
-              <a:rPr sz="2500" b="1" dirty="0" err="1">
-                <a:solidFill>
-                  <a:srgbClr val="236092"/>
-                </a:solidFill>
-                <a:latin typeface="Arial"/>
-              </a:rPr>
-              <a:t>el</a:t>
-            </a:r>
-            <a:r>
-              <a:rPr sz="2500" b="1" dirty="0">
-                <a:solidFill>
-                  <a:srgbClr val="236092"/>
-                </a:solidFill>
-                <a:latin typeface="Arial"/>
-              </a:rPr>
-              <a:t> </a:t>
-            </a:r>
-            <a:r>
-              <a:rPr sz="2500" b="1" dirty="0" err="1">
-                <a:solidFill>
-                  <a:srgbClr val="236092"/>
-                </a:solidFill>
-                <a:latin typeface="Arial"/>
-              </a:rPr>
-              <a:t>procediment</a:t>
-            </a:r>
-            <a:r>
-              <a:rPr sz="2500" b="1" dirty="0">
-                <a:solidFill>
-                  <a:srgbClr val="236092"/>
-                </a:solidFill>
-                <a:latin typeface="Arial"/>
-              </a:rPr>
-              <a:t> </a:t>
-            </a:r>
-            <a:r>
-              <a:rPr sz="2500" b="1" dirty="0" err="1">
-                <a:solidFill>
-                  <a:srgbClr val="236092"/>
-                </a:solidFill>
-                <a:latin typeface="Arial"/>
-              </a:rPr>
-              <a:t>en</a:t>
-            </a:r>
-            <a:r>
-              <a:rPr sz="2500" b="1" dirty="0">
-                <a:solidFill>
-                  <a:srgbClr val="236092"/>
-                </a:solidFill>
-                <a:latin typeface="Arial"/>
-              </a:rPr>
-              <a:t> </a:t>
-            </a:r>
-            <a:r>
-              <a:rPr sz="2500" b="1" dirty="0" err="1">
-                <a:solidFill>
-                  <a:srgbClr val="236092"/>
-                </a:solidFill>
-                <a:latin typeface="Arial"/>
-              </a:rPr>
-              <a:t>depengui</a:t>
-            </a:r>
-            <a:r>
-              <a:rPr sz="2500" b="1" dirty="0">
-                <a:solidFill>
-                  <a:srgbClr val="236092"/>
-                </a:solidFill>
-                <a:latin typeface="Arial"/>
-              </a:rPr>
-              <a:t> </a:t>
-            </a:r>
-            <a:r>
-              <a:rPr sz="2500" b="1" dirty="0" err="1">
-                <a:solidFill>
-                  <a:srgbClr val="236092"/>
-                </a:solidFill>
-                <a:latin typeface="Arial"/>
-              </a:rPr>
-              <a:t>directament</a:t>
-            </a:r>
-            <a:r>
-              <a:rPr sz="2500" b="1" dirty="0">
-                <a:solidFill>
-                  <a:srgbClr val="236092"/>
-                </a:solidFill>
-                <a:latin typeface="Arial"/>
-              </a:rPr>
-              <a:t>.</a:t>
+              <a:t>El problema no és consumir PICA; és que el procediment depengui directament dels detalls tècnics de la integració.</a:t>
             </a:r>
           </a:p>
         </p:txBody>
@@ -11287,340 +10520,7 @@
                 </a:solidFill>
                 <a:latin typeface="Arial"/>
               </a:rPr>
-              <a:t>Els</a:t>
-            </a:r>
-            <a:r>
-              <a:rPr lang="es-ES" sz="1400" b="0" dirty="0">
-                <a:solidFill>
-                  <a:srgbClr val="66707A"/>
-                </a:solidFill>
-                <a:latin typeface="Arial"/>
-              </a:rPr>
-              <a:t> </a:t>
-            </a:r>
-            <a:r>
-              <a:rPr lang="es-ES" sz="1400" b="0" dirty="0" err="1">
-                <a:solidFill>
-                  <a:srgbClr val="66707A"/>
-                </a:solidFill>
-                <a:latin typeface="Arial"/>
-              </a:rPr>
-              <a:t>principis</a:t>
-            </a:r>
-            <a:r>
-              <a:rPr lang="es-ES" sz="1400" b="0" dirty="0">
-                <a:solidFill>
-                  <a:srgbClr val="66707A"/>
-                </a:solidFill>
-                <a:latin typeface="Arial"/>
-              </a:rPr>
-              <a:t> del CTTI orienten </a:t>
-            </a:r>
-            <a:r>
-              <a:rPr lang="es-ES" sz="1400" b="0" dirty="0" err="1">
-                <a:solidFill>
-                  <a:srgbClr val="66707A"/>
-                </a:solidFill>
-                <a:latin typeface="Arial"/>
-              </a:rPr>
-              <a:t>cap</a:t>
-            </a:r>
-            <a:r>
-              <a:rPr lang="es-ES" sz="1400" b="0" dirty="0">
-                <a:solidFill>
-                  <a:srgbClr val="66707A"/>
-                </a:solidFill>
-                <a:latin typeface="Arial"/>
-              </a:rPr>
-              <a:t> a </a:t>
-            </a:r>
-            <a:r>
-              <a:rPr lang="es-ES" sz="1400" b="0" dirty="0" err="1">
-                <a:solidFill>
-                  <a:srgbClr val="66707A"/>
-                </a:solidFill>
-                <a:latin typeface="Arial"/>
-              </a:rPr>
-              <a:t>sistemes</a:t>
-            </a:r>
-            <a:r>
-              <a:rPr lang="es-ES" sz="1400" b="0" dirty="0">
-                <a:solidFill>
-                  <a:srgbClr val="66707A"/>
-                </a:solidFill>
-                <a:latin typeface="Arial"/>
-              </a:rPr>
-              <a:t> </a:t>
-            </a:r>
-            <a:r>
-              <a:rPr lang="es-ES" sz="1400" b="0" dirty="0" err="1">
-                <a:solidFill>
-                  <a:srgbClr val="66707A"/>
-                </a:solidFill>
-                <a:latin typeface="Arial"/>
-              </a:rPr>
-              <a:t>desacoblats</a:t>
-            </a:r>
-            <a:r>
-              <a:rPr lang="es-ES" sz="1400" b="0" dirty="0">
-                <a:solidFill>
-                  <a:srgbClr val="66707A"/>
-                </a:solidFill>
-                <a:latin typeface="Arial"/>
-              </a:rPr>
-              <a:t> i </a:t>
-            </a:r>
-            <a:r>
-              <a:rPr lang="es-ES" sz="1400" b="0" dirty="0" err="1">
-                <a:solidFill>
-                  <a:srgbClr val="66707A"/>
-                </a:solidFill>
-                <a:latin typeface="Arial"/>
-              </a:rPr>
-              <a:t>serveis</a:t>
-            </a:r>
-            <a:r>
-              <a:rPr lang="es-ES" sz="1400" b="0" dirty="0">
-                <a:solidFill>
-                  <a:srgbClr val="66707A"/>
-                </a:solidFill>
-                <a:latin typeface="Arial"/>
-              </a:rPr>
-              <a:t> </a:t>
-            </a:r>
-            <a:r>
-              <a:rPr lang="es-ES" sz="1400" b="0" dirty="0" err="1">
-                <a:solidFill>
-                  <a:srgbClr val="66707A"/>
-                </a:solidFill>
-                <a:latin typeface="Arial"/>
-              </a:rPr>
-              <a:t>substituïbles</a:t>
-            </a:r>
-            <a:r>
-              <a:rPr lang="es-ES" sz="1400" b="0" dirty="0">
-                <a:solidFill>
-                  <a:srgbClr val="66707A"/>
-                </a:solidFill>
-                <a:latin typeface="Arial"/>
-              </a:rPr>
-              <a:t>; per </a:t>
-            </a:r>
-            <a:r>
-              <a:rPr lang="es-ES" sz="1400" b="0" dirty="0" err="1">
-                <a:solidFill>
-                  <a:srgbClr val="66707A"/>
-                </a:solidFill>
-                <a:latin typeface="Arial"/>
-              </a:rPr>
-              <a:t>això</a:t>
-            </a:r>
-            <a:r>
-              <a:rPr lang="es-ES" sz="1400" b="0" dirty="0">
-                <a:solidFill>
-                  <a:srgbClr val="66707A"/>
-                </a:solidFill>
-                <a:latin typeface="Arial"/>
-              </a:rPr>
-              <a:t>, si la </a:t>
-            </a:r>
-            <a:r>
-              <a:rPr lang="es-ES" sz="1400" b="0" dirty="0" err="1">
-                <a:solidFill>
-                  <a:srgbClr val="66707A"/>
-                </a:solidFill>
-                <a:latin typeface="Arial"/>
-              </a:rPr>
-              <a:t>lògica</a:t>
-            </a:r>
-            <a:r>
-              <a:rPr lang="es-ES" sz="1400" b="0" dirty="0">
-                <a:solidFill>
-                  <a:srgbClr val="66707A"/>
-                </a:solidFill>
-                <a:latin typeface="Arial"/>
-              </a:rPr>
-              <a:t> del </a:t>
-            </a:r>
-            <a:r>
-              <a:rPr lang="es-ES" sz="1400" b="0" dirty="0" err="1">
-                <a:solidFill>
-                  <a:srgbClr val="66707A"/>
-                </a:solidFill>
-                <a:latin typeface="Arial"/>
-              </a:rPr>
-              <a:t>procediment</a:t>
-            </a:r>
-            <a:r>
-              <a:rPr lang="es-ES" sz="1400" b="0" dirty="0">
-                <a:solidFill>
-                  <a:srgbClr val="66707A"/>
-                </a:solidFill>
-                <a:latin typeface="Arial"/>
-              </a:rPr>
-              <a:t> </a:t>
-            </a:r>
-            <a:r>
-              <a:rPr lang="es-ES" sz="1400" b="0" dirty="0" err="1">
-                <a:solidFill>
-                  <a:srgbClr val="66707A"/>
-                </a:solidFill>
-                <a:latin typeface="Arial"/>
-              </a:rPr>
-              <a:t>administratiu</a:t>
-            </a:r>
-            <a:r>
-              <a:rPr lang="es-ES" sz="1400" b="0" dirty="0">
-                <a:solidFill>
-                  <a:srgbClr val="66707A"/>
-                </a:solidFill>
-                <a:latin typeface="Arial"/>
-              </a:rPr>
-              <a:t> queda vinculada a crides SOAP/XML contra PICA, </a:t>
-            </a:r>
-            <a:r>
-              <a:rPr lang="es-ES" sz="1400" b="0" dirty="0" err="1">
-                <a:solidFill>
-                  <a:srgbClr val="66707A"/>
-                </a:solidFill>
-                <a:latin typeface="Arial"/>
-              </a:rPr>
-              <a:t>qualsevol</a:t>
-            </a:r>
-            <a:r>
-              <a:rPr lang="es-ES" sz="1400" b="0" dirty="0">
-                <a:solidFill>
-                  <a:srgbClr val="66707A"/>
-                </a:solidFill>
-                <a:latin typeface="Arial"/>
-              </a:rPr>
-              <a:t> </a:t>
-            </a:r>
-            <a:r>
-              <a:rPr lang="es-ES" sz="1400" b="0" dirty="0" err="1">
-                <a:solidFill>
-                  <a:srgbClr val="66707A"/>
-                </a:solidFill>
-                <a:latin typeface="Arial"/>
-              </a:rPr>
-              <a:t>evolució</a:t>
-            </a:r>
-            <a:r>
-              <a:rPr lang="es-ES" sz="1400" b="0" dirty="0">
-                <a:solidFill>
-                  <a:srgbClr val="66707A"/>
-                </a:solidFill>
-                <a:latin typeface="Arial"/>
-              </a:rPr>
-              <a:t> </a:t>
-            </a:r>
-            <a:r>
-              <a:rPr lang="es-ES" sz="1400" b="0" dirty="0" err="1">
-                <a:solidFill>
-                  <a:srgbClr val="66707A"/>
-                </a:solidFill>
-                <a:latin typeface="Arial"/>
-              </a:rPr>
-              <a:t>cap</a:t>
-            </a:r>
-            <a:r>
-              <a:rPr lang="es-ES" sz="1400" b="0" dirty="0">
-                <a:solidFill>
-                  <a:srgbClr val="66707A"/>
-                </a:solidFill>
-                <a:latin typeface="Arial"/>
-              </a:rPr>
-              <a:t> a REST, API Manager o </a:t>
-            </a:r>
-            <a:r>
-              <a:rPr lang="es-ES" sz="1400" b="0" dirty="0" err="1">
-                <a:solidFill>
-                  <a:srgbClr val="66707A"/>
-                </a:solidFill>
-                <a:latin typeface="Arial"/>
-              </a:rPr>
-              <a:t>altres</a:t>
-            </a:r>
-            <a:r>
-              <a:rPr lang="es-ES" sz="1400" b="0" dirty="0">
-                <a:solidFill>
-                  <a:srgbClr val="66707A"/>
-                </a:solidFill>
-                <a:latin typeface="Arial"/>
-              </a:rPr>
-              <a:t> </a:t>
-            </a:r>
-            <a:r>
-              <a:rPr lang="es-ES" sz="1400" b="0" dirty="0" err="1">
-                <a:solidFill>
-                  <a:srgbClr val="66707A"/>
-                </a:solidFill>
-                <a:latin typeface="Arial"/>
-              </a:rPr>
-              <a:t>mecanismes</a:t>
-            </a:r>
-            <a:r>
-              <a:rPr lang="es-ES" sz="1400" b="0" dirty="0">
-                <a:solidFill>
-                  <a:srgbClr val="66707A"/>
-                </a:solidFill>
-                <a:latin typeface="Arial"/>
-              </a:rPr>
-              <a:t> </a:t>
-            </a:r>
-            <a:r>
-              <a:rPr lang="es-ES" sz="1400" b="0" dirty="0" err="1">
-                <a:solidFill>
-                  <a:srgbClr val="66707A"/>
-                </a:solidFill>
-                <a:latin typeface="Arial"/>
-              </a:rPr>
-              <a:t>pot</a:t>
-            </a:r>
-            <a:r>
-              <a:rPr lang="es-ES" sz="1400" b="0" dirty="0">
-                <a:solidFill>
-                  <a:srgbClr val="66707A"/>
-                </a:solidFill>
-                <a:latin typeface="Arial"/>
-              </a:rPr>
-              <a:t> impactar </a:t>
-            </a:r>
-            <a:r>
-              <a:rPr lang="es-ES" sz="1400" b="0" dirty="0" err="1">
-                <a:solidFill>
-                  <a:srgbClr val="66707A"/>
-                </a:solidFill>
-                <a:latin typeface="Arial"/>
-              </a:rPr>
-              <a:t>directament</a:t>
-            </a:r>
-            <a:r>
-              <a:rPr lang="es-ES" sz="1400" b="0" dirty="0">
-                <a:solidFill>
-                  <a:srgbClr val="66707A"/>
-                </a:solidFill>
-                <a:latin typeface="Arial"/>
-              </a:rPr>
-              <a:t> la </a:t>
-            </a:r>
-            <a:r>
-              <a:rPr lang="es-ES" sz="1400" b="0" dirty="0" err="1">
-                <a:solidFill>
-                  <a:srgbClr val="66707A"/>
-                </a:solidFill>
-                <a:latin typeface="Arial"/>
-              </a:rPr>
-              <a:t>tramitació</a:t>
-            </a:r>
-            <a:r>
-              <a:rPr lang="es-ES" sz="1400" b="0" dirty="0">
-                <a:solidFill>
-                  <a:srgbClr val="66707A"/>
-                </a:solidFill>
-                <a:latin typeface="Arial"/>
-              </a:rPr>
-              <a:t>.</a:t>
+              <a:t>Els principis del CTTI orienten cap a sistemes desacoblats i serveis substituïbles; per això, si la lògica del procediment queda vinculada a crides SOAP/XML contra la integració, qualsevol evolució del mecanisme pot impactar directament la tramitació.</a:t>
             </a:r>
             <a:endParaRPr sz="1400" b="0" dirty="0">
               <a:solidFill>
@@ -12268,12 +11168,9 @@
             </a:r>
           </a:p>
           <a:p>
-            <a:endParaRPr sz="500"/>
-          </a:p>
-          <a:p>
             <a:pPr algn="ctr"/>
             <a:r>
-              <a:rPr sz="1400" b="1">
+              <a:rPr sz="1650" b="1">
                 <a:solidFill>
                   <a:srgbClr val="192D3E"/>
                 </a:solidFill>
@@ -12285,22 +11182,19 @@
           <a:p>
             <a:pPr algn="ctr"/>
             <a:r>
-              <a:rPr sz="1300">
-                <a:solidFill>
-                  <a:srgbClr val="192D3E"/>
-                </a:solidFill>
-                <a:latin typeface="Arial"/>
-              </a:rPr>
-              <a:t>interfície de l’aplicació</a:t>
-            </a:r>
-          </a:p>
-          <a:p>
-            <a:endParaRPr sz="500"/>
+              <a:rPr sz="1650" b="1">
+                <a:solidFill>
+                  <a:srgbClr val="192D3E"/>
+                </a:solidFill>
+                <a:latin typeface="Arial"/>
+              </a:rPr>
+              <a:t>contracte de l’aplicació</a:t>
+            </a:r>
           </a:p>
           <a:p>
             <a:pPr algn="ctr"/>
             <a:r>
-              <a:rPr sz="1400" b="1">
+              <a:rPr sz="1650" b="1">
                 <a:solidFill>
                   <a:srgbClr val="192D3E"/>
                 </a:solidFill>
@@ -12312,7 +11206,7 @@
           <a:p>
             <a:pPr algn="ctr"/>
             <a:r>
-              <a:rPr sz="1300">
+              <a:rPr sz="1650" b="1">
                 <a:solidFill>
                   <a:srgbClr val="192D3E"/>
                 </a:solidFill>
@@ -12388,7 +11282,7 @@
                 </a:solidFill>
                 <a:latin typeface="Arial"/>
               </a:rPr>
-              <a:t>La infraestructura depèn del port definit per l’aplicació</a:t>
+              <a:t>Conceptualment és un contracte; en Java el representem amb una interfície</a:t>
             </a:r>
             <a:endParaRPr sz="2300" b="1" dirty="0">
               <a:solidFill>
@@ -12601,133 +11495,7 @@
                 </a:solidFill>
                 <a:latin typeface="Arial"/>
               </a:rPr>
-              <a:t>El cas </a:t>
-            </a:r>
-            <a:r>
-              <a:rPr lang="es-ES" sz="1300" b="0" dirty="0" err="1">
-                <a:solidFill>
-                  <a:srgbClr val="66707A"/>
-                </a:solidFill>
-                <a:latin typeface="Arial"/>
-              </a:rPr>
-              <a:t>d’ús</a:t>
-            </a:r>
-            <a:r>
-              <a:rPr lang="es-ES" sz="1300" b="0" dirty="0">
-                <a:solidFill>
-                  <a:srgbClr val="66707A"/>
-                </a:solidFill>
-                <a:latin typeface="Arial"/>
-              </a:rPr>
-              <a:t> </a:t>
-            </a:r>
-            <a:r>
-              <a:rPr lang="es-ES" sz="1300" b="0" dirty="0" err="1">
-                <a:solidFill>
-                  <a:srgbClr val="66707A"/>
-                </a:solidFill>
-                <a:latin typeface="Arial"/>
-              </a:rPr>
-              <a:t>depèn</a:t>
-            </a:r>
-            <a:r>
-              <a:rPr lang="es-ES" sz="1300" b="0" dirty="0">
-                <a:solidFill>
-                  <a:srgbClr val="66707A"/>
-                </a:solidFill>
-                <a:latin typeface="Arial"/>
-              </a:rPr>
-              <a:t> </a:t>
-            </a:r>
-            <a:r>
-              <a:rPr lang="es-ES" sz="1300" b="0" dirty="0" err="1">
-                <a:solidFill>
-                  <a:srgbClr val="66707A"/>
-                </a:solidFill>
-                <a:latin typeface="Arial"/>
-              </a:rPr>
-              <a:t>d’un</a:t>
-            </a:r>
-            <a:r>
-              <a:rPr lang="es-ES" sz="1300" b="0" dirty="0">
-                <a:solidFill>
-                  <a:srgbClr val="66707A"/>
-                </a:solidFill>
-                <a:latin typeface="Arial"/>
-              </a:rPr>
-              <a:t> contracte de </a:t>
-            </a:r>
-            <a:r>
-              <a:rPr lang="es-ES" sz="1300" b="0" dirty="0" err="1">
-                <a:solidFill>
-                  <a:srgbClr val="66707A"/>
-                </a:solidFill>
-                <a:latin typeface="Arial"/>
-              </a:rPr>
-              <a:t>l’aplicació</a:t>
-            </a:r>
-            <a:r>
-              <a:rPr lang="es-ES" sz="1300" b="0" dirty="0">
-                <a:solidFill>
-                  <a:srgbClr val="66707A"/>
-                </a:solidFill>
-                <a:latin typeface="Arial"/>
-              </a:rPr>
-              <a:t>, no </a:t>
-            </a:r>
-            <a:r>
-              <a:rPr lang="es-ES" sz="1300" b="0" dirty="0" err="1">
-                <a:solidFill>
-                  <a:srgbClr val="66707A"/>
-                </a:solidFill>
-                <a:latin typeface="Arial"/>
-              </a:rPr>
-              <a:t>dels</a:t>
-            </a:r>
-            <a:r>
-              <a:rPr lang="es-ES" sz="1300" b="0" dirty="0">
-                <a:solidFill>
-                  <a:srgbClr val="66707A"/>
-                </a:solidFill>
-                <a:latin typeface="Arial"/>
-              </a:rPr>
-              <a:t> </a:t>
-            </a:r>
-            <a:r>
-              <a:rPr lang="es-ES" sz="1300" b="0" dirty="0" err="1">
-                <a:solidFill>
-                  <a:srgbClr val="66707A"/>
-                </a:solidFill>
-                <a:latin typeface="Arial"/>
-              </a:rPr>
-              <a:t>detalls</a:t>
-            </a:r>
-            <a:r>
-              <a:rPr lang="es-ES" sz="1300" b="0" dirty="0">
-                <a:solidFill>
-                  <a:srgbClr val="66707A"/>
-                </a:solidFill>
-                <a:latin typeface="Arial"/>
-              </a:rPr>
-              <a:t> de PICA, SOAP/XML o REST </a:t>
-            </a:r>
-            <a:r>
-              <a:rPr lang="es-ES" sz="1300" b="0" dirty="0" err="1">
-                <a:solidFill>
-                  <a:srgbClr val="66707A"/>
-                </a:solidFill>
-                <a:latin typeface="Arial"/>
-              </a:rPr>
-              <a:t>APIs</a:t>
-            </a:r>
-            <a:r>
-              <a:rPr lang="es-ES" sz="1300" b="0" dirty="0">
-                <a:solidFill>
-                  <a:srgbClr val="66707A"/>
-                </a:solidFill>
-                <a:latin typeface="Arial"/>
-              </a:rPr>
-              <a:t>.</a:t>
+              <a:t>El cas d’ús depèn d’un contracte de l’aplicació, no dels detalls de PICA, SOAP/XML o API REST.</a:t>
             </a:r>
             <a:endParaRPr sz="1300" b="0" dirty="0">
               <a:solidFill>
@@ -12961,52 +11729,7 @@
                 </a:solidFill>
                 <a:latin typeface="Arial"/>
               </a:rPr>
-              <a:t>Transferència</a:t>
-            </a:r>
-            <a:r>
-              <a:rPr sz="2800" b="1" dirty="0">
-                <a:solidFill>
-                  <a:srgbClr val="192D3E"/>
-                </a:solidFill>
-                <a:latin typeface="Arial"/>
-              </a:rPr>
-              <a:t> a</a:t>
-            </a:r>
-            <a:r>
-              <a:rPr lang="es-ES" sz="2800" b="1" dirty="0">
-                <a:solidFill>
-                  <a:srgbClr val="192D3E"/>
-                </a:solidFill>
-                <a:latin typeface="Arial"/>
-              </a:rPr>
-              <a:t> </a:t>
-            </a:r>
-            <a:r>
-              <a:rPr lang="es-ES" sz="2800" b="1" dirty="0" err="1">
-                <a:solidFill>
-                  <a:srgbClr val="192D3E"/>
-                </a:solidFill>
-                <a:latin typeface="Arial"/>
-              </a:rPr>
-              <a:t>domini</a:t>
-            </a:r>
-            <a:r>
-              <a:rPr lang="es-ES" sz="2800" b="1" dirty="0">
-                <a:solidFill>
-                  <a:srgbClr val="192D3E"/>
-                </a:solidFill>
-                <a:latin typeface="Arial"/>
-              </a:rPr>
-              <a:t> </a:t>
-            </a:r>
-            <a:r>
-              <a:rPr lang="es-ES" sz="2800" b="1" dirty="0" err="1">
-                <a:solidFill>
-                  <a:srgbClr val="192D3E"/>
-                </a:solidFill>
-                <a:latin typeface="Arial"/>
-              </a:rPr>
-              <a:t>financer</a:t>
+              <a:t>Transferència al domini financer</a:t>
             </a:r>
             <a:endParaRPr sz="2800" b="1" dirty="0">
               <a:solidFill>
@@ -13047,115 +11770,7 @@
                 </a:solidFill>
                 <a:latin typeface="Arial"/>
               </a:rPr>
-              <a:t>El cas </a:t>
-            </a:r>
-            <a:r>
-              <a:rPr lang="es-ES" sz="1400" dirty="0" err="1">
-                <a:solidFill>
-                  <a:srgbClr val="192D3E"/>
-                </a:solidFill>
-                <a:latin typeface="Arial"/>
-              </a:rPr>
-              <a:t>d'ús</a:t>
-            </a:r>
-            <a:r>
-              <a:rPr lang="es-ES" sz="1400" dirty="0">
-                <a:solidFill>
-                  <a:srgbClr val="192D3E"/>
-                </a:solidFill>
-                <a:latin typeface="Arial"/>
-              </a:rPr>
-              <a:t> 'Venda </a:t>
-            </a:r>
-            <a:r>
-              <a:rPr lang="es-ES" sz="1400" dirty="0" err="1">
-                <a:solidFill>
-                  <a:srgbClr val="192D3E"/>
-                </a:solidFill>
-                <a:latin typeface="Arial"/>
-              </a:rPr>
-              <a:t>d'accions</a:t>
-            </a:r>
-            <a:r>
-              <a:rPr lang="es-ES" sz="1400" dirty="0">
-                <a:solidFill>
-                  <a:srgbClr val="192D3E"/>
-                </a:solidFill>
-                <a:latin typeface="Arial"/>
-              </a:rPr>
-              <a:t> </a:t>
-            </a:r>
-            <a:r>
-              <a:rPr lang="es-ES" sz="1400" dirty="0" err="1">
-                <a:solidFill>
-                  <a:srgbClr val="192D3E"/>
-                </a:solidFill>
-                <a:latin typeface="Arial"/>
-              </a:rPr>
-              <a:t>borsàries</a:t>
-            </a:r>
-            <a:r>
-              <a:rPr lang="es-ES" sz="1400" dirty="0">
-                <a:solidFill>
-                  <a:srgbClr val="192D3E"/>
-                </a:solidFill>
-                <a:latin typeface="Arial"/>
-              </a:rPr>
-              <a:t>' </a:t>
-            </a:r>
-            <a:r>
-              <a:rPr lang="es-ES" sz="1400" dirty="0" err="1">
-                <a:solidFill>
-                  <a:srgbClr val="192D3E"/>
-                </a:solidFill>
-                <a:latin typeface="Arial"/>
-              </a:rPr>
-              <a:t>necessita</a:t>
-            </a:r>
-            <a:r>
-              <a:rPr lang="es-ES" sz="1400" dirty="0">
-                <a:solidFill>
-                  <a:srgbClr val="192D3E"/>
-                </a:solidFill>
-                <a:latin typeface="Arial"/>
-              </a:rPr>
-              <a:t> el preu actual, </a:t>
-            </a:r>
-            <a:r>
-              <a:rPr lang="es-ES" sz="1400" dirty="0" err="1">
-                <a:solidFill>
-                  <a:srgbClr val="192D3E"/>
-                </a:solidFill>
-                <a:latin typeface="Arial"/>
-              </a:rPr>
-              <a:t>independentment</a:t>
-            </a:r>
-            <a:r>
-              <a:rPr lang="es-ES" sz="1400" dirty="0">
-                <a:solidFill>
-                  <a:srgbClr val="192D3E"/>
-                </a:solidFill>
-                <a:latin typeface="Arial"/>
-              </a:rPr>
-              <a:t> del </a:t>
-            </a:r>
-            <a:r>
-              <a:rPr lang="es-ES" sz="1400" dirty="0" err="1">
-                <a:solidFill>
-                  <a:srgbClr val="192D3E"/>
-                </a:solidFill>
-                <a:latin typeface="Arial"/>
-              </a:rPr>
-              <a:t>proveïdor</a:t>
-            </a:r>
-            <a:r>
-              <a:rPr lang="es-ES" sz="1400" dirty="0">
-                <a:solidFill>
-                  <a:srgbClr val="192D3E"/>
-                </a:solidFill>
-                <a:latin typeface="Arial"/>
-              </a:rPr>
-              <a:t> (API).</a:t>
+              <a:t>El cas d'ús 'Venda d'accions borsàries' necessita el preu actual, independentment del proveïdor de dades i de l’API concreta.</a:t>
             </a:r>
             <a:endParaRPr sz="1300" dirty="0">
               <a:solidFill>

</xml_diff>

<commit_message>
Add closing key-idea recap to slide 10 of the DSI defense deck
Retitle "Agraïment" to "Idea clau i tancament" and add a three-chip
recap (Necessitat funcional / Port de sortida / Adaptador) matching
slide 3's visual language, so the closing takeaway has an on-screen
anchor alongside the existing thank-you text, which is left untouched.
Regenerate the derived DOCX/PDF exports accordingly.
</commit_message>
<xml_diff>
--- a/doc/presentations/defensa-placa-permanent-dsi-ports-sortida-hexagonal/output/IMPORTANTE_MANUAL_defensa-dsi-ports-sortida-hexagonal.pptx
+++ b/doc/presentations/defensa-placa-permanent-dsi-ports-sortida-hexagonal/output/IMPORTANTE_MANUAL_defensa-dsi-ports-sortida-hexagonal.pptx
@@ -11156,7 +11156,7 @@
                 </a:solidFill>
                 <a:latin typeface="Arial"/>
               </a:rPr>
-              <a:t>Agraïment</a:t>
+              <a:t>Idea clau i tancament</a:t>
             </a:r>
           </a:p>
         </p:txBody>
@@ -11231,13 +11231,355 @@
       </p:sp>
       <p:sp>
         <p:nvSpPr>
+          <p:cNvPr id="11" name="Rounded Rectangle 10"/>
+          <p:cNvSpPr/>
+          <p:nvPr/>
+        </p:nvSpPr>
+        <p:spPr>
+          <a:xfrm>
+            <a:off x="813960" y="1260000"/>
+            <a:ext cx="3245760" cy="560000"/>
+          </a:xfrm>
+          <a:prstGeom prst="roundRect">
+            <a:avLst>
+              <a:gd name="adj" fmla="val 16667"/>
+            </a:avLst>
+          </a:prstGeom>
+          <a:solidFill>
+            <a:srgbClr val="F8EAEA"/>
+          </a:solidFill>
+          <a:ln>
+            <a:solidFill>
+              <a:srgbClr val="DCE0E4"/>
+            </a:solidFill>
+            <a:round/>
+          </a:ln>
+          <a:effectLst>
+            <a:outerShdw blurRad="39960" dist="23040" dir="5400000" rotWithShape="0">
+              <a:srgbClr val="000000">
+                <a:alpha val="35000"/>
+              </a:srgbClr>
+            </a:outerShdw>
+          </a:effectLst>
+        </p:spPr>
+        <p:style>
+          <a:lnRef idx="1">
+            <a:schemeClr val="accent1"/>
+          </a:lnRef>
+          <a:fillRef idx="3">
+            <a:schemeClr val="accent1"/>
+          </a:fillRef>
+          <a:effectRef idx="2">
+            <a:schemeClr val="accent1"/>
+          </a:effectRef>
+          <a:fontRef idx="minor"/>
+        </p:style>
+        <p:txBody>
+          <a:bodyPr lIns="90000" tIns="45000" rIns="90000" bIns="45000" anchor="ctr">
+            <a:noAutofit/>
+          </a:bodyPr>
+          <a:lstStyle/>
+          <a:p>
+            <a:endParaRPr lang="en-US" sz="1600" b="0" u="none" strike="noStrike">
+              <a:solidFill>
+                <a:schemeClr val="lt1"/>
+              </a:solidFill>
+              <a:effectLst/>
+              <a:uFillTx/>
+              <a:latin typeface="Calibri"/>
+            </a:endParaRPr>
+          </a:p>
+        </p:txBody>
+      </p:sp>
+      <p:sp>
+        <p:nvSpPr>
+          <p:cNvPr id="12" name="TextBox 11"/>
+          <p:cNvSpPr/>
+          <p:nvPr/>
+        </p:nvSpPr>
+        <p:spPr>
+          <a:xfrm>
+            <a:off x="813960" y="1260000"/>
+            <a:ext cx="3245760" cy="560000"/>
+          </a:xfrm>
+          <a:prstGeom prst="rect">
+            <a:avLst/>
+          </a:prstGeom>
+          <a:noFill/>
+          <a:ln w="0">
+            <a:noFill/>
+          </a:ln>
+        </p:spPr>
+        <p:style>
+          <a:lnRef idx="0">
+            <a:scrgbClr r="0" g="0" b="0"/>
+          </a:lnRef>
+          <a:fillRef idx="0">
+            <a:scrgbClr r="0" g="0" b="0"/>
+          </a:fillRef>
+          <a:effectRef idx="0">
+            <a:scrgbClr r="0" g="0" b="0"/>
+          </a:effectRef>
+          <a:fontRef idx="minor"/>
+        </p:style>
+        <p:txBody>
+          <a:bodyPr lIns="90000" tIns="45000" rIns="90000" bIns="45000" anchor="ctr">
+            <a:normAutofit/>
+          </a:bodyPr>
+          <a:lstStyle/>
+          <a:p>
+            <a:pPr algn="ctr"/>
+            <a:r>
+              <a:rPr lang="ca-ES" sz="1600" b="1" u="none" strike="noStrike">
+                <a:solidFill>
+                  <a:srgbClr val="192D3E"/>
+                </a:solidFill>
+                <a:effectLst/>
+                <a:uFillTx/>
+                <a:latin typeface="Arial"/>
+              </a:rPr>
+              <a:t>1. Necessitat funcional</a:t>
+            </a:r>
+          </a:p>
+        </p:txBody>
+      </p:sp>
+      <p:sp>
+        <p:nvSpPr>
+          <p:cNvPr id="13" name="Rounded Rectangle 12"/>
+          <p:cNvSpPr/>
+          <p:nvPr/>
+        </p:nvSpPr>
+        <p:spPr>
+          <a:xfrm>
+            <a:off x="4544640" y="1260000"/>
+            <a:ext cx="3245760" cy="560000"/>
+          </a:xfrm>
+          <a:prstGeom prst="roundRect">
+            <a:avLst>
+              <a:gd name="adj" fmla="val 16667"/>
+            </a:avLst>
+          </a:prstGeom>
+          <a:solidFill>
+            <a:srgbClr val="FFF3D6"/>
+          </a:solidFill>
+          <a:ln>
+            <a:solidFill>
+              <a:srgbClr val="DCE0E4"/>
+            </a:solidFill>
+            <a:round/>
+          </a:ln>
+          <a:effectLst>
+            <a:outerShdw blurRad="39960" dist="23040" dir="5400000" rotWithShape="0">
+              <a:srgbClr val="000000">
+                <a:alpha val="35000"/>
+              </a:srgbClr>
+            </a:outerShdw>
+          </a:effectLst>
+        </p:spPr>
+        <p:style>
+          <a:lnRef idx="1">
+            <a:schemeClr val="accent1"/>
+          </a:lnRef>
+          <a:fillRef idx="3">
+            <a:schemeClr val="accent1"/>
+          </a:fillRef>
+          <a:effectRef idx="2">
+            <a:schemeClr val="accent1"/>
+          </a:effectRef>
+          <a:fontRef idx="minor"/>
+        </p:style>
+        <p:txBody>
+          <a:bodyPr lIns="90000" tIns="45000" rIns="90000" bIns="45000" anchor="ctr">
+            <a:noAutofit/>
+          </a:bodyPr>
+          <a:lstStyle/>
+          <a:p>
+            <a:endParaRPr lang="en-US" sz="1600" b="0" u="none" strike="noStrike">
+              <a:solidFill>
+                <a:schemeClr val="lt1"/>
+              </a:solidFill>
+              <a:effectLst/>
+              <a:uFillTx/>
+              <a:latin typeface="Calibri"/>
+            </a:endParaRPr>
+          </a:p>
+        </p:txBody>
+      </p:sp>
+      <p:sp>
+        <p:nvSpPr>
+          <p:cNvPr id="14" name="TextBox 13"/>
+          <p:cNvSpPr/>
+          <p:nvPr/>
+        </p:nvSpPr>
+        <p:spPr>
+          <a:xfrm>
+            <a:off x="4544640" y="1260000"/>
+            <a:ext cx="3245760" cy="560000"/>
+          </a:xfrm>
+          <a:prstGeom prst="rect">
+            <a:avLst/>
+          </a:prstGeom>
+          <a:noFill/>
+          <a:ln w="0">
+            <a:noFill/>
+          </a:ln>
+        </p:spPr>
+        <p:style>
+          <a:lnRef idx="0">
+            <a:scrgbClr r="0" g="0" b="0"/>
+          </a:lnRef>
+          <a:fillRef idx="0">
+            <a:scrgbClr r="0" g="0" b="0"/>
+          </a:fillRef>
+          <a:effectRef idx="0">
+            <a:scrgbClr r="0" g="0" b="0"/>
+          </a:effectRef>
+          <a:fontRef idx="minor"/>
+        </p:style>
+        <p:txBody>
+          <a:bodyPr lIns="90000" tIns="45000" rIns="90000" bIns="45000" anchor="ctr">
+            <a:normAutofit/>
+          </a:bodyPr>
+          <a:lstStyle/>
+          <a:p>
+            <a:pPr algn="ctr"/>
+            <a:r>
+              <a:rPr lang="ca-ES" sz="1600" b="1" u="none" strike="noStrike">
+                <a:solidFill>
+                  <a:srgbClr val="192D3E"/>
+                </a:solidFill>
+                <a:effectLst/>
+                <a:uFillTx/>
+                <a:latin typeface="Arial"/>
+              </a:rPr>
+              <a:t>2. Port de sortida</a:t>
+            </a:r>
+          </a:p>
+        </p:txBody>
+      </p:sp>
+      <p:sp>
+        <p:nvSpPr>
+          <p:cNvPr id="15" name="Rounded Rectangle 14"/>
+          <p:cNvSpPr/>
+          <p:nvPr/>
+        </p:nvSpPr>
+        <p:spPr>
+          <a:xfrm>
+            <a:off x="8275320" y="1260000"/>
+            <a:ext cx="3245760" cy="560000"/>
+          </a:xfrm>
+          <a:prstGeom prst="roundRect">
+            <a:avLst>
+              <a:gd name="adj" fmla="val 16667"/>
+            </a:avLst>
+          </a:prstGeom>
+          <a:solidFill>
+            <a:srgbClr val="EBF6F0"/>
+          </a:solidFill>
+          <a:ln>
+            <a:solidFill>
+              <a:srgbClr val="DCE0E4"/>
+            </a:solidFill>
+            <a:round/>
+          </a:ln>
+          <a:effectLst>
+            <a:outerShdw blurRad="39960" dist="23040" dir="5400000" rotWithShape="0">
+              <a:srgbClr val="000000">
+                <a:alpha val="35000"/>
+              </a:srgbClr>
+            </a:outerShdw>
+          </a:effectLst>
+        </p:spPr>
+        <p:style>
+          <a:lnRef idx="1">
+            <a:schemeClr val="accent1"/>
+          </a:lnRef>
+          <a:fillRef idx="3">
+            <a:schemeClr val="accent1"/>
+          </a:fillRef>
+          <a:effectRef idx="2">
+            <a:schemeClr val="accent1"/>
+          </a:effectRef>
+          <a:fontRef idx="minor"/>
+        </p:style>
+        <p:txBody>
+          <a:bodyPr lIns="90000" tIns="45000" rIns="90000" bIns="45000" anchor="ctr">
+            <a:noAutofit/>
+          </a:bodyPr>
+          <a:lstStyle/>
+          <a:p>
+            <a:endParaRPr lang="en-US" sz="1600" b="0" u="none" strike="noStrike">
+              <a:solidFill>
+                <a:schemeClr val="lt1"/>
+              </a:solidFill>
+              <a:effectLst/>
+              <a:uFillTx/>
+              <a:latin typeface="Calibri"/>
+            </a:endParaRPr>
+          </a:p>
+        </p:txBody>
+      </p:sp>
+      <p:sp>
+        <p:nvSpPr>
+          <p:cNvPr id="16" name="TextBox 15"/>
+          <p:cNvSpPr/>
+          <p:nvPr/>
+        </p:nvSpPr>
+        <p:spPr>
+          <a:xfrm>
+            <a:off x="8275320" y="1260000"/>
+            <a:ext cx="3245760" cy="560000"/>
+          </a:xfrm>
+          <a:prstGeom prst="rect">
+            <a:avLst/>
+          </a:prstGeom>
+          <a:noFill/>
+          <a:ln w="0">
+            <a:noFill/>
+          </a:ln>
+        </p:spPr>
+        <p:style>
+          <a:lnRef idx="0">
+            <a:scrgbClr r="0" g="0" b="0"/>
+          </a:lnRef>
+          <a:fillRef idx="0">
+            <a:scrgbClr r="0" g="0" b="0"/>
+          </a:fillRef>
+          <a:effectRef idx="0">
+            <a:scrgbClr r="0" g="0" b="0"/>
+          </a:effectRef>
+          <a:fontRef idx="minor"/>
+        </p:style>
+        <p:txBody>
+          <a:bodyPr lIns="90000" tIns="45000" rIns="90000" bIns="45000" anchor="ctr">
+            <a:normAutofit/>
+          </a:bodyPr>
+          <a:lstStyle/>
+          <a:p>
+            <a:pPr algn="ctr"/>
+            <a:r>
+              <a:rPr lang="ca-ES" sz="1600" b="1" u="none" strike="noStrike">
+                <a:solidFill>
+                  <a:srgbClr val="192D3E"/>
+                </a:solidFill>
+                <a:effectLst/>
+                <a:uFillTx/>
+                <a:latin typeface="Arial"/>
+              </a:rPr>
+              <a:t>3. Adaptador</a:t>
+            </a:r>
+          </a:p>
+        </p:txBody>
+      </p:sp>
+      <p:sp>
+        <p:nvSpPr>
           <p:cNvPr id="5" name="TextBox 4"/>
           <p:cNvSpPr txBox="1"/>
           <p:nvPr/>
         </p:nvSpPr>
         <p:spPr>
           <a:xfrm>
-            <a:off x="1178973" y="1874094"/>
+            <a:off x="1178973" y="2244551"/>
             <a:ext cx="9834053" cy="1780528"/>
           </a:xfrm>
           <a:prstGeom prst="rect">
@@ -11745,7 +12087,7 @@
         </p:nvSpPr>
         <p:spPr>
           <a:xfrm>
-            <a:off x="1885683" y="4295446"/>
+            <a:off x="1869840" y="4380572"/>
             <a:ext cx="8595360" cy="1217428"/>
           </a:xfrm>
           <a:prstGeom prst="roundRect">
@@ -11791,7 +12133,7 @@
         </p:nvSpPr>
         <p:spPr>
           <a:xfrm>
-            <a:off x="2046235" y="4399432"/>
+            <a:off x="2030392" y="4484558"/>
             <a:ext cx="8099528" cy="868681"/>
           </a:xfrm>
           <a:prstGeom prst="rect">

</xml_diff>

<commit_message>
Actualitza les presentacions i els materials derivats
</commit_message>
<xml_diff>
--- a/doc/presentations/defensa-placa-permanent-dsi-ports-sortida-hexagonal/output/IMPORTANTE_MANUAL_defensa-dsi-ports-sortida-hexagonal.pptx
+++ b/doc/presentations/defensa-placa-permanent-dsi-ports-sortida-hexagonal/output/IMPORTANTE_MANUAL_defensa-dsi-ports-sortida-hexagonal.pptx
@@ -11730,103 +11730,22 @@
               <a:t>créixer</a:t>
             </a:r>
             <a:r>
+              <a:rPr lang="es-ES" sz="2400" b="0">
+                <a:solidFill>
+                  <a:srgbClr val="192D3E"/>
+                </a:solidFill>
+                <a:latin typeface="Arial"/>
+              </a:rPr>
+              <a:t>, </a:t>
+            </a:r>
+            <a:r>
               <a:rPr lang="es-ES" sz="2400" b="0" dirty="0">
                 <a:solidFill>
                   <a:srgbClr val="192D3E"/>
                 </a:solidFill>
                 <a:latin typeface="Arial"/>
               </a:rPr>
-              <a:t>, </a:t>
-            </a:r>
-            <a:r>
-              <a:rPr lang="es-ES" sz="2400" b="0" dirty="0" err="1">
-                <a:solidFill>
-                  <a:srgbClr val="192D3E"/>
-                </a:solidFill>
-                <a:latin typeface="Arial"/>
-              </a:rPr>
-              <a:t>tant</a:t>
-            </a:r>
-            <a:r>
-              <a:rPr lang="es-ES" sz="2400" b="0" dirty="0">
-                <a:solidFill>
-                  <a:srgbClr val="192D3E"/>
-                </a:solidFill>
-                <a:latin typeface="Arial"/>
-              </a:rPr>
-              <a:t> en la </a:t>
-            </a:r>
-            <a:r>
-              <a:rPr lang="es-ES" sz="2400" b="0" dirty="0" err="1">
-                <a:solidFill>
-                  <a:srgbClr val="192D3E"/>
-                </a:solidFill>
-                <a:latin typeface="Arial"/>
-              </a:rPr>
-              <a:t>docència</a:t>
-            </a:r>
-            <a:r>
-              <a:rPr lang="es-ES" sz="2400" b="0" dirty="0">
-                <a:solidFill>
-                  <a:srgbClr val="192D3E"/>
-                </a:solidFill>
-                <a:latin typeface="Arial"/>
-              </a:rPr>
-              <a:t> </a:t>
-            </a:r>
-            <a:r>
-              <a:rPr lang="es-ES" sz="2400" b="0" dirty="0" err="1">
-                <a:solidFill>
-                  <a:srgbClr val="192D3E"/>
-                </a:solidFill>
-                <a:latin typeface="Arial"/>
-              </a:rPr>
-              <a:t>com</a:t>
-            </a:r>
-            <a:r>
-              <a:rPr lang="es-ES" sz="2400" b="0" dirty="0">
-                <a:solidFill>
-                  <a:srgbClr val="192D3E"/>
-                </a:solidFill>
-                <a:latin typeface="Arial"/>
-              </a:rPr>
-              <a:t> en </a:t>
-            </a:r>
-            <a:r>
-              <a:rPr lang="es-ES" sz="2400" b="0" dirty="0" err="1">
-                <a:solidFill>
-                  <a:srgbClr val="192D3E"/>
-                </a:solidFill>
-                <a:latin typeface="Arial"/>
-              </a:rPr>
-              <a:t>l'àmbit</a:t>
-            </a:r>
-            <a:r>
-              <a:rPr lang="es-ES" sz="2400" b="0" dirty="0">
-                <a:solidFill>
-                  <a:srgbClr val="192D3E"/>
-                </a:solidFill>
-                <a:latin typeface="Arial"/>
-              </a:rPr>
-              <a:t> </a:t>
-            </a:r>
-            <a:r>
-              <a:rPr lang="es-ES" sz="2400" b="0" dirty="0" err="1">
-                <a:solidFill>
-                  <a:srgbClr val="192D3E"/>
-                </a:solidFill>
-                <a:latin typeface="Arial"/>
-              </a:rPr>
-              <a:t>acadèmic</a:t>
-            </a:r>
-            <a:r>
-              <a:rPr lang="es-ES" sz="2400" b="0" dirty="0">
-                <a:solidFill>
-                  <a:srgbClr val="192D3E"/>
-                </a:solidFill>
-                <a:latin typeface="Arial"/>
-              </a:rPr>
-              <a:t>, al </a:t>
+              <a:t>al </a:t>
             </a:r>
             <a:r>
               <a:rPr lang="es-ES" sz="2400" b="0" dirty="0" err="1">

</xml_diff>

<commit_message>
Separa síntesi i agraïment i afegeix l'annex curricular
Classe magistral de 20 minuts: la diapositiva 10 queda com a
tancament conceptual amb les tres decisions i la frase clau amb
màxima jerarquia, i l'agraïment institucional passa a una
diapositiva 11 pròpia amb la frase literal i el tancament formal.
La demo continua com a annex fora dels 20 minuts. Sincronitza
guió, notes, esquema de memorització, mantra i taula temporal.

Trajectòria de 10 minuts: nova diapositiva Annex A de contrast
d'orientació curricular entre La Salle URL i el TecnoCampus,
només per al torn de preguntes, amb assignatures verificades als
plans oficials, formulacions qualitatives sense sumes d'ECTS no
estables, fonts datades i resposta oral de reserva a les notes.

Regenera tots els materials derivats amb els scripts del projecte.

Co-Authored-By: Claude Fable 5 <noreply@anthropic.com>
</commit_message>
<xml_diff>
--- a/doc/presentations/defensa-placa-permanent-dsi-ports-sortida-hexagonal/output/IMPORTANTE_MANUAL_defensa-dsi-ports-sortida-hexagonal.pptx
+++ b/doc/presentations/defensa-placa-permanent-dsi-ports-sortida-hexagonal/output/IMPORTANTE_MANUAL_defensa-dsi-ports-sortida-hexagonal.pptx
@@ -18,6 +18,7 @@
     <p:sldId id="263" r:id="rId9"/>
     <p:sldId id="264" r:id="rId10"/>
     <p:sldId id="268" r:id="rId11"/>
+    <p:sldId id="269" r:id="rId18"/>
     <p:sldId id="266" r:id="rId12"/>
   </p:sldIdLst>
   <p:sldSz cx="12192000" cy="6858000"/>
@@ -917,13 +918,13 @@
           <a:p>
             <a:r>
               <a:rPr lang="ca-ES"/>
-              <a:t>Agraïment breu al TecnoCampus i al Dr. Josep Roure.</a:t>
+              <a:t>La frase clau és l’element més memorable: l’arquitectura no elimina el canvi; el localitza.</a:t>
             </a:r>
           </a:p>
           <a:p>
             <a:r>
               <a:rPr lang="ca-ES"/>
-              <a:t>Tancar mirant el tribunal: Moltes gràcies.</a:t>
+              <a:t>Sense agraïments en aquesta diapositiva: donar pas a la diapositiva 11.</a:t>
             </a:r>
           </a:p>
         </p:txBody>
@@ -1224,6 +1225,106 @@
             </a:endParaRPr>
           </a:p>
         </p:txBody>
+      </p:sp>
+    </p:spTree>
+  </p:cSld>
+  <p:clrMapOvr>
+    <a:masterClrMapping/>
+  </p:clrMapOvr>
+</p:notes>
+</file>
+
+<file path=ppt/notesSlides/notesSlide12.xml><?xml version="1.0" encoding="utf-8"?>
+<p:notes xmlns:a="http://schemas.openxmlformats.org/drawingml/2006/main" xmlns:r="http://schemas.openxmlformats.org/officeDocument/2006/relationships" xmlns:p="http://schemas.openxmlformats.org/presentationml/2006/main">
+  <p:cSld>
+    <p:spTree>
+      <p:nvGrpSpPr>
+        <p:cNvPr id="1" name=""/>
+        <p:cNvGrpSpPr/>
+        <p:nvPr/>
+      </p:nvGrpSpPr>
+      <p:grpSpPr>
+        <a:xfrm>
+          <a:off x="0" y="0"/>
+          <a:ext cx="0" cy="0"/>
+          <a:chOff x="0" y="0"/>
+          <a:chExt cx="0" cy="0"/>
+        </a:xfrm>
+      </p:grpSpPr>
+      <p:sp>
+        <p:nvSpPr>
+          <p:cNvPr id="2" name="Slide Image Placeholder 1"/>
+          <p:cNvSpPr>
+            <a:spLocks noGrp="1" noRot="1" noChangeAspect="1"/>
+          </p:cNvSpPr>
+          <p:nvPr>
+            <p:ph type="sldImg" idx="2"/>
+          </p:nvPr>
+        </p:nvSpPr>
+        <p:spPr>
+          <a:xfrm>
+            <a:off x="0" y="812800"/>
+            <a:ext cx="0" cy="0"/>
+          </a:xfrm>
+        </p:spPr>
+      </p:sp>
+      <p:sp>
+        <p:nvSpPr>
+          <p:cNvPr id="3" name="Notes Placeholder 2"/>
+          <p:cNvSpPr>
+            <a:spLocks noGrp="1"/>
+          </p:cNvSpPr>
+          <p:nvPr>
+            <p:ph type="body" sz="quarter" idx="3"/>
+          </p:nvPr>
+        </p:nvSpPr>
+        <p:spPr/>
+        <p:txBody>
+          <a:bodyPr/>
+          <a:lstStyle/>
+          <a:p>
+            <a:r>
+              <a:rPr lang="ca-ES"/>
+              <a:t>Frase d’agraïment literal: no resumir-la ni canviar cap paraula.</a:t>
+            </a:r>
+          </a:p>
+          <a:p>
+            <a:r>
+              <a:rPr lang="ca-ES"/>
+              <a:t>Cap nom de persona i cap altre agraïment.</a:t>
+            </a:r>
+          </a:p>
+          <a:p>
+            <a:r>
+              <a:rPr lang="ca-ES"/>
+              <a:t>Pausa natural abans de: Moltes gràcies.</a:t>
+            </a:r>
+          </a:p>
+          <a:p>
+            <a:r>
+              <a:rPr lang="ca-ES"/>
+              <a:t>Després de Moltes gràcies, la classe queda formalment tancada.</a:t>
+            </a:r>
+          </a:p>
+          <a:p>
+            <a:r>
+              <a:rPr lang="ca-ES"/>
+              <a:t>No obrir la demo si el tribunal no la demana o si no hi ha temps explícit.</a:t>
+            </a:r>
+          </a:p>
+        </p:txBody>
+      </p:sp>
+      <p:sp>
+        <p:nvSpPr>
+          <p:cNvPr id="4" name="Slide Number Placeholder 3"/>
+          <p:cNvSpPr>
+            <a:spLocks noGrp="1"/>
+          </p:cNvSpPr>
+          <p:nvPr>
+            <p:ph type="sldNum" sz="quarter" idx="5"/>
+          </p:nvPr>
+        </p:nvSpPr>
+        <p:spPr/>
       </p:sp>
     </p:spTree>
   </p:cSld>
@@ -11238,7 +11339,7 @@
         <p:spPr>
           <a:xfrm>
             <a:off x="813960" y="1260000"/>
-            <a:ext cx="3245760" cy="560000"/>
+            <a:ext cx="3245760" cy="1150000"/>
           </a:xfrm>
           <a:prstGeom prst="roundRect">
             <a:avLst>
@@ -11300,7 +11401,7 @@
         <p:spPr>
           <a:xfrm>
             <a:off x="813960" y="1260000"/>
-            <a:ext cx="3245760" cy="560000"/>
+            <a:ext cx="3245760" cy="1150000"/>
           </a:xfrm>
           <a:prstGeom prst="rect">
             <a:avLst/>
@@ -11341,6 +11442,20 @@
               <a:t>1. Necessitat funcional</a:t>
             </a:r>
           </a:p>
+          <a:p>
+            <a:pPr algn="ctr"/>
+            <a:r>
+              <a:rPr lang="ca-ES" sz="1300" b="0" u="none" strike="noStrike">
+                <a:solidFill>
+                  <a:srgbClr val="192D3E"/>
+                </a:solidFill>
+                <a:effectLst/>
+                <a:uFillTx/>
+                <a:latin typeface="Arial"/>
+              </a:rPr>
+              <a:t>El cas d’ús expressa què necessita.</a:t>
+            </a:r>
+          </a:p>
         </p:txBody>
       </p:sp>
       <p:sp>
@@ -11352,7 +11467,7 @@
         <p:spPr>
           <a:xfrm>
             <a:off x="4544640" y="1260000"/>
-            <a:ext cx="3245760" cy="560000"/>
+            <a:ext cx="3245760" cy="1150000"/>
           </a:xfrm>
           <a:prstGeom prst="roundRect">
             <a:avLst>
@@ -11414,7 +11529,7 @@
         <p:spPr>
           <a:xfrm>
             <a:off x="4544640" y="1260000"/>
-            <a:ext cx="3245760" cy="560000"/>
+            <a:ext cx="3245760" cy="1150000"/>
           </a:xfrm>
           <a:prstGeom prst="rect">
             <a:avLst/>
@@ -11455,6 +11570,20 @@
               <a:t>2. Port de sortida</a:t>
             </a:r>
           </a:p>
+          <a:p>
+            <a:pPr algn="ctr"/>
+            <a:r>
+              <a:rPr lang="ca-ES" sz="1300" b="0" u="none" strike="noStrike">
+                <a:solidFill>
+                  <a:srgbClr val="192D3E"/>
+                </a:solidFill>
+                <a:effectLst/>
+                <a:uFillTx/>
+                <a:latin typeface="Arial"/>
+              </a:rPr>
+              <a:t>El port defineix el contracte de l’aplicació.</a:t>
+            </a:r>
+          </a:p>
         </p:txBody>
       </p:sp>
       <p:sp>
@@ -11466,7 +11595,7 @@
         <p:spPr>
           <a:xfrm>
             <a:off x="8275320" y="1260000"/>
-            <a:ext cx="3245760" cy="560000"/>
+            <a:ext cx="3245760" cy="1150000"/>
           </a:xfrm>
           <a:prstGeom prst="roundRect">
             <a:avLst>
@@ -11528,7 +11657,7 @@
         <p:spPr>
           <a:xfrm>
             <a:off x="8275320" y="1260000"/>
-            <a:ext cx="3245760" cy="560000"/>
+            <a:ext cx="3245760" cy="1150000"/>
           </a:xfrm>
           <a:prstGeom prst="rect">
             <a:avLst/>
@@ -11569,432 +11698,19 @@
               <a:t>3. Adaptador</a:t>
             </a:r>
           </a:p>
-        </p:txBody>
-      </p:sp>
-      <p:sp>
-        <p:nvSpPr>
-          <p:cNvPr id="5" name="TextBox 4"/>
-          <p:cNvSpPr txBox="1"/>
-          <p:nvPr/>
-        </p:nvSpPr>
-        <p:spPr>
-          <a:xfrm>
-            <a:off x="1178973" y="2244551"/>
-            <a:ext cx="9834053" cy="1780528"/>
-          </a:xfrm>
-          <a:prstGeom prst="rect">
-            <a:avLst/>
-          </a:prstGeom>
-          <a:noFill/>
-        </p:spPr>
-        <p:txBody>
-          <a:bodyPr wrap="square">
-            <a:normAutofit lnSpcReduction="10000"/>
-          </a:bodyPr>
-          <a:lstStyle/>
           <a:p>
             <a:pPr algn="ctr"/>
             <a:r>
-              <a:rPr lang="es-ES" sz="2400" b="0" dirty="0" err="1">
+              <a:rPr lang="ca-ES" sz="1300" b="0" u="none" strike="noStrike">
                 <a:solidFill>
                   <a:srgbClr val="192D3E"/>
                 </a:solidFill>
-                <a:latin typeface="Arial"/>
-              </a:rPr>
-              <a:t>Vull</a:t>
-            </a:r>
-            <a:r>
-              <a:rPr lang="es-ES" sz="2400" b="0" dirty="0">
-                <a:solidFill>
-                  <a:srgbClr val="192D3E"/>
-                </a:solidFill>
-                <a:latin typeface="Arial"/>
-              </a:rPr>
-              <a:t> </a:t>
-            </a:r>
-            <a:r>
-              <a:rPr lang="es-ES" sz="2400" b="0" dirty="0" err="1">
-                <a:solidFill>
-                  <a:srgbClr val="192D3E"/>
-                </a:solidFill>
-                <a:latin typeface="Arial"/>
-              </a:rPr>
-              <a:t>expressar</a:t>
-            </a:r>
-            <a:r>
-              <a:rPr lang="es-ES" sz="2400" b="0" dirty="0">
-                <a:solidFill>
-                  <a:srgbClr val="192D3E"/>
-                </a:solidFill>
-                <a:latin typeface="Arial"/>
-              </a:rPr>
-              <a:t> el </a:t>
-            </a:r>
-            <a:r>
-              <a:rPr lang="es-ES" sz="2400" b="0" dirty="0" err="1">
-                <a:solidFill>
-                  <a:srgbClr val="192D3E"/>
-                </a:solidFill>
-                <a:latin typeface="Arial"/>
-              </a:rPr>
-              <a:t>meu</a:t>
-            </a:r>
-            <a:r>
-              <a:rPr lang="es-ES" sz="2400" b="0" dirty="0">
-                <a:solidFill>
-                  <a:srgbClr val="192D3E"/>
-                </a:solidFill>
-                <a:latin typeface="Arial"/>
-              </a:rPr>
-              <a:t> </a:t>
-            </a:r>
-            <a:r>
-              <a:rPr lang="es-ES" sz="2400" b="0" dirty="0" err="1">
-                <a:solidFill>
-                  <a:srgbClr val="192D3E"/>
-                </a:solidFill>
-                <a:latin typeface="Arial"/>
-              </a:rPr>
-              <a:t>agraïment</a:t>
-            </a:r>
-            <a:r>
-              <a:rPr lang="es-ES" sz="2400" b="0" dirty="0">
-                <a:solidFill>
-                  <a:srgbClr val="192D3E"/>
-                </a:solidFill>
-                <a:latin typeface="Arial"/>
-              </a:rPr>
-              <a:t> al </a:t>
-            </a:r>
-            <a:r>
-              <a:rPr lang="es-ES" sz="2400" b="0" dirty="0" err="1">
-                <a:solidFill>
-                  <a:srgbClr val="192D3E"/>
-                </a:solidFill>
-                <a:latin typeface="Arial"/>
-              </a:rPr>
-              <a:t>TecnoCampus</a:t>
-            </a:r>
-            <a:r>
-              <a:rPr lang="es-ES" sz="2400" b="0" dirty="0">
-                <a:solidFill>
-                  <a:srgbClr val="192D3E"/>
-                </a:solidFill>
-                <a:latin typeface="Arial"/>
-              </a:rPr>
-              <a:t> per un </a:t>
-            </a:r>
-            <a:r>
-              <a:rPr lang="es-ES" sz="2400" b="0" dirty="0" err="1">
-                <a:solidFill>
-                  <a:srgbClr val="192D3E"/>
-                </a:solidFill>
-                <a:latin typeface="Arial"/>
-              </a:rPr>
-              <a:t>entorn</a:t>
-            </a:r>
-            <a:r>
-              <a:rPr lang="es-ES" sz="2400" b="0" dirty="0">
-                <a:solidFill>
-                  <a:srgbClr val="192D3E"/>
-                </a:solidFill>
-                <a:latin typeface="Arial"/>
-              </a:rPr>
-              <a:t> que </a:t>
-            </a:r>
-            <a:r>
-              <a:rPr lang="es-ES" sz="2400" b="0" dirty="0" err="1">
-                <a:solidFill>
-                  <a:srgbClr val="192D3E"/>
-                </a:solidFill>
-                <a:latin typeface="Arial"/>
-              </a:rPr>
-              <a:t>m'encoratja</a:t>
-            </a:r>
-            <a:r>
-              <a:rPr lang="es-ES" sz="2400" b="0" dirty="0">
-                <a:solidFill>
-                  <a:srgbClr val="192D3E"/>
-                </a:solidFill>
-                <a:latin typeface="Arial"/>
-              </a:rPr>
-              <a:t> a </a:t>
-            </a:r>
-            <a:r>
-              <a:rPr lang="es-ES" sz="2400" b="0" dirty="0" err="1">
-                <a:solidFill>
-                  <a:srgbClr val="192D3E"/>
-                </a:solidFill>
-                <a:latin typeface="Arial"/>
-              </a:rPr>
-              <a:t>créixer</a:t>
-            </a:r>
-            <a:r>
-              <a:rPr lang="es-ES" sz="2400" b="0">
-                <a:solidFill>
-                  <a:srgbClr val="192D3E"/>
-                </a:solidFill>
-                <a:latin typeface="Arial"/>
-              </a:rPr>
-              <a:t>, </a:t>
-            </a:r>
-            <a:r>
-              <a:rPr lang="es-ES" sz="2400" b="0" dirty="0">
-                <a:solidFill>
-                  <a:srgbClr val="192D3E"/>
-                </a:solidFill>
-                <a:latin typeface="Arial"/>
-              </a:rPr>
-              <a:t>al </a:t>
-            </a:r>
-            <a:r>
-              <a:rPr lang="es-ES" sz="2400" b="0" dirty="0" err="1">
-                <a:solidFill>
-                  <a:srgbClr val="192D3E"/>
-                </a:solidFill>
-                <a:latin typeface="Arial"/>
-              </a:rPr>
-              <a:t>costat</a:t>
-            </a:r>
-            <a:r>
-              <a:rPr lang="es-ES" sz="2400" b="0" dirty="0">
-                <a:solidFill>
-                  <a:srgbClr val="192D3E"/>
-                </a:solidFill>
-                <a:latin typeface="Arial"/>
-              </a:rPr>
-              <a:t> </a:t>
-            </a:r>
-            <a:r>
-              <a:rPr lang="es-ES" sz="2400" b="0" dirty="0" err="1">
-                <a:solidFill>
-                  <a:srgbClr val="192D3E"/>
-                </a:solidFill>
-                <a:latin typeface="Arial"/>
-              </a:rPr>
-              <a:t>d'un</a:t>
-            </a:r>
-            <a:r>
-              <a:rPr lang="es-ES" sz="2400" b="0" dirty="0">
-                <a:solidFill>
-                  <a:srgbClr val="192D3E"/>
-                </a:solidFill>
-                <a:latin typeface="Arial"/>
-              </a:rPr>
-              <a:t> </a:t>
-            </a:r>
-            <a:r>
-              <a:rPr lang="es-ES" sz="2400" b="0" dirty="0" err="1">
-                <a:solidFill>
-                  <a:srgbClr val="192D3E"/>
-                </a:solidFill>
-                <a:latin typeface="Arial"/>
-              </a:rPr>
-              <a:t>equip</a:t>
-            </a:r>
-            <a:r>
-              <a:rPr lang="es-ES" sz="2400" b="0" dirty="0">
-                <a:solidFill>
-                  <a:srgbClr val="192D3E"/>
-                </a:solidFill>
-                <a:latin typeface="Arial"/>
-              </a:rPr>
-              <a:t> del </a:t>
-            </a:r>
-            <a:r>
-              <a:rPr lang="es-ES" sz="2400" b="0" dirty="0" err="1">
-                <a:solidFill>
-                  <a:srgbClr val="192D3E"/>
-                </a:solidFill>
-                <a:latin typeface="Arial"/>
-              </a:rPr>
-              <a:t>qual</a:t>
-            </a:r>
-            <a:r>
-              <a:rPr lang="es-ES" sz="2400" b="0" dirty="0">
-                <a:solidFill>
-                  <a:srgbClr val="192D3E"/>
-                </a:solidFill>
-                <a:latin typeface="Arial"/>
-              </a:rPr>
-              <a:t> </a:t>
-            </a:r>
-            <a:r>
-              <a:rPr lang="es-ES" sz="2400" b="0" dirty="0" err="1">
-                <a:solidFill>
-                  <a:srgbClr val="192D3E"/>
-                </a:solidFill>
-                <a:latin typeface="Arial"/>
-              </a:rPr>
-              <a:t>aprenc</a:t>
-            </a:r>
-            <a:r>
-              <a:rPr lang="es-ES" sz="2400" b="0" dirty="0">
-                <a:solidFill>
-                  <a:srgbClr val="192D3E"/>
-                </a:solidFill>
-                <a:latin typeface="Arial"/>
-              </a:rPr>
-              <a:t> i </a:t>
-            </a:r>
-            <a:r>
-              <a:rPr lang="es-ES" sz="2400" b="0" dirty="0" err="1">
-                <a:solidFill>
-                  <a:srgbClr val="192D3E"/>
-                </a:solidFill>
-                <a:latin typeface="Arial"/>
-              </a:rPr>
-              <a:t>amb</a:t>
-            </a:r>
-            <a:r>
-              <a:rPr lang="es-ES" sz="2400" b="0" dirty="0">
-                <a:solidFill>
-                  <a:srgbClr val="192D3E"/>
-                </a:solidFill>
-                <a:latin typeface="Arial"/>
-              </a:rPr>
-              <a:t> qui </a:t>
-            </a:r>
-            <a:r>
-              <a:rPr lang="es-ES" sz="2400" b="0" dirty="0" err="1">
-                <a:solidFill>
-                  <a:srgbClr val="192D3E"/>
-                </a:solidFill>
-                <a:latin typeface="Arial"/>
-              </a:rPr>
-              <a:t>comparteixo</a:t>
-            </a:r>
-            <a:r>
-              <a:rPr lang="es-ES" sz="2400" b="0" dirty="0">
-                <a:solidFill>
-                  <a:srgbClr val="192D3E"/>
-                </a:solidFill>
-                <a:latin typeface="Arial"/>
-              </a:rPr>
-              <a:t> </a:t>
-            </a:r>
-            <a:r>
-              <a:rPr lang="es-ES" sz="2400" b="0" dirty="0" err="1">
-                <a:solidFill>
-                  <a:srgbClr val="192D3E"/>
-                </a:solidFill>
-                <a:latin typeface="Arial"/>
-              </a:rPr>
-              <a:t>coneixement</a:t>
-            </a:r>
-            <a:r>
-              <a:rPr lang="es-ES" sz="2400" b="0" dirty="0">
-                <a:solidFill>
-                  <a:srgbClr val="192D3E"/>
-                </a:solidFill>
-                <a:latin typeface="Arial"/>
-              </a:rPr>
-              <a:t>, </a:t>
-            </a:r>
-            <a:r>
-              <a:rPr lang="es-ES" sz="2400" b="0" dirty="0" err="1">
-                <a:solidFill>
-                  <a:srgbClr val="192D3E"/>
-                </a:solidFill>
-                <a:latin typeface="Arial"/>
-              </a:rPr>
-              <a:t>responsabilitat</a:t>
-            </a:r>
-            <a:r>
-              <a:rPr lang="es-ES" sz="2400" b="0" dirty="0">
-                <a:solidFill>
-                  <a:srgbClr val="192D3E"/>
-                </a:solidFill>
-                <a:latin typeface="Arial"/>
-              </a:rPr>
-              <a:t> i </a:t>
-            </a:r>
-            <a:r>
-              <a:rPr lang="es-ES" sz="2400" b="0" dirty="0" err="1">
-                <a:solidFill>
-                  <a:srgbClr val="192D3E"/>
-                </a:solidFill>
-                <a:latin typeface="Arial"/>
-              </a:rPr>
-              <a:t>compromís</a:t>
-            </a:r>
-            <a:r>
-              <a:rPr lang="es-ES" sz="2400" b="0" dirty="0">
-                <a:solidFill>
-                  <a:srgbClr val="192D3E"/>
-                </a:solidFill>
-                <a:latin typeface="Arial"/>
-              </a:rPr>
-              <a:t> </a:t>
-            </a:r>
-            <a:r>
-              <a:rPr lang="es-ES" sz="2400" b="0" dirty="0" err="1">
-                <a:solidFill>
-                  <a:srgbClr val="192D3E"/>
-                </a:solidFill>
-                <a:latin typeface="Arial"/>
-              </a:rPr>
-              <a:t>amb</a:t>
-            </a:r>
-            <a:r>
-              <a:rPr lang="es-ES" sz="2400" b="0" dirty="0">
-                <a:solidFill>
-                  <a:srgbClr val="192D3E"/>
-                </a:solidFill>
-                <a:latin typeface="Arial"/>
-              </a:rPr>
-              <a:t> la </a:t>
-            </a:r>
-            <a:r>
-              <a:rPr lang="es-ES" sz="2400" b="0" dirty="0" err="1">
-                <a:solidFill>
-                  <a:srgbClr val="192D3E"/>
-                </a:solidFill>
-                <a:latin typeface="Arial"/>
-              </a:rPr>
-              <a:t>formació</a:t>
-            </a:r>
-            <a:r>
-              <a:rPr lang="es-ES" sz="2400" b="0" dirty="0">
-                <a:solidFill>
-                  <a:srgbClr val="192D3E"/>
-                </a:solidFill>
-                <a:latin typeface="Arial"/>
-              </a:rPr>
-              <a:t> </a:t>
-            </a:r>
-            <a:r>
-              <a:rPr lang="es-ES" sz="2400" b="0" dirty="0" err="1">
-                <a:solidFill>
-                  <a:srgbClr val="192D3E"/>
-                </a:solidFill>
-                <a:latin typeface="Arial"/>
-              </a:rPr>
-              <a:t>universitària</a:t>
-            </a:r>
-            <a:r>
-              <a:rPr lang="es-ES" sz="2400" b="0" dirty="0">
-                <a:solidFill>
-                  <a:srgbClr val="192D3E"/>
-                </a:solidFill>
-                <a:latin typeface="Arial"/>
-              </a:rPr>
-              <a:t>. </a:t>
-            </a:r>
-            <a:br>
-              <a:rPr lang="es-ES" sz="2400" b="0" dirty="0">
-                <a:solidFill>
-                  <a:srgbClr val="192D3E"/>
-                </a:solidFill>
-                <a:latin typeface="Arial"/>
-              </a:rPr>
-            </a:br>
-            <a:endParaRPr lang="es-ES" sz="2400" b="0" dirty="0">
-              <a:solidFill>
-                <a:srgbClr val="192D3E"/>
-              </a:solidFill>
-              <a:latin typeface="Arial"/>
-            </a:endParaRPr>
+                <a:effectLst/>
+                <a:uFillTx/>
+                <a:latin typeface="Arial"/>
+              </a:rPr>
+              <a:t>L’adaptador encapsula la integració externa.</a:t>
+            </a:r>
           </a:p>
         </p:txBody>
       </p:sp>
@@ -12006,7 +11722,7 @@
         </p:nvSpPr>
         <p:spPr>
           <a:xfrm>
-            <a:off x="1869840" y="4380572"/>
+            <a:off x="1869840" y="3350000"/>
             <a:ext cx="8595360" cy="1217428"/>
           </a:xfrm>
           <a:prstGeom prst="roundRect">
@@ -12052,7 +11768,7 @@
         </p:nvSpPr>
         <p:spPr>
           <a:xfrm>
-            <a:off x="2030392" y="4484558"/>
+            <a:off x="2030392" y="3453986"/>
             <a:ext cx="8099528" cy="868681"/>
           </a:xfrm>
           <a:prstGeom prst="rect">
@@ -12068,20 +11784,14 @@
           <a:p>
             <a:pPr algn="ctr"/>
             <a:r>
-              <a:rPr sz="1600" b="0" dirty="0" err="1">
+              <a:rPr lang="ca-ES" sz="2800" b="1" dirty="0">
                 <a:solidFill>
                   <a:srgbClr val="192D3E"/>
                 </a:solidFill>
                 <a:latin typeface="Arial"/>
               </a:rPr>
-              <a:t>Agraïment al TecnoCampus i al Dr. Josep Roure pel treball compartit en arquitectura de software, docència i metodologies actives.</a:t>
-            </a:r>
-            <a:endParaRPr sz="1600" b="0" dirty="0">
-              <a:solidFill>
-                <a:srgbClr val="192D3E"/>
-              </a:solidFill>
-              <a:latin typeface="Arial"/>
-            </a:endParaRPr>
+              <a:t>L’arquitectura no elimina el canvi; el localitza.</a:t>
+            </a:r>
           </a:p>
         </p:txBody>
       </p:sp>
@@ -13205,6 +12915,675 @@
               </a:solidFill>
               <a:effectLst/>
               <a:uFillTx/>
+              <a:latin typeface="Arial"/>
+            </a:endParaRPr>
+          </a:p>
+        </p:txBody>
+      </p:sp>
+    </p:spTree>
+  </p:cSld>
+  <p:clrMapOvr>
+    <a:masterClrMapping/>
+  </p:clrMapOvr>
+</p:sld>
+</file>
+
+<file path=ppt/slides/slide12.xml><?xml version="1.0" encoding="utf-8"?>
+<p:sld xmlns:a="http://schemas.openxmlformats.org/drawingml/2006/main" xmlns:r="http://schemas.openxmlformats.org/officeDocument/2006/relationships" xmlns:p="http://schemas.openxmlformats.org/presentationml/2006/main">
+  <p:cSld>
+    <p:spTree>
+      <p:nvGrpSpPr>
+        <p:cNvPr id="1" name=""/>
+        <p:cNvGrpSpPr/>
+        <p:nvPr/>
+      </p:nvGrpSpPr>
+      <p:grpSpPr>
+        <a:xfrm>
+          <a:off x="0" y="0"/>
+          <a:ext cx="0" cy="0"/>
+          <a:chOff x="0" y="0"/>
+          <a:chExt cx="0" cy="0"/>
+        </a:xfrm>
+      </p:grpSpPr>
+      <p:sp>
+        <p:nvSpPr>
+          <p:cNvPr id="2" name="TextBox 1"/>
+          <p:cNvSpPr txBox="1"/>
+          <p:nvPr/>
+        </p:nvSpPr>
+        <p:spPr>
+          <a:xfrm>
+            <a:off x="594360" y="320040"/>
+            <a:ext cx="8961120" cy="502920"/>
+          </a:xfrm>
+          <a:prstGeom prst="rect">
+            <a:avLst/>
+          </a:prstGeom>
+          <a:noFill/>
+        </p:spPr>
+        <p:txBody>
+          <a:bodyPr wrap="square">
+            <a:normAutofit lnSpcReduction="10000"/>
+          </a:bodyPr>
+          <a:lstStyle/>
+          <a:p>
+            <a:pPr algn="l"/>
+            <a:r>
+              <a:rPr sz="2800" b="1">
+                <a:solidFill>
+                  <a:srgbClr val="192D3E"/>
+                </a:solidFill>
+                <a:latin typeface="Arial"/>
+              </a:rPr>
+              <a:t>Agraïment</a:t>
+            </a:r>
+          </a:p>
+        </p:txBody>
+      </p:sp>
+      <p:pic>
+        <p:nvPicPr>
+          <p:cNvPr id="3" name="Picture 2" descr="logotip-oficial-tecnocampus-upf-horitzontal-color.png"/>
+          <p:cNvPicPr>
+            <a:picLocks noChangeAspect="1"/>
+          </p:cNvPicPr>
+          <p:nvPr/>
+        </p:nvPicPr>
+        <p:blipFill>
+          <a:blip r:embed="rId3"/>
+          <a:stretch>
+            <a:fillRect/>
+          </a:stretch>
+        </p:blipFill>
+        <p:spPr>
+          <a:xfrm>
+            <a:off x="8480078" y="293025"/>
+            <a:ext cx="3041362" cy="575655"/>
+          </a:xfrm>
+          <a:prstGeom prst="rect">
+            <a:avLst/>
+          </a:prstGeom>
+        </p:spPr>
+      </p:pic>
+      <p:sp>
+        <p:nvSpPr>
+          <p:cNvPr id="4" name="Rectangle 3"/>
+          <p:cNvSpPr/>
+          <p:nvPr/>
+        </p:nvSpPr>
+        <p:spPr>
+          <a:xfrm>
+            <a:off x="594360" y="1115568"/>
+            <a:ext cx="10972800" cy="13716"/>
+          </a:xfrm>
+          <a:prstGeom prst="rect">
+            <a:avLst/>
+          </a:prstGeom>
+          <a:solidFill>
+            <a:srgbClr val="D6DBE0"/>
+          </a:solidFill>
+          <a:ln>
+            <a:noFill/>
+          </a:ln>
+        </p:spPr>
+        <p:style>
+          <a:lnRef idx="1">
+            <a:schemeClr val="accent1"/>
+          </a:lnRef>
+          <a:fillRef idx="3">
+            <a:schemeClr val="accent1"/>
+          </a:fillRef>
+          <a:effectRef idx="2">
+            <a:schemeClr val="accent1"/>
+          </a:effectRef>
+          <a:fontRef idx="minor">
+            <a:schemeClr val="lt1"/>
+          </a:fontRef>
+        </p:style>
+        <p:txBody>
+          <a:bodyPr rtlCol="0" anchor="ctr"/>
+          <a:lstStyle/>
+          <a:p>
+            <a:pPr algn="ctr"/>
+            <a:endParaRPr/>
+          </a:p>
+        </p:txBody>
+      </p:sp>
+      <p:sp>
+        <p:nvSpPr>
+          <p:cNvPr id="5" name="TextBox 4"/>
+          <p:cNvSpPr txBox="1"/>
+          <p:nvPr/>
+        </p:nvSpPr>
+        <p:spPr>
+          <a:xfrm>
+            <a:off x="1178973" y="2600000"/>
+            <a:ext cx="9834053" cy="1780528"/>
+          </a:xfrm>
+          <a:prstGeom prst="rect">
+            <a:avLst/>
+          </a:prstGeom>
+          <a:noFill/>
+        </p:spPr>
+        <p:txBody>
+          <a:bodyPr wrap="square">
+            <a:normAutofit lnSpcReduction="10000"/>
+          </a:bodyPr>
+          <a:lstStyle/>
+          <a:p>
+            <a:pPr algn="ctr"/>
+            <a:r>
+              <a:rPr lang="es-ES" sz="2400" b="0" dirty="0" err="1">
+                <a:solidFill>
+                  <a:srgbClr val="192D3E"/>
+                </a:solidFill>
+                <a:latin typeface="Arial"/>
+              </a:rPr>
+              <a:t>Vull</a:t>
+            </a:r>
+            <a:r>
+              <a:rPr lang="es-ES" sz="2400" b="0" dirty="0">
+                <a:solidFill>
+                  <a:srgbClr val="192D3E"/>
+                </a:solidFill>
+                <a:latin typeface="Arial"/>
+              </a:rPr>
+              <a:t> </a:t>
+            </a:r>
+            <a:r>
+              <a:rPr lang="es-ES" sz="2400" b="0" dirty="0" err="1">
+                <a:solidFill>
+                  <a:srgbClr val="192D3E"/>
+                </a:solidFill>
+                <a:latin typeface="Arial"/>
+              </a:rPr>
+              <a:t>expressar</a:t>
+            </a:r>
+            <a:r>
+              <a:rPr lang="es-ES" sz="2400" b="0" dirty="0">
+                <a:solidFill>
+                  <a:srgbClr val="192D3E"/>
+                </a:solidFill>
+                <a:latin typeface="Arial"/>
+              </a:rPr>
+              <a:t> el </a:t>
+            </a:r>
+            <a:r>
+              <a:rPr lang="es-ES" sz="2400" b="0" dirty="0" err="1">
+                <a:solidFill>
+                  <a:srgbClr val="192D3E"/>
+                </a:solidFill>
+                <a:latin typeface="Arial"/>
+              </a:rPr>
+              <a:t>meu</a:t>
+            </a:r>
+            <a:r>
+              <a:rPr lang="es-ES" sz="2400" b="0" dirty="0">
+                <a:solidFill>
+                  <a:srgbClr val="192D3E"/>
+                </a:solidFill>
+                <a:latin typeface="Arial"/>
+              </a:rPr>
+              <a:t> </a:t>
+            </a:r>
+            <a:r>
+              <a:rPr lang="es-ES" sz="2400" b="0" dirty="0" err="1">
+                <a:solidFill>
+                  <a:srgbClr val="192D3E"/>
+                </a:solidFill>
+                <a:latin typeface="Arial"/>
+              </a:rPr>
+              <a:t>agraïment</a:t>
+            </a:r>
+            <a:r>
+              <a:rPr lang="es-ES" sz="2400" b="0" dirty="0">
+                <a:solidFill>
+                  <a:srgbClr val="192D3E"/>
+                </a:solidFill>
+                <a:latin typeface="Arial"/>
+              </a:rPr>
+              <a:t> al </a:t>
+            </a:r>
+            <a:r>
+              <a:rPr lang="es-ES" sz="2400" b="0" dirty="0" err="1">
+                <a:solidFill>
+                  <a:srgbClr val="192D3E"/>
+                </a:solidFill>
+                <a:latin typeface="Arial"/>
+              </a:rPr>
+              <a:t>TecnoCampus</a:t>
+            </a:r>
+            <a:r>
+              <a:rPr lang="es-ES" sz="2400" b="0" dirty="0">
+                <a:solidFill>
+                  <a:srgbClr val="192D3E"/>
+                </a:solidFill>
+                <a:latin typeface="Arial"/>
+              </a:rPr>
+              <a:t> per un </a:t>
+            </a:r>
+            <a:r>
+              <a:rPr lang="es-ES" sz="2400" b="0" dirty="0" err="1">
+                <a:solidFill>
+                  <a:srgbClr val="192D3E"/>
+                </a:solidFill>
+                <a:latin typeface="Arial"/>
+              </a:rPr>
+              <a:t>entorn</a:t>
+            </a:r>
+            <a:r>
+              <a:rPr lang="es-ES" sz="2400" b="0" dirty="0">
+                <a:solidFill>
+                  <a:srgbClr val="192D3E"/>
+                </a:solidFill>
+                <a:latin typeface="Arial"/>
+              </a:rPr>
+              <a:t> que </a:t>
+            </a:r>
+            <a:r>
+              <a:rPr lang="es-ES" sz="2400" b="0" dirty="0" err="1">
+                <a:solidFill>
+                  <a:srgbClr val="192D3E"/>
+                </a:solidFill>
+                <a:latin typeface="Arial"/>
+              </a:rPr>
+              <a:t>m'encoratja</a:t>
+            </a:r>
+            <a:r>
+              <a:rPr lang="es-ES" sz="2400" b="0" dirty="0">
+                <a:solidFill>
+                  <a:srgbClr val="192D3E"/>
+                </a:solidFill>
+                <a:latin typeface="Arial"/>
+              </a:rPr>
+              <a:t> a </a:t>
+            </a:r>
+            <a:r>
+              <a:rPr lang="es-ES" sz="2400" b="0" dirty="0" err="1">
+                <a:solidFill>
+                  <a:srgbClr val="192D3E"/>
+                </a:solidFill>
+                <a:latin typeface="Arial"/>
+              </a:rPr>
+              <a:t>créixer</a:t>
+            </a:r>
+            <a:r>
+              <a:rPr lang="es-ES" sz="2400" b="0">
+                <a:solidFill>
+                  <a:srgbClr val="192D3E"/>
+                </a:solidFill>
+                <a:latin typeface="Arial"/>
+              </a:rPr>
+              <a:t>, </a:t>
+            </a:r>
+            <a:r>
+              <a:rPr lang="es-ES" sz="2400" b="0" dirty="0">
+                <a:solidFill>
+                  <a:srgbClr val="192D3E"/>
+                </a:solidFill>
+                <a:latin typeface="Arial"/>
+              </a:rPr>
+              <a:t>al </a:t>
+            </a:r>
+            <a:r>
+              <a:rPr lang="es-ES" sz="2400" b="0" dirty="0" err="1">
+                <a:solidFill>
+                  <a:srgbClr val="192D3E"/>
+                </a:solidFill>
+                <a:latin typeface="Arial"/>
+              </a:rPr>
+              <a:t>costat</a:t>
+            </a:r>
+            <a:r>
+              <a:rPr lang="es-ES" sz="2400" b="0" dirty="0">
+                <a:solidFill>
+                  <a:srgbClr val="192D3E"/>
+                </a:solidFill>
+                <a:latin typeface="Arial"/>
+              </a:rPr>
+              <a:t> </a:t>
+            </a:r>
+            <a:r>
+              <a:rPr lang="es-ES" sz="2400" b="0" dirty="0" err="1">
+                <a:solidFill>
+                  <a:srgbClr val="192D3E"/>
+                </a:solidFill>
+                <a:latin typeface="Arial"/>
+              </a:rPr>
+              <a:t>d'un</a:t>
+            </a:r>
+            <a:r>
+              <a:rPr lang="es-ES" sz="2400" b="0" dirty="0">
+                <a:solidFill>
+                  <a:srgbClr val="192D3E"/>
+                </a:solidFill>
+                <a:latin typeface="Arial"/>
+              </a:rPr>
+              <a:t> </a:t>
+            </a:r>
+            <a:r>
+              <a:rPr lang="es-ES" sz="2400" b="0" dirty="0" err="1">
+                <a:solidFill>
+                  <a:srgbClr val="192D3E"/>
+                </a:solidFill>
+                <a:latin typeface="Arial"/>
+              </a:rPr>
+              <a:t>equip</a:t>
+            </a:r>
+            <a:r>
+              <a:rPr lang="es-ES" sz="2400" b="0" dirty="0">
+                <a:solidFill>
+                  <a:srgbClr val="192D3E"/>
+                </a:solidFill>
+                <a:latin typeface="Arial"/>
+              </a:rPr>
+              <a:t> del </a:t>
+            </a:r>
+            <a:r>
+              <a:rPr lang="es-ES" sz="2400" b="0" dirty="0" err="1">
+                <a:solidFill>
+                  <a:srgbClr val="192D3E"/>
+                </a:solidFill>
+                <a:latin typeface="Arial"/>
+              </a:rPr>
+              <a:t>qual</a:t>
+            </a:r>
+            <a:r>
+              <a:rPr lang="es-ES" sz="2400" b="0" dirty="0">
+                <a:solidFill>
+                  <a:srgbClr val="192D3E"/>
+                </a:solidFill>
+                <a:latin typeface="Arial"/>
+              </a:rPr>
+              <a:t> </a:t>
+            </a:r>
+            <a:r>
+              <a:rPr lang="es-ES" sz="2400" b="0" dirty="0" err="1">
+                <a:solidFill>
+                  <a:srgbClr val="192D3E"/>
+                </a:solidFill>
+                <a:latin typeface="Arial"/>
+              </a:rPr>
+              <a:t>aprenc</a:t>
+            </a:r>
+            <a:r>
+              <a:rPr lang="es-ES" sz="2400" b="0" dirty="0">
+                <a:solidFill>
+                  <a:srgbClr val="192D3E"/>
+                </a:solidFill>
+                <a:latin typeface="Arial"/>
+              </a:rPr>
+              <a:t> i </a:t>
+            </a:r>
+            <a:r>
+              <a:rPr lang="es-ES" sz="2400" b="0" dirty="0" err="1">
+                <a:solidFill>
+                  <a:srgbClr val="192D3E"/>
+                </a:solidFill>
+                <a:latin typeface="Arial"/>
+              </a:rPr>
+              <a:t>amb</a:t>
+            </a:r>
+            <a:r>
+              <a:rPr lang="es-ES" sz="2400" b="0" dirty="0">
+                <a:solidFill>
+                  <a:srgbClr val="192D3E"/>
+                </a:solidFill>
+                <a:latin typeface="Arial"/>
+              </a:rPr>
+              <a:t> qui </a:t>
+            </a:r>
+            <a:r>
+              <a:rPr lang="es-ES" sz="2400" b="0" dirty="0" err="1">
+                <a:solidFill>
+                  <a:srgbClr val="192D3E"/>
+                </a:solidFill>
+                <a:latin typeface="Arial"/>
+              </a:rPr>
+              <a:t>comparteixo</a:t>
+            </a:r>
+            <a:r>
+              <a:rPr lang="es-ES" sz="2400" b="0" dirty="0">
+                <a:solidFill>
+                  <a:srgbClr val="192D3E"/>
+                </a:solidFill>
+                <a:latin typeface="Arial"/>
+              </a:rPr>
+              <a:t> </a:t>
+            </a:r>
+            <a:r>
+              <a:rPr lang="es-ES" sz="2400" b="0" dirty="0" err="1">
+                <a:solidFill>
+                  <a:srgbClr val="192D3E"/>
+                </a:solidFill>
+                <a:latin typeface="Arial"/>
+              </a:rPr>
+              <a:t>coneixement</a:t>
+            </a:r>
+            <a:r>
+              <a:rPr lang="es-ES" sz="2400" b="0" dirty="0">
+                <a:solidFill>
+                  <a:srgbClr val="192D3E"/>
+                </a:solidFill>
+                <a:latin typeface="Arial"/>
+              </a:rPr>
+              <a:t>, </a:t>
+            </a:r>
+            <a:r>
+              <a:rPr lang="es-ES" sz="2400" b="0" dirty="0" err="1">
+                <a:solidFill>
+                  <a:srgbClr val="192D3E"/>
+                </a:solidFill>
+                <a:latin typeface="Arial"/>
+              </a:rPr>
+              <a:t>responsabilitat</a:t>
+            </a:r>
+            <a:r>
+              <a:rPr lang="es-ES" sz="2400" b="0" dirty="0">
+                <a:solidFill>
+                  <a:srgbClr val="192D3E"/>
+                </a:solidFill>
+                <a:latin typeface="Arial"/>
+              </a:rPr>
+              <a:t> i </a:t>
+            </a:r>
+            <a:r>
+              <a:rPr lang="es-ES" sz="2400" b="0" dirty="0" err="1">
+                <a:solidFill>
+                  <a:srgbClr val="192D3E"/>
+                </a:solidFill>
+                <a:latin typeface="Arial"/>
+              </a:rPr>
+              <a:t>compromís</a:t>
+            </a:r>
+            <a:r>
+              <a:rPr lang="es-ES" sz="2400" b="0" dirty="0">
+                <a:solidFill>
+                  <a:srgbClr val="192D3E"/>
+                </a:solidFill>
+                <a:latin typeface="Arial"/>
+              </a:rPr>
+              <a:t> </a:t>
+            </a:r>
+            <a:r>
+              <a:rPr lang="es-ES" sz="2400" b="0" dirty="0" err="1">
+                <a:solidFill>
+                  <a:srgbClr val="192D3E"/>
+                </a:solidFill>
+                <a:latin typeface="Arial"/>
+              </a:rPr>
+              <a:t>amb</a:t>
+            </a:r>
+            <a:r>
+              <a:rPr lang="es-ES" sz="2400" b="0" dirty="0">
+                <a:solidFill>
+                  <a:srgbClr val="192D3E"/>
+                </a:solidFill>
+                <a:latin typeface="Arial"/>
+              </a:rPr>
+              <a:t> la </a:t>
+            </a:r>
+            <a:r>
+              <a:rPr lang="es-ES" sz="2400" b="0" dirty="0" err="1">
+                <a:solidFill>
+                  <a:srgbClr val="192D3E"/>
+                </a:solidFill>
+                <a:latin typeface="Arial"/>
+              </a:rPr>
+              <a:t>formació</a:t>
+            </a:r>
+            <a:r>
+              <a:rPr lang="es-ES" sz="2400" b="0" dirty="0">
+                <a:solidFill>
+                  <a:srgbClr val="192D3E"/>
+                </a:solidFill>
+                <a:latin typeface="Arial"/>
+              </a:rPr>
+              <a:t> </a:t>
+            </a:r>
+            <a:r>
+              <a:rPr lang="es-ES" sz="2400" b="0" dirty="0" err="1">
+                <a:solidFill>
+                  <a:srgbClr val="192D3E"/>
+                </a:solidFill>
+                <a:latin typeface="Arial"/>
+              </a:rPr>
+              <a:t>universitària</a:t>
+            </a:r>
+            <a:r>
+              <a:rPr lang="es-ES" sz="2400" b="0" dirty="0">
+                <a:solidFill>
+                  <a:srgbClr val="192D3E"/>
+                </a:solidFill>
+                <a:latin typeface="Arial"/>
+              </a:rPr>
+              <a:t>. </a:t>
+            </a:r>
+            <a:br>
+              <a:rPr lang="es-ES" sz="2400" b="0" dirty="0">
+                <a:solidFill>
+                  <a:srgbClr val="192D3E"/>
+                </a:solidFill>
+                <a:latin typeface="Arial"/>
+              </a:rPr>
+            </a:br>
+            <a:endParaRPr lang="es-ES" sz="2400" b="0" dirty="0">
+              <a:solidFill>
+                <a:srgbClr val="192D3E"/>
+              </a:solidFill>
+              <a:latin typeface="Arial"/>
+            </a:endParaRPr>
+          </a:p>
+        </p:txBody>
+      </p:sp>
+      <p:sp>
+        <p:nvSpPr>
+          <p:cNvPr id="8" name="TextBox 7"/>
+          <p:cNvSpPr txBox="1"/>
+          <p:nvPr/>
+        </p:nvSpPr>
+        <p:spPr>
+          <a:xfrm>
+            <a:off x="2030392" y="4800000"/>
+            <a:ext cx="8099528" cy="868681"/>
+          </a:xfrm>
+          <a:prstGeom prst="rect">
+            <a:avLst/>
+          </a:prstGeom>
+          <a:noFill/>
+        </p:spPr>
+        <p:txBody>
+          <a:bodyPr wrap="square">
+            <a:normAutofit/>
+          </a:bodyPr>
+          <a:lstStyle/>
+          <a:p>
+            <a:pPr algn="ctr"/>
+            <a:r>
+              <a:rPr lang="ca-ES" sz="2800" b="1" dirty="0">
+                <a:solidFill>
+                  <a:srgbClr val="192D3E"/>
+                </a:solidFill>
+                <a:latin typeface="Arial"/>
+              </a:rPr>
+              <a:t>Moltes gràcies.</a:t>
+            </a:r>
+          </a:p>
+        </p:txBody>
+      </p:sp>
+      <p:sp>
+        <p:nvSpPr>
+          <p:cNvPr id="9" name="TextBox 8"/>
+          <p:cNvSpPr txBox="1"/>
+          <p:nvPr/>
+        </p:nvSpPr>
+        <p:spPr>
+          <a:xfrm>
+            <a:off x="594360" y="6473952"/>
+            <a:ext cx="8595360" cy="201168"/>
+          </a:xfrm>
+          <a:prstGeom prst="rect">
+            <a:avLst/>
+          </a:prstGeom>
+          <a:noFill/>
+        </p:spPr>
+        <p:txBody>
+          <a:bodyPr wrap="square">
+            <a:normAutofit lnSpcReduction="10000"/>
+          </a:bodyPr>
+          <a:lstStyle/>
+          <a:p>
+            <a:pPr algn="l"/>
+            <a:r>
+              <a:rPr sz="800" b="0">
+                <a:solidFill>
+                  <a:srgbClr val="66707A"/>
+                </a:solidFill>
+                <a:latin typeface="Arial"/>
+              </a:rPr>
+              <a:t>Disseny de Sistemes d'Informació · Ports de sortida en arquitectura hexagonal</a:t>
+            </a:r>
+          </a:p>
+        </p:txBody>
+      </p:sp>
+      <p:sp>
+        <p:nvSpPr>
+          <p:cNvPr id="10" name="TextBox 9"/>
+          <p:cNvSpPr txBox="1"/>
+          <p:nvPr/>
+        </p:nvSpPr>
+        <p:spPr>
+          <a:xfrm>
+            <a:off x="11155680" y="6473952"/>
+            <a:ext cx="411480" cy="201168"/>
+          </a:xfrm>
+          <a:prstGeom prst="rect">
+            <a:avLst/>
+          </a:prstGeom>
+          <a:noFill/>
+        </p:spPr>
+        <p:txBody>
+          <a:bodyPr wrap="square">
+            <a:normAutofit lnSpcReduction="10000"/>
+          </a:bodyPr>
+          <a:lstStyle/>
+          <a:p>
+            <a:pPr algn="r"/>
+            <a:r>
+              <a:rPr lang="es-ES" sz="800" b="0" dirty="0">
+                <a:solidFill>
+                  <a:srgbClr val="66707A"/>
+                </a:solidFill>
+                <a:latin typeface="Arial"/>
+              </a:rPr>
+              <a:t>11</a:t>
+            </a:r>
+          </a:p>
+          <a:p>
+            <a:pPr algn="r"/>
+            <a:endParaRPr sz="800" b="0" dirty="0">
+              <a:solidFill>
+                <a:srgbClr val="66707A"/>
+              </a:solidFill>
               <a:latin typeface="Arial"/>
             </a:endParaRPr>
           </a:p>

</xml_diff>

<commit_message>
Redissenya la concreció en Java de la diapositiva 7 com a diagrama UML
El requadre de la diapositiva 7 del deck de 20 minuts mostra ara la
interfície (contracte) i l'adaptador com a targetes UML unides per la
fletxa discontínua de realització «implements», de l'adaptador cap al
port. S'afegeixen dues acotacions al guió oral canònic per assenyalar
el nou visual i una nota de preservació al recordatori de millores.
Inclou els materials derivats regenerats.

Co-Authored-By: Claude Fable 5 <noreply@anthropic.com>
</commit_message>
<xml_diff>
--- a/doc/presentations/defensa-placa-permanent-dsi-ports-sortida-hexagonal/output/IMPORTANTE_MANUAL_defensa-dsi-ports-sortida-hexagonal.pptx
+++ b/doc/presentations/defensa-placa-permanent-dsi-ports-sortida-hexagonal/output/IMPORTANTE_MANUAL_defensa-dsi-ports-sortida-hexagonal.pptx
@@ -11901,166 +11901,73 @@
       </p:grpSpPr>
       <p:sp>
         <p:nvSpPr>
-          <p:cNvPr id="177" name="TextBox 1"/>
-          <p:cNvSpPr/>
+          <p:cNvPr id="2" name="TextBox 1"/>
+          <p:cNvSpPr txBox="1"/>
           <p:nvPr/>
         </p:nvSpPr>
         <p:spPr>
           <a:xfrm>
             <a:off x="594360" y="320040"/>
-            <a:ext cx="8960760" cy="502560"/>
+            <a:ext cx="8961120" cy="502920"/>
           </a:xfrm>
           <a:prstGeom prst="rect">
             <a:avLst/>
           </a:prstGeom>
           <a:noFill/>
-          <a:ln w="0">
-            <a:noFill/>
-          </a:ln>
-        </p:spPr>
-        <p:style>
-          <a:lnRef idx="0">
-            <a:scrgbClr r="0" g="0" b="0"/>
-          </a:lnRef>
-          <a:fillRef idx="0">
-            <a:scrgbClr r="0" g="0" b="0"/>
-          </a:fillRef>
-          <a:effectRef idx="0">
-            <a:scrgbClr r="0" g="0" b="0"/>
-          </a:effectRef>
-          <a:fontRef idx="minor"/>
-        </p:style>
-        <p:txBody>
-          <a:bodyPr lIns="90000" tIns="45000" rIns="90000" bIns="45000" anchor="t">
-            <a:normAutofit lnSpcReduction="9999"/>
+        </p:spPr>
+        <p:txBody>
+          <a:bodyPr wrap="square">
+            <a:normAutofit lnSpcReduction="10000"/>
           </a:bodyPr>
           <a:lstStyle/>
           <a:p>
-            <a:pPr defTabSz="457200">
-              <a:lnSpc>
-                <a:spcPct val="100000"/>
-              </a:lnSpc>
-            </a:pPr>
-            <a:r>
-              <a:rPr lang="es-ES" sz="2800" b="1" u="none" strike="noStrike">
+            <a:pPr algn="l"/>
+            <a:r>
+              <a:rPr sz="2800" b="1">
                 <a:solidFill>
                   <a:srgbClr val="192D3E"/>
                 </a:solidFill>
-                <a:effectLst/>
-                <a:uFillTx/>
-                <a:latin typeface="Arial"/>
-              </a:rPr>
-              <a:t>Annex. Demo opcional</a:t>
-            </a:r>
-            <a:endParaRPr lang="es-ES" sz="2800" b="0" u="none" strike="noStrike">
-              <a:solidFill>
-                <a:srgbClr val="000000"/>
-              </a:solidFill>
-              <a:effectLst/>
-              <a:uFillTx/>
-              <a:latin typeface="Arial"/>
-            </a:endParaRPr>
-          </a:p>
-        </p:txBody>
-      </p:sp>
-      <p:sp>
-        <p:nvSpPr>
-          <p:cNvPr id="178" name="TextBox 2"/>
-          <p:cNvSpPr/>
-          <p:nvPr/>
-        </p:nvSpPr>
-        <p:spPr>
-          <a:xfrm>
-            <a:off x="612720" y="822960"/>
-            <a:ext cx="8869320" cy="319680"/>
-          </a:xfrm>
-          <a:prstGeom prst="rect">
-            <a:avLst/>
-          </a:prstGeom>
-          <a:noFill/>
-          <a:ln w="0">
-            <a:noFill/>
-          </a:ln>
-        </p:spPr>
-        <p:style>
-          <a:lnRef idx="0">
-            <a:scrgbClr r="0" g="0" b="0"/>
-          </a:lnRef>
-          <a:fillRef idx="0">
-            <a:scrgbClr r="0" g="0" b="0"/>
-          </a:fillRef>
-          <a:effectRef idx="0">
-            <a:scrgbClr r="0" g="0" b="0"/>
-          </a:effectRef>
-          <a:fontRef idx="minor"/>
-        </p:style>
-        <p:txBody>
-          <a:bodyPr lIns="90000" tIns="45000" rIns="90000" bIns="45000" anchor="t">
-            <a:normAutofit/>
-          </a:bodyPr>
-          <a:lstStyle/>
-          <a:p>
-            <a:pPr defTabSz="457200">
-              <a:lnSpc>
-                <a:spcPct val="100000"/>
-              </a:lnSpc>
-            </a:pPr>
-            <a:r>
-              <a:rPr lang="en-US" sz="1300" b="0" u="none" strike="noStrike">
-                <a:solidFill>
-                  <a:srgbClr val="66707A"/>
-                </a:solidFill>
-                <a:effectLst/>
-                <a:uFillTx/>
-                <a:latin typeface="Arial"/>
-              </a:rPr>
-              <a:t>Mateix cas d'ús, adaptador substituïble</a:t>
-            </a:r>
-            <a:endParaRPr lang="es-ES" sz="1300" b="0" u="none" strike="noStrike">
-              <a:solidFill>
-                <a:srgbClr val="000000"/>
-              </a:solidFill>
-              <a:effectLst/>
-              <a:uFillTx/>
-              <a:latin typeface="Arial"/>
-            </a:endParaRPr>
+                <a:latin typeface="Arial"/>
+              </a:rPr>
+              <a:t>Agraïment</a:t>
+            </a:r>
           </a:p>
         </p:txBody>
       </p:sp>
       <p:pic>
         <p:nvPicPr>
-          <p:cNvPr id="179" name="Picture 3" descr="logotip-oficial-tecnocampus-upf-horitzontal-color.png"/>
-          <p:cNvPicPr/>
+          <p:cNvPr id="3" name="Picture 2" descr="logotip-oficial-tecnocampus-upf-horitzontal-color.png"/>
+          <p:cNvPicPr>
+            <a:picLocks noChangeAspect="1"/>
+          </p:cNvPicPr>
           <p:nvPr/>
         </p:nvPicPr>
         <p:blipFill>
           <a:blip r:embed="rId3"/>
-          <a:stretch/>
+          <a:stretch>
+            <a:fillRect/>
+          </a:stretch>
         </p:blipFill>
         <p:spPr>
           <a:xfrm>
-            <a:off x="8480160" y="293040"/>
-            <a:ext cx="3040920" cy="575280"/>
-          </a:xfrm>
-          <a:prstGeom prst="rect">
-            <a:avLst/>
-          </a:prstGeom>
-          <a:noFill/>
-          <a:ln w="0">
-            <a:noFill/>
-          </a:ln>
+            <a:off x="8480078" y="293025"/>
+            <a:ext cx="3041362" cy="575655"/>
+          </a:xfrm>
+          <a:prstGeom prst="rect">
+            <a:avLst/>
+          </a:prstGeom>
         </p:spPr>
       </p:pic>
       <p:sp>
         <p:nvSpPr>
-          <p:cNvPr id="180" name="Rectangle 4"/>
+          <p:cNvPr id="4" name="Rectangle 3"/>
           <p:cNvSpPr/>
           <p:nvPr/>
         </p:nvSpPr>
         <p:spPr>
           <a:xfrm>
-            <a:off x="594360" y="1115640"/>
-            <a:ext cx="10972440" cy="13320"/>
+            <a:off x="594360" y="1115568"/>
+            <a:ext cx="10972800" cy="13716"/>
           </a:xfrm>
           <a:prstGeom prst="rect">
             <a:avLst/>
@@ -12071,13 +11978,6 @@
           <a:ln>
             <a:noFill/>
           </a:ln>
-          <a:effectLst>
-            <a:outerShdw blurRad="39960" dist="23040" dir="5400000" rotWithShape="0">
-              <a:srgbClr val="000000">
-                <a:alpha val="35000"/>
-              </a:srgbClr>
-            </a:outerShdw>
-          </a:effectLst>
         </p:spPr>
         <p:style>
           <a:lnRef idx="1">
@@ -12089,84 +11989,441 @@
           <a:effectRef idx="2">
             <a:schemeClr val="accent1"/>
           </a:effectRef>
-          <a:fontRef idx="minor"/>
+          <a:fontRef idx="minor">
+            <a:schemeClr val="lt1"/>
+          </a:fontRef>
         </p:style>
         <p:txBody>
-          <a:bodyPr lIns="90000" tIns="-31320" rIns="90000" bIns="-31320" anchor="ctr">
-            <a:noAutofit/>
-          </a:bodyPr>
+          <a:bodyPr rtlCol="0" anchor="ctr"/>
           <a:lstStyle/>
           <a:p>
-            <a:endParaRPr lang="en-US" sz="1800" b="0" u="none" strike="noStrike">
-              <a:solidFill>
-                <a:schemeClr val="lt1"/>
-              </a:solidFill>
-              <a:effectLst/>
-              <a:uFillTx/>
-              <a:latin typeface="Calibri"/>
-            </a:endParaRPr>
-          </a:p>
-        </p:txBody>
-      </p:sp>
-      <p:sp>
-        <p:nvSpPr>
-          <p:cNvPr id="181" name="TextBox 5"/>
-          <p:cNvSpPr/>
+            <a:pPr algn="ctr"/>
+            <a:endParaRPr/>
+          </a:p>
+        </p:txBody>
+      </p:sp>
+      <p:sp>
+        <p:nvSpPr>
+          <p:cNvPr id="5" name="TextBox 4"/>
+          <p:cNvSpPr txBox="1"/>
           <p:nvPr/>
         </p:nvSpPr>
         <p:spPr>
           <a:xfrm>
-            <a:off x="914400" y="1325880"/>
-            <a:ext cx="10286640" cy="502560"/>
+            <a:off x="1178973" y="2600000"/>
+            <a:ext cx="9834053" cy="1780528"/>
           </a:xfrm>
           <a:prstGeom prst="rect">
             <a:avLst/>
           </a:prstGeom>
           <a:noFill/>
-          <a:ln w="0">
-            <a:noFill/>
-          </a:ln>
-        </p:spPr>
-        <p:style>
-          <a:lnRef idx="0">
-            <a:scrgbClr r="0" g="0" b="0"/>
-          </a:lnRef>
-          <a:fillRef idx="0">
-            <a:scrgbClr r="0" g="0" b="0"/>
-          </a:fillRef>
-          <a:effectRef idx="0">
-            <a:scrgbClr r="0" g="0" b="0"/>
-          </a:effectRef>
-          <a:fontRef idx="minor"/>
-        </p:style>
-        <p:txBody>
-          <a:bodyPr lIns="90000" tIns="45000" rIns="90000" bIns="45000" anchor="t">
-            <a:normAutofit fontScale="85000" lnSpcReduction="9999"/>
+        </p:spPr>
+        <p:txBody>
+          <a:bodyPr wrap="square">
+            <a:normAutofit lnSpcReduction="10000"/>
           </a:bodyPr>
           <a:lstStyle/>
           <a:p>
-            <a:pPr algn="ctr" defTabSz="457200">
-              <a:lnSpc>
-                <a:spcPct val="100000"/>
-              </a:lnSpc>
-            </a:pPr>
-            <a:r>
-              <a:rPr lang="en-US" sz="1800" b="0" u="none" strike="noStrike">
+            <a:pPr algn="ctr"/>
+            <a:r>
+              <a:rPr lang="es-ES" sz="2400" b="0" dirty="0" err="1">
                 <a:solidFill>
                   <a:srgbClr val="192D3E"/>
                 </a:solidFill>
-                <a:effectLst/>
-                <a:uFillTx/>
-                <a:latin typeface="Arial"/>
-              </a:rPr>
-              <a:t>HexaStock és un projecte open source propi utilitzat en docència universitària i formació o consultoria professional.</a:t>
-            </a:r>
-            <a:endParaRPr lang="es-ES" sz="1800" b="0" u="none" strike="noStrike">
-              <a:solidFill>
-                <a:srgbClr val="000000"/>
-              </a:solidFill>
-              <a:effectLst/>
-              <a:uFillTx/>
+                <a:latin typeface="Arial"/>
+              </a:rPr>
+              <a:t>Vull</a:t>
+            </a:r>
+            <a:r>
+              <a:rPr lang="es-ES" sz="2400" b="0" dirty="0">
+                <a:solidFill>
+                  <a:srgbClr val="192D3E"/>
+                </a:solidFill>
+                <a:latin typeface="Arial"/>
+              </a:rPr>
+              <a:t> </a:t>
+            </a:r>
+            <a:r>
+              <a:rPr lang="es-ES" sz="2400" b="0" dirty="0" err="1">
+                <a:solidFill>
+                  <a:srgbClr val="192D3E"/>
+                </a:solidFill>
+                <a:latin typeface="Arial"/>
+              </a:rPr>
+              <a:t>expressar</a:t>
+            </a:r>
+            <a:r>
+              <a:rPr lang="es-ES" sz="2400" b="0" dirty="0">
+                <a:solidFill>
+                  <a:srgbClr val="192D3E"/>
+                </a:solidFill>
+                <a:latin typeface="Arial"/>
+              </a:rPr>
+              <a:t> el </a:t>
+            </a:r>
+            <a:r>
+              <a:rPr lang="es-ES" sz="2400" b="0" dirty="0" err="1">
+                <a:solidFill>
+                  <a:srgbClr val="192D3E"/>
+                </a:solidFill>
+                <a:latin typeface="Arial"/>
+              </a:rPr>
+              <a:t>meu</a:t>
+            </a:r>
+            <a:r>
+              <a:rPr lang="es-ES" sz="2400" b="0" dirty="0">
+                <a:solidFill>
+                  <a:srgbClr val="192D3E"/>
+                </a:solidFill>
+                <a:latin typeface="Arial"/>
+              </a:rPr>
+              <a:t> </a:t>
+            </a:r>
+            <a:r>
+              <a:rPr lang="es-ES" sz="2400" b="0" dirty="0" err="1">
+                <a:solidFill>
+                  <a:srgbClr val="192D3E"/>
+                </a:solidFill>
+                <a:latin typeface="Arial"/>
+              </a:rPr>
+              <a:t>agraïment</a:t>
+            </a:r>
+            <a:r>
+              <a:rPr lang="es-ES" sz="2400" b="0" dirty="0">
+                <a:solidFill>
+                  <a:srgbClr val="192D3E"/>
+                </a:solidFill>
+                <a:latin typeface="Arial"/>
+              </a:rPr>
+              <a:t> al </a:t>
+            </a:r>
+            <a:r>
+              <a:rPr lang="es-ES" sz="2400" b="0" dirty="0" err="1">
+                <a:solidFill>
+                  <a:srgbClr val="192D3E"/>
+                </a:solidFill>
+                <a:latin typeface="Arial"/>
+              </a:rPr>
+              <a:t>TecnoCampus</a:t>
+            </a:r>
+            <a:r>
+              <a:rPr lang="es-ES" sz="2400" b="0" dirty="0">
+                <a:solidFill>
+                  <a:srgbClr val="192D3E"/>
+                </a:solidFill>
+                <a:latin typeface="Arial"/>
+              </a:rPr>
+              <a:t> per un </a:t>
+            </a:r>
+            <a:r>
+              <a:rPr lang="es-ES" sz="2400" b="0" dirty="0" err="1">
+                <a:solidFill>
+                  <a:srgbClr val="192D3E"/>
+                </a:solidFill>
+                <a:latin typeface="Arial"/>
+              </a:rPr>
+              <a:t>entorn</a:t>
+            </a:r>
+            <a:r>
+              <a:rPr lang="es-ES" sz="2400" b="0" dirty="0">
+                <a:solidFill>
+                  <a:srgbClr val="192D3E"/>
+                </a:solidFill>
+                <a:latin typeface="Arial"/>
+              </a:rPr>
+              <a:t> que </a:t>
+            </a:r>
+            <a:r>
+              <a:rPr lang="es-ES" sz="2400" b="0" dirty="0" err="1">
+                <a:solidFill>
+                  <a:srgbClr val="192D3E"/>
+                </a:solidFill>
+                <a:latin typeface="Arial"/>
+              </a:rPr>
+              <a:t>m'encoratja</a:t>
+            </a:r>
+            <a:r>
+              <a:rPr lang="es-ES" sz="2400" b="0" dirty="0">
+                <a:solidFill>
+                  <a:srgbClr val="192D3E"/>
+                </a:solidFill>
+                <a:latin typeface="Arial"/>
+              </a:rPr>
+              <a:t> a </a:t>
+            </a:r>
+            <a:r>
+              <a:rPr lang="es-ES" sz="2400" b="0" dirty="0" err="1">
+                <a:solidFill>
+                  <a:srgbClr val="192D3E"/>
+                </a:solidFill>
+                <a:latin typeface="Arial"/>
+              </a:rPr>
+              <a:t>créixer</a:t>
+            </a:r>
+            <a:r>
+              <a:rPr lang="es-ES" sz="2400" b="0">
+                <a:solidFill>
+                  <a:srgbClr val="192D3E"/>
+                </a:solidFill>
+                <a:latin typeface="Arial"/>
+              </a:rPr>
+              <a:t>, </a:t>
+            </a:r>
+            <a:r>
+              <a:rPr lang="es-ES" sz="2400" b="0" dirty="0">
+                <a:solidFill>
+                  <a:srgbClr val="192D3E"/>
+                </a:solidFill>
+                <a:latin typeface="Arial"/>
+              </a:rPr>
+              <a:t>al </a:t>
+            </a:r>
+            <a:r>
+              <a:rPr lang="es-ES" sz="2400" b="0" dirty="0" err="1">
+                <a:solidFill>
+                  <a:srgbClr val="192D3E"/>
+                </a:solidFill>
+                <a:latin typeface="Arial"/>
+              </a:rPr>
+              <a:t>costat</a:t>
+            </a:r>
+            <a:r>
+              <a:rPr lang="es-ES" sz="2400" b="0" dirty="0">
+                <a:solidFill>
+                  <a:srgbClr val="192D3E"/>
+                </a:solidFill>
+                <a:latin typeface="Arial"/>
+              </a:rPr>
+              <a:t> </a:t>
+            </a:r>
+            <a:r>
+              <a:rPr lang="es-ES" sz="2400" b="0" dirty="0" err="1">
+                <a:solidFill>
+                  <a:srgbClr val="192D3E"/>
+                </a:solidFill>
+                <a:latin typeface="Arial"/>
+              </a:rPr>
+              <a:t>d'un</a:t>
+            </a:r>
+            <a:r>
+              <a:rPr lang="es-ES" sz="2400" b="0" dirty="0">
+                <a:solidFill>
+                  <a:srgbClr val="192D3E"/>
+                </a:solidFill>
+                <a:latin typeface="Arial"/>
+              </a:rPr>
+              <a:t> </a:t>
+            </a:r>
+            <a:r>
+              <a:rPr lang="es-ES" sz="2400" b="0" dirty="0" err="1">
+                <a:solidFill>
+                  <a:srgbClr val="192D3E"/>
+                </a:solidFill>
+                <a:latin typeface="Arial"/>
+              </a:rPr>
+              <a:t>equip</a:t>
+            </a:r>
+            <a:r>
+              <a:rPr lang="es-ES" sz="2400" b="0" dirty="0">
+                <a:solidFill>
+                  <a:srgbClr val="192D3E"/>
+                </a:solidFill>
+                <a:latin typeface="Arial"/>
+              </a:rPr>
+              <a:t> del </a:t>
+            </a:r>
+            <a:r>
+              <a:rPr lang="es-ES" sz="2400" b="0" dirty="0" err="1">
+                <a:solidFill>
+                  <a:srgbClr val="192D3E"/>
+                </a:solidFill>
+                <a:latin typeface="Arial"/>
+              </a:rPr>
+              <a:t>qual</a:t>
+            </a:r>
+            <a:r>
+              <a:rPr lang="es-ES" sz="2400" b="0" dirty="0">
+                <a:solidFill>
+                  <a:srgbClr val="192D3E"/>
+                </a:solidFill>
+                <a:latin typeface="Arial"/>
+              </a:rPr>
+              <a:t> </a:t>
+            </a:r>
+            <a:r>
+              <a:rPr lang="es-ES" sz="2400" b="0" dirty="0" err="1">
+                <a:solidFill>
+                  <a:srgbClr val="192D3E"/>
+                </a:solidFill>
+                <a:latin typeface="Arial"/>
+              </a:rPr>
+              <a:t>aprenc</a:t>
+            </a:r>
+            <a:r>
+              <a:rPr lang="es-ES" sz="2400" b="0" dirty="0">
+                <a:solidFill>
+                  <a:srgbClr val="192D3E"/>
+                </a:solidFill>
+                <a:latin typeface="Arial"/>
+              </a:rPr>
+              <a:t> i </a:t>
+            </a:r>
+            <a:r>
+              <a:rPr lang="es-ES" sz="2400" b="0" dirty="0" err="1">
+                <a:solidFill>
+                  <a:srgbClr val="192D3E"/>
+                </a:solidFill>
+                <a:latin typeface="Arial"/>
+              </a:rPr>
+              <a:t>amb</a:t>
+            </a:r>
+            <a:r>
+              <a:rPr lang="es-ES" sz="2400" b="0" dirty="0">
+                <a:solidFill>
+                  <a:srgbClr val="192D3E"/>
+                </a:solidFill>
+                <a:latin typeface="Arial"/>
+              </a:rPr>
+              <a:t> qui </a:t>
+            </a:r>
+            <a:r>
+              <a:rPr lang="es-ES" sz="2400" b="0" dirty="0" err="1">
+                <a:solidFill>
+                  <a:srgbClr val="192D3E"/>
+                </a:solidFill>
+                <a:latin typeface="Arial"/>
+              </a:rPr>
+              <a:t>comparteixo</a:t>
+            </a:r>
+            <a:r>
+              <a:rPr lang="es-ES" sz="2400" b="0" dirty="0">
+                <a:solidFill>
+                  <a:srgbClr val="192D3E"/>
+                </a:solidFill>
+                <a:latin typeface="Arial"/>
+              </a:rPr>
+              <a:t> </a:t>
+            </a:r>
+            <a:r>
+              <a:rPr lang="es-ES" sz="2400" b="0" dirty="0" err="1">
+                <a:solidFill>
+                  <a:srgbClr val="192D3E"/>
+                </a:solidFill>
+                <a:latin typeface="Arial"/>
+              </a:rPr>
+              <a:t>coneixement</a:t>
+            </a:r>
+            <a:r>
+              <a:rPr lang="es-ES" sz="2400" b="0" dirty="0">
+                <a:solidFill>
+                  <a:srgbClr val="192D3E"/>
+                </a:solidFill>
+                <a:latin typeface="Arial"/>
+              </a:rPr>
+              <a:t>, </a:t>
+            </a:r>
+            <a:r>
+              <a:rPr lang="es-ES" sz="2400" b="0" dirty="0" err="1">
+                <a:solidFill>
+                  <a:srgbClr val="192D3E"/>
+                </a:solidFill>
+                <a:latin typeface="Arial"/>
+              </a:rPr>
+              <a:t>responsabilitat</a:t>
+            </a:r>
+            <a:r>
+              <a:rPr lang="es-ES" sz="2400" b="0" dirty="0">
+                <a:solidFill>
+                  <a:srgbClr val="192D3E"/>
+                </a:solidFill>
+                <a:latin typeface="Arial"/>
+              </a:rPr>
+              <a:t> i </a:t>
+            </a:r>
+            <a:r>
+              <a:rPr lang="es-ES" sz="2400" b="0" dirty="0" err="1">
+                <a:solidFill>
+                  <a:srgbClr val="192D3E"/>
+                </a:solidFill>
+                <a:latin typeface="Arial"/>
+              </a:rPr>
+              <a:t>compromís</a:t>
+            </a:r>
+            <a:r>
+              <a:rPr lang="es-ES" sz="2400" b="0" dirty="0">
+                <a:solidFill>
+                  <a:srgbClr val="192D3E"/>
+                </a:solidFill>
+                <a:latin typeface="Arial"/>
+              </a:rPr>
+              <a:t> </a:t>
+            </a:r>
+            <a:r>
+              <a:rPr lang="es-ES" sz="2400" b="0" dirty="0" err="1">
+                <a:solidFill>
+                  <a:srgbClr val="192D3E"/>
+                </a:solidFill>
+                <a:latin typeface="Arial"/>
+              </a:rPr>
+              <a:t>amb</a:t>
+            </a:r>
+            <a:r>
+              <a:rPr lang="es-ES" sz="2400" b="0" dirty="0">
+                <a:solidFill>
+                  <a:srgbClr val="192D3E"/>
+                </a:solidFill>
+                <a:latin typeface="Arial"/>
+              </a:rPr>
+              <a:t> la </a:t>
+            </a:r>
+            <a:r>
+              <a:rPr lang="es-ES" sz="2400" b="0" dirty="0" err="1">
+                <a:solidFill>
+                  <a:srgbClr val="192D3E"/>
+                </a:solidFill>
+                <a:latin typeface="Arial"/>
+              </a:rPr>
+              <a:t>formació</a:t>
+            </a:r>
+            <a:r>
+              <a:rPr lang="es-ES" sz="2400" b="0" dirty="0">
+                <a:solidFill>
+                  <a:srgbClr val="192D3E"/>
+                </a:solidFill>
+                <a:latin typeface="Arial"/>
+              </a:rPr>
+              <a:t> </a:t>
+            </a:r>
+            <a:r>
+              <a:rPr lang="es-ES" sz="2400" b="0" dirty="0" err="1">
+                <a:solidFill>
+                  <a:srgbClr val="192D3E"/>
+                </a:solidFill>
+                <a:latin typeface="Arial"/>
+              </a:rPr>
+              <a:t>universitària</a:t>
+            </a:r>
+            <a:r>
+              <a:rPr lang="es-ES" sz="2400" b="0" dirty="0">
+                <a:solidFill>
+                  <a:srgbClr val="192D3E"/>
+                </a:solidFill>
+                <a:latin typeface="Arial"/>
+              </a:rPr>
+              <a:t>. </a:t>
+            </a:r>
+            <a:br>
+              <a:rPr lang="es-ES" sz="2400" b="0" dirty="0">
+                <a:solidFill>
+                  <a:srgbClr val="192D3E"/>
+                </a:solidFill>
+                <a:latin typeface="Arial"/>
+              </a:rPr>
+            </a:br>
+            <a:endParaRPr lang="es-ES" sz="2400" b="0" dirty="0">
+              <a:solidFill>
+                <a:srgbClr val="192D3E"/>
+              </a:solidFill>
               <a:latin typeface="Arial"/>
             </a:endParaRPr>
           </a:p>
@@ -12174,747 +12431,113 @@
       </p:sp>
       <p:sp>
         <p:nvSpPr>
-          <p:cNvPr id="182" name="Rounded Rectangle 6"/>
-          <p:cNvSpPr/>
+          <p:cNvPr id="8" name="TextBox 7"/>
+          <p:cNvSpPr txBox="1"/>
           <p:nvPr/>
         </p:nvSpPr>
         <p:spPr>
           <a:xfrm>
-            <a:off x="868680" y="2240280"/>
-            <a:ext cx="3245760" cy="959760"/>
-          </a:xfrm>
-          <a:prstGeom prst="roundRect">
-            <a:avLst>
-              <a:gd name="adj" fmla="val 16667"/>
-            </a:avLst>
-          </a:prstGeom>
-          <a:solidFill>
-            <a:srgbClr val="E8F1F8"/>
-          </a:solidFill>
-          <a:ln>
-            <a:solidFill>
-              <a:srgbClr val="DCE0E4"/>
-            </a:solidFill>
-            <a:round/>
-          </a:ln>
-          <a:effectLst>
-            <a:outerShdw blurRad="39960" dist="23040" dir="5400000" rotWithShape="0">
-              <a:srgbClr val="000000">
-                <a:alpha val="35000"/>
-              </a:srgbClr>
-            </a:outerShdw>
-          </a:effectLst>
-        </p:spPr>
-        <p:style>
-          <a:lnRef idx="1">
-            <a:schemeClr val="accent1"/>
-          </a:lnRef>
-          <a:fillRef idx="3">
-            <a:schemeClr val="accent1"/>
-          </a:fillRef>
-          <a:effectRef idx="2">
-            <a:schemeClr val="accent1"/>
-          </a:effectRef>
-          <a:fontRef idx="minor"/>
-        </p:style>
-        <p:txBody>
-          <a:bodyPr lIns="90000" tIns="45000" rIns="90000" bIns="45000" anchor="ctr">
-            <a:noAutofit/>
+            <a:off x="2030392" y="4800000"/>
+            <a:ext cx="8099528" cy="868681"/>
+          </a:xfrm>
+          <a:prstGeom prst="rect">
+            <a:avLst/>
+          </a:prstGeom>
+          <a:noFill/>
+        </p:spPr>
+        <p:txBody>
+          <a:bodyPr wrap="square">
+            <a:normAutofit/>
           </a:bodyPr>
           <a:lstStyle/>
           <a:p>
-            <a:endParaRPr lang="en-US" sz="1800" b="0" u="none" strike="noStrike">
-              <a:solidFill>
-                <a:schemeClr val="lt1"/>
-              </a:solidFill>
-              <a:effectLst/>
-              <a:uFillTx/>
-              <a:latin typeface="Calibri"/>
-            </a:endParaRPr>
-          </a:p>
-        </p:txBody>
-      </p:sp>
-      <p:sp>
-        <p:nvSpPr>
-          <p:cNvPr id="183" name="TextBox 7"/>
-          <p:cNvSpPr/>
+            <a:pPr algn="ctr"/>
+            <a:r>
+              <a:rPr lang="ca-ES" sz="2800" b="1" dirty="0">
+                <a:solidFill>
+                  <a:srgbClr val="192D3E"/>
+                </a:solidFill>
+                <a:latin typeface="Arial"/>
+              </a:rPr>
+              <a:t>Moltes gràcies.</a:t>
+            </a:r>
+          </a:p>
+        </p:txBody>
+      </p:sp>
+      <p:sp>
+        <p:nvSpPr>
+          <p:cNvPr id="9" name="TextBox 8"/>
+          <p:cNvSpPr txBox="1"/>
           <p:nvPr/>
         </p:nvSpPr>
         <p:spPr>
           <a:xfrm>
-            <a:off x="1051560" y="2541960"/>
-            <a:ext cx="2880000" cy="255600"/>
+            <a:off x="594360" y="6473952"/>
+            <a:ext cx="8595360" cy="201168"/>
           </a:xfrm>
           <a:prstGeom prst="rect">
             <a:avLst/>
           </a:prstGeom>
           <a:noFill/>
-          <a:ln w="0">
-            <a:noFill/>
-          </a:ln>
-        </p:spPr>
-        <p:style>
-          <a:lnRef idx="0">
-            <a:scrgbClr r="0" g="0" b="0"/>
-          </a:lnRef>
-          <a:fillRef idx="0">
-            <a:scrgbClr r="0" g="0" b="0"/>
-          </a:fillRef>
-          <a:effectRef idx="0">
-            <a:scrgbClr r="0" g="0" b="0"/>
-          </a:effectRef>
-          <a:fontRef idx="minor"/>
-        </p:style>
-        <p:txBody>
-          <a:bodyPr lIns="90000" tIns="45000" rIns="90000" bIns="45000" anchor="t">
-            <a:normAutofit fontScale="77500" lnSpcReduction="20000"/>
+        </p:spPr>
+        <p:txBody>
+          <a:bodyPr wrap="square">
+            <a:normAutofit lnSpcReduction="10000"/>
           </a:bodyPr>
           <a:lstStyle/>
           <a:p>
-            <a:pPr algn="ctr" defTabSz="457200">
-              <a:lnSpc>
-                <a:spcPct val="100000"/>
-              </a:lnSpc>
-            </a:pPr>
-            <a:r>
-              <a:rPr lang="en-US" sz="1900" b="1" u="none" strike="noStrike">
-                <a:solidFill>
-                  <a:srgbClr val="192D3E"/>
-                </a:solidFill>
-                <a:effectLst/>
-                <a:uFillTx/>
-                <a:latin typeface="Arial"/>
-              </a:rPr>
-              <a:t>Mateix cas d'ús</a:t>
-            </a:r>
-            <a:endParaRPr lang="es-ES" sz="1900" b="0" u="none" strike="noStrike">
-              <a:solidFill>
-                <a:srgbClr val="000000"/>
-              </a:solidFill>
-              <a:effectLst/>
-              <a:uFillTx/>
-              <a:latin typeface="Arial"/>
-            </a:endParaRPr>
-          </a:p>
-        </p:txBody>
-      </p:sp>
-      <p:sp>
-        <p:nvSpPr>
-          <p:cNvPr id="184" name="Rounded Rectangle 8"/>
-          <p:cNvSpPr/>
+            <a:pPr algn="l"/>
+            <a:r>
+              <a:rPr sz="800" b="0">
+                <a:solidFill>
+                  <a:srgbClr val="66707A"/>
+                </a:solidFill>
+                <a:latin typeface="Arial"/>
+              </a:rPr>
+              <a:t>Disseny de Sistemes d'Informació · Ports de sortida en arquitectura hexagonal</a:t>
+            </a:r>
+          </a:p>
+        </p:txBody>
+      </p:sp>
+      <p:sp>
+        <p:nvSpPr>
+          <p:cNvPr id="10" name="TextBox 9"/>
+          <p:cNvSpPr txBox="1"/>
           <p:nvPr/>
         </p:nvSpPr>
         <p:spPr>
           <a:xfrm>
-            <a:off x="4572000" y="2240280"/>
-            <a:ext cx="3245760" cy="959760"/>
-          </a:xfrm>
-          <a:prstGeom prst="roundRect">
-            <a:avLst>
-              <a:gd name="adj" fmla="val 16667"/>
-            </a:avLst>
-          </a:prstGeom>
-          <a:solidFill>
-            <a:srgbClr val="FFF3D6"/>
-          </a:solidFill>
-          <a:ln>
-            <a:solidFill>
-              <a:srgbClr val="DCE0E4"/>
-            </a:solidFill>
-            <a:round/>
-          </a:ln>
-          <a:effectLst>
-            <a:outerShdw blurRad="39960" dist="23040" dir="5400000" rotWithShape="0">
-              <a:srgbClr val="000000">
-                <a:alpha val="35000"/>
-              </a:srgbClr>
-            </a:outerShdw>
-          </a:effectLst>
-        </p:spPr>
-        <p:style>
-          <a:lnRef idx="1">
-            <a:schemeClr val="accent1"/>
-          </a:lnRef>
-          <a:fillRef idx="3">
-            <a:schemeClr val="accent1"/>
-          </a:fillRef>
-          <a:effectRef idx="2">
-            <a:schemeClr val="accent1"/>
-          </a:effectRef>
-          <a:fontRef idx="minor"/>
-        </p:style>
-        <p:txBody>
-          <a:bodyPr lIns="90000" tIns="45000" rIns="90000" bIns="45000" anchor="ctr">
-            <a:noAutofit/>
+            <a:off x="11155680" y="6473952"/>
+            <a:ext cx="411480" cy="201168"/>
+          </a:xfrm>
+          <a:prstGeom prst="rect">
+            <a:avLst/>
+          </a:prstGeom>
+          <a:noFill/>
+        </p:spPr>
+        <p:txBody>
+          <a:bodyPr wrap="square">
+            <a:normAutofit lnSpcReduction="10000"/>
           </a:bodyPr>
           <a:lstStyle/>
           <a:p>
-            <a:endParaRPr lang="en-US" sz="1800" b="0" u="none" strike="noStrike">
-              <a:solidFill>
-                <a:schemeClr val="lt1"/>
-              </a:solidFill>
-              <a:effectLst/>
-              <a:uFillTx/>
-              <a:latin typeface="Calibri"/>
-            </a:endParaRPr>
-          </a:p>
-        </p:txBody>
-      </p:sp>
-      <p:sp>
-        <p:nvSpPr>
-          <p:cNvPr id="185" name="TextBox 9"/>
-          <p:cNvSpPr/>
-          <p:nvPr/>
-        </p:nvSpPr>
-        <p:spPr>
-          <a:xfrm>
-            <a:off x="4754880" y="2541960"/>
-            <a:ext cx="2880000" cy="255600"/>
-          </a:xfrm>
-          <a:prstGeom prst="rect">
-            <a:avLst/>
-          </a:prstGeom>
-          <a:noFill/>
-          <a:ln w="0">
-            <a:noFill/>
-          </a:ln>
-        </p:spPr>
-        <p:style>
-          <a:lnRef idx="0">
-            <a:scrgbClr r="0" g="0" b="0"/>
-          </a:lnRef>
-          <a:fillRef idx="0">
-            <a:scrgbClr r="0" g="0" b="0"/>
-          </a:fillRef>
-          <a:effectRef idx="0">
-            <a:scrgbClr r="0" g="0" b="0"/>
-          </a:effectRef>
-          <a:fontRef idx="minor"/>
-        </p:style>
-        <p:txBody>
-          <a:bodyPr lIns="90000" tIns="45000" rIns="90000" bIns="45000" anchor="t">
-            <a:normAutofit fontScale="77500" lnSpcReduction="20000"/>
-          </a:bodyPr>
-          <a:lstStyle/>
-          <a:p>
-            <a:pPr algn="ctr" defTabSz="457200">
-              <a:lnSpc>
-                <a:spcPct val="100000"/>
-              </a:lnSpc>
-            </a:pPr>
-            <a:r>
-              <a:rPr lang="en-US" sz="1900" b="1" u="none" strike="noStrike">
-                <a:solidFill>
-                  <a:srgbClr val="192D3E"/>
-                </a:solidFill>
-                <a:effectLst/>
-                <a:uFillTx/>
-                <a:latin typeface="Arial"/>
-              </a:rPr>
-              <a:t>Mateix </a:t>
-            </a:r>
-            <a:r>
-              <a:rPr lang="es-ES" sz="1900" b="1" u="none" strike="noStrike">
-                <a:solidFill>
-                  <a:srgbClr val="192D3E"/>
-                </a:solidFill>
-                <a:effectLst/>
-                <a:uFillTx/>
-                <a:latin typeface="Arial"/>
-              </a:rPr>
-              <a:t>S</a:t>
-            </a:r>
-            <a:r>
-              <a:rPr lang="en-US" sz="1900" b="1" u="none" strike="noStrike">
-                <a:solidFill>
-                  <a:srgbClr val="192D3E"/>
-                </a:solidFill>
-                <a:effectLst/>
-                <a:uFillTx/>
-                <a:latin typeface="Arial"/>
-              </a:rPr>
-              <a:t>ervei</a:t>
-            </a:r>
-            <a:r>
-              <a:rPr lang="es-ES" sz="1900" b="1" u="none" strike="noStrike">
-                <a:solidFill>
-                  <a:srgbClr val="192D3E"/>
-                </a:solidFill>
-                <a:effectLst/>
-                <a:uFillTx/>
-                <a:latin typeface="Arial"/>
-              </a:rPr>
-              <a:t> d’Aplicació</a:t>
-            </a:r>
-            <a:endParaRPr lang="es-ES" sz="1900" b="0" u="none" strike="noStrike">
-              <a:solidFill>
-                <a:srgbClr val="000000"/>
-              </a:solidFill>
-              <a:effectLst/>
-              <a:uFillTx/>
-              <a:latin typeface="Arial"/>
-            </a:endParaRPr>
-          </a:p>
-          <a:p>
-            <a:pPr algn="ctr" defTabSz="457200">
-              <a:lnSpc>
-                <a:spcPct val="100000"/>
-              </a:lnSpc>
-            </a:pPr>
-            <a:endParaRPr lang="es-ES" sz="1900" b="0" u="none" strike="noStrike">
-              <a:solidFill>
-                <a:srgbClr val="000000"/>
-              </a:solidFill>
-              <a:effectLst/>
-              <a:uFillTx/>
-              <a:latin typeface="Arial"/>
-            </a:endParaRPr>
-          </a:p>
-        </p:txBody>
-      </p:sp>
-      <p:sp>
-        <p:nvSpPr>
-          <p:cNvPr id="186" name="Rounded Rectangle 10"/>
-          <p:cNvSpPr/>
-          <p:nvPr/>
-        </p:nvSpPr>
-        <p:spPr>
-          <a:xfrm>
-            <a:off x="8275320" y="2240280"/>
-            <a:ext cx="3245760" cy="959760"/>
-          </a:xfrm>
-          <a:prstGeom prst="roundRect">
-            <a:avLst>
-              <a:gd name="adj" fmla="val 16667"/>
-            </a:avLst>
-          </a:prstGeom>
-          <a:solidFill>
-            <a:srgbClr val="EBF6F0"/>
-          </a:solidFill>
-          <a:ln>
-            <a:solidFill>
-              <a:srgbClr val="DCE0E4"/>
-            </a:solidFill>
-            <a:round/>
-          </a:ln>
-          <a:effectLst>
-            <a:outerShdw blurRad="39960" dist="23040" dir="5400000" rotWithShape="0">
-              <a:srgbClr val="000000">
-                <a:alpha val="35000"/>
-              </a:srgbClr>
-            </a:outerShdw>
-          </a:effectLst>
-        </p:spPr>
-        <p:style>
-          <a:lnRef idx="1">
-            <a:schemeClr val="accent1"/>
-          </a:lnRef>
-          <a:fillRef idx="3">
-            <a:schemeClr val="accent1"/>
-          </a:fillRef>
-          <a:effectRef idx="2">
-            <a:schemeClr val="accent1"/>
-          </a:effectRef>
-          <a:fontRef idx="minor"/>
-        </p:style>
-        <p:txBody>
-          <a:bodyPr lIns="90000" tIns="45000" rIns="90000" bIns="45000" anchor="ctr">
-            <a:noAutofit/>
-          </a:bodyPr>
-          <a:lstStyle/>
-          <a:p>
-            <a:endParaRPr lang="en-US" sz="1800" b="0" u="none" strike="noStrike">
-              <a:solidFill>
-                <a:schemeClr val="lt1"/>
-              </a:solidFill>
-              <a:effectLst/>
-              <a:uFillTx/>
-              <a:latin typeface="Calibri"/>
-            </a:endParaRPr>
-          </a:p>
-        </p:txBody>
-      </p:sp>
-      <p:sp>
-        <p:nvSpPr>
-          <p:cNvPr id="187" name="TextBox 11"/>
-          <p:cNvSpPr/>
-          <p:nvPr/>
-        </p:nvSpPr>
-        <p:spPr>
-          <a:xfrm>
-            <a:off x="8458200" y="2541960"/>
-            <a:ext cx="2880000" cy="255600"/>
-          </a:xfrm>
-          <a:prstGeom prst="rect">
-            <a:avLst/>
-          </a:prstGeom>
-          <a:noFill/>
-          <a:ln w="0">
-            <a:noFill/>
-          </a:ln>
-        </p:spPr>
-        <p:style>
-          <a:lnRef idx="0">
-            <a:scrgbClr r="0" g="0" b="0"/>
-          </a:lnRef>
-          <a:fillRef idx="0">
-            <a:scrgbClr r="0" g="0" b="0"/>
-          </a:fillRef>
-          <a:effectRef idx="0">
-            <a:scrgbClr r="0" g="0" b="0"/>
-          </a:effectRef>
-          <a:fontRef idx="minor"/>
-        </p:style>
-        <p:txBody>
-          <a:bodyPr lIns="90000" tIns="45000" rIns="90000" bIns="45000" anchor="t">
-            <a:normAutofit fontScale="77500" lnSpcReduction="20000"/>
-          </a:bodyPr>
-          <a:lstStyle/>
-          <a:p>
-            <a:pPr algn="ctr" defTabSz="457200">
-              <a:lnSpc>
-                <a:spcPct val="100000"/>
-              </a:lnSpc>
-            </a:pPr>
-            <a:r>
-              <a:rPr lang="en-US" sz="1900" b="1" u="none" strike="noStrike">
-                <a:solidFill>
-                  <a:srgbClr val="192D3E"/>
-                </a:solidFill>
-                <a:effectLst/>
-                <a:uFillTx/>
-                <a:latin typeface="Arial"/>
-              </a:rPr>
-              <a:t>Mateix domini</a:t>
-            </a:r>
-            <a:endParaRPr lang="es-ES" sz="1900" b="0" u="none" strike="noStrike">
-              <a:solidFill>
-                <a:srgbClr val="000000"/>
-              </a:solidFill>
-              <a:effectLst/>
-              <a:uFillTx/>
-              <a:latin typeface="Arial"/>
-            </a:endParaRPr>
-          </a:p>
-        </p:txBody>
-      </p:sp>
-      <p:sp>
-        <p:nvSpPr>
-          <p:cNvPr id="188" name="TextBox 12"/>
-          <p:cNvSpPr/>
-          <p:nvPr/>
-        </p:nvSpPr>
-        <p:spPr>
-          <a:xfrm>
-            <a:off x="1051560" y="3886200"/>
-            <a:ext cx="10058040" cy="502560"/>
-          </a:xfrm>
-          <a:prstGeom prst="rect">
-            <a:avLst/>
-          </a:prstGeom>
-          <a:noFill/>
-          <a:ln w="0">
-            <a:noFill/>
-          </a:ln>
-        </p:spPr>
-        <p:style>
-          <a:lnRef idx="0">
-            <a:scrgbClr r="0" g="0" b="0"/>
-          </a:lnRef>
-          <a:fillRef idx="0">
-            <a:scrgbClr r="0" g="0" b="0"/>
-          </a:fillRef>
-          <a:effectRef idx="0">
-            <a:scrgbClr r="0" g="0" b="0"/>
-          </a:effectRef>
-          <a:fontRef idx="minor"/>
-        </p:style>
-        <p:txBody>
-          <a:bodyPr lIns="90000" tIns="45000" rIns="90000" bIns="45000" anchor="t">
-            <a:normAutofit fontScale="92500" lnSpcReduction="9999"/>
-          </a:bodyPr>
-          <a:lstStyle/>
-          <a:p>
-            <a:pPr algn="ctr" defTabSz="457200">
-              <a:lnSpc>
-                <a:spcPct val="100000"/>
-              </a:lnSpc>
-            </a:pPr>
-            <a:r>
-              <a:rPr lang="es-ES" sz="2600" b="1" u="none" strike="noStrike">
-                <a:solidFill>
-                  <a:srgbClr val="236092"/>
-                </a:solidFill>
-                <a:effectLst/>
-                <a:uFillTx/>
-                <a:latin typeface="Arial"/>
-              </a:rPr>
-              <a:t>Canvi tecnològic: adaptador Finnhub ↔ adaptador Alpha Vantage</a:t>
-            </a:r>
-            <a:endParaRPr lang="es-ES" sz="2600" b="0" u="none" strike="noStrike">
-              <a:solidFill>
-                <a:srgbClr val="000000"/>
-              </a:solidFill>
-              <a:effectLst/>
-              <a:uFillTx/>
-              <a:latin typeface="Arial"/>
-            </a:endParaRPr>
-          </a:p>
-        </p:txBody>
-      </p:sp>
-      <p:sp>
-        <p:nvSpPr>
-          <p:cNvPr id="189" name="TextBox 13"/>
-          <p:cNvSpPr/>
-          <p:nvPr/>
-        </p:nvSpPr>
-        <p:spPr>
-          <a:xfrm>
-            <a:off x="1051560" y="5074920"/>
-            <a:ext cx="10058040" cy="456840"/>
-          </a:xfrm>
-          <a:prstGeom prst="rect">
-            <a:avLst/>
-          </a:prstGeom>
-          <a:noFill/>
-          <a:ln w="0">
-            <a:noFill/>
-          </a:ln>
-        </p:spPr>
-        <p:style>
-          <a:lnRef idx="0">
-            <a:scrgbClr r="0" g="0" b="0"/>
-          </a:lnRef>
-          <a:fillRef idx="0">
-            <a:scrgbClr r="0" g="0" b="0"/>
-          </a:fillRef>
-          <a:effectRef idx="0">
-            <a:scrgbClr r="0" g="0" b="0"/>
-          </a:effectRef>
-          <a:fontRef idx="minor"/>
-        </p:style>
-        <p:txBody>
-          <a:bodyPr lIns="90000" tIns="45000" rIns="90000" bIns="45000" anchor="t">
-            <a:normAutofit/>
-          </a:bodyPr>
-          <a:lstStyle/>
-          <a:p>
-            <a:pPr algn="ctr" defTabSz="457200">
-              <a:lnSpc>
-                <a:spcPct val="100000"/>
-              </a:lnSpc>
-            </a:pPr>
-            <a:r>
-              <a:rPr lang="en-US" sz="2400" b="1" u="none" strike="noStrike">
-                <a:solidFill>
-                  <a:srgbClr val="192D3E"/>
-                </a:solidFill>
-                <a:effectLst/>
-                <a:uFillTx/>
-                <a:latin typeface="Arial"/>
-              </a:rPr>
-              <a:t>Canvia la infraestructura; el cas d'ús </a:t>
-            </a:r>
-            <a:r>
-              <a:rPr lang="es-ES" sz="2400" b="1" u="none" strike="noStrike">
-                <a:solidFill>
-                  <a:srgbClr val="192D3E"/>
-                </a:solidFill>
-                <a:effectLst/>
-                <a:uFillTx/>
-                <a:latin typeface="Arial"/>
-              </a:rPr>
-              <a:t>i el domini </a:t>
-            </a:r>
-            <a:r>
-              <a:rPr lang="en-US" sz="2400" b="1" u="none" strike="noStrike">
-                <a:solidFill>
-                  <a:srgbClr val="192D3E"/>
-                </a:solidFill>
-                <a:effectLst/>
-                <a:uFillTx/>
-                <a:latin typeface="Arial"/>
-              </a:rPr>
-              <a:t>roman</a:t>
-            </a:r>
-            <a:r>
-              <a:rPr lang="es-ES" sz="2400" b="1" u="none" strike="noStrike">
-                <a:solidFill>
-                  <a:srgbClr val="192D3E"/>
-                </a:solidFill>
-                <a:effectLst/>
-                <a:uFillTx/>
-                <a:latin typeface="Arial"/>
-              </a:rPr>
-              <a:t>en</a:t>
-            </a:r>
-            <a:r>
-              <a:rPr lang="en-US" sz="2400" b="1" u="none" strike="noStrike">
-                <a:solidFill>
-                  <a:srgbClr val="192D3E"/>
-                </a:solidFill>
-                <a:effectLst/>
-                <a:uFillTx/>
-                <a:latin typeface="Arial"/>
-              </a:rPr>
-              <a:t> estable</a:t>
-            </a:r>
-            <a:r>
-              <a:rPr lang="es-ES" sz="2400" b="1" u="none" strike="noStrike">
-                <a:solidFill>
-                  <a:srgbClr val="192D3E"/>
-                </a:solidFill>
-                <a:effectLst/>
-                <a:uFillTx/>
-                <a:latin typeface="Arial"/>
-              </a:rPr>
-              <a:t>s</a:t>
-            </a:r>
-            <a:r>
-              <a:rPr lang="en-US" sz="2400" b="1" u="none" strike="noStrike">
-                <a:solidFill>
-                  <a:srgbClr val="192D3E"/>
-                </a:solidFill>
-                <a:effectLst/>
-                <a:uFillTx/>
-                <a:latin typeface="Arial"/>
-              </a:rPr>
-              <a:t>.</a:t>
-            </a:r>
-            <a:endParaRPr lang="es-ES" sz="2400" b="0" u="none" strike="noStrike">
-              <a:solidFill>
-                <a:srgbClr val="000000"/>
-              </a:solidFill>
-              <a:effectLst/>
-              <a:uFillTx/>
-              <a:latin typeface="Arial"/>
-            </a:endParaRPr>
-          </a:p>
-        </p:txBody>
-      </p:sp>
-      <p:sp>
-        <p:nvSpPr>
-          <p:cNvPr id="190" name="TextBox 14"/>
-          <p:cNvSpPr/>
-          <p:nvPr/>
-        </p:nvSpPr>
-        <p:spPr>
-          <a:xfrm>
-            <a:off x="594360" y="6473880"/>
-            <a:ext cx="8595000" cy="200880"/>
-          </a:xfrm>
-          <a:prstGeom prst="rect">
-            <a:avLst/>
-          </a:prstGeom>
-          <a:noFill/>
-          <a:ln w="0">
-            <a:noFill/>
-          </a:ln>
-        </p:spPr>
-        <p:style>
-          <a:lnRef idx="0">
-            <a:scrgbClr r="0" g="0" b="0"/>
-          </a:lnRef>
-          <a:fillRef idx="0">
-            <a:scrgbClr r="0" g="0" b="0"/>
-          </a:fillRef>
-          <a:effectRef idx="0">
-            <a:scrgbClr r="0" g="0" b="0"/>
-          </a:effectRef>
-          <a:fontRef idx="minor"/>
-        </p:style>
-        <p:txBody>
-          <a:bodyPr lIns="90000" tIns="45000" rIns="90000" bIns="45000" anchor="t">
-            <a:normAutofit lnSpcReduction="9999"/>
-          </a:bodyPr>
-          <a:lstStyle/>
-          <a:p>
-            <a:pPr defTabSz="457200">
-              <a:lnSpc>
-                <a:spcPct val="100000"/>
-              </a:lnSpc>
-            </a:pPr>
-            <a:r>
-              <a:rPr lang="en-US" sz="800" b="0" u="none" strike="noStrike">
+            <a:pPr algn="r"/>
+            <a:r>
+              <a:rPr lang="es-ES" sz="800" b="0" dirty="0">
                 <a:solidFill>
                   <a:srgbClr val="66707A"/>
                 </a:solidFill>
-                <a:effectLst/>
-                <a:uFillTx/>
-                <a:latin typeface="Arial"/>
-              </a:rPr>
-              <a:t>Disseny de Sistemes d'Informació · Ports de sortida en arquitectura hexagonal</a:t>
-            </a:r>
-            <a:endParaRPr lang="es-ES" sz="800" b="0" u="none" strike="noStrike">
-              <a:solidFill>
-                <a:srgbClr val="000000"/>
-              </a:solidFill>
-              <a:effectLst/>
-              <a:uFillTx/>
-              <a:latin typeface="Arial"/>
-            </a:endParaRPr>
-          </a:p>
-        </p:txBody>
-      </p:sp>
-      <p:sp>
-        <p:nvSpPr>
-          <p:cNvPr id="191" name="TextBox 15"/>
-          <p:cNvSpPr/>
-          <p:nvPr/>
-        </p:nvSpPr>
-        <p:spPr>
-          <a:xfrm>
-            <a:off x="11155680" y="6473880"/>
-            <a:ext cx="411120" cy="200880"/>
-          </a:xfrm>
-          <a:prstGeom prst="rect">
-            <a:avLst/>
-          </a:prstGeom>
-          <a:noFill/>
-          <a:ln w="0">
-            <a:noFill/>
-          </a:ln>
-        </p:spPr>
-        <p:style>
-          <a:lnRef idx="0">
-            <a:scrgbClr r="0" g="0" b="0"/>
-          </a:lnRef>
-          <a:fillRef idx="0">
-            <a:scrgbClr r="0" g="0" b="0"/>
-          </a:fillRef>
-          <a:effectRef idx="0">
-            <a:scrgbClr r="0" g="0" b="0"/>
-          </a:effectRef>
-          <a:fontRef idx="minor"/>
-        </p:style>
-        <p:txBody>
-          <a:bodyPr lIns="90000" tIns="45000" rIns="90000" bIns="45000" anchor="t">
-            <a:normAutofit fontScale="92500" lnSpcReduction="9999"/>
-          </a:bodyPr>
-          <a:lstStyle/>
-          <a:p>
-            <a:pPr algn="ctr" defTabSz="457200">
-              <a:lnSpc>
-                <a:spcPct val="100000"/>
-              </a:lnSpc>
-            </a:pPr>
-            <a:r>
-              <a:rPr lang="ca-ES" sz="800" b="0" u="none" strike="noStrike">
-                <a:solidFill>
-                  <a:schemeClr val="dk1"/>
-                </a:solidFill>
-                <a:effectLst/>
-                <a:uFillTx/>
-                <a:latin typeface="Calibri"/>
-              </a:rPr>
-              <a:t>Annex</a:t>
-            </a:r>
-            <a:endParaRPr lang="es-ES" sz="800" b="0" u="none" strike="noStrike">
-              <a:solidFill>
-                <a:srgbClr val="000000"/>
-              </a:solidFill>
-              <a:effectLst/>
-              <a:uFillTx/>
+                <a:latin typeface="Arial"/>
+              </a:rPr>
+              <a:t>11</a:t>
+            </a:r>
+          </a:p>
+          <a:p>
+            <a:pPr algn="r"/>
+            <a:endParaRPr sz="800" b="0" dirty="0">
+              <a:solidFill>
+                <a:srgbClr val="66707A"/>
+              </a:solidFill>
               <a:latin typeface="Arial"/>
             </a:endParaRPr>
           </a:p>
@@ -12947,73 +12570,166 @@
       </p:grpSpPr>
       <p:sp>
         <p:nvSpPr>
-          <p:cNvPr id="2" name="TextBox 1"/>
-          <p:cNvSpPr txBox="1"/>
+          <p:cNvPr id="177" name="TextBox 1"/>
+          <p:cNvSpPr/>
           <p:nvPr/>
         </p:nvSpPr>
         <p:spPr>
           <a:xfrm>
             <a:off x="594360" y="320040"/>
-            <a:ext cx="8961120" cy="502920"/>
+            <a:ext cx="8960760" cy="502560"/>
           </a:xfrm>
           <a:prstGeom prst="rect">
             <a:avLst/>
           </a:prstGeom>
           <a:noFill/>
-        </p:spPr>
-        <p:txBody>
-          <a:bodyPr wrap="square">
-            <a:normAutofit lnSpcReduction="10000"/>
+          <a:ln w="0">
+            <a:noFill/>
+          </a:ln>
+        </p:spPr>
+        <p:style>
+          <a:lnRef idx="0">
+            <a:scrgbClr r="0" g="0" b="0"/>
+          </a:lnRef>
+          <a:fillRef idx="0">
+            <a:scrgbClr r="0" g="0" b="0"/>
+          </a:fillRef>
+          <a:effectRef idx="0">
+            <a:scrgbClr r="0" g="0" b="0"/>
+          </a:effectRef>
+          <a:fontRef idx="minor"/>
+        </p:style>
+        <p:txBody>
+          <a:bodyPr lIns="90000" tIns="45000" rIns="90000" bIns="45000" anchor="t">
+            <a:normAutofit lnSpcReduction="9999"/>
           </a:bodyPr>
           <a:lstStyle/>
           <a:p>
-            <a:pPr algn="l"/>
-            <a:r>
-              <a:rPr sz="2800" b="1">
+            <a:pPr defTabSz="457200">
+              <a:lnSpc>
+                <a:spcPct val="100000"/>
+              </a:lnSpc>
+            </a:pPr>
+            <a:r>
+              <a:rPr lang="es-ES" sz="2800" b="1" u="none" strike="noStrike">
                 <a:solidFill>
                   <a:srgbClr val="192D3E"/>
                 </a:solidFill>
-                <a:latin typeface="Arial"/>
-              </a:rPr>
-              <a:t>Agraïment</a:t>
-            </a:r>
+                <a:effectLst/>
+                <a:uFillTx/>
+                <a:latin typeface="Arial"/>
+              </a:rPr>
+              <a:t>Annex. Demo opcional</a:t>
+            </a:r>
+            <a:endParaRPr lang="es-ES" sz="2800" b="0" u="none" strike="noStrike">
+              <a:solidFill>
+                <a:srgbClr val="000000"/>
+              </a:solidFill>
+              <a:effectLst/>
+              <a:uFillTx/>
+              <a:latin typeface="Arial"/>
+            </a:endParaRPr>
+          </a:p>
+        </p:txBody>
+      </p:sp>
+      <p:sp>
+        <p:nvSpPr>
+          <p:cNvPr id="178" name="TextBox 2"/>
+          <p:cNvSpPr/>
+          <p:nvPr/>
+        </p:nvSpPr>
+        <p:spPr>
+          <a:xfrm>
+            <a:off x="612720" y="822960"/>
+            <a:ext cx="8869320" cy="319680"/>
+          </a:xfrm>
+          <a:prstGeom prst="rect">
+            <a:avLst/>
+          </a:prstGeom>
+          <a:noFill/>
+          <a:ln w="0">
+            <a:noFill/>
+          </a:ln>
+        </p:spPr>
+        <p:style>
+          <a:lnRef idx="0">
+            <a:scrgbClr r="0" g="0" b="0"/>
+          </a:lnRef>
+          <a:fillRef idx="0">
+            <a:scrgbClr r="0" g="0" b="0"/>
+          </a:fillRef>
+          <a:effectRef idx="0">
+            <a:scrgbClr r="0" g="0" b="0"/>
+          </a:effectRef>
+          <a:fontRef idx="minor"/>
+        </p:style>
+        <p:txBody>
+          <a:bodyPr lIns="90000" tIns="45000" rIns="90000" bIns="45000" anchor="t">
+            <a:normAutofit/>
+          </a:bodyPr>
+          <a:lstStyle/>
+          <a:p>
+            <a:pPr defTabSz="457200">
+              <a:lnSpc>
+                <a:spcPct val="100000"/>
+              </a:lnSpc>
+            </a:pPr>
+            <a:r>
+              <a:rPr lang="en-US" sz="1300" b="0" u="none" strike="noStrike">
+                <a:solidFill>
+                  <a:srgbClr val="66707A"/>
+                </a:solidFill>
+                <a:effectLst/>
+                <a:uFillTx/>
+                <a:latin typeface="Arial"/>
+              </a:rPr>
+              <a:t>Mateix cas d'ús, adaptador substituïble</a:t>
+            </a:r>
+            <a:endParaRPr lang="es-ES" sz="1300" b="0" u="none" strike="noStrike">
+              <a:solidFill>
+                <a:srgbClr val="000000"/>
+              </a:solidFill>
+              <a:effectLst/>
+              <a:uFillTx/>
+              <a:latin typeface="Arial"/>
+            </a:endParaRPr>
           </a:p>
         </p:txBody>
       </p:sp>
       <p:pic>
         <p:nvPicPr>
-          <p:cNvPr id="3" name="Picture 2" descr="logotip-oficial-tecnocampus-upf-horitzontal-color.png"/>
-          <p:cNvPicPr>
-            <a:picLocks noChangeAspect="1"/>
-          </p:cNvPicPr>
+          <p:cNvPr id="179" name="Picture 3" descr="logotip-oficial-tecnocampus-upf-horitzontal-color.png"/>
+          <p:cNvPicPr/>
           <p:nvPr/>
         </p:nvPicPr>
         <p:blipFill>
           <a:blip r:embed="rId3"/>
-          <a:stretch>
-            <a:fillRect/>
-          </a:stretch>
+          <a:stretch/>
         </p:blipFill>
         <p:spPr>
           <a:xfrm>
-            <a:off x="8480078" y="293025"/>
-            <a:ext cx="3041362" cy="575655"/>
-          </a:xfrm>
-          <a:prstGeom prst="rect">
-            <a:avLst/>
-          </a:prstGeom>
+            <a:off x="8480160" y="293040"/>
+            <a:ext cx="3040920" cy="575280"/>
+          </a:xfrm>
+          <a:prstGeom prst="rect">
+            <a:avLst/>
+          </a:prstGeom>
+          <a:noFill/>
+          <a:ln w="0">
+            <a:noFill/>
+          </a:ln>
         </p:spPr>
       </p:pic>
       <p:sp>
         <p:nvSpPr>
-          <p:cNvPr id="4" name="Rectangle 3"/>
+          <p:cNvPr id="180" name="Rectangle 4"/>
           <p:cNvSpPr/>
           <p:nvPr/>
         </p:nvSpPr>
         <p:spPr>
           <a:xfrm>
-            <a:off x="594360" y="1115568"/>
-            <a:ext cx="10972800" cy="13716"/>
+            <a:off x="594360" y="1115640"/>
+            <a:ext cx="10972440" cy="13320"/>
           </a:xfrm>
           <a:prstGeom prst="rect">
             <a:avLst/>
@@ -13024,6 +12740,13 @@
           <a:ln>
             <a:noFill/>
           </a:ln>
+          <a:effectLst>
+            <a:outerShdw blurRad="39960" dist="23040" dir="5400000" rotWithShape="0">
+              <a:srgbClr val="000000">
+                <a:alpha val="35000"/>
+              </a:srgbClr>
+            </a:outerShdw>
+          </a:effectLst>
         </p:spPr>
         <p:style>
           <a:lnRef idx="1">
@@ -13035,441 +12758,704 @@
           <a:effectRef idx="2">
             <a:schemeClr val="accent1"/>
           </a:effectRef>
-          <a:fontRef idx="minor">
-            <a:schemeClr val="lt1"/>
-          </a:fontRef>
+          <a:fontRef idx="minor"/>
         </p:style>
         <p:txBody>
-          <a:bodyPr rtlCol="0" anchor="ctr"/>
+          <a:bodyPr lIns="90000" tIns="-31320" rIns="90000" bIns="-31320" anchor="ctr">
+            <a:noAutofit/>
+          </a:bodyPr>
           <a:lstStyle/>
           <a:p>
-            <a:pPr algn="ctr"/>
-            <a:endParaRPr/>
-          </a:p>
-        </p:txBody>
-      </p:sp>
-      <p:sp>
-        <p:nvSpPr>
-          <p:cNvPr id="5" name="TextBox 4"/>
-          <p:cNvSpPr txBox="1"/>
+            <a:endParaRPr lang="en-US" sz="1800" b="0" u="none" strike="noStrike">
+              <a:solidFill>
+                <a:schemeClr val="lt1"/>
+              </a:solidFill>
+              <a:effectLst/>
+              <a:uFillTx/>
+              <a:latin typeface="Calibri"/>
+            </a:endParaRPr>
+          </a:p>
+        </p:txBody>
+      </p:sp>
+      <p:sp>
+        <p:nvSpPr>
+          <p:cNvPr id="181" name="TextBox 5"/>
+          <p:cNvSpPr/>
           <p:nvPr/>
         </p:nvSpPr>
         <p:spPr>
           <a:xfrm>
-            <a:off x="1178973" y="2600000"/>
-            <a:ext cx="9834053" cy="1780528"/>
+            <a:off x="914400" y="1325880"/>
+            <a:ext cx="10286640" cy="502560"/>
           </a:xfrm>
           <a:prstGeom prst="rect">
             <a:avLst/>
           </a:prstGeom>
           <a:noFill/>
-        </p:spPr>
-        <p:txBody>
-          <a:bodyPr wrap="square">
-            <a:normAutofit lnSpcReduction="10000"/>
+          <a:ln w="0">
+            <a:noFill/>
+          </a:ln>
+        </p:spPr>
+        <p:style>
+          <a:lnRef idx="0">
+            <a:scrgbClr r="0" g="0" b="0"/>
+          </a:lnRef>
+          <a:fillRef idx="0">
+            <a:scrgbClr r="0" g="0" b="0"/>
+          </a:fillRef>
+          <a:effectRef idx="0">
+            <a:scrgbClr r="0" g="0" b="0"/>
+          </a:effectRef>
+          <a:fontRef idx="minor"/>
+        </p:style>
+        <p:txBody>
+          <a:bodyPr lIns="90000" tIns="45000" rIns="90000" bIns="45000" anchor="t">
+            <a:normAutofit fontScale="85000" lnSpcReduction="9999"/>
           </a:bodyPr>
           <a:lstStyle/>
           <a:p>
-            <a:pPr algn="ctr"/>
-            <a:r>
-              <a:rPr lang="es-ES" sz="2400" b="0" dirty="0" err="1">
+            <a:pPr algn="ctr" defTabSz="457200">
+              <a:lnSpc>
+                <a:spcPct val="100000"/>
+              </a:lnSpc>
+            </a:pPr>
+            <a:r>
+              <a:rPr lang="en-US" sz="1800" b="0" u="none" strike="noStrike">
                 <a:solidFill>
                   <a:srgbClr val="192D3E"/>
                 </a:solidFill>
-                <a:latin typeface="Arial"/>
-              </a:rPr>
-              <a:t>Vull</a:t>
-            </a:r>
-            <a:r>
-              <a:rPr lang="es-ES" sz="2400" b="0" dirty="0">
+                <a:effectLst/>
+                <a:uFillTx/>
+                <a:latin typeface="Arial"/>
+              </a:rPr>
+              <a:t>HexaStock és un projecte open source propi utilitzat en docència universitària i formació o consultoria professional.</a:t>
+            </a:r>
+            <a:endParaRPr lang="es-ES" sz="1800" b="0" u="none" strike="noStrike">
+              <a:solidFill>
+                <a:srgbClr val="000000"/>
+              </a:solidFill>
+              <a:effectLst/>
+              <a:uFillTx/>
+              <a:latin typeface="Arial"/>
+            </a:endParaRPr>
+          </a:p>
+        </p:txBody>
+      </p:sp>
+      <p:sp>
+        <p:nvSpPr>
+          <p:cNvPr id="182" name="Rounded Rectangle 6"/>
+          <p:cNvSpPr/>
+          <p:nvPr/>
+        </p:nvSpPr>
+        <p:spPr>
+          <a:xfrm>
+            <a:off x="868680" y="2240280"/>
+            <a:ext cx="3245760" cy="959760"/>
+          </a:xfrm>
+          <a:prstGeom prst="roundRect">
+            <a:avLst>
+              <a:gd name="adj" fmla="val 16667"/>
+            </a:avLst>
+          </a:prstGeom>
+          <a:solidFill>
+            <a:srgbClr val="E8F1F8"/>
+          </a:solidFill>
+          <a:ln>
+            <a:solidFill>
+              <a:srgbClr val="DCE0E4"/>
+            </a:solidFill>
+            <a:round/>
+          </a:ln>
+          <a:effectLst>
+            <a:outerShdw blurRad="39960" dist="23040" dir="5400000" rotWithShape="0">
+              <a:srgbClr val="000000">
+                <a:alpha val="35000"/>
+              </a:srgbClr>
+            </a:outerShdw>
+          </a:effectLst>
+        </p:spPr>
+        <p:style>
+          <a:lnRef idx="1">
+            <a:schemeClr val="accent1"/>
+          </a:lnRef>
+          <a:fillRef idx="3">
+            <a:schemeClr val="accent1"/>
+          </a:fillRef>
+          <a:effectRef idx="2">
+            <a:schemeClr val="accent1"/>
+          </a:effectRef>
+          <a:fontRef idx="minor"/>
+        </p:style>
+        <p:txBody>
+          <a:bodyPr lIns="90000" tIns="45000" rIns="90000" bIns="45000" anchor="ctr">
+            <a:noAutofit/>
+          </a:bodyPr>
+          <a:lstStyle/>
+          <a:p>
+            <a:endParaRPr lang="en-US" sz="1800" b="0" u="none" strike="noStrike">
+              <a:solidFill>
+                <a:schemeClr val="lt1"/>
+              </a:solidFill>
+              <a:effectLst/>
+              <a:uFillTx/>
+              <a:latin typeface="Calibri"/>
+            </a:endParaRPr>
+          </a:p>
+        </p:txBody>
+      </p:sp>
+      <p:sp>
+        <p:nvSpPr>
+          <p:cNvPr id="183" name="TextBox 7"/>
+          <p:cNvSpPr/>
+          <p:nvPr/>
+        </p:nvSpPr>
+        <p:spPr>
+          <a:xfrm>
+            <a:off x="1051560" y="2541960"/>
+            <a:ext cx="2880000" cy="255600"/>
+          </a:xfrm>
+          <a:prstGeom prst="rect">
+            <a:avLst/>
+          </a:prstGeom>
+          <a:noFill/>
+          <a:ln w="0">
+            <a:noFill/>
+          </a:ln>
+        </p:spPr>
+        <p:style>
+          <a:lnRef idx="0">
+            <a:scrgbClr r="0" g="0" b="0"/>
+          </a:lnRef>
+          <a:fillRef idx="0">
+            <a:scrgbClr r="0" g="0" b="0"/>
+          </a:fillRef>
+          <a:effectRef idx="0">
+            <a:scrgbClr r="0" g="0" b="0"/>
+          </a:effectRef>
+          <a:fontRef idx="minor"/>
+        </p:style>
+        <p:txBody>
+          <a:bodyPr lIns="90000" tIns="45000" rIns="90000" bIns="45000" anchor="t">
+            <a:normAutofit fontScale="77500" lnSpcReduction="20000"/>
+          </a:bodyPr>
+          <a:lstStyle/>
+          <a:p>
+            <a:pPr algn="ctr" defTabSz="457200">
+              <a:lnSpc>
+                <a:spcPct val="100000"/>
+              </a:lnSpc>
+            </a:pPr>
+            <a:r>
+              <a:rPr lang="en-US" sz="1900" b="1" u="none" strike="noStrike">
                 <a:solidFill>
                   <a:srgbClr val="192D3E"/>
                 </a:solidFill>
-                <a:latin typeface="Arial"/>
-              </a:rPr>
-              <a:t> </a:t>
-            </a:r>
-            <a:r>
-              <a:rPr lang="es-ES" sz="2400" b="0" dirty="0" err="1">
+                <a:effectLst/>
+                <a:uFillTx/>
+                <a:latin typeface="Arial"/>
+              </a:rPr>
+              <a:t>Mateix cas d'ús</a:t>
+            </a:r>
+            <a:endParaRPr lang="es-ES" sz="1900" b="0" u="none" strike="noStrike">
+              <a:solidFill>
+                <a:srgbClr val="000000"/>
+              </a:solidFill>
+              <a:effectLst/>
+              <a:uFillTx/>
+              <a:latin typeface="Arial"/>
+            </a:endParaRPr>
+          </a:p>
+        </p:txBody>
+      </p:sp>
+      <p:sp>
+        <p:nvSpPr>
+          <p:cNvPr id="184" name="Rounded Rectangle 8"/>
+          <p:cNvSpPr/>
+          <p:nvPr/>
+        </p:nvSpPr>
+        <p:spPr>
+          <a:xfrm>
+            <a:off x="4572000" y="2240280"/>
+            <a:ext cx="3245760" cy="959760"/>
+          </a:xfrm>
+          <a:prstGeom prst="roundRect">
+            <a:avLst>
+              <a:gd name="adj" fmla="val 16667"/>
+            </a:avLst>
+          </a:prstGeom>
+          <a:solidFill>
+            <a:srgbClr val="FFF3D6"/>
+          </a:solidFill>
+          <a:ln>
+            <a:solidFill>
+              <a:srgbClr val="DCE0E4"/>
+            </a:solidFill>
+            <a:round/>
+          </a:ln>
+          <a:effectLst>
+            <a:outerShdw blurRad="39960" dist="23040" dir="5400000" rotWithShape="0">
+              <a:srgbClr val="000000">
+                <a:alpha val="35000"/>
+              </a:srgbClr>
+            </a:outerShdw>
+          </a:effectLst>
+        </p:spPr>
+        <p:style>
+          <a:lnRef idx="1">
+            <a:schemeClr val="accent1"/>
+          </a:lnRef>
+          <a:fillRef idx="3">
+            <a:schemeClr val="accent1"/>
+          </a:fillRef>
+          <a:effectRef idx="2">
+            <a:schemeClr val="accent1"/>
+          </a:effectRef>
+          <a:fontRef idx="minor"/>
+        </p:style>
+        <p:txBody>
+          <a:bodyPr lIns="90000" tIns="45000" rIns="90000" bIns="45000" anchor="ctr">
+            <a:noAutofit/>
+          </a:bodyPr>
+          <a:lstStyle/>
+          <a:p>
+            <a:endParaRPr lang="en-US" sz="1800" b="0" u="none" strike="noStrike">
+              <a:solidFill>
+                <a:schemeClr val="lt1"/>
+              </a:solidFill>
+              <a:effectLst/>
+              <a:uFillTx/>
+              <a:latin typeface="Calibri"/>
+            </a:endParaRPr>
+          </a:p>
+        </p:txBody>
+      </p:sp>
+      <p:sp>
+        <p:nvSpPr>
+          <p:cNvPr id="185" name="TextBox 9"/>
+          <p:cNvSpPr/>
+          <p:nvPr/>
+        </p:nvSpPr>
+        <p:spPr>
+          <a:xfrm>
+            <a:off x="4754880" y="2541960"/>
+            <a:ext cx="2880000" cy="255600"/>
+          </a:xfrm>
+          <a:prstGeom prst="rect">
+            <a:avLst/>
+          </a:prstGeom>
+          <a:noFill/>
+          <a:ln w="0">
+            <a:noFill/>
+          </a:ln>
+        </p:spPr>
+        <p:style>
+          <a:lnRef idx="0">
+            <a:scrgbClr r="0" g="0" b="0"/>
+          </a:lnRef>
+          <a:fillRef idx="0">
+            <a:scrgbClr r="0" g="0" b="0"/>
+          </a:fillRef>
+          <a:effectRef idx="0">
+            <a:scrgbClr r="0" g="0" b="0"/>
+          </a:effectRef>
+          <a:fontRef idx="minor"/>
+        </p:style>
+        <p:txBody>
+          <a:bodyPr lIns="90000" tIns="45000" rIns="90000" bIns="45000" anchor="t">
+            <a:normAutofit fontScale="77500" lnSpcReduction="20000"/>
+          </a:bodyPr>
+          <a:lstStyle/>
+          <a:p>
+            <a:pPr algn="ctr" defTabSz="457200">
+              <a:lnSpc>
+                <a:spcPct val="100000"/>
+              </a:lnSpc>
+            </a:pPr>
+            <a:r>
+              <a:rPr lang="en-US" sz="1900" b="1" u="none" strike="noStrike">
                 <a:solidFill>
                   <a:srgbClr val="192D3E"/>
                 </a:solidFill>
-                <a:latin typeface="Arial"/>
-              </a:rPr>
-              <a:t>expressar</a:t>
-            </a:r>
-            <a:r>
-              <a:rPr lang="es-ES" sz="2400" b="0" dirty="0">
+                <a:effectLst/>
+                <a:uFillTx/>
+                <a:latin typeface="Arial"/>
+              </a:rPr>
+              <a:t>Mateix </a:t>
+            </a:r>
+            <a:r>
+              <a:rPr lang="es-ES" sz="1900" b="1" u="none" strike="noStrike">
                 <a:solidFill>
                   <a:srgbClr val="192D3E"/>
                 </a:solidFill>
-                <a:latin typeface="Arial"/>
-              </a:rPr>
-              <a:t> el </a:t>
-            </a:r>
-            <a:r>
-              <a:rPr lang="es-ES" sz="2400" b="0" dirty="0" err="1">
+                <a:effectLst/>
+                <a:uFillTx/>
+                <a:latin typeface="Arial"/>
+              </a:rPr>
+              <a:t>S</a:t>
+            </a:r>
+            <a:r>
+              <a:rPr lang="en-US" sz="1900" b="1" u="none" strike="noStrike">
                 <a:solidFill>
                   <a:srgbClr val="192D3E"/>
                 </a:solidFill>
-                <a:latin typeface="Arial"/>
-              </a:rPr>
-              <a:t>meu</a:t>
-            </a:r>
-            <a:r>
-              <a:rPr lang="es-ES" sz="2400" b="0" dirty="0">
+                <a:effectLst/>
+                <a:uFillTx/>
+                <a:latin typeface="Arial"/>
+              </a:rPr>
+              <a:t>ervei</a:t>
+            </a:r>
+            <a:r>
+              <a:rPr lang="es-ES" sz="1900" b="1" u="none" strike="noStrike">
                 <a:solidFill>
                   <a:srgbClr val="192D3E"/>
                 </a:solidFill>
-                <a:latin typeface="Arial"/>
-              </a:rPr>
-              <a:t> </a:t>
-            </a:r>
-            <a:r>
-              <a:rPr lang="es-ES" sz="2400" b="0" dirty="0" err="1">
+                <a:effectLst/>
+                <a:uFillTx/>
+                <a:latin typeface="Arial"/>
+              </a:rPr>
+              <a:t> d’Aplicació</a:t>
+            </a:r>
+            <a:endParaRPr lang="es-ES" sz="1900" b="0" u="none" strike="noStrike">
+              <a:solidFill>
+                <a:srgbClr val="000000"/>
+              </a:solidFill>
+              <a:effectLst/>
+              <a:uFillTx/>
+              <a:latin typeface="Arial"/>
+            </a:endParaRPr>
+          </a:p>
+          <a:p>
+            <a:pPr algn="ctr" defTabSz="457200">
+              <a:lnSpc>
+                <a:spcPct val="100000"/>
+              </a:lnSpc>
+            </a:pPr>
+            <a:endParaRPr lang="es-ES" sz="1900" b="0" u="none" strike="noStrike">
+              <a:solidFill>
+                <a:srgbClr val="000000"/>
+              </a:solidFill>
+              <a:effectLst/>
+              <a:uFillTx/>
+              <a:latin typeface="Arial"/>
+            </a:endParaRPr>
+          </a:p>
+        </p:txBody>
+      </p:sp>
+      <p:sp>
+        <p:nvSpPr>
+          <p:cNvPr id="186" name="Rounded Rectangle 10"/>
+          <p:cNvSpPr/>
+          <p:nvPr/>
+        </p:nvSpPr>
+        <p:spPr>
+          <a:xfrm>
+            <a:off x="8275320" y="2240280"/>
+            <a:ext cx="3245760" cy="959760"/>
+          </a:xfrm>
+          <a:prstGeom prst="roundRect">
+            <a:avLst>
+              <a:gd name="adj" fmla="val 16667"/>
+            </a:avLst>
+          </a:prstGeom>
+          <a:solidFill>
+            <a:srgbClr val="EBF6F0"/>
+          </a:solidFill>
+          <a:ln>
+            <a:solidFill>
+              <a:srgbClr val="DCE0E4"/>
+            </a:solidFill>
+            <a:round/>
+          </a:ln>
+          <a:effectLst>
+            <a:outerShdw blurRad="39960" dist="23040" dir="5400000" rotWithShape="0">
+              <a:srgbClr val="000000">
+                <a:alpha val="35000"/>
+              </a:srgbClr>
+            </a:outerShdw>
+          </a:effectLst>
+        </p:spPr>
+        <p:style>
+          <a:lnRef idx="1">
+            <a:schemeClr val="accent1"/>
+          </a:lnRef>
+          <a:fillRef idx="3">
+            <a:schemeClr val="accent1"/>
+          </a:fillRef>
+          <a:effectRef idx="2">
+            <a:schemeClr val="accent1"/>
+          </a:effectRef>
+          <a:fontRef idx="minor"/>
+        </p:style>
+        <p:txBody>
+          <a:bodyPr lIns="90000" tIns="45000" rIns="90000" bIns="45000" anchor="ctr">
+            <a:noAutofit/>
+          </a:bodyPr>
+          <a:lstStyle/>
+          <a:p>
+            <a:endParaRPr lang="en-US" sz="1800" b="0" u="none" strike="noStrike">
+              <a:solidFill>
+                <a:schemeClr val="lt1"/>
+              </a:solidFill>
+              <a:effectLst/>
+              <a:uFillTx/>
+              <a:latin typeface="Calibri"/>
+            </a:endParaRPr>
+          </a:p>
+        </p:txBody>
+      </p:sp>
+      <p:sp>
+        <p:nvSpPr>
+          <p:cNvPr id="187" name="TextBox 11"/>
+          <p:cNvSpPr/>
+          <p:nvPr/>
+        </p:nvSpPr>
+        <p:spPr>
+          <a:xfrm>
+            <a:off x="8458200" y="2541960"/>
+            <a:ext cx="2880000" cy="255600"/>
+          </a:xfrm>
+          <a:prstGeom prst="rect">
+            <a:avLst/>
+          </a:prstGeom>
+          <a:noFill/>
+          <a:ln w="0">
+            <a:noFill/>
+          </a:ln>
+        </p:spPr>
+        <p:style>
+          <a:lnRef idx="0">
+            <a:scrgbClr r="0" g="0" b="0"/>
+          </a:lnRef>
+          <a:fillRef idx="0">
+            <a:scrgbClr r="0" g="0" b="0"/>
+          </a:fillRef>
+          <a:effectRef idx="0">
+            <a:scrgbClr r="0" g="0" b="0"/>
+          </a:effectRef>
+          <a:fontRef idx="minor"/>
+        </p:style>
+        <p:txBody>
+          <a:bodyPr lIns="90000" tIns="45000" rIns="90000" bIns="45000" anchor="t">
+            <a:normAutofit fontScale="77500" lnSpcReduction="20000"/>
+          </a:bodyPr>
+          <a:lstStyle/>
+          <a:p>
+            <a:pPr algn="ctr" defTabSz="457200">
+              <a:lnSpc>
+                <a:spcPct val="100000"/>
+              </a:lnSpc>
+            </a:pPr>
+            <a:r>
+              <a:rPr lang="en-US" sz="1900" b="1" u="none" strike="noStrike">
                 <a:solidFill>
                   <a:srgbClr val="192D3E"/>
                 </a:solidFill>
-                <a:latin typeface="Arial"/>
-              </a:rPr>
-              <a:t>agraïment</a:t>
-            </a:r>
-            <a:r>
-              <a:rPr lang="es-ES" sz="2400" b="0" dirty="0">
+                <a:effectLst/>
+                <a:uFillTx/>
+                <a:latin typeface="Arial"/>
+              </a:rPr>
+              <a:t>Mateix domini</a:t>
+            </a:r>
+            <a:endParaRPr lang="es-ES" sz="1900" b="0" u="none" strike="noStrike">
+              <a:solidFill>
+                <a:srgbClr val="000000"/>
+              </a:solidFill>
+              <a:effectLst/>
+              <a:uFillTx/>
+              <a:latin typeface="Arial"/>
+            </a:endParaRPr>
+          </a:p>
+        </p:txBody>
+      </p:sp>
+      <p:sp>
+        <p:nvSpPr>
+          <p:cNvPr id="188" name="TextBox 12"/>
+          <p:cNvSpPr/>
+          <p:nvPr/>
+        </p:nvSpPr>
+        <p:spPr>
+          <a:xfrm>
+            <a:off x="1051560" y="3886200"/>
+            <a:ext cx="10058040" cy="502560"/>
+          </a:xfrm>
+          <a:prstGeom prst="rect">
+            <a:avLst/>
+          </a:prstGeom>
+          <a:noFill/>
+          <a:ln w="0">
+            <a:noFill/>
+          </a:ln>
+        </p:spPr>
+        <p:style>
+          <a:lnRef idx="0">
+            <a:scrgbClr r="0" g="0" b="0"/>
+          </a:lnRef>
+          <a:fillRef idx="0">
+            <a:scrgbClr r="0" g="0" b="0"/>
+          </a:fillRef>
+          <a:effectRef idx="0">
+            <a:scrgbClr r="0" g="0" b="0"/>
+          </a:effectRef>
+          <a:fontRef idx="minor"/>
+        </p:style>
+        <p:txBody>
+          <a:bodyPr lIns="90000" tIns="45000" rIns="90000" bIns="45000" anchor="t">
+            <a:normAutofit fontScale="92500" lnSpcReduction="9999"/>
+          </a:bodyPr>
+          <a:lstStyle/>
+          <a:p>
+            <a:pPr algn="ctr" defTabSz="457200">
+              <a:lnSpc>
+                <a:spcPct val="100000"/>
+              </a:lnSpc>
+            </a:pPr>
+            <a:r>
+              <a:rPr lang="es-ES" sz="2600" b="1" u="none" strike="noStrike">
+                <a:solidFill>
+                  <a:srgbClr val="236092"/>
+                </a:solidFill>
+                <a:effectLst/>
+                <a:uFillTx/>
+                <a:latin typeface="Arial"/>
+              </a:rPr>
+              <a:t>Canvi tecnològic: adaptador Finnhub ↔ adaptador Alpha Vantage</a:t>
+            </a:r>
+            <a:endParaRPr lang="es-ES" sz="2600" b="0" u="none" strike="noStrike">
+              <a:solidFill>
+                <a:srgbClr val="000000"/>
+              </a:solidFill>
+              <a:effectLst/>
+              <a:uFillTx/>
+              <a:latin typeface="Arial"/>
+            </a:endParaRPr>
+          </a:p>
+        </p:txBody>
+      </p:sp>
+      <p:sp>
+        <p:nvSpPr>
+          <p:cNvPr id="189" name="TextBox 13"/>
+          <p:cNvSpPr/>
+          <p:nvPr/>
+        </p:nvSpPr>
+        <p:spPr>
+          <a:xfrm>
+            <a:off x="1051560" y="5074920"/>
+            <a:ext cx="10058040" cy="456840"/>
+          </a:xfrm>
+          <a:prstGeom prst="rect">
+            <a:avLst/>
+          </a:prstGeom>
+          <a:noFill/>
+          <a:ln w="0">
+            <a:noFill/>
+          </a:ln>
+        </p:spPr>
+        <p:style>
+          <a:lnRef idx="0">
+            <a:scrgbClr r="0" g="0" b="0"/>
+          </a:lnRef>
+          <a:fillRef idx="0">
+            <a:scrgbClr r="0" g="0" b="0"/>
+          </a:fillRef>
+          <a:effectRef idx="0">
+            <a:scrgbClr r="0" g="0" b="0"/>
+          </a:effectRef>
+          <a:fontRef idx="minor"/>
+        </p:style>
+        <p:txBody>
+          <a:bodyPr lIns="90000" tIns="45000" rIns="90000" bIns="45000" anchor="t">
+            <a:normAutofit/>
+          </a:bodyPr>
+          <a:lstStyle/>
+          <a:p>
+            <a:pPr algn="ctr" defTabSz="457200">
+              <a:lnSpc>
+                <a:spcPct val="100000"/>
+              </a:lnSpc>
+            </a:pPr>
+            <a:r>
+              <a:rPr lang="en-US" sz="2400" b="1" u="none" strike="noStrike">
                 <a:solidFill>
                   <a:srgbClr val="192D3E"/>
                 </a:solidFill>
-                <a:latin typeface="Arial"/>
-              </a:rPr>
-              <a:t> al </a:t>
-            </a:r>
-            <a:r>
-              <a:rPr lang="es-ES" sz="2400" b="0" dirty="0" err="1">
+                <a:effectLst/>
+                <a:uFillTx/>
+                <a:latin typeface="Arial"/>
+              </a:rPr>
+              <a:t>Canvia la infraestructura; el cas d'ús </a:t>
+            </a:r>
+            <a:r>
+              <a:rPr lang="es-ES" sz="2400" b="1" u="none" strike="noStrike">
                 <a:solidFill>
                   <a:srgbClr val="192D3E"/>
                 </a:solidFill>
-                <a:latin typeface="Arial"/>
-              </a:rPr>
-              <a:t>TecnoCampus</a:t>
-            </a:r>
-            <a:r>
-              <a:rPr lang="es-ES" sz="2400" b="0" dirty="0">
+                <a:effectLst/>
+                <a:uFillTx/>
+                <a:latin typeface="Arial"/>
+              </a:rPr>
+              <a:t>i el domini </a:t>
+            </a:r>
+            <a:r>
+              <a:rPr lang="en-US" sz="2400" b="1" u="none" strike="noStrike">
                 <a:solidFill>
                   <a:srgbClr val="192D3E"/>
                 </a:solidFill>
-                <a:latin typeface="Arial"/>
-              </a:rPr>
-              <a:t> per un </a:t>
-            </a:r>
-            <a:r>
-              <a:rPr lang="es-ES" sz="2400" b="0" dirty="0" err="1">
+                <a:effectLst/>
+                <a:uFillTx/>
+                <a:latin typeface="Arial"/>
+              </a:rPr>
+              <a:t>roman</a:t>
+            </a:r>
+            <a:r>
+              <a:rPr lang="es-ES" sz="2400" b="1" u="none" strike="noStrike">
                 <a:solidFill>
                   <a:srgbClr val="192D3E"/>
                 </a:solidFill>
-                <a:latin typeface="Arial"/>
-              </a:rPr>
-              <a:t>entorn</a:t>
-            </a:r>
-            <a:r>
-              <a:rPr lang="es-ES" sz="2400" b="0" dirty="0">
+                <a:effectLst/>
+                <a:uFillTx/>
+                <a:latin typeface="Arial"/>
+              </a:rPr>
+              <a:t>en</a:t>
+            </a:r>
+            <a:r>
+              <a:rPr lang="en-US" sz="2400" b="1" u="none" strike="noStrike">
                 <a:solidFill>
                   <a:srgbClr val="192D3E"/>
                 </a:solidFill>
-                <a:latin typeface="Arial"/>
-              </a:rPr>
-              <a:t> que </a:t>
-            </a:r>
-            <a:r>
-              <a:rPr lang="es-ES" sz="2400" b="0" dirty="0" err="1">
+                <a:effectLst/>
+                <a:uFillTx/>
+                <a:latin typeface="Arial"/>
+              </a:rPr>
+              <a:t> estable</a:t>
+            </a:r>
+            <a:r>
+              <a:rPr lang="es-ES" sz="2400" b="1" u="none" strike="noStrike">
                 <a:solidFill>
                   <a:srgbClr val="192D3E"/>
                 </a:solidFill>
-                <a:latin typeface="Arial"/>
-              </a:rPr>
-              <a:t>m'encoratja</a:t>
-            </a:r>
-            <a:r>
-              <a:rPr lang="es-ES" sz="2400" b="0" dirty="0">
+                <a:effectLst/>
+                <a:uFillTx/>
+                <a:latin typeface="Arial"/>
+              </a:rPr>
+              <a:t>s</a:t>
+            </a:r>
+            <a:r>
+              <a:rPr lang="en-US" sz="2400" b="1" u="none" strike="noStrike">
                 <a:solidFill>
                   <a:srgbClr val="192D3E"/>
                 </a:solidFill>
-                <a:latin typeface="Arial"/>
-              </a:rPr>
-              <a:t> a </a:t>
-            </a:r>
-            <a:r>
-              <a:rPr lang="es-ES" sz="2400" b="0" dirty="0" err="1">
-                <a:solidFill>
-                  <a:srgbClr val="192D3E"/>
-                </a:solidFill>
-                <a:latin typeface="Arial"/>
-              </a:rPr>
-              <a:t>créixer</a:t>
-            </a:r>
-            <a:r>
-              <a:rPr lang="es-ES" sz="2400" b="0">
-                <a:solidFill>
-                  <a:srgbClr val="192D3E"/>
-                </a:solidFill>
-                <a:latin typeface="Arial"/>
-              </a:rPr>
-              <a:t>, </a:t>
-            </a:r>
-            <a:r>
-              <a:rPr lang="es-ES" sz="2400" b="0" dirty="0">
-                <a:solidFill>
-                  <a:srgbClr val="192D3E"/>
-                </a:solidFill>
-                <a:latin typeface="Arial"/>
-              </a:rPr>
-              <a:t>al </a:t>
-            </a:r>
-            <a:r>
-              <a:rPr lang="es-ES" sz="2400" b="0" dirty="0" err="1">
-                <a:solidFill>
-                  <a:srgbClr val="192D3E"/>
-                </a:solidFill>
-                <a:latin typeface="Arial"/>
-              </a:rPr>
-              <a:t>costat</a:t>
-            </a:r>
-            <a:r>
-              <a:rPr lang="es-ES" sz="2400" b="0" dirty="0">
-                <a:solidFill>
-                  <a:srgbClr val="192D3E"/>
-                </a:solidFill>
-                <a:latin typeface="Arial"/>
-              </a:rPr>
-              <a:t> </a:t>
-            </a:r>
-            <a:r>
-              <a:rPr lang="es-ES" sz="2400" b="0" dirty="0" err="1">
-                <a:solidFill>
-                  <a:srgbClr val="192D3E"/>
-                </a:solidFill>
-                <a:latin typeface="Arial"/>
-              </a:rPr>
-              <a:t>d'un</a:t>
-            </a:r>
-            <a:r>
-              <a:rPr lang="es-ES" sz="2400" b="0" dirty="0">
-                <a:solidFill>
-                  <a:srgbClr val="192D3E"/>
-                </a:solidFill>
-                <a:latin typeface="Arial"/>
-              </a:rPr>
-              <a:t> </a:t>
-            </a:r>
-            <a:r>
-              <a:rPr lang="es-ES" sz="2400" b="0" dirty="0" err="1">
-                <a:solidFill>
-                  <a:srgbClr val="192D3E"/>
-                </a:solidFill>
-                <a:latin typeface="Arial"/>
-              </a:rPr>
-              <a:t>equip</a:t>
-            </a:r>
-            <a:r>
-              <a:rPr lang="es-ES" sz="2400" b="0" dirty="0">
-                <a:solidFill>
-                  <a:srgbClr val="192D3E"/>
-                </a:solidFill>
-                <a:latin typeface="Arial"/>
-              </a:rPr>
-              <a:t> del </a:t>
-            </a:r>
-            <a:r>
-              <a:rPr lang="es-ES" sz="2400" b="0" dirty="0" err="1">
-                <a:solidFill>
-                  <a:srgbClr val="192D3E"/>
-                </a:solidFill>
-                <a:latin typeface="Arial"/>
-              </a:rPr>
-              <a:t>qual</a:t>
-            </a:r>
-            <a:r>
-              <a:rPr lang="es-ES" sz="2400" b="0" dirty="0">
-                <a:solidFill>
-                  <a:srgbClr val="192D3E"/>
-                </a:solidFill>
-                <a:latin typeface="Arial"/>
-              </a:rPr>
-              <a:t> </a:t>
-            </a:r>
-            <a:r>
-              <a:rPr lang="es-ES" sz="2400" b="0" dirty="0" err="1">
-                <a:solidFill>
-                  <a:srgbClr val="192D3E"/>
-                </a:solidFill>
-                <a:latin typeface="Arial"/>
-              </a:rPr>
-              <a:t>aprenc</a:t>
-            </a:r>
-            <a:r>
-              <a:rPr lang="es-ES" sz="2400" b="0" dirty="0">
-                <a:solidFill>
-                  <a:srgbClr val="192D3E"/>
-                </a:solidFill>
-                <a:latin typeface="Arial"/>
-              </a:rPr>
-              <a:t> i </a:t>
-            </a:r>
-            <a:r>
-              <a:rPr lang="es-ES" sz="2400" b="0" dirty="0" err="1">
-                <a:solidFill>
-                  <a:srgbClr val="192D3E"/>
-                </a:solidFill>
-                <a:latin typeface="Arial"/>
-              </a:rPr>
-              <a:t>amb</a:t>
-            </a:r>
-            <a:r>
-              <a:rPr lang="es-ES" sz="2400" b="0" dirty="0">
-                <a:solidFill>
-                  <a:srgbClr val="192D3E"/>
-                </a:solidFill>
-                <a:latin typeface="Arial"/>
-              </a:rPr>
-              <a:t> qui </a:t>
-            </a:r>
-            <a:r>
-              <a:rPr lang="es-ES" sz="2400" b="0" dirty="0" err="1">
-                <a:solidFill>
-                  <a:srgbClr val="192D3E"/>
-                </a:solidFill>
-                <a:latin typeface="Arial"/>
-              </a:rPr>
-              <a:t>comparteixo</a:t>
-            </a:r>
-            <a:r>
-              <a:rPr lang="es-ES" sz="2400" b="0" dirty="0">
-                <a:solidFill>
-                  <a:srgbClr val="192D3E"/>
-                </a:solidFill>
-                <a:latin typeface="Arial"/>
-              </a:rPr>
-              <a:t> </a:t>
-            </a:r>
-            <a:r>
-              <a:rPr lang="es-ES" sz="2400" b="0" dirty="0" err="1">
-                <a:solidFill>
-                  <a:srgbClr val="192D3E"/>
-                </a:solidFill>
-                <a:latin typeface="Arial"/>
-              </a:rPr>
-              <a:t>coneixement</a:t>
-            </a:r>
-            <a:r>
-              <a:rPr lang="es-ES" sz="2400" b="0" dirty="0">
-                <a:solidFill>
-                  <a:srgbClr val="192D3E"/>
-                </a:solidFill>
-                <a:latin typeface="Arial"/>
-              </a:rPr>
-              <a:t>, </a:t>
-            </a:r>
-            <a:r>
-              <a:rPr lang="es-ES" sz="2400" b="0" dirty="0" err="1">
-                <a:solidFill>
-                  <a:srgbClr val="192D3E"/>
-                </a:solidFill>
-                <a:latin typeface="Arial"/>
-              </a:rPr>
-              <a:t>responsabilitat</a:t>
-            </a:r>
-            <a:r>
-              <a:rPr lang="es-ES" sz="2400" b="0" dirty="0">
-                <a:solidFill>
-                  <a:srgbClr val="192D3E"/>
-                </a:solidFill>
-                <a:latin typeface="Arial"/>
-              </a:rPr>
-              <a:t> i </a:t>
-            </a:r>
-            <a:r>
-              <a:rPr lang="es-ES" sz="2400" b="0" dirty="0" err="1">
-                <a:solidFill>
-                  <a:srgbClr val="192D3E"/>
-                </a:solidFill>
-                <a:latin typeface="Arial"/>
-              </a:rPr>
-              <a:t>compromís</a:t>
-            </a:r>
-            <a:r>
-              <a:rPr lang="es-ES" sz="2400" b="0" dirty="0">
-                <a:solidFill>
-                  <a:srgbClr val="192D3E"/>
-                </a:solidFill>
-                <a:latin typeface="Arial"/>
-              </a:rPr>
-              <a:t> </a:t>
-            </a:r>
-            <a:r>
-              <a:rPr lang="es-ES" sz="2400" b="0" dirty="0" err="1">
-                <a:solidFill>
-                  <a:srgbClr val="192D3E"/>
-                </a:solidFill>
-                <a:latin typeface="Arial"/>
-              </a:rPr>
-              <a:t>amb</a:t>
-            </a:r>
-            <a:r>
-              <a:rPr lang="es-ES" sz="2400" b="0" dirty="0">
-                <a:solidFill>
-                  <a:srgbClr val="192D3E"/>
-                </a:solidFill>
-                <a:latin typeface="Arial"/>
-              </a:rPr>
-              <a:t> la </a:t>
-            </a:r>
-            <a:r>
-              <a:rPr lang="es-ES" sz="2400" b="0" dirty="0" err="1">
-                <a:solidFill>
-                  <a:srgbClr val="192D3E"/>
-                </a:solidFill>
-                <a:latin typeface="Arial"/>
-              </a:rPr>
-              <a:t>formació</a:t>
-            </a:r>
-            <a:r>
-              <a:rPr lang="es-ES" sz="2400" b="0" dirty="0">
-                <a:solidFill>
-                  <a:srgbClr val="192D3E"/>
-                </a:solidFill>
-                <a:latin typeface="Arial"/>
-              </a:rPr>
-              <a:t> </a:t>
-            </a:r>
-            <a:r>
-              <a:rPr lang="es-ES" sz="2400" b="0" dirty="0" err="1">
-                <a:solidFill>
-                  <a:srgbClr val="192D3E"/>
-                </a:solidFill>
-                <a:latin typeface="Arial"/>
-              </a:rPr>
-              <a:t>universitària</a:t>
-            </a:r>
-            <a:r>
-              <a:rPr lang="es-ES" sz="2400" b="0" dirty="0">
-                <a:solidFill>
-                  <a:srgbClr val="192D3E"/>
-                </a:solidFill>
-                <a:latin typeface="Arial"/>
-              </a:rPr>
-              <a:t>. </a:t>
-            </a:r>
-            <a:br>
-              <a:rPr lang="es-ES" sz="2400" b="0" dirty="0">
-                <a:solidFill>
-                  <a:srgbClr val="192D3E"/>
-                </a:solidFill>
-                <a:latin typeface="Arial"/>
-              </a:rPr>
-            </a:br>
-            <a:endParaRPr lang="es-ES" sz="2400" b="0" dirty="0">
-              <a:solidFill>
-                <a:srgbClr val="192D3E"/>
-              </a:solidFill>
+                <a:effectLst/>
+                <a:uFillTx/>
+                <a:latin typeface="Arial"/>
+              </a:rPr>
+              <a:t>.</a:t>
+            </a:r>
+            <a:endParaRPr lang="es-ES" sz="2400" b="0" u="none" strike="noStrike">
+              <a:solidFill>
+                <a:srgbClr val="000000"/>
+              </a:solidFill>
+              <a:effectLst/>
+              <a:uFillTx/>
               <a:latin typeface="Arial"/>
             </a:endParaRPr>
           </a:p>
@@ -13477,113 +13463,127 @@
       </p:sp>
       <p:sp>
         <p:nvSpPr>
-          <p:cNvPr id="8" name="TextBox 7"/>
-          <p:cNvSpPr txBox="1"/>
+          <p:cNvPr id="190" name="TextBox 14"/>
+          <p:cNvSpPr/>
           <p:nvPr/>
         </p:nvSpPr>
         <p:spPr>
           <a:xfrm>
-            <a:off x="2030392" y="4800000"/>
-            <a:ext cx="8099528" cy="868681"/>
+            <a:off x="594360" y="6473880"/>
+            <a:ext cx="8595000" cy="200880"/>
           </a:xfrm>
           <a:prstGeom prst="rect">
             <a:avLst/>
           </a:prstGeom>
           <a:noFill/>
-        </p:spPr>
-        <p:txBody>
-          <a:bodyPr wrap="square">
-            <a:normAutofit/>
+          <a:ln w="0">
+            <a:noFill/>
+          </a:ln>
+        </p:spPr>
+        <p:style>
+          <a:lnRef idx="0">
+            <a:scrgbClr r="0" g="0" b="0"/>
+          </a:lnRef>
+          <a:fillRef idx="0">
+            <a:scrgbClr r="0" g="0" b="0"/>
+          </a:fillRef>
+          <a:effectRef idx="0">
+            <a:scrgbClr r="0" g="0" b="0"/>
+          </a:effectRef>
+          <a:fontRef idx="minor"/>
+        </p:style>
+        <p:txBody>
+          <a:bodyPr lIns="90000" tIns="45000" rIns="90000" bIns="45000" anchor="t">
+            <a:normAutofit lnSpcReduction="9999"/>
           </a:bodyPr>
           <a:lstStyle/>
           <a:p>
-            <a:pPr algn="ctr"/>
-            <a:r>
-              <a:rPr lang="ca-ES" sz="2800" b="1" dirty="0">
-                <a:solidFill>
-                  <a:srgbClr val="192D3E"/>
-                </a:solidFill>
-                <a:latin typeface="Arial"/>
-              </a:rPr>
-              <a:t>Moltes gràcies.</a:t>
-            </a:r>
-          </a:p>
-        </p:txBody>
-      </p:sp>
-      <p:sp>
-        <p:nvSpPr>
-          <p:cNvPr id="9" name="TextBox 8"/>
-          <p:cNvSpPr txBox="1"/>
+            <a:pPr defTabSz="457200">
+              <a:lnSpc>
+                <a:spcPct val="100000"/>
+              </a:lnSpc>
+            </a:pPr>
+            <a:r>
+              <a:rPr lang="en-US" sz="800" b="0" u="none" strike="noStrike">
+                <a:solidFill>
+                  <a:srgbClr val="66707A"/>
+                </a:solidFill>
+                <a:effectLst/>
+                <a:uFillTx/>
+                <a:latin typeface="Arial"/>
+              </a:rPr>
+              <a:t>Disseny de Sistemes d'Informació · Ports de sortida en arquitectura hexagonal</a:t>
+            </a:r>
+            <a:endParaRPr lang="es-ES" sz="800" b="0" u="none" strike="noStrike">
+              <a:solidFill>
+                <a:srgbClr val="000000"/>
+              </a:solidFill>
+              <a:effectLst/>
+              <a:uFillTx/>
+              <a:latin typeface="Arial"/>
+            </a:endParaRPr>
+          </a:p>
+        </p:txBody>
+      </p:sp>
+      <p:sp>
+        <p:nvSpPr>
+          <p:cNvPr id="191" name="TextBox 15"/>
+          <p:cNvSpPr/>
           <p:nvPr/>
         </p:nvSpPr>
         <p:spPr>
           <a:xfrm>
-            <a:off x="594360" y="6473952"/>
-            <a:ext cx="8595360" cy="201168"/>
+            <a:off x="11155680" y="6473880"/>
+            <a:ext cx="411120" cy="200880"/>
           </a:xfrm>
           <a:prstGeom prst="rect">
             <a:avLst/>
           </a:prstGeom>
           <a:noFill/>
-        </p:spPr>
-        <p:txBody>
-          <a:bodyPr wrap="square">
-            <a:normAutofit lnSpcReduction="10000"/>
+          <a:ln w="0">
+            <a:noFill/>
+          </a:ln>
+        </p:spPr>
+        <p:style>
+          <a:lnRef idx="0">
+            <a:scrgbClr r="0" g="0" b="0"/>
+          </a:lnRef>
+          <a:fillRef idx="0">
+            <a:scrgbClr r="0" g="0" b="0"/>
+          </a:fillRef>
+          <a:effectRef idx="0">
+            <a:scrgbClr r="0" g="0" b="0"/>
+          </a:effectRef>
+          <a:fontRef idx="minor"/>
+        </p:style>
+        <p:txBody>
+          <a:bodyPr lIns="90000" tIns="45000" rIns="90000" bIns="45000" anchor="t">
+            <a:normAutofit fontScale="92500" lnSpcReduction="9999"/>
           </a:bodyPr>
           <a:lstStyle/>
           <a:p>
-            <a:pPr algn="l"/>
-            <a:r>
-              <a:rPr sz="800" b="0">
-                <a:solidFill>
-                  <a:srgbClr val="66707A"/>
-                </a:solidFill>
-                <a:latin typeface="Arial"/>
-              </a:rPr>
-              <a:t>Disseny de Sistemes d'Informació · Ports de sortida en arquitectura hexagonal</a:t>
-            </a:r>
-          </a:p>
-        </p:txBody>
-      </p:sp>
-      <p:sp>
-        <p:nvSpPr>
-          <p:cNvPr id="10" name="TextBox 9"/>
-          <p:cNvSpPr txBox="1"/>
-          <p:nvPr/>
-        </p:nvSpPr>
-        <p:spPr>
-          <a:xfrm>
-            <a:off x="11155680" y="6473952"/>
-            <a:ext cx="411480" cy="201168"/>
-          </a:xfrm>
-          <a:prstGeom prst="rect">
-            <a:avLst/>
-          </a:prstGeom>
-          <a:noFill/>
-        </p:spPr>
-        <p:txBody>
-          <a:bodyPr wrap="square">
-            <a:normAutofit lnSpcReduction="10000"/>
-          </a:bodyPr>
-          <a:lstStyle/>
-          <a:p>
-            <a:pPr algn="r"/>
-            <a:r>
-              <a:rPr lang="es-ES" sz="800" b="0" dirty="0">
-                <a:solidFill>
-                  <a:srgbClr val="66707A"/>
-                </a:solidFill>
-                <a:latin typeface="Arial"/>
-              </a:rPr>
-              <a:t>11</a:t>
-            </a:r>
-          </a:p>
-          <a:p>
-            <a:pPr algn="r"/>
-            <a:endParaRPr sz="800" b="0" dirty="0">
-              <a:solidFill>
-                <a:srgbClr val="66707A"/>
-              </a:solidFill>
+            <a:pPr algn="ctr" defTabSz="457200">
+              <a:lnSpc>
+                <a:spcPct val="100000"/>
+              </a:lnSpc>
+            </a:pPr>
+            <a:r>
+              <a:rPr lang="ca-ES" sz="800" b="0" u="none" strike="noStrike">
+                <a:solidFill>
+                  <a:schemeClr val="dk1"/>
+                </a:solidFill>
+                <a:effectLst/>
+                <a:uFillTx/>
+                <a:latin typeface="Calibri"/>
+              </a:rPr>
+              <a:t>Annex</a:t>
+            </a:r>
+            <a:endParaRPr lang="es-ES" sz="800" b="0" u="none" strike="noStrike">
+              <a:solidFill>
+                <a:srgbClr val="000000"/>
+              </a:solidFill>
+              <a:effectLst/>
+              <a:uFillTx/>
               <a:latin typeface="Arial"/>
             </a:endParaRPr>
           </a:p>
@@ -18741,36 +18741,285 @@
       </p:sp>
       <p:sp>
         <p:nvSpPr>
-          <p:cNvPr id="149" name="Rounded Rectangle 19"/>
+          <p:cNvPr id="150" name="TextBox 15"/>
           <p:cNvSpPr/>
           <p:nvPr/>
         </p:nvSpPr>
         <p:spPr>
           <a:xfrm>
-            <a:off x="7543800" y="1600200"/>
-            <a:ext cx="3200040" cy="3200040"/>
+            <a:off x="914400" y="5349240"/>
+            <a:ext cx="4754520" cy="347040"/>
+          </a:xfrm>
+          <a:prstGeom prst="rect">
+            <a:avLst/>
+          </a:prstGeom>
+          <a:noFill/>
+          <a:ln w="0">
+            <a:noFill/>
+          </a:ln>
+        </p:spPr>
+        <p:style>
+          <a:lnRef idx="0">
+            <a:scrgbClr r="0" g="0" b="0"/>
+          </a:lnRef>
+          <a:fillRef idx="0">
+            <a:scrgbClr r="0" g="0" b="0"/>
+          </a:fillRef>
+          <a:effectRef idx="0">
+            <a:scrgbClr r="0" g="0" b="0"/>
+          </a:effectRef>
+          <a:fontRef idx="minor"/>
+        </p:style>
+        <p:txBody>
+          <a:bodyPr lIns="90000" tIns="45000" rIns="90000" bIns="45000" anchor="t">
+            <a:normAutofit fontScale="85000" lnSpcReduction="20000"/>
+          </a:bodyPr>
+          <a:lstStyle/>
+          <a:p>
+            <a:pPr algn="ctr" defTabSz="457200">
+              <a:lnSpc>
+                <a:spcPct val="100000"/>
+              </a:lnSpc>
+            </a:pPr>
+            <a:r>
+              <a:rPr lang="en-US" sz="2300" b="1" u="none" strike="noStrike">
+                <a:solidFill>
+                  <a:srgbClr val="192D3E"/>
+                </a:solidFill>
+                <a:effectLst/>
+                <a:uFillTx/>
+                <a:latin typeface="Arial"/>
+              </a:rPr>
+              <a:t>El port defineix què necessita el cas d’ús</a:t>
+            </a:r>
+            <a:endParaRPr lang="es-ES" sz="2300" b="0" u="none" strike="noStrike">
+              <a:solidFill>
+                <a:srgbClr val="000000"/>
+              </a:solidFill>
+              <a:effectLst/>
+              <a:uFillTx/>
+              <a:latin typeface="Arial"/>
+            </a:endParaRPr>
+          </a:p>
+        </p:txBody>
+      </p:sp>
+      <p:sp>
+        <p:nvSpPr>
+          <p:cNvPr id="151" name="TextBox 16"/>
+          <p:cNvSpPr/>
+          <p:nvPr/>
+        </p:nvSpPr>
+        <p:spPr>
+          <a:xfrm>
+            <a:off x="6400800" y="5349240"/>
+            <a:ext cx="5166000" cy="566640"/>
+          </a:xfrm>
+          <a:prstGeom prst="rect">
+            <a:avLst/>
+          </a:prstGeom>
+          <a:noFill/>
+          <a:ln w="0">
+            <a:noFill/>
+          </a:ln>
+        </p:spPr>
+        <p:style>
+          <a:lnRef idx="0">
+            <a:scrgbClr r="0" g="0" b="0"/>
+          </a:lnRef>
+          <a:fillRef idx="0">
+            <a:scrgbClr r="0" g="0" b="0"/>
+          </a:fillRef>
+          <a:effectRef idx="0">
+            <a:scrgbClr r="0" g="0" b="0"/>
+          </a:effectRef>
+          <a:fontRef idx="minor"/>
+        </p:style>
+        <p:txBody>
+          <a:bodyPr lIns="90000" tIns="45000" rIns="90000" bIns="45000" anchor="t">
+            <a:normAutofit fontScale="85000" lnSpcReduction="20000"/>
+          </a:bodyPr>
+          <a:lstStyle/>
+          <a:p>
+            <a:pPr algn="ctr" defTabSz="457200">
+              <a:lnSpc>
+                <a:spcPct val="100000"/>
+              </a:lnSpc>
+            </a:pPr>
+            <a:r>
+              <a:rPr lang="en-US" sz="2300" b="1" u="none" strike="noStrike">
+                <a:solidFill>
+                  <a:srgbClr val="192D3E"/>
+                </a:solidFill>
+                <a:effectLst/>
+                <a:uFillTx/>
+                <a:latin typeface="Arial"/>
+              </a:rPr>
+              <a:t>Conceptualment és un contracte; en Java el representem amb una interfície</a:t>
+            </a:r>
+            <a:endParaRPr lang="es-ES" sz="2300" b="0" u="none" strike="noStrike">
+              <a:solidFill>
+                <a:srgbClr val="000000"/>
+              </a:solidFill>
+              <a:effectLst/>
+              <a:uFillTx/>
+              <a:latin typeface="Arial"/>
+            </a:endParaRPr>
+          </a:p>
+        </p:txBody>
+      </p:sp>
+      <p:sp>
+        <p:nvSpPr>
+          <p:cNvPr id="152" name="TextBox 17"/>
+          <p:cNvSpPr/>
+          <p:nvPr/>
+        </p:nvSpPr>
+        <p:spPr>
+          <a:xfrm>
+            <a:off x="594360" y="6473880"/>
+            <a:ext cx="8595000" cy="200880"/>
+          </a:xfrm>
+          <a:prstGeom prst="rect">
+            <a:avLst/>
+          </a:prstGeom>
+          <a:noFill/>
+          <a:ln w="0">
+            <a:noFill/>
+          </a:ln>
+        </p:spPr>
+        <p:style>
+          <a:lnRef idx="0">
+            <a:scrgbClr r="0" g="0" b="0"/>
+          </a:lnRef>
+          <a:fillRef idx="0">
+            <a:scrgbClr r="0" g="0" b="0"/>
+          </a:fillRef>
+          <a:effectRef idx="0">
+            <a:scrgbClr r="0" g="0" b="0"/>
+          </a:effectRef>
+          <a:fontRef idx="minor"/>
+        </p:style>
+        <p:txBody>
+          <a:bodyPr lIns="90000" tIns="45000" rIns="90000" bIns="45000" anchor="t">
+            <a:normAutofit lnSpcReduction="9999"/>
+          </a:bodyPr>
+          <a:lstStyle/>
+          <a:p>
+            <a:pPr defTabSz="457200">
+              <a:lnSpc>
+                <a:spcPct val="100000"/>
+              </a:lnSpc>
+            </a:pPr>
+            <a:r>
+              <a:rPr lang="en-US" sz="800" b="0" u="none" strike="noStrike">
+                <a:solidFill>
+                  <a:srgbClr val="66707A"/>
+                </a:solidFill>
+                <a:effectLst/>
+                <a:uFillTx/>
+                <a:latin typeface="Arial"/>
+              </a:rPr>
+              <a:t>Disseny de Sistemes d'Informació · Ports de sortida en arquitectura hexagonal</a:t>
+            </a:r>
+            <a:endParaRPr lang="es-ES" sz="800" b="0" u="none" strike="noStrike">
+              <a:solidFill>
+                <a:srgbClr val="000000"/>
+              </a:solidFill>
+              <a:effectLst/>
+              <a:uFillTx/>
+              <a:latin typeface="Arial"/>
+            </a:endParaRPr>
+          </a:p>
+        </p:txBody>
+      </p:sp>
+      <p:sp>
+        <p:nvSpPr>
+          <p:cNvPr id="153" name="TextBox 18"/>
+          <p:cNvSpPr/>
+          <p:nvPr/>
+        </p:nvSpPr>
+        <p:spPr>
+          <a:xfrm>
+            <a:off x="11155680" y="6473880"/>
+            <a:ext cx="411120" cy="200880"/>
+          </a:xfrm>
+          <a:prstGeom prst="rect">
+            <a:avLst/>
+          </a:prstGeom>
+          <a:noFill/>
+          <a:ln w="0">
+            <a:noFill/>
+          </a:ln>
+        </p:spPr>
+        <p:style>
+          <a:lnRef idx="0">
+            <a:scrgbClr r="0" g="0" b="0"/>
+          </a:lnRef>
+          <a:fillRef idx="0">
+            <a:scrgbClr r="0" g="0" b="0"/>
+          </a:fillRef>
+          <a:effectRef idx="0">
+            <a:scrgbClr r="0" g="0" b="0"/>
+          </a:effectRef>
+          <a:fontRef idx="minor"/>
+        </p:style>
+        <p:txBody>
+          <a:bodyPr lIns="90000" tIns="45000" rIns="90000" bIns="45000" anchor="t">
+            <a:normAutofit lnSpcReduction="9999"/>
+          </a:bodyPr>
+          <a:lstStyle/>
+          <a:p>
+            <a:pPr algn="r" defTabSz="457200">
+              <a:lnSpc>
+                <a:spcPct val="100000"/>
+              </a:lnSpc>
+            </a:pPr>
+            <a:r>
+              <a:rPr lang="en-US" sz="800" b="0" u="none" strike="noStrike">
+                <a:solidFill>
+                  <a:srgbClr val="66707A"/>
+                </a:solidFill>
+                <a:effectLst/>
+                <a:uFillTx/>
+                <a:latin typeface="Arial"/>
+              </a:rPr>
+              <a:t>7</a:t>
+            </a:r>
+            <a:endParaRPr lang="es-ES" sz="800" b="0" u="none" strike="noStrike">
+              <a:solidFill>
+                <a:srgbClr val="000000"/>
+              </a:solidFill>
+              <a:effectLst/>
+              <a:uFillTx/>
+              <a:latin typeface="Arial"/>
+            </a:endParaRPr>
+          </a:p>
+        </p:txBody>
+      </p:sp>
+      <p:sp>
+        <p:nvSpPr>
+          <p:cNvPr id="154" name="Java concretion container"/>
+          <p:cNvSpPr/>
+          <p:nvPr/>
+        </p:nvSpPr>
+        <p:spPr>
+          <a:xfrm>
+            <a:off x="7498079" y="1371600"/>
+            <a:ext cx="3657600" cy="3703320"/>
           </a:xfrm>
           <a:prstGeom prst="roundRect">
             <a:avLst>
-              <a:gd name="adj" fmla="val 5000"/>
+              <a:gd name="adj" fmla="val 5500"/>
             </a:avLst>
           </a:prstGeom>
           <a:solidFill>
             <a:srgbClr val="F4F8FB"/>
           </a:solidFill>
-          <a:ln>
+          <a:ln w="9525">
             <a:solidFill>
               <a:srgbClr val="DCE0E4"/>
             </a:solidFill>
-            <a:round/>
-          </a:ln>
-          <a:effectLst>
-            <a:outerShdw blurRad="39960" dist="23040" dir="5400000" rotWithShape="0">
-              <a:srgbClr val="000000">
-                <a:alpha val="35000"/>
-              </a:srgbClr>
-            </a:outerShdw>
-          </a:effectLst>
+          </a:ln>
+          <a:effectLst/>
         </p:spPr>
         <p:style>
           <a:lnRef idx="1">
@@ -18782,398 +19031,516 @@
           <a:effectRef idx="2">
             <a:schemeClr val="accent1"/>
           </a:effectRef>
-          <a:fontRef idx="minor"/>
+          <a:fontRef idx="minor">
+            <a:schemeClr val="lt1"/>
+          </a:fontRef>
         </p:style>
         <p:txBody>
-          <a:bodyPr lIns="182880" tIns="182880" rIns="182880" bIns="182880" anchor="ctr">
-            <a:noAutofit/>
-          </a:bodyPr>
+          <a:bodyPr rtlCol="0" anchor="ctr"/>
           <a:lstStyle/>
           <a:p>
-            <a:pPr algn="ctr" defTabSz="457200">
-              <a:lnSpc>
-                <a:spcPct val="100000"/>
-              </a:lnSpc>
-            </a:pPr>
-            <a:r>
-              <a:rPr lang="en-US" sz="1650" b="1" u="none" strike="noStrike">
+            <a:pPr algn="ctr"/>
+          </a:p>
+        </p:txBody>
+      </p:sp>
+      <p:sp>
+        <p:nvSpPr>
+          <p:cNvPr id="155" name="Java concretion title"/>
+          <p:cNvSpPr txBox="1"/>
+          <p:nvPr/>
+        </p:nvSpPr>
+        <p:spPr>
+          <a:xfrm>
+            <a:off x="7498079" y="1499616"/>
+            <a:ext cx="3657600" cy="292608"/>
+          </a:xfrm>
+          <a:prstGeom prst="rect">
+            <a:avLst/>
+          </a:prstGeom>
+          <a:noFill/>
+        </p:spPr>
+        <p:txBody>
+          <a:bodyPr wrap="square" lIns="0" rIns="0" tIns="0" bIns="0">
+            <a:spAutoFit/>
+          </a:bodyPr>
+          <a:lstStyle/>
+          <a:p>
+            <a:pPr algn="ctr"/>
+            <a:r>
+              <a:rPr sz="1600" b="1" i="0">
                 <a:solidFill>
                   <a:srgbClr val="192D3E"/>
                 </a:solidFill>
-                <a:effectLst/>
-                <a:uFillTx/>
                 <a:latin typeface="Arial"/>
               </a:rPr>
               <a:t>Concreció en Java</a:t>
             </a:r>
-            <a:endParaRPr lang="es-ES" sz="1650" b="0" u="none" strike="noStrike">
-              <a:solidFill>
-                <a:srgbClr val="000000"/>
-              </a:solidFill>
-              <a:effectLst/>
-              <a:uFillTx/>
-              <a:latin typeface="Arial"/>
-            </a:endParaRPr>
-          </a:p>
-          <a:p>
-            <a:pPr algn="ctr" defTabSz="457200">
-              <a:lnSpc>
-                <a:spcPct val="100000"/>
-              </a:lnSpc>
-            </a:pPr>
-            <a:r>
-              <a:rPr lang="en-US" sz="1650" b="1" u="none" strike="noStrike">
-                <a:solidFill>
-                  <a:srgbClr val="192D3E"/>
-                </a:solidFill>
-                <a:effectLst/>
-                <a:uFillTx/>
-                <a:latin typeface="Arial"/>
-              </a:rPr>
-              <a:t>Port de sortida</a:t>
-            </a:r>
-            <a:endParaRPr lang="es-ES" sz="1650" b="0" u="none" strike="noStrike">
-              <a:solidFill>
-                <a:srgbClr val="000000"/>
-              </a:solidFill>
-              <a:effectLst/>
-              <a:uFillTx/>
-              <a:latin typeface="Arial"/>
-            </a:endParaRPr>
-          </a:p>
-          <a:p>
-            <a:pPr algn="ctr" defTabSz="457200">
-              <a:lnSpc>
-                <a:spcPct val="100000"/>
-              </a:lnSpc>
-            </a:pPr>
-            <a:r>
-              <a:rPr lang="en-US" sz="1650" b="1" u="none" strike="noStrike">
-                <a:solidFill>
-                  <a:srgbClr val="192D3E"/>
-                </a:solidFill>
-                <a:effectLst/>
-                <a:uFillTx/>
-                <a:latin typeface="Arial"/>
-              </a:rPr>
-              <a:t>contracte de l’aplicació</a:t>
-            </a:r>
-            <a:endParaRPr lang="es-ES" sz="1650" b="0" u="none" strike="noStrike">
-              <a:solidFill>
-                <a:srgbClr val="000000"/>
-              </a:solidFill>
-              <a:effectLst/>
-              <a:uFillTx/>
-              <a:latin typeface="Arial"/>
-            </a:endParaRPr>
-          </a:p>
-          <a:p>
-            <a:pPr algn="ctr" defTabSz="457200">
-              <a:lnSpc>
-                <a:spcPct val="100000"/>
-              </a:lnSpc>
-            </a:pPr>
-            <a:r>
-              <a:rPr lang="en-US" sz="1650" b="1" u="none" strike="noStrike">
-                <a:solidFill>
-                  <a:srgbClr val="192D3E"/>
-                </a:solidFill>
-                <a:effectLst/>
-                <a:uFillTx/>
-                <a:latin typeface="Arial"/>
-              </a:rPr>
-              <a:t>Adaptador</a:t>
-            </a:r>
-            <a:endParaRPr lang="es-ES" sz="1650" b="0" u="none" strike="noStrike">
-              <a:solidFill>
-                <a:srgbClr val="000000"/>
-              </a:solidFill>
-              <a:effectLst/>
-              <a:uFillTx/>
-              <a:latin typeface="Arial"/>
-            </a:endParaRPr>
-          </a:p>
-          <a:p>
-            <a:pPr algn="ctr" defTabSz="457200">
-              <a:lnSpc>
-                <a:spcPct val="100000"/>
-              </a:lnSpc>
-            </a:pPr>
-            <a:r>
-              <a:rPr lang="en-US" sz="1650" b="1" u="none" strike="noStrike">
-                <a:solidFill>
-                  <a:srgbClr val="192D3E"/>
-                </a:solidFill>
-                <a:effectLst/>
-                <a:uFillTx/>
-                <a:latin typeface="Arial"/>
-              </a:rPr>
-              <a:t>classe que implementa aquesta interfície</a:t>
-            </a:r>
-            <a:endParaRPr lang="es-ES" sz="1650" b="0" u="none" strike="noStrike">
-              <a:solidFill>
-                <a:srgbClr val="000000"/>
-              </a:solidFill>
-              <a:effectLst/>
-              <a:uFillTx/>
-              <a:latin typeface="Arial"/>
-            </a:endParaRPr>
-          </a:p>
-        </p:txBody>
-      </p:sp>
-      <p:sp>
-        <p:nvSpPr>
-          <p:cNvPr id="150" name="TextBox 15"/>
+          </a:p>
+        </p:txBody>
+      </p:sp>
+      <p:sp>
+        <p:nvSpPr>
+          <p:cNvPr id="156" name="Port interface card"/>
           <p:cNvSpPr/>
           <p:nvPr/>
         </p:nvSpPr>
         <p:spPr>
           <a:xfrm>
-            <a:off x="914400" y="5349240"/>
-            <a:ext cx="4754520" cy="347040"/>
+            <a:off x="7818120" y="1874519"/>
+            <a:ext cx="3017520" cy="969264"/>
+          </a:xfrm>
+          <a:prstGeom prst="roundRect">
+            <a:avLst>
+              <a:gd name="adj" fmla="val 9000"/>
+            </a:avLst>
+          </a:prstGeom>
+          <a:solidFill>
+            <a:srgbClr val="FFFFFF"/>
+          </a:solidFill>
+          <a:ln w="12700">
+            <a:solidFill>
+              <a:srgbClr val="AEBECC"/>
+            </a:solidFill>
+          </a:ln>
+          <a:effectLst/>
+        </p:spPr>
+        <p:style>
+          <a:lnRef idx="1">
+            <a:schemeClr val="accent1"/>
+          </a:lnRef>
+          <a:fillRef idx="3">
+            <a:schemeClr val="accent1"/>
+          </a:fillRef>
+          <a:effectRef idx="2">
+            <a:schemeClr val="accent1"/>
+          </a:effectRef>
+          <a:fontRef idx="minor">
+            <a:schemeClr val="lt1"/>
+          </a:fontRef>
+        </p:style>
+        <p:txBody>
+          <a:bodyPr rtlCol="0" anchor="ctr"/>
+          <a:lstStyle/>
+          <a:p>
+            <a:pPr algn="ctr"/>
+          </a:p>
+        </p:txBody>
+      </p:sp>
+      <p:sp>
+        <p:nvSpPr>
+          <p:cNvPr id="157" name="Port interface name"/>
+          <p:cNvSpPr txBox="1"/>
+          <p:nvPr/>
+        </p:nvSpPr>
+        <p:spPr>
+          <a:xfrm>
+            <a:off x="7818120" y="1947672"/>
+            <a:ext cx="3017520" cy="512064"/>
           </a:xfrm>
           <a:prstGeom prst="rect">
             <a:avLst/>
           </a:prstGeom>
           <a:noFill/>
-          <a:ln w="0">
+        </p:spPr>
+        <p:txBody>
+          <a:bodyPr wrap="square" lIns="0" rIns="0" tIns="0" bIns="0">
+            <a:spAutoFit/>
+          </a:bodyPr>
+          <a:lstStyle/>
+          <a:p>
+            <a:pPr algn="ctr"/>
+            <a:r>
+              <a:rPr sz="1100" b="0" i="1">
+                <a:solidFill>
+                  <a:srgbClr val="66707A"/>
+                </a:solidFill>
+                <a:latin typeface="Arial"/>
+              </a:rPr>
+              <a:t>«interface»</a:t>
+            </a:r>
+          </a:p>
+          <a:p>
+            <a:pPr algn="ctr"/>
+            <a:r>
+              <a:rPr sz="1550" b="1" i="0">
+                <a:solidFill>
+                  <a:srgbClr val="192D3E"/>
+                </a:solidFill>
+                <a:latin typeface="Arial"/>
+              </a:rPr>
+              <a:t>Port de sortida</a:t>
+            </a:r>
+          </a:p>
+        </p:txBody>
+      </p:sp>
+      <p:sp>
+        <p:nvSpPr>
+          <p:cNvPr id="158" name="Port card divider"/>
+          <p:cNvSpPr/>
+          <p:nvPr/>
+        </p:nvSpPr>
+        <p:spPr>
+          <a:xfrm>
+            <a:off x="8001000" y="2505456"/>
+            <a:ext cx="2651760" cy="9525"/>
+          </a:xfrm>
+          <a:prstGeom prst="rect">
+            <a:avLst/>
+          </a:prstGeom>
+          <a:solidFill>
+            <a:srgbClr val="D6DBE0"/>
+          </a:solidFill>
+          <a:ln>
             <a:noFill/>
           </a:ln>
+          <a:effectLst/>
         </p:spPr>
         <p:style>
-          <a:lnRef idx="0">
-            <a:scrgbClr r="0" g="0" b="0"/>
+          <a:lnRef idx="1">
+            <a:schemeClr val="accent1"/>
+          </a:lnRef>
+          <a:fillRef idx="3">
+            <a:schemeClr val="accent1"/>
+          </a:fillRef>
+          <a:effectRef idx="2">
+            <a:schemeClr val="accent1"/>
+          </a:effectRef>
+          <a:fontRef idx="minor">
+            <a:schemeClr val="lt1"/>
+          </a:fontRef>
+        </p:style>
+        <p:txBody>
+          <a:bodyPr rtlCol="0" anchor="ctr"/>
+          <a:lstStyle/>
+          <a:p>
+            <a:pPr algn="ctr"/>
+          </a:p>
+        </p:txBody>
+      </p:sp>
+      <p:sp>
+        <p:nvSpPr>
+          <p:cNvPr id="159" name="Port card subtitle"/>
+          <p:cNvSpPr txBox="1"/>
+          <p:nvPr/>
+        </p:nvSpPr>
+        <p:spPr>
+          <a:xfrm>
+            <a:off x="7818120" y="2560320"/>
+            <a:ext cx="3017520" cy="237744"/>
+          </a:xfrm>
+          <a:prstGeom prst="rect">
+            <a:avLst/>
+          </a:prstGeom>
+          <a:noFill/>
+        </p:spPr>
+        <p:txBody>
+          <a:bodyPr wrap="square" lIns="0" rIns="0" tIns="0" bIns="0">
+            <a:spAutoFit/>
+          </a:bodyPr>
+          <a:lstStyle/>
+          <a:p>
+            <a:pPr algn="ctr"/>
+            <a:r>
+              <a:rPr sz="1150" b="0" i="0">
+                <a:solidFill>
+                  <a:srgbClr val="192D3E"/>
+                </a:solidFill>
+                <a:latin typeface="Arial"/>
+              </a:rPr>
+              <a:t>contracte de l’aplicació</a:t>
+            </a:r>
+          </a:p>
+        </p:txBody>
+      </p:sp>
+      <p:sp>
+        <p:nvSpPr>
+          <p:cNvPr id="160" name="Implements arrow head"/>
+          <p:cNvSpPr/>
+          <p:nvPr/>
+        </p:nvSpPr>
+        <p:spPr>
+          <a:xfrm>
+            <a:off x="9226296" y="2871216"/>
+            <a:ext cx="201168" cy="155448"/>
+          </a:xfrm>
+          <a:prstGeom prst="triangle">
+            <a:avLst/>
+          </a:prstGeom>
+          <a:solidFill>
+            <a:srgbClr val="FFFFFF"/>
+          </a:solidFill>
+          <a:ln w="15875">
+            <a:solidFill>
+              <a:srgbClr val="192D3E"/>
+            </a:solidFill>
+          </a:ln>
+          <a:effectLst/>
+        </p:spPr>
+        <p:style>
+          <a:lnRef idx="1">
+            <a:schemeClr val="accent1"/>
+          </a:lnRef>
+          <a:fillRef idx="3">
+            <a:schemeClr val="accent1"/>
+          </a:fillRef>
+          <a:effectRef idx="2">
+            <a:schemeClr val="accent1"/>
+          </a:effectRef>
+          <a:fontRef idx="minor">
+            <a:schemeClr val="lt1"/>
+          </a:fontRef>
+        </p:style>
+        <p:txBody>
+          <a:bodyPr rtlCol="0" anchor="ctr"/>
+          <a:lstStyle/>
+          <a:p>
+            <a:pPr algn="ctr"/>
+          </a:p>
+        </p:txBody>
+      </p:sp>
+      <p:cxnSp>
+        <p:nvCxnSpPr>
+          <p:cNvPr id="161" name="Implements arrow shaft"/>
+          <p:cNvCxnSpPr/>
+          <p:nvPr/>
+        </p:nvCxnSpPr>
+        <p:spPr>
+          <a:xfrm>
+            <a:off x="9326880" y="3026664"/>
+            <a:ext cx="0" cy="768096"/>
+          </a:xfrm>
+          <a:prstGeom prst="line">
+            <a:avLst/>
+          </a:prstGeom>
+          <a:ln w="19050">
+            <a:solidFill>
+              <a:srgbClr val="192D3E"/>
+            </a:solidFill>
+            <a:prstDash val="dash"/>
+          </a:ln>
+          <a:effectLst/>
+        </p:spPr>
+        <p:style>
+          <a:lnRef idx="2">
+            <a:schemeClr val="accent1"/>
           </a:lnRef>
           <a:fillRef idx="0">
-            <a:scrgbClr r="0" g="0" b="0"/>
+            <a:schemeClr val="accent1"/>
           </a:fillRef>
-          <a:effectRef idx="0">
-            <a:scrgbClr r="0" g="0" b="0"/>
+          <a:effectRef idx="1">
+            <a:schemeClr val="accent1"/>
           </a:effectRef>
-          <a:fontRef idx="minor"/>
+          <a:fontRef idx="minor">
+            <a:schemeClr val="tx1"/>
+          </a:fontRef>
         </p:style>
-        <p:txBody>
-          <a:bodyPr lIns="90000" tIns="45000" rIns="90000" bIns="45000" anchor="t">
-            <a:normAutofit fontScale="85000" lnSpcReduction="20000"/>
+      </p:cxnSp>
+      <p:sp>
+        <p:nvSpPr>
+          <p:cNvPr id="162" name="Implements label"/>
+          <p:cNvSpPr txBox="1"/>
+          <p:nvPr/>
+        </p:nvSpPr>
+        <p:spPr>
+          <a:xfrm>
+            <a:off x="9464040" y="3246120"/>
+            <a:ext cx="1417320" cy="256032"/>
+          </a:xfrm>
+          <a:prstGeom prst="rect">
+            <a:avLst/>
+          </a:prstGeom>
+          <a:noFill/>
+        </p:spPr>
+        <p:txBody>
+          <a:bodyPr wrap="square" lIns="0" rIns="0" tIns="0" bIns="0">
+            <a:spAutoFit/>
           </a:bodyPr>
           <a:lstStyle/>
           <a:p>
-            <a:pPr algn="ctr" defTabSz="457200">
-              <a:lnSpc>
-                <a:spcPct val="100000"/>
-              </a:lnSpc>
-            </a:pPr>
-            <a:r>
-              <a:rPr lang="en-US" sz="2300" b="1" u="none" strike="noStrike">
-                <a:solidFill>
-                  <a:srgbClr val="192D3E"/>
-                </a:solidFill>
-                <a:effectLst/>
-                <a:uFillTx/>
-                <a:latin typeface="Arial"/>
-              </a:rPr>
-              <a:t>El port defineix què necessita el cas d’ús</a:t>
-            </a:r>
-            <a:endParaRPr lang="es-ES" sz="2300" b="0" u="none" strike="noStrike">
-              <a:solidFill>
-                <a:srgbClr val="000000"/>
-              </a:solidFill>
-              <a:effectLst/>
-              <a:uFillTx/>
-              <a:latin typeface="Arial"/>
-            </a:endParaRPr>
-          </a:p>
-        </p:txBody>
-      </p:sp>
-      <p:sp>
-        <p:nvSpPr>
-          <p:cNvPr id="151" name="TextBox 16"/>
+            <a:pPr algn="l"/>
+            <a:r>
+              <a:rPr sz="1200" i="1">
+                <a:solidFill>
+                  <a:srgbClr val="66707A"/>
+                </a:solidFill>
+                <a:latin typeface="Consolas"/>
+              </a:rPr>
+              <a:t>implements</a:t>
+            </a:r>
+          </a:p>
+        </p:txBody>
+      </p:sp>
+      <p:sp>
+        <p:nvSpPr>
+          <p:cNvPr id="163" name="Adapter card"/>
           <p:cNvSpPr/>
           <p:nvPr/>
         </p:nvSpPr>
         <p:spPr>
           <a:xfrm>
-            <a:off x="6400800" y="5349240"/>
-            <a:ext cx="5166000" cy="566640"/>
+            <a:off x="7818120" y="3794760"/>
+            <a:ext cx="3017520" cy="969264"/>
+          </a:xfrm>
+          <a:prstGeom prst="roundRect">
+            <a:avLst>
+              <a:gd name="adj" fmla="val 9000"/>
+            </a:avLst>
+          </a:prstGeom>
+          <a:solidFill>
+            <a:srgbClr val="FFFFFF"/>
+          </a:solidFill>
+          <a:ln w="12700">
+            <a:solidFill>
+              <a:srgbClr val="AEBECC"/>
+            </a:solidFill>
+          </a:ln>
+          <a:effectLst/>
+        </p:spPr>
+        <p:style>
+          <a:lnRef idx="1">
+            <a:schemeClr val="accent1"/>
+          </a:lnRef>
+          <a:fillRef idx="3">
+            <a:schemeClr val="accent1"/>
+          </a:fillRef>
+          <a:effectRef idx="2">
+            <a:schemeClr val="accent1"/>
+          </a:effectRef>
+          <a:fontRef idx="minor">
+            <a:schemeClr val="lt1"/>
+          </a:fontRef>
+        </p:style>
+        <p:txBody>
+          <a:bodyPr rtlCol="0" anchor="ctr"/>
+          <a:lstStyle/>
+          <a:p>
+            <a:pPr algn="ctr"/>
+          </a:p>
+        </p:txBody>
+      </p:sp>
+      <p:sp>
+        <p:nvSpPr>
+          <p:cNvPr id="164" name="Adapter name"/>
+          <p:cNvSpPr txBox="1"/>
+          <p:nvPr/>
+        </p:nvSpPr>
+        <p:spPr>
+          <a:xfrm>
+            <a:off x="7818120" y="3886200"/>
+            <a:ext cx="3017520" cy="274320"/>
           </a:xfrm>
           <a:prstGeom prst="rect">
             <a:avLst/>
           </a:prstGeom>
           <a:noFill/>
-          <a:ln w="0">
-            <a:noFill/>
-          </a:ln>
-        </p:spPr>
-        <p:style>
-          <a:lnRef idx="0">
-            <a:scrgbClr r="0" g="0" b="0"/>
-          </a:lnRef>
-          <a:fillRef idx="0">
-            <a:scrgbClr r="0" g="0" b="0"/>
-          </a:fillRef>
-          <a:effectRef idx="0">
-            <a:scrgbClr r="0" g="0" b="0"/>
-          </a:effectRef>
-          <a:fontRef idx="minor"/>
-        </p:style>
-        <p:txBody>
-          <a:bodyPr lIns="90000" tIns="45000" rIns="90000" bIns="45000" anchor="t">
-            <a:normAutofit fontScale="85000" lnSpcReduction="20000"/>
+        </p:spPr>
+        <p:txBody>
+          <a:bodyPr wrap="square" lIns="0" rIns="0" tIns="0" bIns="0">
+            <a:spAutoFit/>
           </a:bodyPr>
           <a:lstStyle/>
           <a:p>
-            <a:pPr algn="ctr" defTabSz="457200">
-              <a:lnSpc>
-                <a:spcPct val="100000"/>
-              </a:lnSpc>
-            </a:pPr>
-            <a:r>
-              <a:rPr lang="en-US" sz="2300" b="1" u="none" strike="noStrike">
+            <a:pPr algn="ctr"/>
+            <a:r>
+              <a:rPr sz="1550" b="1" i="0">
                 <a:solidFill>
                   <a:srgbClr val="192D3E"/>
                 </a:solidFill>
-                <a:effectLst/>
-                <a:uFillTx/>
-                <a:latin typeface="Arial"/>
-              </a:rPr>
-              <a:t>Conceptualment és un contracte; en Java el representem amb una interfície</a:t>
-            </a:r>
-            <a:endParaRPr lang="es-ES" sz="2300" b="0" u="none" strike="noStrike">
-              <a:solidFill>
-                <a:srgbClr val="000000"/>
-              </a:solidFill>
-              <a:effectLst/>
-              <a:uFillTx/>
-              <a:latin typeface="Arial"/>
-            </a:endParaRPr>
-          </a:p>
-        </p:txBody>
-      </p:sp>
-      <p:sp>
-        <p:nvSpPr>
-          <p:cNvPr id="152" name="TextBox 17"/>
+                <a:latin typeface="Arial"/>
+              </a:rPr>
+              <a:t>Adaptador</a:t>
+            </a:r>
+          </a:p>
+        </p:txBody>
+      </p:sp>
+      <p:sp>
+        <p:nvSpPr>
+          <p:cNvPr id="165" name="Adapter card divider"/>
           <p:cNvSpPr/>
           <p:nvPr/>
         </p:nvSpPr>
         <p:spPr>
           <a:xfrm>
-            <a:off x="594360" y="6473880"/>
-            <a:ext cx="8595000" cy="200880"/>
+            <a:off x="8001000" y="4224528"/>
+            <a:ext cx="2651760" cy="9525"/>
+          </a:xfrm>
+          <a:prstGeom prst="rect">
+            <a:avLst/>
+          </a:prstGeom>
+          <a:solidFill>
+            <a:srgbClr val="D6DBE0"/>
+          </a:solidFill>
+          <a:ln>
+            <a:noFill/>
+          </a:ln>
+          <a:effectLst/>
+        </p:spPr>
+        <p:style>
+          <a:lnRef idx="1">
+            <a:schemeClr val="accent1"/>
+          </a:lnRef>
+          <a:fillRef idx="3">
+            <a:schemeClr val="accent1"/>
+          </a:fillRef>
+          <a:effectRef idx="2">
+            <a:schemeClr val="accent1"/>
+          </a:effectRef>
+          <a:fontRef idx="minor">
+            <a:schemeClr val="lt1"/>
+          </a:fontRef>
+        </p:style>
+        <p:txBody>
+          <a:bodyPr rtlCol="0" anchor="ctr"/>
+          <a:lstStyle/>
+          <a:p>
+            <a:pPr algn="ctr"/>
+          </a:p>
+        </p:txBody>
+      </p:sp>
+      <p:sp>
+        <p:nvSpPr>
+          <p:cNvPr id="166" name="Adapter subtitle"/>
+          <p:cNvSpPr txBox="1"/>
+          <p:nvPr/>
+        </p:nvSpPr>
+        <p:spPr>
+          <a:xfrm>
+            <a:off x="7955279" y="4279392"/>
+            <a:ext cx="2743200" cy="457200"/>
           </a:xfrm>
           <a:prstGeom prst="rect">
             <a:avLst/>
           </a:prstGeom>
           <a:noFill/>
-          <a:ln w="0">
-            <a:noFill/>
-          </a:ln>
-        </p:spPr>
-        <p:style>
-          <a:lnRef idx="0">
-            <a:scrgbClr r="0" g="0" b="0"/>
-          </a:lnRef>
-          <a:fillRef idx="0">
-            <a:scrgbClr r="0" g="0" b="0"/>
-          </a:fillRef>
-          <a:effectRef idx="0">
-            <a:scrgbClr r="0" g="0" b="0"/>
-          </a:effectRef>
-          <a:fontRef idx="minor"/>
-        </p:style>
-        <p:txBody>
-          <a:bodyPr lIns="90000" tIns="45000" rIns="90000" bIns="45000" anchor="t">
-            <a:normAutofit lnSpcReduction="9999"/>
+        </p:spPr>
+        <p:txBody>
+          <a:bodyPr wrap="square" lIns="0" rIns="0" tIns="0" bIns="0">
+            <a:spAutoFit/>
           </a:bodyPr>
           <a:lstStyle/>
           <a:p>
-            <a:pPr defTabSz="457200">
-              <a:lnSpc>
-                <a:spcPct val="100000"/>
-              </a:lnSpc>
-            </a:pPr>
-            <a:r>
-              <a:rPr lang="en-US" sz="800" b="0" u="none" strike="noStrike">
-                <a:solidFill>
-                  <a:srgbClr val="66707A"/>
-                </a:solidFill>
-                <a:effectLst/>
-                <a:uFillTx/>
-                <a:latin typeface="Arial"/>
-              </a:rPr>
-              <a:t>Disseny de Sistemes d'Informació · Ports de sortida en arquitectura hexagonal</a:t>
-            </a:r>
-            <a:endParaRPr lang="es-ES" sz="800" b="0" u="none" strike="noStrike">
-              <a:solidFill>
-                <a:srgbClr val="000000"/>
-              </a:solidFill>
-              <a:effectLst/>
-              <a:uFillTx/>
-              <a:latin typeface="Arial"/>
-            </a:endParaRPr>
-          </a:p>
-        </p:txBody>
-      </p:sp>
-      <p:sp>
-        <p:nvSpPr>
-          <p:cNvPr id="153" name="TextBox 18"/>
-          <p:cNvSpPr/>
-          <p:nvPr/>
-        </p:nvSpPr>
-        <p:spPr>
-          <a:xfrm>
-            <a:off x="11155680" y="6473880"/>
-            <a:ext cx="411120" cy="200880"/>
-          </a:xfrm>
-          <a:prstGeom prst="rect">
-            <a:avLst/>
-          </a:prstGeom>
-          <a:noFill/>
-          <a:ln w="0">
-            <a:noFill/>
-          </a:ln>
-        </p:spPr>
-        <p:style>
-          <a:lnRef idx="0">
-            <a:scrgbClr r="0" g="0" b="0"/>
-          </a:lnRef>
-          <a:fillRef idx="0">
-            <a:scrgbClr r="0" g="0" b="0"/>
-          </a:fillRef>
-          <a:effectRef idx="0">
-            <a:scrgbClr r="0" g="0" b="0"/>
-          </a:effectRef>
-          <a:fontRef idx="minor"/>
-        </p:style>
-        <p:txBody>
-          <a:bodyPr lIns="90000" tIns="45000" rIns="90000" bIns="45000" anchor="t">
-            <a:normAutofit lnSpcReduction="9999"/>
-          </a:bodyPr>
-          <a:lstStyle/>
-          <a:p>
-            <a:pPr algn="r" defTabSz="457200">
-              <a:lnSpc>
-                <a:spcPct val="100000"/>
-              </a:lnSpc>
-            </a:pPr>
-            <a:r>
-              <a:rPr lang="en-US" sz="800" b="0" u="none" strike="noStrike">
-                <a:solidFill>
-                  <a:srgbClr val="66707A"/>
-                </a:solidFill>
-                <a:effectLst/>
-                <a:uFillTx/>
-                <a:latin typeface="Arial"/>
-              </a:rPr>
-              <a:t>7</a:t>
-            </a:r>
-            <a:endParaRPr lang="es-ES" sz="800" b="0" u="none" strike="noStrike">
-              <a:solidFill>
-                <a:srgbClr val="000000"/>
-              </a:solidFill>
-              <a:effectLst/>
-              <a:uFillTx/>
-              <a:latin typeface="Arial"/>
-            </a:endParaRPr>
+            <a:pPr algn="ctr"/>
+            <a:r>
+              <a:rPr sz="1150" b="0" i="0">
+                <a:solidFill>
+                  <a:srgbClr val="192D3E"/>
+                </a:solidFill>
+                <a:latin typeface="Arial"/>
+              </a:rPr>
+              <a:t>classe que implementa</a:t>
+            </a:r>
+          </a:p>
+          <a:p>
+            <a:pPr algn="ctr"/>
+            <a:r>
+              <a:rPr sz="1150" b="0" i="0">
+                <a:solidFill>
+                  <a:srgbClr val="192D3E"/>
+                </a:solidFill>
+                <a:latin typeface="Arial"/>
+              </a:rPr>
+              <a:t>aquesta interfície</a:t>
+            </a:r>
           </a:p>
         </p:txBody>
       </p:sp>

</xml_diff>

<commit_message>
Retalla el guió de trajectòria a ~9 minuts i afegeix el script mestre de derivats
S'eliminen redundàncies del guió oral de 10 minuts (detall de protocols,
síntesis repetides, doble enumeració de La Salle i transició duplicada amb
la classe magistral) i es reformulen en afirmatiu els girs del tipus
«no X, sinó Y». El guió passa de 1.193 a ~1.020 paraules, amb temps de
capçalera actualitzats (total previst 8:45).

S'afegeix src/generate_ALL_derived_materials.sh, que executa els dos
scripts de derivats en seqüència i es nega a arrencar amb LibreOffice
obert, per evitar PDF a mig regenerar. S'actualitza AGENTS.md i
s'ignoren els fitxers de bloqueig d'Office. Inclou els derivats
regenerats.

Co-Authored-By: Claude Fable 5 <noreply@anthropic.com>
</commit_message>
<xml_diff>
--- a/doc/presentations/defensa-placa-permanent-dsi-ports-sortida-hexagonal/output/IMPORTANTE_MANUAL_defensa-dsi-ports-sortida-hexagonal.pptx
+++ b/doc/presentations/defensa-placa-permanent-dsi-ports-sortida-hexagonal/output/IMPORTANTE_MANUAL_defensa-dsi-ports-sortida-hexagonal.pptx
@@ -5,7 +5,7 @@
     <p:sldMasterId id="2147483648" r:id="rId1"/>
   </p:sldMasterIdLst>
   <p:notesMasterIdLst>
-    <p:notesMasterId r:id="rId13"/>
+    <p:notesMasterId r:id="rId14"/>
   </p:notesMasterIdLst>
   <p:sldIdLst>
     <p:sldId id="256" r:id="rId2"/>
@@ -18,8 +18,8 @@
     <p:sldId id="263" r:id="rId9"/>
     <p:sldId id="264" r:id="rId10"/>
     <p:sldId id="268" r:id="rId11"/>
-    <p:sldId id="269" r:id="rId18"/>
-    <p:sldId id="266" r:id="rId12"/>
+    <p:sldId id="269" r:id="rId12"/>
+    <p:sldId id="266" r:id="rId13"/>
   </p:sldIdLst>
   <p:sldSz cx="12192000" cy="6858000"/>
   <p:notesSz cx="6858000" cy="9144000"/>
@@ -968,263 +968,78 @@
       </p:grpSpPr>
       <p:sp>
         <p:nvSpPr>
-          <p:cNvPr id="222" name="PlaceHolder 1"/>
+          <p:cNvPr id="2" name="Slide Image Placeholder 1"/>
           <p:cNvSpPr>
             <a:spLocks noGrp="1" noRot="1" noChangeAspect="1"/>
           </p:cNvSpPr>
           <p:nvPr>
-            <p:ph type="sldImg"/>
+            <p:ph type="sldImg" idx="2"/>
           </p:nvPr>
         </p:nvSpPr>
         <p:spPr>
           <a:xfrm>
-            <a:off x="685800" y="1143000"/>
-            <a:ext cx="5486400" cy="3086100"/>
-          </a:xfrm>
-          <a:prstGeom prst="rect">
-            <a:avLst/>
-          </a:prstGeom>
-          <a:ln w="0">
-            <a:noFill/>
-          </a:ln>
-        </p:spPr>
-      </p:sp>
-      <p:sp>
-        <p:nvSpPr>
-          <p:cNvPr id="223" name="PlaceHolder 2"/>
+            <a:off x="0" y="812800"/>
+            <a:ext cx="0" cy="0"/>
+          </a:xfrm>
+        </p:spPr>
+      </p:sp>
+      <p:sp>
+        <p:nvSpPr>
+          <p:cNvPr id="3" name="Notes Placeholder 2"/>
           <p:cNvSpPr>
             <a:spLocks noGrp="1"/>
           </p:cNvSpPr>
           <p:nvPr>
-            <p:ph type="body"/>
+            <p:ph type="body" sz="quarter" idx="3"/>
           </p:nvPr>
         </p:nvSpPr>
-        <p:spPr>
-          <a:xfrm>
-            <a:off x="685800" y="4400640"/>
-            <a:ext cx="5486040" cy="3600000"/>
-          </a:xfrm>
-          <a:prstGeom prst="rect">
-            <a:avLst/>
-          </a:prstGeom>
-          <a:noFill/>
-          <a:ln w="0">
-            <a:noFill/>
-          </a:ln>
-        </p:spPr>
-        <p:txBody>
-          <a:bodyPr lIns="91440" tIns="45720" rIns="91440" bIns="45720" anchor="t">
-            <a:noAutofit/>
-          </a:bodyPr>
+        <p:spPr/>
+        <p:txBody>
+          <a:bodyPr/>
           <a:lstStyle/>
           <a:p>
-            <a:pPr indent="0" algn="l">
-              <a:lnSpc>
-                <a:spcPct val="100000"/>
-              </a:lnSpc>
-              <a:buNone/>
-            </a:pPr>
-            <a:r>
-              <a:rPr lang="ca-ES" sz="2000" b="0" u="none" strike="noStrike">
-                <a:solidFill>
-                  <a:srgbClr val="000000"/>
-                </a:solidFill>
-                <a:effectLst/>
-                <a:uFillTx/>
-                <a:latin typeface="Arial"/>
-              </a:rPr>
-              <a:t>Annex opcional: només si el tribunal ho demana o queda temps clar.</a:t>
-            </a:r>
-            <a:endParaRPr lang="es-ES" sz="2000" b="0" u="none" strike="noStrike">
-              <a:solidFill>
-                <a:srgbClr val="000000"/>
-              </a:solidFill>
-              <a:effectLst/>
-              <a:uFillTx/>
-              <a:latin typeface="Arial"/>
-            </a:endParaRPr>
-          </a:p>
-          <a:p>
-            <a:pPr indent="0" algn="l">
-              <a:lnSpc>
-                <a:spcPct val="100000"/>
-              </a:lnSpc>
-              <a:buNone/>
-            </a:pPr>
-            <a:r>
-              <a:rPr lang="ca-ES" sz="2000" b="0" u="none" strike="noStrike">
-                <a:solidFill>
-                  <a:srgbClr val="000000"/>
-                </a:solidFill>
-                <a:effectLst/>
-                <a:uFillTx/>
-                <a:latin typeface="Arial"/>
-              </a:rPr>
-              <a:t>No forma part del cos principal de 20 minuts.</a:t>
-            </a:r>
-            <a:endParaRPr lang="es-ES" sz="2000" b="0" u="none" strike="noStrike">
-              <a:solidFill>
-                <a:srgbClr val="000000"/>
-              </a:solidFill>
-              <a:effectLst/>
-              <a:uFillTx/>
-              <a:latin typeface="Arial"/>
-            </a:endParaRPr>
-          </a:p>
-          <a:p>
-            <a:pPr indent="0" algn="l">
-              <a:lnSpc>
-                <a:spcPct val="100000"/>
-              </a:lnSpc>
-              <a:buNone/>
-            </a:pPr>
-            <a:r>
-              <a:rPr lang="ca-ES" sz="2000" b="0" u="none" strike="noStrike">
-                <a:solidFill>
-                  <a:srgbClr val="000000"/>
-                </a:solidFill>
-                <a:effectLst/>
-                <a:uFillTx/>
-                <a:latin typeface="Arial"/>
-              </a:rPr>
-              <a:t>Missatge demo: mateix cas d’ús, servei i domini.</a:t>
-            </a:r>
-            <a:endParaRPr lang="es-ES" sz="2000" b="0" u="none" strike="noStrike">
-              <a:solidFill>
-                <a:srgbClr val="000000"/>
-              </a:solidFill>
-              <a:effectLst/>
-              <a:uFillTx/>
-              <a:latin typeface="Arial"/>
-            </a:endParaRPr>
-          </a:p>
-          <a:p>
-            <a:pPr indent="0" algn="l">
-              <a:lnSpc>
-                <a:spcPct val="100000"/>
-              </a:lnSpc>
-              <a:buNone/>
-            </a:pPr>
-            <a:r>
-              <a:rPr lang="ca-ES" sz="2000" b="0" u="none" strike="noStrike">
-                <a:solidFill>
-                  <a:srgbClr val="000000"/>
-                </a:solidFill>
-                <a:effectLst/>
-                <a:uFillTx/>
-                <a:latin typeface="Arial"/>
-              </a:rPr>
-              <a:t>Canvia l’adaptador: Finnhub, Alpha Vantage o mock.</a:t>
-            </a:r>
-            <a:endParaRPr lang="es-ES" sz="2000" b="0" u="none" strike="noStrike">
-              <a:solidFill>
-                <a:srgbClr val="000000"/>
-              </a:solidFill>
-              <a:effectLst/>
-              <a:uFillTx/>
-              <a:latin typeface="Arial"/>
-            </a:endParaRPr>
-          </a:p>
-          <a:p>
-            <a:pPr indent="0" algn="l">
-              <a:lnSpc>
-                <a:spcPct val="100000"/>
-              </a:lnSpc>
-              <a:buNone/>
-            </a:pPr>
-            <a:r>
-              <a:rPr lang="ca-ES" sz="2000" b="0" u="none" strike="noStrike">
-                <a:solidFill>
-                  <a:srgbClr val="000000"/>
-                </a:solidFill>
-                <a:effectLst/>
-                <a:uFillTx/>
-                <a:latin typeface="Arial"/>
-              </a:rPr>
-              <a:t>Objectiu docent: contracte estable, infraestructura substituïble.</a:t>
-            </a:r>
-            <a:endParaRPr lang="es-ES" sz="2000" b="0" u="none" strike="noStrike">
-              <a:solidFill>
-                <a:srgbClr val="000000"/>
-              </a:solidFill>
-              <a:effectLst/>
-              <a:uFillTx/>
-              <a:latin typeface="Arial"/>
-            </a:endParaRPr>
-          </a:p>
-        </p:txBody>
-      </p:sp>
-      <p:sp>
-        <p:nvSpPr>
-          <p:cNvPr id="224" name="PlaceHolder 3"/>
+            <a:r>
+              <a:rPr lang="ca-ES"/>
+              <a:t>Frase d’agraïment literal: no resumir-la ni canviar cap paraula.</a:t>
+            </a:r>
+          </a:p>
+          <a:p>
+            <a:r>
+              <a:rPr lang="ca-ES"/>
+              <a:t>Cap nom de persona i cap altre agraïment.</a:t>
+            </a:r>
+          </a:p>
+          <a:p>
+            <a:r>
+              <a:rPr lang="ca-ES"/>
+              <a:t>Pausa natural abans de: Moltes gràcies.</a:t>
+            </a:r>
+          </a:p>
+          <a:p>
+            <a:r>
+              <a:rPr lang="ca-ES"/>
+              <a:t>Després de Moltes gràcies, la classe queda formalment tancada.</a:t>
+            </a:r>
+          </a:p>
+          <a:p>
+            <a:r>
+              <a:rPr lang="ca-ES"/>
+              <a:t>No obrir la demo si el tribunal no la demana o si no hi ha temps explícit.</a:t>
+            </a:r>
+          </a:p>
+        </p:txBody>
+      </p:sp>
+      <p:sp>
+        <p:nvSpPr>
+          <p:cNvPr id="4" name="Slide Number Placeholder 3"/>
           <p:cNvSpPr>
             <a:spLocks noGrp="1"/>
           </p:cNvSpPr>
           <p:nvPr>
-            <p:ph type="sldNum" idx="47"/>
+            <p:ph type="sldNum" sz="quarter" idx="5"/>
           </p:nvPr>
         </p:nvSpPr>
-        <p:spPr>
-          <a:xfrm>
-            <a:off x="3884760" y="8685360"/>
-            <a:ext cx="2971440" cy="458280"/>
-          </a:xfrm>
-          <a:prstGeom prst="rect">
-            <a:avLst/>
-          </a:prstGeom>
-          <a:noFill/>
-          <a:ln w="0">
-            <a:noFill/>
-          </a:ln>
-        </p:spPr>
-        <p:txBody>
-          <a:bodyPr lIns="91440" tIns="45720" rIns="91440" bIns="45720" anchor="b">
-            <a:noAutofit/>
-          </a:bodyPr>
-          <a:lstStyle>
-            <a:lvl1pPr indent="0" algn="r">
-              <a:lnSpc>
-                <a:spcPct val="100000"/>
-              </a:lnSpc>
-              <a:buNone/>
-              <a:defRPr lang="es-ES" sz="1200" b="0" u="none" strike="noStrike">
-                <a:solidFill>
-                  <a:srgbClr val="000000"/>
-                </a:solidFill>
-                <a:effectLst/>
-                <a:uFillTx/>
-                <a:latin typeface="Times New Roman"/>
-              </a:defRPr>
-            </a:lvl1pPr>
-          </a:lstStyle>
-          <a:p>
-            <a:pPr indent="0" algn="r">
-              <a:lnSpc>
-                <a:spcPct val="100000"/>
-              </a:lnSpc>
-              <a:buNone/>
-            </a:pPr>
-            <a:fld id="{0FCD26F0-68A2-4F90-A117-9A4BFB6DC3AF}" type="slidenum">
-              <a:rPr lang="es-ES" sz="1200" b="0" u="none" strike="noStrike">
-                <a:solidFill>
-                  <a:srgbClr val="000000"/>
-                </a:solidFill>
-                <a:effectLst/>
-                <a:uFillTx/>
-                <a:latin typeface="Times New Roman"/>
-              </a:rPr>
-              <a:t>11</a:t>
-            </a:fld>
-            <a:endParaRPr lang="es-ES" sz="1200" b="0" u="none" strike="noStrike">
-              <a:solidFill>
-                <a:srgbClr val="000000"/>
-              </a:solidFill>
-              <a:effectLst/>
-              <a:uFillTx/>
-              <a:latin typeface="Times New Roman"/>
-            </a:endParaRPr>
-          </a:p>
-        </p:txBody>
+        <p:spPr/>
       </p:sp>
     </p:spTree>
   </p:cSld>
@@ -1253,78 +1068,263 @@
       </p:grpSpPr>
       <p:sp>
         <p:nvSpPr>
-          <p:cNvPr id="2" name="Slide Image Placeholder 1"/>
+          <p:cNvPr id="222" name="PlaceHolder 1"/>
           <p:cNvSpPr>
             <a:spLocks noGrp="1" noRot="1" noChangeAspect="1"/>
           </p:cNvSpPr>
           <p:nvPr>
-            <p:ph type="sldImg" idx="2"/>
+            <p:ph type="sldImg"/>
           </p:nvPr>
         </p:nvSpPr>
         <p:spPr>
           <a:xfrm>
-            <a:off x="0" y="812800"/>
-            <a:ext cx="0" cy="0"/>
-          </a:xfrm>
-        </p:spPr>
-      </p:sp>
-      <p:sp>
-        <p:nvSpPr>
-          <p:cNvPr id="3" name="Notes Placeholder 2"/>
+            <a:off x="685800" y="1143000"/>
+            <a:ext cx="5486400" cy="3086100"/>
+          </a:xfrm>
+          <a:prstGeom prst="rect">
+            <a:avLst/>
+          </a:prstGeom>
+          <a:ln w="0">
+            <a:noFill/>
+          </a:ln>
+        </p:spPr>
+      </p:sp>
+      <p:sp>
+        <p:nvSpPr>
+          <p:cNvPr id="223" name="PlaceHolder 2"/>
           <p:cNvSpPr>
             <a:spLocks noGrp="1"/>
           </p:cNvSpPr>
           <p:nvPr>
-            <p:ph type="body" sz="quarter" idx="3"/>
+            <p:ph type="body"/>
           </p:nvPr>
         </p:nvSpPr>
-        <p:spPr/>
-        <p:txBody>
-          <a:bodyPr/>
+        <p:spPr>
+          <a:xfrm>
+            <a:off x="685800" y="4400640"/>
+            <a:ext cx="5486040" cy="3600000"/>
+          </a:xfrm>
+          <a:prstGeom prst="rect">
+            <a:avLst/>
+          </a:prstGeom>
+          <a:noFill/>
+          <a:ln w="0">
+            <a:noFill/>
+          </a:ln>
+        </p:spPr>
+        <p:txBody>
+          <a:bodyPr lIns="91440" tIns="45720" rIns="91440" bIns="45720" anchor="t">
+            <a:noAutofit/>
+          </a:bodyPr>
           <a:lstStyle/>
           <a:p>
-            <a:r>
-              <a:rPr lang="ca-ES"/>
-              <a:t>Frase d’agraïment literal: no resumir-la ni canviar cap paraula.</a:t>
-            </a:r>
-          </a:p>
-          <a:p>
-            <a:r>
-              <a:rPr lang="ca-ES"/>
-              <a:t>Cap nom de persona i cap altre agraïment.</a:t>
-            </a:r>
-          </a:p>
-          <a:p>
-            <a:r>
-              <a:rPr lang="ca-ES"/>
-              <a:t>Pausa natural abans de: Moltes gràcies.</a:t>
-            </a:r>
-          </a:p>
-          <a:p>
-            <a:r>
-              <a:rPr lang="ca-ES"/>
-              <a:t>Després de Moltes gràcies, la classe queda formalment tancada.</a:t>
-            </a:r>
-          </a:p>
-          <a:p>
-            <a:r>
-              <a:rPr lang="ca-ES"/>
-              <a:t>No obrir la demo si el tribunal no la demana o si no hi ha temps explícit.</a:t>
-            </a:r>
-          </a:p>
-        </p:txBody>
-      </p:sp>
-      <p:sp>
-        <p:nvSpPr>
-          <p:cNvPr id="4" name="Slide Number Placeholder 3"/>
+            <a:pPr indent="0" algn="l">
+              <a:lnSpc>
+                <a:spcPct val="100000"/>
+              </a:lnSpc>
+              <a:buNone/>
+            </a:pPr>
+            <a:r>
+              <a:rPr lang="ca-ES" sz="2000" b="0" u="none" strike="noStrike">
+                <a:solidFill>
+                  <a:srgbClr val="000000"/>
+                </a:solidFill>
+                <a:effectLst/>
+                <a:uFillTx/>
+                <a:latin typeface="Arial"/>
+              </a:rPr>
+              <a:t>Annex opcional: només si el tribunal ho demana o queda temps clar.</a:t>
+            </a:r>
+            <a:endParaRPr lang="es-ES" sz="2000" b="0" u="none" strike="noStrike">
+              <a:solidFill>
+                <a:srgbClr val="000000"/>
+              </a:solidFill>
+              <a:effectLst/>
+              <a:uFillTx/>
+              <a:latin typeface="Arial"/>
+            </a:endParaRPr>
+          </a:p>
+          <a:p>
+            <a:pPr indent="0" algn="l">
+              <a:lnSpc>
+                <a:spcPct val="100000"/>
+              </a:lnSpc>
+              <a:buNone/>
+            </a:pPr>
+            <a:r>
+              <a:rPr lang="ca-ES" sz="2000" b="0" u="none" strike="noStrike">
+                <a:solidFill>
+                  <a:srgbClr val="000000"/>
+                </a:solidFill>
+                <a:effectLst/>
+                <a:uFillTx/>
+                <a:latin typeface="Arial"/>
+              </a:rPr>
+              <a:t>No forma part del cos principal de 20 minuts.</a:t>
+            </a:r>
+            <a:endParaRPr lang="es-ES" sz="2000" b="0" u="none" strike="noStrike">
+              <a:solidFill>
+                <a:srgbClr val="000000"/>
+              </a:solidFill>
+              <a:effectLst/>
+              <a:uFillTx/>
+              <a:latin typeface="Arial"/>
+            </a:endParaRPr>
+          </a:p>
+          <a:p>
+            <a:pPr indent="0" algn="l">
+              <a:lnSpc>
+                <a:spcPct val="100000"/>
+              </a:lnSpc>
+              <a:buNone/>
+            </a:pPr>
+            <a:r>
+              <a:rPr lang="ca-ES" sz="2000" b="0" u="none" strike="noStrike">
+                <a:solidFill>
+                  <a:srgbClr val="000000"/>
+                </a:solidFill>
+                <a:effectLst/>
+                <a:uFillTx/>
+                <a:latin typeface="Arial"/>
+              </a:rPr>
+              <a:t>Missatge demo: mateix cas d’ús, servei i domini.</a:t>
+            </a:r>
+            <a:endParaRPr lang="es-ES" sz="2000" b="0" u="none" strike="noStrike">
+              <a:solidFill>
+                <a:srgbClr val="000000"/>
+              </a:solidFill>
+              <a:effectLst/>
+              <a:uFillTx/>
+              <a:latin typeface="Arial"/>
+            </a:endParaRPr>
+          </a:p>
+          <a:p>
+            <a:pPr indent="0" algn="l">
+              <a:lnSpc>
+                <a:spcPct val="100000"/>
+              </a:lnSpc>
+              <a:buNone/>
+            </a:pPr>
+            <a:r>
+              <a:rPr lang="ca-ES" sz="2000" b="0" u="none" strike="noStrike">
+                <a:solidFill>
+                  <a:srgbClr val="000000"/>
+                </a:solidFill>
+                <a:effectLst/>
+                <a:uFillTx/>
+                <a:latin typeface="Arial"/>
+              </a:rPr>
+              <a:t>Canvia l’adaptador: Finnhub, Alpha Vantage o mock.</a:t>
+            </a:r>
+            <a:endParaRPr lang="es-ES" sz="2000" b="0" u="none" strike="noStrike">
+              <a:solidFill>
+                <a:srgbClr val="000000"/>
+              </a:solidFill>
+              <a:effectLst/>
+              <a:uFillTx/>
+              <a:latin typeface="Arial"/>
+            </a:endParaRPr>
+          </a:p>
+          <a:p>
+            <a:pPr indent="0" algn="l">
+              <a:lnSpc>
+                <a:spcPct val="100000"/>
+              </a:lnSpc>
+              <a:buNone/>
+            </a:pPr>
+            <a:r>
+              <a:rPr lang="ca-ES" sz="2000" b="0" u="none" strike="noStrike">
+                <a:solidFill>
+                  <a:srgbClr val="000000"/>
+                </a:solidFill>
+                <a:effectLst/>
+                <a:uFillTx/>
+                <a:latin typeface="Arial"/>
+              </a:rPr>
+              <a:t>Objectiu docent: contracte estable, infraestructura substituïble.</a:t>
+            </a:r>
+            <a:endParaRPr lang="es-ES" sz="2000" b="0" u="none" strike="noStrike">
+              <a:solidFill>
+                <a:srgbClr val="000000"/>
+              </a:solidFill>
+              <a:effectLst/>
+              <a:uFillTx/>
+              <a:latin typeface="Arial"/>
+            </a:endParaRPr>
+          </a:p>
+        </p:txBody>
+      </p:sp>
+      <p:sp>
+        <p:nvSpPr>
+          <p:cNvPr id="224" name="PlaceHolder 3"/>
           <p:cNvSpPr>
             <a:spLocks noGrp="1"/>
           </p:cNvSpPr>
           <p:nvPr>
-            <p:ph type="sldNum" sz="quarter" idx="5"/>
+            <p:ph type="sldNum" idx="47"/>
           </p:nvPr>
         </p:nvSpPr>
-        <p:spPr/>
+        <p:spPr>
+          <a:xfrm>
+            <a:off x="3884760" y="8685360"/>
+            <a:ext cx="2971440" cy="458280"/>
+          </a:xfrm>
+          <a:prstGeom prst="rect">
+            <a:avLst/>
+          </a:prstGeom>
+          <a:noFill/>
+          <a:ln w="0">
+            <a:noFill/>
+          </a:ln>
+        </p:spPr>
+        <p:txBody>
+          <a:bodyPr lIns="91440" tIns="45720" rIns="91440" bIns="45720" anchor="b">
+            <a:noAutofit/>
+          </a:bodyPr>
+          <a:lstStyle>
+            <a:lvl1pPr indent="0" algn="r">
+              <a:lnSpc>
+                <a:spcPct val="100000"/>
+              </a:lnSpc>
+              <a:buNone/>
+              <a:defRPr lang="es-ES" sz="1200" b="0" u="none" strike="noStrike">
+                <a:solidFill>
+                  <a:srgbClr val="000000"/>
+                </a:solidFill>
+                <a:effectLst/>
+                <a:uFillTx/>
+                <a:latin typeface="Times New Roman"/>
+              </a:defRPr>
+            </a:lvl1pPr>
+          </a:lstStyle>
+          <a:p>
+            <a:pPr indent="0" algn="r">
+              <a:lnSpc>
+                <a:spcPct val="100000"/>
+              </a:lnSpc>
+              <a:buNone/>
+            </a:pPr>
+            <a:fld id="{0FCD26F0-68A2-4F90-A117-9A4BFB6DC3AF}" type="slidenum">
+              <a:rPr lang="es-ES" sz="1200" b="0" u="none" strike="noStrike">
+                <a:solidFill>
+                  <a:srgbClr val="000000"/>
+                </a:solidFill>
+                <a:effectLst/>
+                <a:uFillTx/>
+                <a:latin typeface="Times New Roman"/>
+              </a:rPr>
+              <a:t>12</a:t>
+            </a:fld>
+            <a:endParaRPr lang="es-ES" sz="1200" b="0" u="none" strike="noStrike">
+              <a:solidFill>
+                <a:srgbClr val="000000"/>
+              </a:solidFill>
+              <a:effectLst/>
+              <a:uFillTx/>
+              <a:latin typeface="Times New Roman"/>
+            </a:endParaRPr>
+          </a:p>
+        </p:txBody>
       </p:sp>
     </p:spTree>
   </p:cSld>
@@ -5376,7 +5376,7 @@
           <a:p>
             <a:fld id="{5BCAD085-E8A6-8845-BD4E-CB4CCA059FC4}" type="datetimeFigureOut">
               <a:rPr lang="en-US" smtClean="0"/>
-              <a:t>7/12/26</a:t>
+              <a:t>7/14/26</a:t>
             </a:fld>
             <a:endParaRPr lang="en-US"/>
           </a:p>
@@ -11338,7 +11338,7 @@
         </p:nvSpPr>
         <p:spPr>
           <a:xfrm>
-            <a:off x="813960" y="1260000"/>
+            <a:off x="777877" y="1756956"/>
             <a:ext cx="3245760" cy="1150000"/>
           </a:xfrm>
           <a:prstGeom prst="roundRect">
@@ -11400,7 +11400,7 @@
         </p:nvSpPr>
         <p:spPr>
           <a:xfrm>
-            <a:off x="813960" y="1260000"/>
+            <a:off x="777877" y="1756956"/>
             <a:ext cx="3245760" cy="1150000"/>
           </a:xfrm>
           <a:prstGeom prst="rect">
@@ -11466,7 +11466,7 @@
         </p:nvSpPr>
         <p:spPr>
           <a:xfrm>
-            <a:off x="4544640" y="1260000"/>
+            <a:off x="4508557" y="1756956"/>
             <a:ext cx="3245760" cy="1150000"/>
           </a:xfrm>
           <a:prstGeom prst="roundRect">
@@ -11528,7 +11528,7 @@
         </p:nvSpPr>
         <p:spPr>
           <a:xfrm>
-            <a:off x="4544640" y="1260000"/>
+            <a:off x="4508557" y="1756956"/>
             <a:ext cx="3245760" cy="1150000"/>
           </a:xfrm>
           <a:prstGeom prst="rect">
@@ -11594,7 +11594,7 @@
         </p:nvSpPr>
         <p:spPr>
           <a:xfrm>
-            <a:off x="8275320" y="1260000"/>
+            <a:off x="8239237" y="1756956"/>
             <a:ext cx="3245760" cy="1150000"/>
           </a:xfrm>
           <a:prstGeom prst="roundRect">
@@ -11656,7 +11656,7 @@
         </p:nvSpPr>
         <p:spPr>
           <a:xfrm>
-            <a:off x="8275320" y="1260000"/>
+            <a:off x="8239237" y="1756956"/>
             <a:ext cx="3245760" cy="1150000"/>
           </a:xfrm>
           <a:prstGeom prst="rect">
@@ -11722,7 +11722,7 @@
         </p:nvSpPr>
         <p:spPr>
           <a:xfrm>
-            <a:off x="1869840" y="3350000"/>
+            <a:off x="1833757" y="3846956"/>
             <a:ext cx="8595360" cy="1217428"/>
           </a:xfrm>
           <a:prstGeom prst="roundRect">
@@ -11768,7 +11768,7 @@
         </p:nvSpPr>
         <p:spPr>
           <a:xfrm>
-            <a:off x="2030392" y="3453986"/>
+            <a:off x="1994309" y="3950942"/>
             <a:ext cx="8099528" cy="868681"/>
           </a:xfrm>
           <a:prstGeom prst="rect">
@@ -18186,7 +18186,7 @@
         </p:style>
         <p:txBody>
           <a:bodyPr lIns="90000" tIns="45000" rIns="90000" bIns="45000" anchor="t">
-            <a:normAutofit fontScale="70000" lnSpcReduction="20000"/>
+            <a:normAutofit fontScale="62500" lnSpcReduction="20000"/>
           </a:bodyPr>
           <a:lstStyle/>
           <a:p>
@@ -18360,7 +18360,7 @@
         </p:style>
         <p:txBody>
           <a:bodyPr lIns="90000" tIns="45000" rIns="90000" bIns="45000" anchor="t">
-            <a:normAutofit fontScale="70000" lnSpcReduction="20000"/>
+            <a:normAutofit fontScale="62500" lnSpcReduction="20000"/>
           </a:bodyPr>
           <a:lstStyle/>
           <a:p>
@@ -18534,7 +18534,7 @@
         </p:style>
         <p:txBody>
           <a:bodyPr lIns="90000" tIns="45000" rIns="90000" bIns="45000" anchor="t">
-            <a:normAutofit fontScale="70000" lnSpcReduction="20000"/>
+            <a:normAutofit fontScale="62500" lnSpcReduction="20000"/>
           </a:bodyPr>
           <a:lstStyle/>
           <a:p>
@@ -18708,7 +18708,7 @@
         </p:style>
         <p:txBody>
           <a:bodyPr lIns="90000" tIns="45000" rIns="90000" bIns="45000" anchor="t">
-            <a:normAutofit fontScale="70000" lnSpcReduction="20000"/>
+            <a:normAutofit fontScale="62500" lnSpcReduction="20000"/>
           </a:bodyPr>
           <a:lstStyle/>
           <a:p>
@@ -19040,6 +19040,7 @@
           <a:lstStyle/>
           <a:p>
             <a:pPr algn="ctr"/>
+            <a:endParaRPr/>
           </a:p>
         </p:txBody>
       </p:sp>
@@ -19060,7 +19061,7 @@
           <a:noFill/>
         </p:spPr>
         <p:txBody>
-          <a:bodyPr wrap="square" lIns="0" rIns="0" tIns="0" bIns="0">
+          <a:bodyPr wrap="square" lIns="0" tIns="0" rIns="0" bIns="0">
             <a:spAutoFit/>
           </a:bodyPr>
           <a:lstStyle/>
@@ -19123,6 +19124,7 @@
           <a:lstStyle/>
           <a:p>
             <a:pPr algn="ctr"/>
+            <a:endParaRPr/>
           </a:p>
         </p:txBody>
       </p:sp>
@@ -19143,7 +19145,7 @@
           <a:noFill/>
         </p:spPr>
         <p:txBody>
-          <a:bodyPr wrap="square" lIns="0" rIns="0" tIns="0" bIns="0">
+          <a:bodyPr wrap="square" lIns="0" tIns="0" rIns="0" bIns="0">
             <a:spAutoFit/>
           </a:bodyPr>
           <a:lstStyle/>
@@ -19214,6 +19216,7 @@
           <a:lstStyle/>
           <a:p>
             <a:pPr algn="ctr"/>
+            <a:endParaRPr/>
           </a:p>
         </p:txBody>
       </p:sp>
@@ -19234,7 +19237,7 @@
           <a:noFill/>
         </p:spPr>
         <p:txBody>
-          <a:bodyPr wrap="square" lIns="0" rIns="0" tIns="0" bIns="0">
+          <a:bodyPr wrap="square" lIns="0" tIns="0" rIns="0" bIns="0">
             <a:spAutoFit/>
           </a:bodyPr>
           <a:lstStyle/>
@@ -19295,6 +19298,7 @@
           <a:lstStyle/>
           <a:p>
             <a:pPr algn="ctr"/>
+            <a:endParaRPr/>
           </a:p>
         </p:txBody>
       </p:sp>
@@ -19352,7 +19356,7 @@
           <a:noFill/>
         </p:spPr>
         <p:txBody>
-          <a:bodyPr wrap="square" lIns="0" rIns="0" tIns="0" bIns="0">
+          <a:bodyPr wrap="square" lIns="0" tIns="0" rIns="0" bIns="0">
             <a:spAutoFit/>
           </a:bodyPr>
           <a:lstStyle/>
@@ -19415,6 +19419,7 @@
           <a:lstStyle/>
           <a:p>
             <a:pPr algn="ctr"/>
+            <a:endParaRPr/>
           </a:p>
         </p:txBody>
       </p:sp>
@@ -19435,7 +19440,7 @@
           <a:noFill/>
         </p:spPr>
         <p:txBody>
-          <a:bodyPr wrap="square" lIns="0" rIns="0" tIns="0" bIns="0">
+          <a:bodyPr wrap="square" lIns="0" tIns="0" rIns="0" bIns="0">
             <a:spAutoFit/>
           </a:bodyPr>
           <a:lstStyle/>
@@ -19494,6 +19499,7 @@
           <a:lstStyle/>
           <a:p>
             <a:pPr algn="ctr"/>
+            <a:endParaRPr/>
           </a:p>
         </p:txBody>
       </p:sp>
@@ -19514,7 +19520,7 @@
           <a:noFill/>
         </p:spPr>
         <p:txBody>
-          <a:bodyPr wrap="square" lIns="0" rIns="0" tIns="0" bIns="0">
+          <a:bodyPr wrap="square" lIns="0" tIns="0" rIns="0" bIns="0">
             <a:spAutoFit/>
           </a:bodyPr>
           <a:lstStyle/>

</xml_diff>

<commit_message>
Millora el guió i les notes de la presentació de 20 minuts
</commit_message>
<xml_diff>
--- a/doc/presentations/defensa-placa-permanent-dsi-ports-sortida-hexagonal/output/IMPORTANTE_MANUAL_defensa-dsi-ports-sortida-hexagonal.pptx
+++ b/doc/presentations/defensa-placa-permanent-dsi-ports-sortida-hexagonal/output/IMPORTANTE_MANUAL_defensa-dsi-ports-sortida-hexagonal.pptx
@@ -648,7 +648,7 @@
                 <a:uFillTx/>
                 <a:latin typeface="Arial"/>
               </a:rPr>
-              <a:t>Context: classe de DSI.</a:t>
+              <a:t>FUNCIÓ (1:35): obrir la microlliçó i delimitar-ne el focus.</a:t>
             </a:r>
             <a:endParaRPr lang="es-ES" sz="2000" b="0" u="none" strike="noStrike">
               <a:solidFill>
@@ -675,7 +675,7 @@
                 <a:uFillTx/>
                 <a:latin typeface="Arial"/>
               </a:rPr>
-              <a:t>Cas real acreditat: consultoria Generalitat / AGAUR.</a:t>
+              <a:t>Context: classe de DSI i cas real acreditat de consultoria per a la Generalitat/AGAUR.</a:t>
             </a:r>
             <a:endParaRPr lang="es-ES" sz="2000" b="0" u="none" strike="noStrike">
               <a:solidFill>
@@ -702,7 +702,7 @@
                 <a:uFillTx/>
                 <a:latin typeface="Arial"/>
               </a:rPr>
-              <a:t>Idea: trobada entre dimensió acadèmica i professional.</a:t>
+              <a:t>Missatge: trobada entre dimensió acadèmica i professional, sense detalls interns.</a:t>
             </a:r>
             <a:endParaRPr lang="es-ES" sz="2000" b="0" u="none" strike="noStrike">
               <a:solidFill>
@@ -729,7 +729,7 @@
                 <a:uFillTx/>
                 <a:latin typeface="Arial"/>
               </a:rPr>
-              <a:t>Focus: ports de sortida quan cal informació externa. No panoràmica completa d'arquitectura hexagonal.</a:t>
+              <a:t>NO OBLIDAR: no és una panoràmica completa de l’arquitectura hexagonal.</a:t>
             </a:r>
             <a:endParaRPr lang="es-ES" sz="2000" b="0" u="none" strike="noStrike">
               <a:solidFill>
@@ -756,7 +756,34 @@
                 <a:uFillTx/>
                 <a:latin typeface="Arial"/>
               </a:rPr>
-              <a:t>Transició: situar la sessió dins l’assignatura.</a:t>
+              <a:t>Frase de focus: dissenyar un port de sortida quan el cas d’ús necessita informació externa.</a:t>
+            </a:r>
+            <a:endParaRPr lang="es-ES" sz="2000" b="0" u="none" strike="noStrike">
+              <a:solidFill>
+                <a:srgbClr val="000000"/>
+              </a:solidFill>
+              <a:effectLst/>
+              <a:uFillTx/>
+              <a:latin typeface="Arial"/>
+            </a:endParaRPr>
+          </a:p>
+          <a:p>
+            <a:pPr indent="0" algn="l">
+              <a:lnSpc>
+                <a:spcPct val="100000"/>
+              </a:lnSpc>
+              <a:buNone/>
+            </a:pPr>
+            <a:r>
+              <a:rPr lang="ca-ES" sz="2000" b="0" u="none" strike="noStrike">
+                <a:solidFill>
+                  <a:srgbClr val="000000"/>
+                </a:solidFill>
+                <a:effectLst/>
+                <a:uFillTx/>
+                <a:latin typeface="Arial"/>
+              </a:rPr>
+              <a:t>TRANSICIÓ: «Situem primer la sessió dins l’assignatura.»</a:t>
             </a:r>
             <a:endParaRPr lang="es-ES" sz="2000" b="0" u="none" strike="noStrike">
               <a:solidFill>
@@ -900,31 +927,31 @@
           <a:p>
             <a:r>
               <a:rPr lang="ca-ES"/>
-              <a:t>Tancament: l’arquitectura no elimina la dependència externa; la situa en una frontera explícita i controlable.</a:t>
+              <a:t>FUNCIÓ (0:45): tancar el contingut tècnic, sense introduir res de nou.</a:t>
             </a:r>
           </a:p>
           <a:p>
             <a:r>
               <a:rPr lang="ca-ES"/>
-              <a:t>Quan canvia proveïdor o API, volem localitzar l’impacte a l’adaptador.</a:t>
+              <a:t>Recuperar les tres decisions: necessitat funcional, port i adaptador.</a:t>
             </a:r>
           </a:p>
           <a:p>
             <a:r>
               <a:rPr lang="ca-ES"/>
-              <a:t>No reescriure cas d’ús ni deformar domini.</a:t>
+              <a:t>Matís: l’arquitectura no elimina la dependència externa ni tots els canvis; en localitza l’impacte.</a:t>
             </a:r>
           </a:p>
           <a:p>
             <a:r>
               <a:rPr lang="ca-ES"/>
-              <a:t>La frase clau és l’element més memorable: l’arquitectura no elimina el canvi; el localitza.</a:t>
+              <a:t>FRASE FINAL, amb pausa i mirant el tribunal: «L’arquitectura no elimina el canvi; el localitza.»</a:t>
             </a:r>
           </a:p>
           <a:p>
             <a:r>
               <a:rPr lang="ca-ES"/>
-              <a:t>Sense agraïments en aquesta diapositiva: donar pas a la diapositiva 11.</a:t>
+              <a:t>No fer encara l’agraïment: donar pas net a la diapositiva 11.</a:t>
             </a:r>
           </a:p>
         </p:txBody>
@@ -1000,25 +1027,31 @@
           <a:p>
             <a:r>
               <a:rPr lang="ca-ES"/>
-              <a:t>Frase d’agraïment literal: no resumir-la ni canviar cap paraula.</a:t>
+              <a:t>FUNCIÓ (0:25): tancament institucional i protocol·lari.</a:t>
             </a:r>
           </a:p>
           <a:p>
             <a:r>
               <a:rPr lang="ca-ES"/>
-              <a:t>Cap nom de persona i cap altre agraïment.</a:t>
+              <a:t>Llegir la frase d’agraïment literal; no resumir-la ni canviar-ne cap paraula.</a:t>
             </a:r>
           </a:p>
           <a:p>
             <a:r>
               <a:rPr lang="ca-ES"/>
-              <a:t>Pausa natural abans de: Moltes gràcies.</a:t>
+              <a:t>No afegir noms de persones ni altres agraïments.</a:t>
             </a:r>
           </a:p>
           <a:p>
             <a:r>
               <a:rPr lang="ca-ES"/>
-              <a:t>Després de Moltes gràcies, la classe queda formalment tancada.</a:t>
+              <a:t>Fer una pausa natural abans de «Moltes gràcies» i dir-ho mirant el tribunal.</a:t>
+            </a:r>
+          </a:p>
+          <a:p>
+            <a:r>
+              <a:rPr lang="ca-ES"/>
+              <a:t>Després de «Moltes gràcies», la classe queda formalment tancada.</a:t>
             </a:r>
           </a:p>
           <a:p>
@@ -1133,7 +1166,7 @@
                 <a:uFillTx/>
                 <a:latin typeface="Arial"/>
               </a:rPr>
-              <a:t>Annex opcional: només si el tribunal ho demana o queda temps clar.</a:t>
+              <a:t>FUNCIÓ (1:30–2:30): verificació pràctica opcional, posterior al tancament formal.</a:t>
             </a:r>
             <a:endParaRPr lang="es-ES" sz="2000" b="0" u="none" strike="noStrike">
               <a:solidFill>
@@ -1160,7 +1193,7 @@
                 <a:uFillTx/>
                 <a:latin typeface="Arial"/>
               </a:rPr>
-              <a:t>No forma part del cos principal de 20 minuts.</a:t>
+              <a:t>Activar només si el tribunal ho demana o hi ha temps explícit.</a:t>
             </a:r>
             <a:endParaRPr lang="es-ES" sz="2000" b="0" u="none" strike="noStrike">
               <a:solidFill>
@@ -1187,7 +1220,7 @@
                 <a:uFillTx/>
                 <a:latin typeface="Arial"/>
               </a:rPr>
-              <a:t>Missatge demo: mateix cas d’ús, servei i domini.</a:t>
+              <a:t>Assenyalar: mateix cas d’ús, mateix servei i mateix domini; canvia l’adaptador.</a:t>
             </a:r>
             <a:endParaRPr lang="es-ES" sz="2000" b="0" u="none" strike="noStrike">
               <a:solidFill>
@@ -1214,7 +1247,7 @@
                 <a:uFillTx/>
                 <a:latin typeface="Arial"/>
               </a:rPr>
-              <a:t>Canvia l’adaptador: Finnhub, Alpha Vantage o mock.</a:t>
+              <a:t>Finnhub, Alpha Vantage o mock són implementacions, no el contracte.</a:t>
             </a:r>
             <a:endParaRPr lang="es-ES" sz="2000" b="0" u="none" strike="noStrike">
               <a:solidFill>
@@ -1241,7 +1274,61 @@
                 <a:uFillTx/>
                 <a:latin typeface="Arial"/>
               </a:rPr>
-              <a:t>Objectiu docent: contracte estable, infraestructura substituïble.</a:t>
+              <a:t>Utilitat docent: provar sense claus reals ni disponibilitat del proveïdor.</a:t>
+            </a:r>
+            <a:endParaRPr lang="es-ES" sz="2000" b="0" u="none" strike="noStrike">
+              <a:solidFill>
+                <a:srgbClr val="000000"/>
+              </a:solidFill>
+              <a:effectLst/>
+              <a:uFillTx/>
+              <a:latin typeface="Arial"/>
+            </a:endParaRPr>
+          </a:p>
+          <a:p>
+            <a:pPr indent="0" algn="l">
+              <a:lnSpc>
+                <a:spcPct val="100000"/>
+              </a:lnSpc>
+              <a:buNone/>
+            </a:pPr>
+            <a:r>
+              <a:rPr lang="ca-ES" sz="2000" b="0" u="none" strike="noStrike">
+                <a:solidFill>
+                  <a:srgbClr val="000000"/>
+                </a:solidFill>
+                <a:effectLst/>
+                <a:uFillTx/>
+                <a:latin typeface="Arial"/>
+              </a:rPr>
+              <a:t>FRASE CLAU: «Canvia la infraestructura; el cas d’ús i el domini romanen estables.»</a:t>
+            </a:r>
+            <a:endParaRPr lang="es-ES" sz="2000" b="0" u="none" strike="noStrike">
+              <a:solidFill>
+                <a:srgbClr val="000000"/>
+              </a:solidFill>
+              <a:effectLst/>
+              <a:uFillTx/>
+              <a:latin typeface="Arial"/>
+            </a:endParaRPr>
+          </a:p>
+          <a:p>
+            <a:pPr indent="0" algn="l">
+              <a:lnSpc>
+                <a:spcPct val="100000"/>
+              </a:lnSpc>
+              <a:buNone/>
+            </a:pPr>
+            <a:r>
+              <a:rPr lang="ca-ES" sz="2000" b="0" u="none" strike="noStrike">
+                <a:solidFill>
+                  <a:srgbClr val="000000"/>
+                </a:solidFill>
+                <a:effectLst/>
+                <a:uFillTx/>
+                <a:latin typeface="Arial"/>
+              </a:rPr>
+              <a:t>No convertir l’annex en una segona explicació llarga.</a:t>
             </a:r>
             <a:endParaRPr lang="es-ES" sz="2000" b="0" u="none" strike="noStrike">
               <a:solidFill>
@@ -1418,7 +1505,7 @@
                 <a:uFillTx/>
                 <a:latin typeface="Arial"/>
               </a:rPr>
-              <a:t>Situar: DSI, tercer curs, 6 ECTS.</a:t>
+              <a:t>FUNCIÓ (1:05): justificar l’encaix de la sessió en el pla docent.</a:t>
             </a:r>
             <a:endParaRPr lang="es-ES" sz="2000" b="0" u="none" strike="noStrike">
               <a:solidFill>
@@ -1445,7 +1532,7 @@
                 <a:uFillTx/>
                 <a:latin typeface="Arial"/>
               </a:rPr>
-              <a:t>Bloc: Clean Architecture i arquitectura hexagonal, ports i adaptadors, mapping, modularització i Domain-Driven Design.</a:t>
+              <a:t>Assenyalar: DSI, 3r curs i 6 ECTS.</a:t>
             </a:r>
             <a:endParaRPr lang="es-ES" sz="2000" b="0" u="none" strike="noStrike">
               <a:solidFill>
@@ -1472,7 +1559,7 @@
                 <a:uFillTx/>
                 <a:latin typeface="Arial"/>
               </a:rPr>
-              <a:t>Focus limitat: port de sortida.</a:t>
+              <a:t>Bloc: Clean Architecture, arquitectura hexagonal, ports i adaptadors, mapping, modularització i DDD.</a:t>
             </a:r>
             <a:endParaRPr lang="es-ES" sz="2000" b="0" u="none" strike="noStrike">
               <a:solidFill>
@@ -1499,7 +1586,34 @@
                 <a:uFillTx/>
                 <a:latin typeface="Arial"/>
               </a:rPr>
-              <a:t>Transició: formular l’objectiu de treball.</a:t>
+              <a:t>No fer una enumeració llarga del temari: el focus és una decisió concreta sobre ports de sortida.</a:t>
+            </a:r>
+            <a:endParaRPr lang="es-ES" sz="2000" b="0" u="none" strike="noStrike">
+              <a:solidFill>
+                <a:srgbClr val="000000"/>
+              </a:solidFill>
+              <a:effectLst/>
+              <a:uFillTx/>
+              <a:latin typeface="Arial"/>
+            </a:endParaRPr>
+          </a:p>
+          <a:p>
+            <a:pPr indent="0" algn="l">
+              <a:lnSpc>
+                <a:spcPct val="100000"/>
+              </a:lnSpc>
+              <a:buNone/>
+            </a:pPr>
+            <a:r>
+              <a:rPr lang="ca-ES" sz="2000" b="0" u="none" strike="noStrike">
+                <a:solidFill>
+                  <a:srgbClr val="000000"/>
+                </a:solidFill>
+                <a:effectLst/>
+                <a:uFillTx/>
+                <a:latin typeface="Arial"/>
+              </a:rPr>
+              <a:t>TRANSICIÓ: «Amb aquest context, formulem l’objectiu mínim de la sessió.»</a:t>
             </a:r>
             <a:endParaRPr lang="es-ES" sz="2000" b="0" u="none" strike="noStrike">
               <a:solidFill>
@@ -1676,7 +1790,7 @@
                 <a:uFillTx/>
                 <a:latin typeface="Arial"/>
               </a:rPr>
-              <a:t>Frase clau: capacitat funcional, no tecnologia específica.</a:t>
+              <a:t>FUNCIÓ (0:55): diapositiva pont; passar-hi ràpid i no anticipar tota la teoria.</a:t>
             </a:r>
             <a:endParaRPr lang="es-ES" sz="2000" b="0" u="none" strike="noStrike">
               <a:solidFill>
@@ -1703,7 +1817,7 @@
                 <a:uFillTx/>
                 <a:latin typeface="Arial"/>
               </a:rPr>
-              <a:t>Tres decisions: identificar necessitat, definir port, implementar adaptador.</a:t>
+              <a:t>FRASE CLAU, mirant el tribunal: «El cas d’ús necessita una capacitat, no una tecnologia.»</a:t>
             </a:r>
             <a:endParaRPr lang="es-ES" sz="2000" b="0" u="none" strike="noStrike">
               <a:solidFill>
@@ -1730,7 +1844,7 @@
                 <a:uFillTx/>
                 <a:latin typeface="Arial"/>
               </a:rPr>
-              <a:t>No explicar encara tota l’abstracció.</a:t>
+              <a:t>Assenyalar les tres decisions: identificar necessitat, definir port i implementar adaptador(s).</a:t>
             </a:r>
             <a:endParaRPr lang="es-ES" sz="2000" b="0" u="none" strike="noStrike">
               <a:solidFill>
@@ -1757,7 +1871,7 @@
                 <a:uFillTx/>
                 <a:latin typeface="Arial"/>
               </a:rPr>
-              <a:t>Primer cas real, després decisió arquitectònica.</a:t>
+              <a:t>Metodologia: primer el cas real; després, l’abstracció arquitectònica.</a:t>
             </a:r>
             <a:endParaRPr lang="es-ES" sz="2000" b="0" u="none" strike="noStrike">
               <a:solidFill>
@@ -1784,7 +1898,7 @@
                 <a:uFillTx/>
                 <a:latin typeface="Arial"/>
               </a:rPr>
-              <a:t>Transició: procediment administratiu de beca.</a:t>
+              <a:t>TRANSICIÓ: «Comencem, per tant, pel procediment de beca.»</a:t>
             </a:r>
             <a:endParaRPr lang="es-ES" sz="2000" b="0" u="none" strike="noStrike">
               <a:solidFill>
@@ -1961,7 +2075,7 @@
                 <a:uFillTx/>
                 <a:latin typeface="Arial"/>
               </a:rPr>
-              <a:t>Primer entendre el procediment; després la tecnologia.</a:t>
+              <a:t>FUNCIÓ (1:45): establir el problema funcional abans de parlar de tecnologia.</a:t>
             </a:r>
             <a:endParaRPr lang="es-ES" sz="2000" b="0" u="none" strike="noStrike">
               <a:solidFill>
@@ -1988,7 +2102,7 @@
                 <a:uFillTx/>
                 <a:latin typeface="Arial"/>
               </a:rPr>
-              <a:t>Sol·licitud -&gt; expedient -&gt; requisits -&gt; resolució.</a:t>
+              <a:t>Assenyalar la seqüència: sol·licitud, expedient, requisits, revisió i resolució.</a:t>
             </a:r>
             <a:endParaRPr lang="es-ES" sz="2000" b="0" u="none" strike="noStrike">
               <a:solidFill>
@@ -2015,7 +2129,7 @@
                 <a:uFillTx/>
                 <a:latin typeface="Arial"/>
               </a:rPr>
-              <a:t>Avaluació econòmica: renda i patrimoni.</a:t>
+              <a:t>Focus: l’avaluació econòmica necessita renda i patrimoni fiables.</a:t>
             </a:r>
             <a:endParaRPr lang="es-ES" sz="2000" b="0" u="none" strike="noStrike">
               <a:solidFill>
@@ -2042,7 +2156,7 @@
                 <a:uFillTx/>
                 <a:latin typeface="Arial"/>
               </a:rPr>
-              <a:t>Encara no parlar de SOAP, XML, REST o BD.</a:t>
+              <a:t>NO OBLIDAR: la decisió administrativa i el mecanisme tècnic són nivells diferents.</a:t>
             </a:r>
             <a:endParaRPr lang="es-ES" sz="2000" b="0" u="none" strike="noStrike">
               <a:solidFill>
@@ -2069,7 +2183,34 @@
                 <a:uFillTx/>
                 <a:latin typeface="Arial"/>
               </a:rPr>
-              <a:t>Transició: quina informació externa cal?</a:t>
+              <a:t>Evitar encara SOAP, REST, PICA o bases de dades.</a:t>
+            </a:r>
+            <a:endParaRPr lang="es-ES" sz="2000" b="0" u="none" strike="noStrike">
+              <a:solidFill>
+                <a:srgbClr val="000000"/>
+              </a:solidFill>
+              <a:effectLst/>
+              <a:uFillTx/>
+              <a:latin typeface="Arial"/>
+            </a:endParaRPr>
+          </a:p>
+          <a:p>
+            <a:pPr indent="0" algn="l">
+              <a:lnSpc>
+                <a:spcPct val="100000"/>
+              </a:lnSpc>
+              <a:buNone/>
+            </a:pPr>
+            <a:r>
+              <a:rPr lang="ca-ES" sz="2000" b="0" u="none" strike="noStrike">
+                <a:solidFill>
+                  <a:srgbClr val="000000"/>
+                </a:solidFill>
+                <a:effectLst/>
+                <a:uFillTx/>
+                <a:latin typeface="Arial"/>
+              </a:rPr>
+              <a:t>TRANSICIÓ: «Quina informació externa necessita el procediment per prendre aquesta decisió?»</a:t>
             </a:r>
             <a:endParaRPr lang="es-ES" sz="2000" b="0" u="none" strike="noStrike">
               <a:solidFill>
@@ -2246,7 +2387,7 @@
                 <a:uFillTx/>
                 <a:latin typeface="Arial"/>
               </a:rPr>
-              <a:t>Necessitat funcional: informació fiable de renda i patrimoni.</a:t>
+              <a:t>FUNCIÓ (1:45): separar necessitat funcional, font administrativa i canal d’interoperabilitat.</a:t>
             </a:r>
             <a:endParaRPr lang="es-ES" sz="2000" b="0" u="none" strike="noStrike">
               <a:solidFill>
@@ -2273,7 +2414,7 @@
                 <a:uFillTx/>
                 <a:latin typeface="Arial"/>
               </a:rPr>
-              <a:t>Fonts administratives: AEAT i Cadastre.</a:t>
+              <a:t>Necessitats: renda, patrimoni i béns immobles. Fonts: AEAT i Cadastre. Canal: PICA.</a:t>
             </a:r>
             <a:endParaRPr lang="es-ES" sz="2000" b="0" u="none" strike="noStrike">
               <a:solidFill>
@@ -2300,7 +2441,7 @@
                 <a:uFillTx/>
                 <a:latin typeface="Arial"/>
               </a:rPr>
-              <a:t>Canal o plataforma d’interoperabilitat: PICA.</a:t>
+              <a:t>NO OBLIDAR: PICA no és una font original del mateix tipus que AEAT o Cadastre.</a:t>
             </a:r>
             <a:endParaRPr lang="es-ES" sz="2000" b="0" u="none" strike="noStrike">
               <a:solidFill>
@@ -2327,7 +2468,7 @@
                 <a:uFillTx/>
                 <a:latin typeface="Arial"/>
               </a:rPr>
-              <a:t>No presentar PICA com a font original del mateix tipus.</a:t>
+              <a:t>FRASE CLAU, amb pausa: «El procediment necessita informació administrativa, no una API concreta.»</a:t>
             </a:r>
             <a:endParaRPr lang="es-ES" sz="2000" b="0" u="none" strike="noStrike">
               <a:solidFill>
@@ -2354,34 +2495,7 @@
                 <a:uFillTx/>
                 <a:latin typeface="Arial"/>
               </a:rPr>
-              <a:t>Frase clau: informació administrativa, no API concreta.</a:t>
-            </a:r>
-            <a:endParaRPr lang="es-ES" sz="2000" b="0" u="none" strike="noStrike">
-              <a:solidFill>
-                <a:srgbClr val="000000"/>
-              </a:solidFill>
-              <a:effectLst/>
-              <a:uFillTx/>
-              <a:latin typeface="Arial"/>
-            </a:endParaRPr>
-          </a:p>
-          <a:p>
-            <a:pPr indent="0" algn="l">
-              <a:lnSpc>
-                <a:spcPct val="100000"/>
-              </a:lnSpc>
-              <a:buNone/>
-            </a:pPr>
-            <a:r>
-              <a:rPr lang="ca-ES" sz="2000" b="0" u="none" strike="noStrike">
-                <a:solidFill>
-                  <a:srgbClr val="000000"/>
-                </a:solidFill>
-                <a:effectLst/>
-                <a:uFillTx/>
-                <a:latin typeface="Arial"/>
-              </a:rPr>
-              <a:t>Transició: què passa si el cas d’ús coneix la integració?</a:t>
+              <a:t>TRANSICIÓ: «Quan aquesta separació no es respecta, apareix el problema arquitectònic.»</a:t>
             </a:r>
             <a:endParaRPr lang="es-ES" sz="2000" b="0" u="none" strike="noStrike">
               <a:solidFill>
@@ -2558,7 +2672,7 @@
                 <a:uFillTx/>
                 <a:latin typeface="Arial"/>
               </a:rPr>
-              <a:t>Problema: acoblament directe amb detalls tècnics.</a:t>
+              <a:t>FUNCIÓ (2:20): diagnosticar una cadena causal, no enumerar tres riscos independents.</a:t>
             </a:r>
             <a:endParaRPr lang="es-ES" sz="2000" b="0" u="none" strike="noStrike">
               <a:solidFill>
@@ -2585,7 +2699,7 @@
                 <a:uFillTx/>
                 <a:latin typeface="Arial"/>
               </a:rPr>
-              <a:t>La cadena SOAP/XML -&gt; PICA -&gt; AEAT i/o Cadastre és el problema, no la solució.</a:t>
+              <a:t>Assenyalar d’esquerra a dreta: CAUSA (acoblament) → PROPAGACIÓ (el canvi travessa la frontera) → CONSEQÜÈNCIA (més codi afectat i manteniment més fràgil).</a:t>
             </a:r>
             <a:endParaRPr lang="es-ES" sz="2000" b="0" u="none" strike="noStrike">
               <a:solidFill>
@@ -2612,7 +2726,7 @@
                 <a:uFillTx/>
                 <a:latin typeface="Arial"/>
               </a:rPr>
-              <a:t>El cas d’ús acaba coneixent SOAP/XML, DTOs, clients i errors.</a:t>
+              <a:t>Idea: un únic acoblament converteix el canvi d’infraestructura en un canvi que arriba al procediment.</a:t>
             </a:r>
             <a:endParaRPr lang="es-ES" sz="2000" b="0" u="none" strike="noStrike">
               <a:solidFill>
@@ -2639,7 +2753,7 @@
                 <a:uFillTx/>
                 <a:latin typeface="Arial"/>
               </a:rPr>
-              <a:t>Si canvia la integració, el canvi travessa el cas d’ús.</a:t>
+              <a:t>NO OBLIDAR: el problema no és PICA; és la dependència directa dels seus detalls tècnics.</a:t>
             </a:r>
             <a:endParaRPr lang="es-ES" sz="2000" b="0" u="none" strike="noStrike">
               <a:solidFill>
@@ -2666,7 +2780,7 @@
                 <a:uFillTx/>
                 <a:latin typeface="Arial"/>
               </a:rPr>
-              <a:t>Riscos: manteniment fràgil i més superfície d’impacte davant canvis externs.</a:t>
+              <a:t>PREGUNTA DOCENT, literal: «Com podem permetre que el cas d’ús necessiti dades externes, però sense dependre directament de la tecnologia que les proporciona?»</a:t>
             </a:r>
             <a:endParaRPr lang="es-ES" sz="2000" b="0" u="none" strike="noStrike">
               <a:solidFill>
@@ -2693,7 +2807,7 @@
                 <a:uFillTx/>
                 <a:latin typeface="Arial"/>
               </a:rPr>
-              <a:t>Transició: resposta arquitectònica, port de sortida.</a:t>
+              <a:t>PAUSA. TRANSICIÓ: «La resposta és introduir un port de sortida.»</a:t>
             </a:r>
             <a:endParaRPr lang="es-ES" sz="2000" b="0" u="none" strike="noStrike">
               <a:solidFill>
@@ -2870,7 +2984,7 @@
                 <a:uFillTx/>
                 <a:latin typeface="Arial"/>
               </a:rPr>
-              <a:t>Distingir dues fletxes: flux i dependència de codi.</a:t>
+              <a:t>FUNCIÓ (2:20): frontissa conceptual forta; baixar el ritme.</a:t>
             </a:r>
             <a:endParaRPr lang="es-ES" sz="2000" b="0" u="none" strike="noStrike">
               <a:solidFill>
@@ -2897,7 +3011,7 @@
                 <a:uFillTx/>
                 <a:latin typeface="Arial"/>
               </a:rPr>
-              <a:t>Flux: el cas d’ús demana informació cap enfora.</a:t>
+              <a:t>Primera línia: flux d’execució, del cas d’ús cap al sistema extern.</a:t>
             </a:r>
             <a:endParaRPr lang="es-ES" sz="2000" b="0" u="none" strike="noStrike">
               <a:solidFill>
@@ -2924,7 +3038,7 @@
                 <a:uFillTx/>
                 <a:latin typeface="Arial"/>
               </a:rPr>
-              <a:t>Dependència: cas d’ús -&gt; port; adaptador -&gt; port.</a:t>
+              <a:t>Segona línia: dependència de codi; el cas d’ús depèn del port i l’adaptador implementa el port.</a:t>
             </a:r>
             <a:endParaRPr lang="es-ES" sz="2000" b="0" u="none" strike="noStrike">
               <a:solidFill>
@@ -2951,7 +3065,7 @@
                 <a:uFillTx/>
                 <a:latin typeface="Arial"/>
               </a:rPr>
-              <a:t>Conceptualment, el port és un contracte; en Java, aquí s’expressa com una interfície.</a:t>
+              <a:t>Assenyalar el mini-UML: el port és un contracte; en Java el representem amb una interfície.</a:t>
             </a:r>
             <a:endParaRPr lang="es-ES" sz="2000" b="0" u="none" strike="noStrike">
               <a:solidFill>
@@ -2978,7 +3092,7 @@
                 <a:uFillTx/>
                 <a:latin typeface="Arial"/>
               </a:rPr>
-              <a:t>L’adaptador implementa aquesta interfície.</a:t>
+              <a:t>FRASE CLAU: «El servei usa el port; l’adaptador implementa el port.»</a:t>
             </a:r>
             <a:endParaRPr lang="es-ES" sz="2000" b="0" u="none" strike="noStrike">
               <a:solidFill>
@@ -3005,7 +3119,7 @@
                 <a:uFillTx/>
                 <a:latin typeface="Arial"/>
               </a:rPr>
-              <a:t>Frase clau: la infraestructura depèn del port de l’aplicació.</a:t>
+              <a:t>Inversió: la infraestructura depèn del port definit per l’aplicació.</a:t>
             </a:r>
             <a:endParaRPr lang="es-ES" sz="2000" b="0" u="none" strike="noStrike">
               <a:solidFill>
@@ -3032,7 +3146,7 @@
                 <a:uFillTx/>
                 <a:latin typeface="Arial"/>
               </a:rPr>
-              <a:t>Transició: aplicar-ho a la necessitat d’informació econòmica.</a:t>
+              <a:t>TRANSICIÓ: «Apliquem ara aquesta distinció a la informació patrimonial.»</a:t>
             </a:r>
             <a:endParaRPr lang="es-ES" sz="2000" b="0" u="none" strike="noStrike">
               <a:solidFill>
@@ -3209,7 +3323,7 @@
                 <a:uFillTx/>
                 <a:latin typeface="Arial"/>
               </a:rPr>
-              <a:t>Servei d’aplicació depèn de contractes propis.</a:t>
+              <a:t>FUNCIÓ (1:45): aplicar la distinció al cas administratiu.</a:t>
             </a:r>
             <a:endParaRPr lang="es-ES" sz="2000" b="0" u="none" strike="noStrike">
               <a:solidFill>
@@ -3236,7 +3350,7 @@
                 <a:uFillTx/>
                 <a:latin typeface="Arial"/>
               </a:rPr>
-              <a:t>Ports dins del llenguatge de l’aplicació.</a:t>
+              <a:t>Nucli: servei d’aplicació i domini; el servei depèn de contractes propis.</a:t>
             </a:r>
             <a:endParaRPr lang="es-ES" sz="2000" b="0" u="none" strike="noStrike">
               <a:solidFill>
@@ -3263,7 +3377,7 @@
                 <a:uFillTx/>
                 <a:latin typeface="Arial"/>
               </a:rPr>
-              <a:t>Adaptadors fora del nucli: PICA, JDBC, REST, SOAP/XML.</a:t>
+              <a:t>Exterior: adaptadors PICA/JDBC i mecanismes SOAP/XML o REST.</a:t>
             </a:r>
             <a:endParaRPr lang="es-ES" sz="2000" b="0" u="none" strike="noStrike">
               <a:solidFill>
@@ -3290,7 +3404,7 @@
                 <a:uFillTx/>
                 <a:latin typeface="Arial"/>
               </a:rPr>
-              <a:t>Fletxa important: l’adaptador implementa el port.</a:t>
+              <a:t>Llegir bé les fletxes: el servei usa el port; l’adaptador implementa el port.</a:t>
             </a:r>
             <a:endParaRPr lang="es-ES" sz="2000" b="0" u="none" strike="noStrike">
               <a:solidFill>
@@ -3317,7 +3431,34 @@
                 <a:uFillTx/>
                 <a:latin typeface="Arial"/>
               </a:rPr>
-              <a:t>Transició: mateix patró, canvi de domini.</a:t>
+              <a:t>NO OBLIDAR: el domini no coneix ni PICA ni els adaptadors.</a:t>
+            </a:r>
+            <a:endParaRPr lang="es-ES" sz="2000" b="0" u="none" strike="noStrike">
+              <a:solidFill>
+                <a:srgbClr val="000000"/>
+              </a:solidFill>
+              <a:effectLst/>
+              <a:uFillTx/>
+              <a:latin typeface="Arial"/>
+            </a:endParaRPr>
+          </a:p>
+          <a:p>
+            <a:pPr indent="0" algn="l">
+              <a:lnSpc>
+                <a:spcPct val="100000"/>
+              </a:lnSpc>
+              <a:buNone/>
+            </a:pPr>
+            <a:r>
+              <a:rPr lang="ca-ES" sz="2000" b="0" u="none" strike="noStrike">
+                <a:solidFill>
+                  <a:srgbClr val="000000"/>
+                </a:solidFill>
+                <a:effectLst/>
+                <a:uFillTx/>
+                <a:latin typeface="Arial"/>
+              </a:rPr>
+              <a:t>TRANSICIÓ: «Transferim la mateixa decisió arquitectònica a un domini financer.»</a:t>
             </a:r>
             <a:endParaRPr lang="es-ES" sz="2000" b="0" u="none" strike="noStrike">
               <a:solidFill>
@@ -3494,7 +3635,7 @@
                 <a:uFillTx/>
                 <a:latin typeface="Arial"/>
               </a:rPr>
-              <a:t>Canvi explícit: beca -&gt; cartera d’inversió personal. Cas d’ús: vendre accions. Necessitat: preu actual de l’acció. Port de sortida: StockPriceProviderPort. Separar proveïdor de dades, API concreta, contracte tècnic i adaptador. Servei d’aplicació coordina consulta del preu i recuperació de cartera. Domini decideix; adaptador integra. Transició: conclusió tècnica.</a:t>
+              <a:t>FUNCIÓ (1:25): demostrar que la decisió es transfereix entre dominis.</a:t>
             </a:r>
             <a:endParaRPr lang="es-ES" sz="2000" b="0" u="none" strike="noStrike">
               <a:solidFill>
@@ -3512,6 +3653,17 @@
               </a:lnSpc>
               <a:buNone/>
             </a:pPr>
+            <a:r>
+              <a:rPr lang="ca-ES" sz="2000" b="0" u="none" strike="noStrike">
+                <a:solidFill>
+                  <a:srgbClr val="000000"/>
+                </a:solidFill>
+                <a:effectLst/>
+                <a:uFillTx/>
+                <a:latin typeface="Arial"/>
+              </a:rPr>
+              <a:t>Canvi explícit: beca → cartera d’inversió personal.</a:t>
+            </a:r>
             <a:endParaRPr lang="es-ES" sz="2000" b="0" u="none" strike="noStrike">
               <a:solidFill>
                 <a:srgbClr val="000000"/>
@@ -3528,6 +3680,17 @@
               </a:lnSpc>
               <a:buNone/>
             </a:pPr>
+            <a:r>
+              <a:rPr lang="ca-ES" sz="2000" b="0" u="none" strike="noStrike">
+                <a:solidFill>
+                  <a:srgbClr val="000000"/>
+                </a:solidFill>
+                <a:effectLst/>
+                <a:uFillTx/>
+                <a:latin typeface="Arial"/>
+              </a:rPr>
+              <a:t>Cas d’ús: vendre accions. Necessitat: preu actual. Port: StockPriceProviderPort.</a:t>
+            </a:r>
             <a:endParaRPr lang="es-ES" sz="2000" b="0" u="none" strike="noStrike">
               <a:solidFill>
                 <a:srgbClr val="000000"/>
@@ -3544,6 +3707,17 @@
               </a:lnSpc>
               <a:buNone/>
             </a:pPr>
+            <a:r>
+              <a:rPr lang="ca-ES" sz="2000" b="0" u="none" strike="noStrike">
+                <a:solidFill>
+                  <a:srgbClr val="000000"/>
+                </a:solidFill>
+                <a:effectLst/>
+                <a:uFillTx/>
+                <a:latin typeface="Arial"/>
+              </a:rPr>
+              <a:t>Finnhub, Alpha Vantage o mock són adaptadors que encapsulen APIs concretes.</a:t>
+            </a:r>
             <a:endParaRPr lang="es-ES" sz="2000" b="0" u="none" strike="noStrike">
               <a:solidFill>
                 <a:srgbClr val="000000"/>
@@ -3560,6 +3734,17 @@
               </a:lnSpc>
               <a:buNone/>
             </a:pPr>
+            <a:r>
+              <a:rPr lang="ca-ES" sz="2000" b="0" u="none" strike="noStrike">
+                <a:solidFill>
+                  <a:srgbClr val="000000"/>
+                </a:solidFill>
+                <a:effectLst/>
+                <a:uFillTx/>
+                <a:latin typeface="Arial"/>
+              </a:rPr>
+              <a:t>FRASE CLAU: «El servei coordina; el domini decideix; l’adaptador integra.»</a:t>
+            </a:r>
             <a:endParaRPr lang="es-ES" sz="2000" b="0" u="none" strike="noStrike">
               <a:solidFill>
                 <a:srgbClr val="000000"/>
@@ -3576,6 +3761,44 @@
               </a:lnSpc>
               <a:buNone/>
             </a:pPr>
+            <a:r>
+              <a:rPr lang="ca-ES" sz="2000" b="0" u="none" strike="noStrike">
+                <a:solidFill>
+                  <a:srgbClr val="000000"/>
+                </a:solidFill>
+                <a:effectLst/>
+                <a:uFillTx/>
+                <a:latin typeface="Arial"/>
+              </a:rPr>
+              <a:t>Matís: la substitució exigeix preservar el contracte funcional i la semàntica.</a:t>
+            </a:r>
+            <a:endParaRPr lang="es-ES" sz="2000" b="0" u="none" strike="noStrike">
+              <a:solidFill>
+                <a:srgbClr val="000000"/>
+              </a:solidFill>
+              <a:effectLst/>
+              <a:uFillTx/>
+              <a:latin typeface="Arial"/>
+            </a:endParaRPr>
+          </a:p>
+          <a:p>
+            <a:pPr indent="0" algn="l">
+              <a:lnSpc>
+                <a:spcPct val="100000"/>
+              </a:lnSpc>
+              <a:buNone/>
+            </a:pPr>
+            <a:r>
+              <a:rPr lang="ca-ES" sz="2000" b="0" u="none" strike="noStrike">
+                <a:solidFill>
+                  <a:srgbClr val="000000"/>
+                </a:solidFill>
+                <a:effectLst/>
+                <a:uFillTx/>
+                <a:latin typeface="Arial"/>
+              </a:rPr>
+              <a:t>TRANSICIÓ: «Canvia el domini, però es manté la decisió arquitectònica.»</a:t>
+            </a:r>
             <a:endParaRPr lang="es-ES" sz="2000" b="0" u="none" strike="noStrike">
               <a:solidFill>
                 <a:srgbClr val="000000"/>
@@ -17247,7 +17470,7 @@
                 <a:uFillTx/>
                 <a:latin typeface="Arial"/>
               </a:rPr>
-              <a:t>Acoblament tecnològic</a:t>
+              <a:t>Causa: acoblament tecnològic</a:t>
             </a:r>
             <a:endParaRPr lang="es-ES" sz="1700" b="0" u="none" strike="noStrike">
               <a:solidFill>
@@ -17273,29 +17496,7 @@
                 <a:uFillTx/>
                 <a:latin typeface="Arial"/>
               </a:rPr>
-              <a:t>El procediment </a:t>
-            </a:r>
-            <a:r>
-              <a:rPr lang="es-ES" sz="1700" b="1" u="none" strike="noStrike">
-                <a:solidFill>
-                  <a:srgbClr val="192D3E"/>
-                </a:solidFill>
-                <a:effectLst/>
-                <a:uFillTx/>
-                <a:latin typeface="Arial"/>
-              </a:rPr>
-              <a:t>administratiu </a:t>
-            </a:r>
-            <a:r>
-              <a:rPr lang="en-US" sz="1700" b="1" u="none" strike="noStrike">
-                <a:solidFill>
-                  <a:srgbClr val="192D3E"/>
-                </a:solidFill>
-                <a:effectLst/>
-                <a:uFillTx/>
-                <a:latin typeface="Arial"/>
-              </a:rPr>
-              <a:t>depèn de SOAP/PICA</a:t>
+              <a:t>El cas d’ús coneix SOAP/XML i detalls de PICA</a:t>
             </a:r>
             <a:endParaRPr lang="es-ES" sz="1700" b="0" u="none" strike="noStrike">
               <a:solidFill>
@@ -17414,7 +17615,7 @@
                 <a:uFillTx/>
                 <a:latin typeface="Arial"/>
               </a:rPr>
-              <a:t>Impacte en el cas d’ús</a:t>
+              <a:t>Propagació del canvi</a:t>
             </a:r>
             <a:endParaRPr lang="es-ES" sz="1700" b="0" u="none" strike="noStrike">
               <a:solidFill>
@@ -17440,7 +17641,7 @@
                 <a:uFillTx/>
                 <a:latin typeface="Arial"/>
               </a:rPr>
-              <a:t>L’evolució de la integració travessa la frontera</a:t>
+              <a:t>La integració travessa la frontera del cas d’ús</a:t>
             </a:r>
             <a:endParaRPr lang="es-ES" sz="1700" b="0" u="none" strike="noStrike">
               <a:solidFill>
@@ -17551,7 +17752,7 @@
           <a:lstStyle/>
           <a:p>
             <a:r>
-              <a:rPr lang="en-US" sz="1700" b="1" u="none" strike="noStrike">
+              <a:rPr lang="en-US" sz="1700" b="1" u="none" strike="noStrike" dirty="0" err="1">
                 <a:solidFill>
                   <a:srgbClr val="192D3E"/>
                 </a:solidFill>
@@ -17559,25 +17760,10 @@
                 <a:uFillTx/>
                 <a:latin typeface="Arial"/>
               </a:rPr>
-              <a:t>Més superfície d'impacte</a:t>
-            </a:r>
-            <a:endParaRPr lang="es-ES" sz="1700" b="0" u="none" strike="noStrike">
-              <a:solidFill>
-                <a:srgbClr val="000000"/>
-              </a:solidFill>
-              <a:effectLst/>
-              <a:uFillTx/>
-              <a:latin typeface="Arial"/>
-            </a:endParaRPr>
-          </a:p>
-          <a:p>
-            <a:pPr algn="ctr" defTabSz="457200">
-              <a:lnSpc>
-                <a:spcPct val="100000"/>
-              </a:lnSpc>
-            </a:pPr>
-            <a:r>
-              <a:rPr lang="en-US" sz="1700" b="1" u="none" strike="noStrike">
+              <a:t>Conseqüència</a:t>
+            </a:r>
+            <a:r>
+              <a:rPr lang="en-US" sz="1700" b="1" u="none" strike="noStrike" dirty="0">
                 <a:solidFill>
                   <a:srgbClr val="192D3E"/>
                 </a:solidFill>
@@ -17585,9 +17771,54 @@
                 <a:uFillTx/>
                 <a:latin typeface="Arial"/>
               </a:rPr>
-              <a:t>Manteniment més fràgil del servei</a:t>
-            </a:r>
-            <a:endParaRPr lang="es-ES" sz="1700" b="0" u="none" strike="noStrike">
+              <a:t>: </a:t>
+            </a:r>
+            <a:r>
+              <a:rPr lang="en-US" sz="1700" b="1" dirty="0" err="1">
+                <a:solidFill>
+                  <a:srgbClr val="192D3E"/>
+                </a:solidFill>
+                <a:latin typeface="Arial"/>
+              </a:rPr>
+              <a:t>dificultat</a:t>
+            </a:r>
+            <a:r>
+              <a:rPr lang="en-US" sz="1700" b="1" dirty="0">
+                <a:solidFill>
+                  <a:srgbClr val="192D3E"/>
+                </a:solidFill>
+                <a:latin typeface="Arial"/>
+              </a:rPr>
+              <a:t> </a:t>
+            </a:r>
+            <a:r>
+              <a:rPr lang="en-US" sz="1700" b="1" dirty="0" err="1">
+                <a:solidFill>
+                  <a:srgbClr val="192D3E"/>
+                </a:solidFill>
+                <a:latin typeface="Arial"/>
+              </a:rPr>
+              <a:t>manteniment</a:t>
+            </a:r>
+            <a:r>
+              <a:rPr lang="en-US" sz="1700" b="1" dirty="0">
+                <a:solidFill>
+                  <a:srgbClr val="192D3E"/>
+                </a:solidFill>
+                <a:latin typeface="Arial"/>
+              </a:rPr>
+              <a:t> del </a:t>
+            </a:r>
+            <a:r>
+              <a:rPr lang="en-US" sz="1700" b="1" dirty="0" err="1">
+                <a:solidFill>
+                  <a:srgbClr val="192D3E"/>
+                </a:solidFill>
+                <a:latin typeface="Arial"/>
+              </a:rPr>
+              <a:t>codi</a:t>
+            </a:r>
+            <a:endParaRPr lang="es-ES" sz="1700" b="0" u="none" strike="noStrike" dirty="0">
               <a:solidFill>
                 <a:srgbClr val="000000"/>
               </a:solidFill>

</xml_diff>

<commit_message>
Insereix la diapositiva de context al deck de 20 minuts i renumera el guió
La portada queda només com a salutació i títol (0:20) i la nova
diapositiva 2, «Una trobada entre dos mons», mostra el context AGAUR,
les dimensions acadèmica i professional i el focus de la sessió (1:15).
Renumera diapositives i referències del guió oral de 2-11 a 3-12,
actualitza AGENTS.md i regenera tots els materials derivats.
</commit_message>
<xml_diff>
--- a/doc/presentations/defensa-placa-permanent-dsi-ports-sortida-hexagonal/output/IMPORTANTE_MANUAL_defensa-dsi-ports-sortida-hexagonal.pptx
+++ b/doc/presentations/defensa-placa-permanent-dsi-ports-sortida-hexagonal/output/IMPORTANTE_MANUAL_defensa-dsi-ports-sortida-hexagonal.pptx
@@ -9,6 +9,7 @@
   </p:notesMasterIdLst>
   <p:sldIdLst>
     <p:sldId id="256" r:id="rId2"/>
+    <p:sldId id="270" r:id="rId19"/>
     <p:sldId id="257" r:id="rId3"/>
     <p:sldId id="258" r:id="rId4"/>
     <p:sldId id="259" r:id="rId5"/>
@@ -633,166 +634,19 @@
           </a:bodyPr>
           <a:lstStyle/>
           <a:p>
-            <a:pPr indent="0" algn="l">
-              <a:lnSpc>
-                <a:spcPct val="100000"/>
-              </a:lnSpc>
-              <a:buNone/>
-            </a:pPr>
-            <a:r>
-              <a:rPr lang="ca-ES" sz="2000" b="0" u="none" strike="noStrike">
-                <a:solidFill>
-                  <a:srgbClr val="000000"/>
-                </a:solidFill>
-                <a:effectLst/>
-                <a:uFillTx/>
-                <a:latin typeface="Arial"/>
-              </a:rPr>
-              <a:t>FUNCIÓ (1:35): obrir la microlliçó i delimitar-ne el focus.</a:t>
-            </a:r>
-            <a:endParaRPr lang="es-ES" sz="2000" b="0" u="none" strike="noStrike">
-              <a:solidFill>
-                <a:srgbClr val="000000"/>
-              </a:solidFill>
-              <a:effectLst/>
-              <a:uFillTx/>
-              <a:latin typeface="Arial"/>
-            </a:endParaRPr>
-          </a:p>
-          <a:p>
-            <a:pPr indent="0" algn="l">
-              <a:lnSpc>
-                <a:spcPct val="100000"/>
-              </a:lnSpc>
-              <a:buNone/>
-            </a:pPr>
-            <a:r>
-              <a:rPr lang="ca-ES" sz="2000" b="0" u="none" strike="noStrike">
-                <a:solidFill>
-                  <a:srgbClr val="000000"/>
-                </a:solidFill>
-                <a:effectLst/>
-                <a:uFillTx/>
-                <a:latin typeface="Arial"/>
-              </a:rPr>
-              <a:t>Context: classe de DSI i cas real acreditat de consultoria per a la Generalitat/AGAUR.</a:t>
-            </a:r>
-            <a:endParaRPr lang="es-ES" sz="2000" b="0" u="none" strike="noStrike">
-              <a:solidFill>
-                <a:srgbClr val="000000"/>
-              </a:solidFill>
-              <a:effectLst/>
-              <a:uFillTx/>
-              <a:latin typeface="Arial"/>
-            </a:endParaRPr>
-          </a:p>
-          <a:p>
-            <a:pPr indent="0" algn="l">
-              <a:lnSpc>
-                <a:spcPct val="100000"/>
-              </a:lnSpc>
-              <a:buNone/>
-            </a:pPr>
-            <a:r>
-              <a:rPr lang="ca-ES" sz="2000" b="0" u="none" strike="noStrike">
-                <a:solidFill>
-                  <a:srgbClr val="000000"/>
-                </a:solidFill>
-                <a:effectLst/>
-                <a:uFillTx/>
-                <a:latin typeface="Arial"/>
-              </a:rPr>
-              <a:t>Missatge: trobada entre dimensió acadèmica i professional, sense detalls interns.</a:t>
-            </a:r>
-            <a:endParaRPr lang="es-ES" sz="2000" b="0" u="none" strike="noStrike">
-              <a:solidFill>
-                <a:srgbClr val="000000"/>
-              </a:solidFill>
-              <a:effectLst/>
-              <a:uFillTx/>
-              <a:latin typeface="Arial"/>
-            </a:endParaRPr>
-          </a:p>
-          <a:p>
-            <a:pPr indent="0" algn="l">
-              <a:lnSpc>
-                <a:spcPct val="100000"/>
-              </a:lnSpc>
-              <a:buNone/>
-            </a:pPr>
-            <a:r>
-              <a:rPr lang="ca-ES" sz="2000" b="0" u="none" strike="noStrike">
-                <a:solidFill>
-                  <a:srgbClr val="000000"/>
-                </a:solidFill>
-                <a:effectLst/>
-                <a:uFillTx/>
-                <a:latin typeface="Arial"/>
-              </a:rPr>
-              <a:t>NO OBLIDAR: no és una panoràmica completa de l’arquitectura hexagonal.</a:t>
-            </a:r>
-            <a:endParaRPr lang="es-ES" sz="2000" b="0" u="none" strike="noStrike">
-              <a:solidFill>
-                <a:srgbClr val="000000"/>
-              </a:solidFill>
-              <a:effectLst/>
-              <a:uFillTx/>
-              <a:latin typeface="Arial"/>
-            </a:endParaRPr>
-          </a:p>
-          <a:p>
-            <a:pPr indent="0" algn="l">
-              <a:lnSpc>
-                <a:spcPct val="100000"/>
-              </a:lnSpc>
-              <a:buNone/>
-            </a:pPr>
-            <a:r>
-              <a:rPr lang="ca-ES" sz="2000" b="0" u="none" strike="noStrike">
-                <a:solidFill>
-                  <a:srgbClr val="000000"/>
-                </a:solidFill>
-                <a:effectLst/>
-                <a:uFillTx/>
-                <a:latin typeface="Arial"/>
-              </a:rPr>
-              <a:t>Frase de focus: dissenyar un port de sortida quan el cas d’ús necessita informació externa.</a:t>
-            </a:r>
-            <a:endParaRPr lang="es-ES" sz="2000" b="0" u="none" strike="noStrike">
-              <a:solidFill>
-                <a:srgbClr val="000000"/>
-              </a:solidFill>
-              <a:effectLst/>
-              <a:uFillTx/>
-              <a:latin typeface="Arial"/>
-            </a:endParaRPr>
-          </a:p>
-          <a:p>
-            <a:pPr indent="0" algn="l">
-              <a:lnSpc>
-                <a:spcPct val="100000"/>
-              </a:lnSpc>
-              <a:buNone/>
-            </a:pPr>
-            <a:r>
-              <a:rPr lang="ca-ES" sz="2000" b="0" u="none" strike="noStrike">
-                <a:solidFill>
-                  <a:srgbClr val="000000"/>
-                </a:solidFill>
-                <a:effectLst/>
-                <a:uFillTx/>
-                <a:latin typeface="Arial"/>
-              </a:rPr>
-              <a:t>TRANSICIÓ: «Situem primer la sessió dins l’assignatura.»</a:t>
-            </a:r>
-            <a:endParaRPr lang="es-ES" sz="2000" b="0" u="none" strike="noStrike">
-              <a:solidFill>
-                <a:srgbClr val="000000"/>
-              </a:solidFill>
-              <a:effectLst/>
-              <a:uFillTx/>
-              <a:latin typeface="Arial"/>
-            </a:endParaRPr>
+            <a:r>
+              <a:t>FUNCIÓ (0:20): obrir la microlliçó: salutació i títol de la classe.</a:t>
+            </a:r>
+          </a:p>
+          <a:p>
+            <a:r>
+              <a:t>Assenyalar el títol; el context s’explica amb la diapositiva següent.</a:t>
+            </a:r>
+          </a:p>
+          <a:p>
+            <a:r>
+              <a:t>TRANSICIÓ: avançar a la diapositiva «Una trobada entre dos mons».</a:t>
+            </a:r>
           </a:p>
         </p:txBody>
       </p:sp>
@@ -1412,6 +1266,101 @@
             </a:endParaRPr>
           </a:p>
         </p:txBody>
+      </p:sp>
+    </p:spTree>
+  </p:cSld>
+  <p:clrMapOvr>
+    <a:masterClrMapping/>
+  </p:clrMapOvr>
+</p:notes>
+</file>
+
+<file path=ppt/notesSlides/notesSlide13.xml><?xml version="1.0" encoding="utf-8"?>
+<p:notes xmlns:a="http://schemas.openxmlformats.org/drawingml/2006/main" xmlns:p="http://schemas.openxmlformats.org/presentationml/2006/main" xmlns:r="http://schemas.openxmlformats.org/officeDocument/2006/relationships">
+  <p:cSld>
+    <p:spTree>
+      <p:nvGrpSpPr>
+        <p:cNvPr id="1" name=""/>
+        <p:cNvGrpSpPr/>
+        <p:nvPr/>
+      </p:nvGrpSpPr>
+      <p:grpSpPr>
+        <a:xfrm>
+          <a:off x="0" y="0"/>
+          <a:ext cx="0" cy="0"/>
+          <a:chOff x="0" y="0"/>
+          <a:chExt cx="0" cy="0"/>
+        </a:xfrm>
+      </p:grpSpPr>
+      <p:sp>
+        <p:nvSpPr>
+          <p:cNvPr id="2" name="Slide Image Placeholder 1"/>
+          <p:cNvSpPr>
+            <a:spLocks noGrp="1"/>
+          </p:cNvSpPr>
+          <p:nvPr>
+            <p:ph type="sldImg"/>
+          </p:nvPr>
+        </p:nvSpPr>
+        <p:spPr/>
+      </p:sp>
+      <p:sp>
+        <p:nvSpPr>
+          <p:cNvPr id="3" name="Notes Placeholder 2"/>
+          <p:cNvSpPr>
+            <a:spLocks noGrp="1"/>
+          </p:cNvSpPr>
+          <p:nvPr>
+            <p:ph type="body"/>
+          </p:nvPr>
+        </p:nvSpPr>
+        <p:spPr/>
+        <p:txBody>
+          <a:bodyPr/>
+          <a:lstStyle/>
+          <a:p>
+            <a:r>
+              <a:t>FUNCIÓ (1:15): contextualitzar la sessió i delimitar-ne el focus.</a:t>
+            </a:r>
+          </a:p>
+          <a:p>
+            <a:r>
+              <a:t>Context: classe de DSI i cas real acreditat de consultoria per a la Generalitat/AGAUR.</a:t>
+            </a:r>
+          </a:p>
+          <a:p>
+            <a:r>
+              <a:t>Missatge: trobada entre dimensió acadèmica i professional, sense detalls interns.</a:t>
+            </a:r>
+          </a:p>
+          <a:p>
+            <a:r>
+              <a:t>NO OBLIDAR: no és una panoràmica completa de l’arquitectura hexagonal.</a:t>
+            </a:r>
+          </a:p>
+          <a:p>
+            <a:r>
+              <a:t>Frase de focus: dissenyar un port de sortida quan el cas d’ús necessita informació externa.</a:t>
+            </a:r>
+          </a:p>
+          <a:p>
+            <a:r>
+              <a:t>TRANSICIÓ: «Situem primer la sessió dins l’assignatura.»</a:t>
+            </a:r>
+          </a:p>
+        </p:txBody>
+      </p:sp>
+      <p:sp>
+        <p:nvSpPr>
+          <p:cNvPr id="4" name="Slide Number Placeholder 3"/>
+          <p:cNvSpPr>
+            <a:spLocks noGrp="1"/>
+          </p:cNvSpPr>
+          <p:nvPr>
+            <p:ph type="sldNum" idx="36"/>
+          </p:nvPr>
+        </p:nvSpPr>
+        <p:spPr/>
       </p:sp>
     </p:spTree>
   </p:cSld>
@@ -12083,7 +12032,7 @@
                 </a:solidFill>
                 <a:latin typeface="Arial"/>
               </a:rPr>
-              <a:t>10</a:t>
+              <a:t>11</a:t>
             </a:r>
           </a:p>
           <a:p>
@@ -12752,7 +12701,7 @@
                 </a:solidFill>
                 <a:latin typeface="Arial"/>
               </a:rPr>
-              <a:t>11</a:t>
+              <a:t>12</a:t>
             </a:r>
           </a:p>
           <a:p>
@@ -13820,6 +13769,481 @@
 </p:sld>
 </file>
 
+<file path=ppt/slides/slide13.xml><?xml version="1.0" encoding="utf-8"?>
+<p:sld xmlns:a="http://schemas.openxmlformats.org/drawingml/2006/main" xmlns:p="http://schemas.openxmlformats.org/presentationml/2006/main" xmlns:r="http://schemas.openxmlformats.org/officeDocument/2006/relationships">
+  <p:cSld>
+    <p:spTree>
+      <p:nvGrpSpPr>
+        <p:cNvPr id="1" name=""/>
+        <p:cNvGrpSpPr/>
+        <p:nvPr/>
+      </p:nvGrpSpPr>
+      <p:grpSpPr/>
+      <p:sp>
+        <p:nvSpPr>
+          <p:cNvPr id="2" name="Title 1"/>
+          <p:cNvSpPr>
+            <a:spLocks noGrp="1"/>
+          </p:cNvSpPr>
+          <p:nvPr>
+            <p:ph type="title"/>
+          </p:nvPr>
+        </p:nvSpPr>
+        <p:spPr/>
+        <p:txBody>
+          <a:bodyPr/>
+          <a:lstStyle/>
+          <a:p/>
+        </p:txBody>
+      </p:sp>
+      <p:sp>
+        <p:nvSpPr>
+          <p:cNvPr id="3" name="Text Placeholder 2"/>
+          <p:cNvSpPr>
+            <a:spLocks noGrp="1"/>
+          </p:cNvSpPr>
+          <p:nvPr>
+            <p:ph type="body"/>
+          </p:nvPr>
+        </p:nvSpPr>
+        <p:spPr/>
+        <p:txBody>
+          <a:bodyPr/>
+          <a:lstStyle/>
+          <a:p/>
+        </p:txBody>
+      </p:sp>
+      <p:sp>
+        <p:nvSpPr>
+          <p:cNvPr id="4" name="Titol"/>
+          <p:cNvSpPr txBox="1"/>
+          <p:nvPr/>
+        </p:nvSpPr>
+        <p:spPr>
+          <a:xfrm>
+            <a:off x="594360" y="320040"/>
+            <a:ext cx="8961120" cy="502920"/>
+          </a:xfrm>
+          <a:prstGeom prst="rect">
+            <a:avLst/>
+          </a:prstGeom>
+          <a:noFill/>
+        </p:spPr>
+        <p:txBody>
+          <a:bodyPr wrap="square" lIns="90000" tIns="45000" rIns="90000" bIns="45000">
+            <a:spAutoFit/>
+          </a:bodyPr>
+          <a:lstStyle/>
+          <a:p>
+            <a:pPr/>
+            <a:r>
+              <a:rPr sz="2800" b="1" lang="ca-ES">
+                <a:solidFill>
+                  <a:srgbClr val="192D3E"/>
+                </a:solidFill>
+                <a:latin typeface="Arial"/>
+              </a:rPr>
+              <a:t>Una trobada entre dos mons</a:t>
+            </a:r>
+          </a:p>
+        </p:txBody>
+      </p:sp>
+      <p:sp>
+        <p:nvSpPr>
+          <p:cNvPr id="5" name="Subtitol"/>
+          <p:cNvSpPr txBox="1"/>
+          <p:nvPr/>
+        </p:nvSpPr>
+        <p:spPr>
+          <a:xfrm>
+            <a:off x="612648" y="822960"/>
+            <a:ext cx="8869680" cy="320040"/>
+          </a:xfrm>
+          <a:prstGeom prst="rect">
+            <a:avLst/>
+          </a:prstGeom>
+          <a:noFill/>
+        </p:spPr>
+        <p:txBody>
+          <a:bodyPr wrap="square" lIns="90000" tIns="45000" rIns="90000" bIns="45000">
+            <a:spAutoFit/>
+          </a:bodyPr>
+          <a:lstStyle/>
+          <a:p>
+            <a:pPr/>
+            <a:r>
+              <a:rPr sz="1300" b="0" lang="ca-ES">
+                <a:solidFill>
+                  <a:srgbClr val="66707A"/>
+                </a:solidFill>
+                <a:latin typeface="Arial"/>
+              </a:rPr>
+              <a:t>Consultoria especialitzada acreditada per a la Generalitat de Catalunya (AGAUR)</a:t>
+            </a:r>
+          </a:p>
+        </p:txBody>
+      </p:sp>
+      <p:pic>
+        <p:nvPicPr>
+          <p:cNvPr id="6" name="Picture 5" descr="image.png"/>
+          <p:cNvPicPr>
+            <a:picLocks noChangeAspect="1"/>
+          </p:cNvPicPr>
+          <p:nvPr/>
+        </p:nvPicPr>
+        <p:blipFill>
+          <a:blip r:embed="rId2"/>
+          <a:stretch>
+            <a:fillRect/>
+          </a:stretch>
+        </p:blipFill>
+        <p:spPr>
+          <a:xfrm>
+            <a:off x="8476488" y="292608"/>
+            <a:ext cx="3044952" cy="576072"/>
+          </a:xfrm>
+          <a:prstGeom prst="rect">
+            <a:avLst/>
+          </a:prstGeom>
+        </p:spPr>
+      </p:pic>
+      <p:sp>
+        <p:nvSpPr>
+          <p:cNvPr id="7" name="Linia divisoria"/>
+          <p:cNvSpPr/>
+          <p:nvPr/>
+        </p:nvSpPr>
+        <p:spPr>
+          <a:xfrm>
+            <a:off x="594360" y="1115568"/>
+            <a:ext cx="10972800" cy="13320"/>
+          </a:xfrm>
+          <a:prstGeom prst="rect">
+            <a:avLst/>
+          </a:prstGeom>
+          <a:solidFill>
+            <a:srgbClr val="D6DBE0"/>
+          </a:solidFill>
+          <a:ln>
+            <a:noFill/>
+          </a:ln>
+          <a:effectLst>
+            <a:outerShdw blurRad="39960" dist="23040" dir="5400000" rotWithShape="0">
+              <a:srgbClr val="000000">
+                <a:alpha val="35000"/>
+              </a:srgbClr>
+            </a:outerShdw>
+          </a:effectLst>
+        </p:spPr>
+        <p:style>
+          <a:lnRef idx="1">
+            <a:schemeClr val="accent1"/>
+          </a:lnRef>
+          <a:fillRef idx="3">
+            <a:schemeClr val="accent1"/>
+          </a:fillRef>
+          <a:effectRef idx="2">
+            <a:schemeClr val="accent1"/>
+          </a:effectRef>
+          <a:fontRef idx="minor">
+            <a:schemeClr val="lt1"/>
+          </a:fontRef>
+        </p:style>
+        <p:txBody>
+          <a:bodyPr rtlCol="0" anchor="ctr"/>
+          <a:lstStyle/>
+          <a:p>
+            <a:pPr algn="ctr"/>
+          </a:p>
+        </p:txBody>
+      </p:sp>
+      <p:sp>
+        <p:nvSpPr>
+          <p:cNvPr id="8" name="Mon academic"/>
+          <p:cNvSpPr/>
+          <p:nvPr/>
+        </p:nvSpPr>
+        <p:spPr>
+          <a:xfrm>
+            <a:off x="822960" y="1737360"/>
+            <a:ext cx="4846320" cy="2377440"/>
+          </a:xfrm>
+          <a:prstGeom prst="roundRect">
+            <a:avLst>
+              <a:gd name="adj" fmla="val 16667"/>
+            </a:avLst>
+          </a:prstGeom>
+          <a:solidFill>
+            <a:srgbClr val="E8F1F8"/>
+          </a:solidFill>
+          <a:ln>
+            <a:solidFill>
+              <a:srgbClr val="DCE0E4"/>
+            </a:solidFill>
+          </a:ln>
+          <a:effectLst>
+            <a:outerShdw blurRad="39960" dist="23040" dir="5400000" rotWithShape="0">
+              <a:srgbClr val="000000">
+                <a:alpha val="35000"/>
+              </a:srgbClr>
+            </a:outerShdw>
+          </a:effectLst>
+        </p:spPr>
+        <p:style>
+          <a:lnRef idx="1">
+            <a:schemeClr val="accent1"/>
+          </a:lnRef>
+          <a:fillRef idx="3">
+            <a:schemeClr val="accent1"/>
+          </a:fillRef>
+          <a:effectRef idx="2">
+            <a:schemeClr val="accent1"/>
+          </a:effectRef>
+          <a:fontRef idx="minor">
+            <a:schemeClr val="lt1"/>
+          </a:fontRef>
+        </p:style>
+        <p:txBody>
+          <a:bodyPr rtlCol="0" anchor="ctr" lIns="90000" tIns="45000" rIns="90000" bIns="45000" wrap="square"/>
+          <a:lstStyle/>
+          <a:p>
+            <a:pPr algn="ctr"/>
+            <a:r>
+              <a:rPr sz="2000" b="1" lang="ca-ES">
+                <a:solidFill>
+                  <a:srgbClr val="192D3E"/>
+                </a:solidFill>
+                <a:latin typeface="Arial"/>
+              </a:rPr>
+              <a:t>Món acadèmic</a:t>
+            </a:r>
+          </a:p>
+          <a:p>
+            <a:pPr algn="ctr"/>
+            <a:r>
+              <a:rPr sz="1500" b="0" lang="ca-ES">
+                <a:solidFill>
+                  <a:srgbClr val="262626"/>
+                </a:solidFill>
+                <a:latin typeface="Arial"/>
+              </a:rPr>
+              <a:t>Disseny de Sistemes d’Informació</a:t>
+            </a:r>
+          </a:p>
+          <a:p>
+            <a:pPr algn="ctr"/>
+            <a:r>
+              <a:rPr sz="1300" b="0" lang="ca-ES">
+                <a:solidFill>
+                  <a:srgbClr val="66707A"/>
+                </a:solidFill>
+                <a:latin typeface="Arial"/>
+              </a:rPr>
+              <a:t>arquitectura hexagonal, ports i adaptadors, inversió de dependències</a:t>
+            </a:r>
+          </a:p>
+        </p:txBody>
+      </p:sp>
+      <p:sp>
+        <p:nvSpPr>
+          <p:cNvPr id="9" name="Mon professional"/>
+          <p:cNvSpPr/>
+          <p:nvPr/>
+        </p:nvSpPr>
+        <p:spPr>
+          <a:xfrm>
+            <a:off x="6492240" y="1737360"/>
+            <a:ext cx="4846320" cy="2377440"/>
+          </a:xfrm>
+          <a:prstGeom prst="roundRect">
+            <a:avLst>
+              <a:gd name="adj" fmla="val 16667"/>
+            </a:avLst>
+          </a:prstGeom>
+          <a:solidFill>
+            <a:srgbClr val="EBF6F0"/>
+          </a:solidFill>
+          <a:ln>
+            <a:solidFill>
+              <a:srgbClr val="DCE0E4"/>
+            </a:solidFill>
+          </a:ln>
+          <a:effectLst>
+            <a:outerShdw blurRad="39960" dist="23040" dir="5400000" rotWithShape="0">
+              <a:srgbClr val="000000">
+                <a:alpha val="35000"/>
+              </a:srgbClr>
+            </a:outerShdw>
+          </a:effectLst>
+        </p:spPr>
+        <p:style>
+          <a:lnRef idx="1">
+            <a:schemeClr val="accent1"/>
+          </a:lnRef>
+          <a:fillRef idx="3">
+            <a:schemeClr val="accent1"/>
+          </a:fillRef>
+          <a:effectRef idx="2">
+            <a:schemeClr val="accent1"/>
+          </a:effectRef>
+          <a:fontRef idx="minor">
+            <a:schemeClr val="lt1"/>
+          </a:fontRef>
+        </p:style>
+        <p:txBody>
+          <a:bodyPr rtlCol="0" anchor="ctr" lIns="90000" tIns="45000" rIns="90000" bIns="45000" wrap="square"/>
+          <a:lstStyle/>
+          <a:p>
+            <a:pPr algn="ctr"/>
+            <a:r>
+              <a:rPr sz="2000" b="1" lang="ca-ES">
+                <a:solidFill>
+                  <a:srgbClr val="192D3E"/>
+                </a:solidFill>
+                <a:latin typeface="Arial"/>
+              </a:rPr>
+              <a:t>Món professional</a:t>
+            </a:r>
+          </a:p>
+          <a:p>
+            <a:pPr algn="ctr"/>
+            <a:r>
+              <a:rPr sz="1500" b="0" lang="ca-ES">
+                <a:solidFill>
+                  <a:srgbClr val="262626"/>
+                </a:solidFill>
+                <a:latin typeface="Arial"/>
+              </a:rPr>
+              <a:t>Cas real de consultoria per a l’AGAUR</a:t>
+            </a:r>
+          </a:p>
+          <a:p>
+            <a:pPr algn="ctr"/>
+            <a:r>
+              <a:rPr sz="1300" b="0" lang="ca-ES">
+                <a:solidFill>
+                  <a:srgbClr val="66707A"/>
+                </a:solidFill>
+                <a:latin typeface="Arial"/>
+              </a:rPr>
+              <a:t>reptes concrets d’arquitectura de software</a:t>
+            </a:r>
+          </a:p>
+        </p:txBody>
+      </p:sp>
+      <p:sp>
+        <p:nvSpPr>
+          <p:cNvPr id="10" name="Focus"/>
+          <p:cNvSpPr txBox="1"/>
+          <p:nvPr/>
+        </p:nvSpPr>
+        <p:spPr>
+          <a:xfrm>
+            <a:off x="960120" y="4617720"/>
+            <a:ext cx="10241280" cy="868680"/>
+          </a:xfrm>
+          <a:prstGeom prst="rect">
+            <a:avLst/>
+          </a:prstGeom>
+          <a:noFill/>
+        </p:spPr>
+        <p:txBody>
+          <a:bodyPr wrap="square" lIns="90000" tIns="45000" rIns="90000" bIns="45000">
+            <a:spAutoFit/>
+          </a:bodyPr>
+          <a:lstStyle/>
+          <a:p>
+            <a:pPr algn="ctr"/>
+            <a:r>
+              <a:rPr sz="2200" b="1" lang="ca-ES">
+                <a:solidFill>
+                  <a:srgbClr val="192D3E"/>
+                </a:solidFill>
+                <a:latin typeface="Arial"/>
+              </a:rPr>
+              <a:t>En vint minuts, una decisió concreta: dissenyar un port de sortida quan el cas d’ús necessita informació externa.</a:t>
+            </a:r>
+          </a:p>
+        </p:txBody>
+      </p:sp>
+      <p:sp>
+        <p:nvSpPr>
+          <p:cNvPr id="11" name="Peu"/>
+          <p:cNvSpPr txBox="1"/>
+          <p:nvPr/>
+        </p:nvSpPr>
+        <p:spPr>
+          <a:xfrm>
+            <a:off x="594360" y="6473952"/>
+            <a:ext cx="8595360" cy="201168"/>
+          </a:xfrm>
+          <a:prstGeom prst="rect">
+            <a:avLst/>
+          </a:prstGeom>
+          <a:noFill/>
+        </p:spPr>
+        <p:txBody>
+          <a:bodyPr wrap="square" lIns="90000" tIns="45000" rIns="90000" bIns="45000">
+            <a:spAutoFit/>
+          </a:bodyPr>
+          <a:lstStyle/>
+          <a:p>
+            <a:pPr/>
+            <a:r>
+              <a:rPr sz="800" b="0" lang="ca-ES">
+                <a:solidFill>
+                  <a:srgbClr val="66707A"/>
+                </a:solidFill>
+                <a:latin typeface="Arial"/>
+              </a:rPr>
+              <a:t>Disseny de Sistemes d’Informació · Ports de sortida en arquitectura hexagonal</a:t>
+            </a:r>
+          </a:p>
+        </p:txBody>
+      </p:sp>
+      <p:sp>
+        <p:nvSpPr>
+          <p:cNvPr id="12" name="Numero"/>
+          <p:cNvSpPr txBox="1"/>
+          <p:nvPr/>
+        </p:nvSpPr>
+        <p:spPr>
+          <a:xfrm>
+            <a:off x="11155680" y="6473952"/>
+            <a:ext cx="411480" cy="201168"/>
+          </a:xfrm>
+          <a:prstGeom prst="rect">
+            <a:avLst/>
+          </a:prstGeom>
+          <a:noFill/>
+        </p:spPr>
+        <p:txBody>
+          <a:bodyPr wrap="square" lIns="90000" tIns="45000" rIns="90000" bIns="45000">
+            <a:spAutoFit/>
+          </a:bodyPr>
+          <a:lstStyle/>
+          <a:p>
+            <a:pPr algn="r"/>
+            <a:r>
+              <a:rPr sz="800" b="0" lang="ca-ES">
+                <a:solidFill>
+                  <a:srgbClr val="66707A"/>
+                </a:solidFill>
+                <a:latin typeface="Arial"/>
+              </a:rPr>
+              <a:t>2</a:t>
+            </a:r>
+          </a:p>
+        </p:txBody>
+      </p:sp>
+    </p:spTree>
+  </p:cSld>
+  <p:clrMapOvr>
+    <a:masterClrMapping/>
+  </p:clrMapOvr>
+</p:sld>
+</file>
+
 <file path=ppt/slides/slide2.xml><?xml version="1.0" encoding="utf-8"?>
 <p:sld xmlns:a="http://schemas.openxmlformats.org/drawingml/2006/main" xmlns:r="http://schemas.openxmlformats.org/officeDocument/2006/relationships" xmlns:p="http://schemas.openxmlformats.org/presentationml/2006/main">
   <p:cSld>
@@ -14585,7 +15009,7 @@
                 <a:uFillTx/>
                 <a:latin typeface="Arial"/>
               </a:rPr>
-              <a:t>2</a:t>
+              <a:t>3</a:t>
             </a:r>
             <a:endParaRPr lang="es-ES" sz="800" b="0" u="none" strike="noStrike">
               <a:solidFill>
@@ -15471,7 +15895,7 @@
                 <a:uFillTx/>
                 <a:latin typeface="Arial"/>
               </a:rPr>
-              <a:t>3</a:t>
+              <a:t>4</a:t>
             </a:r>
             <a:endParaRPr lang="es-ES" sz="800" b="0" u="none" strike="noStrike">
               <a:solidFill>
@@ -16186,7 +16610,7 @@
                 <a:uFillTx/>
                 <a:latin typeface="Arial"/>
               </a:rPr>
-              <a:t>4</a:t>
+              <a:t>5</a:t>
             </a:r>
             <a:endParaRPr lang="es-ES" sz="800" b="0" u="none" strike="noStrike">
               <a:solidFill>
@@ -16695,7 +17119,7 @@
                 <a:uFillTx/>
                 <a:latin typeface="Arial"/>
               </a:rPr>
-              <a:t>5</a:t>
+              <a:t>6</a:t>
             </a:r>
             <a:endParaRPr lang="es-ES" sz="800" b="0" u="none" strike="noStrike">
               <a:solidFill>
@@ -18008,7 +18432,7 @@
                 <a:uFillTx/>
                 <a:latin typeface="Arial"/>
               </a:rPr>
-              <a:t>6</a:t>
+              <a:t>7</a:t>
             </a:r>
             <a:endParaRPr lang="es-ES" sz="800" b="0" u="none" strike="noStrike">
               <a:solidFill>
@@ -19213,7 +19637,7 @@
                 <a:uFillTx/>
                 <a:latin typeface="Arial"/>
               </a:rPr>
-              <a:t>7</a:t>
+              <a:t>8</a:t>
             </a:r>
             <a:endParaRPr lang="es-ES" sz="800" b="0" u="none" strike="noStrike">
               <a:solidFill>
@@ -20130,7 +20554,7 @@
                 <a:uFillTx/>
                 <a:latin typeface="Arial"/>
               </a:rPr>
-              <a:t>8</a:t>
+              <a:t>9</a:t>
             </a:r>
             <a:endParaRPr lang="es-ES" sz="800" b="0" u="none" strike="noStrike">
               <a:solidFill>
@@ -20516,7 +20940,7 @@
                 <a:uFillTx/>
                 <a:latin typeface="Arial"/>
               </a:rPr>
-              <a:t>9</a:t>
+              <a:t>10</a:t>
             </a:r>
             <a:endParaRPr lang="es-ES" sz="800" b="0" u="none" strike="noStrike">
               <a:solidFill>

</xml_diff>